<commit_message>
Deliver proposal-quality review and complete geospatial candidate run evidence
</commit_message>
<xml_diff>
--- a/extras/usd/examples/usdGeospatialBuild/delivery/geospatial-build.pptx
+++ b/extras/usd/examples/usdGeospatialBuild/delivery/geospatial-build.pptx
@@ -2,22 +2,22 @@
 <file path=ppt/presentation.xml><?xml version="1.0" encoding="utf-8"?>
 <p:presentation xmlns:p="http://schemas.openxmlformats.org/presentationml/2006/main">
   <p:sldMasterIdLst>
-    <p:sldMasterId xmlns:r="http://schemas.openxmlformats.org/officeDocument/2006/relationships" id="2147483648" r:id="Rde02cfb239a843fc"/>
+    <p:sldMasterId xmlns:r="http://schemas.openxmlformats.org/officeDocument/2006/relationships" id="2147483648" r:id="R8a9c9b49e7844aae"/>
   </p:sldMasterIdLst>
   <p:notesMasterIdLst>
-    <p:notesMasterId xmlns:r="http://schemas.openxmlformats.org/officeDocument/2006/relationships" r:id="R2da6416b36554272"/>
+    <p:notesMasterId xmlns:r="http://schemas.openxmlformats.org/officeDocument/2006/relationships" r:id="R8f2f26abd1134ea7"/>
   </p:notesMasterIdLst>
   <p:sldIdLst>
-    <p:sldId xmlns:r="http://schemas.openxmlformats.org/officeDocument/2006/relationships" id="256" r:id="R54a7a7a8b617410e"/>
-    <p:sldId xmlns:r="http://schemas.openxmlformats.org/officeDocument/2006/relationships" id="257" r:id="R133410885cdb48a7"/>
-    <p:sldId xmlns:r="http://schemas.openxmlformats.org/officeDocument/2006/relationships" id="258" r:id="R7e3c879bf9a747e8"/>
-    <p:sldId xmlns:r="http://schemas.openxmlformats.org/officeDocument/2006/relationships" id="259" r:id="R4c80bad8cd024ffc"/>
-    <p:sldId xmlns:r="http://schemas.openxmlformats.org/officeDocument/2006/relationships" id="260" r:id="Raa830915dfe24196"/>
-    <p:sldId xmlns:r="http://schemas.openxmlformats.org/officeDocument/2006/relationships" id="261" r:id="R8da20666cab54a03"/>
-    <p:sldId xmlns:r="http://schemas.openxmlformats.org/officeDocument/2006/relationships" id="262" r:id="R85ffe6ee43bc4b0c"/>
-    <p:sldId xmlns:r="http://schemas.openxmlformats.org/officeDocument/2006/relationships" id="263" r:id="R63efb70e9f4a4699"/>
-    <p:sldId xmlns:r="http://schemas.openxmlformats.org/officeDocument/2006/relationships" id="264" r:id="R26c884d5b91f42a6"/>
-    <p:sldId xmlns:r="http://schemas.openxmlformats.org/officeDocument/2006/relationships" id="265" r:id="R0a9f7bb3338b441e"/>
+    <p:sldId xmlns:r="http://schemas.openxmlformats.org/officeDocument/2006/relationships" id="256" r:id="R3f8c324f15444381"/>
+    <p:sldId xmlns:r="http://schemas.openxmlformats.org/officeDocument/2006/relationships" id="257" r:id="Rf7f279fa977b4f9a"/>
+    <p:sldId xmlns:r="http://schemas.openxmlformats.org/officeDocument/2006/relationships" id="258" r:id="R19a4c575fdac4dfe"/>
+    <p:sldId xmlns:r="http://schemas.openxmlformats.org/officeDocument/2006/relationships" id="259" r:id="R8849873a68f845bd"/>
+    <p:sldId xmlns:r="http://schemas.openxmlformats.org/officeDocument/2006/relationships" id="260" r:id="R5e9a00e1a4c4495f"/>
+    <p:sldId xmlns:r="http://schemas.openxmlformats.org/officeDocument/2006/relationships" id="261" r:id="R7e754cbd976f442c"/>
+    <p:sldId xmlns:r="http://schemas.openxmlformats.org/officeDocument/2006/relationships" id="262" r:id="R8a4da9c791624fd0"/>
+    <p:sldId xmlns:r="http://schemas.openxmlformats.org/officeDocument/2006/relationships" id="263" r:id="R93182e4830ef4dbe"/>
+    <p:sldId xmlns:r="http://schemas.openxmlformats.org/officeDocument/2006/relationships" id="264" r:id="Re3b19bf37ed44496"/>
+    <p:sldId xmlns:r="http://schemas.openxmlformats.org/officeDocument/2006/relationships" id="265" r:id="R545936b4151047f4"/>
   </p:sldIdLst>
   <p:sldSz cx="12192000" cy="6858000"/>
   <p:notesSz cx="6858000" cy="9144000"/>
@@ -451,37 +451,37 @@
           <a:lstStyle xmlns:a="http://schemas.openxmlformats.org/drawingml/2006/main"/>
           <a:p xmlns:a="http://schemas.openxmlformats.org/drawingml/2006/main">
             <a:r>
-              <a:t>README section: Proposal authority and decisions requiring review</a:t>
-            </a:r>
-          </a:p>
-          <a:p xmlns:a="http://schemas.openxmlformats.org/drawingml/2006/main">
-            <a:r>
-              <a:t>README SHA-256: c8526cd9672f2b8759543cc9d70a0c46dfb12b90f6efdc873b35ce1f4b6c0226</a:t>
-            </a:r>
-          </a:p>
-          <a:p xmlns:a="http://schemas.openxmlformats.org/drawingml/2006/main">
-            <a:r>
-              <a:t>Receipt SHA-256: 6c79acd04eab6bc51bc3a0e3ed50dcd66f1e7ec12395db537c76bc0dbb94a35d</a:t>
-            </a:r>
-          </a:p>
-          <a:p xmlns:a="http://schemas.openxmlformats.org/drawingml/2006/main">
-            <a:r>
-              <a:t>Immutable execution receipt SHA-256: d3c90dd02e9642080edef6d0dfed00c95e6e3d01e18b746df9fdd185e63c31ca</a:t>
-            </a:r>
-          </a:p>
-          <a:p xmlns:a="http://schemas.openxmlformats.org/drawingml/2006/main">
-            <a:r>
-              <a:t>Proposal SHA-256: 2120953af221f83816486afbe88a06768e206d23cb570b5e39a193f254ba7a11</a:t>
-            </a:r>
-          </a:p>
-          <a:p xmlns:a="http://schemas.openxmlformats.org/drawingml/2006/main">
-            <a:r>
-              <a:t>Integration evidence SHA-256: 235be1ab2b43c161614d1bba09517b8cb20166592929e7061d6b53f59f2ae8e9</a:t>
-            </a:r>
-          </a:p>
-          <a:p xmlns:a="http://schemas.openxmlformats.org/drawingml/2006/main">
-            <a:r>
-              <a:t>Executed source parent: 874ad2059b4a0c168600804acc9ce56e5834d35a; exact executed files frozen in receipt.</a:t>
+              <a:t>README section: Proposal quality and review choices</a:t>
+            </a:r>
+          </a:p>
+          <a:p xmlns:a="http://schemas.openxmlformats.org/drawingml/2006/main">
+            <a:r>
+              <a:t>README SHA-256: f471c007044418d39804cfdc39a84f82cd195d428bd6cd934455f544ff35ab11</a:t>
+            </a:r>
+          </a:p>
+          <a:p xmlns:a="http://schemas.openxmlformats.org/drawingml/2006/main">
+            <a:r>
+              <a:t>Receipt SHA-256: f9694edf234e4a69cef58bb6ea0f5551b45f22c4f3a61501db1b27f513c44fed</a:t>
+            </a:r>
+          </a:p>
+          <a:p xmlns:a="http://schemas.openxmlformats.org/drawingml/2006/main">
+            <a:r>
+              <a:t>Immutable execution receipt SHA-256: 3baf0e2c215e8ac2ea30fb41197242b663469cd51f31ba48dc9e6c0d7b76833c</a:t>
+            </a:r>
+          </a:p>
+          <a:p xmlns:a="http://schemas.openxmlformats.org/drawingml/2006/main">
+            <a:r>
+              <a:t>Proposal SHA-256: 1727a552053cfdcdf202e2c84ad1209d1a898fe2eab2e322d51e9c7b4ad7c7c0</a:t>
+            </a:r>
+          </a:p>
+          <a:p xmlns:a="http://schemas.openxmlformats.org/drawingml/2006/main">
+            <a:r>
+              <a:t>Integration evidence SHA-256: 0bcdb95aa92032522d31c919ae91894cece9557fbd0371cb3a66fdcdb8199fd1</a:t>
+            </a:r>
+          </a:p>
+          <a:p xmlns:a="http://schemas.openxmlformats.org/drawingml/2006/main">
+            <a:r>
+              <a:t>Executed source parent: 5c116fd2dd5767d42d34083d616edf66723efe92; exact executed files frozen in receipt.</a:t>
             </a:r>
           </a:p>
           <a:p xmlns:a="http://schemas.openxmlformats.org/drawingml/2006/main">
@@ -571,37 +571,37 @@
           <a:lstStyle xmlns:a="http://schemas.openxmlformats.org/drawingml/2006/main"/>
           <a:p xmlns:a="http://schemas.openxmlformats.org/drawingml/2006/main">
             <a:r>
-              <a:t>README section: Actual consumers and shared components</a:t>
-            </a:r>
-          </a:p>
-          <a:p xmlns:a="http://schemas.openxmlformats.org/drawingml/2006/main">
-            <a:r>
-              <a:t>README SHA-256: c8526cd9672f2b8759543cc9d70a0c46dfb12b90f6efdc873b35ce1f4b6c0226</a:t>
-            </a:r>
-          </a:p>
-          <a:p xmlns:a="http://schemas.openxmlformats.org/drawingml/2006/main">
-            <a:r>
-              <a:t>Receipt SHA-256: 6c79acd04eab6bc51bc3a0e3ed50dcd66f1e7ec12395db537c76bc0dbb94a35d</a:t>
-            </a:r>
-          </a:p>
-          <a:p xmlns:a="http://schemas.openxmlformats.org/drawingml/2006/main">
-            <a:r>
-              <a:t>Immutable execution receipt SHA-256: d3c90dd02e9642080edef6d0dfed00c95e6e3d01e18b746df9fdd185e63c31ca</a:t>
-            </a:r>
-          </a:p>
-          <a:p xmlns:a="http://schemas.openxmlformats.org/drawingml/2006/main">
-            <a:r>
-              <a:t>Proposal SHA-256: 2120953af221f83816486afbe88a06768e206d23cb570b5e39a193f254ba7a11</a:t>
-            </a:r>
-          </a:p>
-          <a:p xmlns:a="http://schemas.openxmlformats.org/drawingml/2006/main">
-            <a:r>
-              <a:t>Integration evidence SHA-256: 235be1ab2b43c161614d1bba09517b8cb20166592929e7061d6b53f59f2ae8e9</a:t>
-            </a:r>
-          </a:p>
-          <a:p xmlns:a="http://schemas.openxmlformats.org/drawingml/2006/main">
-            <a:r>
-              <a:t>Executed source parent: 874ad2059b4a0c168600804acc9ce56e5834d35a; exact executed files frozen in receipt.</a:t>
+              <a:t>README section: Consumer evidence and limits</a:t>
+            </a:r>
+          </a:p>
+          <a:p xmlns:a="http://schemas.openxmlformats.org/drawingml/2006/main">
+            <a:r>
+              <a:t>README SHA-256: f471c007044418d39804cfdc39a84f82cd195d428bd6cd934455f544ff35ab11</a:t>
+            </a:r>
+          </a:p>
+          <a:p xmlns:a="http://schemas.openxmlformats.org/drawingml/2006/main">
+            <a:r>
+              <a:t>Receipt SHA-256: f9694edf234e4a69cef58bb6ea0f5551b45f22c4f3a61501db1b27f513c44fed</a:t>
+            </a:r>
+          </a:p>
+          <a:p xmlns:a="http://schemas.openxmlformats.org/drawingml/2006/main">
+            <a:r>
+              <a:t>Immutable execution receipt SHA-256: 3baf0e2c215e8ac2ea30fb41197242b663469cd51f31ba48dc9e6c0d7b76833c</a:t>
+            </a:r>
+          </a:p>
+          <a:p xmlns:a="http://schemas.openxmlformats.org/drawingml/2006/main">
+            <a:r>
+              <a:t>Proposal SHA-256: 1727a552053cfdcdf202e2c84ad1209d1a898fe2eab2e322d51e9c7b4ad7c7c0</a:t>
+            </a:r>
+          </a:p>
+          <a:p xmlns:a="http://schemas.openxmlformats.org/drawingml/2006/main">
+            <a:r>
+              <a:t>Integration evidence SHA-256: 0bcdb95aa92032522d31c919ae91894cece9557fbd0371cb3a66fdcdb8199fd1</a:t>
+            </a:r>
+          </a:p>
+          <a:p xmlns:a="http://schemas.openxmlformats.org/drawingml/2006/main">
+            <a:r>
+              <a:t>Executed source parent: 5c116fd2dd5767d42d34083d616edf66723efe92; exact executed files frozen in receipt.</a:t>
             </a:r>
           </a:p>
           <a:p xmlns:a="http://schemas.openxmlformats.org/drawingml/2006/main">
@@ -691,37 +691,37 @@
           <a:lstStyle xmlns:a="http://schemas.openxmlformats.org/drawingml/2006/main"/>
           <a:p xmlns:a="http://schemas.openxmlformats.org/drawingml/2006/main">
             <a:r>
-              <a:t>README section: Proposal authority and decisions requiring review</a:t>
-            </a:r>
-          </a:p>
-          <a:p xmlns:a="http://schemas.openxmlformats.org/drawingml/2006/main">
-            <a:r>
-              <a:t>README SHA-256: c8526cd9672f2b8759543cc9d70a0c46dfb12b90f6efdc873b35ce1f4b6c0226</a:t>
-            </a:r>
-          </a:p>
-          <a:p xmlns:a="http://schemas.openxmlformats.org/drawingml/2006/main">
-            <a:r>
-              <a:t>Receipt SHA-256: 6c79acd04eab6bc51bc3a0e3ed50dcd66f1e7ec12395db537c76bc0dbb94a35d</a:t>
-            </a:r>
-          </a:p>
-          <a:p xmlns:a="http://schemas.openxmlformats.org/drawingml/2006/main">
-            <a:r>
-              <a:t>Immutable execution receipt SHA-256: d3c90dd02e9642080edef6d0dfed00c95e6e3d01e18b746df9fdd185e63c31ca</a:t>
-            </a:r>
-          </a:p>
-          <a:p xmlns:a="http://schemas.openxmlformats.org/drawingml/2006/main">
-            <a:r>
-              <a:t>Proposal SHA-256: 2120953af221f83816486afbe88a06768e206d23cb570b5e39a193f254ba7a11</a:t>
-            </a:r>
-          </a:p>
-          <a:p xmlns:a="http://schemas.openxmlformats.org/drawingml/2006/main">
-            <a:r>
-              <a:t>Integration evidence SHA-256: 235be1ab2b43c161614d1bba09517b8cb20166592929e7061d6b53f59f2ae8e9</a:t>
-            </a:r>
-          </a:p>
-          <a:p xmlns:a="http://schemas.openxmlformats.org/drawingml/2006/main">
-            <a:r>
-              <a:t>Executed source parent: 874ad2059b4a0c168600804acc9ce56e5834d35a; exact executed files frozen in receipt.</a:t>
+              <a:t>README section: Proposal quality and review choices</a:t>
+            </a:r>
+          </a:p>
+          <a:p xmlns:a="http://schemas.openxmlformats.org/drawingml/2006/main">
+            <a:r>
+              <a:t>README SHA-256: f471c007044418d39804cfdc39a84f82cd195d428bd6cd934455f544ff35ab11</a:t>
+            </a:r>
+          </a:p>
+          <a:p xmlns:a="http://schemas.openxmlformats.org/drawingml/2006/main">
+            <a:r>
+              <a:t>Receipt SHA-256: f9694edf234e4a69cef58bb6ea0f5551b45f22c4f3a61501db1b27f513c44fed</a:t>
+            </a:r>
+          </a:p>
+          <a:p xmlns:a="http://schemas.openxmlformats.org/drawingml/2006/main">
+            <a:r>
+              <a:t>Immutable execution receipt SHA-256: 3baf0e2c215e8ac2ea30fb41197242b663469cd51f31ba48dc9e6c0d7b76833c</a:t>
+            </a:r>
+          </a:p>
+          <a:p xmlns:a="http://schemas.openxmlformats.org/drawingml/2006/main">
+            <a:r>
+              <a:t>Proposal SHA-256: 1727a552053cfdcdf202e2c84ad1209d1a898fe2eab2e322d51e9c7b4ad7c7c0</a:t>
+            </a:r>
+          </a:p>
+          <a:p xmlns:a="http://schemas.openxmlformats.org/drawingml/2006/main">
+            <a:r>
+              <a:t>Integration evidence SHA-256: 0bcdb95aa92032522d31c919ae91894cece9557fbd0371cb3a66fdcdb8199fd1</a:t>
+            </a:r>
+          </a:p>
+          <a:p xmlns:a="http://schemas.openxmlformats.org/drawingml/2006/main">
+            <a:r>
+              <a:t>Executed source parent: 5c116fd2dd5767d42d34083d616edf66723efe92; exact executed files frozen in receipt.</a:t>
             </a:r>
           </a:p>
           <a:p xmlns:a="http://schemas.openxmlformats.org/drawingml/2006/main">
@@ -811,37 +811,37 @@
           <a:lstStyle xmlns:a="http://schemas.openxmlformats.org/drawingml/2006/main"/>
           <a:p xmlns:a="http://schemas.openxmlformats.org/drawingml/2006/main">
             <a:r>
-              <a:t>README section: Physical placement and ordinary transforms</a:t>
-            </a:r>
-          </a:p>
-          <a:p xmlns:a="http://schemas.openxmlformats.org/drawingml/2006/main">
-            <a:r>
-              <a:t>README SHA-256: c8526cd9672f2b8759543cc9d70a0c46dfb12b90f6efdc873b35ce1f4b6c0226</a:t>
-            </a:r>
-          </a:p>
-          <a:p xmlns:a="http://schemas.openxmlformats.org/drawingml/2006/main">
-            <a:r>
-              <a:t>Receipt SHA-256: 6c79acd04eab6bc51bc3a0e3ed50dcd66f1e7ec12395db537c76bc0dbb94a35d</a:t>
-            </a:r>
-          </a:p>
-          <a:p xmlns:a="http://schemas.openxmlformats.org/drawingml/2006/main">
-            <a:r>
-              <a:t>Immutable execution receipt SHA-256: d3c90dd02e9642080edef6d0dfed00c95e6e3d01e18b746df9fdd185e63c31ca</a:t>
-            </a:r>
-          </a:p>
-          <a:p xmlns:a="http://schemas.openxmlformats.org/drawingml/2006/main">
-            <a:r>
-              <a:t>Proposal SHA-256: 2120953af221f83816486afbe88a06768e206d23cb570b5e39a193f254ba7a11</a:t>
-            </a:r>
-          </a:p>
-          <a:p xmlns:a="http://schemas.openxmlformats.org/drawingml/2006/main">
-            <a:r>
-              <a:t>Integration evidence SHA-256: 235be1ab2b43c161614d1bba09517b8cb20166592929e7061d6b53f59f2ae8e9</a:t>
-            </a:r>
-          </a:p>
-          <a:p xmlns:a="http://schemas.openxmlformats.org/drawingml/2006/main">
-            <a:r>
-              <a:t>Executed source parent: 874ad2059b4a0c168600804acc9ce56e5834d35a; exact executed files frozen in receipt.</a:t>
+              <a:t>README section: Ordered math and the descendant choice</a:t>
+            </a:r>
+          </a:p>
+          <a:p xmlns:a="http://schemas.openxmlformats.org/drawingml/2006/main">
+            <a:r>
+              <a:t>README SHA-256: f471c007044418d39804cfdc39a84f82cd195d428bd6cd934455f544ff35ab11</a:t>
+            </a:r>
+          </a:p>
+          <a:p xmlns:a="http://schemas.openxmlformats.org/drawingml/2006/main">
+            <a:r>
+              <a:t>Receipt SHA-256: f9694edf234e4a69cef58bb6ea0f5551b45f22c4f3a61501db1b27f513c44fed</a:t>
+            </a:r>
+          </a:p>
+          <a:p xmlns:a="http://schemas.openxmlformats.org/drawingml/2006/main">
+            <a:r>
+              <a:t>Immutable execution receipt SHA-256: 3baf0e2c215e8ac2ea30fb41197242b663469cd51f31ba48dc9e6c0d7b76833c</a:t>
+            </a:r>
+          </a:p>
+          <a:p xmlns:a="http://schemas.openxmlformats.org/drawingml/2006/main">
+            <a:r>
+              <a:t>Proposal SHA-256: 1727a552053cfdcdf202e2c84ad1209d1a898fe2eab2e322d51e9c7b4ad7c7c0</a:t>
+            </a:r>
+          </a:p>
+          <a:p xmlns:a="http://schemas.openxmlformats.org/drawingml/2006/main">
+            <a:r>
+              <a:t>Integration evidence SHA-256: 0bcdb95aa92032522d31c919ae91894cece9557fbd0371cb3a66fdcdb8199fd1</a:t>
+            </a:r>
+          </a:p>
+          <a:p xmlns:a="http://schemas.openxmlformats.org/drawingml/2006/main">
+            <a:r>
+              <a:t>Executed source parent: 5c116fd2dd5767d42d34083d616edf66723efe92; exact executed files frozen in receipt.</a:t>
             </a:r>
           </a:p>
           <a:p xmlns:a="http://schemas.openxmlformats.org/drawingml/2006/main">
@@ -931,37 +931,37 @@
           <a:lstStyle xmlns:a="http://schemas.openxmlformats.org/drawingml/2006/main"/>
           <a:p xmlns:a="http://schemas.openxmlformats.org/drawingml/2006/main">
             <a:r>
-              <a:t>README section: Eiffel model and native Hydra rendering</a:t>
-            </a:r>
-          </a:p>
-          <a:p xmlns:a="http://schemas.openxmlformats.org/drawingml/2006/main">
-            <a:r>
-              <a:t>README SHA-256: c8526cd9672f2b8759543cc9d70a0c46dfb12b90f6efdc873b35ce1f4b6c0226</a:t>
-            </a:r>
-          </a:p>
-          <a:p xmlns:a="http://schemas.openxmlformats.org/drawingml/2006/main">
-            <a:r>
-              <a:t>Receipt SHA-256: 6c79acd04eab6bc51bc3a0e3ed50dcd66f1e7ec12395db537c76bc0dbb94a35d</a:t>
-            </a:r>
-          </a:p>
-          <a:p xmlns:a="http://schemas.openxmlformats.org/drawingml/2006/main">
-            <a:r>
-              <a:t>Immutable execution receipt SHA-256: d3c90dd02e9642080edef6d0dfed00c95e6e3d01e18b746df9fdd185e63c31ca</a:t>
-            </a:r>
-          </a:p>
-          <a:p xmlns:a="http://schemas.openxmlformats.org/drawingml/2006/main">
-            <a:r>
-              <a:t>Proposal SHA-256: 2120953af221f83816486afbe88a06768e206d23cb570b5e39a193f254ba7a11</a:t>
-            </a:r>
-          </a:p>
-          <a:p xmlns:a="http://schemas.openxmlformats.org/drawingml/2006/main">
-            <a:r>
-              <a:t>Integration evidence SHA-256: 235be1ab2b43c161614d1bba09517b8cb20166592929e7061d6b53f59f2ae8e9</a:t>
-            </a:r>
-          </a:p>
-          <a:p xmlns:a="http://schemas.openxmlformats.org/drawingml/2006/main">
-            <a:r>
-              <a:t>Executed source parent: 874ad2059b4a0c168600804acc9ce56e5834d35a; exact executed files frozen in receipt.</a:t>
+              <a:t>README section: Eiffel geometry and shading</a:t>
+            </a:r>
+          </a:p>
+          <a:p xmlns:a="http://schemas.openxmlformats.org/drawingml/2006/main">
+            <a:r>
+              <a:t>README SHA-256: f471c007044418d39804cfdc39a84f82cd195d428bd6cd934455f544ff35ab11</a:t>
+            </a:r>
+          </a:p>
+          <a:p xmlns:a="http://schemas.openxmlformats.org/drawingml/2006/main">
+            <a:r>
+              <a:t>Receipt SHA-256: f9694edf234e4a69cef58bb6ea0f5551b45f22c4f3a61501db1b27f513c44fed</a:t>
+            </a:r>
+          </a:p>
+          <a:p xmlns:a="http://schemas.openxmlformats.org/drawingml/2006/main">
+            <a:r>
+              <a:t>Immutable execution receipt SHA-256: 3baf0e2c215e8ac2ea30fb41197242b663469cd51f31ba48dc9e6c0d7b76833c</a:t>
+            </a:r>
+          </a:p>
+          <a:p xmlns:a="http://schemas.openxmlformats.org/drawingml/2006/main">
+            <a:r>
+              <a:t>Proposal SHA-256: 1727a552053cfdcdf202e2c84ad1209d1a898fe2eab2e322d51e9c7b4ad7c7c0</a:t>
+            </a:r>
+          </a:p>
+          <a:p xmlns:a="http://schemas.openxmlformats.org/drawingml/2006/main">
+            <a:r>
+              <a:t>Integration evidence SHA-256: 0bcdb95aa92032522d31c919ae91894cece9557fbd0371cb3a66fdcdb8199fd1</a:t>
+            </a:r>
+          </a:p>
+          <a:p xmlns:a="http://schemas.openxmlformats.org/drawingml/2006/main">
+            <a:r>
+              <a:t>Executed source parent: 5c116fd2dd5767d42d34083d616edf66723efe92; exact executed files frozen in receipt.</a:t>
             </a:r>
           </a:p>
           <a:p xmlns:a="http://schemas.openxmlformats.org/drawingml/2006/main">
@@ -981,7 +981,7 @@
           </a:p>
           <a:p xmlns:a="http://schemas.openxmlformats.org/drawingml/2006/main">
             <a:r>
-              <a:t/>
+              <a:t>Eiffel mesh: ( FREE ) La tour Eiffel by SDC PERFORMANCE, https://sketchfab.com/3d-models/free-la-tour-eiffel-8553f94d06e24cb4b0fde1080f281674 ; CC BY 4.0, https://creativecommons.org/licenses/by/4.0/ . Reoriented, placed and rendered with illustrative context. Actual native Storm output from this frozen run.</a:t>
             </a:r>
           </a:p>
         </p:txBody>
@@ -1051,37 +1051,37 @@
           <a:lstStyle xmlns:a="http://schemas.openxmlformats.org/drawingml/2006/main"/>
           <a:p xmlns:a="http://schemas.openxmlformats.org/drawingml/2006/main">
             <a:r>
-              <a:t>README section: Colorado survey geometry and site calibration</a:t>
-            </a:r>
-          </a:p>
-          <a:p xmlns:a="http://schemas.openxmlformats.org/drawingml/2006/main">
-            <a:r>
-              <a:t>README SHA-256: c8526cd9672f2b8759543cc9d70a0c46dfb12b90f6efdc873b35ce1f4b6c0226</a:t>
-            </a:r>
-          </a:p>
-          <a:p xmlns:a="http://schemas.openxmlformats.org/drawingml/2006/main">
-            <a:r>
-              <a:t>Receipt SHA-256: 6c79acd04eab6bc51bc3a0e3ed50dcd66f1e7ec12395db537c76bc0dbb94a35d</a:t>
-            </a:r>
-          </a:p>
-          <a:p xmlns:a="http://schemas.openxmlformats.org/drawingml/2006/main">
-            <a:r>
-              <a:t>Immutable execution receipt SHA-256: d3c90dd02e9642080edef6d0dfed00c95e6e3d01e18b746df9fdd185e63c31ca</a:t>
-            </a:r>
-          </a:p>
-          <a:p xmlns:a="http://schemas.openxmlformats.org/drawingml/2006/main">
-            <a:r>
-              <a:t>Proposal SHA-256: 2120953af221f83816486afbe88a06768e206d23cb570b5e39a193f254ba7a11</a:t>
-            </a:r>
-          </a:p>
-          <a:p xmlns:a="http://schemas.openxmlformats.org/drawingml/2006/main">
-            <a:r>
-              <a:t>Integration evidence SHA-256: 235be1ab2b43c161614d1bba09517b8cb20166592929e7061d6b53f59f2ae8e9</a:t>
-            </a:r>
-          </a:p>
-          <a:p xmlns:a="http://schemas.openxmlformats.org/drawingml/2006/main">
-            <a:r>
-              <a:t>Executed source parent: 874ad2059b4a0c168600804acc9ce56e5834d35a; exact executed files frozen in receipt.</a:t>
+              <a:t>README section: Colorado site calibration</a:t>
+            </a:r>
+          </a:p>
+          <a:p xmlns:a="http://schemas.openxmlformats.org/drawingml/2006/main">
+            <a:r>
+              <a:t>README SHA-256: f471c007044418d39804cfdc39a84f82cd195d428bd6cd934455f544ff35ab11</a:t>
+            </a:r>
+          </a:p>
+          <a:p xmlns:a="http://schemas.openxmlformats.org/drawingml/2006/main">
+            <a:r>
+              <a:t>Receipt SHA-256: f9694edf234e4a69cef58bb6ea0f5551b45f22c4f3a61501db1b27f513c44fed</a:t>
+            </a:r>
+          </a:p>
+          <a:p xmlns:a="http://schemas.openxmlformats.org/drawingml/2006/main">
+            <a:r>
+              <a:t>Immutable execution receipt SHA-256: 3baf0e2c215e8ac2ea30fb41197242b663469cd51f31ba48dc9e6c0d7b76833c</a:t>
+            </a:r>
+          </a:p>
+          <a:p xmlns:a="http://schemas.openxmlformats.org/drawingml/2006/main">
+            <a:r>
+              <a:t>Proposal SHA-256: 1727a552053cfdcdf202e2c84ad1209d1a898fe2eab2e322d51e9c7b4ad7c7c0</a:t>
+            </a:r>
+          </a:p>
+          <a:p xmlns:a="http://schemas.openxmlformats.org/drawingml/2006/main">
+            <a:r>
+              <a:t>Integration evidence SHA-256: 0bcdb95aa92032522d31c919ae91894cece9557fbd0371cb3a66fdcdb8199fd1</a:t>
+            </a:r>
+          </a:p>
+          <a:p xmlns:a="http://schemas.openxmlformats.org/drawingml/2006/main">
+            <a:r>
+              <a:t>Executed source parent: 5c116fd2dd5767d42d34083d616edf66723efe92; exact executed files frozen in receipt.</a:t>
             </a:r>
           </a:p>
           <a:p xmlns:a="http://schemas.openxmlformats.org/drawingml/2006/main">
@@ -1171,37 +1171,37 @@
           <a:lstStyle xmlns:a="http://schemas.openxmlformats.org/drawingml/2006/main"/>
           <a:p xmlns:a="http://schemas.openxmlformats.org/drawingml/2006/main">
             <a:r>
-              <a:t>README section: Non-visual measurements and regional geometry</a:t>
-            </a:r>
-          </a:p>
-          <a:p xmlns:a="http://schemas.openxmlformats.org/drawingml/2006/main">
-            <a:r>
-              <a:t>README SHA-256: c8526cd9672f2b8759543cc9d70a0c46dfb12b90f6efdc873b35ce1f4b6c0226</a:t>
-            </a:r>
-          </a:p>
-          <a:p xmlns:a="http://schemas.openxmlformats.org/drawingml/2006/main">
-            <a:r>
-              <a:t>Receipt SHA-256: 6c79acd04eab6bc51bc3a0e3ed50dcd66f1e7ec12395db537c76bc0dbb94a35d</a:t>
-            </a:r>
-          </a:p>
-          <a:p xmlns:a="http://schemas.openxmlformats.org/drawingml/2006/main">
-            <a:r>
-              <a:t>Immutable execution receipt SHA-256: d3c90dd02e9642080edef6d0dfed00c95e6e3d01e18b746df9fdd185e63c31ca</a:t>
-            </a:r>
-          </a:p>
-          <a:p xmlns:a="http://schemas.openxmlformats.org/drawingml/2006/main">
-            <a:r>
-              <a:t>Proposal SHA-256: 2120953af221f83816486afbe88a06768e206d23cb570b5e39a193f254ba7a11</a:t>
-            </a:r>
-          </a:p>
-          <a:p xmlns:a="http://schemas.openxmlformats.org/drawingml/2006/main">
-            <a:r>
-              <a:t>Integration evidence SHA-256: 235be1ab2b43c161614d1bba09517b8cb20166592929e7061d6b53f59f2ae8e9</a:t>
-            </a:r>
-          </a:p>
-          <a:p xmlns:a="http://schemas.openxmlformats.org/drawingml/2006/main">
-            <a:r>
-              <a:t>Executed source parent: 874ad2059b4a0c168600804acc9ce56e5834d35a; exact executed files frozen in receipt.</a:t>
+              <a:t>README section: Native measurements and larger-scale workflows</a:t>
+            </a:r>
+          </a:p>
+          <a:p xmlns:a="http://schemas.openxmlformats.org/drawingml/2006/main">
+            <a:r>
+              <a:t>README SHA-256: f471c007044418d39804cfdc39a84f82cd195d428bd6cd934455f544ff35ab11</a:t>
+            </a:r>
+          </a:p>
+          <a:p xmlns:a="http://schemas.openxmlformats.org/drawingml/2006/main">
+            <a:r>
+              <a:t>Receipt SHA-256: f9694edf234e4a69cef58bb6ea0f5551b45f22c4f3a61501db1b27f513c44fed</a:t>
+            </a:r>
+          </a:p>
+          <a:p xmlns:a="http://schemas.openxmlformats.org/drawingml/2006/main">
+            <a:r>
+              <a:t>Immutable execution receipt SHA-256: 3baf0e2c215e8ac2ea30fb41197242b663469cd51f31ba48dc9e6c0d7b76833c</a:t>
+            </a:r>
+          </a:p>
+          <a:p xmlns:a="http://schemas.openxmlformats.org/drawingml/2006/main">
+            <a:r>
+              <a:t>Proposal SHA-256: 1727a552053cfdcdf202e2c84ad1209d1a898fe2eab2e322d51e9c7b4ad7c7c0</a:t>
+            </a:r>
+          </a:p>
+          <a:p xmlns:a="http://schemas.openxmlformats.org/drawingml/2006/main">
+            <a:r>
+              <a:t>Integration evidence SHA-256: 0bcdb95aa92032522d31c919ae91894cece9557fbd0371cb3a66fdcdb8199fd1</a:t>
+            </a:r>
+          </a:p>
+          <a:p xmlns:a="http://schemas.openxmlformats.org/drawingml/2006/main">
+            <a:r>
+              <a:t>Executed source parent: 5c116fd2dd5767d42d34083d616edf66723efe92; exact executed files frozen in receipt.</a:t>
             </a:r>
           </a:p>
           <a:p xmlns:a="http://schemas.openxmlformats.org/drawingml/2006/main">
@@ -1291,37 +1291,37 @@
           <a:lstStyle xmlns:a="http://schemas.openxmlformats.org/drawingml/2006/main"/>
           <a:p xmlns:a="http://schemas.openxmlformats.org/drawingml/2006/main">
             <a:r>
-              <a:t>README section: Non-visual measurements and regional geometry</a:t>
-            </a:r>
-          </a:p>
-          <a:p xmlns:a="http://schemas.openxmlformats.org/drawingml/2006/main">
-            <a:r>
-              <a:t>README SHA-256: c8526cd9672f2b8759543cc9d70a0c46dfb12b90f6efdc873b35ce1f4b6c0226</a:t>
-            </a:r>
-          </a:p>
-          <a:p xmlns:a="http://schemas.openxmlformats.org/drawingml/2006/main">
-            <a:r>
-              <a:t>Receipt SHA-256: 6c79acd04eab6bc51bc3a0e3ed50dcd66f1e7ec12395db537c76bc0dbb94a35d</a:t>
-            </a:r>
-          </a:p>
-          <a:p xmlns:a="http://schemas.openxmlformats.org/drawingml/2006/main">
-            <a:r>
-              <a:t>Immutable execution receipt SHA-256: d3c90dd02e9642080edef6d0dfed00c95e6e3d01e18b746df9fdd185e63c31ca</a:t>
-            </a:r>
-          </a:p>
-          <a:p xmlns:a="http://schemas.openxmlformats.org/drawingml/2006/main">
-            <a:r>
-              <a:t>Proposal SHA-256: 2120953af221f83816486afbe88a06768e206d23cb570b5e39a193f254ba7a11</a:t>
-            </a:r>
-          </a:p>
-          <a:p xmlns:a="http://schemas.openxmlformats.org/drawingml/2006/main">
-            <a:r>
-              <a:t>Integration evidence SHA-256: 235be1ab2b43c161614d1bba09517b8cb20166592929e7061d6b53f59f2ae8e9</a:t>
-            </a:r>
-          </a:p>
-          <a:p xmlns:a="http://schemas.openxmlformats.org/drawingml/2006/main">
-            <a:r>
-              <a:t>Executed source parent: 874ad2059b4a0c168600804acc9ce56e5834d35a; exact executed files frozen in receipt.</a:t>
+              <a:t>README section: Native measurements and larger-scale workflows</a:t>
+            </a:r>
+          </a:p>
+          <a:p xmlns:a="http://schemas.openxmlformats.org/drawingml/2006/main">
+            <a:r>
+              <a:t>README SHA-256: f471c007044418d39804cfdc39a84f82cd195d428bd6cd934455f544ff35ab11</a:t>
+            </a:r>
+          </a:p>
+          <a:p xmlns:a="http://schemas.openxmlformats.org/drawingml/2006/main">
+            <a:r>
+              <a:t>Receipt SHA-256: f9694edf234e4a69cef58bb6ea0f5551b45f22c4f3a61501db1b27f513c44fed</a:t>
+            </a:r>
+          </a:p>
+          <a:p xmlns:a="http://schemas.openxmlformats.org/drawingml/2006/main">
+            <a:r>
+              <a:t>Immutable execution receipt SHA-256: 3baf0e2c215e8ac2ea30fb41197242b663469cd51f31ba48dc9e6c0d7b76833c</a:t>
+            </a:r>
+          </a:p>
+          <a:p xmlns:a="http://schemas.openxmlformats.org/drawingml/2006/main">
+            <a:r>
+              <a:t>Proposal SHA-256: 1727a552053cfdcdf202e2c84ad1209d1a898fe2eab2e322d51e9c7b4ad7c7c0</a:t>
+            </a:r>
+          </a:p>
+          <a:p xmlns:a="http://schemas.openxmlformats.org/drawingml/2006/main">
+            <a:r>
+              <a:t>Integration evidence SHA-256: 0bcdb95aa92032522d31c919ae91894cece9557fbd0371cb3a66fdcdb8199fd1</a:t>
+            </a:r>
+          </a:p>
+          <a:p xmlns:a="http://schemas.openxmlformats.org/drawingml/2006/main">
+            <a:r>
+              <a:t>Executed source parent: 5c116fd2dd5767d42d34083d616edf66723efe92; exact executed files frozen in receipt.</a:t>
             </a:r>
           </a:p>
           <a:p xmlns:a="http://schemas.openxmlformats.org/drawingml/2006/main">
@@ -1411,37 +1411,37 @@
           <a:lstStyle xmlns:a="http://schemas.openxmlformats.org/drawingml/2006/main"/>
           <a:p xmlns:a="http://schemas.openxmlformats.org/drawingml/2006/main">
             <a:r>
-              <a:t>README section: Same partner coordinate inputs in both implementations and the OV host</a:t>
-            </a:r>
-          </a:p>
-          <a:p xmlns:a="http://schemas.openxmlformats.org/drawingml/2006/main">
-            <a:r>
-              <a:t>README SHA-256: c8526cd9672f2b8759543cc9d70a0c46dfb12b90f6efdc873b35ce1f4b6c0226</a:t>
-            </a:r>
-          </a:p>
-          <a:p xmlns:a="http://schemas.openxmlformats.org/drawingml/2006/main">
-            <a:r>
-              <a:t>Receipt SHA-256: 6c79acd04eab6bc51bc3a0e3ed50dcd66f1e7ec12395db537c76bc0dbb94a35d</a:t>
-            </a:r>
-          </a:p>
-          <a:p xmlns:a="http://schemas.openxmlformats.org/drawingml/2006/main">
-            <a:r>
-              <a:t>Immutable execution receipt SHA-256: d3c90dd02e9642080edef6d0dfed00c95e6e3d01e18b746df9fdd185e63c31ca</a:t>
-            </a:r>
-          </a:p>
-          <a:p xmlns:a="http://schemas.openxmlformats.org/drawingml/2006/main">
-            <a:r>
-              <a:t>Proposal SHA-256: 2120953af221f83816486afbe88a06768e206d23cb570b5e39a193f254ba7a11</a:t>
-            </a:r>
-          </a:p>
-          <a:p xmlns:a="http://schemas.openxmlformats.org/drawingml/2006/main">
-            <a:r>
-              <a:t>Integration evidence SHA-256: 235be1ab2b43c161614d1bba09517b8cb20166592929e7061d6b53f59f2ae8e9</a:t>
-            </a:r>
-          </a:p>
-          <a:p xmlns:a="http://schemas.openxmlformats.org/drawingml/2006/main">
-            <a:r>
-              <a:t>Executed source parent: 874ad2059b4a0c168600804acc9ce56e5834d35a; exact executed files frozen in receipt.</a:t>
+              <a:t>README section: Same partner data in both placements</a:t>
+            </a:r>
+          </a:p>
+          <a:p xmlns:a="http://schemas.openxmlformats.org/drawingml/2006/main">
+            <a:r>
+              <a:t>README SHA-256: f471c007044418d39804cfdc39a84f82cd195d428bd6cd934455f544ff35ab11</a:t>
+            </a:r>
+          </a:p>
+          <a:p xmlns:a="http://schemas.openxmlformats.org/drawingml/2006/main">
+            <a:r>
+              <a:t>Receipt SHA-256: f9694edf234e4a69cef58bb6ea0f5551b45f22c4f3a61501db1b27f513c44fed</a:t>
+            </a:r>
+          </a:p>
+          <a:p xmlns:a="http://schemas.openxmlformats.org/drawingml/2006/main">
+            <a:r>
+              <a:t>Immutable execution receipt SHA-256: 3baf0e2c215e8ac2ea30fb41197242b663469cd51f31ba48dc9e6c0d7b76833c</a:t>
+            </a:r>
+          </a:p>
+          <a:p xmlns:a="http://schemas.openxmlformats.org/drawingml/2006/main">
+            <a:r>
+              <a:t>Proposal SHA-256: 1727a552053cfdcdf202e2c84ad1209d1a898fe2eab2e322d51e9c7b4ad7c7c0</a:t>
+            </a:r>
+          </a:p>
+          <a:p xmlns:a="http://schemas.openxmlformats.org/drawingml/2006/main">
+            <a:r>
+              <a:t>Integration evidence SHA-256: 0bcdb95aa92032522d31c919ae91894cece9557fbd0371cb3a66fdcdb8199fd1</a:t>
+            </a:r>
+          </a:p>
+          <a:p xmlns:a="http://schemas.openxmlformats.org/drawingml/2006/main">
+            <a:r>
+              <a:t>Executed source parent: 5c116fd2dd5767d42d34083d616edf66723efe92; exact executed files frozen in receipt.</a:t>
             </a:r>
           </a:p>
           <a:p xmlns:a="http://schemas.openxmlformats.org/drawingml/2006/main">
@@ -1531,37 +1531,37 @@
           <a:lstStyle xmlns:a="http://schemas.openxmlformats.org/drawingml/2006/main"/>
           <a:p xmlns:a="http://schemas.openxmlformats.org/drawingml/2006/main">
             <a:r>
-              <a:t>README section: Source interpolation and freshly reread exports</a:t>
-            </a:r>
-          </a:p>
-          <a:p xmlns:a="http://schemas.openxmlformats.org/drawingml/2006/main">
-            <a:r>
-              <a:t>README SHA-256: c8526cd9672f2b8759543cc9d70a0c46dfb12b90f6efdc873b35ce1f4b6c0226</a:t>
-            </a:r>
-          </a:p>
-          <a:p xmlns:a="http://schemas.openxmlformats.org/drawingml/2006/main">
-            <a:r>
-              <a:t>Receipt SHA-256: 6c79acd04eab6bc51bc3a0e3ed50dcd66f1e7ec12395db537c76bc0dbb94a35d</a:t>
-            </a:r>
-          </a:p>
-          <a:p xmlns:a="http://schemas.openxmlformats.org/drawingml/2006/main">
-            <a:r>
-              <a:t>Immutable execution receipt SHA-256: d3c90dd02e9642080edef6d0dfed00c95e6e3d01e18b746df9fdd185e63c31ca</a:t>
-            </a:r>
-          </a:p>
-          <a:p xmlns:a="http://schemas.openxmlformats.org/drawingml/2006/main">
-            <a:r>
-              <a:t>Proposal SHA-256: 2120953af221f83816486afbe88a06768e206d23cb570b5e39a193f254ba7a11</a:t>
-            </a:r>
-          </a:p>
-          <a:p xmlns:a="http://schemas.openxmlformats.org/drawingml/2006/main">
-            <a:r>
-              <a:t>Integration evidence SHA-256: 235be1ab2b43c161614d1bba09517b8cb20166592929e7061d6b53f59f2ae8e9</a:t>
-            </a:r>
-          </a:p>
-          <a:p xmlns:a="http://schemas.openxmlformats.org/drawingml/2006/main">
-            <a:r>
-              <a:t>Executed source parent: 874ad2059b4a0c168600804acc9ce56e5834d35a; exact executed files frozen in receipt.</a:t>
+              <a:t>README section: Geographic scene charts and exports</a:t>
+            </a:r>
+          </a:p>
+          <a:p xmlns:a="http://schemas.openxmlformats.org/drawingml/2006/main">
+            <a:r>
+              <a:t>README SHA-256: f471c007044418d39804cfdc39a84f82cd195d428bd6cd934455f544ff35ab11</a:t>
+            </a:r>
+          </a:p>
+          <a:p xmlns:a="http://schemas.openxmlformats.org/drawingml/2006/main">
+            <a:r>
+              <a:t>Receipt SHA-256: f9694edf234e4a69cef58bb6ea0f5551b45f22c4f3a61501db1b27f513c44fed</a:t>
+            </a:r>
+          </a:p>
+          <a:p xmlns:a="http://schemas.openxmlformats.org/drawingml/2006/main">
+            <a:r>
+              <a:t>Immutable execution receipt SHA-256: 3baf0e2c215e8ac2ea30fb41197242b663469cd51f31ba48dc9e6c0d7b76833c</a:t>
+            </a:r>
+          </a:p>
+          <a:p xmlns:a="http://schemas.openxmlformats.org/drawingml/2006/main">
+            <a:r>
+              <a:t>Proposal SHA-256: 1727a552053cfdcdf202e2c84ad1209d1a898fe2eab2e322d51e9c7b4ad7c7c0</a:t>
+            </a:r>
+          </a:p>
+          <a:p xmlns:a="http://schemas.openxmlformats.org/drawingml/2006/main">
+            <a:r>
+              <a:t>Integration evidence SHA-256: 0bcdb95aa92032522d31c919ae91894cece9557fbd0371cb3a66fdcdb8199fd1</a:t>
+            </a:r>
+          </a:p>
+          <a:p xmlns:a="http://schemas.openxmlformats.org/drawingml/2006/main">
+            <a:r>
+              <a:t>Executed source parent: 5c116fd2dd5767d42d34083d616edf66723efe92; exact executed files frozen in receipt.</a:t>
             </a:r>
           </a:p>
           <a:p xmlns:a="http://schemas.openxmlformats.org/drawingml/2006/main">
@@ -1649,7 +1649,7 @@
   </p:cSld>
   <p:clrMap bg1="lt1" tx1="dk1" bg2="lt2" tx2="dk2" accent1="accent1" accent2="accent2" accent3="accent3" accent4="accent4" accent5="accent5" accent6="accent6" hlink="hlink" folHlink="folHlink"/>
   <p:sldLayoutIdLst>
-    <p:sldLayoutId xmlns:r="http://schemas.openxmlformats.org/officeDocument/2006/relationships" id="2147483649" r:id="Rddd8393df91b485f"/>
+    <p:sldLayoutId xmlns:r="http://schemas.openxmlformats.org/officeDocument/2006/relationships" id="2147483649" r:id="Radc18a526a34415f"/>
   </p:sldLayoutIdLst>
   <p:txStyles>
     <p:titleStyle>
@@ -2979,7 +2979,7 @@
           <p:cNvPr id="6" name="">
             <a:extLst xmlns:a="http://schemas.openxmlformats.org/drawingml/2006/main">
               <a:ext uri="{FF2B5EF4-FFF2-40B4-BE49-F238E27FC236}">
-                <a16:creationId xmlns:a16="http://schemas.microsoft.com/office/drawing/2014/main" id="{20F183E2-6E86-4AA4-BE14-51F549863F7F}"/>
+                <a16:creationId xmlns:a16="http://schemas.microsoft.com/office/drawing/2014/main" id="{9709C7C5-5949-4F64-9D94-6251AA830D44}"/>
               </a:ext>
             </a:extLst>
           </p:cNvPr>
@@ -3026,7 +3026,7 @@
                 <a:ea typeface="Arial"/>
                 <a:cs typeface="Arial"/>
               </a:rPr>
-              <a:t>Proposal quality and candidate evidence</a:t>
+              <a:t>Proposal quality and review choices</a:t>
             </a:r>
           </a:p>
         </p:txBody>
@@ -3036,7 +3036,7 @@
           <p:cNvPr id="2" name="">
             <a:extLst xmlns:a="http://schemas.openxmlformats.org/drawingml/2006/main">
               <a:ext uri="{FF2B5EF4-FFF2-40B4-BE49-F238E27FC236}">
-                <a16:creationId xmlns:a16="http://schemas.microsoft.com/office/drawing/2014/main" id="{F3BD5200-BF7B-4527-949C-D6128B9F5649}"/>
+                <a16:creationId xmlns:a16="http://schemas.microsoft.com/office/drawing/2014/main" id="{1430BA4B-8469-4C39-8DE6-7E345CDF3553}"/>
               </a:ext>
             </a:extLst>
           </p:cNvPr>
@@ -3083,7 +3083,7 @@
                 <a:ea typeface="Arial"/>
                 <a:cs typeface="Arial"/>
               </a:rPr>
-              <a:t>The emailed leans now have explicit local candidate contracts.</a:t>
+              <a:t>Known contract gaps now have concrete proposed answers.</a:t>
             </a:r>
           </a:p>
         </p:txBody>
@@ -3093,7 +3093,7 @@
           <p:cNvPr id="3" name="">
             <a:extLst xmlns:a="http://schemas.openxmlformats.org/drawingml/2006/main">
               <a:ext uri="{FF2B5EF4-FFF2-40B4-BE49-F238E27FC236}">
-                <a16:creationId xmlns:a16="http://schemas.microsoft.com/office/drawing/2014/main" id="{481A6D71-482B-48FB-A5B4-6D64C40DAD2C}"/>
+                <a16:creationId xmlns:a16="http://schemas.microsoft.com/office/drawing/2014/main" id="{F616881D-7C10-4D5F-BCF8-603703F1750E}"/>
               </a:ext>
             </a:extLst>
           </p:cNvPr>
@@ -3140,7 +3140,7 @@
                 <a:ea typeface="Arial"/>
                 <a:cs typeface="Arial"/>
               </a:rPr>
-              <a:t>The group still needs to review those choices. Independently CRS-bound point-instancer prototypes remain a model gap.</a:t>
+              <a:t>Position and model attitude are source inputs. Detailed transform, dataset, instance and scene-chart choices still need author review.</a:t>
             </a:r>
           </a:p>
         </p:txBody>
@@ -3150,7 +3150,7 @@
           <p:cNvPr id="4" name="">
             <a:extLst xmlns:a="http://schemas.openxmlformats.org/drawingml/2006/main">
               <a:ext uri="{FF2B5EF4-FFF2-40B4-BE49-F238E27FC236}">
-                <a16:creationId xmlns:a16="http://schemas.microsoft.com/office/drawing/2014/main" id="{757F7960-0B41-44FF-BED7-C75F50212BAE}"/>
+                <a16:creationId xmlns:a16="http://schemas.microsoft.com/office/drawing/2014/main" id="{24173D9E-658F-4F52-8B42-4B0E7486A06F}"/>
               </a:ext>
             </a:extLst>
           </p:cNvPr>
@@ -3197,7 +3197,7 @@
                 <a:ea typeface="Arial"/>
                 <a:cs typeface="Arial"/>
               </a:rPr>
-              <a:t>64 regressions and 47 distinguishing controls passed.</a:t>
+              <a:t>64 regressions and 61 distinguishing controls passed.</a:t>
             </a:r>
           </a:p>
           <a:p xmlns:a="http://schemas.openxmlformats.org/drawingml/2006/main">
@@ -3220,7 +3220,7 @@
                 <a:ea typeface="Arial"/>
                 <a:cs typeface="Arial"/>
               </a:rPr>
-              <a:t>204,729 coordinate results per Python/C++ path.</a:t>
+              <a:t>213,231 coordinate results per Python/C++ path.</a:t>
             </a:r>
           </a:p>
         </p:txBody>
@@ -3230,7 +3230,7 @@
           <p:cNvPr id="5" name="">
             <a:extLst xmlns:a="http://schemas.openxmlformats.org/drawingml/2006/main">
               <a:ext uri="{FF2B5EF4-FFF2-40B4-BE49-F238E27FC236}">
-                <a16:creationId xmlns:a16="http://schemas.microsoft.com/office/drawing/2014/main" id="{0A20D608-7FCD-4A6F-B8BB-69D2E3DE1932}"/>
+                <a16:creationId xmlns:a16="http://schemas.microsoft.com/office/drawing/2014/main" id="{E2D3918A-F10E-4CDA-A986-A58988764068}"/>
               </a:ext>
             </a:extLst>
           </p:cNvPr>
@@ -3277,7 +3277,7 @@
                 <a:ea typeface="Arial"/>
                 <a:cs typeface="Arial"/>
               </a:rPr>
-              <a:t>Geographic scene frames/bounds remain Q9. Complete proposal conformance is not claimed.</a:t>
+              <a:t>No new computed source properties. Group adoption and whole-proposal conformance are not claimed.</a:t>
             </a:r>
           </a:p>
         </p:txBody>
@@ -3285,7 +3285,7 @@
     </p:spTree>
     <p:extLst>
       <p:ext uri="{BB962C8B-B14F-4D97-AF65-F5344CB8AC3E}">
-        <p14:creationId xmlns:p14="http://schemas.microsoft.com/office/powerpoint/2010/main" val="985122918"/>
+        <p14:creationId xmlns:p14="http://schemas.microsoft.com/office/powerpoint/2010/main" val="387407555"/>
       </p:ext>
     </p:extLst>
   </p:cSld>
@@ -3316,7 +3316,7 @@
           <p:cNvPr id="5" name="">
             <a:extLst xmlns:a="http://schemas.openxmlformats.org/drawingml/2006/main">
               <a:ext uri="{FF2B5EF4-FFF2-40B4-BE49-F238E27FC236}">
-                <a16:creationId xmlns:a16="http://schemas.microsoft.com/office/drawing/2014/main" id="{DC3A6E04-EE57-49A9-977C-08E2F089715E}"/>
+                <a16:creationId xmlns:a16="http://schemas.microsoft.com/office/drawing/2014/main" id="{F49717B1-84CB-4488-90ED-7FB1AFF61B05}"/>
               </a:ext>
             </a:extLst>
           </p:cNvPr>
@@ -3363,7 +3363,7 @@
                 <a:ea typeface="Arial"/>
                 <a:cs typeface="Arial"/>
               </a:rPr>
-              <a:t>Consumer evidence and remaining limits</a:t>
+              <a:t>Verified consumers and remaining evidence limits</a:t>
             </a:r>
           </a:p>
         </p:txBody>
@@ -3537,7 +3537,7 @@
                           <a:ea typeface="Arial"/>
                           <a:cs typeface="Arial"/>
                         </a:rPr>
-                        <a:t>177,846 vertices read back from runtime buffers/matrices. 27 edit, failure and recovery checks. Reuses Python placement.</a:t>
+                        <a:t>177,864 vertices read back from runtime buffers/matrices. 36 edit, failure and recovery checks. Reuses Python placement.</a:t>
                       </a:r>
                     </a:p>
                   </a:txBody>
@@ -3611,7 +3611,7 @@
           <p:cNvPr id="3" name="">
             <a:extLst xmlns:a="http://schemas.openxmlformats.org/drawingml/2006/main">
               <a:ext uri="{FF2B5EF4-FFF2-40B4-BE49-F238E27FC236}">
-                <a16:creationId xmlns:a16="http://schemas.microsoft.com/office/drawing/2014/main" id="{26F41EDE-1C5B-4A12-BAE9-3656950A6F8F}"/>
+                <a16:creationId xmlns:a16="http://schemas.microsoft.com/office/drawing/2014/main" id="{2175C659-6DC6-4808-8495-2CB9C893BD41}"/>
               </a:ext>
             </a:extLst>
           </p:cNvPr>
@@ -3658,7 +3658,7 @@
                 <a:ea typeface="Arial"/>
                 <a:cs typeface="Arial"/>
               </a:rPr>
-              <a:t>Eight exports pass fresh-reader checks. Authored source layers remain unchanged.</a:t>
+              <a:t>All 11 exports pass fresh-reader checks. Geographic scene charts and bound prototypes are covered.</a:t>
             </a:r>
           </a:p>
         </p:txBody>
@@ -3668,7 +3668,7 @@
           <p:cNvPr id="4" name="">
             <a:extLst xmlns:a="http://schemas.openxmlformats.org/drawingml/2006/main">
               <a:ext uri="{FF2B5EF4-FFF2-40B4-BE49-F238E27FC236}">
-                <a16:creationId xmlns:a16="http://schemas.microsoft.com/office/drawing/2014/main" id="{92A9EB75-FD14-4D3E-8696-A87EFDDA2694}"/>
+                <a16:creationId xmlns:a16="http://schemas.microsoft.com/office/drawing/2014/main" id="{4C411C8D-7134-4CB7-8215-3C62679BAFE5}"/>
               </a:ext>
             </a:extLst>
           </p:cNvPr>
@@ -3715,7 +3715,7 @@
                 <a:ea typeface="Arial"/>
                 <a:cs typeface="Arial"/>
               </a:rPr>
-              <a:t>Remaining limits: bound point-instancer prototypes, geographic scene frames/bounds, continuous nonlinear certificates and physics integration. Candidate choices still need group review.</a:t>
+              <a:t>Remaining evidence limits: continuous nonlinear certificates, general primvar coverage and physics integration. Detailed candidate choices still need author review.</a:t>
             </a:r>
           </a:p>
         </p:txBody>
@@ -3723,7 +3723,7 @@
     </p:spTree>
     <p:extLst>
       <p:ext uri="{BB962C8B-B14F-4D97-AF65-F5344CB8AC3E}">
-        <p14:creationId xmlns:p14="http://schemas.microsoft.com/office/powerpoint/2010/main" val="591610580"/>
+        <p14:creationId xmlns:p14="http://schemas.microsoft.com/office/powerpoint/2010/main" val="814754788"/>
       </p:ext>
     </p:extLst>
   </p:cSld>
@@ -3754,7 +3754,7 @@
           <p:cNvPr id="4" name="">
             <a:extLst xmlns:a="http://schemas.openxmlformats.org/drawingml/2006/main">
               <a:ext uri="{FF2B5EF4-FFF2-40B4-BE49-F238E27FC236}">
-                <a16:creationId xmlns:a16="http://schemas.microsoft.com/office/drawing/2014/main" id="{3E35642A-1BA7-40D3-B8B0-F28E145E70C1}"/>
+                <a16:creationId xmlns:a16="http://schemas.microsoft.com/office/drawing/2014/main" id="{898F8119-5EF2-4445-832B-B33FA1D6B68A}"/>
               </a:ext>
             </a:extLst>
           </p:cNvPr>
@@ -3801,7 +3801,7 @@
                 <a:ea typeface="Arial"/>
                 <a:cs typeface="Arial"/>
               </a:rPr>
-              <a:t>Concrete contracts for group review</a:t>
+              <a:t>Authored inputs and computed results</a:t>
             </a:r>
           </a:p>
         </p:txBody>
@@ -3814,7 +3814,7 @@
         </p:nvGraphicFramePr>
         <p:xfrm>
           <a:off xmlns:a="http://schemas.openxmlformats.org/drawingml/2006/main" x="609600" y="1428750"/>
-          <a:ext xmlns:a="http://schemas.openxmlformats.org/drawingml/2006/main" cx="10972800" cy="4429125"/>
+          <a:ext xmlns:a="http://schemas.openxmlformats.org/drawingml/2006/main" cx="10972800" cy="4286250"/>
         </p:xfrm>
         <a:graphic xmlns:a="http://schemas.openxmlformats.org/drawingml/2006/main">
           <a:graphicData uri="http://schemas.openxmlformats.org/drawingml/2006/table">
@@ -3824,7 +3824,7 @@
                 <a:gridCol w="2857500"/>
                 <a:gridCol w="8115300"/>
               </a:tblGrid>
-              <a:tr h="885825">
+              <a:tr h="714375">
                 <a:tc>
                   <a:txBody>
                     <a:bodyPr>
@@ -3833,7 +3833,7 @@
                     <a:lstStyle/>
                     <a:p>
                       <a:r>
-                        <a:rPr sz="1875" b="1">
+                        <a:rPr sz="1800" b="1">
                           <a:solidFill>
                             <a:srgbClr val="FFFFFF"/>
                           </a:solidFill>
@@ -3841,7 +3841,7 @@
                           <a:ea typeface="Arial"/>
                           <a:cs typeface="Arial"/>
                         </a:rPr>
-                        <a:t>Subject</a:t>
+                        <a:t>Authored inputs</a:t>
                       </a:r>
                     </a:p>
                   </a:txBody>
@@ -3859,7 +3859,7 @@
                     <a:lstStyle/>
                     <a:p>
                       <a:r>
-                        <a:rPr sz="1875" b="1">
+                        <a:rPr sz="1800" b="1">
                           <a:solidFill>
                             <a:srgbClr val="FFFFFF"/>
                           </a:solidFill>
@@ -3867,7 +3867,7 @@
                           <a:ea typeface="Arial"/>
                           <a:cs typeface="Arial"/>
                         </a:rPr>
-                        <a:t>Concrete candidate answer</a:t>
+                        <a:t>Meaning in the proposed model</a:t>
                       </a:r>
                     </a:p>
                   </a:txBody>
@@ -3878,7 +3878,7 @@
                   </a:tcPr>
                 </a:tc>
               </a:tr>
-              <a:tr h="885825">
+              <a:tr h="714375">
                 <a:tc>
                   <a:txBody>
                     <a:bodyPr>
@@ -3887,7 +3887,7 @@
                     <a:lstStyle/>
                     <a:p>
                       <a:r>
-                        <a:rPr sz="1875" b="0">
+                        <a:rPr sz="1800" b="0">
                           <a:solidFill>
                             <a:srgbClr val="213744"/>
                           </a:solidFill>
@@ -3895,7 +3895,7 @@
                           <a:ea typeface="Arial"/>
                           <a:cs typeface="Arial"/>
                         </a:rPr>
-                        <a:t>Q3: working frame</a:t>
+                        <a:t>crs:position</a:t>
                       </a:r>
                     </a:p>
                   </a:txBody>
@@ -3913,7 +3913,7 @@
                     <a:lstStyle/>
                     <a:p>
                       <a:r>
-                        <a:rPr sz="1875" b="0">
+                        <a:rPr sz="1800" b="0">
                           <a:solidFill>
                             <a:srgbClr val="213744"/>
                           </a:solidFill>
@@ -3921,7 +3921,7 @@
                           <a:ea typeface="Arial"/>
                           <a:cs typeface="Arial"/>
                         </a:rPr>
-                        <a:t>Nearest enclosing CRS fixes the adjustment chart. The candidate specifies origins, pivots and descendant resets.</a:t>
+                        <a:t>Absolute 3D model origin in source WKT components, units and height reference.</a:t>
                       </a:r>
                     </a:p>
                   </a:txBody>
@@ -3932,7 +3932,7 @@
                   </a:tcPr>
                 </a:tc>
               </a:tr>
-              <a:tr h="885825">
+              <a:tr h="714375">
                 <a:tc>
                   <a:txBody>
                     <a:bodyPr>
@@ -3941,7 +3941,7 @@
                     <a:lstStyle/>
                     <a:p>
                       <a:r>
-                        <a:rPr sz="1875" b="0">
+                        <a:rPr sz="1800" b="0">
                           <a:solidFill>
                             <a:srgbClr val="213744"/>
                           </a:solidFill>
@@ -3949,7 +3949,7 @@
                           <a:ea typeface="Arial"/>
                           <a:cs typeface="Arial"/>
                         </a:rPr>
-                        <a:t>Q6: axes and units</a:t>
+                        <a:t>crs:orientation</a:t>
                       </a:r>
                     </a:p>
                   </a:txBody>
@@ -3967,7 +3967,7 @@
                     <a:lstStyle/>
                     <a:p>
                       <a:r>
-                        <a:rPr sz="1875" b="0">
+                        <a:rPr sz="1800" b="0">
                           <a:solidFill>
                             <a:srgbClr val="213744"/>
                           </a:solidFill>
@@ -3975,7 +3975,7 @@
                           <a:ea typeface="Arial"/>
                           <a:cs typeface="Arial"/>
                         </a:rPr>
-                        <a:t>Z-up: (x,y,z). Y-up: (x,-z,y). Convert stage units before scale and orientation.</a:t>
+                        <a:t>Physical geodetic ENU model attitude; identity fallback. Distinct from projected grid convergence.</a:t>
                       </a:r>
                     </a:p>
                   </a:txBody>
@@ -3986,7 +3986,7 @@
                   </a:tcPr>
                 </a:tc>
               </a:tr>
-              <a:tr h="885825">
+              <a:tr h="714375">
                 <a:tc>
                   <a:txBody>
                     <a:bodyPr>
@@ -3995,7 +3995,7 @@
                     <a:lstStyle/>
                     <a:p>
                       <a:r>
-                        <a:rPr sz="1875" b="0">
+                        <a:rPr sz="1800" b="0">
                           <a:solidFill>
                             <a:srgbClr val="213744"/>
                           </a:solidFill>
@@ -4003,7 +4003,7 @@
                           <a:ea typeface="Arial"/>
                           <a:cs typeface="Arial"/>
                         </a:rPr>
-                        <a:t>Q11: measurements</a:t>
+                        <a:t>Ordinary xformOps</a:t>
                       </a:r>
                     </a:p>
                   </a:txBody>
@@ -4021,7 +4021,7 @@
                     <a:lstStyle/>
                     <a:p>
                       <a:r>
-                        <a:rPr sz="1875" b="0">
+                        <a:rPr sz="1800" b="0">
                           <a:solidFill>
                             <a:srgbClr val="213744"/>
                           </a:solidFill>
@@ -4029,7 +4029,7 @@
                           <a:ea typeface="Arial"/>
                           <a:cs typeface="Arial"/>
                         </a:rPr>
-                        <a:t>A proposed non-Xformable data-source schema selects asset, format, field and coordinate domain. Native formats retain values and times.</a:t>
+                        <a:t>Intentional scale, pivots and project adjustment. Descendant stacks retain model-local meaning.</a:t>
                       </a:r>
                     </a:p>
                   </a:txBody>
@@ -4040,7 +4040,7 @@
                   </a:tcPr>
                 </a:tc>
               </a:tr>
-              <a:tr h="885825">
+              <a:tr h="714375">
                 <a:tc>
                   <a:txBody>
                     <a:bodyPr>
@@ -4049,7 +4049,7 @@
                     <a:lstStyle/>
                     <a:p>
                       <a:r>
-                        <a:rPr sz="1875" b="0">
+                        <a:rPr sz="1800" b="0">
                           <a:solidFill>
                             <a:srgbClr val="213744"/>
                           </a:solidFill>
@@ -4057,7 +4057,7 @@
                           <a:ea typeface="Arial"/>
                           <a:cs typeface="Arial"/>
                         </a:rPr>
-                        <a:t>Q12: dependency</a:t>
+                        <a:t>Native data association</a:t>
                       </a:r>
                     </a:p>
                   </a:txBody>
@@ -4075,7 +4075,7 @@
                     <a:lstStyle/>
                     <a:p>
                       <a:r>
-                        <a:rPr sz="1875" b="0">
+                        <a:rPr sz="1800" b="0">
                           <a:solidFill>
                             <a:srgbClr val="213744"/>
                           </a:solidFill>
@@ -4083,7 +4083,61 @@
                           <a:ea typeface="Arial"/>
                           <a:cs typeface="Arial"/>
                         </a:rPr>
-                        <a:t>Profiles on defaultPrim carries a conservative hard capability claim for the whole scene, including unloaded content.</a:t>
+                        <a:t>Asset, format, field and coordinate domain. Values, masks and observation times remain native.</a:t>
+                      </a:r>
+                    </a:p>
+                  </a:txBody>
+                  <a:tcPr marL="91440" marR="91440" marT="45720" marB="45720">
+                    <a:solidFill>
+                      <a:srgbClr val="FFFFFF"/>
+                    </a:solidFill>
+                  </a:tcPr>
+                </a:tc>
+              </a:tr>
+              <a:tr h="714375">
+                <a:tc>
+                  <a:txBody>
+                    <a:bodyPr>
+                      <a:noAutofit/>
+                    </a:bodyPr>
+                    <a:lstStyle/>
+                    <a:p>
+                      <a:r>
+                        <a:rPr sz="1800" b="0">
+                          <a:solidFill>
+                            <a:srgbClr val="213744"/>
+                          </a:solidFill>
+                          <a:latin typeface="Arial"/>
+                          <a:ea typeface="Arial"/>
+                          <a:cs typeface="Arial"/>
+                        </a:rPr>
+                        <a:t>Computed results</a:t>
+                      </a:r>
+                    </a:p>
+                  </a:txBody>
+                  <a:tcPr marL="91440" marR="91440" marT="45720" marB="45720">
+                    <a:solidFill>
+                      <a:srgbClr val="FFFFFF"/>
+                    </a:solidFill>
+                  </a:tcPr>
+                </a:tc>
+                <a:tc>
+                  <a:txBody>
+                    <a:bodyPr>
+                      <a:noAutofit/>
+                    </a:bodyPr>
+                    <a:lstStyle/>
+                    <a:p>
+                      <a:r>
+                        <a:rPr sz="1800" b="0">
+                          <a:solidFill>
+                            <a:srgbClr val="213744"/>
+                          </a:solidFill>
+                          <a:latin typeface="Arial"/>
+                          <a:ea typeface="Arial"/>
+                          <a:cs typeface="Arial"/>
+                        </a:rPr>
+                        <a:t>Resolution, convergence, projection scale and bounds are results; no crs:scale source property.</a:t>
                       </a:r>
                     </a:p>
                   </a:txBody>
@@ -4103,7 +4157,7 @@
           <p:cNvPr id="3" name="">
             <a:extLst xmlns:a="http://schemas.openxmlformats.org/drawingml/2006/main">
               <a:ext uri="{FF2B5EF4-FFF2-40B4-BE49-F238E27FC236}">
-                <a16:creationId xmlns:a16="http://schemas.microsoft.com/office/drawing/2014/main" id="{6863E12C-EB80-48BA-B9A9-733253B381BF}"/>
+                <a16:creationId xmlns:a16="http://schemas.microsoft.com/office/drawing/2014/main" id="{9078AFF5-3C70-4379-AC93-8ED726D26658}"/>
               </a:ext>
             </a:extLst>
           </p:cNvPr>
@@ -4150,7 +4204,7 @@
                 <a:ea typeface="Arial"/>
                 <a:cs typeface="Arial"/>
               </a:rPr>
-              <a:t>These are proposed details, including a new external-association schema. Passing tests does not establish group agreement.</a:t>
+              <a:t>This is a complete review candidate. Tests do not establish author agreement to the detailed choices.</a:t>
             </a:r>
           </a:p>
         </p:txBody>
@@ -4158,7 +4212,7 @@
     </p:spTree>
     <p:extLst>
       <p:ext uri="{BB962C8B-B14F-4D97-AF65-F5344CB8AC3E}">
-        <p14:creationId xmlns:p14="http://schemas.microsoft.com/office/powerpoint/2010/main" val="919488112"/>
+        <p14:creationId xmlns:p14="http://schemas.microsoft.com/office/powerpoint/2010/main" val="859447311"/>
       </p:ext>
     </p:extLst>
   </p:cSld>
@@ -4189,7 +4243,7 @@
           <p:cNvPr id="6" name="">
             <a:extLst xmlns:a="http://schemas.openxmlformats.org/drawingml/2006/main">
               <a:ext uri="{FF2B5EF4-FFF2-40B4-BE49-F238E27FC236}">
-                <a16:creationId xmlns:a16="http://schemas.microsoft.com/office/drawing/2014/main" id="{BF79E4CA-3A3E-4B7B-AF78-4B84C072AF1F}"/>
+                <a16:creationId xmlns:a16="http://schemas.microsoft.com/office/drawing/2014/main" id="{C766EBB2-01C0-4D95-B64A-25957D7CE6DB}"/>
               </a:ext>
             </a:extLst>
           </p:cNvPr>
@@ -4236,7 +4290,7 @@
                 <a:ea typeface="Arial"/>
                 <a:cs typeface="Arial"/>
               </a:rPr>
-              <a:t>A fixed working frame for project adjustments</a:t>
+              <a:t>Anchor adjustments and model-local descendants</a:t>
             </a:r>
           </a:p>
         </p:txBody>
@@ -4246,7 +4300,7 @@
           <p:cNvPr id="2" name="">
             <a:extLst xmlns:a="http://schemas.openxmlformats.org/drawingml/2006/main">
               <a:ext uri="{FF2B5EF4-FFF2-40B4-BE49-F238E27FC236}">
-                <a16:creationId xmlns:a16="http://schemas.microsoft.com/office/drawing/2014/main" id="{53E13377-E809-4778-8C4C-FC949E32EA2F}"/>
+                <a16:creationId xmlns:a16="http://schemas.microsoft.com/office/drawing/2014/main" id="{8DD487D3-E216-4620-8511-8C8E8124C8E4}"/>
               </a:ext>
             </a:extLst>
           </p:cNvPr>
@@ -4751,7 +4805,7 @@
           <p:cNvPr id="4" name="">
             <a:extLst xmlns:a="http://schemas.openxmlformats.org/drawingml/2006/main">
               <a:ext uri="{FF2B5EF4-FFF2-40B4-BE49-F238E27FC236}">
-                <a16:creationId xmlns:a16="http://schemas.microsoft.com/office/drawing/2014/main" id="{AE676D42-5B4E-488D-AAF0-81EAB55BC93E}"/>
+                <a16:creationId xmlns:a16="http://schemas.microsoft.com/office/drawing/2014/main" id="{05DF5E75-851C-49E4-B30A-C4B1609898E1}"/>
               </a:ext>
             </a:extLst>
           </p:cNvPr>
@@ -4831,7 +4885,7 @@
           <p:cNvPr id="5" name="">
             <a:extLst xmlns:a="http://schemas.openxmlformats.org/drawingml/2006/main">
               <a:ext uri="{FF2B5EF4-FFF2-40B4-BE49-F238E27FC236}">
-                <a16:creationId xmlns:a16="http://schemas.microsoft.com/office/drawing/2014/main" id="{183AF568-FFD9-45EA-BEF4-B1D4B9EF4EFE}"/>
+                <a16:creationId xmlns:a16="http://schemas.microsoft.com/office/drawing/2014/main" id="{00D66EFD-816C-47FF-8C09-E5755E66DCF6}"/>
               </a:ext>
             </a:extLst>
           </p:cNvPr>
@@ -4878,7 +4932,7 @@
                 <a:ea typeface="Arial"/>
                 <a:cs typeface="Arial"/>
               </a:rPr>
-              <a:t>Reprojection to ECEF preserves the same adjusted physical result. Ordinary parent transforms remain excluded at a direct binding.</a:t>
+              <a:t>The raw working-axis child alternative differs by 4.222 m. Descendant semantics are proposed for review.</a:t>
             </a:r>
           </a:p>
         </p:txBody>
@@ -4886,7 +4940,7 @@
     </p:spTree>
     <p:extLst>
       <p:ext uri="{BB962C8B-B14F-4D97-AF65-F5344CB8AC3E}">
-        <p14:creationId xmlns:p14="http://schemas.microsoft.com/office/powerpoint/2010/main" val="1946306800"/>
+        <p14:creationId xmlns:p14="http://schemas.microsoft.com/office/powerpoint/2010/main" val="651390213"/>
       </p:ext>
     </p:extLst>
   </p:cSld>
@@ -4917,7 +4971,7 @@
           <p:cNvPr id="7" name="">
             <a:extLst xmlns:a="http://schemas.openxmlformats.org/drawingml/2006/main">
               <a:ext uri="{FF2B5EF4-FFF2-40B4-BE49-F238E27FC236}">
-                <a16:creationId xmlns:a16="http://schemas.microsoft.com/office/drawing/2014/main" id="{FE900492-1FC5-4953-9957-84929CE9C45A}"/>
+                <a16:creationId xmlns:a16="http://schemas.microsoft.com/office/drawing/2014/main" id="{02060096-28E2-417D-B655-51EA4C21960C}"/>
               </a:ext>
             </a:extLst>
           </p:cNvPr>
@@ -4964,7 +5018,7 @@
                 <a:ea typeface="Arial"/>
                 <a:cs typeface="Arial"/>
               </a:rPr>
-              <a:t>Eiffel geometry in the native Hydra consumer</a:t>
+              <a:t>Eiffel geometry in native Hydra / Storm</a:t>
             </a:r>
           </a:p>
         </p:txBody>
@@ -4978,7 +5032,7 @@
           <p:nvPr/>
         </p:nvPicPr>
         <p:blipFill>
-          <a:blip xmlns:r="http://schemas.openxmlformats.org/officeDocument/2006/relationships" xmlns:a="http://schemas.openxmlformats.org/drawingml/2006/main" r:embed="R06b4362a47174dda"/>
+          <a:blip xmlns:r="http://schemas.openxmlformats.org/officeDocument/2006/relationships" xmlns:a="http://schemas.openxmlformats.org/drawingml/2006/main" r:embed="R0654262e2e72446b"/>
           <a:stretch xmlns:a="http://schemas.openxmlformats.org/drawingml/2006/main"/>
         </p:blipFill>
         <p:spPr>
@@ -4996,7 +5050,7 @@
           <p:cNvPr id="3" name="">
             <a:extLst xmlns:a="http://schemas.openxmlformats.org/drawingml/2006/main">
               <a:ext uri="{FF2B5EF4-FFF2-40B4-BE49-F238E27FC236}">
-                <a16:creationId xmlns:a16="http://schemas.microsoft.com/office/drawing/2014/main" id="{4AEA1437-A405-4ED1-AB68-3F9B30CB6BEB}"/>
+                <a16:creationId xmlns:a16="http://schemas.microsoft.com/office/drawing/2014/main" id="{14F196C6-98C0-46D4-A42B-88272699349F}"/>
               </a:ext>
             </a:extLst>
           </p:cNvPr>
@@ -5053,7 +5107,7 @@
           <p:cNvPr id="4" name="">
             <a:extLst xmlns:a="http://schemas.openxmlformats.org/drawingml/2006/main">
               <a:ext uri="{FF2B5EF4-FFF2-40B4-BE49-F238E27FC236}">
-                <a16:creationId xmlns:a16="http://schemas.microsoft.com/office/drawing/2014/main" id="{22ED5F05-AA62-46E1-AE3D-A607F5FECBD1}"/>
+                <a16:creationId xmlns:a16="http://schemas.microsoft.com/office/drawing/2014/main" id="{61365638-CC26-4039-91FE-38E284B35684}"/>
               </a:ext>
             </a:extLst>
           </p:cNvPr>
@@ -5123,7 +5177,7 @@
                 <a:ea typeface="Arial"/>
                 <a:cs typeface="Arial"/>
               </a:rPr>
-              <a:t>Fresh USD export readers</a:t>
+              <a:t>163,416 shading normals</a:t>
             </a:r>
           </a:p>
           <a:p xmlns:a="http://schemas.openxmlformats.org/drawingml/2006/main">
@@ -5146,7 +5200,7 @@
                 <a:ea typeface="Arial"/>
                 <a:cs typeface="Arial"/>
               </a:rPr>
-              <a:t>Hydra points and transforms</a:t>
+              <a:t>Fresh USD export readers</a:t>
             </a:r>
           </a:p>
           <a:p xmlns:a="http://schemas.openxmlformats.org/drawingml/2006/main">
@@ -5179,7 +5233,7 @@
           <p:cNvPr id="5" name="">
             <a:extLst xmlns:a="http://schemas.openxmlformats.org/drawingml/2006/main">
               <a:ext uri="{FF2B5EF4-FFF2-40B4-BE49-F238E27FC236}">
-                <a16:creationId xmlns:a16="http://schemas.microsoft.com/office/drawing/2014/main" id="{2909EF76-FD20-47BB-AD00-C9B597419E55}"/>
+                <a16:creationId xmlns:a16="http://schemas.microsoft.com/office/drawing/2014/main" id="{11F5003E-E044-4DED-886A-DDB8A0DB1686}"/>
               </a:ext>
             </a:extLst>
           </p:cNvPr>
@@ -5259,7 +5313,7 @@
           <p:cNvPr id="6" name="">
             <a:extLst xmlns:a="http://schemas.openxmlformats.org/drawingml/2006/main">
               <a:ext uri="{FF2B5EF4-FFF2-40B4-BE49-F238E27FC236}">
-                <a16:creationId xmlns:a16="http://schemas.microsoft.com/office/drawing/2014/main" id="{DB3E8D27-57B8-4C69-9469-5BFC2D3FC453}"/>
+                <a16:creationId xmlns:a16="http://schemas.microsoft.com/office/drawing/2014/main" id="{F8E54D7A-7988-48AD-A20A-AEA72475353C}"/>
               </a:ext>
             </a:extLst>
           </p:cNvPr>
@@ -5314,7 +5368,7 @@
     </p:spTree>
     <p:extLst>
       <p:ext uri="{BB962C8B-B14F-4D97-AF65-F5344CB8AC3E}">
-        <p14:creationId xmlns:p14="http://schemas.microsoft.com/office/powerpoint/2010/main" val="423970486"/>
+        <p14:creationId xmlns:p14="http://schemas.microsoft.com/office/powerpoint/2010/main" val="1742066659"/>
       </p:ext>
     </p:extLst>
   </p:cSld>
@@ -5345,7 +5399,7 @@
           <p:cNvPr id="7" name="">
             <a:extLst xmlns:a="http://schemas.openxmlformats.org/drawingml/2006/main">
               <a:ext uri="{FF2B5EF4-FFF2-40B4-BE49-F238E27FC236}">
-                <a16:creationId xmlns:a16="http://schemas.microsoft.com/office/drawing/2014/main" id="{5049A040-A04B-4A8E-95A9-71017F61A1F8}"/>
+                <a16:creationId xmlns:a16="http://schemas.microsoft.com/office/drawing/2014/main" id="{C11A9428-4E45-4D7A-B49B-B162F9C5E911}"/>
               </a:ext>
             </a:extLst>
           </p:cNvPr>
@@ -5392,7 +5446,7 @@
                 <a:ea typeface="Arial"/>
                 <a:cs typeface="Arial"/>
               </a:rPr>
-              <a:t>Colorado survey geometry in a calibrated site</a:t>
+              <a:t>Colorado survey in a calibrated site</a:t>
             </a:r>
           </a:p>
         </p:txBody>
@@ -5406,7 +5460,7 @@
           <p:nvPr/>
         </p:nvPicPr>
         <p:blipFill>
-          <a:blip xmlns:r="http://schemas.openxmlformats.org/officeDocument/2006/relationships" xmlns:a="http://schemas.openxmlformats.org/drawingml/2006/main" r:embed="Racf75f57d7e341fa"/>
+          <a:blip xmlns:r="http://schemas.openxmlformats.org/officeDocument/2006/relationships" xmlns:a="http://schemas.openxmlformats.org/drawingml/2006/main" r:embed="R498990e703bf4387"/>
           <a:stretch xmlns:a="http://schemas.openxmlformats.org/drawingml/2006/main"/>
         </p:blipFill>
         <p:spPr>
@@ -5424,7 +5478,7 @@
           <p:cNvPr id="3" name="">
             <a:extLst xmlns:a="http://schemas.openxmlformats.org/drawingml/2006/main">
               <a:ext uri="{FF2B5EF4-FFF2-40B4-BE49-F238E27FC236}">
-                <a16:creationId xmlns:a16="http://schemas.microsoft.com/office/drawing/2014/main" id="{417DC696-436A-472B-9D49-75EC0AB43452}"/>
+                <a16:creationId xmlns:a16="http://schemas.microsoft.com/office/drawing/2014/main" id="{D7606484-FC0F-4ADE-95A4-FA923BF49AB5}"/>
               </a:ext>
             </a:extLst>
           </p:cNvPr>
@@ -5481,7 +5535,7 @@
           <p:cNvPr id="4" name="">
             <a:extLst xmlns:a="http://schemas.openxmlformats.org/drawingml/2006/main">
               <a:ext uri="{FF2B5EF4-FFF2-40B4-BE49-F238E27FC236}">
-                <a16:creationId xmlns:a16="http://schemas.microsoft.com/office/drawing/2014/main" id="{39B56DF1-2661-43F9-B3E3-550D4FC5DDEB}"/>
+                <a16:creationId xmlns:a16="http://schemas.microsoft.com/office/drawing/2014/main" id="{7EB658BA-230C-430A-BFF6-3F1627288571}"/>
               </a:ext>
             </a:extLst>
           </p:cNvPr>
@@ -5607,7 +5661,7 @@
           <p:cNvPr id="5" name="">
             <a:extLst xmlns:a="http://schemas.openxmlformats.org/drawingml/2006/main">
               <a:ext uri="{FF2B5EF4-FFF2-40B4-BE49-F238E27FC236}">
-                <a16:creationId xmlns:a16="http://schemas.microsoft.com/office/drawing/2014/main" id="{4EFCCED7-F343-43C0-90F9-37189263546B}"/>
+                <a16:creationId xmlns:a16="http://schemas.microsoft.com/office/drawing/2014/main" id="{5D9F2A6E-DBBB-46F9-886C-29706B571227}"/>
               </a:ext>
             </a:extLst>
           </p:cNvPr>
@@ -5687,7 +5741,7 @@
           <p:cNvPr id="6" name="">
             <a:extLst xmlns:a="http://schemas.openxmlformats.org/drawingml/2006/main">
               <a:ext uri="{FF2B5EF4-FFF2-40B4-BE49-F238E27FC236}">
-                <a16:creationId xmlns:a16="http://schemas.microsoft.com/office/drawing/2014/main" id="{DC6F2A8D-55A0-4525-84B3-9B63354B360C}"/>
+                <a16:creationId xmlns:a16="http://schemas.microsoft.com/office/drawing/2014/main" id="{A77B112D-63E6-4286-8DC7-1C9EEC440CA0}"/>
               </a:ext>
             </a:extLst>
           </p:cNvPr>
@@ -5742,7 +5796,7 @@
     </p:spTree>
     <p:extLst>
       <p:ext uri="{BB962C8B-B14F-4D97-AF65-F5344CB8AC3E}">
-        <p14:creationId xmlns:p14="http://schemas.microsoft.com/office/powerpoint/2010/main" val="2130764067"/>
+        <p14:creationId xmlns:p14="http://schemas.microsoft.com/office/powerpoint/2010/main" val="1185984270"/>
       </p:ext>
     </p:extLst>
   </p:cSld>
@@ -5773,7 +5827,7 @@
           <p:cNvPr id="5" name="">
             <a:extLst xmlns:a="http://schemas.openxmlformats.org/drawingml/2006/main">
               <a:ext uri="{FF2B5EF4-FFF2-40B4-BE49-F238E27FC236}">
-                <a16:creationId xmlns:a16="http://schemas.microsoft.com/office/drawing/2014/main" id="{198705F0-18FA-4A33-A0AD-0586A5135D52}"/>
+                <a16:creationId xmlns:a16="http://schemas.microsoft.com/office/drawing/2014/main" id="{2533BB52-F4A7-49C7-8838-1E77013B3BA7}"/>
               </a:ext>
             </a:extLst>
           </p:cNvPr>
@@ -5820,7 +5874,7 @@
                 <a:ea typeface="Arial"/>
                 <a:cs typeface="Arial"/>
               </a:rPr>
-              <a:t>Georeferenced measurements remain usable as data</a:t>
+              <a:t>Global measurements in geographic and ECEF coordinates</a:t>
             </a:r>
           </a:p>
         </p:txBody>
@@ -5834,7 +5888,7 @@
           <p:nvPr/>
         </p:nvPicPr>
         <p:blipFill>
-          <a:blip xmlns:r="http://schemas.openxmlformats.org/officeDocument/2006/relationships" xmlns:a="http://schemas.openxmlformats.org/drawingml/2006/main" r:embed="Rc1bd0301090b4eb1"/>
+          <a:blip xmlns:r="http://schemas.openxmlformats.org/officeDocument/2006/relationships" xmlns:a="http://schemas.openxmlformats.org/drawingml/2006/main" r:embed="R2c43a07783f0466d"/>
           <a:stretch xmlns:a="http://schemas.openxmlformats.org/drawingml/2006/main"/>
         </p:blipFill>
         <p:spPr>
@@ -5852,7 +5906,7 @@
           <p:cNvPr id="3" name="">
             <a:extLst xmlns:a="http://schemas.openxmlformats.org/drawingml/2006/main">
               <a:ext uri="{FF2B5EF4-FFF2-40B4-BE49-F238E27FC236}">
-                <a16:creationId xmlns:a16="http://schemas.microsoft.com/office/drawing/2014/main" id="{2C331095-46A3-4F56-A135-51FDF7657FBD}"/>
+                <a16:creationId xmlns:a16="http://schemas.microsoft.com/office/drawing/2014/main" id="{50949073-DA8D-4CC3-A956-7D262D8DD517}"/>
               </a:ext>
             </a:extLst>
           </p:cNvPr>
@@ -5899,7 +5953,7 @@
                 <a:ea typeface="Arial"/>
                 <a:cs typeface="Arial"/>
               </a:rPr>
-              <a:t>2,664 original values and horizontal coordinates remain paired.</a:t>
+              <a:t>154 synthetic 3D samples retain values and two observation times.</a:t>
             </a:r>
           </a:p>
         </p:txBody>
@@ -5909,7 +5963,7 @@
           <p:cNvPr id="4" name="">
             <a:extLst xmlns:a="http://schemas.openxmlformats.org/drawingml/2006/main">
               <a:ext uri="{FF2B5EF4-FFF2-40B4-BE49-F238E27FC236}">
-                <a16:creationId xmlns:a16="http://schemas.microsoft.com/office/drawing/2014/main" id="{4C288A83-86E9-4FE1-AABF-B360B067FB26}"/>
+                <a16:creationId xmlns:a16="http://schemas.microsoft.com/office/drawing/2014/main" id="{FBE2CEF1-3D7C-4534-9306-681A2C194252}"/>
               </a:ext>
             </a:extLst>
           </p:cNvPr>
@@ -5956,7 +6010,7 @@
                 <a:ea typeface="Arial"/>
                 <a:cs typeface="Arial"/>
               </a:rPr>
-              <a:t>The association invents no height, physical units or observation times. A 3D request fails without a height reference and coordinate.</a:t>
+              <a:t>Explicit 100 m ellipsoidal height; illustrative temperature in kelvin. Both readers resolve geographic and ECEF outputs. Observation time is distinct from epoch.</a:t>
             </a:r>
           </a:p>
         </p:txBody>
@@ -5964,7 +6018,7 @@
     </p:spTree>
     <p:extLst>
       <p:ext uri="{BB962C8B-B14F-4D97-AF65-F5344CB8AC3E}">
-        <p14:creationId xmlns:p14="http://schemas.microsoft.com/office/powerpoint/2010/main" val="873845668"/>
+        <p14:creationId xmlns:p14="http://schemas.microsoft.com/office/powerpoint/2010/main" val="1201974988"/>
       </p:ext>
     </p:extLst>
   </p:cSld>
@@ -5995,7 +6049,7 @@
           <p:cNvPr id="7" name="">
             <a:extLst xmlns:a="http://schemas.openxmlformats.org/drawingml/2006/main">
               <a:ext uri="{FF2B5EF4-FFF2-40B4-BE49-F238E27FC236}">
-                <a16:creationId xmlns:a16="http://schemas.microsoft.com/office/drawing/2014/main" id="{E1E8AA9A-C937-4953-9747-3CB3A0E91012}"/>
+                <a16:creationId xmlns:a16="http://schemas.microsoft.com/office/drawing/2014/main" id="{3331E018-4635-416F-AAF2-79E65E7425A5}"/>
               </a:ext>
             </a:extLst>
           </p:cNvPr>
@@ -6042,7 +6096,7 @@
                 <a:ea typeface="Arial"/>
                 <a:cs typeface="Arial"/>
               </a:rPr>
-              <a:t>Regional geometry retains its source coordinates</a:t>
+              <a:t>Railway geometry retains its source coordinates</a:t>
             </a:r>
           </a:p>
         </p:txBody>
@@ -6056,7 +6110,7 @@
           <p:nvPr/>
         </p:nvPicPr>
         <p:blipFill>
-          <a:blip xmlns:r="http://schemas.openxmlformats.org/officeDocument/2006/relationships" xmlns:a="http://schemas.openxmlformats.org/drawingml/2006/main" r:embed="Rd86f07368a3c49c8"/>
+          <a:blip xmlns:r="http://schemas.openxmlformats.org/officeDocument/2006/relationships" xmlns:a="http://schemas.openxmlformats.org/drawingml/2006/main" r:embed="R5ae96a8ae9c14ab3"/>
           <a:stretch xmlns:a="http://schemas.openxmlformats.org/drawingml/2006/main"/>
         </p:blipFill>
         <p:spPr>
@@ -6074,7 +6128,7 @@
           <p:cNvPr id="3" name="">
             <a:extLst xmlns:a="http://schemas.openxmlformats.org/drawingml/2006/main">
               <a:ext uri="{FF2B5EF4-FFF2-40B4-BE49-F238E27FC236}">
-                <a16:creationId xmlns:a16="http://schemas.microsoft.com/office/drawing/2014/main" id="{11621353-0A90-42BC-A14C-4502E9D6155B}"/>
+                <a16:creationId xmlns:a16="http://schemas.microsoft.com/office/drawing/2014/main" id="{CCFCBC98-4AD5-4F3F-AC4E-1421302A7ABE}"/>
               </a:ext>
             </a:extLst>
           </p:cNvPr>
@@ -6131,7 +6185,7 @@
           <p:cNvPr id="4" name="">
             <a:extLst xmlns:a="http://schemas.openxmlformats.org/drawingml/2006/main">
               <a:ext uri="{FF2B5EF4-FFF2-40B4-BE49-F238E27FC236}">
-                <a16:creationId xmlns:a16="http://schemas.microsoft.com/office/drawing/2014/main" id="{E0CD636D-BD57-4162-978C-A47A8179B801}"/>
+                <a16:creationId xmlns:a16="http://schemas.microsoft.com/office/drawing/2014/main" id="{25F9D69D-5F36-476B-AC69-20417FDA5BD1}"/>
               </a:ext>
             </a:extLst>
           </p:cNvPr>
@@ -6257,7 +6311,7 @@
           <p:cNvPr id="5" name="">
             <a:extLst xmlns:a="http://schemas.openxmlformats.org/drawingml/2006/main">
               <a:ext uri="{FF2B5EF4-FFF2-40B4-BE49-F238E27FC236}">
-                <a16:creationId xmlns:a16="http://schemas.microsoft.com/office/drawing/2014/main" id="{1484FDA2-B72C-4A44-A219-92D5A170FC04}"/>
+                <a16:creationId xmlns:a16="http://schemas.microsoft.com/office/drawing/2014/main" id="{2674E3ED-2C68-4103-83CE-DAD7AC44E084}"/>
               </a:ext>
             </a:extLst>
           </p:cNvPr>
@@ -6337,7 +6391,7 @@
           <p:cNvPr id="6" name="">
             <a:extLst xmlns:a="http://schemas.openxmlformats.org/drawingml/2006/main">
               <a:ext uri="{FF2B5EF4-FFF2-40B4-BE49-F238E27FC236}">
-                <a16:creationId xmlns:a16="http://schemas.microsoft.com/office/drawing/2014/main" id="{0D2ACC8E-6A22-469B-99C9-B0A50A1A364B}"/>
+                <a16:creationId xmlns:a16="http://schemas.microsoft.com/office/drawing/2014/main" id="{6F2E5857-D5D6-41C9-9CD7-4CCE1651D3F2}"/>
               </a:ext>
             </a:extLst>
           </p:cNvPr>
@@ -6392,7 +6446,7 @@
     </p:spTree>
     <p:extLst>
       <p:ext uri="{BB962C8B-B14F-4D97-AF65-F5344CB8AC3E}">
-        <p14:creationId xmlns:p14="http://schemas.microsoft.com/office/powerpoint/2010/main" val="1627296343"/>
+        <p14:creationId xmlns:p14="http://schemas.microsoft.com/office/powerpoint/2010/main" val="426570032"/>
       </p:ext>
     </p:extLst>
   </p:cSld>
@@ -6423,7 +6477,7 @@
           <p:cNvPr id="7" name="">
             <a:extLst xmlns:a="http://schemas.openxmlformats.org/drawingml/2006/main">
               <a:ext uri="{FF2B5EF4-FFF2-40B4-BE49-F238E27FC236}">
-                <a16:creationId xmlns:a16="http://schemas.microsoft.com/office/drawing/2014/main" id="{AFBAE026-B2CD-4239-A546-A2DA9AAF02F9}"/>
+                <a16:creationId xmlns:a16="http://schemas.microsoft.com/office/drawing/2014/main" id="{231F8456-5B25-40D4-B8B4-5A973A2D44FA}"/>
               </a:ext>
             </a:extLst>
           </p:cNvPr>
@@ -6470,7 +6524,7 @@
                 <a:ea typeface="Arial"/>
                 <a:cs typeface="Arial"/>
               </a:rPr>
-              <a:t>Matching partner-coordinate queries</a:t>
+              <a:t>The same partner data in both placements</a:t>
             </a:r>
           </a:p>
         </p:txBody>
@@ -6480,7 +6534,7 @@
           <p:cNvPr id="2" name="">
             <a:extLst xmlns:a="http://schemas.openxmlformats.org/drawingml/2006/main">
               <a:ext uri="{FF2B5EF4-FFF2-40B4-BE49-F238E27FC236}">
-                <a16:creationId xmlns:a16="http://schemas.microsoft.com/office/drawing/2014/main" id="{1069267D-9E75-4280-8DA3-867E3F9EA463}"/>
+                <a16:creationId xmlns:a16="http://schemas.microsoft.com/office/drawing/2014/main" id="{EF28643E-2F81-4439-B064-E8E615F5342A}"/>
               </a:ext>
             </a:extLst>
           </p:cNvPr>
@@ -7090,7 +7144,7 @@
           <p:cNvPr id="4" name="">
             <a:extLst xmlns:a="http://schemas.openxmlformats.org/drawingml/2006/main">
               <a:ext uri="{FF2B5EF4-FFF2-40B4-BE49-F238E27FC236}">
-                <a16:creationId xmlns:a16="http://schemas.microsoft.com/office/drawing/2014/main" id="{77D02744-46E5-4595-A8C2-071AC0EC540B}"/>
+                <a16:creationId xmlns:a16="http://schemas.microsoft.com/office/drawing/2014/main" id="{1901A62E-AF30-4C09-9099-D5C5738FB418}"/>
               </a:ext>
             </a:extLst>
           </p:cNvPr>
@@ -7700,7 +7754,7 @@
           <p:cNvPr id="6" name="">
             <a:extLst xmlns:a="http://schemas.openxmlformats.org/drawingml/2006/main">
               <a:ext uri="{FF2B5EF4-FFF2-40B4-BE49-F238E27FC236}">
-                <a16:creationId xmlns:a16="http://schemas.microsoft.com/office/drawing/2014/main" id="{971E5FB3-A62D-46BE-B100-77AF36224FED}"/>
+                <a16:creationId xmlns:a16="http://schemas.microsoft.com/office/drawing/2014/main" id="{1B648329-FA0B-44A2-873E-B0B16F63AEF7}"/>
               </a:ext>
             </a:extLst>
           </p:cNvPr>
@@ -7755,7 +7809,7 @@
     </p:spTree>
     <p:extLst>
       <p:ext uri="{BB962C8B-B14F-4D97-AF65-F5344CB8AC3E}">
-        <p14:creationId xmlns:p14="http://schemas.microsoft.com/office/powerpoint/2010/main" val="1282784304"/>
+        <p14:creationId xmlns:p14="http://schemas.microsoft.com/office/powerpoint/2010/main" val="374381457"/>
       </p:ext>
     </p:extLst>
   </p:cSld>
@@ -7786,7 +7840,7 @@
           <p:cNvPr id="7" name="">
             <a:extLst xmlns:a="http://schemas.openxmlformats.org/drawingml/2006/main">
               <a:ext uri="{FF2B5EF4-FFF2-40B4-BE49-F238E27FC236}">
-                <a16:creationId xmlns:a16="http://schemas.microsoft.com/office/drawing/2014/main" id="{421708AB-6346-48CF-810D-08E480E0C8B6}"/>
+                <a16:creationId xmlns:a16="http://schemas.microsoft.com/office/drawing/2014/main" id="{A2309A21-3D12-462A-9AD4-28D070FC646B}"/>
               </a:ext>
             </a:extLst>
           </p:cNvPr>
@@ -7850,7 +7904,7 @@
         </p:xfrm>
         <a:graphic xmlns:a="http://schemas.openxmlformats.org/drawingml/2006/main">
           <a:graphicData uri="http://schemas.openxmlformats.org/drawingml/2006/chart">
-            <c:chart xmlns:r="http://schemas.openxmlformats.org/officeDocument/2006/relationships" xmlns:c="http://schemas.openxmlformats.org/drawingml/2006/chart" r:id="R2acb5832f09e4f68"/>
+            <c:chart xmlns:r="http://schemas.openxmlformats.org/officeDocument/2006/relationships" xmlns:c="http://schemas.openxmlformats.org/drawingml/2006/chart" r:id="Rf2cb10de781e4f6a"/>
           </a:graphicData>
         </a:graphic>
       </p:graphicFrame>
@@ -7859,7 +7913,7 @@
           <p:cNvPr id="3" name="">
             <a:extLst xmlns:a="http://schemas.openxmlformats.org/drawingml/2006/main">
               <a:ext uri="{FF2B5EF4-FFF2-40B4-BE49-F238E27FC236}">
-                <a16:creationId xmlns:a16="http://schemas.microsoft.com/office/drawing/2014/main" id="{47B9A050-DCED-4F08-BFB8-FE985A7C0ADE}"/>
+                <a16:creationId xmlns:a16="http://schemas.microsoft.com/office/drawing/2014/main" id="{3E9F76D7-B88C-4955-9949-7F896D9CB31B}"/>
               </a:ext>
             </a:extLst>
           </p:cNvPr>
@@ -7916,7 +7970,7 @@
           <p:cNvPr id="4" name="">
             <a:extLst xmlns:a="http://schemas.openxmlformats.org/drawingml/2006/main">
               <a:ext uri="{FF2B5EF4-FFF2-40B4-BE49-F238E27FC236}">
-                <a16:creationId xmlns:a16="http://schemas.microsoft.com/office/drawing/2014/main" id="{E4861F78-5378-4928-9712-BF317081974C}"/>
+                <a16:creationId xmlns:a16="http://schemas.microsoft.com/office/drawing/2014/main" id="{FAF5EBA8-9582-47EC-881B-5CD42609863A}"/>
               </a:ext>
             </a:extLst>
           </p:cNvPr>
@@ -8019,7 +8073,7 @@
           <p:cNvPr id="5" name="">
             <a:extLst xmlns:a="http://schemas.openxmlformats.org/drawingml/2006/main">
               <a:ext uri="{FF2B5EF4-FFF2-40B4-BE49-F238E27FC236}">
-                <a16:creationId xmlns:a16="http://schemas.microsoft.com/office/drawing/2014/main" id="{EF7046D7-D8BA-4117-B4FD-04AFA93EC6C6}"/>
+                <a16:creationId xmlns:a16="http://schemas.microsoft.com/office/drawing/2014/main" id="{68643C15-C24B-43C5-AA8C-78AD7C0900DB}"/>
               </a:ext>
             </a:extLst>
           </p:cNvPr>
@@ -8122,7 +8176,7 @@
           <p:cNvPr id="6" name="">
             <a:extLst xmlns:a="http://schemas.openxmlformats.org/drawingml/2006/main">
               <a:ext uri="{FF2B5EF4-FFF2-40B4-BE49-F238E27FC236}">
-                <a16:creationId xmlns:a16="http://schemas.microsoft.com/office/drawing/2014/main" id="{4A233801-AEA9-4C37-B558-5A128844A9FF}"/>
+                <a16:creationId xmlns:a16="http://schemas.microsoft.com/office/drawing/2014/main" id="{D4DCF8B0-DC43-4B9F-AF6A-FFA426953868}"/>
               </a:ext>
             </a:extLst>
           </p:cNvPr>
@@ -8177,7 +8231,7 @@
     </p:spTree>
     <p:extLst>
       <p:ext uri="{BB962C8B-B14F-4D97-AF65-F5344CB8AC3E}">
-        <p14:creationId xmlns:p14="http://schemas.microsoft.com/office/powerpoint/2010/main" val="84676947"/>
+        <p14:creationId xmlns:p14="http://schemas.microsoft.com/office/powerpoint/2010/main" val="1420045238"/>
       </p:ext>
     </p:extLst>
   </p:cSld>

</xml_diff>

<commit_message>
Deliver merged-baseline comparison and repeated audit evidence
</commit_message>
<xml_diff>
--- a/extras/usd/examples/usdGeospatialBuild/delivery/geospatial-build.pptx
+++ b/extras/usd/examples/usdGeospatialBuild/delivery/geospatial-build.pptx
@@ -2,26 +2,26 @@
 <file path=ppt/presentation.xml><?xml version="1.0" encoding="utf-8"?>
 <p:presentation xmlns:p="http://schemas.openxmlformats.org/presentationml/2006/main">
   <p:sldMasterIdLst>
-    <p:sldMasterId xmlns:r="http://schemas.openxmlformats.org/officeDocument/2006/relationships" id="2147483648" r:id="R8901746ec3dd4c8e"/>
+    <p:sldMasterId xmlns:r="http://schemas.openxmlformats.org/officeDocument/2006/relationships" id="2147483648" r:id="R03740ff4bb0e4a2e"/>
   </p:sldMasterIdLst>
   <p:notesMasterIdLst>
-    <p:notesMasterId xmlns:r="http://schemas.openxmlformats.org/officeDocument/2006/relationships" r:id="R5d6a9f9e9810472e"/>
+    <p:notesMasterId xmlns:r="http://schemas.openxmlformats.org/officeDocument/2006/relationships" r:id="Rcebec120b52b408f"/>
   </p:notesMasterIdLst>
   <p:sldIdLst>
-    <p:sldId xmlns:r="http://schemas.openxmlformats.org/officeDocument/2006/relationships" id="256" r:id="R991b8ac733be4a8d"/>
-    <p:sldId xmlns:r="http://schemas.openxmlformats.org/officeDocument/2006/relationships" id="257" r:id="R509a829bc7d84e2c"/>
-    <p:sldId xmlns:r="http://schemas.openxmlformats.org/officeDocument/2006/relationships" id="258" r:id="R688a28a404aa48e7"/>
-    <p:sldId xmlns:r="http://schemas.openxmlformats.org/officeDocument/2006/relationships" id="259" r:id="Rd87e6c00a0b64f21"/>
-    <p:sldId xmlns:r="http://schemas.openxmlformats.org/officeDocument/2006/relationships" id="260" r:id="Rec7135b852a949be"/>
-    <p:sldId xmlns:r="http://schemas.openxmlformats.org/officeDocument/2006/relationships" id="261" r:id="R1fb6548ecec347f8"/>
-    <p:sldId xmlns:r="http://schemas.openxmlformats.org/officeDocument/2006/relationships" id="262" r:id="R1bfd4317d2614b46"/>
-    <p:sldId xmlns:r="http://schemas.openxmlformats.org/officeDocument/2006/relationships" id="263" r:id="R6bf3c1e34af54b7f"/>
-    <p:sldId xmlns:r="http://schemas.openxmlformats.org/officeDocument/2006/relationships" id="264" r:id="Rb0800cc21dbe4995"/>
-    <p:sldId xmlns:r="http://schemas.openxmlformats.org/officeDocument/2006/relationships" id="265" r:id="Rba1ef84558434f35"/>
-    <p:sldId xmlns:r="http://schemas.openxmlformats.org/officeDocument/2006/relationships" id="266" r:id="R2d0dfe7959554bb7"/>
-    <p:sldId xmlns:r="http://schemas.openxmlformats.org/officeDocument/2006/relationships" id="267" r:id="R8f07bc0b168c4da3"/>
-    <p:sldId xmlns:r="http://schemas.openxmlformats.org/officeDocument/2006/relationships" id="268" r:id="Ra8d3a7c4d66f4fee"/>
-    <p:sldId xmlns:r="http://schemas.openxmlformats.org/officeDocument/2006/relationships" id="269" r:id="R91d990e0db6f4ecb"/>
+    <p:sldId xmlns:r="http://schemas.openxmlformats.org/officeDocument/2006/relationships" id="256" r:id="Rc336eeb4ab154cb7"/>
+    <p:sldId xmlns:r="http://schemas.openxmlformats.org/officeDocument/2006/relationships" id="257" r:id="R530cc6729af3476f"/>
+    <p:sldId xmlns:r="http://schemas.openxmlformats.org/officeDocument/2006/relationships" id="258" r:id="R4c868b37a97a46b6"/>
+    <p:sldId xmlns:r="http://schemas.openxmlformats.org/officeDocument/2006/relationships" id="259" r:id="R42cefb046e254832"/>
+    <p:sldId xmlns:r="http://schemas.openxmlformats.org/officeDocument/2006/relationships" id="260" r:id="R630202b3d46b4c4d"/>
+    <p:sldId xmlns:r="http://schemas.openxmlformats.org/officeDocument/2006/relationships" id="261" r:id="R4334d98dc21d41e8"/>
+    <p:sldId xmlns:r="http://schemas.openxmlformats.org/officeDocument/2006/relationships" id="262" r:id="R0880b9c5649743a4"/>
+    <p:sldId xmlns:r="http://schemas.openxmlformats.org/officeDocument/2006/relationships" id="263" r:id="R7ca3e0a0e81d4017"/>
+    <p:sldId xmlns:r="http://schemas.openxmlformats.org/officeDocument/2006/relationships" id="264" r:id="Rf0815b3a734248e1"/>
+    <p:sldId xmlns:r="http://schemas.openxmlformats.org/officeDocument/2006/relationships" id="265" r:id="R8cc4889ab0bb4c16"/>
+    <p:sldId xmlns:r="http://schemas.openxmlformats.org/officeDocument/2006/relationships" id="266" r:id="R7cb2d114c0f44b93"/>
+    <p:sldId xmlns:r="http://schemas.openxmlformats.org/officeDocument/2006/relationships" id="267" r:id="R57259f88cb5e4f0c"/>
+    <p:sldId xmlns:r="http://schemas.openxmlformats.org/officeDocument/2006/relationships" id="268" r:id="R3d73954d34c44e59"/>
+    <p:sldId xmlns:r="http://schemas.openxmlformats.org/officeDocument/2006/relationships" id="269" r:id="R898cdd03f6c34f21"/>
   </p:sldIdLst>
   <p:sldSz cx="12192000" cy="6858000"/>
   <p:notesSz cx="6858000" cy="9144000"/>
@@ -211,16 +211,16 @@
         <a:srgbClr val="96607D"/>
       </a:folHlink>
     </a:clrScheme>
-    <a:fontScheme name="Office">
+    <a:fontScheme name="">
       <a:majorFont>
-        <a:latin typeface="Calibri Light"/>
-        <a:ea typeface="Calibri Light"/>
-        <a:cs typeface="Calibri Light"/>
+        <a:latin typeface="Aptos"/>
+        <a:ea typeface=""/>
+        <a:cs typeface=""/>
       </a:majorFont>
       <a:minorFont>
-        <a:latin typeface="Calibri"/>
-        <a:ea typeface="Calibri"/>
-        <a:cs typeface="Calibri"/>
+        <a:latin typeface="Aptos"/>
+        <a:ea typeface=""/>
+        <a:cs typeface=""/>
       </a:minorFont>
     </a:fontScheme>
     <a:fmtScheme name="ChatGPT">
@@ -465,27 +465,27 @@
           </a:p>
           <a:p xmlns:a="http://schemas.openxmlformats.org/drawingml/2006/main">
             <a:r>
-              <a:t>README SHA-256 a45f759d69e14f28301cce5931f6578c8a64ebc8262403a6c8cc3b15b9a0b069</a:t>
-            </a:r>
-          </a:p>
-          <a:p xmlns:a="http://schemas.openxmlformats.org/drawingml/2006/main">
-            <a:r>
-              <a:t>Proposal SHA-256 1727a552053cfdcdf202e2c84ad1209d1a898fe2eab2e322d51e9c7b4ad7c7c0</a:t>
-            </a:r>
-          </a:p>
-          <a:p xmlns:a="http://schemas.openxmlformats.org/drawingml/2006/main">
-            <a:r>
-              <a:t>Immutable execution receipt SHA-256 3baf0e2c215e8ac2ea30fb41197242b663469cd51f31ba48dc9e6c0d7b76833c</a:t>
-            </a:r>
-          </a:p>
-          <a:p xmlns:a="http://schemas.openxmlformats.org/drawingml/2006/main">
-            <a:r>
-              <a:t>Later audit SHA-256 9456363dd93059d7884c0b71a7942f5eed5454ee0d0628e567c2f4856b60a00b</a:t>
-            </a:r>
-          </a:p>
-          <a:p xmlns:a="http://schemas.openxmlformats.org/drawingml/2006/main">
-            <a:r>
-              <a:t>Explanatory delivery refresh of the same frozen execution, with later audit disclosure. No new runtime execution or repairs.</a:t>
+              <a:t>README SHA-256 516b20d0c5b90558e7659c4ca71b2f2741d929c1a41d2427ac823f265f49b730</a:t>
+            </a:r>
+          </a:p>
+          <a:p xmlns:a="http://schemas.openxmlformats.org/drawingml/2006/main">
+            <a:r>
+              <a:t>Proposal SHA-256 02323339203777b80b0bf8969f2392a4663b78be29e88f26f859df376999774a</a:t>
+            </a:r>
+          </a:p>
+          <a:p xmlns:a="http://schemas.openxmlformats.org/drawingml/2006/main">
+            <a:r>
+              <a:t>Immutable execution receipt SHA-256 4f212b53f00cd7f31bae7b94ea63e6a4b99e3a9cf9e645b2989e888a51ceecbf</a:t>
+            </a:r>
+          </a:p>
+          <a:p xmlns:a="http://schemas.openxmlformats.org/drawingml/2006/main">
+            <a:r>
+              <a:t>Later audit SHA-256 75abc802636f2e337b6fda2002b14f4ddf89f434901bae4a034734403f73e35f</a:t>
+            </a:r>
+          </a:p>
+          <a:p xmlns:a="http://schemas.openxmlformats.org/drawingml/2006/main">
+            <a:r>
+              <a:t>Fresh October 7 execution of the merged proposal candidate, compared with the prior immutable run and followed by repeated independent diagnostics. No runtime implementation repairs.</a:t>
             </a:r>
           </a:p>
           <a:p xmlns:a="http://schemas.openxmlformats.org/drawingml/2006/main">
@@ -590,12 +590,12 @@
           </a:p>
           <a:p xmlns:a="http://schemas.openxmlformats.org/drawingml/2006/main">
             <a:r>
-              <a:t>Proposal: ### External measurement association at proposal/proposal-source.txt:1558</a:t>
-            </a:r>
-          </a:p>
-          <a:p xmlns:a="http://schemas.openxmlformats.org/drawingml/2006/main">
-            <a:r>
-              <a:t>Functional requirements: [{"id":8,"title":"Brought-in data keeps its coordinates and its CRS.","line":710},{"id":12,"title":"No angle read as a length.","line":790},{"id":19,"title":"Resolution leaves the scene as authored.","line":894},{"id":21,"title":"Never placed by a guess.","line":930}]</a:t>
+              <a:t>Proposal: ### External measurement association at proposal/proposal-source.txt:1594</a:t>
+            </a:r>
+          </a:p>
+          <a:p xmlns:a="http://schemas.openxmlformats.org/drawingml/2006/main">
+            <a:r>
+              <a:t>Functional requirements: [{"id":8,"title":"Brought-in data keeps its coordinates and its CRS.","line":746},{"id":12,"title":"No angle read as a length.","line":826},{"id":19,"title":"Resolution leaves the scene as authored.","line":930},{"id":21,"title":"Never placed by a guess.","line":966}]</a:t>
             </a:r>
           </a:p>
           <a:p xmlns:a="http://schemas.openxmlformats.org/drawingml/2006/main">
@@ -610,27 +610,27 @@
           </a:p>
           <a:p xmlns:a="http://schemas.openxmlformats.org/drawingml/2006/main">
             <a:r>
-              <a:t>README SHA-256 a45f759d69e14f28301cce5931f6578c8a64ebc8262403a6c8cc3b15b9a0b069</a:t>
-            </a:r>
-          </a:p>
-          <a:p xmlns:a="http://schemas.openxmlformats.org/drawingml/2006/main">
-            <a:r>
-              <a:t>Proposal SHA-256 1727a552053cfdcdf202e2c84ad1209d1a898fe2eab2e322d51e9c7b4ad7c7c0</a:t>
-            </a:r>
-          </a:p>
-          <a:p xmlns:a="http://schemas.openxmlformats.org/drawingml/2006/main">
-            <a:r>
-              <a:t>Immutable execution receipt SHA-256 3baf0e2c215e8ac2ea30fb41197242b663469cd51f31ba48dc9e6c0d7b76833c</a:t>
-            </a:r>
-          </a:p>
-          <a:p xmlns:a="http://schemas.openxmlformats.org/drawingml/2006/main">
-            <a:r>
-              <a:t>Later audit SHA-256 9456363dd93059d7884c0b71a7942f5eed5454ee0d0628e567c2f4856b60a00b</a:t>
-            </a:r>
-          </a:p>
-          <a:p xmlns:a="http://schemas.openxmlformats.org/drawingml/2006/main">
-            <a:r>
-              <a:t>Explanatory delivery refresh of the same frozen execution, with later audit disclosure. No new runtime execution or repairs.</a:t>
+              <a:t>README SHA-256 516b20d0c5b90558e7659c4ca71b2f2741d929c1a41d2427ac823f265f49b730</a:t>
+            </a:r>
+          </a:p>
+          <a:p xmlns:a="http://schemas.openxmlformats.org/drawingml/2006/main">
+            <a:r>
+              <a:t>Proposal SHA-256 02323339203777b80b0bf8969f2392a4663b78be29e88f26f859df376999774a</a:t>
+            </a:r>
+          </a:p>
+          <a:p xmlns:a="http://schemas.openxmlformats.org/drawingml/2006/main">
+            <a:r>
+              <a:t>Immutable execution receipt SHA-256 4f212b53f00cd7f31bae7b94ea63e6a4b99e3a9cf9e645b2989e888a51ceecbf</a:t>
+            </a:r>
+          </a:p>
+          <a:p xmlns:a="http://schemas.openxmlformats.org/drawingml/2006/main">
+            <a:r>
+              <a:t>Later audit SHA-256 75abc802636f2e337b6fda2002b14f4ddf89f434901bae4a034734403f73e35f</a:t>
+            </a:r>
+          </a:p>
+          <a:p xmlns:a="http://schemas.openxmlformats.org/drawingml/2006/main">
+            <a:r>
+              <a:t>Fresh October 7 execution of the merged proposal candidate, compared with the prior immutable run and followed by repeated independent diagnostics. No runtime implementation repairs.</a:t>
             </a:r>
           </a:p>
           <a:p xmlns:a="http://schemas.openxmlformats.org/drawingml/2006/main">
@@ -735,12 +735,12 @@
           </a:p>
           <a:p xmlns:a="http://schemas.openxmlformats.org/drawingml/2006/main">
             <a:r>
-              <a:t>Proposal: #### Evaluation at proposal/proposal-source.txt:1788</a:t>
-            </a:r>
-          </a:p>
-          <a:p xmlns:a="http://schemas.openxmlformats.org/drawingml/2006/main">
-            <a:r>
-              <a:t>Functional requirements: [{"id":20,"title":"Positions between recorded moments.","line":913},{"id":29,"title":"Implementable from the text alone.","line":1070}]</a:t>
+              <a:t>Proposal: #### Evaluation at proposal/proposal-source.txt:1887</a:t>
+            </a:r>
+          </a:p>
+          <a:p xmlns:a="http://schemas.openxmlformats.org/drawingml/2006/main">
+            <a:r>
+              <a:t>Functional requirements: [{"id":20,"title":"Positions between recorded moments.","line":949},{"id":29,"title":"Implementable from the text alone.","line":1106}]</a:t>
             </a:r>
           </a:p>
           <a:p xmlns:a="http://schemas.openxmlformats.org/drawingml/2006/main">
@@ -755,27 +755,27 @@
           </a:p>
           <a:p xmlns:a="http://schemas.openxmlformats.org/drawingml/2006/main">
             <a:r>
-              <a:t>README SHA-256 a45f759d69e14f28301cce5931f6578c8a64ebc8262403a6c8cc3b15b9a0b069</a:t>
-            </a:r>
-          </a:p>
-          <a:p xmlns:a="http://schemas.openxmlformats.org/drawingml/2006/main">
-            <a:r>
-              <a:t>Proposal SHA-256 1727a552053cfdcdf202e2c84ad1209d1a898fe2eab2e322d51e9c7b4ad7c7c0</a:t>
-            </a:r>
-          </a:p>
-          <a:p xmlns:a="http://schemas.openxmlformats.org/drawingml/2006/main">
-            <a:r>
-              <a:t>Immutable execution receipt SHA-256 3baf0e2c215e8ac2ea30fb41197242b663469cd51f31ba48dc9e6c0d7b76833c</a:t>
-            </a:r>
-          </a:p>
-          <a:p xmlns:a="http://schemas.openxmlformats.org/drawingml/2006/main">
-            <a:r>
-              <a:t>Later audit SHA-256 9456363dd93059d7884c0b71a7942f5eed5454ee0d0628e567c2f4856b60a00b</a:t>
-            </a:r>
-          </a:p>
-          <a:p xmlns:a="http://schemas.openxmlformats.org/drawingml/2006/main">
-            <a:r>
-              <a:t>Explanatory delivery refresh of the same frozen execution, with later audit disclosure. No new runtime execution or repairs.</a:t>
+              <a:t>README SHA-256 516b20d0c5b90558e7659c4ca71b2f2741d929c1a41d2427ac823f265f49b730</a:t>
+            </a:r>
+          </a:p>
+          <a:p xmlns:a="http://schemas.openxmlformats.org/drawingml/2006/main">
+            <a:r>
+              <a:t>Proposal SHA-256 02323339203777b80b0bf8969f2392a4663b78be29e88f26f859df376999774a</a:t>
+            </a:r>
+          </a:p>
+          <a:p xmlns:a="http://schemas.openxmlformats.org/drawingml/2006/main">
+            <a:r>
+              <a:t>Immutable execution receipt SHA-256 4f212b53f00cd7f31bae7b94ea63e6a4b99e3a9cf9e645b2989e888a51ceecbf</a:t>
+            </a:r>
+          </a:p>
+          <a:p xmlns:a="http://schemas.openxmlformats.org/drawingml/2006/main">
+            <a:r>
+              <a:t>Later audit SHA-256 75abc802636f2e337b6fda2002b14f4ddf89f434901bae4a034734403f73e35f</a:t>
+            </a:r>
+          </a:p>
+          <a:p xmlns:a="http://schemas.openxmlformats.org/drawingml/2006/main">
+            <a:r>
+              <a:t>Fresh October 7 execution of the merged proposal candidate, compared with the prior immutable run and followed by repeated independent diagnostics. No runtime implementation repairs.</a:t>
             </a:r>
           </a:p>
           <a:p xmlns:a="http://schemas.openxmlformats.org/drawingml/2006/main">
@@ -860,27 +860,27 @@
           </a:p>
           <a:p xmlns:a="http://schemas.openxmlformats.org/drawingml/2006/main">
             <a:r>
-              <a:t>README SHA-256 a45f759d69e14f28301cce5931f6578c8a64ebc8262403a6c8cc3b15b9a0b069</a:t>
-            </a:r>
-          </a:p>
-          <a:p xmlns:a="http://schemas.openxmlformats.org/drawingml/2006/main">
-            <a:r>
-              <a:t>Proposal SHA-256 1727a552053cfdcdf202e2c84ad1209d1a898fe2eab2e322d51e9c7b4ad7c7c0</a:t>
-            </a:r>
-          </a:p>
-          <a:p xmlns:a="http://schemas.openxmlformats.org/drawingml/2006/main">
-            <a:r>
-              <a:t>Immutable execution receipt SHA-256 3baf0e2c215e8ac2ea30fb41197242b663469cd51f31ba48dc9e6c0d7b76833c</a:t>
-            </a:r>
-          </a:p>
-          <a:p xmlns:a="http://schemas.openxmlformats.org/drawingml/2006/main">
-            <a:r>
-              <a:t>Later audit SHA-256 9456363dd93059d7884c0b71a7942f5eed5454ee0d0628e567c2f4856b60a00b</a:t>
-            </a:r>
-          </a:p>
-          <a:p xmlns:a="http://schemas.openxmlformats.org/drawingml/2006/main">
-            <a:r>
-              <a:t>Explanatory delivery refresh of the same frozen execution, with later audit disclosure. No new runtime execution or repairs.</a:t>
+              <a:t>README SHA-256 516b20d0c5b90558e7659c4ca71b2f2741d929c1a41d2427ac823f265f49b730</a:t>
+            </a:r>
+          </a:p>
+          <a:p xmlns:a="http://schemas.openxmlformats.org/drawingml/2006/main">
+            <a:r>
+              <a:t>Proposal SHA-256 02323339203777b80b0bf8969f2392a4663b78be29e88f26f859df376999774a</a:t>
+            </a:r>
+          </a:p>
+          <a:p xmlns:a="http://schemas.openxmlformats.org/drawingml/2006/main">
+            <a:r>
+              <a:t>Immutable execution receipt SHA-256 4f212b53f00cd7f31bae7b94ea63e6a4b99e3a9cf9e645b2989e888a51ceecbf</a:t>
+            </a:r>
+          </a:p>
+          <a:p xmlns:a="http://schemas.openxmlformats.org/drawingml/2006/main">
+            <a:r>
+              <a:t>Later audit SHA-256 75abc802636f2e337b6fda2002b14f4ddf89f434901bae4a034734403f73e35f</a:t>
+            </a:r>
+          </a:p>
+          <a:p xmlns:a="http://schemas.openxmlformats.org/drawingml/2006/main">
+            <a:r>
+              <a:t>Fresh October 7 execution of the merged proposal candidate, compared with the prior immutable run and followed by repeated independent diagnostics. No runtime implementation repairs.</a:t>
             </a:r>
           </a:p>
           <a:p xmlns:a="http://schemas.openxmlformats.org/drawingml/2006/main">
@@ -965,27 +965,27 @@
           </a:p>
           <a:p xmlns:a="http://schemas.openxmlformats.org/drawingml/2006/main">
             <a:r>
-              <a:t>README SHA-256 a45f759d69e14f28301cce5931f6578c8a64ebc8262403a6c8cc3b15b9a0b069</a:t>
-            </a:r>
-          </a:p>
-          <a:p xmlns:a="http://schemas.openxmlformats.org/drawingml/2006/main">
-            <a:r>
-              <a:t>Proposal SHA-256 1727a552053cfdcdf202e2c84ad1209d1a898fe2eab2e322d51e9c7b4ad7c7c0</a:t>
-            </a:r>
-          </a:p>
-          <a:p xmlns:a="http://schemas.openxmlformats.org/drawingml/2006/main">
-            <a:r>
-              <a:t>Immutable execution receipt SHA-256 3baf0e2c215e8ac2ea30fb41197242b663469cd51f31ba48dc9e6c0d7b76833c</a:t>
-            </a:r>
-          </a:p>
-          <a:p xmlns:a="http://schemas.openxmlformats.org/drawingml/2006/main">
-            <a:r>
-              <a:t>Later audit SHA-256 9456363dd93059d7884c0b71a7942f5eed5454ee0d0628e567c2f4856b60a00b</a:t>
-            </a:r>
-          </a:p>
-          <a:p xmlns:a="http://schemas.openxmlformats.org/drawingml/2006/main">
-            <a:r>
-              <a:t>Explanatory delivery refresh of the same frozen execution, with later audit disclosure. No new runtime execution or repairs.</a:t>
+              <a:t>README SHA-256 516b20d0c5b90558e7659c4ca71b2f2741d929c1a41d2427ac823f265f49b730</a:t>
+            </a:r>
+          </a:p>
+          <a:p xmlns:a="http://schemas.openxmlformats.org/drawingml/2006/main">
+            <a:r>
+              <a:t>Proposal SHA-256 02323339203777b80b0bf8969f2392a4663b78be29e88f26f859df376999774a</a:t>
+            </a:r>
+          </a:p>
+          <a:p xmlns:a="http://schemas.openxmlformats.org/drawingml/2006/main">
+            <a:r>
+              <a:t>Immutable execution receipt SHA-256 4f212b53f00cd7f31bae7b94ea63e6a4b99e3a9cf9e645b2989e888a51ceecbf</a:t>
+            </a:r>
+          </a:p>
+          <a:p xmlns:a="http://schemas.openxmlformats.org/drawingml/2006/main">
+            <a:r>
+              <a:t>Later audit SHA-256 75abc802636f2e337b6fda2002b14f4ddf89f434901bae4a034734403f73e35f</a:t>
+            </a:r>
+          </a:p>
+          <a:p xmlns:a="http://schemas.openxmlformats.org/drawingml/2006/main">
+            <a:r>
+              <a:t>Fresh October 7 execution of the merged proposal candidate, compared with the prior immutable run and followed by repeated independent diagnostics. No runtime implementation repairs.</a:t>
             </a:r>
           </a:p>
           <a:p xmlns:a="http://schemas.openxmlformats.org/drawingml/2006/main">
@@ -1065,32 +1065,32 @@
           </a:p>
           <a:p xmlns:a="http://schemas.openxmlformats.org/drawingml/2006/main">
             <a:r>
-              <a:t>[["Python and C++ readers","213,231 coordinate results per reader. Maximum measured difference 3.39e-08 m. They share PROJ and native dataset decoding."],["Omniverse stage geometry integration","Reuses Python placement. Recorded readback covers 177,864 geometry vertices and 36 edit, failure and recovery checks, across 35 jobs."],["Hydra / Storm","Two selected ordinary USD bakes reach native rendering. This consumer path uses the C++ placement results."],["Recorded tests","64 regressions and 61 distinguishing controls passed. The later audit exposes cases the suite missed."],["Source preservation","Original inputs and 40 executed source-file hashes remain unchanged. The immutable receipt identifies the executed content."],["Bake readbacks","11 selected exports were checked. The later nested-geometry case demonstrates that the original inventory check was incomplete."]]</a:t>
-            </a:r>
-          </a:p>
-          <a:p xmlns:a="http://schemas.openxmlformats.org/drawingml/2006/main">
-            <a:r>
-              <a:t>README SHA-256 a45f759d69e14f28301cce5931f6578c8a64ebc8262403a6c8cc3b15b9a0b069</a:t>
-            </a:r>
-          </a:p>
-          <a:p xmlns:a="http://schemas.openxmlformats.org/drawingml/2006/main">
-            <a:r>
-              <a:t>Proposal SHA-256 1727a552053cfdcdf202e2c84ad1209d1a898fe2eab2e322d51e9c7b4ad7c7c0</a:t>
-            </a:r>
-          </a:p>
-          <a:p xmlns:a="http://schemas.openxmlformats.org/drawingml/2006/main">
-            <a:r>
-              <a:t>Immutable execution receipt SHA-256 3baf0e2c215e8ac2ea30fb41197242b663469cd51f31ba48dc9e6c0d7b76833c</a:t>
-            </a:r>
-          </a:p>
-          <a:p xmlns:a="http://schemas.openxmlformats.org/drawingml/2006/main">
-            <a:r>
-              <a:t>Later audit SHA-256 9456363dd93059d7884c0b71a7942f5eed5454ee0d0628e567c2f4856b60a00b</a:t>
-            </a:r>
-          </a:p>
-          <a:p xmlns:a="http://schemas.openxmlformats.org/drawingml/2006/main">
-            <a:r>
-              <a:t>Explanatory delivery refresh of the same frozen execution, with later audit disclosure. No new runtime execution or repairs.</a:t>
+              <a:t>[["Python and C++ readers","213,231 coordinate results per reader. Maximum measured difference 3.39e-08 m. They share PROJ and native dataset decoding."],["Omniverse stage geometry integration","Reuses Python placement. Recorded readback covers 177,864 geometry vertices and 36 edit, failure and recovery checks, across 35 jobs."],["Hydra / Storm","Two selected ordinary USD bakes reach native rendering. This consumer path uses the C++ placement results."],["Recorded tests","64 regressions and 61 distinguishing controls passed. The later audit exposes cases the suite missed."],["Source preservation","Original inputs and all frozen execution files remained unchanged during this run. The immutable receipt identifies the exact executed content."],["Bake readbacks","11 selected exports were checked. The later nested-geometry case demonstrates that the original inventory check was incomplete."]]</a:t>
+            </a:r>
+          </a:p>
+          <a:p xmlns:a="http://schemas.openxmlformats.org/drawingml/2006/main">
+            <a:r>
+              <a:t>README SHA-256 516b20d0c5b90558e7659c4ca71b2f2741d929c1a41d2427ac823f265f49b730</a:t>
+            </a:r>
+          </a:p>
+          <a:p xmlns:a="http://schemas.openxmlformats.org/drawingml/2006/main">
+            <a:r>
+              <a:t>Proposal SHA-256 02323339203777b80b0bf8969f2392a4663b78be29e88f26f859df376999774a</a:t>
+            </a:r>
+          </a:p>
+          <a:p xmlns:a="http://schemas.openxmlformats.org/drawingml/2006/main">
+            <a:r>
+              <a:t>Immutable execution receipt SHA-256 4f212b53f00cd7f31bae7b94ea63e6a4b99e3a9cf9e645b2989e888a51ceecbf</a:t>
+            </a:r>
+          </a:p>
+          <a:p xmlns:a="http://schemas.openxmlformats.org/drawingml/2006/main">
+            <a:r>
+              <a:t>Later audit SHA-256 75abc802636f2e337b6fda2002b14f4ddf89f434901bae4a034734403f73e35f</a:t>
+            </a:r>
+          </a:p>
+          <a:p xmlns:a="http://schemas.openxmlformats.org/drawingml/2006/main">
+            <a:r>
+              <a:t>Fresh October 7 execution of the merged proposal candidate, compared with the prior immutable run and followed by repeated independent diagnostics. No runtime implementation repairs.</a:t>
             </a:r>
           </a:p>
           <a:p xmlns:a="http://schemas.openxmlformats.org/drawingml/2006/main">
@@ -1195,12 +1195,12 @@
           </a:p>
           <a:p xmlns:a="http://schemas.openxmlformats.org/drawingml/2006/main">
             <a:r>
-              <a:t>Proposal: #### Authored properties at proposal/proposal-source.txt:1476</a:t>
-            </a:r>
-          </a:p>
-          <a:p xmlns:a="http://schemas.openxmlformats.org/drawingml/2006/main">
-            <a:r>
-              <a:t>Functional requirements: [{"id":9,"title":"Positions, and offsets from them.","line":736},{"id":10,"title":"Offsets along the axes of their position.","line":754},{"id":12,"title":"No angle read as a length.","line":790},{"id":14,"title":"Scene conventions stay the scene's.","line":821},{"id":15,"title":"Placement separate from conformance.","line":834}]</a:t>
+              <a:t>Proposal: #### Authored properties at proposal/proposal-source.txt:1512</a:t>
+            </a:r>
+          </a:p>
+          <a:p xmlns:a="http://schemas.openxmlformats.org/drawingml/2006/main">
+            <a:r>
+              <a:t>Functional requirements: [{"id":9,"title":"Positions, and offsets from them.","line":772},{"id":10,"title":"Offsets along the axes of their position.","line":790},{"id":12,"title":"No angle read as a length.","line":826},{"id":14,"title":"Scene conventions stay the scene's.","line":857},{"id":15,"title":"Placement separate from conformance.","line":870}]</a:t>
             </a:r>
           </a:p>
           <a:p xmlns:a="http://schemas.openxmlformats.org/drawingml/2006/main">
@@ -1215,27 +1215,27 @@
           </a:p>
           <a:p xmlns:a="http://schemas.openxmlformats.org/drawingml/2006/main">
             <a:r>
-              <a:t>README SHA-256 a45f759d69e14f28301cce5931f6578c8a64ebc8262403a6c8cc3b15b9a0b069</a:t>
-            </a:r>
-          </a:p>
-          <a:p xmlns:a="http://schemas.openxmlformats.org/drawingml/2006/main">
-            <a:r>
-              <a:t>Proposal SHA-256 1727a552053cfdcdf202e2c84ad1209d1a898fe2eab2e322d51e9c7b4ad7c7c0</a:t>
-            </a:r>
-          </a:p>
-          <a:p xmlns:a="http://schemas.openxmlformats.org/drawingml/2006/main">
-            <a:r>
-              <a:t>Immutable execution receipt SHA-256 3baf0e2c215e8ac2ea30fb41197242b663469cd51f31ba48dc9e6c0d7b76833c</a:t>
-            </a:r>
-          </a:p>
-          <a:p xmlns:a="http://schemas.openxmlformats.org/drawingml/2006/main">
-            <a:r>
-              <a:t>Later audit SHA-256 9456363dd93059d7884c0b71a7942f5eed5454ee0d0628e567c2f4856b60a00b</a:t>
-            </a:r>
-          </a:p>
-          <a:p xmlns:a="http://schemas.openxmlformats.org/drawingml/2006/main">
-            <a:r>
-              <a:t>Explanatory delivery refresh of the same frozen execution, with later audit disclosure. No new runtime execution or repairs.</a:t>
+              <a:t>README SHA-256 516b20d0c5b90558e7659c4ca71b2f2741d929c1a41d2427ac823f265f49b730</a:t>
+            </a:r>
+          </a:p>
+          <a:p xmlns:a="http://schemas.openxmlformats.org/drawingml/2006/main">
+            <a:r>
+              <a:t>Proposal SHA-256 02323339203777b80b0bf8969f2392a4663b78be29e88f26f859df376999774a</a:t>
+            </a:r>
+          </a:p>
+          <a:p xmlns:a="http://schemas.openxmlformats.org/drawingml/2006/main">
+            <a:r>
+              <a:t>Immutable execution receipt SHA-256 4f212b53f00cd7f31bae7b94ea63e6a4b99e3a9cf9e645b2989e888a51ceecbf</a:t>
+            </a:r>
+          </a:p>
+          <a:p xmlns:a="http://schemas.openxmlformats.org/drawingml/2006/main">
+            <a:r>
+              <a:t>Later audit SHA-256 75abc802636f2e337b6fda2002b14f4ddf89f434901bae4a034734403f73e35f</a:t>
+            </a:r>
+          </a:p>
+          <a:p xmlns:a="http://schemas.openxmlformats.org/drawingml/2006/main">
+            <a:r>
+              <a:t>Fresh October 7 execution of the merged proposal candidate, compared with the prior immutable run and followed by repeated independent diagnostics. No runtime implementation repairs.</a:t>
             </a:r>
           </a:p>
           <a:p xmlns:a="http://schemas.openxmlformats.org/drawingml/2006/main">
@@ -1340,12 +1340,12 @@
           </a:p>
           <a:p xmlns:a="http://schemas.openxmlformats.org/drawingml/2006/main">
             <a:r>
-              <a:t>Proposal: ### Source placement evaluation and transform order at proposal/proposal-source.txt:1750</a:t>
-            </a:r>
-          </a:p>
-          <a:p xmlns:a="http://schemas.openxmlformats.org/drawingml/2006/main">
-            <a:r>
-              <a:t>Functional requirements: [{"id":9,"title":"Positions, and offsets from them.","line":736},{"id":12,"title":"No angle read as a length.","line":790},{"id":13,"title":"One axis mapping.","line":804},{"id":16,"title":"One CRS out.","line":846},{"id":19,"title":"Resolution leaves the scene as authored.","line":894}]</a:t>
+              <a:t>Proposal: ### Source placement evaluation and transform order at proposal/proposal-source.txt:1787</a:t>
+            </a:r>
+          </a:p>
+          <a:p xmlns:a="http://schemas.openxmlformats.org/drawingml/2006/main">
+            <a:r>
+              <a:t>Functional requirements: [{"id":9,"title":"Positions, and offsets from them.","line":772},{"id":12,"title":"No angle read as a length.","line":826},{"id":13,"title":"One axis mapping.","line":840},{"id":16,"title":"One CRS out.","line":882},{"id":19,"title":"Resolution leaves the scene as authored.","line":930}]</a:t>
             </a:r>
           </a:p>
           <a:p xmlns:a="http://schemas.openxmlformats.org/drawingml/2006/main">
@@ -1360,27 +1360,27 @@
           </a:p>
           <a:p xmlns:a="http://schemas.openxmlformats.org/drawingml/2006/main">
             <a:r>
-              <a:t>README SHA-256 a45f759d69e14f28301cce5931f6578c8a64ebc8262403a6c8cc3b15b9a0b069</a:t>
-            </a:r>
-          </a:p>
-          <a:p xmlns:a="http://schemas.openxmlformats.org/drawingml/2006/main">
-            <a:r>
-              <a:t>Proposal SHA-256 1727a552053cfdcdf202e2c84ad1209d1a898fe2eab2e322d51e9c7b4ad7c7c0</a:t>
-            </a:r>
-          </a:p>
-          <a:p xmlns:a="http://schemas.openxmlformats.org/drawingml/2006/main">
-            <a:r>
-              <a:t>Immutable execution receipt SHA-256 3baf0e2c215e8ac2ea30fb41197242b663469cd51f31ba48dc9e6c0d7b76833c</a:t>
-            </a:r>
-          </a:p>
-          <a:p xmlns:a="http://schemas.openxmlformats.org/drawingml/2006/main">
-            <a:r>
-              <a:t>Later audit SHA-256 9456363dd93059d7884c0b71a7942f5eed5454ee0d0628e567c2f4856b60a00b</a:t>
-            </a:r>
-          </a:p>
-          <a:p xmlns:a="http://schemas.openxmlformats.org/drawingml/2006/main">
-            <a:r>
-              <a:t>Explanatory delivery refresh of the same frozen execution, with later audit disclosure. No new runtime execution or repairs.</a:t>
+              <a:t>README SHA-256 516b20d0c5b90558e7659c4ca71b2f2741d929c1a41d2427ac823f265f49b730</a:t>
+            </a:r>
+          </a:p>
+          <a:p xmlns:a="http://schemas.openxmlformats.org/drawingml/2006/main">
+            <a:r>
+              <a:t>Proposal SHA-256 02323339203777b80b0bf8969f2392a4663b78be29e88f26f859df376999774a</a:t>
+            </a:r>
+          </a:p>
+          <a:p xmlns:a="http://schemas.openxmlformats.org/drawingml/2006/main">
+            <a:r>
+              <a:t>Immutable execution receipt SHA-256 4f212b53f00cd7f31bae7b94ea63e6a4b99e3a9cf9e645b2989e888a51ceecbf</a:t>
+            </a:r>
+          </a:p>
+          <a:p xmlns:a="http://schemas.openxmlformats.org/drawingml/2006/main">
+            <a:r>
+              <a:t>Later audit SHA-256 75abc802636f2e337b6fda2002b14f4ddf89f434901bae4a034734403f73e35f</a:t>
+            </a:r>
+          </a:p>
+          <a:p xmlns:a="http://schemas.openxmlformats.org/drawingml/2006/main">
+            <a:r>
+              <a:t>Fresh October 7 execution of the merged proposal candidate, compared with the prior immutable run and followed by repeated independent diagnostics. No runtime implementation repairs.</a:t>
             </a:r>
           </a:p>
           <a:p xmlns:a="http://schemas.openxmlformats.org/drawingml/2006/main">
@@ -1485,12 +1485,12 @@
           </a:p>
           <a:p xmlns:a="http://schemas.openxmlformats.org/drawingml/2006/main">
             <a:r>
-              <a:t>Proposal: #### Evaluation at proposal/proposal-source.txt:1788</a:t>
-            </a:r>
-          </a:p>
-          <a:p xmlns:a="http://schemas.openxmlformats.org/drawingml/2006/main">
-            <a:r>
-              <a:t>Functional requirements: [{"id":9,"title":"Positions, and offsets from them.","line":736},{"id":14,"title":"Scene conventions stay the scene's.","line":821},{"id":15,"title":"Placement separate from conformance.","line":834},{"id":17,"title":"The same answer for every consumer.","line":866},{"id":19,"title":"Resolution leaves the scene as authored.","line":894}]</a:t>
+              <a:t>Proposal: #### Evaluation at proposal/proposal-source.txt:1887</a:t>
+            </a:r>
+          </a:p>
+          <a:p xmlns:a="http://schemas.openxmlformats.org/drawingml/2006/main">
+            <a:r>
+              <a:t>Functional requirements: [{"id":9,"title":"Positions, and offsets from them.","line":772},{"id":14,"title":"Scene conventions stay the scene's.","line":857},{"id":15,"title":"Placement separate from conformance.","line":870},{"id":17,"title":"The same answer for every consumer.","line":902},{"id":19,"title":"Resolution leaves the scene as authored.","line":930}]</a:t>
             </a:r>
           </a:p>
           <a:p xmlns:a="http://schemas.openxmlformats.org/drawingml/2006/main">
@@ -1505,27 +1505,27 @@
           </a:p>
           <a:p xmlns:a="http://schemas.openxmlformats.org/drawingml/2006/main">
             <a:r>
-              <a:t>README SHA-256 a45f759d69e14f28301cce5931f6578c8a64ebc8262403a6c8cc3b15b9a0b069</a:t>
-            </a:r>
-          </a:p>
-          <a:p xmlns:a="http://schemas.openxmlformats.org/drawingml/2006/main">
-            <a:r>
-              <a:t>Proposal SHA-256 1727a552053cfdcdf202e2c84ad1209d1a898fe2eab2e322d51e9c7b4ad7c7c0</a:t>
-            </a:r>
-          </a:p>
-          <a:p xmlns:a="http://schemas.openxmlformats.org/drawingml/2006/main">
-            <a:r>
-              <a:t>Immutable execution receipt SHA-256 3baf0e2c215e8ac2ea30fb41197242b663469cd51f31ba48dc9e6c0d7b76833c</a:t>
-            </a:r>
-          </a:p>
-          <a:p xmlns:a="http://schemas.openxmlformats.org/drawingml/2006/main">
-            <a:r>
-              <a:t>Later audit SHA-256 9456363dd93059d7884c0b71a7942f5eed5454ee0d0628e567c2f4856b60a00b</a:t>
-            </a:r>
-          </a:p>
-          <a:p xmlns:a="http://schemas.openxmlformats.org/drawingml/2006/main">
-            <a:r>
-              <a:t>Explanatory delivery refresh of the same frozen execution, with later audit disclosure. No new runtime execution or repairs.</a:t>
+              <a:t>README SHA-256 516b20d0c5b90558e7659c4ca71b2f2741d929c1a41d2427ac823f265f49b730</a:t>
+            </a:r>
+          </a:p>
+          <a:p xmlns:a="http://schemas.openxmlformats.org/drawingml/2006/main">
+            <a:r>
+              <a:t>Proposal SHA-256 02323339203777b80b0bf8969f2392a4663b78be29e88f26f859df376999774a</a:t>
+            </a:r>
+          </a:p>
+          <a:p xmlns:a="http://schemas.openxmlformats.org/drawingml/2006/main">
+            <a:r>
+              <a:t>Immutable execution receipt SHA-256 4f212b53f00cd7f31bae7b94ea63e6a4b99e3a9cf9e645b2989e888a51ceecbf</a:t>
+            </a:r>
+          </a:p>
+          <a:p xmlns:a="http://schemas.openxmlformats.org/drawingml/2006/main">
+            <a:r>
+              <a:t>Later audit SHA-256 75abc802636f2e337b6fda2002b14f4ddf89f434901bae4a034734403f73e35f</a:t>
+            </a:r>
+          </a:p>
+          <a:p xmlns:a="http://schemas.openxmlformats.org/drawingml/2006/main">
+            <a:r>
+              <a:t>Fresh October 7 execution of the merged proposal candidate, compared with the prior immutable run and followed by repeated independent diagnostics. No runtime implementation repairs.</a:t>
             </a:r>
           </a:p>
           <a:p xmlns:a="http://schemas.openxmlformats.org/drawingml/2006/main">
@@ -1630,12 +1630,12 @@
           </a:p>
           <a:p xmlns:a="http://schemas.openxmlformats.org/drawingml/2006/main">
             <a:r>
-              <a:t>Proposal: ### Extent and result comparison at proposal/proposal-source.txt:1919</a:t>
-            </a:r>
-          </a:p>
-          <a:p xmlns:a="http://schemas.openxmlformats.org/drawingml/2006/main">
-            <a:r>
-              <a:t>Functional requirements: [{"id":4,"title":"A site's own grid is a CRS like any other.","line":633},{"id":13,"title":"One axis mapping.","line":804},{"id":16,"title":"One CRS out.","line":846},{"id":17,"title":"The same answer for every consumer.","line":866},{"id":18,"title":"Coordinates back out.","line":879},{"id":28,"title":"A result says what produced it.","line":1052},{"id":29,"title":"Implementable from the text alone.","line":1070}]</a:t>
+              <a:t>Proposal: ### Extent and result comparison at proposal/proposal-source.txt:2018</a:t>
+            </a:r>
+          </a:p>
+          <a:p xmlns:a="http://schemas.openxmlformats.org/drawingml/2006/main">
+            <a:r>
+              <a:t>Functional requirements: [{"id":4,"title":"A site's own grid is a CRS like any other.","line":669},{"id":13,"title":"One axis mapping.","line":840},{"id":16,"title":"One CRS out.","line":882},{"id":17,"title":"The same answer for every consumer.","line":902},{"id":18,"title":"Coordinates back out.","line":915},{"id":28,"title":"A result says what produced it.","line":1088},{"id":29,"title":"Implementable from the text alone.","line":1106}]</a:t>
             </a:r>
           </a:p>
           <a:p xmlns:a="http://schemas.openxmlformats.org/drawingml/2006/main">
@@ -1650,27 +1650,27 @@
           </a:p>
           <a:p xmlns:a="http://schemas.openxmlformats.org/drawingml/2006/main">
             <a:r>
-              <a:t>README SHA-256 a45f759d69e14f28301cce5931f6578c8a64ebc8262403a6c8cc3b15b9a0b069</a:t>
-            </a:r>
-          </a:p>
-          <a:p xmlns:a="http://schemas.openxmlformats.org/drawingml/2006/main">
-            <a:r>
-              <a:t>Proposal SHA-256 1727a552053cfdcdf202e2c84ad1209d1a898fe2eab2e322d51e9c7b4ad7c7c0</a:t>
-            </a:r>
-          </a:p>
-          <a:p xmlns:a="http://schemas.openxmlformats.org/drawingml/2006/main">
-            <a:r>
-              <a:t>Immutable execution receipt SHA-256 3baf0e2c215e8ac2ea30fb41197242b663469cd51f31ba48dc9e6c0d7b76833c</a:t>
-            </a:r>
-          </a:p>
-          <a:p xmlns:a="http://schemas.openxmlformats.org/drawingml/2006/main">
-            <a:r>
-              <a:t>Later audit SHA-256 9456363dd93059d7884c0b71a7942f5eed5454ee0d0628e567c2f4856b60a00b</a:t>
-            </a:r>
-          </a:p>
-          <a:p xmlns:a="http://schemas.openxmlformats.org/drawingml/2006/main">
-            <a:r>
-              <a:t>Explanatory delivery refresh of the same frozen execution, with later audit disclosure. No new runtime execution or repairs.</a:t>
+              <a:t>README SHA-256 516b20d0c5b90558e7659c4ca71b2f2741d929c1a41d2427ac823f265f49b730</a:t>
+            </a:r>
+          </a:p>
+          <a:p xmlns:a="http://schemas.openxmlformats.org/drawingml/2006/main">
+            <a:r>
+              <a:t>Proposal SHA-256 02323339203777b80b0bf8969f2392a4663b78be29e88f26f859df376999774a</a:t>
+            </a:r>
+          </a:p>
+          <a:p xmlns:a="http://schemas.openxmlformats.org/drawingml/2006/main">
+            <a:r>
+              <a:t>Immutable execution receipt SHA-256 4f212b53f00cd7f31bae7b94ea63e6a4b99e3a9cf9e645b2989e888a51ceecbf</a:t>
+            </a:r>
+          </a:p>
+          <a:p xmlns:a="http://schemas.openxmlformats.org/drawingml/2006/main">
+            <a:r>
+              <a:t>Later audit SHA-256 75abc802636f2e337b6fda2002b14f4ddf89f434901bae4a034734403f73e35f</a:t>
+            </a:r>
+          </a:p>
+          <a:p xmlns:a="http://schemas.openxmlformats.org/drawingml/2006/main">
+            <a:r>
+              <a:t>Fresh October 7 execution of the merged proposal candidate, compared with the prior immutable run and followed by repeated independent diagnostics. No runtime implementation repairs.</a:t>
             </a:r>
           </a:p>
           <a:p xmlns:a="http://schemas.openxmlformats.org/drawingml/2006/main">
@@ -1775,12 +1775,12 @@
           </a:p>
           <a:p xmlns:a="http://schemas.openxmlformats.org/drawingml/2006/main">
             <a:r>
-              <a:t>Proposal: ### Explicit export and sampling at proposal/proposal-source.txt:1972</a:t>
-            </a:r>
-          </a:p>
-          <a:p xmlns:a="http://schemas.openxmlformats.org/drawingml/2006/main">
-            <a:r>
-              <a:t>Functional requirements: [{"id":17,"title":"The same answer for every consumer.","line":866},{"id":19,"title":"Resolution leaves the scene as authored.","line":894},{"id":23,"title":"Detail that does not depend on location.","line":992},{"id":25,"title":"Additive for consumers that ignore it.","line":1016},{"id":29,"title":"Implementable from the text alone.","line":1070}]</a:t>
+              <a:t>Proposal: ### Explicit export and sampling at proposal/proposal-source.txt:2071</a:t>
+            </a:r>
+          </a:p>
+          <a:p xmlns:a="http://schemas.openxmlformats.org/drawingml/2006/main">
+            <a:r>
+              <a:t>Functional requirements: [{"id":17,"title":"The same answer for every consumer.","line":902},{"id":19,"title":"Resolution leaves the scene as authored.","line":930},{"id":23,"title":"Detail that does not depend on location.","line":1028},{"id":25,"title":"Additive for consumers that ignore it.","line":1052},{"id":29,"title":"Implementable from the text alone.","line":1106}]</a:t>
             </a:r>
           </a:p>
           <a:p xmlns:a="http://schemas.openxmlformats.org/drawingml/2006/main">
@@ -1795,27 +1795,27 @@
           </a:p>
           <a:p xmlns:a="http://schemas.openxmlformats.org/drawingml/2006/main">
             <a:r>
-              <a:t>README SHA-256 a45f759d69e14f28301cce5931f6578c8a64ebc8262403a6c8cc3b15b9a0b069</a:t>
-            </a:r>
-          </a:p>
-          <a:p xmlns:a="http://schemas.openxmlformats.org/drawingml/2006/main">
-            <a:r>
-              <a:t>Proposal SHA-256 1727a552053cfdcdf202e2c84ad1209d1a898fe2eab2e322d51e9c7b4ad7c7c0</a:t>
-            </a:r>
-          </a:p>
-          <a:p xmlns:a="http://schemas.openxmlformats.org/drawingml/2006/main">
-            <a:r>
-              <a:t>Immutable execution receipt SHA-256 3baf0e2c215e8ac2ea30fb41197242b663469cd51f31ba48dc9e6c0d7b76833c</a:t>
-            </a:r>
-          </a:p>
-          <a:p xmlns:a="http://schemas.openxmlformats.org/drawingml/2006/main">
-            <a:r>
-              <a:t>Later audit SHA-256 9456363dd93059d7884c0b71a7942f5eed5454ee0d0628e567c2f4856b60a00b</a:t>
-            </a:r>
-          </a:p>
-          <a:p xmlns:a="http://schemas.openxmlformats.org/drawingml/2006/main">
-            <a:r>
-              <a:t>Explanatory delivery refresh of the same frozen execution, with later audit disclosure. No new runtime execution or repairs.</a:t>
+              <a:t>README SHA-256 516b20d0c5b90558e7659c4ca71b2f2741d929c1a41d2427ac823f265f49b730</a:t>
+            </a:r>
+          </a:p>
+          <a:p xmlns:a="http://schemas.openxmlformats.org/drawingml/2006/main">
+            <a:r>
+              <a:t>Proposal SHA-256 02323339203777b80b0bf8969f2392a4663b78be29e88f26f859df376999774a</a:t>
+            </a:r>
+          </a:p>
+          <a:p xmlns:a="http://schemas.openxmlformats.org/drawingml/2006/main">
+            <a:r>
+              <a:t>Immutable execution receipt SHA-256 4f212b53f00cd7f31bae7b94ea63e6a4b99e3a9cf9e645b2989e888a51ceecbf</a:t>
+            </a:r>
+          </a:p>
+          <a:p xmlns:a="http://schemas.openxmlformats.org/drawingml/2006/main">
+            <a:r>
+              <a:t>Later audit SHA-256 75abc802636f2e337b6fda2002b14f4ddf89f434901bae4a034734403f73e35f</a:t>
+            </a:r>
+          </a:p>
+          <a:p xmlns:a="http://schemas.openxmlformats.org/drawingml/2006/main">
+            <a:r>
+              <a:t>Fresh October 7 execution of the merged proposal candidate, compared with the prior immutable run and followed by repeated independent diagnostics. No runtime implementation repairs.</a:t>
             </a:r>
           </a:p>
           <a:p xmlns:a="http://schemas.openxmlformats.org/drawingml/2006/main">
@@ -1920,12 +1920,12 @@
           </a:p>
           <a:p xmlns:a="http://schemas.openxmlformats.org/drawingml/2006/main">
             <a:r>
-              <a:t>Proposal: ### External measurement association at proposal/proposal-source.txt:1558</a:t>
-            </a:r>
-          </a:p>
-          <a:p xmlns:a="http://schemas.openxmlformats.org/drawingml/2006/main">
-            <a:r>
-              <a:t>Functional requirements: [{"id":8,"title":"Brought-in data keeps its coordinates and its CRS.","line":710},{"id":12,"title":"No angle read as a length.","line":790},{"id":18,"title":"Coordinates back out.","line":879},{"id":19,"title":"Resolution leaves the scene as authored.","line":894},{"id":21,"title":"Never placed by a guess.","line":930},{"id":30,"title":"Measurements remain usable as data.","line":962}]</a:t>
+              <a:t>Proposal: ### External measurement association at proposal/proposal-source.txt:1594</a:t>
+            </a:r>
+          </a:p>
+          <a:p xmlns:a="http://schemas.openxmlformats.org/drawingml/2006/main">
+            <a:r>
+              <a:t>Functional requirements: [{"id":8,"title":"Brought-in data keeps its coordinates and its CRS.","line":746},{"id":12,"title":"No angle read as a length.","line":826},{"id":18,"title":"Coordinates back out.","line":915},{"id":19,"title":"Resolution leaves the scene as authored.","line":930},{"id":21,"title":"Never placed by a guess.","line":966},{"id":30,"title":"Measurements remain usable as data.","line":998}]</a:t>
             </a:r>
           </a:p>
           <a:p xmlns:a="http://schemas.openxmlformats.org/drawingml/2006/main">
@@ -1940,27 +1940,27 @@
           </a:p>
           <a:p xmlns:a="http://schemas.openxmlformats.org/drawingml/2006/main">
             <a:r>
-              <a:t>README SHA-256 a45f759d69e14f28301cce5931f6578c8a64ebc8262403a6c8cc3b15b9a0b069</a:t>
-            </a:r>
-          </a:p>
-          <a:p xmlns:a="http://schemas.openxmlformats.org/drawingml/2006/main">
-            <a:r>
-              <a:t>Proposal SHA-256 1727a552053cfdcdf202e2c84ad1209d1a898fe2eab2e322d51e9c7b4ad7c7c0</a:t>
-            </a:r>
-          </a:p>
-          <a:p xmlns:a="http://schemas.openxmlformats.org/drawingml/2006/main">
-            <a:r>
-              <a:t>Immutable execution receipt SHA-256 3baf0e2c215e8ac2ea30fb41197242b663469cd51f31ba48dc9e6c0d7b76833c</a:t>
-            </a:r>
-          </a:p>
-          <a:p xmlns:a="http://schemas.openxmlformats.org/drawingml/2006/main">
-            <a:r>
-              <a:t>Later audit SHA-256 9456363dd93059d7884c0b71a7942f5eed5454ee0d0628e567c2f4856b60a00b</a:t>
-            </a:r>
-          </a:p>
-          <a:p xmlns:a="http://schemas.openxmlformats.org/drawingml/2006/main">
-            <a:r>
-              <a:t>Explanatory delivery refresh of the same frozen execution, with later audit disclosure. No new runtime execution or repairs.</a:t>
+              <a:t>README SHA-256 516b20d0c5b90558e7659c4ca71b2f2741d929c1a41d2427ac823f265f49b730</a:t>
+            </a:r>
+          </a:p>
+          <a:p xmlns:a="http://schemas.openxmlformats.org/drawingml/2006/main">
+            <a:r>
+              <a:t>Proposal SHA-256 02323339203777b80b0bf8969f2392a4663b78be29e88f26f859df376999774a</a:t>
+            </a:r>
+          </a:p>
+          <a:p xmlns:a="http://schemas.openxmlformats.org/drawingml/2006/main">
+            <a:r>
+              <a:t>Immutable execution receipt SHA-256 4f212b53f00cd7f31bae7b94ea63e6a4b99e3a9cf9e645b2989e888a51ceecbf</a:t>
+            </a:r>
+          </a:p>
+          <a:p xmlns:a="http://schemas.openxmlformats.org/drawingml/2006/main">
+            <a:r>
+              <a:t>Later audit SHA-256 75abc802636f2e337b6fda2002b14f4ddf89f434901bae4a034734403f73e35f</a:t>
+            </a:r>
+          </a:p>
+          <a:p xmlns:a="http://schemas.openxmlformats.org/drawingml/2006/main">
+            <a:r>
+              <a:t>Fresh October 7 execution of the merged proposal candidate, compared with the prior immutable run and followed by repeated independent diagnostics. No runtime implementation repairs.</a:t>
             </a:r>
           </a:p>
           <a:p xmlns:a="http://schemas.openxmlformats.org/drawingml/2006/main">
@@ -2045,27 +2045,27 @@
           </a:p>
           <a:p xmlns:a="http://schemas.openxmlformats.org/drawingml/2006/main">
             <a:r>
-              <a:t>README SHA-256 a45f759d69e14f28301cce5931f6578c8a64ebc8262403a6c8cc3b15b9a0b069</a:t>
-            </a:r>
-          </a:p>
-          <a:p xmlns:a="http://schemas.openxmlformats.org/drawingml/2006/main">
-            <a:r>
-              <a:t>Proposal SHA-256 1727a552053cfdcdf202e2c84ad1209d1a898fe2eab2e322d51e9c7b4ad7c7c0</a:t>
-            </a:r>
-          </a:p>
-          <a:p xmlns:a="http://schemas.openxmlformats.org/drawingml/2006/main">
-            <a:r>
-              <a:t>Immutable execution receipt SHA-256 3baf0e2c215e8ac2ea30fb41197242b663469cd51f31ba48dc9e6c0d7b76833c</a:t>
-            </a:r>
-          </a:p>
-          <a:p xmlns:a="http://schemas.openxmlformats.org/drawingml/2006/main">
-            <a:r>
-              <a:t>Later audit SHA-256 9456363dd93059d7884c0b71a7942f5eed5454ee0d0628e567c2f4856b60a00b</a:t>
-            </a:r>
-          </a:p>
-          <a:p xmlns:a="http://schemas.openxmlformats.org/drawingml/2006/main">
-            <a:r>
-              <a:t>Explanatory delivery refresh of the same frozen execution, with later audit disclosure. No new runtime execution or repairs.</a:t>
+              <a:t>README SHA-256 516b20d0c5b90558e7659c4ca71b2f2741d929c1a41d2427ac823f265f49b730</a:t>
+            </a:r>
+          </a:p>
+          <a:p xmlns:a="http://schemas.openxmlformats.org/drawingml/2006/main">
+            <a:r>
+              <a:t>Proposal SHA-256 02323339203777b80b0bf8969f2392a4663b78be29e88f26f859df376999774a</a:t>
+            </a:r>
+          </a:p>
+          <a:p xmlns:a="http://schemas.openxmlformats.org/drawingml/2006/main">
+            <a:r>
+              <a:t>Immutable execution receipt SHA-256 4f212b53f00cd7f31bae7b94ea63e6a4b99e3a9cf9e645b2989e888a51ceecbf</a:t>
+            </a:r>
+          </a:p>
+          <a:p xmlns:a="http://schemas.openxmlformats.org/drawingml/2006/main">
+            <a:r>
+              <a:t>Later audit SHA-256 75abc802636f2e337b6fda2002b14f4ddf89f434901bae4a034734403f73e35f</a:t>
+            </a:r>
+          </a:p>
+          <a:p xmlns:a="http://schemas.openxmlformats.org/drawingml/2006/main">
+            <a:r>
+              <a:t>Fresh October 7 execution of the merged proposal candidate, compared with the prior immutable run and followed by repeated independent diagnostics. No runtime implementation repairs.</a:t>
             </a:r>
           </a:p>
           <a:p xmlns:a="http://schemas.openxmlformats.org/drawingml/2006/main">
@@ -2170,12 +2170,12 @@
           </a:p>
           <a:p xmlns:a="http://schemas.openxmlformats.org/drawingml/2006/main">
             <a:r>
-              <a:t>Proposal: #### Decision on question 7: site calibration at proposal/proposal-source.txt:1247</a:t>
-            </a:r>
-          </a:p>
-          <a:p xmlns:a="http://schemas.openxmlformats.org/drawingml/2006/main">
-            <a:r>
-              <a:t>Functional requirements: [{"id":4,"title":"A site's own grid is a CRS like any other.","line":633},{"id":14,"title":"Scene conventions stay the scene's.","line":821},{"id":15,"title":"Placement separate from conformance.","line":834},{"id":17,"title":"The same answer for every consumer.","line":866}]</a:t>
+              <a:t>Proposal: #### Decision on question 7: site calibration at proposal/proposal-source.txt:1283</a:t>
+            </a:r>
+          </a:p>
+          <a:p xmlns:a="http://schemas.openxmlformats.org/drawingml/2006/main">
+            <a:r>
+              <a:t>Functional requirements: [{"id":4,"title":"A site's own grid is a CRS like any other.","line":669},{"id":14,"title":"Scene conventions stay the scene's.","line":857},{"id":15,"title":"Placement separate from conformance.","line":870},{"id":17,"title":"The same answer for every consumer.","line":902}]</a:t>
             </a:r>
           </a:p>
           <a:p xmlns:a="http://schemas.openxmlformats.org/drawingml/2006/main">
@@ -2190,27 +2190,27 @@
           </a:p>
           <a:p xmlns:a="http://schemas.openxmlformats.org/drawingml/2006/main">
             <a:r>
-              <a:t>README SHA-256 a45f759d69e14f28301cce5931f6578c8a64ebc8262403a6c8cc3b15b9a0b069</a:t>
-            </a:r>
-          </a:p>
-          <a:p xmlns:a="http://schemas.openxmlformats.org/drawingml/2006/main">
-            <a:r>
-              <a:t>Proposal SHA-256 1727a552053cfdcdf202e2c84ad1209d1a898fe2eab2e322d51e9c7b4ad7c7c0</a:t>
-            </a:r>
-          </a:p>
-          <a:p xmlns:a="http://schemas.openxmlformats.org/drawingml/2006/main">
-            <a:r>
-              <a:t>Immutable execution receipt SHA-256 3baf0e2c215e8ac2ea30fb41197242b663469cd51f31ba48dc9e6c0d7b76833c</a:t>
-            </a:r>
-          </a:p>
-          <a:p xmlns:a="http://schemas.openxmlformats.org/drawingml/2006/main">
-            <a:r>
-              <a:t>Later audit SHA-256 9456363dd93059d7884c0b71a7942f5eed5454ee0d0628e567c2f4856b60a00b</a:t>
-            </a:r>
-          </a:p>
-          <a:p xmlns:a="http://schemas.openxmlformats.org/drawingml/2006/main">
-            <a:r>
-              <a:t>Explanatory delivery refresh of the same frozen execution, with later audit disclosure. No new runtime execution or repairs.</a:t>
+              <a:t>README SHA-256 516b20d0c5b90558e7659c4ca71b2f2741d929c1a41d2427ac823f265f49b730</a:t>
+            </a:r>
+          </a:p>
+          <a:p xmlns:a="http://schemas.openxmlformats.org/drawingml/2006/main">
+            <a:r>
+              <a:t>Proposal SHA-256 02323339203777b80b0bf8969f2392a4663b78be29e88f26f859df376999774a</a:t>
+            </a:r>
+          </a:p>
+          <a:p xmlns:a="http://schemas.openxmlformats.org/drawingml/2006/main">
+            <a:r>
+              <a:t>Immutable execution receipt SHA-256 4f212b53f00cd7f31bae7b94ea63e6a4b99e3a9cf9e645b2989e888a51ceecbf</a:t>
+            </a:r>
+          </a:p>
+          <a:p xmlns:a="http://schemas.openxmlformats.org/drawingml/2006/main">
+            <a:r>
+              <a:t>Later audit SHA-256 75abc802636f2e337b6fda2002b14f4ddf89f434901bae4a034734403f73e35f</a:t>
+            </a:r>
+          </a:p>
+          <a:p xmlns:a="http://schemas.openxmlformats.org/drawingml/2006/main">
+            <a:r>
+              <a:t>Fresh October 7 execution of the merged proposal candidate, compared with the prior immutable run and followed by repeated independent diagnostics. No runtime implementation repairs.</a:t>
             </a:r>
           </a:p>
           <a:p xmlns:a="http://schemas.openxmlformats.org/drawingml/2006/main">
@@ -2257,6 +2257,1661 @@
       <p:grpSpPr>
         <a:xfrm xmlns:a="http://schemas.openxmlformats.org/drawingml/2006/main"/>
       </p:grpSpPr>
+      <p:sp>
+        <p:nvSpPr>
+          <p:cNvPr id="3" name="Title">
+            <a:extLst xmlns:a="http://schemas.openxmlformats.org/drawingml/2006/main">
+              <a:ext uri="{FF2B5EF4-FFF2-40B4-BE49-F238E27FC236}">
+                <a16:creationId xmlns:a16="http://schemas.microsoft.com/office/drawing/2014/main" id="{220659E9-D203-4473-AA5F-2871A1BDF4B9}"/>
+              </a:ext>
+            </a:extLst>
+          </p:cNvPr>
+          <p:cNvSpPr>
+            <a:spLocks xmlns:a="http://schemas.openxmlformats.org/drawingml/2006/main" noGrp="1"/>
+          </p:cNvSpPr>
+          <p:nvPr>
+            <p:ph type="title" idx="0"/>
+          </p:nvPr>
+        </p:nvSpPr>
+        <p:spPr>
+          <a:xfrm xmlns:a="http://schemas.openxmlformats.org/drawingml/2006/main">
+            <a:off x="1219200" y="2590800"/>
+            <a:ext cx="9753600" cy="990600"/>
+          </a:xfrm>
+          <a:prstGeom xmlns:a="http://schemas.openxmlformats.org/drawingml/2006/main" prst="rect">
+            <a:avLst/>
+          </a:prstGeom>
+          <a:noFill xmlns:a="http://schemas.openxmlformats.org/drawingml/2006/main"/>
+          <a:ln xmlns:a="http://schemas.openxmlformats.org/drawingml/2006/main">
+            <a:noFill/>
+            <a:prstDash val="solid"/>
+          </a:ln>
+        </p:spPr>
+        <p:txBody>
+          <a:bodyPr xmlns:a="http://schemas.openxmlformats.org/drawingml/2006/main" wrap="square" lIns="0" tIns="0" rIns="0" bIns="0" anchor="ctr">
+            <a:normAutofit/>
+          </a:bodyPr>
+          <a:lstStyle xmlns:a="http://schemas.openxmlformats.org/drawingml/2006/main">
+            <a:defPPr algn="ctr">
+              <a:defRPr sz="4800" b="1">
+                <a:solidFill>
+                  <a:schemeClr val="tx1"/>
+                </a:solidFill>
+                <a:latin typeface="+mj-lt"/>
+                <a:ea typeface="+mj-lt"/>
+                <a:cs typeface="+mj-lt"/>
+              </a:defRPr>
+            </a:defPPr>
+            <a:lvl1pPr marL="0" indent="0">
+              <a:lnSpc>
+                <a:spcPct val="110000"/>
+              </a:lnSpc>
+              <a:spcBef>
+                <a:spcPts val="0"/>
+              </a:spcBef>
+              <a:spcAft>
+                <a:spcPts val="0"/>
+              </a:spcAft>
+              <a:buNone/>
+            </a:lvl1pPr>
+            <a:lvl2pPr marL="0" indent="0">
+              <a:lnSpc>
+                <a:spcPct val="110000"/>
+              </a:lnSpc>
+              <a:spcBef>
+                <a:spcPts val="0"/>
+              </a:spcBef>
+              <a:spcAft>
+                <a:spcPts val="0"/>
+              </a:spcAft>
+              <a:buNone/>
+            </a:lvl2pPr>
+            <a:lvl3pPr marL="0" indent="0">
+              <a:lnSpc>
+                <a:spcPct val="110000"/>
+              </a:lnSpc>
+              <a:spcBef>
+                <a:spcPts val="0"/>
+              </a:spcBef>
+              <a:spcAft>
+                <a:spcPts val="0"/>
+              </a:spcAft>
+              <a:buNone/>
+            </a:lvl3pPr>
+            <a:lvl4pPr marL="0" indent="0">
+              <a:lnSpc>
+                <a:spcPct val="110000"/>
+              </a:lnSpc>
+              <a:spcBef>
+                <a:spcPts val="0"/>
+              </a:spcBef>
+              <a:spcAft>
+                <a:spcPts val="0"/>
+              </a:spcAft>
+              <a:buNone/>
+            </a:lvl4pPr>
+            <a:lvl5pPr marL="0" indent="0">
+              <a:lnSpc>
+                <a:spcPct val="110000"/>
+              </a:lnSpc>
+              <a:spcBef>
+                <a:spcPts val="0"/>
+              </a:spcBef>
+              <a:spcAft>
+                <a:spcPts val="0"/>
+              </a:spcAft>
+              <a:buNone/>
+            </a:lvl5pPr>
+            <a:lvl6pPr marL="0" indent="0">
+              <a:lnSpc>
+                <a:spcPct val="110000"/>
+              </a:lnSpc>
+              <a:spcBef>
+                <a:spcPts val="0"/>
+              </a:spcBef>
+              <a:spcAft>
+                <a:spcPts val="0"/>
+              </a:spcAft>
+              <a:buNone/>
+            </a:lvl6pPr>
+            <a:lvl7pPr marL="0" indent="0">
+              <a:lnSpc>
+                <a:spcPct val="110000"/>
+              </a:lnSpc>
+              <a:spcBef>
+                <a:spcPts val="0"/>
+              </a:spcBef>
+              <a:spcAft>
+                <a:spcPts val="0"/>
+              </a:spcAft>
+              <a:buNone/>
+            </a:lvl7pPr>
+            <a:lvl8pPr marL="0" indent="0">
+              <a:lnSpc>
+                <a:spcPct val="110000"/>
+              </a:lnSpc>
+              <a:spcBef>
+                <a:spcPts val="0"/>
+              </a:spcBef>
+              <a:spcAft>
+                <a:spcPts val="0"/>
+              </a:spcAft>
+              <a:buNone/>
+            </a:lvl8pPr>
+            <a:lvl9pPr marL="0" indent="0">
+              <a:lnSpc>
+                <a:spcPct val="110000"/>
+              </a:lnSpc>
+              <a:spcBef>
+                <a:spcPts val="0"/>
+              </a:spcBef>
+              <a:spcAft>
+                <a:spcPts val="0"/>
+              </a:spcAft>
+              <a:buNone/>
+            </a:lvl9pPr>
+          </a:lstStyle>
+          <a:p xmlns:a="http://schemas.openxmlformats.org/drawingml/2006/main"/>
+        </p:txBody>
+      </p:sp>
+      <p:sp>
+        <p:nvSpPr>
+          <p:cNvPr id="2" name="Subtitle">
+            <a:extLst xmlns:a="http://schemas.openxmlformats.org/drawingml/2006/main">
+              <a:ext uri="{FF2B5EF4-FFF2-40B4-BE49-F238E27FC236}">
+                <a16:creationId xmlns:a16="http://schemas.microsoft.com/office/drawing/2014/main" id="{1F75DA7E-1AE4-47CA-8A2C-599C2659F0E8}"/>
+              </a:ext>
+            </a:extLst>
+          </p:cNvPr>
+          <p:cNvSpPr>
+            <a:spLocks xmlns:a="http://schemas.openxmlformats.org/drawingml/2006/main" noGrp="1"/>
+          </p:cNvSpPr>
+          <p:nvPr>
+            <p:ph type="subTitle" idx="1"/>
+          </p:nvPr>
+        </p:nvSpPr>
+        <p:spPr>
+          <a:xfrm xmlns:a="http://schemas.openxmlformats.org/drawingml/2006/main">
+            <a:off x="1828800" y="3771900"/>
+            <a:ext cx="8534400" cy="762000"/>
+          </a:xfrm>
+          <a:prstGeom xmlns:a="http://schemas.openxmlformats.org/drawingml/2006/main" prst="rect">
+            <a:avLst/>
+          </a:prstGeom>
+          <a:noFill xmlns:a="http://schemas.openxmlformats.org/drawingml/2006/main"/>
+          <a:ln xmlns:a="http://schemas.openxmlformats.org/drawingml/2006/main">
+            <a:noFill/>
+            <a:prstDash val="solid"/>
+          </a:ln>
+        </p:spPr>
+        <p:txBody>
+          <a:bodyPr xmlns:a="http://schemas.openxmlformats.org/drawingml/2006/main" wrap="square" lIns="0" tIns="0" rIns="0" bIns="0" anchor="ctr">
+            <a:normAutofit/>
+          </a:bodyPr>
+          <a:lstStyle xmlns:a="http://schemas.openxmlformats.org/drawingml/2006/main">
+            <a:defPPr algn="ctr">
+              <a:defRPr sz="2100" b="0">
+                <a:solidFill>
+                  <a:schemeClr val="tx1"/>
+                </a:solidFill>
+                <a:latin typeface="+mn-lt"/>
+                <a:ea typeface="+mn-lt"/>
+                <a:cs typeface="+mn-lt"/>
+              </a:defRPr>
+            </a:defPPr>
+            <a:lvl1pPr marL="0" indent="0">
+              <a:lnSpc>
+                <a:spcPct val="110000"/>
+              </a:lnSpc>
+              <a:spcBef>
+                <a:spcPts val="0"/>
+              </a:spcBef>
+              <a:spcAft>
+                <a:spcPts val="0"/>
+              </a:spcAft>
+              <a:buNone/>
+            </a:lvl1pPr>
+            <a:lvl2pPr marL="0" indent="0">
+              <a:lnSpc>
+                <a:spcPct val="110000"/>
+              </a:lnSpc>
+              <a:spcBef>
+                <a:spcPts val="0"/>
+              </a:spcBef>
+              <a:spcAft>
+                <a:spcPts val="0"/>
+              </a:spcAft>
+              <a:buNone/>
+            </a:lvl2pPr>
+            <a:lvl3pPr marL="0" indent="0">
+              <a:lnSpc>
+                <a:spcPct val="110000"/>
+              </a:lnSpc>
+              <a:spcBef>
+                <a:spcPts val="0"/>
+              </a:spcBef>
+              <a:spcAft>
+                <a:spcPts val="0"/>
+              </a:spcAft>
+              <a:buNone/>
+            </a:lvl3pPr>
+            <a:lvl4pPr marL="0" indent="0">
+              <a:lnSpc>
+                <a:spcPct val="110000"/>
+              </a:lnSpc>
+              <a:spcBef>
+                <a:spcPts val="0"/>
+              </a:spcBef>
+              <a:spcAft>
+                <a:spcPts val="0"/>
+              </a:spcAft>
+              <a:buNone/>
+            </a:lvl4pPr>
+            <a:lvl5pPr marL="0" indent="0">
+              <a:lnSpc>
+                <a:spcPct val="110000"/>
+              </a:lnSpc>
+              <a:spcBef>
+                <a:spcPts val="0"/>
+              </a:spcBef>
+              <a:spcAft>
+                <a:spcPts val="0"/>
+              </a:spcAft>
+              <a:buNone/>
+            </a:lvl5pPr>
+            <a:lvl6pPr marL="0" indent="0">
+              <a:lnSpc>
+                <a:spcPct val="110000"/>
+              </a:lnSpc>
+              <a:spcBef>
+                <a:spcPts val="0"/>
+              </a:spcBef>
+              <a:spcAft>
+                <a:spcPts val="0"/>
+              </a:spcAft>
+              <a:buNone/>
+            </a:lvl6pPr>
+            <a:lvl7pPr marL="0" indent="0">
+              <a:lnSpc>
+                <a:spcPct val="110000"/>
+              </a:lnSpc>
+              <a:spcBef>
+                <a:spcPts val="0"/>
+              </a:spcBef>
+              <a:spcAft>
+                <a:spcPts val="0"/>
+              </a:spcAft>
+              <a:buNone/>
+            </a:lvl7pPr>
+            <a:lvl8pPr marL="0" indent="0">
+              <a:lnSpc>
+                <a:spcPct val="110000"/>
+              </a:lnSpc>
+              <a:spcBef>
+                <a:spcPts val="0"/>
+              </a:spcBef>
+              <a:spcAft>
+                <a:spcPts val="0"/>
+              </a:spcAft>
+              <a:buNone/>
+            </a:lvl8pPr>
+            <a:lvl9pPr marL="0" indent="0">
+              <a:lnSpc>
+                <a:spcPct val="110000"/>
+              </a:lnSpc>
+              <a:spcBef>
+                <a:spcPts val="0"/>
+              </a:spcBef>
+              <a:spcAft>
+                <a:spcPts val="0"/>
+              </a:spcAft>
+              <a:buNone/>
+            </a:lvl9pPr>
+          </a:lstStyle>
+          <a:p xmlns:a="http://schemas.openxmlformats.org/drawingml/2006/main"/>
+        </p:txBody>
+      </p:sp>
+    </p:spTree>
+  </p:cSld>
+</p:sldLayout>
+</file>
+
+<file path=ppt/slideLayouts/slideLayout2.xml><?xml version="1.0" encoding="utf-8"?>
+<p:sldLayout xmlns:p="http://schemas.openxmlformats.org/presentationml/2006/main">
+  <p:cSld name="Section Header">
+    <p:spTree>
+      <p:nvGrpSpPr>
+        <p:cNvPr id="1" name=""/>
+        <p:cNvGrpSpPr/>
+        <p:nvPr/>
+      </p:nvGrpSpPr>
+      <p:grpSpPr>
+        <a:xfrm xmlns:a="http://schemas.openxmlformats.org/drawingml/2006/main"/>
+      </p:grpSpPr>
+      <p:sp>
+        <p:nvSpPr>
+          <p:cNvPr id="2" name="Section title">
+            <a:extLst xmlns:a="http://schemas.openxmlformats.org/drawingml/2006/main">
+              <a:ext uri="{FF2B5EF4-FFF2-40B4-BE49-F238E27FC236}">
+                <a16:creationId xmlns:a16="http://schemas.microsoft.com/office/drawing/2014/main" id="{BBD11E14-5A80-4070-B363-D8B4AAB9BC48}"/>
+              </a:ext>
+            </a:extLst>
+          </p:cNvPr>
+          <p:cNvSpPr>
+            <a:spLocks xmlns:a="http://schemas.openxmlformats.org/drawingml/2006/main" noGrp="1"/>
+          </p:cNvSpPr>
+          <p:nvPr>
+            <p:ph type="title" idx="0"/>
+          </p:nvPr>
+        </p:nvSpPr>
+        <p:spPr>
+          <a:xfrm xmlns:a="http://schemas.openxmlformats.org/drawingml/2006/main">
+            <a:off x="1219200" y="2857500"/>
+            <a:ext cx="9753600" cy="1143000"/>
+          </a:xfrm>
+          <a:prstGeom xmlns:a="http://schemas.openxmlformats.org/drawingml/2006/main" prst="rect">
+            <a:avLst/>
+          </a:prstGeom>
+          <a:noFill xmlns:a="http://schemas.openxmlformats.org/drawingml/2006/main"/>
+          <a:ln xmlns:a="http://schemas.openxmlformats.org/drawingml/2006/main">
+            <a:noFill/>
+            <a:prstDash val="solid"/>
+          </a:ln>
+        </p:spPr>
+        <p:txBody>
+          <a:bodyPr xmlns:a="http://schemas.openxmlformats.org/drawingml/2006/main" wrap="square" lIns="0" tIns="0" rIns="0" bIns="0" anchor="ctr">
+            <a:normAutofit/>
+          </a:bodyPr>
+          <a:lstStyle xmlns:a="http://schemas.openxmlformats.org/drawingml/2006/main">
+            <a:defPPr algn="ctr">
+              <a:defRPr sz="4200" b="1">
+                <a:solidFill>
+                  <a:schemeClr val="tx1"/>
+                </a:solidFill>
+                <a:latin typeface="+mj-lt"/>
+                <a:ea typeface="+mj-lt"/>
+                <a:cs typeface="+mj-lt"/>
+              </a:defRPr>
+            </a:defPPr>
+            <a:lvl1pPr marL="0" indent="0">
+              <a:lnSpc>
+                <a:spcPct val="110000"/>
+              </a:lnSpc>
+              <a:spcBef>
+                <a:spcPts val="0"/>
+              </a:spcBef>
+              <a:spcAft>
+                <a:spcPts val="0"/>
+              </a:spcAft>
+              <a:buNone/>
+            </a:lvl1pPr>
+            <a:lvl2pPr marL="0" indent="0">
+              <a:lnSpc>
+                <a:spcPct val="110000"/>
+              </a:lnSpc>
+              <a:spcBef>
+                <a:spcPts val="0"/>
+              </a:spcBef>
+              <a:spcAft>
+                <a:spcPts val="0"/>
+              </a:spcAft>
+              <a:buNone/>
+            </a:lvl2pPr>
+            <a:lvl3pPr marL="0" indent="0">
+              <a:lnSpc>
+                <a:spcPct val="110000"/>
+              </a:lnSpc>
+              <a:spcBef>
+                <a:spcPts val="0"/>
+              </a:spcBef>
+              <a:spcAft>
+                <a:spcPts val="0"/>
+              </a:spcAft>
+              <a:buNone/>
+            </a:lvl3pPr>
+            <a:lvl4pPr marL="0" indent="0">
+              <a:lnSpc>
+                <a:spcPct val="110000"/>
+              </a:lnSpc>
+              <a:spcBef>
+                <a:spcPts val="0"/>
+              </a:spcBef>
+              <a:spcAft>
+                <a:spcPts val="0"/>
+              </a:spcAft>
+              <a:buNone/>
+            </a:lvl4pPr>
+            <a:lvl5pPr marL="0" indent="0">
+              <a:lnSpc>
+                <a:spcPct val="110000"/>
+              </a:lnSpc>
+              <a:spcBef>
+                <a:spcPts val="0"/>
+              </a:spcBef>
+              <a:spcAft>
+                <a:spcPts val="0"/>
+              </a:spcAft>
+              <a:buNone/>
+            </a:lvl5pPr>
+            <a:lvl6pPr marL="0" indent="0">
+              <a:lnSpc>
+                <a:spcPct val="110000"/>
+              </a:lnSpc>
+              <a:spcBef>
+                <a:spcPts val="0"/>
+              </a:spcBef>
+              <a:spcAft>
+                <a:spcPts val="0"/>
+              </a:spcAft>
+              <a:buNone/>
+            </a:lvl6pPr>
+            <a:lvl7pPr marL="0" indent="0">
+              <a:lnSpc>
+                <a:spcPct val="110000"/>
+              </a:lnSpc>
+              <a:spcBef>
+                <a:spcPts val="0"/>
+              </a:spcBef>
+              <a:spcAft>
+                <a:spcPts val="0"/>
+              </a:spcAft>
+              <a:buNone/>
+            </a:lvl7pPr>
+            <a:lvl8pPr marL="0" indent="0">
+              <a:lnSpc>
+                <a:spcPct val="110000"/>
+              </a:lnSpc>
+              <a:spcBef>
+                <a:spcPts val="0"/>
+              </a:spcBef>
+              <a:spcAft>
+                <a:spcPts val="0"/>
+              </a:spcAft>
+              <a:buNone/>
+            </a:lvl8pPr>
+            <a:lvl9pPr marL="0" indent="0">
+              <a:lnSpc>
+                <a:spcPct val="110000"/>
+              </a:lnSpc>
+              <a:spcBef>
+                <a:spcPts val="0"/>
+              </a:spcBef>
+              <a:spcAft>
+                <a:spcPts val="0"/>
+              </a:spcAft>
+              <a:buNone/>
+            </a:lvl9pPr>
+          </a:lstStyle>
+          <a:p xmlns:a="http://schemas.openxmlformats.org/drawingml/2006/main"/>
+        </p:txBody>
+      </p:sp>
+    </p:spTree>
+  </p:cSld>
+</p:sldLayout>
+</file>
+
+<file path=ppt/slideLayouts/slideLayout3.xml><?xml version="1.0" encoding="utf-8"?>
+<p:sldLayout xmlns:p="http://schemas.openxmlformats.org/presentationml/2006/main">
+  <p:cSld name="Title and Body">
+    <p:spTree>
+      <p:nvGrpSpPr>
+        <p:cNvPr id="1" name=""/>
+        <p:cNvGrpSpPr/>
+        <p:nvPr/>
+      </p:nvGrpSpPr>
+      <p:grpSpPr>
+        <a:xfrm xmlns:a="http://schemas.openxmlformats.org/drawingml/2006/main"/>
+      </p:grpSpPr>
+      <p:sp>
+        <p:nvSpPr>
+          <p:cNvPr id="3" name="Title">
+            <a:extLst xmlns:a="http://schemas.openxmlformats.org/drawingml/2006/main">
+              <a:ext uri="{FF2B5EF4-FFF2-40B4-BE49-F238E27FC236}">
+                <a16:creationId xmlns:a16="http://schemas.microsoft.com/office/drawing/2014/main" id="{2185428A-A9AE-4754-A167-A4883351AA5A}"/>
+              </a:ext>
+            </a:extLst>
+          </p:cNvPr>
+          <p:cNvSpPr>
+            <a:spLocks xmlns:a="http://schemas.openxmlformats.org/drawingml/2006/main" noGrp="1"/>
+          </p:cNvSpPr>
+          <p:nvPr>
+            <p:ph type="title" idx="0"/>
+          </p:nvPr>
+        </p:nvSpPr>
+        <p:spPr>
+          <a:xfrm xmlns:a="http://schemas.openxmlformats.org/drawingml/2006/main">
+            <a:off x="685800" y="533400"/>
+            <a:ext cx="10820400" cy="838200"/>
+          </a:xfrm>
+          <a:prstGeom xmlns:a="http://schemas.openxmlformats.org/drawingml/2006/main" prst="rect">
+            <a:avLst/>
+          </a:prstGeom>
+          <a:noFill xmlns:a="http://schemas.openxmlformats.org/drawingml/2006/main"/>
+          <a:ln xmlns:a="http://schemas.openxmlformats.org/drawingml/2006/main">
+            <a:noFill/>
+            <a:prstDash val="solid"/>
+          </a:ln>
+        </p:spPr>
+        <p:txBody>
+          <a:bodyPr xmlns:a="http://schemas.openxmlformats.org/drawingml/2006/main" wrap="square" lIns="0" tIns="0" rIns="0" bIns="0" anchor="t">
+            <a:normAutofit/>
+          </a:bodyPr>
+          <a:lstStyle xmlns:a="http://schemas.openxmlformats.org/drawingml/2006/main">
+            <a:defPPr algn="l">
+              <a:defRPr sz="3300" b="1">
+                <a:solidFill>
+                  <a:schemeClr val="tx1"/>
+                </a:solidFill>
+                <a:latin typeface="+mj-lt"/>
+                <a:ea typeface="+mj-lt"/>
+                <a:cs typeface="+mj-lt"/>
+              </a:defRPr>
+            </a:defPPr>
+            <a:lvl1pPr marL="0" indent="0">
+              <a:lnSpc>
+                <a:spcPct val="110000"/>
+              </a:lnSpc>
+              <a:spcBef>
+                <a:spcPts val="0"/>
+              </a:spcBef>
+              <a:spcAft>
+                <a:spcPts val="0"/>
+              </a:spcAft>
+              <a:buNone/>
+            </a:lvl1pPr>
+            <a:lvl2pPr marL="0" indent="0">
+              <a:lnSpc>
+                <a:spcPct val="110000"/>
+              </a:lnSpc>
+              <a:spcBef>
+                <a:spcPts val="0"/>
+              </a:spcBef>
+              <a:spcAft>
+                <a:spcPts val="0"/>
+              </a:spcAft>
+              <a:buNone/>
+            </a:lvl2pPr>
+            <a:lvl3pPr marL="0" indent="0">
+              <a:lnSpc>
+                <a:spcPct val="110000"/>
+              </a:lnSpc>
+              <a:spcBef>
+                <a:spcPts val="0"/>
+              </a:spcBef>
+              <a:spcAft>
+                <a:spcPts val="0"/>
+              </a:spcAft>
+              <a:buNone/>
+            </a:lvl3pPr>
+            <a:lvl4pPr marL="0" indent="0">
+              <a:lnSpc>
+                <a:spcPct val="110000"/>
+              </a:lnSpc>
+              <a:spcBef>
+                <a:spcPts val="0"/>
+              </a:spcBef>
+              <a:spcAft>
+                <a:spcPts val="0"/>
+              </a:spcAft>
+              <a:buNone/>
+            </a:lvl4pPr>
+            <a:lvl5pPr marL="0" indent="0">
+              <a:lnSpc>
+                <a:spcPct val="110000"/>
+              </a:lnSpc>
+              <a:spcBef>
+                <a:spcPts val="0"/>
+              </a:spcBef>
+              <a:spcAft>
+                <a:spcPts val="0"/>
+              </a:spcAft>
+              <a:buNone/>
+            </a:lvl5pPr>
+            <a:lvl6pPr marL="0" indent="0">
+              <a:lnSpc>
+                <a:spcPct val="110000"/>
+              </a:lnSpc>
+              <a:spcBef>
+                <a:spcPts val="0"/>
+              </a:spcBef>
+              <a:spcAft>
+                <a:spcPts val="0"/>
+              </a:spcAft>
+              <a:buNone/>
+            </a:lvl6pPr>
+            <a:lvl7pPr marL="0" indent="0">
+              <a:lnSpc>
+                <a:spcPct val="110000"/>
+              </a:lnSpc>
+              <a:spcBef>
+                <a:spcPts val="0"/>
+              </a:spcBef>
+              <a:spcAft>
+                <a:spcPts val="0"/>
+              </a:spcAft>
+              <a:buNone/>
+            </a:lvl7pPr>
+            <a:lvl8pPr marL="0" indent="0">
+              <a:lnSpc>
+                <a:spcPct val="110000"/>
+              </a:lnSpc>
+              <a:spcBef>
+                <a:spcPts val="0"/>
+              </a:spcBef>
+              <a:spcAft>
+                <a:spcPts val="0"/>
+              </a:spcAft>
+              <a:buNone/>
+            </a:lvl8pPr>
+            <a:lvl9pPr marL="0" indent="0">
+              <a:lnSpc>
+                <a:spcPct val="110000"/>
+              </a:lnSpc>
+              <a:spcBef>
+                <a:spcPts val="0"/>
+              </a:spcBef>
+              <a:spcAft>
+                <a:spcPts val="0"/>
+              </a:spcAft>
+              <a:buNone/>
+            </a:lvl9pPr>
+          </a:lstStyle>
+          <a:p xmlns:a="http://schemas.openxmlformats.org/drawingml/2006/main"/>
+        </p:txBody>
+      </p:sp>
+      <p:sp>
+        <p:nvSpPr>
+          <p:cNvPr id="2" name="Body">
+            <a:extLst xmlns:a="http://schemas.openxmlformats.org/drawingml/2006/main">
+              <a:ext uri="{FF2B5EF4-FFF2-40B4-BE49-F238E27FC236}">
+                <a16:creationId xmlns:a16="http://schemas.microsoft.com/office/drawing/2014/main" id="{4A01EE01-423C-4BF1-BAD9-AD71A01B2E74}"/>
+              </a:ext>
+            </a:extLst>
+          </p:cNvPr>
+          <p:cNvSpPr>
+            <a:spLocks xmlns:a="http://schemas.openxmlformats.org/drawingml/2006/main" noGrp="1"/>
+          </p:cNvSpPr>
+          <p:nvPr>
+            <p:ph type="body" idx="1"/>
+          </p:nvPr>
+        </p:nvSpPr>
+        <p:spPr>
+          <a:xfrm xmlns:a="http://schemas.openxmlformats.org/drawingml/2006/main">
+            <a:off x="685800" y="1905000"/>
+            <a:ext cx="10820400" cy="4267200"/>
+          </a:xfrm>
+          <a:prstGeom xmlns:a="http://schemas.openxmlformats.org/drawingml/2006/main" prst="rect">
+            <a:avLst/>
+          </a:prstGeom>
+          <a:noFill xmlns:a="http://schemas.openxmlformats.org/drawingml/2006/main"/>
+          <a:ln xmlns:a="http://schemas.openxmlformats.org/drawingml/2006/main">
+            <a:noFill/>
+            <a:prstDash val="solid"/>
+          </a:ln>
+        </p:spPr>
+        <p:txBody>
+          <a:bodyPr xmlns:a="http://schemas.openxmlformats.org/drawingml/2006/main" wrap="square" lIns="0" tIns="0" rIns="0" bIns="0" anchor="t">
+            <a:normAutofit/>
+          </a:bodyPr>
+          <a:lstStyle xmlns:a="http://schemas.openxmlformats.org/drawingml/2006/main">
+            <a:defPPr algn="l">
+              <a:defRPr sz="2250" b="0">
+                <a:solidFill>
+                  <a:schemeClr val="tx1"/>
+                </a:solidFill>
+                <a:latin typeface="+mn-lt"/>
+                <a:ea typeface="+mn-lt"/>
+                <a:cs typeface="+mn-lt"/>
+              </a:defRPr>
+            </a:defPPr>
+            <a:lvl1pPr marL="228600" indent="-228600">
+              <a:lnSpc>
+                <a:spcPct val="110000"/>
+              </a:lnSpc>
+              <a:spcBef>
+                <a:spcPts val="0"/>
+              </a:spcBef>
+              <a:spcAft>
+                <a:spcPts val="1200"/>
+              </a:spcAft>
+              <a:buChar char="•"/>
+            </a:lvl1pPr>
+            <a:lvl2pPr marL="533400" indent="-228600">
+              <a:lnSpc>
+                <a:spcPct val="110000"/>
+              </a:lnSpc>
+              <a:spcBef>
+                <a:spcPts val="0"/>
+              </a:spcBef>
+              <a:spcAft>
+                <a:spcPts val="1200"/>
+              </a:spcAft>
+              <a:buChar char="•"/>
+            </a:lvl2pPr>
+            <a:lvl3pPr marL="838200" indent="-228600">
+              <a:lnSpc>
+                <a:spcPct val="110000"/>
+              </a:lnSpc>
+              <a:spcBef>
+                <a:spcPts val="0"/>
+              </a:spcBef>
+              <a:spcAft>
+                <a:spcPts val="1200"/>
+              </a:spcAft>
+              <a:buChar char="•"/>
+            </a:lvl3pPr>
+            <a:lvl4pPr marL="1143000" indent="-228600">
+              <a:lnSpc>
+                <a:spcPct val="110000"/>
+              </a:lnSpc>
+              <a:spcBef>
+                <a:spcPts val="0"/>
+              </a:spcBef>
+              <a:spcAft>
+                <a:spcPts val="1200"/>
+              </a:spcAft>
+              <a:buChar char="•"/>
+            </a:lvl4pPr>
+            <a:lvl5pPr marL="1447800" indent="-228600">
+              <a:lnSpc>
+                <a:spcPct val="110000"/>
+              </a:lnSpc>
+              <a:spcBef>
+                <a:spcPts val="0"/>
+              </a:spcBef>
+              <a:spcAft>
+                <a:spcPts val="1200"/>
+              </a:spcAft>
+              <a:buChar char="•"/>
+            </a:lvl5pPr>
+            <a:lvl6pPr marL="1752600" indent="-228600">
+              <a:lnSpc>
+                <a:spcPct val="110000"/>
+              </a:lnSpc>
+              <a:spcBef>
+                <a:spcPts val="0"/>
+              </a:spcBef>
+              <a:spcAft>
+                <a:spcPts val="1200"/>
+              </a:spcAft>
+              <a:buChar char="•"/>
+            </a:lvl6pPr>
+            <a:lvl7pPr marL="2057400" indent="-228600">
+              <a:lnSpc>
+                <a:spcPct val="110000"/>
+              </a:lnSpc>
+              <a:spcBef>
+                <a:spcPts val="0"/>
+              </a:spcBef>
+              <a:spcAft>
+                <a:spcPts val="1200"/>
+              </a:spcAft>
+              <a:buChar char="•"/>
+            </a:lvl7pPr>
+            <a:lvl8pPr marL="2362200" indent="-228600">
+              <a:lnSpc>
+                <a:spcPct val="110000"/>
+              </a:lnSpc>
+              <a:spcBef>
+                <a:spcPts val="0"/>
+              </a:spcBef>
+              <a:spcAft>
+                <a:spcPts val="1200"/>
+              </a:spcAft>
+              <a:buChar char="•"/>
+            </a:lvl8pPr>
+            <a:lvl9pPr marL="2667000" indent="-228600">
+              <a:lnSpc>
+                <a:spcPct val="110000"/>
+              </a:lnSpc>
+              <a:spcBef>
+                <a:spcPts val="0"/>
+              </a:spcBef>
+              <a:spcAft>
+                <a:spcPts val="1200"/>
+              </a:spcAft>
+              <a:buChar char="•"/>
+            </a:lvl9pPr>
+          </a:lstStyle>
+          <a:p xmlns:a="http://schemas.openxmlformats.org/drawingml/2006/main"/>
+        </p:txBody>
+      </p:sp>
+    </p:spTree>
+  </p:cSld>
+</p:sldLayout>
+</file>
+
+<file path=ppt/slideLayouts/slideLayout4.xml><?xml version="1.0" encoding="utf-8"?>
+<p:sldLayout xmlns:p="http://schemas.openxmlformats.org/presentationml/2006/main">
+  <p:cSld name="Title and Two Column">
+    <p:spTree>
+      <p:nvGrpSpPr>
+        <p:cNvPr id="1" name=""/>
+        <p:cNvGrpSpPr/>
+        <p:nvPr/>
+      </p:nvGrpSpPr>
+      <p:grpSpPr>
+        <a:xfrm xmlns:a="http://schemas.openxmlformats.org/drawingml/2006/main"/>
+      </p:grpSpPr>
+      <p:sp>
+        <p:nvSpPr>
+          <p:cNvPr id="4" name="Title">
+            <a:extLst xmlns:a="http://schemas.openxmlformats.org/drawingml/2006/main">
+              <a:ext uri="{FF2B5EF4-FFF2-40B4-BE49-F238E27FC236}">
+                <a16:creationId xmlns:a16="http://schemas.microsoft.com/office/drawing/2014/main" id="{1F18A24A-B485-4A01-8117-0E26196E5EA9}"/>
+              </a:ext>
+            </a:extLst>
+          </p:cNvPr>
+          <p:cNvSpPr>
+            <a:spLocks xmlns:a="http://schemas.openxmlformats.org/drawingml/2006/main" noGrp="1"/>
+          </p:cNvSpPr>
+          <p:nvPr>
+            <p:ph type="title" idx="0"/>
+          </p:nvPr>
+        </p:nvSpPr>
+        <p:spPr>
+          <a:xfrm xmlns:a="http://schemas.openxmlformats.org/drawingml/2006/main">
+            <a:off x="685800" y="533400"/>
+            <a:ext cx="10820400" cy="838200"/>
+          </a:xfrm>
+          <a:prstGeom xmlns:a="http://schemas.openxmlformats.org/drawingml/2006/main" prst="rect">
+            <a:avLst/>
+          </a:prstGeom>
+          <a:noFill xmlns:a="http://schemas.openxmlformats.org/drawingml/2006/main"/>
+          <a:ln xmlns:a="http://schemas.openxmlformats.org/drawingml/2006/main">
+            <a:noFill/>
+            <a:prstDash val="solid"/>
+          </a:ln>
+        </p:spPr>
+        <p:txBody>
+          <a:bodyPr xmlns:a="http://schemas.openxmlformats.org/drawingml/2006/main" wrap="square" lIns="0" tIns="0" rIns="0" bIns="0" anchor="t">
+            <a:normAutofit/>
+          </a:bodyPr>
+          <a:lstStyle xmlns:a="http://schemas.openxmlformats.org/drawingml/2006/main">
+            <a:defPPr algn="l">
+              <a:defRPr sz="3300" b="1">
+                <a:solidFill>
+                  <a:schemeClr val="tx1"/>
+                </a:solidFill>
+                <a:latin typeface="+mj-lt"/>
+                <a:ea typeface="+mj-lt"/>
+                <a:cs typeface="+mj-lt"/>
+              </a:defRPr>
+            </a:defPPr>
+            <a:lvl1pPr marL="0" indent="0">
+              <a:lnSpc>
+                <a:spcPct val="110000"/>
+              </a:lnSpc>
+              <a:spcBef>
+                <a:spcPts val="0"/>
+              </a:spcBef>
+              <a:spcAft>
+                <a:spcPts val="0"/>
+              </a:spcAft>
+              <a:buNone/>
+            </a:lvl1pPr>
+            <a:lvl2pPr marL="0" indent="0">
+              <a:lnSpc>
+                <a:spcPct val="110000"/>
+              </a:lnSpc>
+              <a:spcBef>
+                <a:spcPts val="0"/>
+              </a:spcBef>
+              <a:spcAft>
+                <a:spcPts val="0"/>
+              </a:spcAft>
+              <a:buNone/>
+            </a:lvl2pPr>
+            <a:lvl3pPr marL="0" indent="0">
+              <a:lnSpc>
+                <a:spcPct val="110000"/>
+              </a:lnSpc>
+              <a:spcBef>
+                <a:spcPts val="0"/>
+              </a:spcBef>
+              <a:spcAft>
+                <a:spcPts val="0"/>
+              </a:spcAft>
+              <a:buNone/>
+            </a:lvl3pPr>
+            <a:lvl4pPr marL="0" indent="0">
+              <a:lnSpc>
+                <a:spcPct val="110000"/>
+              </a:lnSpc>
+              <a:spcBef>
+                <a:spcPts val="0"/>
+              </a:spcBef>
+              <a:spcAft>
+                <a:spcPts val="0"/>
+              </a:spcAft>
+              <a:buNone/>
+            </a:lvl4pPr>
+            <a:lvl5pPr marL="0" indent="0">
+              <a:lnSpc>
+                <a:spcPct val="110000"/>
+              </a:lnSpc>
+              <a:spcBef>
+                <a:spcPts val="0"/>
+              </a:spcBef>
+              <a:spcAft>
+                <a:spcPts val="0"/>
+              </a:spcAft>
+              <a:buNone/>
+            </a:lvl5pPr>
+            <a:lvl6pPr marL="0" indent="0">
+              <a:lnSpc>
+                <a:spcPct val="110000"/>
+              </a:lnSpc>
+              <a:spcBef>
+                <a:spcPts val="0"/>
+              </a:spcBef>
+              <a:spcAft>
+                <a:spcPts val="0"/>
+              </a:spcAft>
+              <a:buNone/>
+            </a:lvl6pPr>
+            <a:lvl7pPr marL="0" indent="0">
+              <a:lnSpc>
+                <a:spcPct val="110000"/>
+              </a:lnSpc>
+              <a:spcBef>
+                <a:spcPts val="0"/>
+              </a:spcBef>
+              <a:spcAft>
+                <a:spcPts val="0"/>
+              </a:spcAft>
+              <a:buNone/>
+            </a:lvl7pPr>
+            <a:lvl8pPr marL="0" indent="0">
+              <a:lnSpc>
+                <a:spcPct val="110000"/>
+              </a:lnSpc>
+              <a:spcBef>
+                <a:spcPts val="0"/>
+              </a:spcBef>
+              <a:spcAft>
+                <a:spcPts val="0"/>
+              </a:spcAft>
+              <a:buNone/>
+            </a:lvl8pPr>
+            <a:lvl9pPr marL="0" indent="0">
+              <a:lnSpc>
+                <a:spcPct val="110000"/>
+              </a:lnSpc>
+              <a:spcBef>
+                <a:spcPts val="0"/>
+              </a:spcBef>
+              <a:spcAft>
+                <a:spcPts val="0"/>
+              </a:spcAft>
+              <a:buNone/>
+            </a:lvl9pPr>
+          </a:lstStyle>
+          <a:p xmlns:a="http://schemas.openxmlformats.org/drawingml/2006/main"/>
+        </p:txBody>
+      </p:sp>
+      <p:sp>
+        <p:nvSpPr>
+          <p:cNvPr id="2" name="Left column">
+            <a:extLst xmlns:a="http://schemas.openxmlformats.org/drawingml/2006/main">
+              <a:ext uri="{FF2B5EF4-FFF2-40B4-BE49-F238E27FC236}">
+                <a16:creationId xmlns:a16="http://schemas.microsoft.com/office/drawing/2014/main" id="{B4D9F165-3908-428C-9190-966CE7848D93}"/>
+              </a:ext>
+            </a:extLst>
+          </p:cNvPr>
+          <p:cNvSpPr>
+            <a:spLocks xmlns:a="http://schemas.openxmlformats.org/drawingml/2006/main" noGrp="1"/>
+          </p:cNvSpPr>
+          <p:nvPr>
+            <p:ph type="body" idx="1"/>
+          </p:nvPr>
+        </p:nvSpPr>
+        <p:spPr>
+          <a:xfrm xmlns:a="http://schemas.openxmlformats.org/drawingml/2006/main">
+            <a:off x="685800" y="1905000"/>
+            <a:ext cx="5029200" cy="4267200"/>
+          </a:xfrm>
+          <a:prstGeom xmlns:a="http://schemas.openxmlformats.org/drawingml/2006/main" prst="rect">
+            <a:avLst/>
+          </a:prstGeom>
+          <a:noFill xmlns:a="http://schemas.openxmlformats.org/drawingml/2006/main"/>
+          <a:ln xmlns:a="http://schemas.openxmlformats.org/drawingml/2006/main">
+            <a:noFill/>
+            <a:prstDash val="solid"/>
+          </a:ln>
+        </p:spPr>
+        <p:txBody>
+          <a:bodyPr xmlns:a="http://schemas.openxmlformats.org/drawingml/2006/main" wrap="square" lIns="0" tIns="0" rIns="0" bIns="0" anchor="t">
+            <a:normAutofit/>
+          </a:bodyPr>
+          <a:lstStyle xmlns:a="http://schemas.openxmlformats.org/drawingml/2006/main">
+            <a:defPPr algn="l">
+              <a:defRPr sz="2100" b="0">
+                <a:solidFill>
+                  <a:schemeClr val="tx1"/>
+                </a:solidFill>
+                <a:latin typeface="+mn-lt"/>
+                <a:ea typeface="+mn-lt"/>
+                <a:cs typeface="+mn-lt"/>
+              </a:defRPr>
+            </a:defPPr>
+            <a:lvl1pPr marL="228600" indent="-228600">
+              <a:lnSpc>
+                <a:spcPct val="110000"/>
+              </a:lnSpc>
+              <a:spcBef>
+                <a:spcPts val="0"/>
+              </a:spcBef>
+              <a:spcAft>
+                <a:spcPts val="1200"/>
+              </a:spcAft>
+              <a:buChar char="•"/>
+            </a:lvl1pPr>
+            <a:lvl2pPr marL="533400" indent="-228600">
+              <a:lnSpc>
+                <a:spcPct val="110000"/>
+              </a:lnSpc>
+              <a:spcBef>
+                <a:spcPts val="0"/>
+              </a:spcBef>
+              <a:spcAft>
+                <a:spcPts val="1200"/>
+              </a:spcAft>
+              <a:buChar char="•"/>
+            </a:lvl2pPr>
+            <a:lvl3pPr marL="838200" indent="-228600">
+              <a:lnSpc>
+                <a:spcPct val="110000"/>
+              </a:lnSpc>
+              <a:spcBef>
+                <a:spcPts val="0"/>
+              </a:spcBef>
+              <a:spcAft>
+                <a:spcPts val="1200"/>
+              </a:spcAft>
+              <a:buChar char="•"/>
+            </a:lvl3pPr>
+            <a:lvl4pPr marL="1143000" indent="-228600">
+              <a:lnSpc>
+                <a:spcPct val="110000"/>
+              </a:lnSpc>
+              <a:spcBef>
+                <a:spcPts val="0"/>
+              </a:spcBef>
+              <a:spcAft>
+                <a:spcPts val="1200"/>
+              </a:spcAft>
+              <a:buChar char="•"/>
+            </a:lvl4pPr>
+            <a:lvl5pPr marL="1447800" indent="-228600">
+              <a:lnSpc>
+                <a:spcPct val="110000"/>
+              </a:lnSpc>
+              <a:spcBef>
+                <a:spcPts val="0"/>
+              </a:spcBef>
+              <a:spcAft>
+                <a:spcPts val="1200"/>
+              </a:spcAft>
+              <a:buChar char="•"/>
+            </a:lvl5pPr>
+            <a:lvl6pPr marL="1752600" indent="-228600">
+              <a:lnSpc>
+                <a:spcPct val="110000"/>
+              </a:lnSpc>
+              <a:spcBef>
+                <a:spcPts val="0"/>
+              </a:spcBef>
+              <a:spcAft>
+                <a:spcPts val="1200"/>
+              </a:spcAft>
+              <a:buChar char="•"/>
+            </a:lvl6pPr>
+            <a:lvl7pPr marL="2057400" indent="-228600">
+              <a:lnSpc>
+                <a:spcPct val="110000"/>
+              </a:lnSpc>
+              <a:spcBef>
+                <a:spcPts val="0"/>
+              </a:spcBef>
+              <a:spcAft>
+                <a:spcPts val="1200"/>
+              </a:spcAft>
+              <a:buChar char="•"/>
+            </a:lvl7pPr>
+            <a:lvl8pPr marL="2362200" indent="-228600">
+              <a:lnSpc>
+                <a:spcPct val="110000"/>
+              </a:lnSpc>
+              <a:spcBef>
+                <a:spcPts val="0"/>
+              </a:spcBef>
+              <a:spcAft>
+                <a:spcPts val="1200"/>
+              </a:spcAft>
+              <a:buChar char="•"/>
+            </a:lvl8pPr>
+            <a:lvl9pPr marL="2667000" indent="-228600">
+              <a:lnSpc>
+                <a:spcPct val="110000"/>
+              </a:lnSpc>
+              <a:spcBef>
+                <a:spcPts val="0"/>
+              </a:spcBef>
+              <a:spcAft>
+                <a:spcPts val="1200"/>
+              </a:spcAft>
+              <a:buChar char="•"/>
+            </a:lvl9pPr>
+          </a:lstStyle>
+          <a:p xmlns:a="http://schemas.openxmlformats.org/drawingml/2006/main"/>
+        </p:txBody>
+      </p:sp>
+      <p:sp>
+        <p:nvSpPr>
+          <p:cNvPr id="3" name="Right column">
+            <a:extLst xmlns:a="http://schemas.openxmlformats.org/drawingml/2006/main">
+              <a:ext uri="{FF2B5EF4-FFF2-40B4-BE49-F238E27FC236}">
+                <a16:creationId xmlns:a16="http://schemas.microsoft.com/office/drawing/2014/main" id="{1D455195-7D37-4699-9600-513CE51B2A45}"/>
+              </a:ext>
+            </a:extLst>
+          </p:cNvPr>
+          <p:cNvSpPr>
+            <a:spLocks xmlns:a="http://schemas.openxmlformats.org/drawingml/2006/main" noGrp="1"/>
+          </p:cNvSpPr>
+          <p:nvPr>
+            <p:ph type="body" idx="2"/>
+          </p:nvPr>
+        </p:nvSpPr>
+        <p:spPr>
+          <a:xfrm xmlns:a="http://schemas.openxmlformats.org/drawingml/2006/main">
+            <a:off x="6477000" y="1905000"/>
+            <a:ext cx="5029200" cy="4267200"/>
+          </a:xfrm>
+          <a:prstGeom xmlns:a="http://schemas.openxmlformats.org/drawingml/2006/main" prst="rect">
+            <a:avLst/>
+          </a:prstGeom>
+          <a:noFill xmlns:a="http://schemas.openxmlformats.org/drawingml/2006/main"/>
+          <a:ln xmlns:a="http://schemas.openxmlformats.org/drawingml/2006/main">
+            <a:noFill/>
+            <a:prstDash val="solid"/>
+          </a:ln>
+        </p:spPr>
+        <p:txBody>
+          <a:bodyPr xmlns:a="http://schemas.openxmlformats.org/drawingml/2006/main" wrap="square" lIns="0" tIns="0" rIns="0" bIns="0" anchor="t">
+            <a:normAutofit/>
+          </a:bodyPr>
+          <a:lstStyle xmlns:a="http://schemas.openxmlformats.org/drawingml/2006/main">
+            <a:defPPr algn="l">
+              <a:defRPr sz="2100" b="0">
+                <a:solidFill>
+                  <a:schemeClr val="tx1"/>
+                </a:solidFill>
+                <a:latin typeface="+mn-lt"/>
+                <a:ea typeface="+mn-lt"/>
+                <a:cs typeface="+mn-lt"/>
+              </a:defRPr>
+            </a:defPPr>
+            <a:lvl1pPr marL="228600" indent="-228600">
+              <a:lnSpc>
+                <a:spcPct val="110000"/>
+              </a:lnSpc>
+              <a:spcBef>
+                <a:spcPts val="0"/>
+              </a:spcBef>
+              <a:spcAft>
+                <a:spcPts val="1200"/>
+              </a:spcAft>
+              <a:buChar char="•"/>
+            </a:lvl1pPr>
+            <a:lvl2pPr marL="533400" indent="-228600">
+              <a:lnSpc>
+                <a:spcPct val="110000"/>
+              </a:lnSpc>
+              <a:spcBef>
+                <a:spcPts val="0"/>
+              </a:spcBef>
+              <a:spcAft>
+                <a:spcPts val="1200"/>
+              </a:spcAft>
+              <a:buChar char="•"/>
+            </a:lvl2pPr>
+            <a:lvl3pPr marL="838200" indent="-228600">
+              <a:lnSpc>
+                <a:spcPct val="110000"/>
+              </a:lnSpc>
+              <a:spcBef>
+                <a:spcPts val="0"/>
+              </a:spcBef>
+              <a:spcAft>
+                <a:spcPts val="1200"/>
+              </a:spcAft>
+              <a:buChar char="•"/>
+            </a:lvl3pPr>
+            <a:lvl4pPr marL="1143000" indent="-228600">
+              <a:lnSpc>
+                <a:spcPct val="110000"/>
+              </a:lnSpc>
+              <a:spcBef>
+                <a:spcPts val="0"/>
+              </a:spcBef>
+              <a:spcAft>
+                <a:spcPts val="1200"/>
+              </a:spcAft>
+              <a:buChar char="•"/>
+            </a:lvl4pPr>
+            <a:lvl5pPr marL="1447800" indent="-228600">
+              <a:lnSpc>
+                <a:spcPct val="110000"/>
+              </a:lnSpc>
+              <a:spcBef>
+                <a:spcPts val="0"/>
+              </a:spcBef>
+              <a:spcAft>
+                <a:spcPts val="1200"/>
+              </a:spcAft>
+              <a:buChar char="•"/>
+            </a:lvl5pPr>
+            <a:lvl6pPr marL="1752600" indent="-228600">
+              <a:lnSpc>
+                <a:spcPct val="110000"/>
+              </a:lnSpc>
+              <a:spcBef>
+                <a:spcPts val="0"/>
+              </a:spcBef>
+              <a:spcAft>
+                <a:spcPts val="1200"/>
+              </a:spcAft>
+              <a:buChar char="•"/>
+            </a:lvl6pPr>
+            <a:lvl7pPr marL="2057400" indent="-228600">
+              <a:lnSpc>
+                <a:spcPct val="110000"/>
+              </a:lnSpc>
+              <a:spcBef>
+                <a:spcPts val="0"/>
+              </a:spcBef>
+              <a:spcAft>
+                <a:spcPts val="1200"/>
+              </a:spcAft>
+              <a:buChar char="•"/>
+            </a:lvl7pPr>
+            <a:lvl8pPr marL="2362200" indent="-228600">
+              <a:lnSpc>
+                <a:spcPct val="110000"/>
+              </a:lnSpc>
+              <a:spcBef>
+                <a:spcPts val="0"/>
+              </a:spcBef>
+              <a:spcAft>
+                <a:spcPts val="1200"/>
+              </a:spcAft>
+              <a:buChar char="•"/>
+            </a:lvl8pPr>
+            <a:lvl9pPr marL="2667000" indent="-228600">
+              <a:lnSpc>
+                <a:spcPct val="110000"/>
+              </a:lnSpc>
+              <a:spcBef>
+                <a:spcPts val="0"/>
+              </a:spcBef>
+              <a:spcAft>
+                <a:spcPts val="1200"/>
+              </a:spcAft>
+              <a:buChar char="•"/>
+            </a:lvl9pPr>
+          </a:lstStyle>
+          <a:p xmlns:a="http://schemas.openxmlformats.org/drawingml/2006/main"/>
+        </p:txBody>
+      </p:sp>
+    </p:spTree>
+  </p:cSld>
+</p:sldLayout>
+</file>
+
+<file path=ppt/slideLayouts/slideLayout5.xml><?xml version="1.0" encoding="utf-8"?>
+<p:sldLayout xmlns:p="http://schemas.openxmlformats.org/presentationml/2006/main">
+  <p:cSld name="Title and One Column">
+    <p:spTree>
+      <p:nvGrpSpPr>
+        <p:cNvPr id="1" name=""/>
+        <p:cNvGrpSpPr/>
+        <p:nvPr/>
+      </p:nvGrpSpPr>
+      <p:grpSpPr>
+        <a:xfrm xmlns:a="http://schemas.openxmlformats.org/drawingml/2006/main"/>
+      </p:grpSpPr>
+      <p:sp>
+        <p:nvSpPr>
+          <p:cNvPr id="3" name="Title">
+            <a:extLst xmlns:a="http://schemas.openxmlformats.org/drawingml/2006/main">
+              <a:ext uri="{FF2B5EF4-FFF2-40B4-BE49-F238E27FC236}">
+                <a16:creationId xmlns:a16="http://schemas.microsoft.com/office/drawing/2014/main" id="{A30F211D-3C5B-4295-92D5-00AA23A6033B}"/>
+              </a:ext>
+            </a:extLst>
+          </p:cNvPr>
+          <p:cNvSpPr>
+            <a:spLocks xmlns:a="http://schemas.openxmlformats.org/drawingml/2006/main" noGrp="1"/>
+          </p:cNvSpPr>
+          <p:nvPr>
+            <p:ph type="title" idx="0"/>
+          </p:nvPr>
+        </p:nvSpPr>
+        <p:spPr>
+          <a:xfrm xmlns:a="http://schemas.openxmlformats.org/drawingml/2006/main">
+            <a:off x="685800" y="533400"/>
+            <a:ext cx="10820400" cy="838200"/>
+          </a:xfrm>
+          <a:prstGeom xmlns:a="http://schemas.openxmlformats.org/drawingml/2006/main" prst="rect">
+            <a:avLst/>
+          </a:prstGeom>
+          <a:noFill xmlns:a="http://schemas.openxmlformats.org/drawingml/2006/main"/>
+          <a:ln xmlns:a="http://schemas.openxmlformats.org/drawingml/2006/main">
+            <a:noFill/>
+            <a:prstDash val="solid"/>
+          </a:ln>
+        </p:spPr>
+        <p:txBody>
+          <a:bodyPr xmlns:a="http://schemas.openxmlformats.org/drawingml/2006/main" wrap="square" lIns="0" tIns="0" rIns="0" bIns="0" anchor="t">
+            <a:normAutofit/>
+          </a:bodyPr>
+          <a:lstStyle xmlns:a="http://schemas.openxmlformats.org/drawingml/2006/main">
+            <a:defPPr algn="l">
+              <a:defRPr sz="3300" b="1">
+                <a:solidFill>
+                  <a:schemeClr val="tx1"/>
+                </a:solidFill>
+                <a:latin typeface="+mj-lt"/>
+                <a:ea typeface="+mj-lt"/>
+                <a:cs typeface="+mj-lt"/>
+              </a:defRPr>
+            </a:defPPr>
+            <a:lvl1pPr marL="0" indent="0">
+              <a:lnSpc>
+                <a:spcPct val="110000"/>
+              </a:lnSpc>
+              <a:spcBef>
+                <a:spcPts val="0"/>
+              </a:spcBef>
+              <a:spcAft>
+                <a:spcPts val="0"/>
+              </a:spcAft>
+              <a:buNone/>
+            </a:lvl1pPr>
+            <a:lvl2pPr marL="0" indent="0">
+              <a:lnSpc>
+                <a:spcPct val="110000"/>
+              </a:lnSpc>
+              <a:spcBef>
+                <a:spcPts val="0"/>
+              </a:spcBef>
+              <a:spcAft>
+                <a:spcPts val="0"/>
+              </a:spcAft>
+              <a:buNone/>
+            </a:lvl2pPr>
+            <a:lvl3pPr marL="0" indent="0">
+              <a:lnSpc>
+                <a:spcPct val="110000"/>
+              </a:lnSpc>
+              <a:spcBef>
+                <a:spcPts val="0"/>
+              </a:spcBef>
+              <a:spcAft>
+                <a:spcPts val="0"/>
+              </a:spcAft>
+              <a:buNone/>
+            </a:lvl3pPr>
+            <a:lvl4pPr marL="0" indent="0">
+              <a:lnSpc>
+                <a:spcPct val="110000"/>
+              </a:lnSpc>
+              <a:spcBef>
+                <a:spcPts val="0"/>
+              </a:spcBef>
+              <a:spcAft>
+                <a:spcPts val="0"/>
+              </a:spcAft>
+              <a:buNone/>
+            </a:lvl4pPr>
+            <a:lvl5pPr marL="0" indent="0">
+              <a:lnSpc>
+                <a:spcPct val="110000"/>
+              </a:lnSpc>
+              <a:spcBef>
+                <a:spcPts val="0"/>
+              </a:spcBef>
+              <a:spcAft>
+                <a:spcPts val="0"/>
+              </a:spcAft>
+              <a:buNone/>
+            </a:lvl5pPr>
+            <a:lvl6pPr marL="0" indent="0">
+              <a:lnSpc>
+                <a:spcPct val="110000"/>
+              </a:lnSpc>
+              <a:spcBef>
+                <a:spcPts val="0"/>
+              </a:spcBef>
+              <a:spcAft>
+                <a:spcPts val="0"/>
+              </a:spcAft>
+              <a:buNone/>
+            </a:lvl6pPr>
+            <a:lvl7pPr marL="0" indent="0">
+              <a:lnSpc>
+                <a:spcPct val="110000"/>
+              </a:lnSpc>
+              <a:spcBef>
+                <a:spcPts val="0"/>
+              </a:spcBef>
+              <a:spcAft>
+                <a:spcPts val="0"/>
+              </a:spcAft>
+              <a:buNone/>
+            </a:lvl7pPr>
+            <a:lvl8pPr marL="0" indent="0">
+              <a:lnSpc>
+                <a:spcPct val="110000"/>
+              </a:lnSpc>
+              <a:spcBef>
+                <a:spcPts val="0"/>
+              </a:spcBef>
+              <a:spcAft>
+                <a:spcPts val="0"/>
+              </a:spcAft>
+              <a:buNone/>
+            </a:lvl8pPr>
+            <a:lvl9pPr marL="0" indent="0">
+              <a:lnSpc>
+                <a:spcPct val="110000"/>
+              </a:lnSpc>
+              <a:spcBef>
+                <a:spcPts val="0"/>
+              </a:spcBef>
+              <a:spcAft>
+                <a:spcPts val="0"/>
+              </a:spcAft>
+              <a:buNone/>
+            </a:lvl9pPr>
+          </a:lstStyle>
+          <a:p xmlns:a="http://schemas.openxmlformats.org/drawingml/2006/main"/>
+        </p:txBody>
+      </p:sp>
+      <p:sp>
+        <p:nvSpPr>
+          <p:cNvPr id="2" name="Left column">
+            <a:extLst xmlns:a="http://schemas.openxmlformats.org/drawingml/2006/main">
+              <a:ext uri="{FF2B5EF4-FFF2-40B4-BE49-F238E27FC236}">
+                <a16:creationId xmlns:a16="http://schemas.microsoft.com/office/drawing/2014/main" id="{87AE72FE-A597-42F4-B993-42C5BDCE5A8E}"/>
+              </a:ext>
+            </a:extLst>
+          </p:cNvPr>
+          <p:cNvSpPr>
+            <a:spLocks xmlns:a="http://schemas.openxmlformats.org/drawingml/2006/main" noGrp="1"/>
+          </p:cNvSpPr>
+          <p:nvPr>
+            <p:ph type="body" idx="1"/>
+          </p:nvPr>
+        </p:nvSpPr>
+        <p:spPr>
+          <a:xfrm xmlns:a="http://schemas.openxmlformats.org/drawingml/2006/main">
+            <a:off x="685800" y="1905000"/>
+            <a:ext cx="5029200" cy="4267200"/>
+          </a:xfrm>
+          <a:prstGeom xmlns:a="http://schemas.openxmlformats.org/drawingml/2006/main" prst="rect">
+            <a:avLst/>
+          </a:prstGeom>
+          <a:noFill xmlns:a="http://schemas.openxmlformats.org/drawingml/2006/main"/>
+          <a:ln xmlns:a="http://schemas.openxmlformats.org/drawingml/2006/main">
+            <a:noFill/>
+            <a:prstDash val="solid"/>
+          </a:ln>
+        </p:spPr>
+        <p:txBody>
+          <a:bodyPr xmlns:a="http://schemas.openxmlformats.org/drawingml/2006/main" wrap="square" lIns="0" tIns="0" rIns="0" bIns="0" anchor="t">
+            <a:normAutofit/>
+          </a:bodyPr>
+          <a:lstStyle xmlns:a="http://schemas.openxmlformats.org/drawingml/2006/main">
+            <a:defPPr algn="l">
+              <a:defRPr sz="2250" b="0">
+                <a:solidFill>
+                  <a:schemeClr val="tx1"/>
+                </a:solidFill>
+                <a:latin typeface="+mn-lt"/>
+                <a:ea typeface="+mn-lt"/>
+                <a:cs typeface="+mn-lt"/>
+              </a:defRPr>
+            </a:defPPr>
+            <a:lvl1pPr marL="228600" indent="-228600">
+              <a:lnSpc>
+                <a:spcPct val="110000"/>
+              </a:lnSpc>
+              <a:spcBef>
+                <a:spcPts val="0"/>
+              </a:spcBef>
+              <a:spcAft>
+                <a:spcPts val="1200"/>
+              </a:spcAft>
+              <a:buChar char="•"/>
+            </a:lvl1pPr>
+            <a:lvl2pPr marL="533400" indent="-228600">
+              <a:lnSpc>
+                <a:spcPct val="110000"/>
+              </a:lnSpc>
+              <a:spcBef>
+                <a:spcPts val="0"/>
+              </a:spcBef>
+              <a:spcAft>
+                <a:spcPts val="1200"/>
+              </a:spcAft>
+              <a:buChar char="•"/>
+            </a:lvl2pPr>
+            <a:lvl3pPr marL="838200" indent="-228600">
+              <a:lnSpc>
+                <a:spcPct val="110000"/>
+              </a:lnSpc>
+              <a:spcBef>
+                <a:spcPts val="0"/>
+              </a:spcBef>
+              <a:spcAft>
+                <a:spcPts val="1200"/>
+              </a:spcAft>
+              <a:buChar char="•"/>
+            </a:lvl3pPr>
+            <a:lvl4pPr marL="1143000" indent="-228600">
+              <a:lnSpc>
+                <a:spcPct val="110000"/>
+              </a:lnSpc>
+              <a:spcBef>
+                <a:spcPts val="0"/>
+              </a:spcBef>
+              <a:spcAft>
+                <a:spcPts val="1200"/>
+              </a:spcAft>
+              <a:buChar char="•"/>
+            </a:lvl4pPr>
+            <a:lvl5pPr marL="1447800" indent="-228600">
+              <a:lnSpc>
+                <a:spcPct val="110000"/>
+              </a:lnSpc>
+              <a:spcBef>
+                <a:spcPts val="0"/>
+              </a:spcBef>
+              <a:spcAft>
+                <a:spcPts val="1200"/>
+              </a:spcAft>
+              <a:buChar char="•"/>
+            </a:lvl5pPr>
+            <a:lvl6pPr marL="1752600" indent="-228600">
+              <a:lnSpc>
+                <a:spcPct val="110000"/>
+              </a:lnSpc>
+              <a:spcBef>
+                <a:spcPts val="0"/>
+              </a:spcBef>
+              <a:spcAft>
+                <a:spcPts val="1200"/>
+              </a:spcAft>
+              <a:buChar char="•"/>
+            </a:lvl6pPr>
+            <a:lvl7pPr marL="2057400" indent="-228600">
+              <a:lnSpc>
+                <a:spcPct val="110000"/>
+              </a:lnSpc>
+              <a:spcBef>
+                <a:spcPts val="0"/>
+              </a:spcBef>
+              <a:spcAft>
+                <a:spcPts val="1200"/>
+              </a:spcAft>
+              <a:buChar char="•"/>
+            </a:lvl7pPr>
+            <a:lvl8pPr marL="2362200" indent="-228600">
+              <a:lnSpc>
+                <a:spcPct val="110000"/>
+              </a:lnSpc>
+              <a:spcBef>
+                <a:spcPts val="0"/>
+              </a:spcBef>
+              <a:spcAft>
+                <a:spcPts val="1200"/>
+              </a:spcAft>
+              <a:buChar char="•"/>
+            </a:lvl8pPr>
+            <a:lvl9pPr marL="2667000" indent="-228600">
+              <a:lnSpc>
+                <a:spcPct val="110000"/>
+              </a:lnSpc>
+              <a:spcBef>
+                <a:spcPts val="0"/>
+              </a:spcBef>
+              <a:spcAft>
+                <a:spcPts val="1200"/>
+              </a:spcAft>
+              <a:buChar char="•"/>
+            </a:lvl9pPr>
+          </a:lstStyle>
+          <a:p xmlns:a="http://schemas.openxmlformats.org/drawingml/2006/main"/>
+        </p:txBody>
+      </p:sp>
+    </p:spTree>
+  </p:cSld>
+</p:sldLayout>
+</file>
+
+<file path=ppt/slideLayouts/slideLayout6.xml><?xml version="1.0" encoding="utf-8"?>
+<p:sldLayout xmlns:p="http://schemas.openxmlformats.org/presentationml/2006/main" type="blank">
+  <p:cSld name="Blank">
+    <p:spTree>
+      <p:nvGrpSpPr>
+        <p:cNvPr id="1" name=""/>
+        <p:cNvGrpSpPr/>
+        <p:nvPr/>
+      </p:nvGrpSpPr>
+      <p:grpSpPr>
+        <a:xfrm xmlns:a="http://schemas.openxmlformats.org/drawingml/2006/main"/>
+      </p:grpSpPr>
     </p:spTree>
   </p:cSld>
 </p:sldLayout>
@@ -2283,7 +3938,12 @@
   </p:cSld>
   <p:clrMap bg1="lt1" tx1="dk1" bg2="lt2" tx2="dk2" accent1="accent1" accent2="accent2" accent3="accent3" accent4="accent4" accent5="accent5" accent6="accent6" hlink="hlink" folHlink="folHlink"/>
   <p:sldLayoutIdLst>
-    <p:sldLayoutId xmlns:r="http://schemas.openxmlformats.org/officeDocument/2006/relationships" id="2147483649" r:id="R63993a8ec42f4b90"/>
+    <p:sldLayoutId xmlns:r="http://schemas.openxmlformats.org/officeDocument/2006/relationships" id="2147483649" r:id="Rd553a99e5c8742ce"/>
+    <p:sldLayoutId xmlns:r="http://schemas.openxmlformats.org/officeDocument/2006/relationships" id="2147483650" r:id="R408132e069874fcd"/>
+    <p:sldLayoutId xmlns:r="http://schemas.openxmlformats.org/officeDocument/2006/relationships" id="2147483651" r:id="Rd963513004a04202"/>
+    <p:sldLayoutId xmlns:r="http://schemas.openxmlformats.org/officeDocument/2006/relationships" id="2147483652" r:id="R5462bf3210d842d5"/>
+    <p:sldLayoutId xmlns:r="http://schemas.openxmlformats.org/officeDocument/2006/relationships" id="2147483653" r:id="R205afdfa0fcd4551"/>
+    <p:sldLayoutId xmlns:r="http://schemas.openxmlformats.org/officeDocument/2006/relationships" id="2147483654" r:id="R023c756582894d55"/>
   </p:sldLayoutIdLst>
   <p:txStyles>
     <p:titleStyle>
@@ -2606,16 +4266,16 @@
         <a:srgbClr val="96607D"/>
       </a:folHlink>
     </a:clrScheme>
-    <a:fontScheme name="Office">
+    <a:fontScheme name="">
       <a:majorFont>
-        <a:latin typeface="Calibri Light"/>
-        <a:ea typeface="Calibri Light"/>
-        <a:cs typeface="Calibri Light"/>
+        <a:latin typeface="Aptos"/>
+        <a:ea typeface=""/>
+        <a:cs typeface=""/>
       </a:majorFont>
       <a:minorFont>
-        <a:latin typeface="Calibri"/>
-        <a:ea typeface="Calibri"/>
-        <a:cs typeface="Calibri"/>
+        <a:latin typeface="Aptos"/>
+        <a:ea typeface=""/>
+        <a:cs typeface=""/>
       </a:minorFont>
     </a:fontScheme>
     <a:fmtScheme name="ChatGPT">
@@ -2868,6 +4528,7 @@
           </c:val>
         </c:ser>
         <c:dLbls>
+          <c:numFmt formatCode="0.0" sourceLinked="0"/>
           <c:txPr>
             <a:bodyPr xmlns:a="http://schemas.openxmlformats.org/drawingml/2006/main" anchorCtr="1"/>
             <a:lstStyle xmlns:a="http://schemas.openxmlformats.org/drawingml/2006/main"/>
@@ -3097,7 +4758,7 @@
           <p:cNvPr id="5" name="">
             <a:extLst xmlns:a="http://schemas.openxmlformats.org/drawingml/2006/main">
               <a:ext uri="{FF2B5EF4-FFF2-40B4-BE49-F238E27FC236}">
-                <a16:creationId xmlns:a16="http://schemas.microsoft.com/office/drawing/2014/main" id="{65404368-CA0A-4ED6-84A0-FAF0F330019C}"/>
+                <a16:creationId xmlns:a16="http://schemas.microsoft.com/office/drawing/2014/main" id="{C8D60A16-78C3-4EE0-AFB8-9F873F12A3CF}"/>
               </a:ext>
             </a:extLst>
           </p:cNvPr>
@@ -3127,7 +4788,18 @@
           <a:bodyPr xmlns:a="http://schemas.openxmlformats.org/drawingml/2006/main" anchor="t">
             <a:noAutofit/>
           </a:bodyPr>
-          <a:lstStyle xmlns:a="http://schemas.openxmlformats.org/drawingml/2006/main"/>
+          <a:lstStyle xmlns:a="http://schemas.openxmlformats.org/drawingml/2006/main">
+            <a:defPPr>
+              <a:defRPr sz="3150" b="1">
+                <a:solidFill>
+                  <a:srgbClr val="213744"/>
+                </a:solidFill>
+                <a:latin typeface="Arial"/>
+                <a:ea typeface="Arial"/>
+                <a:cs typeface="Arial"/>
+              </a:defRPr>
+            </a:defPPr>
+          </a:lstStyle>
           <a:p xmlns:a="http://schemas.openxmlformats.org/drawingml/2006/main">
             <a:pPr>
               <a:defRPr sz="3150" b="1">
@@ -3158,7 +4830,7 @@
           <p:cNvPr id="2" name="">
             <a:extLst xmlns:a="http://schemas.openxmlformats.org/drawingml/2006/main">
               <a:ext uri="{FF2B5EF4-FFF2-40B4-BE49-F238E27FC236}">
-                <a16:creationId xmlns:a16="http://schemas.microsoft.com/office/drawing/2014/main" id="{EEC180C0-43E7-4493-B47D-58521CAE435F}"/>
+                <a16:creationId xmlns:a16="http://schemas.microsoft.com/office/drawing/2014/main" id="{E31A36F0-9BEB-4F15-B98F-D3886E3A0997}"/>
               </a:ext>
             </a:extLst>
           </p:cNvPr>
@@ -3188,7 +4860,18 @@
           <a:bodyPr xmlns:a="http://schemas.openxmlformats.org/drawingml/2006/main" anchor="t">
             <a:noAutofit/>
           </a:bodyPr>
-          <a:lstStyle xmlns:a="http://schemas.openxmlformats.org/drawingml/2006/main"/>
+          <a:lstStyle xmlns:a="http://schemas.openxmlformats.org/drawingml/2006/main">
+            <a:defPPr>
+              <a:defRPr sz="2325" b="0">
+                <a:solidFill>
+                  <a:srgbClr val="213744"/>
+                </a:solidFill>
+                <a:latin typeface="Arial"/>
+                <a:ea typeface="Arial"/>
+                <a:cs typeface="Arial"/>
+              </a:defRPr>
+            </a:defPPr>
+          </a:lstStyle>
           <a:p xmlns:a="http://schemas.openxmlformats.org/drawingml/2006/main">
             <a:pPr>
               <a:defRPr sz="2325" b="0">
@@ -3219,7 +4902,7 @@
           <p:cNvPr id="3" name="">
             <a:extLst xmlns:a="http://schemas.openxmlformats.org/drawingml/2006/main">
               <a:ext uri="{FF2B5EF4-FFF2-40B4-BE49-F238E27FC236}">
-                <a16:creationId xmlns:a16="http://schemas.microsoft.com/office/drawing/2014/main" id="{A4AFE987-6D67-4F6C-8CF5-FAA68E94516E}"/>
+                <a16:creationId xmlns:a16="http://schemas.microsoft.com/office/drawing/2014/main" id="{BAC565FE-91AD-4BD8-9B0A-AB0CE696C6B6}"/>
               </a:ext>
             </a:extLst>
           </p:cNvPr>
@@ -3249,7 +4932,18 @@
           <a:bodyPr xmlns:a="http://schemas.openxmlformats.org/drawingml/2006/main" anchor="t">
             <a:noAutofit/>
           </a:bodyPr>
-          <a:lstStyle xmlns:a="http://schemas.openxmlformats.org/drawingml/2006/main"/>
+          <a:lstStyle xmlns:a="http://schemas.openxmlformats.org/drawingml/2006/main">
+            <a:defPPr>
+              <a:defRPr sz="2325" b="0">
+                <a:solidFill>
+                  <a:srgbClr val="157C87"/>
+                </a:solidFill>
+                <a:latin typeface="Arial"/>
+                <a:ea typeface="Arial"/>
+                <a:cs typeface="Arial"/>
+              </a:defRPr>
+            </a:defPPr>
+          </a:lstStyle>
           <a:p xmlns:a="http://schemas.openxmlformats.org/drawingml/2006/main">
             <a:pPr>
               <a:defRPr sz="2325" b="0">
@@ -3270,7 +4964,7 @@
                 <a:ea typeface="Arial"/>
                 <a:cs typeface="Arial"/>
               </a:rPr>
-              <a:t>The question: can another implementer derive the behavior without guessing? The draft now defines the tested inputs and rules. Those choices still need group review.</a:t>
+              <a:t>The merged background separates map-grid distances and north from physical model size and orientation. A narrow clarification keeps stage axes distinct. Existing placement rules remain unchanged.</a:t>
             </a:r>
           </a:p>
         </p:txBody>
@@ -3280,7 +4974,7 @@
           <p:cNvPr id="4" name="">
             <a:extLst xmlns:a="http://schemas.openxmlformats.org/drawingml/2006/main">
               <a:ext uri="{FF2B5EF4-FFF2-40B4-BE49-F238E27FC236}">
-                <a16:creationId xmlns:a16="http://schemas.microsoft.com/office/drawing/2014/main" id="{6BD85FDD-38D6-4BA2-A29A-1E4CA473BE92}"/>
+                <a16:creationId xmlns:a16="http://schemas.microsoft.com/office/drawing/2014/main" id="{93662254-A4ED-4FB9-9B1B-57F2519AB24D}"/>
               </a:ext>
             </a:extLst>
           </p:cNvPr>
@@ -3310,7 +5004,18 @@
           <a:bodyPr xmlns:a="http://schemas.openxmlformats.org/drawingml/2006/main" anchor="t">
             <a:noAutofit/>
           </a:bodyPr>
-          <a:lstStyle xmlns:a="http://schemas.openxmlformats.org/drawingml/2006/main"/>
+          <a:lstStyle xmlns:a="http://schemas.openxmlformats.org/drawingml/2006/main">
+            <a:defPPr>
+              <a:defRPr sz="2025" b="0">
+                <a:solidFill>
+                  <a:srgbClr val="526B79"/>
+                </a:solidFill>
+                <a:latin typeface="Arial"/>
+                <a:ea typeface="Arial"/>
+                <a:cs typeface="Arial"/>
+              </a:defRPr>
+            </a:defPPr>
+          </a:lstStyle>
           <a:p xmlns:a="http://schemas.openxmlformats.org/drawingml/2006/main">
             <a:pPr>
               <a:defRPr sz="2025" b="0">
@@ -3331,7 +5036,7 @@
                 <a:ea typeface="Arial"/>
                 <a:cs typeface="Arial"/>
               </a:rPr>
-              <a:t>Selected demonstrations work. A later audit found seven prototype issues. No additional model blocker was confirmed; this does not establish complete coverage.</a:t>
+              <a:t>The fresh run reproduces the selected results with no numerical changes. Seven known prototype issues also reproduce. Clearer explanation does not mean those defects are fixed.</a:t>
             </a:r>
           </a:p>
         </p:txBody>
@@ -3339,7 +5044,7 @@
     </p:spTree>
     <p:extLst>
       <p:ext uri="{BB962C8B-B14F-4D97-AF65-F5344CB8AC3E}">
-        <p14:creationId xmlns:p14="http://schemas.microsoft.com/office/powerpoint/2010/main" val="1329898867"/>
+        <p14:creationId xmlns:p14="http://schemas.microsoft.com/office/powerpoint/2010/main" val="2105127"/>
       </p:ext>
     </p:extLst>
   </p:cSld>
@@ -3370,7 +5075,7 @@
           <p:cNvPr id="9" name="">
             <a:extLst xmlns:a="http://schemas.openxmlformats.org/drawingml/2006/main">
               <a:ext uri="{FF2B5EF4-FFF2-40B4-BE49-F238E27FC236}">
-                <a16:creationId xmlns:a16="http://schemas.microsoft.com/office/drawing/2014/main" id="{9FA5CAD0-44ED-4A25-9DBE-85A15C2A28A2}"/>
+                <a16:creationId xmlns:a16="http://schemas.microsoft.com/office/drawing/2014/main" id="{4D307153-D94B-44C8-8601-7196D7A2E91B}"/>
               </a:ext>
             </a:extLst>
           </p:cNvPr>
@@ -3400,7 +5105,18 @@
           <a:bodyPr xmlns:a="http://schemas.openxmlformats.org/drawingml/2006/main" anchor="t">
             <a:noAutofit/>
           </a:bodyPr>
-          <a:lstStyle xmlns:a="http://schemas.openxmlformats.org/drawingml/2006/main"/>
+          <a:lstStyle xmlns:a="http://schemas.openxmlformats.org/drawingml/2006/main">
+            <a:defPPr>
+              <a:defRPr sz="3150" b="1">
+                <a:solidFill>
+                  <a:srgbClr val="213744"/>
+                </a:solidFill>
+                <a:latin typeface="Arial"/>
+                <a:ea typeface="Arial"/>
+                <a:cs typeface="Arial"/>
+              </a:defRPr>
+            </a:defPPr>
+          </a:lstStyle>
           <a:p xmlns:a="http://schemas.openxmlformats.org/drawingml/2006/main">
             <a:pPr>
               <a:defRPr sz="3150" b="1">
@@ -3431,7 +5147,7 @@
           <p:cNvPr id="2" name="">
             <a:extLst xmlns:a="http://schemas.openxmlformats.org/drawingml/2006/main">
               <a:ext uri="{FF2B5EF4-FFF2-40B4-BE49-F238E27FC236}">
-                <a16:creationId xmlns:a16="http://schemas.microsoft.com/office/drawing/2014/main" id="{EE0024D1-0446-446C-81FF-DBB7BA79644D}"/>
+                <a16:creationId xmlns:a16="http://schemas.microsoft.com/office/drawing/2014/main" id="{6B273EF4-58A1-46BB-A5B5-BD79CE69D0D0}"/>
               </a:ext>
             </a:extLst>
           </p:cNvPr>
@@ -3461,7 +5177,18 @@
           <a:bodyPr xmlns:a="http://schemas.openxmlformats.org/drawingml/2006/main" anchor="t">
             <a:noAutofit/>
           </a:bodyPr>
-          <a:lstStyle xmlns:a="http://schemas.openxmlformats.org/drawingml/2006/main"/>
+          <a:lstStyle xmlns:a="http://schemas.openxmlformats.org/drawingml/2006/main">
+            <a:defPPr>
+              <a:defRPr sz="2325" b="1">
+                <a:solidFill>
+                  <a:srgbClr val="157C87"/>
+                </a:solidFill>
+                <a:latin typeface="Arial"/>
+                <a:ea typeface="Arial"/>
+                <a:cs typeface="Arial"/>
+              </a:defRPr>
+            </a:defPPr>
+          </a:lstStyle>
           <a:p xmlns:a="http://schemas.openxmlformats.org/drawingml/2006/main">
             <a:pPr>
               <a:defRPr sz="2325" b="1">
@@ -3489,14 +5216,20 @@
       </p:sp>
       <p:pic>
         <p:nvPicPr>
-          <p:cNvPr id="11" name=""/>
+          <p:cNvPr id="3" name="">
+            <a:extLst xmlns:a="http://schemas.openxmlformats.org/drawingml/2006/main">
+              <a:ext uri="{FF2B5EF4-FFF2-40B4-BE49-F238E27FC236}">
+                <a16:creationId xmlns:a16="http://schemas.microsoft.com/office/drawing/2014/main" id="{1E0DBABB-D27B-4046-A810-149F2659D54D}"/>
+              </a:ext>
+            </a:extLst>
+          </p:cNvPr>
           <p:cNvPicPr>
             <a:picLocks xmlns:a="http://schemas.openxmlformats.org/drawingml/2006/main" noChangeAspect="1"/>
           </p:cNvPicPr>
           <p:nvPr/>
         </p:nvPicPr>
         <p:blipFill>
-          <a:blip xmlns:r="http://schemas.openxmlformats.org/officeDocument/2006/relationships" xmlns:a="http://schemas.openxmlformats.org/drawingml/2006/main" r:embed="R66bbf444a85f4034"/>
+          <a:blip xmlns:r="http://schemas.openxmlformats.org/officeDocument/2006/relationships" xmlns:a="http://schemas.openxmlformats.org/drawingml/2006/main" r:embed="R5a3c4667fbfa46b3"/>
           <a:stretch xmlns:a="http://schemas.openxmlformats.org/drawingml/2006/main"/>
         </p:blipFill>
         <p:spPr>
@@ -3514,7 +5247,7 @@
           <p:cNvPr id="4" name="">
             <a:extLst xmlns:a="http://schemas.openxmlformats.org/drawingml/2006/main">
               <a:ext uri="{FF2B5EF4-FFF2-40B4-BE49-F238E27FC236}">
-                <a16:creationId xmlns:a16="http://schemas.microsoft.com/office/drawing/2014/main" id="{42625F29-27A8-4579-B586-97230A85997B}"/>
+                <a16:creationId xmlns:a16="http://schemas.microsoft.com/office/drawing/2014/main" id="{D78AA00A-2B71-4C5F-AB7F-E044908661B6}"/>
               </a:ext>
             </a:extLst>
           </p:cNvPr>
@@ -3544,7 +5277,18 @@
           <a:bodyPr xmlns:a="http://schemas.openxmlformats.org/drawingml/2006/main" anchor="t">
             <a:noAutofit/>
           </a:bodyPr>
-          <a:lstStyle xmlns:a="http://schemas.openxmlformats.org/drawingml/2006/main"/>
+          <a:lstStyle xmlns:a="http://schemas.openxmlformats.org/drawingml/2006/main">
+            <a:defPPr>
+              <a:defRPr sz="1650" b="1">
+                <a:solidFill>
+                  <a:srgbClr val="157C87"/>
+                </a:solidFill>
+                <a:latin typeface="Arial"/>
+                <a:ea typeface="Arial"/>
+                <a:cs typeface="Arial"/>
+              </a:defRPr>
+            </a:defPPr>
+          </a:lstStyle>
           <a:p xmlns:a="http://schemas.openxmlformats.org/drawingml/2006/main">
             <a:pPr>
               <a:defRPr sz="1650" b="1">
@@ -3575,7 +5319,7 @@
           <p:cNvPr id="5" name="">
             <a:extLst xmlns:a="http://schemas.openxmlformats.org/drawingml/2006/main">
               <a:ext uri="{FF2B5EF4-FFF2-40B4-BE49-F238E27FC236}">
-                <a16:creationId xmlns:a16="http://schemas.microsoft.com/office/drawing/2014/main" id="{9A063B63-4002-4292-8B75-6600310C3631}"/>
+                <a16:creationId xmlns:a16="http://schemas.microsoft.com/office/drawing/2014/main" id="{7044622D-FA76-4EAF-BBDF-BC0DEDAB463A}"/>
               </a:ext>
             </a:extLst>
           </p:cNvPr>
@@ -3605,7 +5349,18 @@
           <a:bodyPr xmlns:a="http://schemas.openxmlformats.org/drawingml/2006/main" anchor="t">
             <a:noAutofit/>
           </a:bodyPr>
-          <a:lstStyle xmlns:a="http://schemas.openxmlformats.org/drawingml/2006/main"/>
+          <a:lstStyle xmlns:a="http://schemas.openxmlformats.org/drawingml/2006/main">
+            <a:defPPr>
+              <a:defRPr sz="1800" b="0">
+                <a:solidFill>
+                  <a:srgbClr val="213744"/>
+                </a:solidFill>
+                <a:latin typeface="Arial"/>
+                <a:ea typeface="Arial"/>
+                <a:cs typeface="Arial"/>
+              </a:defRPr>
+            </a:defPPr>
+          </a:lstStyle>
           <a:p xmlns:a="http://schemas.openxmlformats.org/drawingml/2006/main">
             <a:pPr>
               <a:defRPr sz="1800" b="0">
@@ -3636,7 +5391,7 @@
           <p:cNvPr id="6" name="">
             <a:extLst xmlns:a="http://schemas.openxmlformats.org/drawingml/2006/main">
               <a:ext uri="{FF2B5EF4-FFF2-40B4-BE49-F238E27FC236}">
-                <a16:creationId xmlns:a16="http://schemas.microsoft.com/office/drawing/2014/main" id="{C4885DE8-3166-4363-B827-0BF7F6EF5E2A}"/>
+                <a16:creationId xmlns:a16="http://schemas.microsoft.com/office/drawing/2014/main" id="{068C5AB4-737D-45A5-A565-4B6B1C8AB448}"/>
               </a:ext>
             </a:extLst>
           </p:cNvPr>
@@ -3666,7 +5421,18 @@
           <a:bodyPr xmlns:a="http://schemas.openxmlformats.org/drawingml/2006/main" anchor="t">
             <a:noAutofit/>
           </a:bodyPr>
-          <a:lstStyle xmlns:a="http://schemas.openxmlformats.org/drawingml/2006/main"/>
+          <a:lstStyle xmlns:a="http://schemas.openxmlformats.org/drawingml/2006/main">
+            <a:defPPr>
+              <a:defRPr sz="1650" b="1">
+                <a:solidFill>
+                  <a:srgbClr val="157C87"/>
+                </a:solidFill>
+                <a:latin typeface="Arial"/>
+                <a:ea typeface="Arial"/>
+                <a:cs typeface="Arial"/>
+              </a:defRPr>
+            </a:defPPr>
+          </a:lstStyle>
           <a:p xmlns:a="http://schemas.openxmlformats.org/drawingml/2006/main">
             <a:pPr>
               <a:defRPr sz="1650" b="1">
@@ -3697,7 +5463,7 @@
           <p:cNvPr id="7" name="">
             <a:extLst xmlns:a="http://schemas.openxmlformats.org/drawingml/2006/main">
               <a:ext uri="{FF2B5EF4-FFF2-40B4-BE49-F238E27FC236}">
-                <a16:creationId xmlns:a16="http://schemas.microsoft.com/office/drawing/2014/main" id="{C97C1D50-1683-4116-83FD-8C37CEBE3DB8}"/>
+                <a16:creationId xmlns:a16="http://schemas.microsoft.com/office/drawing/2014/main" id="{3995FE27-49CD-4941-B5BC-D6C38EEBA8B1}"/>
               </a:ext>
             </a:extLst>
           </p:cNvPr>
@@ -3727,7 +5493,18 @@
           <a:bodyPr xmlns:a="http://schemas.openxmlformats.org/drawingml/2006/main" anchor="t">
             <a:noAutofit/>
           </a:bodyPr>
-          <a:lstStyle xmlns:a="http://schemas.openxmlformats.org/drawingml/2006/main"/>
+          <a:lstStyle xmlns:a="http://schemas.openxmlformats.org/drawingml/2006/main">
+            <a:defPPr>
+              <a:defRPr sz="1800" b="0">
+                <a:solidFill>
+                  <a:srgbClr val="213744"/>
+                </a:solidFill>
+                <a:latin typeface="Arial"/>
+                <a:ea typeface="Arial"/>
+                <a:cs typeface="Arial"/>
+              </a:defRPr>
+            </a:defPPr>
+          </a:lstStyle>
           <a:p xmlns:a="http://schemas.openxmlformats.org/drawingml/2006/main">
             <a:pPr>
               <a:defRPr sz="1800" b="0">
@@ -3758,7 +5535,7 @@
           <p:cNvPr id="8" name="">
             <a:extLst xmlns:a="http://schemas.openxmlformats.org/drawingml/2006/main">
               <a:ext uri="{FF2B5EF4-FFF2-40B4-BE49-F238E27FC236}">
-                <a16:creationId xmlns:a16="http://schemas.microsoft.com/office/drawing/2014/main" id="{AB94F6D9-9DF9-4FBE-844A-CD8F45A18571}"/>
+                <a16:creationId xmlns:a16="http://schemas.microsoft.com/office/drawing/2014/main" id="{9F650FB1-06F4-4B30-91C6-2BC8A59965A6}"/>
               </a:ext>
             </a:extLst>
           </p:cNvPr>
@@ -3788,7 +5565,18 @@
           <a:bodyPr xmlns:a="http://schemas.openxmlformats.org/drawingml/2006/main" anchor="t">
             <a:noAutofit/>
           </a:bodyPr>
-          <a:lstStyle xmlns:a="http://schemas.openxmlformats.org/drawingml/2006/main"/>
+          <a:lstStyle xmlns:a="http://schemas.openxmlformats.org/drawingml/2006/main">
+            <a:defPPr>
+              <a:defRPr sz="1350" b="0">
+                <a:solidFill>
+                  <a:srgbClr val="526B79"/>
+                </a:solidFill>
+                <a:latin typeface="Arial"/>
+                <a:ea typeface="Arial"/>
+                <a:cs typeface="Arial"/>
+              </a:defRPr>
+            </a:defPPr>
+          </a:lstStyle>
           <a:p xmlns:a="http://schemas.openxmlformats.org/drawingml/2006/main">
             <a:pPr>
               <a:defRPr sz="1350" b="0">
@@ -3817,7 +5605,7 @@
     </p:spTree>
     <p:extLst>
       <p:ext uri="{BB962C8B-B14F-4D97-AF65-F5344CB8AC3E}">
-        <p14:creationId xmlns:p14="http://schemas.microsoft.com/office/powerpoint/2010/main" val="121795502"/>
+        <p14:creationId xmlns:p14="http://schemas.microsoft.com/office/powerpoint/2010/main" val="1667724693"/>
       </p:ext>
     </p:extLst>
   </p:cSld>
@@ -3848,7 +5636,7 @@
           <p:cNvPr id="7" name="">
             <a:extLst xmlns:a="http://schemas.openxmlformats.org/drawingml/2006/main">
               <a:ext uri="{FF2B5EF4-FFF2-40B4-BE49-F238E27FC236}">
-                <a16:creationId xmlns:a16="http://schemas.microsoft.com/office/drawing/2014/main" id="{EA3800C2-9EDA-4CDF-A966-B82169C5AF81}"/>
+                <a16:creationId xmlns:a16="http://schemas.microsoft.com/office/drawing/2014/main" id="{FB1808EC-2E13-4BA0-982B-1EF43D1995D2}"/>
               </a:ext>
             </a:extLst>
           </p:cNvPr>
@@ -3878,7 +5666,18 @@
           <a:bodyPr xmlns:a="http://schemas.openxmlformats.org/drawingml/2006/main" anchor="t">
             <a:noAutofit/>
           </a:bodyPr>
-          <a:lstStyle xmlns:a="http://schemas.openxmlformats.org/drawingml/2006/main"/>
+          <a:lstStyle xmlns:a="http://schemas.openxmlformats.org/drawingml/2006/main">
+            <a:defPPr>
+              <a:defRPr sz="3150" b="1">
+                <a:solidFill>
+                  <a:srgbClr val="213744"/>
+                </a:solidFill>
+                <a:latin typeface="Arial"/>
+                <a:ea typeface="Arial"/>
+                <a:cs typeface="Arial"/>
+              </a:defRPr>
+            </a:defPPr>
+          </a:lstStyle>
           <a:p xmlns:a="http://schemas.openxmlformats.org/drawingml/2006/main">
             <a:pPr>
               <a:defRPr sz="3150" b="1">
@@ -3909,7 +5708,7 @@
           <p:cNvPr id="2" name="">
             <a:extLst xmlns:a="http://schemas.openxmlformats.org/drawingml/2006/main">
               <a:ext uri="{FF2B5EF4-FFF2-40B4-BE49-F238E27FC236}">
-                <a16:creationId xmlns:a16="http://schemas.microsoft.com/office/drawing/2014/main" id="{52C152B9-35CF-425A-8F33-F9DF47D0F26D}"/>
+                <a16:creationId xmlns:a16="http://schemas.microsoft.com/office/drawing/2014/main" id="{82F66357-1293-4A68-B4F2-FD7E6360F6BC}"/>
               </a:ext>
             </a:extLst>
           </p:cNvPr>
@@ -3939,7 +5738,18 @@
           <a:bodyPr xmlns:a="http://schemas.openxmlformats.org/drawingml/2006/main" anchor="t">
             <a:noAutofit/>
           </a:bodyPr>
-          <a:lstStyle xmlns:a="http://schemas.openxmlformats.org/drawingml/2006/main"/>
+          <a:lstStyle xmlns:a="http://schemas.openxmlformats.org/drawingml/2006/main">
+            <a:defPPr>
+              <a:defRPr sz="2250" b="1">
+                <a:solidFill>
+                  <a:srgbClr val="157C87"/>
+                </a:solidFill>
+                <a:latin typeface="Arial"/>
+                <a:ea typeface="Arial"/>
+                <a:cs typeface="Arial"/>
+              </a:defRPr>
+            </a:defPPr>
+          </a:lstStyle>
           <a:p xmlns:a="http://schemas.openxmlformats.org/drawingml/2006/main">
             <a:pPr>
               <a:defRPr sz="2250" b="1">
@@ -3967,7 +5777,13 @@
       </p:sp>
       <p:graphicFrame>
         <p:nvGraphicFramePr>
-          <p:cNvPr id="9" name="Chart"/>
+          <p:cNvPr id="3" name="Chart">
+            <a:extLst xmlns:a="http://schemas.openxmlformats.org/drawingml/2006/main">
+              <a:ext uri="{FF2B5EF4-FFF2-40B4-BE49-F238E27FC236}">
+                <a16:creationId xmlns:a16="http://schemas.microsoft.com/office/drawing/2014/main" id="{BE6B5CFE-E99A-4E75-B6FB-0361FF4D09F7}"/>
+              </a:ext>
+            </a:extLst>
+          </p:cNvPr>
           <p:cNvGraphicFramePr/>
           <p:nvPr/>
         </p:nvGraphicFramePr>
@@ -3977,7 +5793,7 @@
         </p:xfrm>
         <a:graphic xmlns:a="http://schemas.openxmlformats.org/drawingml/2006/main">
           <a:graphicData uri="http://schemas.openxmlformats.org/drawingml/2006/chart">
-            <c:chart xmlns:r="http://schemas.openxmlformats.org/officeDocument/2006/relationships" xmlns:c="http://schemas.openxmlformats.org/drawingml/2006/chart" r:id="Rf9b45f0bca1849bf"/>
+            <c:chart xmlns:r="http://schemas.openxmlformats.org/officeDocument/2006/relationships" xmlns:c="http://schemas.openxmlformats.org/drawingml/2006/chart" r:id="Rd814ae8aeb1741e1"/>
           </a:graphicData>
         </a:graphic>
       </p:graphicFrame>
@@ -3986,7 +5802,7 @@
           <p:cNvPr id="4" name="">
             <a:extLst xmlns:a="http://schemas.openxmlformats.org/drawingml/2006/main">
               <a:ext uri="{FF2B5EF4-FFF2-40B4-BE49-F238E27FC236}">
-                <a16:creationId xmlns:a16="http://schemas.microsoft.com/office/drawing/2014/main" id="{330E83A2-59BB-4DD1-A549-C6716F596392}"/>
+                <a16:creationId xmlns:a16="http://schemas.microsoft.com/office/drawing/2014/main" id="{9F003387-EB0F-4CDB-942B-B63147D5DB6F}"/>
               </a:ext>
             </a:extLst>
           </p:cNvPr>
@@ -4016,7 +5832,18 @@
           <a:bodyPr xmlns:a="http://schemas.openxmlformats.org/drawingml/2006/main" anchor="t">
             <a:noAutofit/>
           </a:bodyPr>
-          <a:lstStyle xmlns:a="http://schemas.openxmlformats.org/drawingml/2006/main"/>
+          <a:lstStyle xmlns:a="http://schemas.openxmlformats.org/drawingml/2006/main">
+            <a:defPPr>
+              <a:defRPr sz="2250" b="1">
+                <a:solidFill>
+                  <a:srgbClr val="213744"/>
+                </a:solidFill>
+                <a:latin typeface="Arial"/>
+                <a:ea typeface="Arial"/>
+                <a:cs typeface="Arial"/>
+              </a:defRPr>
+            </a:defPPr>
+          </a:lstStyle>
           <a:p xmlns:a="http://schemas.openxmlformats.org/drawingml/2006/main">
             <a:pPr>
               <a:defRPr sz="2250" b="1">
@@ -4047,7 +5874,7 @@
           <p:cNvPr id="5" name="">
             <a:extLst xmlns:a="http://schemas.openxmlformats.org/drawingml/2006/main">
               <a:ext uri="{FF2B5EF4-FFF2-40B4-BE49-F238E27FC236}">
-                <a16:creationId xmlns:a16="http://schemas.microsoft.com/office/drawing/2014/main" id="{8546DB51-5BD9-44E2-B0CD-7EB5E514F1D9}"/>
+                <a16:creationId xmlns:a16="http://schemas.microsoft.com/office/drawing/2014/main" id="{742EE51F-07A0-49BE-9295-FBE6043852B4}"/>
               </a:ext>
             </a:extLst>
           </p:cNvPr>
@@ -4077,7 +5904,18 @@
           <a:bodyPr xmlns:a="http://schemas.openxmlformats.org/drawingml/2006/main" anchor="t">
             <a:noAutofit/>
           </a:bodyPr>
-          <a:lstStyle xmlns:a="http://schemas.openxmlformats.org/drawingml/2006/main"/>
+          <a:lstStyle xmlns:a="http://schemas.openxmlformats.org/drawingml/2006/main">
+            <a:defPPr>
+              <a:defRPr sz="2025" b="0">
+                <a:solidFill>
+                  <a:srgbClr val="213744"/>
+                </a:solidFill>
+                <a:latin typeface="Arial"/>
+                <a:ea typeface="Arial"/>
+                <a:cs typeface="Arial"/>
+              </a:defRPr>
+            </a:defPPr>
+          </a:lstStyle>
           <a:p xmlns:a="http://schemas.openxmlformats.org/drawingml/2006/main">
             <a:pPr>
               <a:defRPr sz="2025" b="0">
@@ -4108,7 +5946,7 @@
           <p:cNvPr id="6" name="">
             <a:extLst xmlns:a="http://schemas.openxmlformats.org/drawingml/2006/main">
               <a:ext uri="{FF2B5EF4-FFF2-40B4-BE49-F238E27FC236}">
-                <a16:creationId xmlns:a16="http://schemas.microsoft.com/office/drawing/2014/main" id="{140D5B93-DD20-4A49-AF59-955679803EFE}"/>
+                <a16:creationId xmlns:a16="http://schemas.microsoft.com/office/drawing/2014/main" id="{4FC0A719-5B98-47F6-801F-4507E801A28A}"/>
               </a:ext>
             </a:extLst>
           </p:cNvPr>
@@ -4138,7 +5976,18 @@
           <a:bodyPr xmlns:a="http://schemas.openxmlformats.org/drawingml/2006/main" anchor="t">
             <a:noAutofit/>
           </a:bodyPr>
-          <a:lstStyle xmlns:a="http://schemas.openxmlformats.org/drawingml/2006/main"/>
+          <a:lstStyle xmlns:a="http://schemas.openxmlformats.org/drawingml/2006/main">
+            <a:defPPr>
+              <a:defRPr sz="1800" b="0">
+                <a:solidFill>
+                  <a:srgbClr val="526B79"/>
+                </a:solidFill>
+                <a:latin typeface="Arial"/>
+                <a:ea typeface="Arial"/>
+                <a:cs typeface="Arial"/>
+              </a:defRPr>
+            </a:defPPr>
+          </a:lstStyle>
           <a:p xmlns:a="http://schemas.openxmlformats.org/drawingml/2006/main">
             <a:pPr>
               <a:defRPr sz="1800" b="0">
@@ -4167,7 +6016,7 @@
     </p:spTree>
     <p:extLst>
       <p:ext uri="{BB962C8B-B14F-4D97-AF65-F5344CB8AC3E}">
-        <p14:creationId xmlns:p14="http://schemas.microsoft.com/office/powerpoint/2010/main" val="1282733613"/>
+        <p14:creationId xmlns:p14="http://schemas.microsoft.com/office/powerpoint/2010/main" val="607872323"/>
       </p:ext>
     </p:extLst>
   </p:cSld>
@@ -4198,7 +6047,7 @@
           <p:cNvPr id="4" name="">
             <a:extLst xmlns:a="http://schemas.openxmlformats.org/drawingml/2006/main">
               <a:ext uri="{FF2B5EF4-FFF2-40B4-BE49-F238E27FC236}">
-                <a16:creationId xmlns:a16="http://schemas.microsoft.com/office/drawing/2014/main" id="{C6CACD5C-69DB-4C1C-843D-FC242C30A41C}"/>
+                <a16:creationId xmlns:a16="http://schemas.microsoft.com/office/drawing/2014/main" id="{2DBDE8B4-401F-4681-86EA-B0AAEF9035E2}"/>
               </a:ext>
             </a:extLst>
           </p:cNvPr>
@@ -4228,7 +6077,18 @@
           <a:bodyPr xmlns:a="http://schemas.openxmlformats.org/drawingml/2006/main" anchor="t">
             <a:noAutofit/>
           </a:bodyPr>
-          <a:lstStyle xmlns:a="http://schemas.openxmlformats.org/drawingml/2006/main"/>
+          <a:lstStyle xmlns:a="http://schemas.openxmlformats.org/drawingml/2006/main">
+            <a:defPPr>
+              <a:defRPr sz="3150" b="1">
+                <a:solidFill>
+                  <a:srgbClr val="213744"/>
+                </a:solidFill>
+                <a:latin typeface="Arial"/>
+                <a:ea typeface="Arial"/>
+                <a:cs typeface="Arial"/>
+              </a:defRPr>
+            </a:defPPr>
+          </a:lstStyle>
           <a:p xmlns:a="http://schemas.openxmlformats.org/drawingml/2006/main">
             <a:pPr>
               <a:defRPr sz="3150" b="1">
@@ -4256,7 +6116,13 @@
       </p:sp>
       <p:graphicFrame>
         <p:nvGraphicFramePr>
-          <p:cNvPr id="5" name=""/>
+          <p:cNvPr id="2" name="">
+            <a:extLst xmlns:a="http://schemas.openxmlformats.org/drawingml/2006/main">
+              <a:ext uri="{FF2B5EF4-FFF2-40B4-BE49-F238E27FC236}">
+                <a16:creationId xmlns:a16="http://schemas.microsoft.com/office/drawing/2014/main" id="{A0A6F905-2E35-4455-88D9-F3D667A020C3}"/>
+              </a:ext>
+            </a:extLst>
+          </p:cNvPr>
           <p:cNvGraphicFramePr/>
           <p:nvPr/>
         </p:nvGraphicFramePr>
@@ -4605,7 +6471,7 @@
           <p:cNvPr id="3" name="">
             <a:extLst xmlns:a="http://schemas.openxmlformats.org/drawingml/2006/main">
               <a:ext uri="{FF2B5EF4-FFF2-40B4-BE49-F238E27FC236}">
-                <a16:creationId xmlns:a16="http://schemas.microsoft.com/office/drawing/2014/main" id="{F33E548E-9C7B-4B7C-A013-CC3D7A758F76}"/>
+                <a16:creationId xmlns:a16="http://schemas.microsoft.com/office/drawing/2014/main" id="{B5918D31-1BFA-42CB-8361-4E5A1C15CE99}"/>
               </a:ext>
             </a:extLst>
           </p:cNvPr>
@@ -4635,7 +6501,18 @@
           <a:bodyPr xmlns:a="http://schemas.openxmlformats.org/drawingml/2006/main" anchor="t">
             <a:noAutofit/>
           </a:bodyPr>
-          <a:lstStyle xmlns:a="http://schemas.openxmlformats.org/drawingml/2006/main"/>
+          <a:lstStyle xmlns:a="http://schemas.openxmlformats.org/drawingml/2006/main">
+            <a:defPPr>
+              <a:defRPr sz="1950" b="0">
+                <a:solidFill>
+                  <a:srgbClr val="A25D20"/>
+                </a:solidFill>
+                <a:latin typeface="Arial"/>
+                <a:ea typeface="Arial"/>
+                <a:cs typeface="Arial"/>
+              </a:defRPr>
+            </a:defPPr>
+          </a:lstStyle>
           <a:p xmlns:a="http://schemas.openxmlformats.org/drawingml/2006/main">
             <a:pPr>
               <a:defRPr sz="1950" b="0">
@@ -4664,7 +6541,7 @@
     </p:spTree>
     <p:extLst>
       <p:ext uri="{BB962C8B-B14F-4D97-AF65-F5344CB8AC3E}">
-        <p14:creationId xmlns:p14="http://schemas.microsoft.com/office/powerpoint/2010/main" val="553023959"/>
+        <p14:creationId xmlns:p14="http://schemas.microsoft.com/office/powerpoint/2010/main" val="74984838"/>
       </p:ext>
     </p:extLst>
   </p:cSld>
@@ -4695,7 +6572,7 @@
           <p:cNvPr id="4" name="">
             <a:extLst xmlns:a="http://schemas.openxmlformats.org/drawingml/2006/main">
               <a:ext uri="{FF2B5EF4-FFF2-40B4-BE49-F238E27FC236}">
-                <a16:creationId xmlns:a16="http://schemas.microsoft.com/office/drawing/2014/main" id="{D9E6A118-D71B-4CE3-8E65-06471975CB2D}"/>
+                <a16:creationId xmlns:a16="http://schemas.microsoft.com/office/drawing/2014/main" id="{56924FCE-E771-4274-9C8A-8F437FFA3A46}"/>
               </a:ext>
             </a:extLst>
           </p:cNvPr>
@@ -4725,7 +6602,18 @@
           <a:bodyPr xmlns:a="http://schemas.openxmlformats.org/drawingml/2006/main" anchor="t">
             <a:noAutofit/>
           </a:bodyPr>
-          <a:lstStyle xmlns:a="http://schemas.openxmlformats.org/drawingml/2006/main"/>
+          <a:lstStyle xmlns:a="http://schemas.openxmlformats.org/drawingml/2006/main">
+            <a:defPPr>
+              <a:defRPr sz="3150" b="1">
+                <a:solidFill>
+                  <a:srgbClr val="213744"/>
+                </a:solidFill>
+                <a:latin typeface="Arial"/>
+                <a:ea typeface="Arial"/>
+                <a:cs typeface="Arial"/>
+              </a:defRPr>
+            </a:defPPr>
+          </a:lstStyle>
           <a:p xmlns:a="http://schemas.openxmlformats.org/drawingml/2006/main">
             <a:pPr>
               <a:defRPr sz="3150" b="1">
@@ -4753,7 +6641,13 @@
       </p:sp>
       <p:graphicFrame>
         <p:nvGraphicFramePr>
-          <p:cNvPr id="5" name=""/>
+          <p:cNvPr id="2" name="">
+            <a:extLst xmlns:a="http://schemas.openxmlformats.org/drawingml/2006/main">
+              <a:ext uri="{FF2B5EF4-FFF2-40B4-BE49-F238E27FC236}">
+                <a16:creationId xmlns:a16="http://schemas.microsoft.com/office/drawing/2014/main" id="{C8D4C97B-0688-47D3-9A28-EF2529166536}"/>
+              </a:ext>
+            </a:extLst>
+          </p:cNvPr>
           <p:cNvGraphicFramePr/>
           <p:nvPr/>
         </p:nvGraphicFramePr>
@@ -5102,7 +6996,7 @@
           <p:cNvPr id="3" name="">
             <a:extLst xmlns:a="http://schemas.openxmlformats.org/drawingml/2006/main">
               <a:ext uri="{FF2B5EF4-FFF2-40B4-BE49-F238E27FC236}">
-                <a16:creationId xmlns:a16="http://schemas.microsoft.com/office/drawing/2014/main" id="{E645BA15-B343-4965-9F47-7C08DCE5E54F}"/>
+                <a16:creationId xmlns:a16="http://schemas.microsoft.com/office/drawing/2014/main" id="{5E1EB3FB-1996-43D8-9924-A0DD436F2AAB}"/>
               </a:ext>
             </a:extLst>
           </p:cNvPr>
@@ -5132,7 +7026,18 @@
           <a:bodyPr xmlns:a="http://schemas.openxmlformats.org/drawingml/2006/main" anchor="t">
             <a:noAutofit/>
           </a:bodyPr>
-          <a:lstStyle xmlns:a="http://schemas.openxmlformats.org/drawingml/2006/main"/>
+          <a:lstStyle xmlns:a="http://schemas.openxmlformats.org/drawingml/2006/main">
+            <a:defPPr>
+              <a:defRPr sz="1950" b="0">
+                <a:solidFill>
+                  <a:srgbClr val="A25D20"/>
+                </a:solidFill>
+                <a:latin typeface="Arial"/>
+                <a:ea typeface="Arial"/>
+                <a:cs typeface="Arial"/>
+              </a:defRPr>
+            </a:defPPr>
+          </a:lstStyle>
           <a:p xmlns:a="http://schemas.openxmlformats.org/drawingml/2006/main">
             <a:pPr>
               <a:defRPr sz="1950" b="0">
@@ -5161,7 +7066,7 @@
     </p:spTree>
     <p:extLst>
       <p:ext uri="{BB962C8B-B14F-4D97-AF65-F5344CB8AC3E}">
-        <p14:creationId xmlns:p14="http://schemas.microsoft.com/office/powerpoint/2010/main" val="1333930309"/>
+        <p14:creationId xmlns:p14="http://schemas.microsoft.com/office/powerpoint/2010/main" val="1024770362"/>
       </p:ext>
     </p:extLst>
   </p:cSld>
@@ -5192,7 +7097,7 @@
           <p:cNvPr id="4" name="">
             <a:extLst xmlns:a="http://schemas.openxmlformats.org/drawingml/2006/main">
               <a:ext uri="{FF2B5EF4-FFF2-40B4-BE49-F238E27FC236}">
-                <a16:creationId xmlns:a16="http://schemas.microsoft.com/office/drawing/2014/main" id="{1FF94C11-2C5B-4AD9-820D-53930A4EBE64}"/>
+                <a16:creationId xmlns:a16="http://schemas.microsoft.com/office/drawing/2014/main" id="{74A59391-F3FC-44F9-87DD-9DD6A1A40D74}"/>
               </a:ext>
             </a:extLst>
           </p:cNvPr>
@@ -5222,7 +7127,18 @@
           <a:bodyPr xmlns:a="http://schemas.openxmlformats.org/drawingml/2006/main" anchor="t">
             <a:noAutofit/>
           </a:bodyPr>
-          <a:lstStyle xmlns:a="http://schemas.openxmlformats.org/drawingml/2006/main"/>
+          <a:lstStyle xmlns:a="http://schemas.openxmlformats.org/drawingml/2006/main">
+            <a:defPPr>
+              <a:defRPr sz="3150" b="1">
+                <a:solidFill>
+                  <a:srgbClr val="213744"/>
+                </a:solidFill>
+                <a:latin typeface="Arial"/>
+                <a:ea typeface="Arial"/>
+                <a:cs typeface="Arial"/>
+              </a:defRPr>
+            </a:defPPr>
+          </a:lstStyle>
           <a:p xmlns:a="http://schemas.openxmlformats.org/drawingml/2006/main">
             <a:pPr>
               <a:defRPr sz="3150" b="1">
@@ -5250,7 +7166,13 @@
       </p:sp>
       <p:graphicFrame>
         <p:nvGraphicFramePr>
-          <p:cNvPr id="5" name=""/>
+          <p:cNvPr id="2" name="">
+            <a:extLst xmlns:a="http://schemas.openxmlformats.org/drawingml/2006/main">
+              <a:ext uri="{FF2B5EF4-FFF2-40B4-BE49-F238E27FC236}">
+                <a16:creationId xmlns:a16="http://schemas.microsoft.com/office/drawing/2014/main" id="{6658C26E-BB19-41F0-80C1-917DCDB7B0BE}"/>
+              </a:ext>
+            </a:extLst>
+          </p:cNvPr>
           <p:cNvGraphicFramePr/>
           <p:nvPr/>
         </p:nvGraphicFramePr>
@@ -5579,7 +7501,7 @@
                           <a:ea typeface="Arial"/>
                           <a:cs typeface="Arial"/>
                         </a:rPr>
-                        <a:t>Original inputs and 40 executed source-file hashes remain unchanged. The immutable receipt identifies the executed content.</a:t>
+                        <a:t>Original inputs and all frozen execution files remained unchanged during this run. The immutable receipt identifies the exact executed content.</a:t>
                       </a:r>
                     </a:p>
                   </a:txBody>
@@ -5653,7 +7575,7 @@
           <p:cNvPr id="3" name="">
             <a:extLst xmlns:a="http://schemas.openxmlformats.org/drawingml/2006/main">
               <a:ext uri="{FF2B5EF4-FFF2-40B4-BE49-F238E27FC236}">
-                <a16:creationId xmlns:a16="http://schemas.microsoft.com/office/drawing/2014/main" id="{A9714003-9C38-468B-9DC0-AE8839511D4B}"/>
+                <a16:creationId xmlns:a16="http://schemas.microsoft.com/office/drawing/2014/main" id="{0C805AAC-28C6-492F-84CF-DBB3B771503D}"/>
               </a:ext>
             </a:extLst>
           </p:cNvPr>
@@ -5683,7 +7605,18 @@
           <a:bodyPr xmlns:a="http://schemas.openxmlformats.org/drawingml/2006/main" anchor="t">
             <a:noAutofit/>
           </a:bodyPr>
-          <a:lstStyle xmlns:a="http://schemas.openxmlformats.org/drawingml/2006/main"/>
+          <a:lstStyle xmlns:a="http://schemas.openxmlformats.org/drawingml/2006/main">
+            <a:defPPr>
+              <a:defRPr sz="1875" b="0">
+                <a:solidFill>
+                  <a:srgbClr val="526B79"/>
+                </a:solidFill>
+                <a:latin typeface="Arial"/>
+                <a:ea typeface="Arial"/>
+                <a:cs typeface="Arial"/>
+              </a:defRPr>
+            </a:defPPr>
+          </a:lstStyle>
           <a:p xmlns:a="http://schemas.openxmlformats.org/drawingml/2006/main">
             <a:pPr>
               <a:defRPr sz="1875" b="0">
@@ -5712,7 +7645,7 @@
     </p:spTree>
     <p:extLst>
       <p:ext uri="{BB962C8B-B14F-4D97-AF65-F5344CB8AC3E}">
-        <p14:creationId xmlns:p14="http://schemas.microsoft.com/office/powerpoint/2010/main" val="2045297964"/>
+        <p14:creationId xmlns:p14="http://schemas.microsoft.com/office/powerpoint/2010/main" val="115224191"/>
       </p:ext>
     </p:extLst>
   </p:cSld>
@@ -5743,7 +7676,7 @@
           <p:cNvPr id="5" name="">
             <a:extLst xmlns:a="http://schemas.openxmlformats.org/drawingml/2006/main">
               <a:ext uri="{FF2B5EF4-FFF2-40B4-BE49-F238E27FC236}">
-                <a16:creationId xmlns:a16="http://schemas.microsoft.com/office/drawing/2014/main" id="{39199EB5-27C0-4B6E-9A1B-AB8064662C93}"/>
+                <a16:creationId xmlns:a16="http://schemas.microsoft.com/office/drawing/2014/main" id="{51D3FA83-3CF0-4D29-80A1-A92E66F44436}"/>
               </a:ext>
             </a:extLst>
           </p:cNvPr>
@@ -5773,7 +7706,18 @@
           <a:bodyPr xmlns:a="http://schemas.openxmlformats.org/drawingml/2006/main" anchor="t">
             <a:noAutofit/>
           </a:bodyPr>
-          <a:lstStyle xmlns:a="http://schemas.openxmlformats.org/drawingml/2006/main"/>
+          <a:lstStyle xmlns:a="http://schemas.openxmlformats.org/drawingml/2006/main">
+            <a:defPPr>
+              <a:defRPr sz="3150" b="1">
+                <a:solidFill>
+                  <a:srgbClr val="213744"/>
+                </a:solidFill>
+                <a:latin typeface="Arial"/>
+                <a:ea typeface="Arial"/>
+                <a:cs typeface="Arial"/>
+              </a:defRPr>
+            </a:defPPr>
+          </a:lstStyle>
           <a:p xmlns:a="http://schemas.openxmlformats.org/drawingml/2006/main">
             <a:pPr>
               <a:defRPr sz="3150" b="1">
@@ -5804,7 +7748,7 @@
           <p:cNvPr id="2" name="">
             <a:extLst xmlns:a="http://schemas.openxmlformats.org/drawingml/2006/main">
               <a:ext uri="{FF2B5EF4-FFF2-40B4-BE49-F238E27FC236}">
-                <a16:creationId xmlns:a16="http://schemas.microsoft.com/office/drawing/2014/main" id="{A1EE7CC0-0196-4325-A82D-427C94BE25A1}"/>
+                <a16:creationId xmlns:a16="http://schemas.microsoft.com/office/drawing/2014/main" id="{47D4F09B-0FC0-4AEF-BCFF-648BA4FDC251}"/>
               </a:ext>
             </a:extLst>
           </p:cNvPr>
@@ -5834,7 +7778,18 @@
           <a:bodyPr xmlns:a="http://schemas.openxmlformats.org/drawingml/2006/main" anchor="t">
             <a:noAutofit/>
           </a:bodyPr>
-          <a:lstStyle xmlns:a="http://schemas.openxmlformats.org/drawingml/2006/main"/>
+          <a:lstStyle xmlns:a="http://schemas.openxmlformats.org/drawingml/2006/main">
+            <a:defPPr>
+              <a:defRPr sz="2325" b="0">
+                <a:solidFill>
+                  <a:srgbClr val="213744"/>
+                </a:solidFill>
+                <a:latin typeface="Arial"/>
+                <a:ea typeface="Arial"/>
+                <a:cs typeface="Arial"/>
+              </a:defRPr>
+            </a:defPPr>
+          </a:lstStyle>
           <a:p xmlns:a="http://schemas.openxmlformats.org/drawingml/2006/main">
             <a:pPr>
               <a:defRPr sz="2325" b="0">
@@ -5862,7 +7817,13 @@
       </p:sp>
       <p:graphicFrame>
         <p:nvGraphicFramePr>
-          <p:cNvPr id="7" name=""/>
+          <p:cNvPr id="3" name="">
+            <a:extLst xmlns:a="http://schemas.openxmlformats.org/drawingml/2006/main">
+              <a:ext uri="{FF2B5EF4-FFF2-40B4-BE49-F238E27FC236}">
+                <a16:creationId xmlns:a16="http://schemas.microsoft.com/office/drawing/2014/main" id="{5CF45E00-BF87-475F-B612-865502752FD2}"/>
+              </a:ext>
+            </a:extLst>
+          </p:cNvPr>
           <p:cNvGraphicFramePr/>
           <p:nvPr/>
         </p:nvGraphicFramePr>
@@ -6157,7 +8118,7 @@
           <p:cNvPr id="4" name="">
             <a:extLst xmlns:a="http://schemas.openxmlformats.org/drawingml/2006/main">
               <a:ext uri="{FF2B5EF4-FFF2-40B4-BE49-F238E27FC236}">
-                <a16:creationId xmlns:a16="http://schemas.microsoft.com/office/drawing/2014/main" id="{73D176F9-FF4E-4005-9001-608D76CF5949}"/>
+                <a16:creationId xmlns:a16="http://schemas.microsoft.com/office/drawing/2014/main" id="{AC9A4B84-0A44-491B-8109-BFFA354A6E4E}"/>
               </a:ext>
             </a:extLst>
           </p:cNvPr>
@@ -6187,7 +8148,18 @@
           <a:bodyPr xmlns:a="http://schemas.openxmlformats.org/drawingml/2006/main" anchor="t">
             <a:noAutofit/>
           </a:bodyPr>
-          <a:lstStyle xmlns:a="http://schemas.openxmlformats.org/drawingml/2006/main"/>
+          <a:lstStyle xmlns:a="http://schemas.openxmlformats.org/drawingml/2006/main">
+            <a:defPPr>
+              <a:defRPr sz="2025" b="0">
+                <a:solidFill>
+                  <a:srgbClr val="157C87"/>
+                </a:solidFill>
+                <a:latin typeface="Arial"/>
+                <a:ea typeface="Arial"/>
+                <a:cs typeface="Arial"/>
+              </a:defRPr>
+            </a:defPPr>
+          </a:lstStyle>
           <a:p xmlns:a="http://schemas.openxmlformats.org/drawingml/2006/main">
             <a:pPr>
               <a:defRPr sz="2025" b="0">
@@ -6216,7 +8188,7 @@
     </p:spTree>
     <p:extLst>
       <p:ext uri="{BB962C8B-B14F-4D97-AF65-F5344CB8AC3E}">
-        <p14:creationId xmlns:p14="http://schemas.microsoft.com/office/powerpoint/2010/main" val="1702470801"/>
+        <p14:creationId xmlns:p14="http://schemas.microsoft.com/office/powerpoint/2010/main" val="1186204746"/>
       </p:ext>
     </p:extLst>
   </p:cSld>
@@ -6247,7 +8219,7 @@
           <ns0:cNvPr id="9" name="">
             <ns1:extLst>
               <ns1:ext uri="{FF2B5EF4-FFF2-40B4-BE49-F238E27FC236}">
-                <ns2:creationId id="{1F0BDE01-7AF1-4660-85A6-40F7ED3F9B45}"/>
+                <ns2:creationId id="{A8997B19-FBF6-432E-9D97-F01C839DB4EB}"/>
               </ns1:ext>
             </ns1:extLst>
           </ns0:cNvPr>
@@ -6277,7 +8249,18 @@
           <ns1:bodyPr anchor="t">
             <ns1:noAutofit/>
           </ns1:bodyPr>
-          <ns1:lstStyle/>
+          <ns1:lstStyle>
+            <ns1:defPPr>
+              <ns1:defRPr sz="3150" b="1">
+                <ns1:solidFill>
+                  <ns1:srgbClr val="213744"/>
+                </ns1:solidFill>
+                <ns1:latin typeface="Arial"/>
+                <ns1:ea typeface="Arial"/>
+                <ns1:cs typeface="Arial"/>
+              </ns1:defRPr>
+            </ns1:defPPr>
+          </ns1:lstStyle>
           <ns1:p>
             <ns1:pPr>
               <ns1:defRPr sz="3150" b="1">
@@ -6308,7 +8291,7 @@
           <ns0:cNvPr id="2" name="">
             <ns1:extLst>
               <ns1:ext uri="{FF2B5EF4-FFF2-40B4-BE49-F238E27FC236}">
-                <ns2:creationId id="{A1A630AD-CBCB-4482-8963-EBEF2595E6EA}"/>
+                <ns2:creationId id="{A0046876-670D-44A8-BB36-C1818ACA27BE}"/>
               </ns1:ext>
             </ns1:extLst>
           </ns0:cNvPr>
@@ -6338,7 +8321,18 @@
           <ns1:bodyPr anchor="t">
             <ns1:noAutofit/>
           </ns1:bodyPr>
-          <ns1:lstStyle/>
+          <ns1:lstStyle>
+            <ns1:defPPr>
+              <ns1:defRPr sz="2325" b="1">
+                <ns1:solidFill>
+                  <ns1:srgbClr val="157C87"/>
+                </ns1:solidFill>
+                <ns1:latin typeface="Arial"/>
+                <ns1:ea typeface="Arial"/>
+                <ns1:cs typeface="Arial"/>
+              </ns1:defRPr>
+            </ns1:defPPr>
+          </ns1:lstStyle>
           <ns1:p>
             <ns1:pPr>
               <ns1:defRPr sz="2325" b="1">
@@ -6366,18 +8360,22 @@
       </ns0:sp>
       <ns0:pic>
         <ns0:nvPicPr>
-          <ns0:cNvPr id="11" name=""/>
+          <ns0:cNvPr id="3" name="">
+            <ns1:extLst>
+              <ns1:ext uri="{FF2B5EF4-FFF2-40B4-BE49-F238E27FC236}">
+                <ns2:creationId id="{AE6A5364-26FC-4894-B9BA-E8C98454E129}"/>
+              </ns1:ext>
+            </ns1:extLst>
+          </ns0:cNvPr>
           <ns0:cNvPicPr>
             <ns1:picLocks noChangeAspect="1"/>
           </ns0:cNvPicPr>
           <ns0:nvPr/>
         </ns0:nvPicPr>
         <ns0:blipFill>
-          <ns1:blip ns3:embed="R0a86b55bcb1d4937"/>
+          <ns1:blip ns3:embed="Rfd4a5a114129447e"/>
           <ns1:srcRect l="0" t="8974" r="0" b="33333"/>
-          <ns1:stretch>
-            <ns1:fillRect l="0" t="0" r="0" b="0"/>
-          </ns1:stretch>
+          <ns1:stretch/>
         </ns0:blipFill>
         <ns0:spPr>
           <ns1:xfrm>
@@ -6394,7 +8392,7 @@
           <ns0:cNvPr id="4" name="">
             <ns1:extLst>
               <ns1:ext uri="{FF2B5EF4-FFF2-40B4-BE49-F238E27FC236}">
-                <ns2:creationId id="{5E48D08A-A045-4D3A-9BAC-4B9A46661E0F}"/>
+                <ns2:creationId id="{793B4E92-1261-4548-9CFD-6623CC26C48C}"/>
               </ns1:ext>
             </ns1:extLst>
           </ns0:cNvPr>
@@ -6424,7 +8422,18 @@
           <ns1:bodyPr anchor="t">
             <ns1:noAutofit/>
           </ns1:bodyPr>
-          <ns1:lstStyle/>
+          <ns1:lstStyle>
+            <ns1:defPPr>
+              <ns1:defRPr sz="1650" b="1">
+                <ns1:solidFill>
+                  <ns1:srgbClr val="157C87"/>
+                </ns1:solidFill>
+                <ns1:latin typeface="Arial"/>
+                <ns1:ea typeface="Arial"/>
+                <ns1:cs typeface="Arial"/>
+              </ns1:defRPr>
+            </ns1:defPPr>
+          </ns1:lstStyle>
           <ns1:p>
             <ns1:pPr>
               <ns1:defRPr sz="1650" b="1">
@@ -6455,7 +8464,7 @@
           <ns0:cNvPr id="5" name="">
             <ns1:extLst>
               <ns1:ext uri="{FF2B5EF4-FFF2-40B4-BE49-F238E27FC236}">
-                <ns2:creationId id="{C5C3DED6-1B0B-45EB-93DF-5C1CFAE423A7}"/>
+                <ns2:creationId id="{B89751A4-573F-47A5-87F4-C1863A5E5A88}"/>
               </ns1:ext>
             </ns1:extLst>
           </ns0:cNvPr>
@@ -6485,7 +8494,18 @@
           <ns1:bodyPr anchor="t">
             <ns1:noAutofit/>
           </ns1:bodyPr>
-          <ns1:lstStyle/>
+          <ns1:lstStyle>
+            <ns1:defPPr>
+              <ns1:defRPr sz="1800" b="0">
+                <ns1:solidFill>
+                  <ns1:srgbClr val="213744"/>
+                </ns1:solidFill>
+                <ns1:latin typeface="Arial"/>
+                <ns1:ea typeface="Arial"/>
+                <ns1:cs typeface="Arial"/>
+              </ns1:defRPr>
+            </ns1:defPPr>
+          </ns1:lstStyle>
           <ns1:p>
             <ns1:pPr>
               <ns1:defRPr sz="1800" b="0">
@@ -6516,7 +8536,7 @@
           <ns0:cNvPr id="6" name="">
             <ns1:extLst>
               <ns1:ext uri="{FF2B5EF4-FFF2-40B4-BE49-F238E27FC236}">
-                <ns2:creationId id="{BECA3207-1A8E-4156-A0BA-786419882077}"/>
+                <ns2:creationId id="{691ADE80-F196-470B-B53E-A5698918D270}"/>
               </ns1:ext>
             </ns1:extLst>
           </ns0:cNvPr>
@@ -6546,7 +8566,18 @@
           <ns1:bodyPr anchor="t">
             <ns1:noAutofit/>
           </ns1:bodyPr>
-          <ns1:lstStyle/>
+          <ns1:lstStyle>
+            <ns1:defPPr>
+              <ns1:defRPr sz="1650" b="1">
+                <ns1:solidFill>
+                  <ns1:srgbClr val="157C87"/>
+                </ns1:solidFill>
+                <ns1:latin typeface="Arial"/>
+                <ns1:ea typeface="Arial"/>
+                <ns1:cs typeface="Arial"/>
+              </ns1:defRPr>
+            </ns1:defPPr>
+          </ns1:lstStyle>
           <ns1:p>
             <ns1:pPr>
               <ns1:defRPr sz="1650" b="1">
@@ -6577,7 +8608,7 @@
           <ns0:cNvPr id="7" name="">
             <ns1:extLst>
               <ns1:ext uri="{FF2B5EF4-FFF2-40B4-BE49-F238E27FC236}">
-                <ns2:creationId id="{09510A33-8CFE-40FC-88C7-EA923125CAFE}"/>
+                <ns2:creationId id="{88C1F53E-E920-409D-A9F0-FC162DDCA51F}"/>
               </ns1:ext>
             </ns1:extLst>
           </ns0:cNvPr>
@@ -6607,7 +8638,18 @@
           <ns1:bodyPr anchor="t">
             <ns1:noAutofit/>
           </ns1:bodyPr>
-          <ns1:lstStyle/>
+          <ns1:lstStyle>
+            <ns1:defPPr>
+              <ns1:defRPr sz="1800" b="0">
+                <ns1:solidFill>
+                  <ns1:srgbClr val="213744"/>
+                </ns1:solidFill>
+                <ns1:latin typeface="Arial"/>
+                <ns1:ea typeface="Arial"/>
+                <ns1:cs typeface="Arial"/>
+              </ns1:defRPr>
+            </ns1:defPPr>
+          </ns1:lstStyle>
           <ns1:p>
             <ns1:pPr>
               <ns1:defRPr sz="1800" b="0">
@@ -6638,7 +8680,7 @@
           <ns0:cNvPr id="8" name="">
             <ns1:extLst>
               <ns1:ext uri="{FF2B5EF4-FFF2-40B4-BE49-F238E27FC236}">
-                <ns2:creationId id="{77721CDB-FDDF-4B8C-A959-C946CE78599A}"/>
+                <ns2:creationId id="{F036CAFA-53D5-4192-8777-444138BA875A}"/>
               </ns1:ext>
             </ns1:extLst>
           </ns0:cNvPr>
@@ -6668,7 +8710,18 @@
           <ns1:bodyPr anchor="t">
             <ns1:noAutofit/>
           </ns1:bodyPr>
-          <ns1:lstStyle/>
+          <ns1:lstStyle>
+            <ns1:defPPr>
+              <ns1:defRPr sz="1350" b="0">
+                <ns1:solidFill>
+                  <ns1:srgbClr val="526B79"/>
+                </ns1:solidFill>
+                <ns1:latin typeface="Arial"/>
+                <ns1:ea typeface="Arial"/>
+                <ns1:cs typeface="Arial"/>
+              </ns1:defRPr>
+            </ns1:defPPr>
+          </ns1:lstStyle>
           <ns1:p>
             <ns1:pPr>
               <ns1:defRPr sz="1350" b="0">
@@ -6697,7 +8750,7 @@
     </ns0:spTree>
     <ns0:extLst>
       <ns0:ext uri="{BB962C8B-B14F-4D97-AF65-F5344CB8AC3E}">
-        <ns4:creationId val="1465094394"/>
+        <ns4:creationId val="342702757"/>
       </ns0:ext>
     </ns0:extLst>
   </ns0:cSld>
@@ -6728,7 +8781,7 @@
           <ns0:cNvPr id="9" name="">
             <ns1:extLst>
               <ns1:ext uri="{FF2B5EF4-FFF2-40B4-BE49-F238E27FC236}">
-                <ns2:creationId id="{1D47866D-759F-41D1-82C8-3A1A98332431}"/>
+                <ns2:creationId id="{660F4F99-9711-46BE-A86F-64F56A35CD52}"/>
               </ns1:ext>
             </ns1:extLst>
           </ns0:cNvPr>
@@ -6758,7 +8811,18 @@
           <ns1:bodyPr anchor="t">
             <ns1:noAutofit/>
           </ns1:bodyPr>
-          <ns1:lstStyle/>
+          <ns1:lstStyle>
+            <ns1:defPPr>
+              <ns1:defRPr sz="3150" b="1">
+                <ns1:solidFill>
+                  <ns1:srgbClr val="213744"/>
+                </ns1:solidFill>
+                <ns1:latin typeface="Arial"/>
+                <ns1:ea typeface="Arial"/>
+                <ns1:cs typeface="Arial"/>
+              </ns1:defRPr>
+            </ns1:defPPr>
+          </ns1:lstStyle>
           <ns1:p>
             <ns1:pPr>
               <ns1:defRPr sz="3150" b="1">
@@ -6789,7 +8853,7 @@
           <ns0:cNvPr id="2" name="">
             <ns1:extLst>
               <ns1:ext uri="{FF2B5EF4-FFF2-40B4-BE49-F238E27FC236}">
-                <ns2:creationId id="{F94DD4E3-18AF-44CA-B060-7E434F9767CA}"/>
+                <ns2:creationId id="{6FEFF846-2D8C-4E48-BAE8-B5619BDCC334}"/>
               </ns1:ext>
             </ns1:extLst>
           </ns0:cNvPr>
@@ -6819,7 +8883,18 @@
           <ns1:bodyPr anchor="t">
             <ns1:noAutofit/>
           </ns1:bodyPr>
-          <ns1:lstStyle/>
+          <ns1:lstStyle>
+            <ns1:defPPr>
+              <ns1:defRPr sz="2325" b="1">
+                <ns1:solidFill>
+                  <ns1:srgbClr val="157C87"/>
+                </ns1:solidFill>
+                <ns1:latin typeface="Arial"/>
+                <ns1:ea typeface="Arial"/>
+                <ns1:cs typeface="Arial"/>
+              </ns1:defRPr>
+            </ns1:defPPr>
+          </ns1:lstStyle>
           <ns1:p>
             <ns1:pPr>
               <ns1:defRPr sz="2325" b="1">
@@ -6847,18 +8922,22 @@
       </ns0:sp>
       <ns0:pic>
         <ns0:nvPicPr>
-          <ns0:cNvPr id="11" name=""/>
+          <ns0:cNvPr id="3" name="">
+            <ns1:extLst>
+              <ns1:ext uri="{FF2B5EF4-FFF2-40B4-BE49-F238E27FC236}">
+                <ns2:creationId id="{427A7AFA-4EE7-4987-B107-12D9E4F62684}"/>
+              </ns1:ext>
+            </ns1:extLst>
+          </ns0:cNvPr>
           <ns0:cNvPicPr>
             <ns1:picLocks noChangeAspect="1"/>
           </ns0:cNvPicPr>
           <ns0:nvPr/>
         </ns0:nvPicPr>
         <ns0:blipFill>
-          <ns1:blip ns3:embed="R89afa665a7ce42a7"/>
+          <ns1:blip ns3:embed="R46ca8c7b4f3c44ef"/>
           <ns1:srcRect l="0" t="8974" r="0" b="33333"/>
-          <ns1:stretch>
-            <ns1:fillRect l="0" t="0" r="0" b="0"/>
-          </ns1:stretch>
+          <ns1:stretch/>
         </ns0:blipFill>
         <ns0:spPr>
           <ns1:xfrm>
@@ -6875,7 +8954,7 @@
           <ns0:cNvPr id="4" name="">
             <ns1:extLst>
               <ns1:ext uri="{FF2B5EF4-FFF2-40B4-BE49-F238E27FC236}">
-                <ns2:creationId id="{45B4C72B-528D-4599-AC97-3E9D1573258F}"/>
+                <ns2:creationId id="{738DA97F-3CF6-42EA-AA2B-270B77F4A3E0}"/>
               </ns1:ext>
             </ns1:extLst>
           </ns0:cNvPr>
@@ -6905,7 +8984,18 @@
           <ns1:bodyPr anchor="t">
             <ns1:noAutofit/>
           </ns1:bodyPr>
-          <ns1:lstStyle/>
+          <ns1:lstStyle>
+            <ns1:defPPr>
+              <ns1:defRPr sz="1650" b="1">
+                <ns1:solidFill>
+                  <ns1:srgbClr val="157C87"/>
+                </ns1:solidFill>
+                <ns1:latin typeface="Arial"/>
+                <ns1:ea typeface="Arial"/>
+                <ns1:cs typeface="Arial"/>
+              </ns1:defRPr>
+            </ns1:defPPr>
+          </ns1:lstStyle>
           <ns1:p>
             <ns1:pPr>
               <ns1:defRPr sz="1650" b="1">
@@ -6936,7 +9026,7 @@
           <ns0:cNvPr id="5" name="">
             <ns1:extLst>
               <ns1:ext uri="{FF2B5EF4-FFF2-40B4-BE49-F238E27FC236}">
-                <ns2:creationId id="{160DD388-3033-44F2-A719-09DCA7E6D876}"/>
+                <ns2:creationId id="{8EC15DC7-B656-4DFA-AB7E-393AB3CC1B96}"/>
               </ns1:ext>
             </ns1:extLst>
           </ns0:cNvPr>
@@ -6966,7 +9056,18 @@
           <ns1:bodyPr anchor="t">
             <ns1:noAutofit/>
           </ns1:bodyPr>
-          <ns1:lstStyle/>
+          <ns1:lstStyle>
+            <ns1:defPPr>
+              <ns1:defRPr sz="1800" b="0">
+                <ns1:solidFill>
+                  <ns1:srgbClr val="213744"/>
+                </ns1:solidFill>
+                <ns1:latin typeface="Arial"/>
+                <ns1:ea typeface="Arial"/>
+                <ns1:cs typeface="Arial"/>
+              </ns1:defRPr>
+            </ns1:defPPr>
+          </ns1:lstStyle>
           <ns1:p>
             <ns1:pPr>
               <ns1:defRPr sz="1800" b="0">
@@ -6997,7 +9098,7 @@
           <ns0:cNvPr id="6" name="">
             <ns1:extLst>
               <ns1:ext uri="{FF2B5EF4-FFF2-40B4-BE49-F238E27FC236}">
-                <ns2:creationId id="{B3D3A38C-2F28-4328-BC82-F5F2BC2FED87}"/>
+                <ns2:creationId id="{D783CBEA-A742-47F5-BC74-1BA013814A04}"/>
               </ns1:ext>
             </ns1:extLst>
           </ns0:cNvPr>
@@ -7027,7 +9128,18 @@
           <ns1:bodyPr anchor="t">
             <ns1:noAutofit/>
           </ns1:bodyPr>
-          <ns1:lstStyle/>
+          <ns1:lstStyle>
+            <ns1:defPPr>
+              <ns1:defRPr sz="1650" b="1">
+                <ns1:solidFill>
+                  <ns1:srgbClr val="157C87"/>
+                </ns1:solidFill>
+                <ns1:latin typeface="Arial"/>
+                <ns1:ea typeface="Arial"/>
+                <ns1:cs typeface="Arial"/>
+              </ns1:defRPr>
+            </ns1:defPPr>
+          </ns1:lstStyle>
           <ns1:p>
             <ns1:pPr>
               <ns1:defRPr sz="1650" b="1">
@@ -7058,7 +9170,7 @@
           <ns0:cNvPr id="7" name="">
             <ns1:extLst>
               <ns1:ext uri="{FF2B5EF4-FFF2-40B4-BE49-F238E27FC236}">
-                <ns2:creationId id="{721F031B-8FD0-4558-A388-A73DB8B33D3F}"/>
+                <ns2:creationId id="{B845B4EC-CD2B-4090-8330-61420B51D03D}"/>
               </ns1:ext>
             </ns1:extLst>
           </ns0:cNvPr>
@@ -7088,7 +9200,18 @@
           <ns1:bodyPr anchor="t">
             <ns1:noAutofit/>
           </ns1:bodyPr>
-          <ns1:lstStyle/>
+          <ns1:lstStyle>
+            <ns1:defPPr>
+              <ns1:defRPr sz="1800" b="0">
+                <ns1:solidFill>
+                  <ns1:srgbClr val="213744"/>
+                </ns1:solidFill>
+                <ns1:latin typeface="Arial"/>
+                <ns1:ea typeface="Arial"/>
+                <ns1:cs typeface="Arial"/>
+              </ns1:defRPr>
+            </ns1:defPPr>
+          </ns1:lstStyle>
           <ns1:p>
             <ns1:pPr>
               <ns1:defRPr sz="1800" b="0">
@@ -7119,7 +9242,7 @@
           <ns0:cNvPr id="8" name="">
             <ns1:extLst>
               <ns1:ext uri="{FF2B5EF4-FFF2-40B4-BE49-F238E27FC236}">
-                <ns2:creationId id="{7C0F9179-650B-4F6F-9376-6B18B27173B8}"/>
+                <ns2:creationId id="{7D9C4843-0C26-4430-A117-03FF13E0D239}"/>
               </ns1:ext>
             </ns1:extLst>
           </ns0:cNvPr>
@@ -7149,7 +9272,18 @@
           <ns1:bodyPr anchor="t">
             <ns1:noAutofit/>
           </ns1:bodyPr>
-          <ns1:lstStyle/>
+          <ns1:lstStyle>
+            <ns1:defPPr>
+              <ns1:defRPr sz="1350" b="0">
+                <ns1:solidFill>
+                  <ns1:srgbClr val="526B79"/>
+                </ns1:solidFill>
+                <ns1:latin typeface="Arial"/>
+                <ns1:ea typeface="Arial"/>
+                <ns1:cs typeface="Arial"/>
+              </ns1:defRPr>
+            </ns1:defPPr>
+          </ns1:lstStyle>
           <ns1:p>
             <ns1:pPr>
               <ns1:defRPr sz="1350" b="0">
@@ -7178,7 +9312,7 @@
     </ns0:spTree>
     <ns0:extLst>
       <ns0:ext uri="{BB962C8B-B14F-4D97-AF65-F5344CB8AC3E}">
-        <ns4:creationId val="866545666"/>
+        <ns4:creationId val="912373193"/>
       </ns0:ext>
     </ns0:extLst>
   </ns0:cSld>
@@ -7209,7 +9343,7 @@
           <p:cNvPr id="8" name="">
             <a:extLst xmlns:a="http://schemas.openxmlformats.org/drawingml/2006/main">
               <a:ext uri="{FF2B5EF4-FFF2-40B4-BE49-F238E27FC236}">
-                <a16:creationId xmlns:a16="http://schemas.microsoft.com/office/drawing/2014/main" id="{4DDC8E45-3EDF-4367-83AF-C4D81A51BAE0}"/>
+                <a16:creationId xmlns:a16="http://schemas.microsoft.com/office/drawing/2014/main" id="{CC556289-84F8-4CB8-BF07-FAEA60A311E8}"/>
               </a:ext>
             </a:extLst>
           </p:cNvPr>
@@ -7239,7 +9373,18 @@
           <a:bodyPr xmlns:a="http://schemas.openxmlformats.org/drawingml/2006/main" anchor="t">
             <a:noAutofit/>
           </a:bodyPr>
-          <a:lstStyle xmlns:a="http://schemas.openxmlformats.org/drawingml/2006/main"/>
+          <a:lstStyle xmlns:a="http://schemas.openxmlformats.org/drawingml/2006/main">
+            <a:defPPr>
+              <a:defRPr sz="3150" b="1">
+                <a:solidFill>
+                  <a:srgbClr val="213744"/>
+                </a:solidFill>
+                <a:latin typeface="Arial"/>
+                <a:ea typeface="Arial"/>
+                <a:cs typeface="Arial"/>
+              </a:defRPr>
+            </a:defPPr>
+          </a:lstStyle>
           <a:p xmlns:a="http://schemas.openxmlformats.org/drawingml/2006/main">
             <a:pPr>
               <a:defRPr sz="3150" b="1">
@@ -7270,7 +9415,7 @@
           <p:cNvPr id="2" name="">
             <a:extLst xmlns:a="http://schemas.openxmlformats.org/drawingml/2006/main">
               <a:ext uri="{FF2B5EF4-FFF2-40B4-BE49-F238E27FC236}">
-                <a16:creationId xmlns:a16="http://schemas.microsoft.com/office/drawing/2014/main" id="{0EC0BCFA-550B-42CD-AEA1-5016A1D6D922}"/>
+                <a16:creationId xmlns:a16="http://schemas.microsoft.com/office/drawing/2014/main" id="{D60B97B2-4F20-47A1-AC76-79281264E868}"/>
               </a:ext>
             </a:extLst>
           </p:cNvPr>
@@ -7300,7 +9445,18 @@
           <a:bodyPr xmlns:a="http://schemas.openxmlformats.org/drawingml/2006/main" anchor="t">
             <a:noAutofit/>
           </a:bodyPr>
-          <a:lstStyle xmlns:a="http://schemas.openxmlformats.org/drawingml/2006/main"/>
+          <a:lstStyle xmlns:a="http://schemas.openxmlformats.org/drawingml/2006/main">
+            <a:defPPr>
+              <a:defRPr sz="2325" b="0">
+                <a:solidFill>
+                  <a:srgbClr val="213744"/>
+                </a:solidFill>
+                <a:latin typeface="Arial"/>
+                <a:ea typeface="Arial"/>
+                <a:cs typeface="Arial"/>
+              </a:defRPr>
+            </a:defPPr>
+          </a:lstStyle>
           <a:p xmlns:a="http://schemas.openxmlformats.org/drawingml/2006/main">
             <a:pPr>
               <a:defRPr sz="2325" b="0">
@@ -7331,7 +9487,7 @@
           <p:cNvPr id="3" name="">
             <a:extLst xmlns:a="http://schemas.openxmlformats.org/drawingml/2006/main">
               <a:ext uri="{FF2B5EF4-FFF2-40B4-BE49-F238E27FC236}">
-                <a16:creationId xmlns:a16="http://schemas.microsoft.com/office/drawing/2014/main" id="{332A35C9-60B7-4621-A27C-2ECB3E992B12}"/>
+                <a16:creationId xmlns:a16="http://schemas.microsoft.com/office/drawing/2014/main" id="{D7DC10D9-5E66-4882-B7E2-D5E55D31EAE2}"/>
               </a:ext>
             </a:extLst>
           </p:cNvPr>
@@ -7361,7 +9517,18 @@
           <a:bodyPr xmlns:a="http://schemas.openxmlformats.org/drawingml/2006/main" anchor="t">
             <a:noAutofit/>
           </a:bodyPr>
-          <a:lstStyle xmlns:a="http://schemas.openxmlformats.org/drawingml/2006/main"/>
+          <a:lstStyle xmlns:a="http://schemas.openxmlformats.org/drawingml/2006/main">
+            <a:defPPr>
+              <a:defRPr sz="1875" b="1">
+                <a:solidFill>
+                  <a:srgbClr val="157C87"/>
+                </a:solidFill>
+                <a:latin typeface="Arial"/>
+                <a:ea typeface="Arial"/>
+                <a:cs typeface="Arial"/>
+              </a:defRPr>
+            </a:defPPr>
+          </a:lstStyle>
           <a:p xmlns:a="http://schemas.openxmlformats.org/drawingml/2006/main">
             <a:pPr>
               <a:defRPr sz="1875" b="1">
@@ -7389,7 +9556,13 @@
       </p:sp>
       <p:graphicFrame>
         <p:nvGraphicFramePr>
-          <p:cNvPr id="11" name=""/>
+          <p:cNvPr id="4" name="">
+            <a:extLst xmlns:a="http://schemas.openxmlformats.org/drawingml/2006/main">
+              <a:ext uri="{FF2B5EF4-FFF2-40B4-BE49-F238E27FC236}">
+                <a16:creationId xmlns:a16="http://schemas.microsoft.com/office/drawing/2014/main" id="{D5D1D4AE-4C5D-4135-BE8E-D259CE924804}"/>
+              </a:ext>
+            </a:extLst>
+          </p:cNvPr>
           <p:cNvGraphicFramePr/>
           <p:nvPr/>
         </p:nvGraphicFramePr>
@@ -7735,7 +9908,7 @@
           <p:cNvPr id="5" name="">
             <a:extLst xmlns:a="http://schemas.openxmlformats.org/drawingml/2006/main">
               <a:ext uri="{FF2B5EF4-FFF2-40B4-BE49-F238E27FC236}">
-                <a16:creationId xmlns:a16="http://schemas.microsoft.com/office/drawing/2014/main" id="{3545969C-4C7C-4A06-A467-CCEEB07FBD8B}"/>
+                <a16:creationId xmlns:a16="http://schemas.microsoft.com/office/drawing/2014/main" id="{24BC7458-6C3C-4DCC-AC2B-509F1BDECCF4}"/>
               </a:ext>
             </a:extLst>
           </p:cNvPr>
@@ -7765,7 +9938,18 @@
           <a:bodyPr xmlns:a="http://schemas.openxmlformats.org/drawingml/2006/main" anchor="t">
             <a:noAutofit/>
           </a:bodyPr>
-          <a:lstStyle xmlns:a="http://schemas.openxmlformats.org/drawingml/2006/main"/>
+          <a:lstStyle xmlns:a="http://schemas.openxmlformats.org/drawingml/2006/main">
+            <a:defPPr>
+              <a:defRPr sz="1875" b="1">
+                <a:solidFill>
+                  <a:srgbClr val="157C87"/>
+                </a:solidFill>
+                <a:latin typeface="Arial"/>
+                <a:ea typeface="Arial"/>
+                <a:cs typeface="Arial"/>
+              </a:defRPr>
+            </a:defPPr>
+          </a:lstStyle>
           <a:p xmlns:a="http://schemas.openxmlformats.org/drawingml/2006/main">
             <a:pPr>
               <a:defRPr sz="1875" b="1">
@@ -7793,7 +9977,13 @@
       </p:sp>
       <p:graphicFrame>
         <p:nvGraphicFramePr>
-          <p:cNvPr id="13" name=""/>
+          <p:cNvPr id="6" name="">
+            <a:extLst xmlns:a="http://schemas.openxmlformats.org/drawingml/2006/main">
+              <a:ext uri="{FF2B5EF4-FFF2-40B4-BE49-F238E27FC236}">
+                <a16:creationId xmlns:a16="http://schemas.microsoft.com/office/drawing/2014/main" id="{36FD42DF-65F8-436F-A290-8B1D41FA9F6D}"/>
+              </a:ext>
+            </a:extLst>
+          </p:cNvPr>
           <p:cNvGraphicFramePr/>
           <p:nvPr/>
         </p:nvGraphicFramePr>
@@ -8139,7 +10329,7 @@
           <p:cNvPr id="7" name="">
             <a:extLst xmlns:a="http://schemas.openxmlformats.org/drawingml/2006/main">
               <a:ext uri="{FF2B5EF4-FFF2-40B4-BE49-F238E27FC236}">
-                <a16:creationId xmlns:a16="http://schemas.microsoft.com/office/drawing/2014/main" id="{60636990-EED8-4C09-ACC8-B14B6B99A8C9}"/>
+                <a16:creationId xmlns:a16="http://schemas.microsoft.com/office/drawing/2014/main" id="{4E918993-3FE6-46E1-8C8A-526DEB4D516F}"/>
               </a:ext>
             </a:extLst>
           </p:cNvPr>
@@ -8169,7 +10359,18 @@
           <a:bodyPr xmlns:a="http://schemas.openxmlformats.org/drawingml/2006/main" anchor="t">
             <a:noAutofit/>
           </a:bodyPr>
-          <a:lstStyle xmlns:a="http://schemas.openxmlformats.org/drawingml/2006/main"/>
+          <a:lstStyle xmlns:a="http://schemas.openxmlformats.org/drawingml/2006/main">
+            <a:defPPr>
+              <a:defRPr sz="1725" b="0">
+                <a:solidFill>
+                  <a:srgbClr val="526B79"/>
+                </a:solidFill>
+                <a:latin typeface="Arial"/>
+                <a:ea typeface="Arial"/>
+                <a:cs typeface="Arial"/>
+              </a:defRPr>
+            </a:defPPr>
+          </a:lstStyle>
           <a:p xmlns:a="http://schemas.openxmlformats.org/drawingml/2006/main">
             <a:pPr>
               <a:defRPr sz="1725" b="0">
@@ -8198,7 +10399,7 @@
     </p:spTree>
     <p:extLst>
       <p:ext uri="{BB962C8B-B14F-4D97-AF65-F5344CB8AC3E}">
-        <p14:creationId xmlns:p14="http://schemas.microsoft.com/office/powerpoint/2010/main" val="1673537037"/>
+        <p14:creationId xmlns:p14="http://schemas.microsoft.com/office/powerpoint/2010/main" val="1240854999"/>
       </p:ext>
     </p:extLst>
   </p:cSld>
@@ -8229,7 +10430,7 @@
           <p:cNvPr id="9" name="">
             <a:extLst xmlns:a="http://schemas.openxmlformats.org/drawingml/2006/main">
               <a:ext uri="{FF2B5EF4-FFF2-40B4-BE49-F238E27FC236}">
-                <a16:creationId xmlns:a16="http://schemas.microsoft.com/office/drawing/2014/main" id="{3BCDAC36-B3EC-46F0-B0CD-981978FB2DFC}"/>
+                <a16:creationId xmlns:a16="http://schemas.microsoft.com/office/drawing/2014/main" id="{1D7067A2-1238-4C49-B217-6691362A3C61}"/>
               </a:ext>
             </a:extLst>
           </p:cNvPr>
@@ -8259,7 +10460,18 @@
           <a:bodyPr xmlns:a="http://schemas.openxmlformats.org/drawingml/2006/main" anchor="t">
             <a:noAutofit/>
           </a:bodyPr>
-          <a:lstStyle xmlns:a="http://schemas.openxmlformats.org/drawingml/2006/main"/>
+          <a:lstStyle xmlns:a="http://schemas.openxmlformats.org/drawingml/2006/main">
+            <a:defPPr>
+              <a:defRPr sz="3150" b="1">
+                <a:solidFill>
+                  <a:srgbClr val="213744"/>
+                </a:solidFill>
+                <a:latin typeface="Arial"/>
+                <a:ea typeface="Arial"/>
+                <a:cs typeface="Arial"/>
+              </a:defRPr>
+            </a:defPPr>
+          </a:lstStyle>
           <a:p xmlns:a="http://schemas.openxmlformats.org/drawingml/2006/main">
             <a:pPr>
               <a:defRPr sz="3150" b="1">
@@ -8290,7 +10502,7 @@
           <p:cNvPr id="2" name="">
             <a:extLst xmlns:a="http://schemas.openxmlformats.org/drawingml/2006/main">
               <a:ext uri="{FF2B5EF4-FFF2-40B4-BE49-F238E27FC236}">
-                <a16:creationId xmlns:a16="http://schemas.microsoft.com/office/drawing/2014/main" id="{FA210D90-EDBA-4F16-809D-3687A9918C24}"/>
+                <a16:creationId xmlns:a16="http://schemas.microsoft.com/office/drawing/2014/main" id="{5A64ED0F-A8AD-4663-A6AF-4E0E8FA9B207}"/>
               </a:ext>
             </a:extLst>
           </p:cNvPr>
@@ -8320,7 +10532,18 @@
           <a:bodyPr xmlns:a="http://schemas.openxmlformats.org/drawingml/2006/main" anchor="t">
             <a:noAutofit/>
           </a:bodyPr>
-          <a:lstStyle xmlns:a="http://schemas.openxmlformats.org/drawingml/2006/main"/>
+          <a:lstStyle xmlns:a="http://schemas.openxmlformats.org/drawingml/2006/main">
+            <a:defPPr>
+              <a:defRPr sz="2325" b="1">
+                <a:solidFill>
+                  <a:srgbClr val="157C87"/>
+                </a:solidFill>
+                <a:latin typeface="Arial"/>
+                <a:ea typeface="Arial"/>
+                <a:cs typeface="Arial"/>
+              </a:defRPr>
+            </a:defPPr>
+          </a:lstStyle>
           <a:p xmlns:a="http://schemas.openxmlformats.org/drawingml/2006/main">
             <a:pPr>
               <a:defRPr sz="2325" b="1">
@@ -8348,14 +10571,20 @@
       </p:sp>
       <p:pic>
         <p:nvPicPr>
-          <p:cNvPr id="11" name=""/>
+          <p:cNvPr id="3" name="">
+            <a:extLst xmlns:a="http://schemas.openxmlformats.org/drawingml/2006/main">
+              <a:ext uri="{FF2B5EF4-FFF2-40B4-BE49-F238E27FC236}">
+                <a16:creationId xmlns:a16="http://schemas.microsoft.com/office/drawing/2014/main" id="{605AD69D-7903-42F5-AE7F-52959F8A7CE7}"/>
+              </a:ext>
+            </a:extLst>
+          </p:cNvPr>
           <p:cNvPicPr>
             <a:picLocks xmlns:a="http://schemas.openxmlformats.org/drawingml/2006/main" noChangeAspect="1"/>
           </p:cNvPicPr>
           <p:nvPr/>
         </p:nvPicPr>
         <p:blipFill>
-          <a:blip xmlns:r="http://schemas.openxmlformats.org/officeDocument/2006/relationships" xmlns:a="http://schemas.openxmlformats.org/drawingml/2006/main" r:embed="Redf0e614e70e4045"/>
+          <a:blip xmlns:r="http://schemas.openxmlformats.org/officeDocument/2006/relationships" xmlns:a="http://schemas.openxmlformats.org/drawingml/2006/main" r:embed="R8b7aa18c79314023"/>
           <a:stretch xmlns:a="http://schemas.openxmlformats.org/drawingml/2006/main"/>
         </p:blipFill>
         <p:spPr>
@@ -8373,7 +10602,7 @@
           <p:cNvPr id="4" name="">
             <a:extLst xmlns:a="http://schemas.openxmlformats.org/drawingml/2006/main">
               <a:ext uri="{FF2B5EF4-FFF2-40B4-BE49-F238E27FC236}">
-                <a16:creationId xmlns:a16="http://schemas.microsoft.com/office/drawing/2014/main" id="{9F297252-5C92-44C5-B5FC-8626F1E6F663}"/>
+                <a16:creationId xmlns:a16="http://schemas.microsoft.com/office/drawing/2014/main" id="{39EF8DE5-BCA5-4D0B-BCCB-28001A13F029}"/>
               </a:ext>
             </a:extLst>
           </p:cNvPr>
@@ -8403,7 +10632,18 @@
           <a:bodyPr xmlns:a="http://schemas.openxmlformats.org/drawingml/2006/main" anchor="t">
             <a:noAutofit/>
           </a:bodyPr>
-          <a:lstStyle xmlns:a="http://schemas.openxmlformats.org/drawingml/2006/main"/>
+          <a:lstStyle xmlns:a="http://schemas.openxmlformats.org/drawingml/2006/main">
+            <a:defPPr>
+              <a:defRPr sz="1650" b="1">
+                <a:solidFill>
+                  <a:srgbClr val="157C87"/>
+                </a:solidFill>
+                <a:latin typeface="Arial"/>
+                <a:ea typeface="Arial"/>
+                <a:cs typeface="Arial"/>
+              </a:defRPr>
+            </a:defPPr>
+          </a:lstStyle>
           <a:p xmlns:a="http://schemas.openxmlformats.org/drawingml/2006/main">
             <a:pPr>
               <a:defRPr sz="1650" b="1">
@@ -8434,7 +10674,7 @@
           <p:cNvPr id="5" name="">
             <a:extLst xmlns:a="http://schemas.openxmlformats.org/drawingml/2006/main">
               <a:ext uri="{FF2B5EF4-FFF2-40B4-BE49-F238E27FC236}">
-                <a16:creationId xmlns:a16="http://schemas.microsoft.com/office/drawing/2014/main" id="{6A4D40E1-2C6D-48CD-8AFD-4729A9320DBE}"/>
+                <a16:creationId xmlns:a16="http://schemas.microsoft.com/office/drawing/2014/main" id="{D65B6ED9-060B-4EA8-8B56-5835EBE71B34}"/>
               </a:ext>
             </a:extLst>
           </p:cNvPr>
@@ -8464,7 +10704,18 @@
           <a:bodyPr xmlns:a="http://schemas.openxmlformats.org/drawingml/2006/main" anchor="t">
             <a:noAutofit/>
           </a:bodyPr>
-          <a:lstStyle xmlns:a="http://schemas.openxmlformats.org/drawingml/2006/main"/>
+          <a:lstStyle xmlns:a="http://schemas.openxmlformats.org/drawingml/2006/main">
+            <a:defPPr>
+              <a:defRPr sz="1800" b="0">
+                <a:solidFill>
+                  <a:srgbClr val="213744"/>
+                </a:solidFill>
+                <a:latin typeface="Arial"/>
+                <a:ea typeface="Arial"/>
+                <a:cs typeface="Arial"/>
+              </a:defRPr>
+            </a:defPPr>
+          </a:lstStyle>
           <a:p xmlns:a="http://schemas.openxmlformats.org/drawingml/2006/main">
             <a:pPr>
               <a:defRPr sz="1800" b="0">
@@ -8495,7 +10746,7 @@
           <p:cNvPr id="6" name="">
             <a:extLst xmlns:a="http://schemas.openxmlformats.org/drawingml/2006/main">
               <a:ext uri="{FF2B5EF4-FFF2-40B4-BE49-F238E27FC236}">
-                <a16:creationId xmlns:a16="http://schemas.microsoft.com/office/drawing/2014/main" id="{82BE0FB3-CDFD-4E6D-B69C-C8797F8839C9}"/>
+                <a16:creationId xmlns:a16="http://schemas.microsoft.com/office/drawing/2014/main" id="{A159CD9D-9221-45D4-A770-A0324CBF5D5D}"/>
               </a:ext>
             </a:extLst>
           </p:cNvPr>
@@ -8525,7 +10776,18 @@
           <a:bodyPr xmlns:a="http://schemas.openxmlformats.org/drawingml/2006/main" anchor="t">
             <a:noAutofit/>
           </a:bodyPr>
-          <a:lstStyle xmlns:a="http://schemas.openxmlformats.org/drawingml/2006/main"/>
+          <a:lstStyle xmlns:a="http://schemas.openxmlformats.org/drawingml/2006/main">
+            <a:defPPr>
+              <a:defRPr sz="1650" b="1">
+                <a:solidFill>
+                  <a:srgbClr val="157C87"/>
+                </a:solidFill>
+                <a:latin typeface="Arial"/>
+                <a:ea typeface="Arial"/>
+                <a:cs typeface="Arial"/>
+              </a:defRPr>
+            </a:defPPr>
+          </a:lstStyle>
           <a:p xmlns:a="http://schemas.openxmlformats.org/drawingml/2006/main">
             <a:pPr>
               <a:defRPr sz="1650" b="1">
@@ -8556,7 +10818,7 @@
           <p:cNvPr id="7" name="">
             <a:extLst xmlns:a="http://schemas.openxmlformats.org/drawingml/2006/main">
               <a:ext uri="{FF2B5EF4-FFF2-40B4-BE49-F238E27FC236}">
-                <a16:creationId xmlns:a16="http://schemas.microsoft.com/office/drawing/2014/main" id="{0518B390-8E26-4DB1-9860-DA22F79FF516}"/>
+                <a16:creationId xmlns:a16="http://schemas.microsoft.com/office/drawing/2014/main" id="{A55F29CC-4D69-403A-929D-8D74CF66577C}"/>
               </a:ext>
             </a:extLst>
           </p:cNvPr>
@@ -8586,7 +10848,18 @@
           <a:bodyPr xmlns:a="http://schemas.openxmlformats.org/drawingml/2006/main" anchor="t">
             <a:noAutofit/>
           </a:bodyPr>
-          <a:lstStyle xmlns:a="http://schemas.openxmlformats.org/drawingml/2006/main"/>
+          <a:lstStyle xmlns:a="http://schemas.openxmlformats.org/drawingml/2006/main">
+            <a:defPPr>
+              <a:defRPr sz="1800" b="0">
+                <a:solidFill>
+                  <a:srgbClr val="213744"/>
+                </a:solidFill>
+                <a:latin typeface="Arial"/>
+                <a:ea typeface="Arial"/>
+                <a:cs typeface="Arial"/>
+              </a:defRPr>
+            </a:defPPr>
+          </a:lstStyle>
           <a:p xmlns:a="http://schemas.openxmlformats.org/drawingml/2006/main">
             <a:pPr>
               <a:defRPr sz="1800" b="0">
@@ -8617,7 +10890,7 @@
           <p:cNvPr id="8" name="">
             <a:extLst xmlns:a="http://schemas.openxmlformats.org/drawingml/2006/main">
               <a:ext uri="{FF2B5EF4-FFF2-40B4-BE49-F238E27FC236}">
-                <a16:creationId xmlns:a16="http://schemas.microsoft.com/office/drawing/2014/main" id="{FCC34774-083A-4083-92C2-DCEED74F4C35}"/>
+                <a16:creationId xmlns:a16="http://schemas.microsoft.com/office/drawing/2014/main" id="{93D7C810-AF82-4BDE-9908-6F9A539BCF85}"/>
               </a:ext>
             </a:extLst>
           </p:cNvPr>
@@ -8647,7 +10920,18 @@
           <a:bodyPr xmlns:a="http://schemas.openxmlformats.org/drawingml/2006/main" anchor="t">
             <a:noAutofit/>
           </a:bodyPr>
-          <a:lstStyle xmlns:a="http://schemas.openxmlformats.org/drawingml/2006/main"/>
+          <a:lstStyle xmlns:a="http://schemas.openxmlformats.org/drawingml/2006/main">
+            <a:defPPr>
+              <a:defRPr sz="1350" b="0">
+                <a:solidFill>
+                  <a:srgbClr val="526B79"/>
+                </a:solidFill>
+                <a:latin typeface="Arial"/>
+                <a:ea typeface="Arial"/>
+                <a:cs typeface="Arial"/>
+              </a:defRPr>
+            </a:defPPr>
+          </a:lstStyle>
           <a:p xmlns:a="http://schemas.openxmlformats.org/drawingml/2006/main">
             <a:pPr>
               <a:defRPr sz="1350" b="0">
@@ -8676,7 +10960,7 @@
     </p:spTree>
     <p:extLst>
       <p:ext uri="{BB962C8B-B14F-4D97-AF65-F5344CB8AC3E}">
-        <p14:creationId xmlns:p14="http://schemas.microsoft.com/office/powerpoint/2010/main" val="21936802"/>
+        <p14:creationId xmlns:p14="http://schemas.microsoft.com/office/powerpoint/2010/main" val="649580977"/>
       </p:ext>
     </p:extLst>
   </p:cSld>
@@ -8707,7 +10991,7 @@
           <p:cNvPr id="6" name="">
             <a:extLst xmlns:a="http://schemas.openxmlformats.org/drawingml/2006/main">
               <a:ext uri="{FF2B5EF4-FFF2-40B4-BE49-F238E27FC236}">
-                <a16:creationId xmlns:a16="http://schemas.microsoft.com/office/drawing/2014/main" id="{B7A1D6BF-29F3-4921-9653-80B7E93B38DB}"/>
+                <a16:creationId xmlns:a16="http://schemas.microsoft.com/office/drawing/2014/main" id="{92F94A92-7B97-49EE-97A3-DDFF37A06220}"/>
               </a:ext>
             </a:extLst>
           </p:cNvPr>
@@ -8737,7 +11021,18 @@
           <a:bodyPr xmlns:a="http://schemas.openxmlformats.org/drawingml/2006/main" anchor="t">
             <a:noAutofit/>
           </a:bodyPr>
-          <a:lstStyle xmlns:a="http://schemas.openxmlformats.org/drawingml/2006/main"/>
+          <a:lstStyle xmlns:a="http://schemas.openxmlformats.org/drawingml/2006/main">
+            <a:defPPr>
+              <a:defRPr sz="3150" b="1">
+                <a:solidFill>
+                  <a:srgbClr val="213744"/>
+                </a:solidFill>
+                <a:latin typeface="Arial"/>
+                <a:ea typeface="Arial"/>
+                <a:cs typeface="Arial"/>
+              </a:defRPr>
+            </a:defPPr>
+          </a:lstStyle>
           <a:p xmlns:a="http://schemas.openxmlformats.org/drawingml/2006/main">
             <a:pPr>
               <a:defRPr sz="3150" b="1">
@@ -8768,7 +11063,7 @@
           <p:cNvPr id="2" name="">
             <a:extLst xmlns:a="http://schemas.openxmlformats.org/drawingml/2006/main">
               <a:ext uri="{FF2B5EF4-FFF2-40B4-BE49-F238E27FC236}">
-                <a16:creationId xmlns:a16="http://schemas.microsoft.com/office/drawing/2014/main" id="{E941A44C-6538-493D-965B-44751BFE3B85}"/>
+                <a16:creationId xmlns:a16="http://schemas.microsoft.com/office/drawing/2014/main" id="{3B2E9724-D19A-4130-97E6-F1CBA533AE82}"/>
               </a:ext>
             </a:extLst>
           </p:cNvPr>
@@ -8798,7 +11093,18 @@
           <a:bodyPr xmlns:a="http://schemas.openxmlformats.org/drawingml/2006/main" anchor="t">
             <a:noAutofit/>
           </a:bodyPr>
-          <a:lstStyle xmlns:a="http://schemas.openxmlformats.org/drawingml/2006/main"/>
+          <a:lstStyle xmlns:a="http://schemas.openxmlformats.org/drawingml/2006/main">
+            <a:defPPr>
+              <a:defRPr sz="2250" b="0">
+                <a:solidFill>
+                  <a:srgbClr val="213744"/>
+                </a:solidFill>
+                <a:latin typeface="Arial"/>
+                <a:ea typeface="Arial"/>
+                <a:cs typeface="Arial"/>
+              </a:defRPr>
+            </a:defPPr>
+          </a:lstStyle>
           <a:p xmlns:a="http://schemas.openxmlformats.org/drawingml/2006/main">
             <a:pPr>
               <a:defRPr sz="2250" b="0">
@@ -8826,14 +11132,20 @@
       </p:sp>
       <p:pic>
         <p:nvPicPr>
-          <p:cNvPr id="8" name=""/>
+          <p:cNvPr id="3" name="">
+            <a:extLst xmlns:a="http://schemas.openxmlformats.org/drawingml/2006/main">
+              <a:ext uri="{FF2B5EF4-FFF2-40B4-BE49-F238E27FC236}">
+                <a16:creationId xmlns:a16="http://schemas.microsoft.com/office/drawing/2014/main" id="{E3811190-EFD5-4201-8BB4-8DEAF5D33217}"/>
+              </a:ext>
+            </a:extLst>
+          </p:cNvPr>
           <p:cNvPicPr>
             <a:picLocks xmlns:a="http://schemas.openxmlformats.org/drawingml/2006/main" noChangeAspect="1"/>
           </p:cNvPicPr>
           <p:nvPr/>
         </p:nvPicPr>
         <p:blipFill>
-          <a:blip xmlns:r="http://schemas.openxmlformats.org/officeDocument/2006/relationships" xmlns:a="http://schemas.openxmlformats.org/drawingml/2006/main" r:embed="R897db4e78b664be4"/>
+          <a:blip xmlns:r="http://schemas.openxmlformats.org/officeDocument/2006/relationships" xmlns:a="http://schemas.openxmlformats.org/drawingml/2006/main" r:embed="R0b1fc4eb1f484ab1"/>
           <a:stretch xmlns:a="http://schemas.openxmlformats.org/drawingml/2006/main"/>
         </p:blipFill>
         <p:spPr>
@@ -8851,7 +11163,7 @@
           <p:cNvPr id="4" name="">
             <a:extLst xmlns:a="http://schemas.openxmlformats.org/drawingml/2006/main">
               <a:ext uri="{FF2B5EF4-FFF2-40B4-BE49-F238E27FC236}">
-                <a16:creationId xmlns:a16="http://schemas.microsoft.com/office/drawing/2014/main" id="{86AA60C4-8265-423A-A194-DF0B059B5E91}"/>
+                <a16:creationId xmlns:a16="http://schemas.microsoft.com/office/drawing/2014/main" id="{6AA03224-CBEA-42BB-A679-8DE2455C4F33}"/>
               </a:ext>
             </a:extLst>
           </p:cNvPr>
@@ -8881,7 +11193,18 @@
           <a:bodyPr xmlns:a="http://schemas.openxmlformats.org/drawingml/2006/main" anchor="t">
             <a:noAutofit/>
           </a:bodyPr>
-          <a:lstStyle xmlns:a="http://schemas.openxmlformats.org/drawingml/2006/main"/>
+          <a:lstStyle xmlns:a="http://schemas.openxmlformats.org/drawingml/2006/main">
+            <a:defPPr>
+              <a:defRPr sz="1875" b="0">
+                <a:solidFill>
+                  <a:srgbClr val="157C87"/>
+                </a:solidFill>
+                <a:latin typeface="Arial"/>
+                <a:ea typeface="Arial"/>
+                <a:cs typeface="Arial"/>
+              </a:defRPr>
+            </a:defPPr>
+          </a:lstStyle>
           <a:p xmlns:a="http://schemas.openxmlformats.org/drawingml/2006/main">
             <a:pPr>
               <a:defRPr sz="1875" b="0">
@@ -8912,7 +11235,7 @@
           <p:cNvPr id="5" name="">
             <a:extLst xmlns:a="http://schemas.openxmlformats.org/drawingml/2006/main">
               <a:ext uri="{FF2B5EF4-FFF2-40B4-BE49-F238E27FC236}">
-                <a16:creationId xmlns:a16="http://schemas.microsoft.com/office/drawing/2014/main" id="{32E456A4-0744-49E6-B920-240DB7F858AC}"/>
+                <a16:creationId xmlns:a16="http://schemas.microsoft.com/office/drawing/2014/main" id="{D3FEA31A-B19F-4E19-BC6F-163054D8B2AC}"/>
               </a:ext>
             </a:extLst>
           </p:cNvPr>
@@ -8942,7 +11265,18 @@
           <a:bodyPr xmlns:a="http://schemas.openxmlformats.org/drawingml/2006/main" anchor="t">
             <a:noAutofit/>
           </a:bodyPr>
-          <a:lstStyle xmlns:a="http://schemas.openxmlformats.org/drawingml/2006/main"/>
+          <a:lstStyle xmlns:a="http://schemas.openxmlformats.org/drawingml/2006/main">
+            <a:defPPr>
+              <a:defRPr sz="1575" b="0">
+                <a:solidFill>
+                  <a:srgbClr val="526B79"/>
+                </a:solidFill>
+                <a:latin typeface="Arial"/>
+                <a:ea typeface="Arial"/>
+                <a:cs typeface="Arial"/>
+              </a:defRPr>
+            </a:defPPr>
+          </a:lstStyle>
           <a:p xmlns:a="http://schemas.openxmlformats.org/drawingml/2006/main">
             <a:pPr>
               <a:defRPr sz="1575" b="0">
@@ -8971,7 +11305,7 @@
     </p:spTree>
     <p:extLst>
       <p:ext uri="{BB962C8B-B14F-4D97-AF65-F5344CB8AC3E}">
-        <p14:creationId xmlns:p14="http://schemas.microsoft.com/office/powerpoint/2010/main" val="1483927669"/>
+        <p14:creationId xmlns:p14="http://schemas.microsoft.com/office/powerpoint/2010/main" val="1385028474"/>
       </p:ext>
     </p:extLst>
   </p:cSld>
@@ -9002,7 +11336,7 @@
           <p:cNvPr id="5" name="">
             <a:extLst xmlns:a="http://schemas.openxmlformats.org/drawingml/2006/main">
               <a:ext uri="{FF2B5EF4-FFF2-40B4-BE49-F238E27FC236}">
-                <a16:creationId xmlns:a16="http://schemas.microsoft.com/office/drawing/2014/main" id="{845606DD-E85F-4439-A659-D7F37649D321}"/>
+                <a16:creationId xmlns:a16="http://schemas.microsoft.com/office/drawing/2014/main" id="{FBC84943-F769-4E05-AAD7-18C5FF4A70A4}"/>
               </a:ext>
             </a:extLst>
           </p:cNvPr>
@@ -9032,7 +11366,18 @@
           <a:bodyPr xmlns:a="http://schemas.openxmlformats.org/drawingml/2006/main" anchor="t">
             <a:noAutofit/>
           </a:bodyPr>
-          <a:lstStyle xmlns:a="http://schemas.openxmlformats.org/drawingml/2006/main"/>
+          <a:lstStyle xmlns:a="http://schemas.openxmlformats.org/drawingml/2006/main">
+            <a:defPPr>
+              <a:defRPr sz="3150" b="1">
+                <a:solidFill>
+                  <a:srgbClr val="213744"/>
+                </a:solidFill>
+                <a:latin typeface="Arial"/>
+                <a:ea typeface="Arial"/>
+                <a:cs typeface="Arial"/>
+              </a:defRPr>
+            </a:defPPr>
+          </a:lstStyle>
           <a:p xmlns:a="http://schemas.openxmlformats.org/drawingml/2006/main">
             <a:pPr>
               <a:defRPr sz="3150" b="1">
@@ -9063,7 +11408,7 @@
           <p:cNvPr id="2" name="">
             <a:extLst xmlns:a="http://schemas.openxmlformats.org/drawingml/2006/main">
               <a:ext uri="{FF2B5EF4-FFF2-40B4-BE49-F238E27FC236}">
-                <a16:creationId xmlns:a16="http://schemas.microsoft.com/office/drawing/2014/main" id="{A31959C9-7C79-4230-9BAB-F0E5BDF73203}"/>
+                <a16:creationId xmlns:a16="http://schemas.microsoft.com/office/drawing/2014/main" id="{9FB0D66B-5E44-4497-ABA1-9A2BAB572953}"/>
               </a:ext>
             </a:extLst>
           </p:cNvPr>
@@ -9093,7 +11438,18 @@
           <a:bodyPr xmlns:a="http://schemas.openxmlformats.org/drawingml/2006/main" anchor="t">
             <a:noAutofit/>
           </a:bodyPr>
-          <a:lstStyle xmlns:a="http://schemas.openxmlformats.org/drawingml/2006/main"/>
+          <a:lstStyle xmlns:a="http://schemas.openxmlformats.org/drawingml/2006/main">
+            <a:defPPr>
+              <a:defRPr sz="2250" b="0">
+                <a:solidFill>
+                  <a:srgbClr val="213744"/>
+                </a:solidFill>
+                <a:latin typeface="Arial"/>
+                <a:ea typeface="Arial"/>
+                <a:cs typeface="Arial"/>
+              </a:defRPr>
+            </a:defPPr>
+          </a:lstStyle>
           <a:p xmlns:a="http://schemas.openxmlformats.org/drawingml/2006/main">
             <a:pPr>
               <a:defRPr sz="2250" b="0">
@@ -9121,7 +11477,13 @@
       </p:sp>
       <p:graphicFrame>
         <p:nvGraphicFramePr>
-          <p:cNvPr id="7" name=""/>
+          <p:cNvPr id="3" name="">
+            <a:extLst xmlns:a="http://schemas.openxmlformats.org/drawingml/2006/main">
+              <a:ext uri="{FF2B5EF4-FFF2-40B4-BE49-F238E27FC236}">
+                <a16:creationId xmlns:a16="http://schemas.microsoft.com/office/drawing/2014/main" id="{86ED5D3F-E0B4-4AB8-BE3A-3DFCB95D4261}"/>
+              </a:ext>
+            </a:extLst>
+          </p:cNvPr>
           <p:cNvGraphicFramePr/>
           <p:nvPr/>
         </p:nvGraphicFramePr>
@@ -9578,7 +11940,7 @@
           <p:cNvPr id="4" name="">
             <a:extLst xmlns:a="http://schemas.openxmlformats.org/drawingml/2006/main">
               <a:ext uri="{FF2B5EF4-FFF2-40B4-BE49-F238E27FC236}">
-                <a16:creationId xmlns:a16="http://schemas.microsoft.com/office/drawing/2014/main" id="{5DB8D73B-D817-4713-A8BF-E8F880D3ACBB}"/>
+                <a16:creationId xmlns:a16="http://schemas.microsoft.com/office/drawing/2014/main" id="{2A0D9D80-ECB5-4435-9575-E27A5110AD9C}"/>
               </a:ext>
             </a:extLst>
           </p:cNvPr>
@@ -9608,7 +11970,18 @@
           <a:bodyPr xmlns:a="http://schemas.openxmlformats.org/drawingml/2006/main" anchor="t">
             <a:noAutofit/>
           </a:bodyPr>
-          <a:lstStyle xmlns:a="http://schemas.openxmlformats.org/drawingml/2006/main"/>
+          <a:lstStyle xmlns:a="http://schemas.openxmlformats.org/drawingml/2006/main">
+            <a:defPPr>
+              <a:defRPr sz="1800" b="0">
+                <a:solidFill>
+                  <a:srgbClr val="A25D20"/>
+                </a:solidFill>
+                <a:latin typeface="Arial"/>
+                <a:ea typeface="Arial"/>
+                <a:cs typeface="Arial"/>
+              </a:defRPr>
+            </a:defPPr>
+          </a:lstStyle>
           <a:p xmlns:a="http://schemas.openxmlformats.org/drawingml/2006/main">
             <a:pPr>
               <a:defRPr sz="1800" b="0">
@@ -9637,7 +12010,7 @@
     </p:spTree>
     <p:extLst>
       <p:ext uri="{BB962C8B-B14F-4D97-AF65-F5344CB8AC3E}">
-        <p14:creationId xmlns:p14="http://schemas.microsoft.com/office/powerpoint/2010/main" val="207730346"/>
+        <p14:creationId xmlns:p14="http://schemas.microsoft.com/office/powerpoint/2010/main" val="1322089845"/>
       </p:ext>
     </p:extLst>
   </p:cSld>
@@ -9668,7 +12041,7 @@
           <p:cNvPr id="9" name="">
             <a:extLst xmlns:a="http://schemas.openxmlformats.org/drawingml/2006/main">
               <a:ext uri="{FF2B5EF4-FFF2-40B4-BE49-F238E27FC236}">
-                <a16:creationId xmlns:a16="http://schemas.microsoft.com/office/drawing/2014/main" id="{7A25B002-EAD8-4B23-BA99-32CE8FA8E78A}"/>
+                <a16:creationId xmlns:a16="http://schemas.microsoft.com/office/drawing/2014/main" id="{0D7063AB-BC4F-4F2A-88FD-5E32E18D89BB}"/>
               </a:ext>
             </a:extLst>
           </p:cNvPr>
@@ -9698,7 +12071,18 @@
           <a:bodyPr xmlns:a="http://schemas.openxmlformats.org/drawingml/2006/main" anchor="t">
             <a:noAutofit/>
           </a:bodyPr>
-          <a:lstStyle xmlns:a="http://schemas.openxmlformats.org/drawingml/2006/main"/>
+          <a:lstStyle xmlns:a="http://schemas.openxmlformats.org/drawingml/2006/main">
+            <a:defPPr>
+              <a:defRPr sz="3150" b="1">
+                <a:solidFill>
+                  <a:srgbClr val="213744"/>
+                </a:solidFill>
+                <a:latin typeface="Arial"/>
+                <a:ea typeface="Arial"/>
+                <a:cs typeface="Arial"/>
+              </a:defRPr>
+            </a:defPPr>
+          </a:lstStyle>
           <a:p xmlns:a="http://schemas.openxmlformats.org/drawingml/2006/main">
             <a:pPr>
               <a:defRPr sz="3150" b="1">
@@ -9729,7 +12113,7 @@
           <p:cNvPr id="2" name="">
             <a:extLst xmlns:a="http://schemas.openxmlformats.org/drawingml/2006/main">
               <a:ext uri="{FF2B5EF4-FFF2-40B4-BE49-F238E27FC236}">
-                <a16:creationId xmlns:a16="http://schemas.microsoft.com/office/drawing/2014/main" id="{F50FF2E1-905F-4606-932F-E110793F485D}"/>
+                <a16:creationId xmlns:a16="http://schemas.microsoft.com/office/drawing/2014/main" id="{88066F21-6D6C-4C7E-8B45-853AEE432EFC}"/>
               </a:ext>
             </a:extLst>
           </p:cNvPr>
@@ -9759,7 +12143,18 @@
           <a:bodyPr xmlns:a="http://schemas.openxmlformats.org/drawingml/2006/main" anchor="t">
             <a:noAutofit/>
           </a:bodyPr>
-          <a:lstStyle xmlns:a="http://schemas.openxmlformats.org/drawingml/2006/main"/>
+          <a:lstStyle xmlns:a="http://schemas.openxmlformats.org/drawingml/2006/main">
+            <a:defPPr>
+              <a:defRPr sz="2325" b="1">
+                <a:solidFill>
+                  <a:srgbClr val="157C87"/>
+                </a:solidFill>
+                <a:latin typeface="Arial"/>
+                <a:ea typeface="Arial"/>
+                <a:cs typeface="Arial"/>
+              </a:defRPr>
+            </a:defPPr>
+          </a:lstStyle>
           <a:p xmlns:a="http://schemas.openxmlformats.org/drawingml/2006/main">
             <a:pPr>
               <a:defRPr sz="2325" b="1">
@@ -9787,14 +12182,20 @@
       </p:sp>
       <p:pic>
         <p:nvPicPr>
-          <p:cNvPr id="11" name=""/>
+          <p:cNvPr id="3" name="">
+            <a:extLst xmlns:a="http://schemas.openxmlformats.org/drawingml/2006/main">
+              <a:ext uri="{FF2B5EF4-FFF2-40B4-BE49-F238E27FC236}">
+                <a16:creationId xmlns:a16="http://schemas.microsoft.com/office/drawing/2014/main" id="{DD8ACDB4-857F-4588-8F16-6B1EC37F6B3C}"/>
+              </a:ext>
+            </a:extLst>
+          </p:cNvPr>
           <p:cNvPicPr>
             <a:picLocks xmlns:a="http://schemas.openxmlformats.org/drawingml/2006/main" noChangeAspect="1"/>
           </p:cNvPicPr>
           <p:nvPr/>
         </p:nvPicPr>
         <p:blipFill>
-          <a:blip xmlns:r="http://schemas.openxmlformats.org/officeDocument/2006/relationships" xmlns:a="http://schemas.openxmlformats.org/drawingml/2006/main" r:embed="R870ab05cce7a4d3b"/>
+          <a:blip xmlns:r="http://schemas.openxmlformats.org/officeDocument/2006/relationships" xmlns:a="http://schemas.openxmlformats.org/drawingml/2006/main" r:embed="R84745d2bd1d74eac"/>
           <a:stretch xmlns:a="http://schemas.openxmlformats.org/drawingml/2006/main"/>
         </p:blipFill>
         <p:spPr>
@@ -9812,7 +12213,7 @@
           <p:cNvPr id="4" name="">
             <a:extLst xmlns:a="http://schemas.openxmlformats.org/drawingml/2006/main">
               <a:ext uri="{FF2B5EF4-FFF2-40B4-BE49-F238E27FC236}">
-                <a16:creationId xmlns:a16="http://schemas.microsoft.com/office/drawing/2014/main" id="{DB989FB5-58AE-4441-A800-DE59C77B8123}"/>
+                <a16:creationId xmlns:a16="http://schemas.microsoft.com/office/drawing/2014/main" id="{84C2E3AA-F4C1-4153-8B64-46CD28C78285}"/>
               </a:ext>
             </a:extLst>
           </p:cNvPr>
@@ -9842,7 +12243,18 @@
           <a:bodyPr xmlns:a="http://schemas.openxmlformats.org/drawingml/2006/main" anchor="t">
             <a:noAutofit/>
           </a:bodyPr>
-          <a:lstStyle xmlns:a="http://schemas.openxmlformats.org/drawingml/2006/main"/>
+          <a:lstStyle xmlns:a="http://schemas.openxmlformats.org/drawingml/2006/main">
+            <a:defPPr>
+              <a:defRPr sz="1650" b="1">
+                <a:solidFill>
+                  <a:srgbClr val="157C87"/>
+                </a:solidFill>
+                <a:latin typeface="Arial"/>
+                <a:ea typeface="Arial"/>
+                <a:cs typeface="Arial"/>
+              </a:defRPr>
+            </a:defPPr>
+          </a:lstStyle>
           <a:p xmlns:a="http://schemas.openxmlformats.org/drawingml/2006/main">
             <a:pPr>
               <a:defRPr sz="1650" b="1">
@@ -9873,7 +12285,7 @@
           <p:cNvPr id="5" name="">
             <a:extLst xmlns:a="http://schemas.openxmlformats.org/drawingml/2006/main">
               <a:ext uri="{FF2B5EF4-FFF2-40B4-BE49-F238E27FC236}">
-                <a16:creationId xmlns:a16="http://schemas.microsoft.com/office/drawing/2014/main" id="{336F84FC-9469-4077-BC95-327135DFC544}"/>
+                <a16:creationId xmlns:a16="http://schemas.microsoft.com/office/drawing/2014/main" id="{5132ECD4-A1D6-407E-9CA4-303E7CCE946A}"/>
               </a:ext>
             </a:extLst>
           </p:cNvPr>
@@ -9903,7 +12315,18 @@
           <a:bodyPr xmlns:a="http://schemas.openxmlformats.org/drawingml/2006/main" anchor="t">
             <a:noAutofit/>
           </a:bodyPr>
-          <a:lstStyle xmlns:a="http://schemas.openxmlformats.org/drawingml/2006/main"/>
+          <a:lstStyle xmlns:a="http://schemas.openxmlformats.org/drawingml/2006/main">
+            <a:defPPr>
+              <a:defRPr sz="1800" b="0">
+                <a:solidFill>
+                  <a:srgbClr val="213744"/>
+                </a:solidFill>
+                <a:latin typeface="Arial"/>
+                <a:ea typeface="Arial"/>
+                <a:cs typeface="Arial"/>
+              </a:defRPr>
+            </a:defPPr>
+          </a:lstStyle>
           <a:p xmlns:a="http://schemas.openxmlformats.org/drawingml/2006/main">
             <a:pPr>
               <a:defRPr sz="1800" b="0">
@@ -9934,7 +12357,7 @@
           <p:cNvPr id="6" name="">
             <a:extLst xmlns:a="http://schemas.openxmlformats.org/drawingml/2006/main">
               <a:ext uri="{FF2B5EF4-FFF2-40B4-BE49-F238E27FC236}">
-                <a16:creationId xmlns:a16="http://schemas.microsoft.com/office/drawing/2014/main" id="{D0B963D7-8CA9-4A25-B988-87AC88568197}"/>
+                <a16:creationId xmlns:a16="http://schemas.microsoft.com/office/drawing/2014/main" id="{140DEB75-B3B2-4BAF-9281-2EA3B52C3D96}"/>
               </a:ext>
             </a:extLst>
           </p:cNvPr>
@@ -9964,7 +12387,18 @@
           <a:bodyPr xmlns:a="http://schemas.openxmlformats.org/drawingml/2006/main" anchor="t">
             <a:noAutofit/>
           </a:bodyPr>
-          <a:lstStyle xmlns:a="http://schemas.openxmlformats.org/drawingml/2006/main"/>
+          <a:lstStyle xmlns:a="http://schemas.openxmlformats.org/drawingml/2006/main">
+            <a:defPPr>
+              <a:defRPr sz="1650" b="1">
+                <a:solidFill>
+                  <a:srgbClr val="157C87"/>
+                </a:solidFill>
+                <a:latin typeface="Arial"/>
+                <a:ea typeface="Arial"/>
+                <a:cs typeface="Arial"/>
+              </a:defRPr>
+            </a:defPPr>
+          </a:lstStyle>
           <a:p xmlns:a="http://schemas.openxmlformats.org/drawingml/2006/main">
             <a:pPr>
               <a:defRPr sz="1650" b="1">
@@ -9995,7 +12429,7 @@
           <p:cNvPr id="7" name="">
             <a:extLst xmlns:a="http://schemas.openxmlformats.org/drawingml/2006/main">
               <a:ext uri="{FF2B5EF4-FFF2-40B4-BE49-F238E27FC236}">
-                <a16:creationId xmlns:a16="http://schemas.microsoft.com/office/drawing/2014/main" id="{F293E2F9-963C-468E-B39C-C0FE9B8B7717}"/>
+                <a16:creationId xmlns:a16="http://schemas.microsoft.com/office/drawing/2014/main" id="{4E2D8C1C-C6BC-4EE3-BB28-85F3AB4B0F5D}"/>
               </a:ext>
             </a:extLst>
           </p:cNvPr>
@@ -10025,7 +12459,18 @@
           <a:bodyPr xmlns:a="http://schemas.openxmlformats.org/drawingml/2006/main" anchor="t">
             <a:noAutofit/>
           </a:bodyPr>
-          <a:lstStyle xmlns:a="http://schemas.openxmlformats.org/drawingml/2006/main"/>
+          <a:lstStyle xmlns:a="http://schemas.openxmlformats.org/drawingml/2006/main">
+            <a:defPPr>
+              <a:defRPr sz="1800" b="0">
+                <a:solidFill>
+                  <a:srgbClr val="213744"/>
+                </a:solidFill>
+                <a:latin typeface="Arial"/>
+                <a:ea typeface="Arial"/>
+                <a:cs typeface="Arial"/>
+              </a:defRPr>
+            </a:defPPr>
+          </a:lstStyle>
           <a:p xmlns:a="http://schemas.openxmlformats.org/drawingml/2006/main">
             <a:pPr>
               <a:defRPr sz="1800" b="0">
@@ -10056,7 +12501,7 @@
           <p:cNvPr id="8" name="">
             <a:extLst xmlns:a="http://schemas.openxmlformats.org/drawingml/2006/main">
               <a:ext uri="{FF2B5EF4-FFF2-40B4-BE49-F238E27FC236}">
-                <a16:creationId xmlns:a16="http://schemas.microsoft.com/office/drawing/2014/main" id="{8AEB2282-640A-46FB-8182-B21587C78532}"/>
+                <a16:creationId xmlns:a16="http://schemas.microsoft.com/office/drawing/2014/main" id="{F024C352-014E-4C70-BF26-0543EEF606AF}"/>
               </a:ext>
             </a:extLst>
           </p:cNvPr>
@@ -10086,7 +12531,18 @@
           <a:bodyPr xmlns:a="http://schemas.openxmlformats.org/drawingml/2006/main" anchor="t">
             <a:noAutofit/>
           </a:bodyPr>
-          <a:lstStyle xmlns:a="http://schemas.openxmlformats.org/drawingml/2006/main"/>
+          <a:lstStyle xmlns:a="http://schemas.openxmlformats.org/drawingml/2006/main">
+            <a:defPPr>
+              <a:defRPr sz="1350" b="0">
+                <a:solidFill>
+                  <a:srgbClr val="526B79"/>
+                </a:solidFill>
+                <a:latin typeface="Arial"/>
+                <a:ea typeface="Arial"/>
+                <a:cs typeface="Arial"/>
+              </a:defRPr>
+            </a:defPPr>
+          </a:lstStyle>
           <a:p xmlns:a="http://schemas.openxmlformats.org/drawingml/2006/main">
             <a:pPr>
               <a:defRPr sz="1350" b="0">
@@ -10115,7 +12571,7 @@
     </p:spTree>
     <p:extLst>
       <p:ext uri="{BB962C8B-B14F-4D97-AF65-F5344CB8AC3E}">
-        <p14:creationId xmlns:p14="http://schemas.microsoft.com/office/powerpoint/2010/main" val="1544593935"/>
+        <p14:creationId xmlns:p14="http://schemas.microsoft.com/office/powerpoint/2010/main" val="1721608692"/>
       </p:ext>
     </p:extLst>
   </p:cSld>
@@ -10163,16 +12619,16 @@
         <a:srgbClr val="96607D"/>
       </a:folHlink>
     </a:clrScheme>
-    <a:fontScheme name="Office">
+    <a:fontScheme name="">
       <a:majorFont>
-        <a:latin typeface="Calibri Light"/>
-        <a:ea typeface="Calibri Light"/>
-        <a:cs typeface="Calibri Light"/>
+        <a:latin typeface="Aptos"/>
+        <a:ea typeface=""/>
+        <a:cs typeface=""/>
       </a:majorFont>
       <a:minorFont>
-        <a:latin typeface="Calibri"/>
-        <a:ea typeface="Calibri"/>
-        <a:cs typeface="Calibri"/>
+        <a:latin typeface="Aptos"/>
+        <a:ea typeface=""/>
+        <a:cs typeface=""/>
       </a:minorFont>
     </a:fontScheme>
     <a:fmtScheme name="ChatGPT">

</xml_diff>

<commit_message>
Deliver local split-candidate assessment and verified repair evidence
</commit_message>
<xml_diff>
--- a/extras/usd/examples/usdGeospatialBuild/delivery/geospatial-build.pptx
+++ b/extras/usd/examples/usdGeospatialBuild/delivery/geospatial-build.pptx
@@ -2,26 +2,26 @@
 <file path=ppt/presentation.xml><?xml version="1.0" encoding="utf-8"?>
 <p:presentation xmlns:p="http://schemas.openxmlformats.org/presentationml/2006/main">
   <p:sldMasterIdLst>
-    <p:sldMasterId xmlns:r="http://schemas.openxmlformats.org/officeDocument/2006/relationships" id="2147483648" r:id="R03740ff4bb0e4a2e"/>
+    <p:sldMasterId xmlns:r="http://schemas.openxmlformats.org/officeDocument/2006/relationships" id="2147483648" r:id="Rdb7e2e0cc0f74f48"/>
   </p:sldMasterIdLst>
   <p:notesMasterIdLst>
-    <p:notesMasterId xmlns:r="http://schemas.openxmlformats.org/officeDocument/2006/relationships" r:id="Rcebec120b52b408f"/>
+    <p:notesMasterId xmlns:r="http://schemas.openxmlformats.org/officeDocument/2006/relationships" r:id="R040f136531de4a88"/>
   </p:notesMasterIdLst>
   <p:sldIdLst>
-    <p:sldId xmlns:r="http://schemas.openxmlformats.org/officeDocument/2006/relationships" id="256" r:id="Rc336eeb4ab154cb7"/>
-    <p:sldId xmlns:r="http://schemas.openxmlformats.org/officeDocument/2006/relationships" id="257" r:id="R530cc6729af3476f"/>
-    <p:sldId xmlns:r="http://schemas.openxmlformats.org/officeDocument/2006/relationships" id="258" r:id="R4c868b37a97a46b6"/>
-    <p:sldId xmlns:r="http://schemas.openxmlformats.org/officeDocument/2006/relationships" id="259" r:id="R42cefb046e254832"/>
-    <p:sldId xmlns:r="http://schemas.openxmlformats.org/officeDocument/2006/relationships" id="260" r:id="R630202b3d46b4c4d"/>
-    <p:sldId xmlns:r="http://schemas.openxmlformats.org/officeDocument/2006/relationships" id="261" r:id="R4334d98dc21d41e8"/>
-    <p:sldId xmlns:r="http://schemas.openxmlformats.org/officeDocument/2006/relationships" id="262" r:id="R0880b9c5649743a4"/>
-    <p:sldId xmlns:r="http://schemas.openxmlformats.org/officeDocument/2006/relationships" id="263" r:id="R7ca3e0a0e81d4017"/>
-    <p:sldId xmlns:r="http://schemas.openxmlformats.org/officeDocument/2006/relationships" id="264" r:id="Rf0815b3a734248e1"/>
-    <p:sldId xmlns:r="http://schemas.openxmlformats.org/officeDocument/2006/relationships" id="265" r:id="R8cc4889ab0bb4c16"/>
-    <p:sldId xmlns:r="http://schemas.openxmlformats.org/officeDocument/2006/relationships" id="266" r:id="R7cb2d114c0f44b93"/>
-    <p:sldId xmlns:r="http://schemas.openxmlformats.org/officeDocument/2006/relationships" id="267" r:id="R57259f88cb5e4f0c"/>
-    <p:sldId xmlns:r="http://schemas.openxmlformats.org/officeDocument/2006/relationships" id="268" r:id="R3d73954d34c44e59"/>
-    <p:sldId xmlns:r="http://schemas.openxmlformats.org/officeDocument/2006/relationships" id="269" r:id="R898cdd03f6c34f21"/>
+    <p:sldId xmlns:r="http://schemas.openxmlformats.org/officeDocument/2006/relationships" id="256" r:id="R97802bcd5ce04758"/>
+    <p:sldId xmlns:r="http://schemas.openxmlformats.org/officeDocument/2006/relationships" id="257" r:id="Rbfd173ff249e4525"/>
+    <p:sldId xmlns:r="http://schemas.openxmlformats.org/officeDocument/2006/relationships" id="258" r:id="R99a4a70af04f4271"/>
+    <p:sldId xmlns:r="http://schemas.openxmlformats.org/officeDocument/2006/relationships" id="259" r:id="R90ea7b0f14d44179"/>
+    <p:sldId xmlns:r="http://schemas.openxmlformats.org/officeDocument/2006/relationships" id="260" r:id="R0fe1607c7ea646ba"/>
+    <p:sldId xmlns:r="http://schemas.openxmlformats.org/officeDocument/2006/relationships" id="261" r:id="R6ecd547532664220"/>
+    <p:sldId xmlns:r="http://schemas.openxmlformats.org/officeDocument/2006/relationships" id="262" r:id="R75eb8b4bfe754741"/>
+    <p:sldId xmlns:r="http://schemas.openxmlformats.org/officeDocument/2006/relationships" id="263" r:id="R4060aa22fcc84108"/>
+    <p:sldId xmlns:r="http://schemas.openxmlformats.org/officeDocument/2006/relationships" id="264" r:id="Ra9b805987d6e4d05"/>
+    <p:sldId xmlns:r="http://schemas.openxmlformats.org/officeDocument/2006/relationships" id="265" r:id="Rf4ec0743b14e4da1"/>
+    <p:sldId xmlns:r="http://schemas.openxmlformats.org/officeDocument/2006/relationships" id="266" r:id="R1c2206ef310c4212"/>
+    <p:sldId xmlns:r="http://schemas.openxmlformats.org/officeDocument/2006/relationships" id="267" r:id="R0142330e72d94e4c"/>
+    <p:sldId xmlns:r="http://schemas.openxmlformats.org/officeDocument/2006/relationships" id="268" r:id="R4d28be993475403c"/>
+    <p:sldId xmlns:r="http://schemas.openxmlformats.org/officeDocument/2006/relationships" id="269" r:id="Rb04c1697162b446f"/>
   </p:sldIdLst>
   <p:sldSz cx="12192000" cy="6858000"/>
   <p:notesSz cx="6858000" cy="9144000"/>
@@ -455,7 +455,7 @@
           <a:lstStyle xmlns:a="http://schemas.openxmlformats.org/drawingml/2006/main"/>
           <a:p xmlns:a="http://schemas.openxmlformats.org/drawingml/2006/main">
             <a:r>
-              <a:t>{"section":"Assessment of the proposal","status":[["Proposal definitions","The candidate specifies inputs and evaluation rules for the displayed cases. Detailed choices still need group review."],["Newly confirmed model gap","This audit established no additional data-model blocker. It does not establish an exhaustive search for missing meaning."],["Implementation evidence","The selected cases work. 7 later audit issues remain failed or unverified."],["Deferred capabilities","Coordinate epochs and scene-authored transformation resources remain on the roadmap. Initial choices must preserve a path to adding them."]]}</a:t>
+              <a:t>{"section":"Assessment of the proposal","status":[["Proposal definitions","A focused requirements baseline is separate from the full candidate used for execution. Supported meaning and pending conventions are distinguished."],["Newly confirmed model gap","No additional undefined model rule was confirmed in reviewed paths. This is a scoped assessment, not an exhaustive completeness proof."],["Implementation evidence","The selected cases work. 6 prior defects pass fresh counterexamples; 1 remains unresolved."],["Deferred capabilities","Coordinate epochs and scene-authored transformation resources remain on the roadmap. Initial choices must preserve a path to adding them."]]}</a:t>
             </a:r>
           </a:p>
           <a:p xmlns:a="http://schemas.openxmlformats.org/drawingml/2006/main">
@@ -465,27 +465,27 @@
           </a:p>
           <a:p xmlns:a="http://schemas.openxmlformats.org/drawingml/2006/main">
             <a:r>
-              <a:t>README SHA-256 516b20d0c5b90558e7659c4ca71b2f2741d929c1a41d2427ac823f265f49b730</a:t>
-            </a:r>
-          </a:p>
-          <a:p xmlns:a="http://schemas.openxmlformats.org/drawingml/2006/main">
-            <a:r>
-              <a:t>Proposal SHA-256 02323339203777b80b0bf8969f2392a4663b78be29e88f26f859df376999774a</a:t>
-            </a:r>
-          </a:p>
-          <a:p xmlns:a="http://schemas.openxmlformats.org/drawingml/2006/main">
-            <a:r>
-              <a:t>Immutable execution receipt SHA-256 4f212b53f00cd7f31bae7b94ea63e6a4b99e3a9cf9e645b2989e888a51ceecbf</a:t>
-            </a:r>
-          </a:p>
-          <a:p xmlns:a="http://schemas.openxmlformats.org/drawingml/2006/main">
-            <a:r>
-              <a:t>Later audit SHA-256 75abc802636f2e337b6fda2002b14f4ddf89f434901bae4a034734403f73e35f</a:t>
-            </a:r>
-          </a:p>
-          <a:p xmlns:a="http://schemas.openxmlformats.org/drawingml/2006/main">
-            <a:r>
-              <a:t>Fresh October 7 execution of the merged proposal candidate, compared with the prior immutable run and followed by repeated independent diagnostics. No runtime implementation repairs.</a:t>
+              <a:t>README SHA-256 708a3b5c2d26a82e32e7ec3c381c2ebb7cda8274fd4567709f98d76d85ca8f6c</a:t>
+            </a:r>
+          </a:p>
+          <a:p xmlns:a="http://schemas.openxmlformats.org/drawingml/2006/main">
+            <a:r>
+              <a:t>Proposal SHA-256 28768109389139a56d5c8e5f473446bfa46dd1ab46a48924165b97fb92cb7ae9</a:t>
+            </a:r>
+          </a:p>
+          <a:p xmlns:a="http://schemas.openxmlformats.org/drawingml/2006/main">
+            <a:r>
+              <a:t>Immutable execution receipt SHA-256 b12019e039ab52f930fb2f4321ca2289875bcdefbd3dbbd669b72a8689647e46</a:t>
+            </a:r>
+          </a:p>
+          <a:p xmlns:a="http://schemas.openxmlformats.org/drawingml/2006/main">
+            <a:r>
+              <a:t>Later audit SHA-256 e7e5278ba30509b5a3e94196ffdb6d59aaa54eadacae97022f6ffab098d94a9a</a:t>
+            </a:r>
+          </a:p>
+          <a:p xmlns:a="http://schemas.openxmlformats.org/drawingml/2006/main">
+            <a:r>
+              <a:t>Fresh October 8 execution of the local stacked follow-up, with clause-traced adapter repairs and repeated independent diagnostics. No changes have been published.</a:t>
             </a:r>
           </a:p>
           <a:p xmlns:a="http://schemas.openxmlformats.org/drawingml/2006/main">
@@ -590,12 +590,12 @@
           </a:p>
           <a:p xmlns:a="http://schemas.openxmlformats.org/drawingml/2006/main">
             <a:r>
-              <a:t>Proposal: ### External measurement association at proposal/proposal-source.txt:1594</a:t>
-            </a:r>
-          </a:p>
-          <a:p xmlns:a="http://schemas.openxmlformats.org/drawingml/2006/main">
-            <a:r>
-              <a:t>Functional requirements: [{"id":8,"title":"Brought-in data keeps its coordinates and its CRS.","line":746},{"id":12,"title":"No angle read as a length.","line":826},{"id":19,"title":"Resolution leaves the scene as authored.","line":930},{"id":21,"title":"Never placed by a guess.","line":966}]</a:t>
+              <a:t>Proposal: ### External measurement association at proposal/proposal-source.txt:1610</a:t>
+            </a:r>
+          </a:p>
+          <a:p xmlns:a="http://schemas.openxmlformats.org/drawingml/2006/main">
+            <a:r>
+              <a:t>Functional requirements: [{"id":8,"title":"Brought-in data keeps its coordinates and its CRS.","line":751},{"id":12,"title":"No angle read as a length.","line":831},{"id":19,"title":"Resolution leaves the scene as authored.","line":932},{"id":21,"title":"Never placed by a guess.","line":968}]</a:t>
             </a:r>
           </a:p>
           <a:p xmlns:a="http://schemas.openxmlformats.org/drawingml/2006/main">
@@ -610,27 +610,27 @@
           </a:p>
           <a:p xmlns:a="http://schemas.openxmlformats.org/drawingml/2006/main">
             <a:r>
-              <a:t>README SHA-256 516b20d0c5b90558e7659c4ca71b2f2741d929c1a41d2427ac823f265f49b730</a:t>
-            </a:r>
-          </a:p>
-          <a:p xmlns:a="http://schemas.openxmlformats.org/drawingml/2006/main">
-            <a:r>
-              <a:t>Proposal SHA-256 02323339203777b80b0bf8969f2392a4663b78be29e88f26f859df376999774a</a:t>
-            </a:r>
-          </a:p>
-          <a:p xmlns:a="http://schemas.openxmlformats.org/drawingml/2006/main">
-            <a:r>
-              <a:t>Immutable execution receipt SHA-256 4f212b53f00cd7f31bae7b94ea63e6a4b99e3a9cf9e645b2989e888a51ceecbf</a:t>
-            </a:r>
-          </a:p>
-          <a:p xmlns:a="http://schemas.openxmlformats.org/drawingml/2006/main">
-            <a:r>
-              <a:t>Later audit SHA-256 75abc802636f2e337b6fda2002b14f4ddf89f434901bae4a034734403f73e35f</a:t>
-            </a:r>
-          </a:p>
-          <a:p xmlns:a="http://schemas.openxmlformats.org/drawingml/2006/main">
-            <a:r>
-              <a:t>Fresh October 7 execution of the merged proposal candidate, compared with the prior immutable run and followed by repeated independent diagnostics. No runtime implementation repairs.</a:t>
+              <a:t>README SHA-256 708a3b5c2d26a82e32e7ec3c381c2ebb7cda8274fd4567709f98d76d85ca8f6c</a:t>
+            </a:r>
+          </a:p>
+          <a:p xmlns:a="http://schemas.openxmlformats.org/drawingml/2006/main">
+            <a:r>
+              <a:t>Proposal SHA-256 28768109389139a56d5c8e5f473446bfa46dd1ab46a48924165b97fb92cb7ae9</a:t>
+            </a:r>
+          </a:p>
+          <a:p xmlns:a="http://schemas.openxmlformats.org/drawingml/2006/main">
+            <a:r>
+              <a:t>Immutable execution receipt SHA-256 b12019e039ab52f930fb2f4321ca2289875bcdefbd3dbbd669b72a8689647e46</a:t>
+            </a:r>
+          </a:p>
+          <a:p xmlns:a="http://schemas.openxmlformats.org/drawingml/2006/main">
+            <a:r>
+              <a:t>Later audit SHA-256 e7e5278ba30509b5a3e94196ffdb6d59aaa54eadacae97022f6ffab098d94a9a</a:t>
+            </a:r>
+          </a:p>
+          <a:p xmlns:a="http://schemas.openxmlformats.org/drawingml/2006/main">
+            <a:r>
+              <a:t>Fresh October 8 execution of the local stacked follow-up, with clause-traced adapter repairs and repeated independent diagnostics. No changes have been published.</a:t>
             </a:r>
           </a:p>
           <a:p xmlns:a="http://schemas.openxmlformats.org/drawingml/2006/main">
@@ -735,12 +735,12 @@
           </a:p>
           <a:p xmlns:a="http://schemas.openxmlformats.org/drawingml/2006/main">
             <a:r>
-              <a:t>Proposal: #### Evaluation at proposal/proposal-source.txt:1887</a:t>
-            </a:r>
-          </a:p>
-          <a:p xmlns:a="http://schemas.openxmlformats.org/drawingml/2006/main">
-            <a:r>
-              <a:t>Functional requirements: [{"id":20,"title":"Positions between recorded moments.","line":949},{"id":29,"title":"Implementable from the text alone.","line":1106}]</a:t>
+              <a:t>Proposal: #### Evaluation at proposal/proposal-source.txt:1910</a:t>
+            </a:r>
+          </a:p>
+          <a:p xmlns:a="http://schemas.openxmlformats.org/drawingml/2006/main">
+            <a:r>
+              <a:t>Functional requirements: [{"id":20,"title":"Positions between recorded moments.","line":951},{"id":29,"title":"Implementable from the text alone.","line":1117}]</a:t>
             </a:r>
           </a:p>
           <a:p xmlns:a="http://schemas.openxmlformats.org/drawingml/2006/main">
@@ -755,27 +755,27 @@
           </a:p>
           <a:p xmlns:a="http://schemas.openxmlformats.org/drawingml/2006/main">
             <a:r>
-              <a:t>README SHA-256 516b20d0c5b90558e7659c4ca71b2f2741d929c1a41d2427ac823f265f49b730</a:t>
-            </a:r>
-          </a:p>
-          <a:p xmlns:a="http://schemas.openxmlformats.org/drawingml/2006/main">
-            <a:r>
-              <a:t>Proposal SHA-256 02323339203777b80b0bf8969f2392a4663b78be29e88f26f859df376999774a</a:t>
-            </a:r>
-          </a:p>
-          <a:p xmlns:a="http://schemas.openxmlformats.org/drawingml/2006/main">
-            <a:r>
-              <a:t>Immutable execution receipt SHA-256 4f212b53f00cd7f31bae7b94ea63e6a4b99e3a9cf9e645b2989e888a51ceecbf</a:t>
-            </a:r>
-          </a:p>
-          <a:p xmlns:a="http://schemas.openxmlformats.org/drawingml/2006/main">
-            <a:r>
-              <a:t>Later audit SHA-256 75abc802636f2e337b6fda2002b14f4ddf89f434901bae4a034734403f73e35f</a:t>
-            </a:r>
-          </a:p>
-          <a:p xmlns:a="http://schemas.openxmlformats.org/drawingml/2006/main">
-            <a:r>
-              <a:t>Fresh October 7 execution of the merged proposal candidate, compared with the prior immutable run and followed by repeated independent diagnostics. No runtime implementation repairs.</a:t>
+              <a:t>README SHA-256 708a3b5c2d26a82e32e7ec3c381c2ebb7cda8274fd4567709f98d76d85ca8f6c</a:t>
+            </a:r>
+          </a:p>
+          <a:p xmlns:a="http://schemas.openxmlformats.org/drawingml/2006/main">
+            <a:r>
+              <a:t>Proposal SHA-256 28768109389139a56d5c8e5f473446bfa46dd1ab46a48924165b97fb92cb7ae9</a:t>
+            </a:r>
+          </a:p>
+          <a:p xmlns:a="http://schemas.openxmlformats.org/drawingml/2006/main">
+            <a:r>
+              <a:t>Immutable execution receipt SHA-256 b12019e039ab52f930fb2f4321ca2289875bcdefbd3dbbd669b72a8689647e46</a:t>
+            </a:r>
+          </a:p>
+          <a:p xmlns:a="http://schemas.openxmlformats.org/drawingml/2006/main">
+            <a:r>
+              <a:t>Later audit SHA-256 e7e5278ba30509b5a3e94196ffdb6d59aaa54eadacae97022f6ffab098d94a9a</a:t>
+            </a:r>
+          </a:p>
+          <a:p xmlns:a="http://schemas.openxmlformats.org/drawingml/2006/main">
+            <a:r>
+              <a:t>Fresh October 8 execution of the local stacked follow-up, with clause-traced adapter repairs and repeated independent diagnostics. No changes have been published.</a:t>
             </a:r>
           </a:p>
           <a:p xmlns:a="http://schemas.openxmlformats.org/drawingml/2006/main">
@@ -850,37 +850,37 @@
           <a:lstStyle xmlns:a="http://schemas.openxmlformats.org/drawingml/2006/main"/>
           <a:p xmlns:a="http://schemas.openxmlformats.org/drawingml/2006/main">
             <a:r>
-              <a:t>{"section":"Proposed choices awaiting agreement","status":[["Proposal definitions","The candidate specifies inputs and evaluation rules for the displayed cases. Detailed choices still need group review."],["Newly confirmed model gap","This audit established no additional data-model blocker. It does not establish an exhaustive search for missing meaning."],["Implementation evidence","The selected cases work. 7 later audit issues remain failed or unverified."],["Deferred capabilities","Coordinate epochs and scene-authored transformation resources remain on the roadmap. Initial choices must preserve a path to adding them."]]}</a:t>
-            </a:r>
-          </a:p>
-          <a:p xmlns:a="http://schemas.openxmlformats.org/drawingml/2006/main">
-            <a:r>
-              <a:t>[["Physical orientation","Record model orientation relative to local east, north and up. A different map projection does not redefine it."],["The object with its own georeference","Its ordinary scale, rotation and translation adjust placed geometry in a fixed project frame."],["Child objects","Child transforms define model-local geometry. Their offsets follow model axes instead of being silently reinterpreted as map axes."],["Independently georeferenced repeated models","Keep a prototype's own geographic placement and apply each instance effect once."],["Geographic queries and scene geometry","Return longitude/latitude/height for geographic queries. Cartesian geometry and bounds use the datum's Earth-centred frame."]]</a:t>
-            </a:r>
-          </a:p>
-          <a:p xmlns:a="http://schemas.openxmlformats.org/drawingml/2006/main">
-            <a:r>
-              <a:t>README SHA-256 516b20d0c5b90558e7659c4ca71b2f2741d929c1a41d2427ac823f265f49b730</a:t>
-            </a:r>
-          </a:p>
-          <a:p xmlns:a="http://schemas.openxmlformats.org/drawingml/2006/main">
-            <a:r>
-              <a:t>Proposal SHA-256 02323339203777b80b0bf8969f2392a4663b78be29e88f26f859df376999774a</a:t>
-            </a:r>
-          </a:p>
-          <a:p xmlns:a="http://schemas.openxmlformats.org/drawingml/2006/main">
-            <a:r>
-              <a:t>Immutable execution receipt SHA-256 4f212b53f00cd7f31bae7b94ea63e6a4b99e3a9cf9e645b2989e888a51ceecbf</a:t>
-            </a:r>
-          </a:p>
-          <a:p xmlns:a="http://schemas.openxmlformats.org/drawingml/2006/main">
-            <a:r>
-              <a:t>Later audit SHA-256 75abc802636f2e337b6fda2002b14f4ddf89f434901bae4a034734403f73e35f</a:t>
-            </a:r>
-          </a:p>
-          <a:p xmlns:a="http://schemas.openxmlformats.org/drawingml/2006/main">
-            <a:r>
-              <a:t>Fresh October 7 execution of the merged proposal candidate, compared with the prior immutable run and followed by repeated independent diagnostics. No runtime implementation repairs.</a:t>
+              <a:t>{"section":"Proposed choices awaiting agreement","status":[["Proposal definitions","A focused requirements baseline is separate from the full candidate used for execution. Supported meaning and pending conventions are distinguished."],["Newly confirmed model gap","No additional undefined model rule was confirmed in reviewed paths. This is a scoped assessment, not an exhaustive completeness proof."],["Implementation evidence","The selected cases work. 6 prior defects pass fresh counterexamples; 1 remains unresolved."],["Deferred capabilities","Coordinate epochs and scene-authored transformation resources remain on the roadmap. Initial choices must preserve a path to adding them."]]}</a:t>
+            </a:r>
+          </a:p>
+          <a:p xmlns:a="http://schemas.openxmlformats.org/drawingml/2006/main">
+            <a:r>
+              <a:t>[["Physical orientation","Input-only meaning is supported. Stored quaternion versus one heading/pitch/roll tuple and its interpolation need review."],["The object with its own georeference","Project adjustment meaning is supported. The detailed fixed working-frame convention remains a candidate."],["Child objects","Model-local meaning is supported. The follow-up specifies chart/reset details and tests that offsets retain their interpretation."],["Independently georeferenced repeated models","Keep a prototype's own geographic placement and apply each instance effect once."],["Geographic queries and scene geometry","Return longitude/latitude/height for geographic queries. Cartesian geometry and bounds use the datum's Earth-centred frame."]]</a:t>
+            </a:r>
+          </a:p>
+          <a:p xmlns:a="http://schemas.openxmlformats.org/drawingml/2006/main">
+            <a:r>
+              <a:t>README SHA-256 708a3b5c2d26a82e32e7ec3c381c2ebb7cda8274fd4567709f98d76d85ca8f6c</a:t>
+            </a:r>
+          </a:p>
+          <a:p xmlns:a="http://schemas.openxmlformats.org/drawingml/2006/main">
+            <a:r>
+              <a:t>Proposal SHA-256 28768109389139a56d5c8e5f473446bfa46dd1ab46a48924165b97fb92cb7ae9</a:t>
+            </a:r>
+          </a:p>
+          <a:p xmlns:a="http://schemas.openxmlformats.org/drawingml/2006/main">
+            <a:r>
+              <a:t>Immutable execution receipt SHA-256 b12019e039ab52f930fb2f4321ca2289875bcdefbd3dbbd669b72a8689647e46</a:t>
+            </a:r>
+          </a:p>
+          <a:p xmlns:a="http://schemas.openxmlformats.org/drawingml/2006/main">
+            <a:r>
+              <a:t>Later audit SHA-256 e7e5278ba30509b5a3e94196ffdb6d59aaa54eadacae97022f6ffab098d94a9a</a:t>
+            </a:r>
+          </a:p>
+          <a:p xmlns:a="http://schemas.openxmlformats.org/drawingml/2006/main">
+            <a:r>
+              <a:t>Fresh October 8 execution of the local stacked follow-up, with clause-traced adapter repairs and repeated independent diagnostics. No changes have been published.</a:t>
             </a:r>
           </a:p>
           <a:p xmlns:a="http://schemas.openxmlformats.org/drawingml/2006/main">
@@ -955,37 +955,37 @@
           <a:lstStyle xmlns:a="http://schemas.openxmlformats.org/drawingml/2006/main"/>
           <a:p xmlns:a="http://schemas.openxmlformats.org/drawingml/2006/main">
             <a:r>
-              <a:t>{"section":"Proposed choices awaiting agreement","status":[["Proposal definitions","The candidate specifies inputs and evaluation rules for the displayed cases. Detailed choices still need group review."],["Newly confirmed model gap","This audit established no additional data-model blocker. It does not establish an exhaustive search for missing meaning."],["Implementation evidence","The selected cases work. 7 later audit issues remain failed or unverified."],["Deferred capabilities","Coordinate epochs and scene-authored transformation resources remain on the roadmap. Initial choices must preserve a path to adding them."]]}</a:t>
-            </a:r>
-          </a:p>
-          <a:p xmlns:a="http://schemas.openxmlformats.org/drawingml/2006/main">
-            <a:r>
-              <a:t>[["Native data association","Name the asset, format, field and coordinate domain. Preserve the association between values, locations and observation times."],["WKT string normalization","A prescribed text form supports token comparison. Different normalized texts can still describe equivalent CRSs."],["Semantic CRS comparison","Specify equivalence criteria and the comparison domain, accounting for relevant axes, units and metadata."],["Dependency declaration using Profiles","Declare the composed scene's need for geospatial interpretation, including unloaded content. Writers and assemblers maintain the declaration."],["Baked output context","Keep a Cartesian CRS context without an active placement binding, so readers do not apply georeferencing a second time."]]</a:t>
-            </a:r>
-          </a:p>
-          <a:p xmlns:a="http://schemas.openxmlformats.org/drawingml/2006/main">
-            <a:r>
-              <a:t>README SHA-256 516b20d0c5b90558e7659c4ca71b2f2741d929c1a41d2427ac823f265f49b730</a:t>
-            </a:r>
-          </a:p>
-          <a:p xmlns:a="http://schemas.openxmlformats.org/drawingml/2006/main">
-            <a:r>
-              <a:t>Proposal SHA-256 02323339203777b80b0bf8969f2392a4663b78be29e88f26f859df376999774a</a:t>
-            </a:r>
-          </a:p>
-          <a:p xmlns:a="http://schemas.openxmlformats.org/drawingml/2006/main">
-            <a:r>
-              <a:t>Immutable execution receipt SHA-256 4f212b53f00cd7f31bae7b94ea63e6a4b99e3a9cf9e645b2989e888a51ceecbf</a:t>
-            </a:r>
-          </a:p>
-          <a:p xmlns:a="http://schemas.openxmlformats.org/drawingml/2006/main">
-            <a:r>
-              <a:t>Later audit SHA-256 75abc802636f2e337b6fda2002b14f4ddf89f434901bae4a034734403f73e35f</a:t>
-            </a:r>
-          </a:p>
-          <a:p xmlns:a="http://schemas.openxmlformats.org/drawingml/2006/main">
-            <a:r>
-              <a:t>Fresh October 7 execution of the merged proposal candidate, compared with the prior immutable run and followed by repeated independent diagnostics. No runtime implementation repairs.</a:t>
+              <a:t>{"section":"Proposed choices awaiting agreement","status":[["Proposal definitions","A focused requirements baseline is separate from the full candidate used for execution. Supported meaning and pending conventions are distinguished."],["Newly confirmed model gap","No additional undefined model rule was confirmed in reviewed paths. This is a scoped assessment, not an exhaustive completeness proof."],["Implementation evidence","The selected cases work. 6 prior defects pass fresh counterexamples; 1 remains unresolved."],["Deferred capabilities","Coordinate epochs and scene-authored transformation resources remain on the roadmap. Initial choices must preserve a path to adding them."]]}</a:t>
+            </a:r>
+          </a:p>
+          <a:p xmlns:a="http://schemas.openxmlformats.org/drawingml/2006/main">
+            <a:r>
+              <a:t>[["Native data association","Name the asset, format, field and coordinate domain. Preserve the association between values, locations and observation times."],["WKT string normalization","A prescribed text form supports token comparison. Different normalized texts can still describe equivalent CRSs."],["Semantic CRS comparison","Specify equivalence criteria and the comparison domain, accounting for relevant axes, units and metadata."],["Dependency declaration using Profiles","Declare the composed scene's need for geospatial interpretation, including unloaded content. Writers and assemblers maintain the declaration."],["Baked output context","Record a Cartesian CRS and ordinary double-precision origin. Preserve precision and space/time coverage."]]</a:t>
+            </a:r>
+          </a:p>
+          <a:p xmlns:a="http://schemas.openxmlformats.org/drawingml/2006/main">
+            <a:r>
+              <a:t>README SHA-256 708a3b5c2d26a82e32e7ec3c381c2ebb7cda8274fd4567709f98d76d85ca8f6c</a:t>
+            </a:r>
+          </a:p>
+          <a:p xmlns:a="http://schemas.openxmlformats.org/drawingml/2006/main">
+            <a:r>
+              <a:t>Proposal SHA-256 28768109389139a56d5c8e5f473446bfa46dd1ab46a48924165b97fb92cb7ae9</a:t>
+            </a:r>
+          </a:p>
+          <a:p xmlns:a="http://schemas.openxmlformats.org/drawingml/2006/main">
+            <a:r>
+              <a:t>Immutable execution receipt SHA-256 b12019e039ab52f930fb2f4321ca2289875bcdefbd3dbbd669b72a8689647e46</a:t>
+            </a:r>
+          </a:p>
+          <a:p xmlns:a="http://schemas.openxmlformats.org/drawingml/2006/main">
+            <a:r>
+              <a:t>Later audit SHA-256 e7e5278ba30509b5a3e94196ffdb6d59aaa54eadacae97022f6ffab098d94a9a</a:t>
+            </a:r>
+          </a:p>
+          <a:p xmlns:a="http://schemas.openxmlformats.org/drawingml/2006/main">
+            <a:r>
+              <a:t>Fresh October 8 execution of the local stacked follow-up, with clause-traced adapter repairs and repeated independent diagnostics. No changes have been published.</a:t>
             </a:r>
           </a:p>
           <a:p xmlns:a="http://schemas.openxmlformats.org/drawingml/2006/main">
@@ -1060,37 +1060,37 @@
           <a:lstStyle xmlns:a="http://schemas.openxmlformats.org/drawingml/2006/main"/>
           <a:p xmlns:a="http://schemas.openxmlformats.org/drawingml/2006/main">
             <a:r>
-              <a:t>{"section":"Detailed evidence","status":[["Proposal definitions","The candidate specifies inputs and evaluation rules for the displayed cases. Detailed choices still need group review."],["Newly confirmed model gap","This audit established no additional data-model blocker. It does not establish an exhaustive search for missing meaning."],["Implementation evidence","The selected cases work. 7 later audit issues remain failed or unverified."],["Deferred capabilities","Coordinate epochs and scene-authored transformation resources remain on the roadmap. Initial choices must preserve a path to adding them."]]}</a:t>
-            </a:r>
-          </a:p>
-          <a:p xmlns:a="http://schemas.openxmlformats.org/drawingml/2006/main">
-            <a:r>
-              <a:t>[["Python and C++ readers","213,231 coordinate results per reader. Maximum measured difference 3.39e-08 m. They share PROJ and native dataset decoding."],["Omniverse stage geometry integration","Reuses Python placement. Recorded readback covers 177,864 geometry vertices and 36 edit, failure and recovery checks, across 35 jobs."],["Hydra / Storm","Two selected ordinary USD bakes reach native rendering. This consumer path uses the C++ placement results."],["Recorded tests","64 regressions and 61 distinguishing controls passed. The later audit exposes cases the suite missed."],["Source preservation","Original inputs and all frozen execution files remained unchanged during this run. The immutable receipt identifies the exact executed content."],["Bake readbacks","11 selected exports were checked. The later nested-geometry case demonstrates that the original inventory check was incomplete."]]</a:t>
-            </a:r>
-          </a:p>
-          <a:p xmlns:a="http://schemas.openxmlformats.org/drawingml/2006/main">
-            <a:r>
-              <a:t>README SHA-256 516b20d0c5b90558e7659c4ca71b2f2741d929c1a41d2427ac823f265f49b730</a:t>
-            </a:r>
-          </a:p>
-          <a:p xmlns:a="http://schemas.openxmlformats.org/drawingml/2006/main">
-            <a:r>
-              <a:t>Proposal SHA-256 02323339203777b80b0bf8969f2392a4663b78be29e88f26f859df376999774a</a:t>
-            </a:r>
-          </a:p>
-          <a:p xmlns:a="http://schemas.openxmlformats.org/drawingml/2006/main">
-            <a:r>
-              <a:t>Immutable execution receipt SHA-256 4f212b53f00cd7f31bae7b94ea63e6a4b99e3a9cf9e645b2989e888a51ceecbf</a:t>
-            </a:r>
-          </a:p>
-          <a:p xmlns:a="http://schemas.openxmlformats.org/drawingml/2006/main">
-            <a:r>
-              <a:t>Later audit SHA-256 75abc802636f2e337b6fda2002b14f4ddf89f434901bae4a034734403f73e35f</a:t>
-            </a:r>
-          </a:p>
-          <a:p xmlns:a="http://schemas.openxmlformats.org/drawingml/2006/main">
-            <a:r>
-              <a:t>Fresh October 7 execution of the merged proposal candidate, compared with the prior immutable run and followed by repeated independent diagnostics. No runtime implementation repairs.</a:t>
+              <a:t>{"section":"Detailed evidence","status":[["Proposal definitions","A focused requirements baseline is separate from the full candidate used for execution. Supported meaning and pending conventions are distinguished."],["Newly confirmed model gap","No additional undefined model rule was confirmed in reviewed paths. This is a scoped assessment, not an exhaustive completeness proof."],["Implementation evidence","The selected cases work. 6 prior defects pass fresh counterexamples; 1 remains unresolved."],["Deferred capabilities","Coordinate epochs and scene-authored transformation resources remain on the roadmap. Initial choices must preserve a path to adding them."]]}</a:t>
+            </a:r>
+          </a:p>
+          <a:p xmlns:a="http://schemas.openxmlformats.org/drawingml/2006/main">
+            <a:r>
+              <a:t>[["Python and C++ readers","213,231 coordinate results per reader. Maximum measured difference 3.39e-08 m. They share PROJ and native dataset decoding."],["Omniverse stage geometry integration","Reuses Python placement. Recorded readback covers 177,864 geometry vertices and 36 edit, failure and recovery checks, across 35 jobs."],["Hydra / Storm","Two selected ordinary USD bakes reach native rendering. This consumer path uses the C++ placement results."],["Recorded tests","70 regressions and 61 distinguishing controls passed. Fresh independent diagnostics verify six repairs and retain the unresolved normal case."],["Source preservation","Original inputs and all frozen execution files remained unchanged during this run. The immutable receipt identifies the exact executed content."],["Bake readbacks","11 selected exports were checked. The fresh nested-geometry counterexample verifies the complete inventory, including unexpected extras."]]</a:t>
+            </a:r>
+          </a:p>
+          <a:p xmlns:a="http://schemas.openxmlformats.org/drawingml/2006/main">
+            <a:r>
+              <a:t>README SHA-256 708a3b5c2d26a82e32e7ec3c381c2ebb7cda8274fd4567709f98d76d85ca8f6c</a:t>
+            </a:r>
+          </a:p>
+          <a:p xmlns:a="http://schemas.openxmlformats.org/drawingml/2006/main">
+            <a:r>
+              <a:t>Proposal SHA-256 28768109389139a56d5c8e5f473446bfa46dd1ab46a48924165b97fb92cb7ae9</a:t>
+            </a:r>
+          </a:p>
+          <a:p xmlns:a="http://schemas.openxmlformats.org/drawingml/2006/main">
+            <a:r>
+              <a:t>Immutable execution receipt SHA-256 b12019e039ab52f930fb2f4321ca2289875bcdefbd3dbbd669b72a8689647e46</a:t>
+            </a:r>
+          </a:p>
+          <a:p xmlns:a="http://schemas.openxmlformats.org/drawingml/2006/main">
+            <a:r>
+              <a:t>Later audit SHA-256 e7e5278ba30509b5a3e94196ffdb6d59aaa54eadacae97022f6ffab098d94a9a</a:t>
+            </a:r>
+          </a:p>
+          <a:p xmlns:a="http://schemas.openxmlformats.org/drawingml/2006/main">
+            <a:r>
+              <a:t>Fresh October 8 execution of the local stacked follow-up, with clause-traced adapter repairs and repeated independent diagnostics. No changes have been published.</a:t>
             </a:r>
           </a:p>
           <a:p xmlns:a="http://schemas.openxmlformats.org/drawingml/2006/main">
@@ -1195,12 +1195,12 @@
           </a:p>
           <a:p xmlns:a="http://schemas.openxmlformats.org/drawingml/2006/main">
             <a:r>
-              <a:t>Proposal: #### Authored properties at proposal/proposal-source.txt:1512</a:t>
-            </a:r>
-          </a:p>
-          <a:p xmlns:a="http://schemas.openxmlformats.org/drawingml/2006/main">
-            <a:r>
-              <a:t>Functional requirements: [{"id":9,"title":"Positions, and offsets from them.","line":772},{"id":10,"title":"Offsets along the axes of their position.","line":790},{"id":12,"title":"No angle read as a length.","line":826},{"id":14,"title":"Scene conventions stay the scene's.","line":857},{"id":15,"title":"Placement separate from conformance.","line":870}]</a:t>
+              <a:t>Proposal: #### Authored properties at proposal/proposal-source.txt:1523</a:t>
+            </a:r>
+          </a:p>
+          <a:p xmlns:a="http://schemas.openxmlformats.org/drawingml/2006/main">
+            <a:r>
+              <a:t>Functional requirements: [{"id":9,"title":"Positions, and offsets from them.","line":777},{"id":10,"title":"Offsets along the axes of their position.","line":795},{"id":12,"title":"No angle read as a length.","line":831},{"id":14,"title":"Scene conventions stay the scene's.","line":857},{"id":15,"title":"Placement separate from conformance.","line":870}]</a:t>
             </a:r>
           </a:p>
           <a:p xmlns:a="http://schemas.openxmlformats.org/drawingml/2006/main">
@@ -1215,27 +1215,27 @@
           </a:p>
           <a:p xmlns:a="http://schemas.openxmlformats.org/drawingml/2006/main">
             <a:r>
-              <a:t>README SHA-256 516b20d0c5b90558e7659c4ca71b2f2741d929c1a41d2427ac823f265f49b730</a:t>
-            </a:r>
-          </a:p>
-          <a:p xmlns:a="http://schemas.openxmlformats.org/drawingml/2006/main">
-            <a:r>
-              <a:t>Proposal SHA-256 02323339203777b80b0bf8969f2392a4663b78be29e88f26f859df376999774a</a:t>
-            </a:r>
-          </a:p>
-          <a:p xmlns:a="http://schemas.openxmlformats.org/drawingml/2006/main">
-            <a:r>
-              <a:t>Immutable execution receipt SHA-256 4f212b53f00cd7f31bae7b94ea63e6a4b99e3a9cf9e645b2989e888a51ceecbf</a:t>
-            </a:r>
-          </a:p>
-          <a:p xmlns:a="http://schemas.openxmlformats.org/drawingml/2006/main">
-            <a:r>
-              <a:t>Later audit SHA-256 75abc802636f2e337b6fda2002b14f4ddf89f434901bae4a034734403f73e35f</a:t>
-            </a:r>
-          </a:p>
-          <a:p xmlns:a="http://schemas.openxmlformats.org/drawingml/2006/main">
-            <a:r>
-              <a:t>Fresh October 7 execution of the merged proposal candidate, compared with the prior immutable run and followed by repeated independent diagnostics. No runtime implementation repairs.</a:t>
+              <a:t>README SHA-256 708a3b5c2d26a82e32e7ec3c381c2ebb7cda8274fd4567709f98d76d85ca8f6c</a:t>
+            </a:r>
+          </a:p>
+          <a:p xmlns:a="http://schemas.openxmlformats.org/drawingml/2006/main">
+            <a:r>
+              <a:t>Proposal SHA-256 28768109389139a56d5c8e5f473446bfa46dd1ab46a48924165b97fb92cb7ae9</a:t>
+            </a:r>
+          </a:p>
+          <a:p xmlns:a="http://schemas.openxmlformats.org/drawingml/2006/main">
+            <a:r>
+              <a:t>Immutable execution receipt SHA-256 b12019e039ab52f930fb2f4321ca2289875bcdefbd3dbbd669b72a8689647e46</a:t>
+            </a:r>
+          </a:p>
+          <a:p xmlns:a="http://schemas.openxmlformats.org/drawingml/2006/main">
+            <a:r>
+              <a:t>Later audit SHA-256 e7e5278ba30509b5a3e94196ffdb6d59aaa54eadacae97022f6ffab098d94a9a</a:t>
+            </a:r>
+          </a:p>
+          <a:p xmlns:a="http://schemas.openxmlformats.org/drawingml/2006/main">
+            <a:r>
+              <a:t>Fresh October 8 execution of the local stacked follow-up, with clause-traced adapter repairs and repeated independent diagnostics. No changes have been published.</a:t>
             </a:r>
           </a:p>
           <a:p xmlns:a="http://schemas.openxmlformats.org/drawingml/2006/main">
@@ -1340,12 +1340,12 @@
           </a:p>
           <a:p xmlns:a="http://schemas.openxmlformats.org/drawingml/2006/main">
             <a:r>
-              <a:t>Proposal: ### Source placement evaluation and transform order at proposal/proposal-source.txt:1787</a:t>
-            </a:r>
-          </a:p>
-          <a:p xmlns:a="http://schemas.openxmlformats.org/drawingml/2006/main">
-            <a:r>
-              <a:t>Functional requirements: [{"id":9,"title":"Positions, and offsets from them.","line":772},{"id":12,"title":"No angle read as a length.","line":826},{"id":13,"title":"One axis mapping.","line":840},{"id":16,"title":"One CRS out.","line":882},{"id":19,"title":"Resolution leaves the scene as authored.","line":930}]</a:t>
+              <a:t>Proposal: ### Source placement evaluation and transform order at proposal/proposal-source.txt:1810</a:t>
+            </a:r>
+          </a:p>
+          <a:p xmlns:a="http://schemas.openxmlformats.org/drawingml/2006/main">
+            <a:r>
+              <a:t>Functional requirements: [{"id":9,"title":"Positions, and offsets from them.","line":777},{"id":12,"title":"No angle read as a length.","line":831},{"id":13,"title":"One axis mapping.","line":845},{"id":16,"title":"One CRS out.","line":882},{"id":19,"title":"Resolution leaves the scene as authored.","line":932}]</a:t>
             </a:r>
           </a:p>
           <a:p xmlns:a="http://schemas.openxmlformats.org/drawingml/2006/main">
@@ -1360,27 +1360,27 @@
           </a:p>
           <a:p xmlns:a="http://schemas.openxmlformats.org/drawingml/2006/main">
             <a:r>
-              <a:t>README SHA-256 516b20d0c5b90558e7659c4ca71b2f2741d929c1a41d2427ac823f265f49b730</a:t>
-            </a:r>
-          </a:p>
-          <a:p xmlns:a="http://schemas.openxmlformats.org/drawingml/2006/main">
-            <a:r>
-              <a:t>Proposal SHA-256 02323339203777b80b0bf8969f2392a4663b78be29e88f26f859df376999774a</a:t>
-            </a:r>
-          </a:p>
-          <a:p xmlns:a="http://schemas.openxmlformats.org/drawingml/2006/main">
-            <a:r>
-              <a:t>Immutable execution receipt SHA-256 4f212b53f00cd7f31bae7b94ea63e6a4b99e3a9cf9e645b2989e888a51ceecbf</a:t>
-            </a:r>
-          </a:p>
-          <a:p xmlns:a="http://schemas.openxmlformats.org/drawingml/2006/main">
-            <a:r>
-              <a:t>Later audit SHA-256 75abc802636f2e337b6fda2002b14f4ddf89f434901bae4a034734403f73e35f</a:t>
-            </a:r>
-          </a:p>
-          <a:p xmlns:a="http://schemas.openxmlformats.org/drawingml/2006/main">
-            <a:r>
-              <a:t>Fresh October 7 execution of the merged proposal candidate, compared with the prior immutable run and followed by repeated independent diagnostics. No runtime implementation repairs.</a:t>
+              <a:t>README SHA-256 708a3b5c2d26a82e32e7ec3c381c2ebb7cda8274fd4567709f98d76d85ca8f6c</a:t>
+            </a:r>
+          </a:p>
+          <a:p xmlns:a="http://schemas.openxmlformats.org/drawingml/2006/main">
+            <a:r>
+              <a:t>Proposal SHA-256 28768109389139a56d5c8e5f473446bfa46dd1ab46a48924165b97fb92cb7ae9</a:t>
+            </a:r>
+          </a:p>
+          <a:p xmlns:a="http://schemas.openxmlformats.org/drawingml/2006/main">
+            <a:r>
+              <a:t>Immutable execution receipt SHA-256 b12019e039ab52f930fb2f4321ca2289875bcdefbd3dbbd669b72a8689647e46</a:t>
+            </a:r>
+          </a:p>
+          <a:p xmlns:a="http://schemas.openxmlformats.org/drawingml/2006/main">
+            <a:r>
+              <a:t>Later audit SHA-256 e7e5278ba30509b5a3e94196ffdb6d59aaa54eadacae97022f6ffab098d94a9a</a:t>
+            </a:r>
+          </a:p>
+          <a:p xmlns:a="http://schemas.openxmlformats.org/drawingml/2006/main">
+            <a:r>
+              <a:t>Fresh October 8 execution of the local stacked follow-up, with clause-traced adapter repairs and repeated independent diagnostics. No changes have been published.</a:t>
             </a:r>
           </a:p>
           <a:p xmlns:a="http://schemas.openxmlformats.org/drawingml/2006/main">
@@ -1475,22 +1475,22 @@
           </a:p>
           <a:p xmlns:a="http://schemas.openxmlformats.org/drawingml/2006/main">
             <a:r>
-              <a:t>Implication for proposal quality: Order changes the result. The control makes the proposed child-transform choice reviewable; matching readers do not establish agreement.</a:t>
-            </a:r>
-          </a:p>
-          <a:p xmlns:a="http://schemas.openxmlformats.org/drawingml/2006/main">
-            <a:r>
-              <a:t>Limit: The image is informative. The child-transform rule is a proposed clarification, not a claim that the call settled every descendant case.</a:t>
-            </a:r>
-          </a:p>
-          <a:p xmlns:a="http://schemas.openxmlformats.org/drawingml/2006/main">
-            <a:r>
-              <a:t>Proposal: #### Evaluation at proposal/proposal-source.txt:1887</a:t>
-            </a:r>
-          </a:p>
-          <a:p xmlns:a="http://schemas.openxmlformats.org/drawingml/2006/main">
-            <a:r>
-              <a:t>Functional requirements: [{"id":9,"title":"Positions, and offsets from them.","line":772},{"id":14,"title":"Scene conventions stay the scene's.","line":857},{"id":15,"title":"Placement separate from conformance.","line":870},{"id":17,"title":"The same answer for every consumer.","line":902},{"id":19,"title":"Resolution leaves the scene as authored.","line":930}]</a:t>
+              <a:t>Implication for proposal quality: Order changes the result. The control tests the agreed anchor/child distinction while detailed chart and instance conventions remain candidates.</a:t>
+            </a:r>
+          </a:p>
+          <a:p xmlns:a="http://schemas.openxmlformats.org/drawingml/2006/main">
+            <a:r>
+              <a:t>Limit: The image is informative. Feedback supports project adjustments versus model-local child offsets; detailed rules still need review.</a:t>
+            </a:r>
+          </a:p>
+          <a:p xmlns:a="http://schemas.openxmlformats.org/drawingml/2006/main">
+            <a:r>
+              <a:t>Proposal: #### Evaluation at proposal/proposal-source.txt:1910</a:t>
+            </a:r>
+          </a:p>
+          <a:p xmlns:a="http://schemas.openxmlformats.org/drawingml/2006/main">
+            <a:r>
+              <a:t>Functional requirements: [{"id":9,"title":"Positions, and offsets from them.","line":777},{"id":14,"title":"Scene conventions stay the scene's.","line":857},{"id":15,"title":"Placement separate from conformance.","line":870},{"id":17,"title":"The same answer for every consumer.","line":902},{"id":19,"title":"Resolution leaves the scene as authored.","line":932}]</a:t>
             </a:r>
           </a:p>
           <a:p xmlns:a="http://schemas.openxmlformats.org/drawingml/2006/main">
@@ -1505,27 +1505,27 @@
           </a:p>
           <a:p xmlns:a="http://schemas.openxmlformats.org/drawingml/2006/main">
             <a:r>
-              <a:t>README SHA-256 516b20d0c5b90558e7659c4ca71b2f2741d929c1a41d2427ac823f265f49b730</a:t>
-            </a:r>
-          </a:p>
-          <a:p xmlns:a="http://schemas.openxmlformats.org/drawingml/2006/main">
-            <a:r>
-              <a:t>Proposal SHA-256 02323339203777b80b0bf8969f2392a4663b78be29e88f26f859df376999774a</a:t>
-            </a:r>
-          </a:p>
-          <a:p xmlns:a="http://schemas.openxmlformats.org/drawingml/2006/main">
-            <a:r>
-              <a:t>Immutable execution receipt SHA-256 4f212b53f00cd7f31bae7b94ea63e6a4b99e3a9cf9e645b2989e888a51ceecbf</a:t>
-            </a:r>
-          </a:p>
-          <a:p xmlns:a="http://schemas.openxmlformats.org/drawingml/2006/main">
-            <a:r>
-              <a:t>Later audit SHA-256 75abc802636f2e337b6fda2002b14f4ddf89f434901bae4a034734403f73e35f</a:t>
-            </a:r>
-          </a:p>
-          <a:p xmlns:a="http://schemas.openxmlformats.org/drawingml/2006/main">
-            <a:r>
-              <a:t>Fresh October 7 execution of the merged proposal candidate, compared with the prior immutable run and followed by repeated independent diagnostics. No runtime implementation repairs.</a:t>
+              <a:t>README SHA-256 708a3b5c2d26a82e32e7ec3c381c2ebb7cda8274fd4567709f98d76d85ca8f6c</a:t>
+            </a:r>
+          </a:p>
+          <a:p xmlns:a="http://schemas.openxmlformats.org/drawingml/2006/main">
+            <a:r>
+              <a:t>Proposal SHA-256 28768109389139a56d5c8e5f473446bfa46dd1ab46a48924165b97fb92cb7ae9</a:t>
+            </a:r>
+          </a:p>
+          <a:p xmlns:a="http://schemas.openxmlformats.org/drawingml/2006/main">
+            <a:r>
+              <a:t>Immutable execution receipt SHA-256 b12019e039ab52f930fb2f4321ca2289875bcdefbd3dbbd669b72a8689647e46</a:t>
+            </a:r>
+          </a:p>
+          <a:p xmlns:a="http://schemas.openxmlformats.org/drawingml/2006/main">
+            <a:r>
+              <a:t>Later audit SHA-256 e7e5278ba30509b5a3e94196ffdb6d59aaa54eadacae97022f6ffab098d94a9a</a:t>
+            </a:r>
+          </a:p>
+          <a:p xmlns:a="http://schemas.openxmlformats.org/drawingml/2006/main">
+            <a:r>
+              <a:t>Fresh October 8 execution of the local stacked follow-up, with clause-traced adapter repairs and repeated independent diagnostics. No changes have been published.</a:t>
             </a:r>
           </a:p>
           <a:p xmlns:a="http://schemas.openxmlformats.org/drawingml/2006/main">
@@ -1625,17 +1625,17 @@
           </a:p>
           <a:p xmlns:a="http://schemas.openxmlformats.org/drawingml/2006/main">
             <a:r>
-              <a:t>Limit: Both readers use PROJ, the same CRS conversion library, and share native dataset decoding. Agreement therefore does not independently verify geodetic accuracy or detect shared mistakes. The later audit also finds incomplete per-component and angular error reporting.</a:t>
-            </a:r>
-          </a:p>
-          <a:p xmlns:a="http://schemas.openxmlformats.org/drawingml/2006/main">
-            <a:r>
-              <a:t>Proposal: ### Extent and result comparison at proposal/proposal-source.txt:2018</a:t>
-            </a:r>
-          </a:p>
-          <a:p xmlns:a="http://schemas.openxmlformats.org/drawingml/2006/main">
-            <a:r>
-              <a:t>Functional requirements: [{"id":4,"title":"A site's own grid is a CRS like any other.","line":669},{"id":13,"title":"One axis mapping.","line":840},{"id":16,"title":"One CRS out.","line":882},{"id":17,"title":"The same answer for every consumer.","line":902},{"id":18,"title":"Coordinates back out.","line":915},{"id":28,"title":"A result says what produced it.","line":1088},{"id":29,"title":"Implementable from the text alone.","line":1106}]</a:t>
+              <a:t>Limit: Both readers use PROJ and share dataset decoding. Agreement is limited to tested domains and is not independent geodetic validation.</a:t>
+            </a:r>
+          </a:p>
+          <a:p xmlns:a="http://schemas.openxmlformats.org/drawingml/2006/main">
+            <a:r>
+              <a:t>Proposal: ### Extent and result comparison at proposal/proposal-source.txt:2042</a:t>
+            </a:r>
+          </a:p>
+          <a:p xmlns:a="http://schemas.openxmlformats.org/drawingml/2006/main">
+            <a:r>
+              <a:t>Functional requirements: [{"id":4,"title":"A site's own grid is a CRS like any other.","line":674},{"id":13,"title":"One axis mapping.","line":845},{"id":16,"title":"One CRS out.","line":882},{"id":17,"title":"The same answer for every consumer.","line":902},{"id":18,"title":"Coordinates back out.","line":917},{"id":28,"title":"A result says what produced it.","line":1099},{"id":29,"title":"Implementable from the text alone.","line":1117}]</a:t>
             </a:r>
           </a:p>
           <a:p xmlns:a="http://schemas.openxmlformats.org/drawingml/2006/main">
@@ -1645,32 +1645,32 @@
           </a:p>
           <a:p xmlns:a="http://schemas.openxmlformats.org/drawingml/2006/main">
             <a:r>
-              <a:t>The tables round one point per dataset to six decimals in their declared units. Shared PROJ and decoding limit independence. Required component/angular reports remain incomplete (audit A6). {"France_01":{"source":[1661099.039,8180053.117,37.298],"source_label":"CC49","target_label":"Lambert-93","unit":"m","python":[661101.1094171533,6857834.256535667,37.297999998112694],"native":[661101.1094171533,6857834.256535667,37.298000000906654],"ov":[661101.1094171533,6857834.256535667,37.297999998112694]},"Colorado_02":{"source":[3108002.1122,1752265.0666,5482.9424],"source_label":"State Plane","target_label":"Westminster site grid","unit":"ftUS","python":[3108871.450100667,1206317.4694031866,5484.677949332321],"native":[3108871.450100667,1206317.469403112,5484.677949268161],"ov":[3108871.450100667,1206317.4694031866,5484.677949332321]}}</a:t>
-            </a:r>
-          </a:p>
-          <a:p xmlns:a="http://schemas.openxmlformats.org/drawingml/2006/main">
-            <a:r>
-              <a:t>README SHA-256 516b20d0c5b90558e7659c4ca71b2f2741d929c1a41d2427ac823f265f49b730</a:t>
-            </a:r>
-          </a:p>
-          <a:p xmlns:a="http://schemas.openxmlformats.org/drawingml/2006/main">
-            <a:r>
-              <a:t>Proposal SHA-256 02323339203777b80b0bf8969f2392a4663b78be29e88f26f859df376999774a</a:t>
-            </a:r>
-          </a:p>
-          <a:p xmlns:a="http://schemas.openxmlformats.org/drawingml/2006/main">
-            <a:r>
-              <a:t>Immutable execution receipt SHA-256 4f212b53f00cd7f31bae7b94ea63e6a4b99e3a9cf9e645b2989e888a51ceecbf</a:t>
-            </a:r>
-          </a:p>
-          <a:p xmlns:a="http://schemas.openxmlformats.org/drawingml/2006/main">
-            <a:r>
-              <a:t>Later audit SHA-256 75abc802636f2e337b6fda2002b14f4ddf89f434901bae4a034734403f73e35f</a:t>
-            </a:r>
-          </a:p>
-          <a:p xmlns:a="http://schemas.openxmlformats.org/drawingml/2006/main">
-            <a:r>
-              <a:t>Fresh October 7 execution of the merged proposal candidate, compared with the prior immutable run and followed by repeated independent diagnostics. No runtime implementation repairs.</a:t>
+              <a:t>The tables round one point per dataset to six decimals in their declared units. Shared PROJ and decoding limit independence. Component, magnitude and angular reporting now pass the independent counterexample. {"France_01":{"source":[1661099.039,8180053.117,37.298],"source_label":"CC49","target_label":"Lambert-93","unit":"m","python":[661101.1094171533,6857834.256535667,37.297999998112694],"native":[661101.1094171533,6857834.256535667,37.298000000906654],"ov":[661101.1094171533,6857834.256535667,37.297999998112694]},"Colorado_02":{"source":[3108002.1122,1752265.0666,5482.9424],"source_label":"State Plane","target_label":"Westminster site grid","unit":"ftUS","python":[3108871.450100667,1206317.4694031866,5484.677949332321],"native":[3108871.450100667,1206317.469403112,5484.677949268161],"ov":[3108871.450100667,1206317.4694031866,5484.677949332321]}}</a:t>
+            </a:r>
+          </a:p>
+          <a:p xmlns:a="http://schemas.openxmlformats.org/drawingml/2006/main">
+            <a:r>
+              <a:t>README SHA-256 708a3b5c2d26a82e32e7ec3c381c2ebb7cda8274fd4567709f98d76d85ca8f6c</a:t>
+            </a:r>
+          </a:p>
+          <a:p xmlns:a="http://schemas.openxmlformats.org/drawingml/2006/main">
+            <a:r>
+              <a:t>Proposal SHA-256 28768109389139a56d5c8e5f473446bfa46dd1ab46a48924165b97fb92cb7ae9</a:t>
+            </a:r>
+          </a:p>
+          <a:p xmlns:a="http://schemas.openxmlformats.org/drawingml/2006/main">
+            <a:r>
+              <a:t>Immutable execution receipt SHA-256 b12019e039ab52f930fb2f4321ca2289875bcdefbd3dbbd669b72a8689647e46</a:t>
+            </a:r>
+          </a:p>
+          <a:p xmlns:a="http://schemas.openxmlformats.org/drawingml/2006/main">
+            <a:r>
+              <a:t>Later audit SHA-256 e7e5278ba30509b5a3e94196ffdb6d59aaa54eadacae97022f6ffab098d94a9a</a:t>
+            </a:r>
+          </a:p>
+          <a:p xmlns:a="http://schemas.openxmlformats.org/drawingml/2006/main">
+            <a:r>
+              <a:t>Fresh October 8 execution of the local stacked follow-up, with clause-traced adapter repairs and repeated independent diagnostics. No changes have been published.</a:t>
             </a:r>
           </a:p>
           <a:p xmlns:a="http://schemas.openxmlformats.org/drawingml/2006/main">
@@ -1760,27 +1760,27 @@
           </a:p>
           <a:p xmlns:a="http://schemas.openxmlformats.org/drawingml/2006/main">
             <a:r>
-              <a:t>Observed: The C++ reader's resolved Eiffel copy reaches Hydra/Storm, a USD rendering path. This image is actual output from the recorded run.</a:t>
-            </a:r>
-          </a:p>
-          <a:p xmlns:a="http://schemas.openxmlformats.org/drawingml/2006/main">
-            <a:r>
-              <a:t>Implication for proposal quality: This case shows compatibility with an ordinary USD renderer. A separate nested-geometry failure prevents a claim that every bake is correct.</a:t>
-            </a:r>
-          </a:p>
-          <a:p xmlns:a="http://schemas.openxmlformats.org/drawingml/2006/main">
-            <a:r>
-              <a:t>Limit: The ground plane is illustrative, without surveyed Paris context. This run has no geospatial Hydra filter or Omniverse render proof. Other bake diagnostics fail, as listed below.</a:t>
-            </a:r>
-          </a:p>
-          <a:p xmlns:a="http://schemas.openxmlformats.org/drawingml/2006/main">
-            <a:r>
-              <a:t>Proposal: ### Explicit export and sampling at proposal/proposal-source.txt:2071</a:t>
-            </a:r>
-          </a:p>
-          <a:p xmlns:a="http://schemas.openxmlformats.org/drawingml/2006/main">
-            <a:r>
-              <a:t>Functional requirements: [{"id":17,"title":"The same answer for every consumer.","line":902},{"id":19,"title":"Resolution leaves the scene as authored.","line":930},{"id":23,"title":"Detail that does not depend on location.","line":1028},{"id":25,"title":"Additive for consumers that ignore it.","line":1052},{"id":29,"title":"Implementable from the text alone.","line":1106}]</a:t>
+              <a:t>Observed: Native Hydra/Storm renders the ordinary USD bake. A double-precision origin keeps local points small; fresh readers recover the placement.</a:t>
+            </a:r>
+          </a:p>
+          <a:p xmlns:a="http://schemas.openxmlformats.org/drawingml/2006/main">
+            <a:r>
+              <a:t>Implication for proposal quality: Unaware viewers receive resolved ordinary geometry. Fresh checks reject duplicate meshes and retain an unrelated applied schema.</a:t>
+            </a:r>
+          </a:p>
+          <a:p xmlns:a="http://schemas.openxmlformats.org/drawingml/2006/main">
+            <a:r>
+              <a:t>Limit: This is a recorded native render. General materials, primvars and continuous coverage remain unverified.</a:t>
+            </a:r>
+          </a:p>
+          <a:p xmlns:a="http://schemas.openxmlformats.org/drawingml/2006/main">
+            <a:r>
+              <a:t>Proposal: ### Explicit export and sampling at proposal/proposal-source.txt:2095</a:t>
+            </a:r>
+          </a:p>
+          <a:p xmlns:a="http://schemas.openxmlformats.org/drawingml/2006/main">
+            <a:r>
+              <a:t>Functional requirements: [{"id":17,"title":"The same answer for every consumer.","line":902},{"id":19,"title":"Resolution leaves the scene as authored.","line":932},{"id":23,"title":"Detail that does not depend on location.","line":1038},{"id":25,"title":"Additive for consumers that ignore it.","line":1062},{"id":29,"title":"Implementable from the text alone.","line":1117}]</a:t>
             </a:r>
           </a:p>
           <a:p xmlns:a="http://schemas.openxmlformats.org/drawingml/2006/main">
@@ -1795,27 +1795,27 @@
           </a:p>
           <a:p xmlns:a="http://schemas.openxmlformats.org/drawingml/2006/main">
             <a:r>
-              <a:t>README SHA-256 516b20d0c5b90558e7659c4ca71b2f2741d929c1a41d2427ac823f265f49b730</a:t>
-            </a:r>
-          </a:p>
-          <a:p xmlns:a="http://schemas.openxmlformats.org/drawingml/2006/main">
-            <a:r>
-              <a:t>Proposal SHA-256 02323339203777b80b0bf8969f2392a4663b78be29e88f26f859df376999774a</a:t>
-            </a:r>
-          </a:p>
-          <a:p xmlns:a="http://schemas.openxmlformats.org/drawingml/2006/main">
-            <a:r>
-              <a:t>Immutable execution receipt SHA-256 4f212b53f00cd7f31bae7b94ea63e6a4b99e3a9cf9e645b2989e888a51ceecbf</a:t>
-            </a:r>
-          </a:p>
-          <a:p xmlns:a="http://schemas.openxmlformats.org/drawingml/2006/main">
-            <a:r>
-              <a:t>Later audit SHA-256 75abc802636f2e337b6fda2002b14f4ddf89f434901bae4a034734403f73e35f</a:t>
-            </a:r>
-          </a:p>
-          <a:p xmlns:a="http://schemas.openxmlformats.org/drawingml/2006/main">
-            <a:r>
-              <a:t>Fresh October 7 execution of the merged proposal candidate, compared with the prior immutable run and followed by repeated independent diagnostics. No runtime implementation repairs.</a:t>
+              <a:t>README SHA-256 708a3b5c2d26a82e32e7ec3c381c2ebb7cda8274fd4567709f98d76d85ca8f6c</a:t>
+            </a:r>
+          </a:p>
+          <a:p xmlns:a="http://schemas.openxmlformats.org/drawingml/2006/main">
+            <a:r>
+              <a:t>Proposal SHA-256 28768109389139a56d5c8e5f473446bfa46dd1ab46a48924165b97fb92cb7ae9</a:t>
+            </a:r>
+          </a:p>
+          <a:p xmlns:a="http://schemas.openxmlformats.org/drawingml/2006/main">
+            <a:r>
+              <a:t>Immutable execution receipt SHA-256 b12019e039ab52f930fb2f4321ca2289875bcdefbd3dbbd669b72a8689647e46</a:t>
+            </a:r>
+          </a:p>
+          <a:p xmlns:a="http://schemas.openxmlformats.org/drawingml/2006/main">
+            <a:r>
+              <a:t>Later audit SHA-256 e7e5278ba30509b5a3e94196ffdb6d59aaa54eadacae97022f6ffab098d94a9a</a:t>
+            </a:r>
+          </a:p>
+          <a:p xmlns:a="http://schemas.openxmlformats.org/drawingml/2006/main">
+            <a:r>
+              <a:t>Fresh October 8 execution of the local stacked follow-up, with clause-traced adapter repairs and repeated independent diagnostics. No changes have been published.</a:t>
             </a:r>
           </a:p>
           <a:p xmlns:a="http://schemas.openxmlformats.org/drawingml/2006/main">
@@ -1915,17 +1915,17 @@
           </a:p>
           <a:p xmlns:a="http://schemas.openxmlformats.org/drawingml/2006/main">
             <a:r>
-              <a:t>Limit: The heatmap contains synthetic temperatures in kelvin. A different array layout mispairs four of six values and locations. This passing case does not establish support for every layout.</a:t>
-            </a:r>
-          </a:p>
-          <a:p xmlns:a="http://schemas.openxmlformats.org/drawingml/2006/main">
-            <a:r>
-              <a:t>Proposal: ### External measurement association at proposal/proposal-source.txt:1594</a:t>
-            </a:r>
-          </a:p>
-          <a:p xmlns:a="http://schemas.openxmlformats.org/drawingml/2006/main">
-            <a:r>
-              <a:t>Functional requirements: [{"id":8,"title":"Brought-in data keeps its coordinates and its CRS.","line":746},{"id":12,"title":"No angle read as a length.","line":826},{"id":18,"title":"Coordinates back out.","line":915},{"id":19,"title":"Resolution leaves the scene as authored.","line":930},{"id":21,"title":"Never placed by a guess.","line":966},{"id":30,"title":"Measurements remain usable as data.","line":998}]</a:t>
+              <a:t>Limit: Synthetic values. Dimension-name tests check associations independently of the shared decoder.</a:t>
+            </a:r>
+          </a:p>
+          <a:p xmlns:a="http://schemas.openxmlformats.org/drawingml/2006/main">
+            <a:r>
+              <a:t>Proposal: ### External measurement association at proposal/proposal-source.txt:1610</a:t>
+            </a:r>
+          </a:p>
+          <a:p xmlns:a="http://schemas.openxmlformats.org/drawingml/2006/main">
+            <a:r>
+              <a:t>Functional requirements: [{"id":8,"title":"Brought-in data keeps its coordinates and its CRS.","line":751},{"id":12,"title":"No angle read as a length.","line":831},{"id":18,"title":"Coordinates back out.","line":917},{"id":19,"title":"Resolution leaves the scene as authored.","line":932},{"id":21,"title":"Never placed by a guess.","line":968},{"id":30,"title":"Measurements remain usable as data.","line":1003}]</a:t>
             </a:r>
           </a:p>
           <a:p xmlns:a="http://schemas.openxmlformats.org/drawingml/2006/main">
@@ -1940,27 +1940,27 @@
           </a:p>
           <a:p xmlns:a="http://schemas.openxmlformats.org/drawingml/2006/main">
             <a:r>
-              <a:t>README SHA-256 516b20d0c5b90558e7659c4ca71b2f2741d929c1a41d2427ac823f265f49b730</a:t>
-            </a:r>
-          </a:p>
-          <a:p xmlns:a="http://schemas.openxmlformats.org/drawingml/2006/main">
-            <a:r>
-              <a:t>Proposal SHA-256 02323339203777b80b0bf8969f2392a4663b78be29e88f26f859df376999774a</a:t>
-            </a:r>
-          </a:p>
-          <a:p xmlns:a="http://schemas.openxmlformats.org/drawingml/2006/main">
-            <a:r>
-              <a:t>Immutable execution receipt SHA-256 4f212b53f00cd7f31bae7b94ea63e6a4b99e3a9cf9e645b2989e888a51ceecbf</a:t>
-            </a:r>
-          </a:p>
-          <a:p xmlns:a="http://schemas.openxmlformats.org/drawingml/2006/main">
-            <a:r>
-              <a:t>Later audit SHA-256 75abc802636f2e337b6fda2002b14f4ddf89f434901bae4a034734403f73e35f</a:t>
-            </a:r>
-          </a:p>
-          <a:p xmlns:a="http://schemas.openxmlformats.org/drawingml/2006/main">
-            <a:r>
-              <a:t>Fresh October 7 execution of the merged proposal candidate, compared with the prior immutable run and followed by repeated independent diagnostics. No runtime implementation repairs.</a:t>
+              <a:t>README SHA-256 708a3b5c2d26a82e32e7ec3c381c2ebb7cda8274fd4567709f98d76d85ca8f6c</a:t>
+            </a:r>
+          </a:p>
+          <a:p xmlns:a="http://schemas.openxmlformats.org/drawingml/2006/main">
+            <a:r>
+              <a:t>Proposal SHA-256 28768109389139a56d5c8e5f473446bfa46dd1ab46a48924165b97fb92cb7ae9</a:t>
+            </a:r>
+          </a:p>
+          <a:p xmlns:a="http://schemas.openxmlformats.org/drawingml/2006/main">
+            <a:r>
+              <a:t>Immutable execution receipt SHA-256 b12019e039ab52f930fb2f4321ca2289875bcdefbd3dbbd669b72a8689647e46</a:t>
+            </a:r>
+          </a:p>
+          <a:p xmlns:a="http://schemas.openxmlformats.org/drawingml/2006/main">
+            <a:r>
+              <a:t>Later audit SHA-256 e7e5278ba30509b5a3e94196ffdb6d59aaa54eadacae97022f6ffab098d94a9a</a:t>
+            </a:r>
+          </a:p>
+          <a:p xmlns:a="http://schemas.openxmlformats.org/drawingml/2006/main">
+            <a:r>
+              <a:t>Fresh October 8 execution of the local stacked follow-up, with clause-traced adapter repairs and repeated independent diagnostics. No changes have been published.</a:t>
             </a:r>
           </a:p>
           <a:p xmlns:a="http://schemas.openxmlformats.org/drawingml/2006/main">
@@ -2035,7 +2035,7 @@
           <a:lstStyle xmlns:a="http://schemas.openxmlformats.org/drawingml/2006/main"/>
           <a:p xmlns:a="http://schemas.openxmlformats.org/drawingml/2006/main">
             <a:r>
-              <a:t>{"section":"What the later audit changes","status":[["Proposal definitions","The candidate specifies inputs and evaluation rules for the displayed cases. Detailed choices still need group review."],["Newly confirmed model gap","This audit established no additional data-model blocker. It does not establish an exhaustive search for missing meaning."],["Implementation evidence","The selected cases work. 7 later audit issues remain failed or unverified."],["Deferred capabilities","Coordinate epochs and scene-authored transformation resources remain on the roadmap. Initial choices must preserve a path to adding them."]],"issues":[["Surface lighting directions","A private sampling shortcut has no justified error bound. One projected case differs by about 1.24 degrees."],["Repeated models","A referenced model outside the bound subtree fails instead of receiving the instancer's placement."],["Baked geometry","Two source triangles become three output triangles. The check misses the extra geometry."],["Measurement locations","A different array dimension order pairs four of six values with the wrong locations. Both readers share this decoder."],["Other scene information","The bake removes an unrelated MotionAPI schema application, changing other scene meaning."],["Error reporting","Reports omit required per-component errors and separate angular errors."],["Invalid input detection","An invalid placement attribute on an inherited-only child is silently ignored."]]}</a:t>
+              <a:t>{"section":"Fresh independent audit","status":[["Proposal definitions","A focused requirements baseline is separate from the full candidate used for execution. Supported meaning and pending conventions are distinguished."],["Newly confirmed model gap","No additional undefined model rule was confirmed in reviewed paths. This is a scoped assessment, not an exhaustive completeness proof."],["Implementation evidence","The selected cases work. 6 prior defects pass fresh counterexamples; 1 remains unresolved."],["Deferred capabilities","Coordinate epochs and scene-authored transformation resources remain on the roadmap. Initial choices must preserve a path to adding them."]],"issues":[["Surface lighting directions","Remaining: normal sampling has no justified domain/error bound; projected difference about 1.24 degrees."],["Repeated models","Corrected: an unbound library prototype receives its instancer placement in both readers."],["Baked geometry","Corrected: two source meshes yield exactly two baked meshes; extras are rejected."],["Measurement locations","Corrected: all six measurements retain the coordinates declared by dimension names."],["Other scene information","Corrected: the bake retains MotionAPI and its velocity-scale value."],["Error reporting","Corrected: reports include component errors, magnitudes and angular errors."],["Invalid input detection","Corrected: both readers reject an invalid child placement field."]]}</a:t>
             </a:r>
           </a:p>
           <a:p xmlns:a="http://schemas.openxmlformats.org/drawingml/2006/main">
@@ -2045,27 +2045,27 @@
           </a:p>
           <a:p xmlns:a="http://schemas.openxmlformats.org/drawingml/2006/main">
             <a:r>
-              <a:t>README SHA-256 516b20d0c5b90558e7659c4ca71b2f2741d929c1a41d2427ac823f265f49b730</a:t>
-            </a:r>
-          </a:p>
-          <a:p xmlns:a="http://schemas.openxmlformats.org/drawingml/2006/main">
-            <a:r>
-              <a:t>Proposal SHA-256 02323339203777b80b0bf8969f2392a4663b78be29e88f26f859df376999774a</a:t>
-            </a:r>
-          </a:p>
-          <a:p xmlns:a="http://schemas.openxmlformats.org/drawingml/2006/main">
-            <a:r>
-              <a:t>Immutable execution receipt SHA-256 4f212b53f00cd7f31bae7b94ea63e6a4b99e3a9cf9e645b2989e888a51ceecbf</a:t>
-            </a:r>
-          </a:p>
-          <a:p xmlns:a="http://schemas.openxmlformats.org/drawingml/2006/main">
-            <a:r>
-              <a:t>Later audit SHA-256 75abc802636f2e337b6fda2002b14f4ddf89f434901bae4a034734403f73e35f</a:t>
-            </a:r>
-          </a:p>
-          <a:p xmlns:a="http://schemas.openxmlformats.org/drawingml/2006/main">
-            <a:r>
-              <a:t>Fresh October 7 execution of the merged proposal candidate, compared with the prior immutable run and followed by repeated independent diagnostics. No runtime implementation repairs.</a:t>
+              <a:t>README SHA-256 708a3b5c2d26a82e32e7ec3c381c2ebb7cda8274fd4567709f98d76d85ca8f6c</a:t>
+            </a:r>
+          </a:p>
+          <a:p xmlns:a="http://schemas.openxmlformats.org/drawingml/2006/main">
+            <a:r>
+              <a:t>Proposal SHA-256 28768109389139a56d5c8e5f473446bfa46dd1ab46a48924165b97fb92cb7ae9</a:t>
+            </a:r>
+          </a:p>
+          <a:p xmlns:a="http://schemas.openxmlformats.org/drawingml/2006/main">
+            <a:r>
+              <a:t>Immutable execution receipt SHA-256 b12019e039ab52f930fb2f4321ca2289875bcdefbd3dbbd669b72a8689647e46</a:t>
+            </a:r>
+          </a:p>
+          <a:p xmlns:a="http://schemas.openxmlformats.org/drawingml/2006/main">
+            <a:r>
+              <a:t>Later audit SHA-256 e7e5278ba30509b5a3e94196ffdb6d59aaa54eadacae97022f6ffab098d94a9a</a:t>
+            </a:r>
+          </a:p>
+          <a:p xmlns:a="http://schemas.openxmlformats.org/drawingml/2006/main">
+            <a:r>
+              <a:t>Fresh October 8 execution of the local stacked follow-up, with clause-traced adapter repairs and repeated independent diagnostics. No changes have been published.</a:t>
             </a:r>
           </a:p>
           <a:p xmlns:a="http://schemas.openxmlformats.org/drawingml/2006/main">
@@ -2170,12 +2170,12 @@
           </a:p>
           <a:p xmlns:a="http://schemas.openxmlformats.org/drawingml/2006/main">
             <a:r>
-              <a:t>Proposal: #### Decision on question 7: site calibration at proposal/proposal-source.txt:1283</a:t>
-            </a:r>
-          </a:p>
-          <a:p xmlns:a="http://schemas.openxmlformats.org/drawingml/2006/main">
-            <a:r>
-              <a:t>Functional requirements: [{"id":4,"title":"A site's own grid is a CRS like any other.","line":669},{"id":14,"title":"Scene conventions stay the scene's.","line":857},{"id":15,"title":"Placement separate from conformance.","line":870},{"id":17,"title":"The same answer for every consumer.","line":902}]</a:t>
+              <a:t>Proposal: #### Decision on question 7: site calibration at proposal/proposal-source.txt:1294</a:t>
+            </a:r>
+          </a:p>
+          <a:p xmlns:a="http://schemas.openxmlformats.org/drawingml/2006/main">
+            <a:r>
+              <a:t>Functional requirements: [{"id":4,"title":"A site's own grid is a CRS like any other.","line":674},{"id":14,"title":"Scene conventions stay the scene's.","line":857},{"id":15,"title":"Placement separate from conformance.","line":870},{"id":17,"title":"The same answer for every consumer.","line":902}]</a:t>
             </a:r>
           </a:p>
           <a:p xmlns:a="http://schemas.openxmlformats.org/drawingml/2006/main">
@@ -2190,27 +2190,27 @@
           </a:p>
           <a:p xmlns:a="http://schemas.openxmlformats.org/drawingml/2006/main">
             <a:r>
-              <a:t>README SHA-256 516b20d0c5b90558e7659c4ca71b2f2741d929c1a41d2427ac823f265f49b730</a:t>
-            </a:r>
-          </a:p>
-          <a:p xmlns:a="http://schemas.openxmlformats.org/drawingml/2006/main">
-            <a:r>
-              <a:t>Proposal SHA-256 02323339203777b80b0bf8969f2392a4663b78be29e88f26f859df376999774a</a:t>
-            </a:r>
-          </a:p>
-          <a:p xmlns:a="http://schemas.openxmlformats.org/drawingml/2006/main">
-            <a:r>
-              <a:t>Immutable execution receipt SHA-256 4f212b53f00cd7f31bae7b94ea63e6a4b99e3a9cf9e645b2989e888a51ceecbf</a:t>
-            </a:r>
-          </a:p>
-          <a:p xmlns:a="http://schemas.openxmlformats.org/drawingml/2006/main">
-            <a:r>
-              <a:t>Later audit SHA-256 75abc802636f2e337b6fda2002b14f4ddf89f434901bae4a034734403f73e35f</a:t>
-            </a:r>
-          </a:p>
-          <a:p xmlns:a="http://schemas.openxmlformats.org/drawingml/2006/main">
-            <a:r>
-              <a:t>Fresh October 7 execution of the merged proposal candidate, compared with the prior immutable run and followed by repeated independent diagnostics. No runtime implementation repairs.</a:t>
+              <a:t>README SHA-256 708a3b5c2d26a82e32e7ec3c381c2ebb7cda8274fd4567709f98d76d85ca8f6c</a:t>
+            </a:r>
+          </a:p>
+          <a:p xmlns:a="http://schemas.openxmlformats.org/drawingml/2006/main">
+            <a:r>
+              <a:t>Proposal SHA-256 28768109389139a56d5c8e5f473446bfa46dd1ab46a48924165b97fb92cb7ae9</a:t>
+            </a:r>
+          </a:p>
+          <a:p xmlns:a="http://schemas.openxmlformats.org/drawingml/2006/main">
+            <a:r>
+              <a:t>Immutable execution receipt SHA-256 b12019e039ab52f930fb2f4321ca2289875bcdefbd3dbbd669b72a8689647e46</a:t>
+            </a:r>
+          </a:p>
+          <a:p xmlns:a="http://schemas.openxmlformats.org/drawingml/2006/main">
+            <a:r>
+              <a:t>Later audit SHA-256 e7e5278ba30509b5a3e94196ffdb6d59aaa54eadacae97022f6ffab098d94a9a</a:t>
+            </a:r>
+          </a:p>
+          <a:p xmlns:a="http://schemas.openxmlformats.org/drawingml/2006/main">
+            <a:r>
+              <a:t>Fresh October 8 execution of the local stacked follow-up, with clause-traced adapter repairs and repeated independent diagnostics. No changes have been published.</a:t>
             </a:r>
           </a:p>
           <a:p xmlns:a="http://schemas.openxmlformats.org/drawingml/2006/main">
@@ -2262,7 +2262,7 @@
           <p:cNvPr id="3" name="Title">
             <a:extLst xmlns:a="http://schemas.openxmlformats.org/drawingml/2006/main">
               <a:ext uri="{FF2B5EF4-FFF2-40B4-BE49-F238E27FC236}">
-                <a16:creationId xmlns:a16="http://schemas.microsoft.com/office/drawing/2014/main" id="{220659E9-D203-4473-AA5F-2871A1BDF4B9}"/>
+                <a16:creationId xmlns:a16="http://schemas.microsoft.com/office/drawing/2014/main" id="{21BB5223-5EEC-44E0-AE9A-8D60D412E027}"/>
               </a:ext>
             </a:extLst>
           </p:cNvPr>
@@ -2419,7 +2419,7 @@
           <p:cNvPr id="2" name="Subtitle">
             <a:extLst xmlns:a="http://schemas.openxmlformats.org/drawingml/2006/main">
               <a:ext uri="{FF2B5EF4-FFF2-40B4-BE49-F238E27FC236}">
-                <a16:creationId xmlns:a16="http://schemas.microsoft.com/office/drawing/2014/main" id="{1F75DA7E-1AE4-47CA-8A2C-599C2659F0E8}"/>
+                <a16:creationId xmlns:a16="http://schemas.microsoft.com/office/drawing/2014/main" id="{011BF116-BB13-46A9-90BE-2E473EF69CE7}"/>
               </a:ext>
             </a:extLst>
           </p:cNvPr>
@@ -2593,7 +2593,7 @@
           <p:cNvPr id="2" name="Section title">
             <a:extLst xmlns:a="http://schemas.openxmlformats.org/drawingml/2006/main">
               <a:ext uri="{FF2B5EF4-FFF2-40B4-BE49-F238E27FC236}">
-                <a16:creationId xmlns:a16="http://schemas.microsoft.com/office/drawing/2014/main" id="{BBD11E14-5A80-4070-B363-D8B4AAB9BC48}"/>
+                <a16:creationId xmlns:a16="http://schemas.microsoft.com/office/drawing/2014/main" id="{23BCB66F-27A5-4AE5-BCD3-AEAC8EE46F7D}"/>
               </a:ext>
             </a:extLst>
           </p:cNvPr>
@@ -2767,7 +2767,7 @@
           <p:cNvPr id="3" name="Title">
             <a:extLst xmlns:a="http://schemas.openxmlformats.org/drawingml/2006/main">
               <a:ext uri="{FF2B5EF4-FFF2-40B4-BE49-F238E27FC236}">
-                <a16:creationId xmlns:a16="http://schemas.microsoft.com/office/drawing/2014/main" id="{2185428A-A9AE-4754-A167-A4883351AA5A}"/>
+                <a16:creationId xmlns:a16="http://schemas.microsoft.com/office/drawing/2014/main" id="{24E279D9-2EB9-416D-A08E-5E01B5862D6E}"/>
               </a:ext>
             </a:extLst>
           </p:cNvPr>
@@ -2924,7 +2924,7 @@
           <p:cNvPr id="2" name="Body">
             <a:extLst xmlns:a="http://schemas.openxmlformats.org/drawingml/2006/main">
               <a:ext uri="{FF2B5EF4-FFF2-40B4-BE49-F238E27FC236}">
-                <a16:creationId xmlns:a16="http://schemas.microsoft.com/office/drawing/2014/main" id="{4A01EE01-423C-4BF1-BAD9-AD71A01B2E74}"/>
+                <a16:creationId xmlns:a16="http://schemas.microsoft.com/office/drawing/2014/main" id="{AC70189C-322D-4E71-A2D1-BFAC58395084}"/>
               </a:ext>
             </a:extLst>
           </p:cNvPr>
@@ -3098,7 +3098,7 @@
           <p:cNvPr id="4" name="Title">
             <a:extLst xmlns:a="http://schemas.openxmlformats.org/drawingml/2006/main">
               <a:ext uri="{FF2B5EF4-FFF2-40B4-BE49-F238E27FC236}">
-                <a16:creationId xmlns:a16="http://schemas.microsoft.com/office/drawing/2014/main" id="{1F18A24A-B485-4A01-8117-0E26196E5EA9}"/>
+                <a16:creationId xmlns:a16="http://schemas.microsoft.com/office/drawing/2014/main" id="{E444A410-EB75-4A5B-9E35-5A33E8322C64}"/>
               </a:ext>
             </a:extLst>
           </p:cNvPr>
@@ -3255,7 +3255,7 @@
           <p:cNvPr id="2" name="Left column">
             <a:extLst xmlns:a="http://schemas.openxmlformats.org/drawingml/2006/main">
               <a:ext uri="{FF2B5EF4-FFF2-40B4-BE49-F238E27FC236}">
-                <a16:creationId xmlns:a16="http://schemas.microsoft.com/office/drawing/2014/main" id="{B4D9F165-3908-428C-9190-966CE7848D93}"/>
+                <a16:creationId xmlns:a16="http://schemas.microsoft.com/office/drawing/2014/main" id="{9A7B4911-8414-46C6-BD4E-8A208B2817F5}"/>
               </a:ext>
             </a:extLst>
           </p:cNvPr>
@@ -3412,7 +3412,7 @@
           <p:cNvPr id="3" name="Right column">
             <a:extLst xmlns:a="http://schemas.openxmlformats.org/drawingml/2006/main">
               <a:ext uri="{FF2B5EF4-FFF2-40B4-BE49-F238E27FC236}">
-                <a16:creationId xmlns:a16="http://schemas.microsoft.com/office/drawing/2014/main" id="{1D455195-7D37-4699-9600-513CE51B2A45}"/>
+                <a16:creationId xmlns:a16="http://schemas.microsoft.com/office/drawing/2014/main" id="{10785BDE-9A24-4D8D-AB5A-9E6CEE9EFD03}"/>
               </a:ext>
             </a:extLst>
           </p:cNvPr>
@@ -3586,7 +3586,7 @@
           <p:cNvPr id="3" name="Title">
             <a:extLst xmlns:a="http://schemas.openxmlformats.org/drawingml/2006/main">
               <a:ext uri="{FF2B5EF4-FFF2-40B4-BE49-F238E27FC236}">
-                <a16:creationId xmlns:a16="http://schemas.microsoft.com/office/drawing/2014/main" id="{A30F211D-3C5B-4295-92D5-00AA23A6033B}"/>
+                <a16:creationId xmlns:a16="http://schemas.microsoft.com/office/drawing/2014/main" id="{EA7322A0-617E-4A6D-9B63-543C50B1B663}"/>
               </a:ext>
             </a:extLst>
           </p:cNvPr>
@@ -3743,7 +3743,7 @@
           <p:cNvPr id="2" name="Left column">
             <a:extLst xmlns:a="http://schemas.openxmlformats.org/drawingml/2006/main">
               <a:ext uri="{FF2B5EF4-FFF2-40B4-BE49-F238E27FC236}">
-                <a16:creationId xmlns:a16="http://schemas.microsoft.com/office/drawing/2014/main" id="{87AE72FE-A597-42F4-B993-42C5BDCE5A8E}"/>
+                <a16:creationId xmlns:a16="http://schemas.microsoft.com/office/drawing/2014/main" id="{7A3F0FC4-FCCF-498D-B8AB-DC92CFA92172}"/>
               </a:ext>
             </a:extLst>
           </p:cNvPr>
@@ -3938,12 +3938,12 @@
   </p:cSld>
   <p:clrMap bg1="lt1" tx1="dk1" bg2="lt2" tx2="dk2" accent1="accent1" accent2="accent2" accent3="accent3" accent4="accent4" accent5="accent5" accent6="accent6" hlink="hlink" folHlink="folHlink"/>
   <p:sldLayoutIdLst>
-    <p:sldLayoutId xmlns:r="http://schemas.openxmlformats.org/officeDocument/2006/relationships" id="2147483649" r:id="Rd553a99e5c8742ce"/>
-    <p:sldLayoutId xmlns:r="http://schemas.openxmlformats.org/officeDocument/2006/relationships" id="2147483650" r:id="R408132e069874fcd"/>
-    <p:sldLayoutId xmlns:r="http://schemas.openxmlformats.org/officeDocument/2006/relationships" id="2147483651" r:id="Rd963513004a04202"/>
-    <p:sldLayoutId xmlns:r="http://schemas.openxmlformats.org/officeDocument/2006/relationships" id="2147483652" r:id="R5462bf3210d842d5"/>
-    <p:sldLayoutId xmlns:r="http://schemas.openxmlformats.org/officeDocument/2006/relationships" id="2147483653" r:id="R205afdfa0fcd4551"/>
-    <p:sldLayoutId xmlns:r="http://schemas.openxmlformats.org/officeDocument/2006/relationships" id="2147483654" r:id="R023c756582894d55"/>
+    <p:sldLayoutId xmlns:r="http://schemas.openxmlformats.org/officeDocument/2006/relationships" id="2147483649" r:id="R47389a25d2694ec1"/>
+    <p:sldLayoutId xmlns:r="http://schemas.openxmlformats.org/officeDocument/2006/relationships" id="2147483650" r:id="R5c9e4b39db504ff9"/>
+    <p:sldLayoutId xmlns:r="http://schemas.openxmlformats.org/officeDocument/2006/relationships" id="2147483651" r:id="R974c490a934049ea"/>
+    <p:sldLayoutId xmlns:r="http://schemas.openxmlformats.org/officeDocument/2006/relationships" id="2147483652" r:id="R4bfcf0087f034859"/>
+    <p:sldLayoutId xmlns:r="http://schemas.openxmlformats.org/officeDocument/2006/relationships" id="2147483653" r:id="R9eb25a25fd9a4fc1"/>
+    <p:sldLayoutId xmlns:r="http://schemas.openxmlformats.org/officeDocument/2006/relationships" id="2147483654" r:id="Rac238190cc924918"/>
   </p:sldLayoutIdLst>
   <p:txStyles>
     <p:titleStyle>
@@ -4758,7 +4758,7 @@
           <p:cNvPr id="5" name="">
             <a:extLst xmlns:a="http://schemas.openxmlformats.org/drawingml/2006/main">
               <a:ext uri="{FF2B5EF4-FFF2-40B4-BE49-F238E27FC236}">
-                <a16:creationId xmlns:a16="http://schemas.microsoft.com/office/drawing/2014/main" id="{C8D60A16-78C3-4EE0-AFB8-9F873F12A3CF}"/>
+                <a16:creationId xmlns:a16="http://schemas.microsoft.com/office/drawing/2014/main" id="{B339C9E5-DF6F-4457-B0B3-C80E3076CF75}"/>
               </a:ext>
             </a:extLst>
           </p:cNvPr>
@@ -4830,7 +4830,7 @@
           <p:cNvPr id="2" name="">
             <a:extLst xmlns:a="http://schemas.openxmlformats.org/drawingml/2006/main">
               <a:ext uri="{FF2B5EF4-FFF2-40B4-BE49-F238E27FC236}">
-                <a16:creationId xmlns:a16="http://schemas.microsoft.com/office/drawing/2014/main" id="{E31A36F0-9BEB-4F15-B98F-D3886E3A0997}"/>
+                <a16:creationId xmlns:a16="http://schemas.microsoft.com/office/drawing/2014/main" id="{8D3C77EB-E9C4-44C3-8E48-EBA8BE154B7D}"/>
               </a:ext>
             </a:extLst>
           </p:cNvPr>
@@ -4902,7 +4902,7 @@
           <p:cNvPr id="3" name="">
             <a:extLst xmlns:a="http://schemas.openxmlformats.org/drawingml/2006/main">
               <a:ext uri="{FF2B5EF4-FFF2-40B4-BE49-F238E27FC236}">
-                <a16:creationId xmlns:a16="http://schemas.microsoft.com/office/drawing/2014/main" id="{BAC565FE-91AD-4BD8-9B0A-AB0CE696C6B6}"/>
+                <a16:creationId xmlns:a16="http://schemas.microsoft.com/office/drawing/2014/main" id="{E91A9F4F-FF3E-494E-90AE-08B943FBA73E}"/>
               </a:ext>
             </a:extLst>
           </p:cNvPr>
@@ -4964,7 +4964,7 @@
                 <a:ea typeface="Arial"/>
                 <a:cs typeface="Arial"/>
               </a:rPr>
-              <a:t>The merged background separates map-grid distances and north from physical model size and orientation. A narrow clarification keeps stage axes distinct. Existing placement rules remain unchanged.</a:t>
+              <a:t>The local split gives reviewers a focused requirements baseline and a separate full model/runtime candidate. Clearer array, invalid-input and bake rules now have fresh tests.</a:t>
             </a:r>
           </a:p>
         </p:txBody>
@@ -4974,7 +4974,7 @@
           <p:cNvPr id="4" name="">
             <a:extLst xmlns:a="http://schemas.openxmlformats.org/drawingml/2006/main">
               <a:ext uri="{FF2B5EF4-FFF2-40B4-BE49-F238E27FC236}">
-                <a16:creationId xmlns:a16="http://schemas.microsoft.com/office/drawing/2014/main" id="{93662254-A4ED-4FB9-9B1B-57F2519AB24D}"/>
+                <a16:creationId xmlns:a16="http://schemas.microsoft.com/office/drawing/2014/main" id="{04AF12E0-4D5D-4755-B730-A288F2D2AE4C}"/>
               </a:ext>
             </a:extLst>
           </p:cNvPr>
@@ -5036,7 +5036,7 @@
                 <a:ea typeface="Arial"/>
                 <a:cs typeface="Arial"/>
               </a:rPr>
-              <a:t>The fresh run reproduces the selected results with no numerical changes. Seven known prototype issues also reproduce. Clearer explanation does not mean those defects are fixed.</a:t>
+              <a:t>All prior recorded numeric results match. Six audited defects are corrected; normal sampling remains unresolved. Orientation storage and detailed conventions still need review.</a:t>
             </a:r>
           </a:p>
         </p:txBody>
@@ -5044,7 +5044,7 @@
     </p:spTree>
     <p:extLst>
       <p:ext uri="{BB962C8B-B14F-4D97-AF65-F5344CB8AC3E}">
-        <p14:creationId xmlns:p14="http://schemas.microsoft.com/office/powerpoint/2010/main" val="2105127"/>
+        <p14:creationId xmlns:p14="http://schemas.microsoft.com/office/powerpoint/2010/main" val="1674383663"/>
       </p:ext>
     </p:extLst>
   </p:cSld>
@@ -5075,7 +5075,7 @@
           <p:cNvPr id="9" name="">
             <a:extLst xmlns:a="http://schemas.openxmlformats.org/drawingml/2006/main">
               <a:ext uri="{FF2B5EF4-FFF2-40B4-BE49-F238E27FC236}">
-                <a16:creationId xmlns:a16="http://schemas.microsoft.com/office/drawing/2014/main" id="{4D307153-D94B-44C8-8601-7196D7A2E91B}"/>
+                <a16:creationId xmlns:a16="http://schemas.microsoft.com/office/drawing/2014/main" id="{F82EAF67-1390-4799-B7DD-5CD317638EE3}"/>
               </a:ext>
             </a:extLst>
           </p:cNvPr>
@@ -5147,7 +5147,7 @@
           <p:cNvPr id="2" name="">
             <a:extLst xmlns:a="http://schemas.openxmlformats.org/drawingml/2006/main">
               <a:ext uri="{FF2B5EF4-FFF2-40B4-BE49-F238E27FC236}">
-                <a16:creationId xmlns:a16="http://schemas.microsoft.com/office/drawing/2014/main" id="{6B273EF4-58A1-46BB-A5B5-BD79CE69D0D0}"/>
+                <a16:creationId xmlns:a16="http://schemas.microsoft.com/office/drawing/2014/main" id="{EC16A695-28E5-4D86-8A7A-DB6954A10881}"/>
               </a:ext>
             </a:extLst>
           </p:cNvPr>
@@ -5219,7 +5219,7 @@
           <p:cNvPr id="3" name="">
             <a:extLst xmlns:a="http://schemas.openxmlformats.org/drawingml/2006/main">
               <a:ext uri="{FF2B5EF4-FFF2-40B4-BE49-F238E27FC236}">
-                <a16:creationId xmlns:a16="http://schemas.microsoft.com/office/drawing/2014/main" id="{1E0DBABB-D27B-4046-A810-149F2659D54D}"/>
+                <a16:creationId xmlns:a16="http://schemas.microsoft.com/office/drawing/2014/main" id="{A4260F1B-37C8-46F2-9899-BEBC6ACD6FBC}"/>
               </a:ext>
             </a:extLst>
           </p:cNvPr>
@@ -5229,7 +5229,7 @@
           <p:nvPr/>
         </p:nvPicPr>
         <p:blipFill>
-          <a:blip xmlns:r="http://schemas.openxmlformats.org/officeDocument/2006/relationships" xmlns:a="http://schemas.openxmlformats.org/drawingml/2006/main" r:embed="R5a3c4667fbfa46b3"/>
+          <a:blip xmlns:r="http://schemas.openxmlformats.org/officeDocument/2006/relationships" xmlns:a="http://schemas.openxmlformats.org/drawingml/2006/main" r:embed="R2e02d866ed564574"/>
           <a:stretch xmlns:a="http://schemas.openxmlformats.org/drawingml/2006/main"/>
         </p:blipFill>
         <p:spPr>
@@ -5247,7 +5247,7 @@
           <p:cNvPr id="4" name="">
             <a:extLst xmlns:a="http://schemas.openxmlformats.org/drawingml/2006/main">
               <a:ext uri="{FF2B5EF4-FFF2-40B4-BE49-F238E27FC236}">
-                <a16:creationId xmlns:a16="http://schemas.microsoft.com/office/drawing/2014/main" id="{D78AA00A-2B71-4C5F-AB7F-E044908661B6}"/>
+                <a16:creationId xmlns:a16="http://schemas.microsoft.com/office/drawing/2014/main" id="{7ADD2866-C0AE-447F-8355-BD923741E0CC}"/>
               </a:ext>
             </a:extLst>
           </p:cNvPr>
@@ -5319,7 +5319,7 @@
           <p:cNvPr id="5" name="">
             <a:extLst xmlns:a="http://schemas.openxmlformats.org/drawingml/2006/main">
               <a:ext uri="{FF2B5EF4-FFF2-40B4-BE49-F238E27FC236}">
-                <a16:creationId xmlns:a16="http://schemas.microsoft.com/office/drawing/2014/main" id="{7044622D-FA76-4EAF-BBDF-BC0DEDAB463A}"/>
+                <a16:creationId xmlns:a16="http://schemas.microsoft.com/office/drawing/2014/main" id="{9420BE06-00E2-40E6-806B-A20C8BF214D6}"/>
               </a:ext>
             </a:extLst>
           </p:cNvPr>
@@ -5391,7 +5391,7 @@
           <p:cNvPr id="6" name="">
             <a:extLst xmlns:a="http://schemas.openxmlformats.org/drawingml/2006/main">
               <a:ext uri="{FF2B5EF4-FFF2-40B4-BE49-F238E27FC236}">
-                <a16:creationId xmlns:a16="http://schemas.microsoft.com/office/drawing/2014/main" id="{068C5AB4-737D-45A5-A565-4B6B1C8AB448}"/>
+                <a16:creationId xmlns:a16="http://schemas.microsoft.com/office/drawing/2014/main" id="{78ED6A29-2FF0-432D-A10D-9DEA0B618836}"/>
               </a:ext>
             </a:extLst>
           </p:cNvPr>
@@ -5463,7 +5463,7 @@
           <p:cNvPr id="7" name="">
             <a:extLst xmlns:a="http://schemas.openxmlformats.org/drawingml/2006/main">
               <a:ext uri="{FF2B5EF4-FFF2-40B4-BE49-F238E27FC236}">
-                <a16:creationId xmlns:a16="http://schemas.microsoft.com/office/drawing/2014/main" id="{3995FE27-49CD-4941-B5BC-D6C38EEBA8B1}"/>
+                <a16:creationId xmlns:a16="http://schemas.microsoft.com/office/drawing/2014/main" id="{82E1BB47-20E9-4B26-8668-3A1167A689C7}"/>
               </a:ext>
             </a:extLst>
           </p:cNvPr>
@@ -5535,7 +5535,7 @@
           <p:cNvPr id="8" name="">
             <a:extLst xmlns:a="http://schemas.openxmlformats.org/drawingml/2006/main">
               <a:ext uri="{FF2B5EF4-FFF2-40B4-BE49-F238E27FC236}">
-                <a16:creationId xmlns:a16="http://schemas.microsoft.com/office/drawing/2014/main" id="{9F650FB1-06F4-4B30-91C6-2BC8A59965A6}"/>
+                <a16:creationId xmlns:a16="http://schemas.microsoft.com/office/drawing/2014/main" id="{0E16DF49-A3FB-4C87-B501-3A3264A27C7E}"/>
               </a:ext>
             </a:extLst>
           </p:cNvPr>
@@ -5605,7 +5605,7 @@
     </p:spTree>
     <p:extLst>
       <p:ext uri="{BB962C8B-B14F-4D97-AF65-F5344CB8AC3E}">
-        <p14:creationId xmlns:p14="http://schemas.microsoft.com/office/powerpoint/2010/main" val="1667724693"/>
+        <p14:creationId xmlns:p14="http://schemas.microsoft.com/office/powerpoint/2010/main" val="465805258"/>
       </p:ext>
     </p:extLst>
   </p:cSld>
@@ -5636,7 +5636,7 @@
           <p:cNvPr id="7" name="">
             <a:extLst xmlns:a="http://schemas.openxmlformats.org/drawingml/2006/main">
               <a:ext uri="{FF2B5EF4-FFF2-40B4-BE49-F238E27FC236}">
-                <a16:creationId xmlns:a16="http://schemas.microsoft.com/office/drawing/2014/main" id="{FB1808EC-2E13-4BA0-982B-1EF43D1995D2}"/>
+                <a16:creationId xmlns:a16="http://schemas.microsoft.com/office/drawing/2014/main" id="{4D88F204-8723-436A-BF7F-03B1E7F10E19}"/>
               </a:ext>
             </a:extLst>
           </p:cNvPr>
@@ -5708,7 +5708,7 @@
           <p:cNvPr id="2" name="">
             <a:extLst xmlns:a="http://schemas.openxmlformats.org/drawingml/2006/main">
               <a:ext uri="{FF2B5EF4-FFF2-40B4-BE49-F238E27FC236}">
-                <a16:creationId xmlns:a16="http://schemas.microsoft.com/office/drawing/2014/main" id="{82F66357-1293-4A68-B4F2-FD7E6360F6BC}"/>
+                <a16:creationId xmlns:a16="http://schemas.microsoft.com/office/drawing/2014/main" id="{04A40F4B-5382-42BB-B555-FE28CD3429F7}"/>
               </a:ext>
             </a:extLst>
           </p:cNvPr>
@@ -5780,7 +5780,7 @@
           <p:cNvPr id="3" name="Chart">
             <a:extLst xmlns:a="http://schemas.openxmlformats.org/drawingml/2006/main">
               <a:ext uri="{FF2B5EF4-FFF2-40B4-BE49-F238E27FC236}">
-                <a16:creationId xmlns:a16="http://schemas.microsoft.com/office/drawing/2014/main" id="{BE6B5CFE-E99A-4E75-B6FB-0361FF4D09F7}"/>
+                <a16:creationId xmlns:a16="http://schemas.microsoft.com/office/drawing/2014/main" id="{4819782F-2B50-43D3-80EB-D1D8C64785F6}"/>
               </a:ext>
             </a:extLst>
           </p:cNvPr>
@@ -5793,7 +5793,7 @@
         </p:xfrm>
         <a:graphic xmlns:a="http://schemas.openxmlformats.org/drawingml/2006/main">
           <a:graphicData uri="http://schemas.openxmlformats.org/drawingml/2006/chart">
-            <c:chart xmlns:r="http://schemas.openxmlformats.org/officeDocument/2006/relationships" xmlns:c="http://schemas.openxmlformats.org/drawingml/2006/chart" r:id="Rd814ae8aeb1741e1"/>
+            <c:chart xmlns:r="http://schemas.openxmlformats.org/officeDocument/2006/relationships" xmlns:c="http://schemas.openxmlformats.org/drawingml/2006/chart" r:id="R737f6c6caba24874"/>
           </a:graphicData>
         </a:graphic>
       </p:graphicFrame>
@@ -5802,7 +5802,7 @@
           <p:cNvPr id="4" name="">
             <a:extLst xmlns:a="http://schemas.openxmlformats.org/drawingml/2006/main">
               <a:ext uri="{FF2B5EF4-FFF2-40B4-BE49-F238E27FC236}">
-                <a16:creationId xmlns:a16="http://schemas.microsoft.com/office/drawing/2014/main" id="{9F003387-EB0F-4CDB-942B-B63147D5DB6F}"/>
+                <a16:creationId xmlns:a16="http://schemas.microsoft.com/office/drawing/2014/main" id="{63714EE2-9E5C-4D9B-A271-23F1B303A628}"/>
               </a:ext>
             </a:extLst>
           </p:cNvPr>
@@ -5874,7 +5874,7 @@
           <p:cNvPr id="5" name="">
             <a:extLst xmlns:a="http://schemas.openxmlformats.org/drawingml/2006/main">
               <a:ext uri="{FF2B5EF4-FFF2-40B4-BE49-F238E27FC236}">
-                <a16:creationId xmlns:a16="http://schemas.microsoft.com/office/drawing/2014/main" id="{742EE51F-07A0-49BE-9295-FBE6043852B4}"/>
+                <a16:creationId xmlns:a16="http://schemas.microsoft.com/office/drawing/2014/main" id="{A4CFC832-D3F4-4D84-9B35-69442FCCD750}"/>
               </a:ext>
             </a:extLst>
           </p:cNvPr>
@@ -5946,7 +5946,7 @@
           <p:cNvPr id="6" name="">
             <a:extLst xmlns:a="http://schemas.openxmlformats.org/drawingml/2006/main">
               <a:ext uri="{FF2B5EF4-FFF2-40B4-BE49-F238E27FC236}">
-                <a16:creationId xmlns:a16="http://schemas.microsoft.com/office/drawing/2014/main" id="{4FC0A719-5B98-47F6-801F-4507E801A28A}"/>
+                <a16:creationId xmlns:a16="http://schemas.microsoft.com/office/drawing/2014/main" id="{AE1027ED-4A1E-4EE1-B372-BEAC93788B38}"/>
               </a:ext>
             </a:extLst>
           </p:cNvPr>
@@ -6016,7 +6016,7 @@
     </p:spTree>
     <p:extLst>
       <p:ext uri="{BB962C8B-B14F-4D97-AF65-F5344CB8AC3E}">
-        <p14:creationId xmlns:p14="http://schemas.microsoft.com/office/powerpoint/2010/main" val="607872323"/>
+        <p14:creationId xmlns:p14="http://schemas.microsoft.com/office/powerpoint/2010/main" val="1580927308"/>
       </p:ext>
     </p:extLst>
   </p:cSld>
@@ -6047,7 +6047,7 @@
           <p:cNvPr id="4" name="">
             <a:extLst xmlns:a="http://schemas.openxmlformats.org/drawingml/2006/main">
               <a:ext uri="{FF2B5EF4-FFF2-40B4-BE49-F238E27FC236}">
-                <a16:creationId xmlns:a16="http://schemas.microsoft.com/office/drawing/2014/main" id="{2DBDE8B4-401F-4681-86EA-B0AAEF9035E2}"/>
+                <a16:creationId xmlns:a16="http://schemas.microsoft.com/office/drawing/2014/main" id="{C166774B-7F2B-48AF-9D5B-65941AAE0262}"/>
               </a:ext>
             </a:extLst>
           </p:cNvPr>
@@ -6119,7 +6119,7 @@
           <p:cNvPr id="2" name="">
             <a:extLst xmlns:a="http://schemas.openxmlformats.org/drawingml/2006/main">
               <a:ext uri="{FF2B5EF4-FFF2-40B4-BE49-F238E27FC236}">
-                <a16:creationId xmlns:a16="http://schemas.microsoft.com/office/drawing/2014/main" id="{A0A6F905-2E35-4455-88D9-F3D667A020C3}"/>
+                <a16:creationId xmlns:a16="http://schemas.microsoft.com/office/drawing/2014/main" id="{F0A6E468-D0C7-41BD-B066-6163EA746BE4}"/>
               </a:ext>
             </a:extLst>
           </p:cNvPr>
@@ -6181,7 +6181,7 @@
                           <a:ea typeface="Arial"/>
                           <a:cs typeface="Arial"/>
                         </a:rPr>
-                        <a:t>Proposed meaning to review</a:t>
+                        <a:t>Supported meaning and candidate detail</a:t>
                       </a:r>
                     </a:p>
                   </a:txBody>
@@ -6235,7 +6235,7 @@
                           <a:ea typeface="Arial"/>
                           <a:cs typeface="Arial"/>
                         </a:rPr>
-                        <a:t>Record model orientation relative to local east, north and up. A different map projection does not redefine it.</a:t>
+                        <a:t>Input-only meaning is supported. Stored quaternion versus one heading/pitch/roll tuple and its interpolation need review.</a:t>
                       </a:r>
                     </a:p>
                   </a:txBody>
@@ -6289,7 +6289,7 @@
                           <a:ea typeface="Arial"/>
                           <a:cs typeface="Arial"/>
                         </a:rPr>
-                        <a:t>Its ordinary scale, rotation and translation adjust placed geometry in a fixed project frame.</a:t>
+                        <a:t>Project adjustment meaning is supported. The detailed fixed working-frame convention remains a candidate.</a:t>
                       </a:r>
                     </a:p>
                   </a:txBody>
@@ -6343,7 +6343,7 @@
                           <a:ea typeface="Arial"/>
                           <a:cs typeface="Arial"/>
                         </a:rPr>
-                        <a:t>Child transforms define model-local geometry. Their offsets follow model axes instead of being silently reinterpreted as map axes.</a:t>
+                        <a:t>Model-local meaning is supported. The follow-up specifies chart/reset details and tests that offsets retain their interpretation.</a:t>
                       </a:r>
                     </a:p>
                   </a:txBody>
@@ -6471,7 +6471,7 @@
           <p:cNvPr id="3" name="">
             <a:extLst xmlns:a="http://schemas.openxmlformats.org/drawingml/2006/main">
               <a:ext uri="{FF2B5EF4-FFF2-40B4-BE49-F238E27FC236}">
-                <a16:creationId xmlns:a16="http://schemas.microsoft.com/office/drawing/2014/main" id="{B5918D31-1BFA-42CB-8361-4E5A1C15CE99}"/>
+                <a16:creationId xmlns:a16="http://schemas.microsoft.com/office/drawing/2014/main" id="{3318E34D-242F-4065-B85A-6DF13EC76921}"/>
               </a:ext>
             </a:extLst>
           </p:cNvPr>
@@ -6533,7 +6533,7 @@
                 <a:ea typeface="Arial"/>
                 <a:cs typeface="Arial"/>
               </a:rPr>
-              <a:t>These are definitions in the candidate, not new inferred behavior supplied by the demonstrations.</a:t>
+              <a:t>Review stored orientation and detailed conventions; keep the supported input-only meaning.</a:t>
             </a:r>
           </a:p>
         </p:txBody>
@@ -6541,7 +6541,7 @@
     </p:spTree>
     <p:extLst>
       <p:ext uri="{BB962C8B-B14F-4D97-AF65-F5344CB8AC3E}">
-        <p14:creationId xmlns:p14="http://schemas.microsoft.com/office/powerpoint/2010/main" val="74984838"/>
+        <p14:creationId xmlns:p14="http://schemas.microsoft.com/office/powerpoint/2010/main" val="2059646077"/>
       </p:ext>
     </p:extLst>
   </p:cSld>
@@ -6572,7 +6572,7 @@
           <p:cNvPr id="4" name="">
             <a:extLst xmlns:a="http://schemas.openxmlformats.org/drawingml/2006/main">
               <a:ext uri="{FF2B5EF4-FFF2-40B4-BE49-F238E27FC236}">
-                <a16:creationId xmlns:a16="http://schemas.microsoft.com/office/drawing/2014/main" id="{56924FCE-E771-4274-9C8A-8F437FFA3A46}"/>
+                <a16:creationId xmlns:a16="http://schemas.microsoft.com/office/drawing/2014/main" id="{93DD7A22-F0D1-4E8E-A06D-1313101D09B7}"/>
               </a:ext>
             </a:extLst>
           </p:cNvPr>
@@ -6644,7 +6644,7 @@
           <p:cNvPr id="2" name="">
             <a:extLst xmlns:a="http://schemas.openxmlformats.org/drawingml/2006/main">
               <a:ext uri="{FF2B5EF4-FFF2-40B4-BE49-F238E27FC236}">
-                <a16:creationId xmlns:a16="http://schemas.microsoft.com/office/drawing/2014/main" id="{C8D4C97B-0688-47D3-9A28-EF2529166536}"/>
+                <a16:creationId xmlns:a16="http://schemas.microsoft.com/office/drawing/2014/main" id="{E85426E1-D85F-409F-92C1-18F056F48C77}"/>
               </a:ext>
             </a:extLst>
           </p:cNvPr>
@@ -6706,7 +6706,7 @@
                           <a:ea typeface="Arial"/>
                           <a:cs typeface="Arial"/>
                         </a:rPr>
-                        <a:t>Proposed meaning to review</a:t>
+                        <a:t>Supported meaning and candidate detail</a:t>
                       </a:r>
                     </a:p>
                   </a:txBody>
@@ -6976,7 +6976,7 @@
                           <a:ea typeface="Arial"/>
                           <a:cs typeface="Arial"/>
                         </a:rPr>
-                        <a:t>Keep a Cartesian CRS context without an active placement binding, so readers do not apply georeferencing a second time.</a:t>
+                        <a:t>Record a Cartesian CRS and ordinary double-precision origin. Preserve precision and space/time coverage.</a:t>
                       </a:r>
                     </a:p>
                   </a:txBody>
@@ -6996,7 +6996,7 @@
           <p:cNvPr id="3" name="">
             <a:extLst xmlns:a="http://schemas.openxmlformats.org/drawingml/2006/main">
               <a:ext uri="{FF2B5EF4-FFF2-40B4-BE49-F238E27FC236}">
-                <a16:creationId xmlns:a16="http://schemas.microsoft.com/office/drawing/2014/main" id="{5E1EB3FB-1996-43D8-9924-A0DD436F2AAB}"/>
+                <a16:creationId xmlns:a16="http://schemas.microsoft.com/office/drawing/2014/main" id="{1CB5E1FF-DAD5-413D-B09B-2CF3FE0ED234}"/>
               </a:ext>
             </a:extLst>
           </p:cNvPr>
@@ -7066,7 +7066,7 @@
     </p:spTree>
     <p:extLst>
       <p:ext uri="{BB962C8B-B14F-4D97-AF65-F5344CB8AC3E}">
-        <p14:creationId xmlns:p14="http://schemas.microsoft.com/office/powerpoint/2010/main" val="1024770362"/>
+        <p14:creationId xmlns:p14="http://schemas.microsoft.com/office/powerpoint/2010/main" val="1354288103"/>
       </p:ext>
     </p:extLst>
   </p:cSld>
@@ -7097,7 +7097,7 @@
           <p:cNvPr id="4" name="">
             <a:extLst xmlns:a="http://schemas.openxmlformats.org/drawingml/2006/main">
               <a:ext uri="{FF2B5EF4-FFF2-40B4-BE49-F238E27FC236}">
-                <a16:creationId xmlns:a16="http://schemas.microsoft.com/office/drawing/2014/main" id="{74A59391-F3FC-44F9-87DD-9DD6A1A40D74}"/>
+                <a16:creationId xmlns:a16="http://schemas.microsoft.com/office/drawing/2014/main" id="{0A8DA65A-F5AE-4A29-A568-644D37B5B6A5}"/>
               </a:ext>
             </a:extLst>
           </p:cNvPr>
@@ -7169,7 +7169,7 @@
           <p:cNvPr id="2" name="">
             <a:extLst xmlns:a="http://schemas.openxmlformats.org/drawingml/2006/main">
               <a:ext uri="{FF2B5EF4-FFF2-40B4-BE49-F238E27FC236}">
-                <a16:creationId xmlns:a16="http://schemas.microsoft.com/office/drawing/2014/main" id="{6658C26E-BB19-41F0-80C1-917DCDB7B0BE}"/>
+                <a16:creationId xmlns:a16="http://schemas.microsoft.com/office/drawing/2014/main" id="{880D8B17-AEEC-438A-88BC-789A1370D361}"/>
               </a:ext>
             </a:extLst>
           </p:cNvPr>
@@ -7447,7 +7447,7 @@
                           <a:ea typeface="Arial"/>
                           <a:cs typeface="Arial"/>
                         </a:rPr>
-                        <a:t>64 regressions and 61 distinguishing controls passed. The later audit exposes cases the suite missed.</a:t>
+                        <a:t>70 regressions and 61 distinguishing controls passed. Fresh independent diagnostics verify six repairs and retain the unresolved normal case.</a:t>
                       </a:r>
                     </a:p>
                   </a:txBody>
@@ -7555,7 +7555,7 @@
                           <a:ea typeface="Arial"/>
                           <a:cs typeface="Arial"/>
                         </a:rPr>
-                        <a:t>11 selected exports were checked. The later nested-geometry case demonstrates that the original inventory check was incomplete.</a:t>
+                        <a:t>11 selected exports were checked. The fresh nested-geometry counterexample verifies the complete inventory, including unexpected extras.</a:t>
                       </a:r>
                     </a:p>
                   </a:txBody>
@@ -7575,7 +7575,7 @@
           <p:cNvPr id="3" name="">
             <a:extLst xmlns:a="http://schemas.openxmlformats.org/drawingml/2006/main">
               <a:ext uri="{FF2B5EF4-FFF2-40B4-BE49-F238E27FC236}">
-                <a16:creationId xmlns:a16="http://schemas.microsoft.com/office/drawing/2014/main" id="{0C805AAC-28C6-492F-84CF-DBB3B771503D}"/>
+                <a16:creationId xmlns:a16="http://schemas.microsoft.com/office/drawing/2014/main" id="{799C3C2D-0E32-433F-A1CD-8C840C554423}"/>
               </a:ext>
             </a:extLst>
           </p:cNvPr>
@@ -7645,7 +7645,7 @@
     </p:spTree>
     <p:extLst>
       <p:ext uri="{BB962C8B-B14F-4D97-AF65-F5344CB8AC3E}">
-        <p14:creationId xmlns:p14="http://schemas.microsoft.com/office/powerpoint/2010/main" val="115224191"/>
+        <p14:creationId xmlns:p14="http://schemas.microsoft.com/office/powerpoint/2010/main" val="1941559474"/>
       </p:ext>
     </p:extLst>
   </p:cSld>
@@ -7676,7 +7676,7 @@
           <p:cNvPr id="5" name="">
             <a:extLst xmlns:a="http://schemas.openxmlformats.org/drawingml/2006/main">
               <a:ext uri="{FF2B5EF4-FFF2-40B4-BE49-F238E27FC236}">
-                <a16:creationId xmlns:a16="http://schemas.microsoft.com/office/drawing/2014/main" id="{51D3FA83-3CF0-4D29-80A1-A92E66F44436}"/>
+                <a16:creationId xmlns:a16="http://schemas.microsoft.com/office/drawing/2014/main" id="{16E05D2E-B59A-4A21-AE8D-177F977D3D34}"/>
               </a:ext>
             </a:extLst>
           </p:cNvPr>
@@ -7748,7 +7748,7 @@
           <p:cNvPr id="2" name="">
             <a:extLst xmlns:a="http://schemas.openxmlformats.org/drawingml/2006/main">
               <a:ext uri="{FF2B5EF4-FFF2-40B4-BE49-F238E27FC236}">
-                <a16:creationId xmlns:a16="http://schemas.microsoft.com/office/drawing/2014/main" id="{47D4F09B-0FC0-4AEF-BCFF-648BA4FDC251}"/>
+                <a16:creationId xmlns:a16="http://schemas.microsoft.com/office/drawing/2014/main" id="{7A894154-04AC-445D-9F96-91709503C409}"/>
               </a:ext>
             </a:extLst>
           </p:cNvPr>
@@ -7820,7 +7820,7 @@
           <p:cNvPr id="3" name="">
             <a:extLst xmlns:a="http://schemas.openxmlformats.org/drawingml/2006/main">
               <a:ext uri="{FF2B5EF4-FFF2-40B4-BE49-F238E27FC236}">
-                <a16:creationId xmlns:a16="http://schemas.microsoft.com/office/drawing/2014/main" id="{5CF45E00-BF87-475F-B612-865502752FD2}"/>
+                <a16:creationId xmlns:a16="http://schemas.microsoft.com/office/drawing/2014/main" id="{6FB36966-D90A-45AC-81F1-BDA953897139}"/>
               </a:ext>
             </a:extLst>
           </p:cNvPr>
@@ -8118,7 +8118,7 @@
           <p:cNvPr id="4" name="">
             <a:extLst xmlns:a="http://schemas.openxmlformats.org/drawingml/2006/main">
               <a:ext uri="{FF2B5EF4-FFF2-40B4-BE49-F238E27FC236}">
-                <a16:creationId xmlns:a16="http://schemas.microsoft.com/office/drawing/2014/main" id="{AC9A4B84-0A44-491B-8109-BFFA354A6E4E}"/>
+                <a16:creationId xmlns:a16="http://schemas.microsoft.com/office/drawing/2014/main" id="{921F0828-9793-4813-A65B-ADFABF4CBDF3}"/>
               </a:ext>
             </a:extLst>
           </p:cNvPr>
@@ -8188,7 +8188,7 @@
     </p:spTree>
     <p:extLst>
       <p:ext uri="{BB962C8B-B14F-4D97-AF65-F5344CB8AC3E}">
-        <p14:creationId xmlns:p14="http://schemas.microsoft.com/office/powerpoint/2010/main" val="1186204746"/>
+        <p14:creationId xmlns:p14="http://schemas.microsoft.com/office/powerpoint/2010/main" val="1763462481"/>
       </p:ext>
     </p:extLst>
   </p:cSld>
@@ -8219,7 +8219,7 @@
           <ns0:cNvPr id="9" name="">
             <ns1:extLst>
               <ns1:ext uri="{FF2B5EF4-FFF2-40B4-BE49-F238E27FC236}">
-                <ns2:creationId id="{A8997B19-FBF6-432E-9D97-F01C839DB4EB}"/>
+                <ns2:creationId id="{3D86A9BA-8A12-415A-BFB4-AFE6D8B382F5}"/>
               </ns1:ext>
             </ns1:extLst>
           </ns0:cNvPr>
@@ -8291,7 +8291,7 @@
           <ns0:cNvPr id="2" name="">
             <ns1:extLst>
               <ns1:ext uri="{FF2B5EF4-FFF2-40B4-BE49-F238E27FC236}">
-                <ns2:creationId id="{A0046876-670D-44A8-BB36-C1818ACA27BE}"/>
+                <ns2:creationId id="{95DF31BE-574A-427B-899C-1A671E863588}"/>
               </ns1:ext>
             </ns1:extLst>
           </ns0:cNvPr>
@@ -8363,7 +8363,7 @@
           <ns0:cNvPr id="3" name="">
             <ns1:extLst>
               <ns1:ext uri="{FF2B5EF4-FFF2-40B4-BE49-F238E27FC236}">
-                <ns2:creationId id="{AE6A5364-26FC-4894-B9BA-E8C98454E129}"/>
+                <ns2:creationId id="{D1B9E510-DBB8-4A17-A926-CC2A7BC0E611}"/>
               </ns1:ext>
             </ns1:extLst>
           </ns0:cNvPr>
@@ -8373,7 +8373,7 @@
           <ns0:nvPr/>
         </ns0:nvPicPr>
         <ns0:blipFill>
-          <ns1:blip ns3:embed="Rfd4a5a114129447e"/>
+          <ns1:blip ns3:embed="Rb8d858c899bd4a9d"/>
           <ns1:srcRect l="0" t="8974" r="0" b="33333"/>
           <ns1:stretch/>
         </ns0:blipFill>
@@ -8392,7 +8392,7 @@
           <ns0:cNvPr id="4" name="">
             <ns1:extLst>
               <ns1:ext uri="{FF2B5EF4-FFF2-40B4-BE49-F238E27FC236}">
-                <ns2:creationId id="{793B4E92-1261-4548-9CFD-6623CC26C48C}"/>
+                <ns2:creationId id="{AA1FB82F-B4E3-4407-BC1E-6CB4CAD6D4A2}"/>
               </ns1:ext>
             </ns1:extLst>
           </ns0:cNvPr>
@@ -8464,7 +8464,7 @@
           <ns0:cNvPr id="5" name="">
             <ns1:extLst>
               <ns1:ext uri="{FF2B5EF4-FFF2-40B4-BE49-F238E27FC236}">
-                <ns2:creationId id="{B89751A4-573F-47A5-87F4-C1863A5E5A88}"/>
+                <ns2:creationId id="{AFBC5CDA-3B79-4986-B954-948331925C04}"/>
               </ns1:ext>
             </ns1:extLst>
           </ns0:cNvPr>
@@ -8536,7 +8536,7 @@
           <ns0:cNvPr id="6" name="">
             <ns1:extLst>
               <ns1:ext uri="{FF2B5EF4-FFF2-40B4-BE49-F238E27FC236}">
-                <ns2:creationId id="{691ADE80-F196-470B-B53E-A5698918D270}"/>
+                <ns2:creationId id="{5E7D78C6-AD82-4579-A2AB-45EC61855353}"/>
               </ns1:ext>
             </ns1:extLst>
           </ns0:cNvPr>
@@ -8608,7 +8608,7 @@
           <ns0:cNvPr id="7" name="">
             <ns1:extLst>
               <ns1:ext uri="{FF2B5EF4-FFF2-40B4-BE49-F238E27FC236}">
-                <ns2:creationId id="{88C1F53E-E920-409D-A9F0-FC162DDCA51F}"/>
+                <ns2:creationId id="{F5C322F2-F9BD-4F8E-9897-CB49546197A9}"/>
               </ns1:ext>
             </ns1:extLst>
           </ns0:cNvPr>
@@ -8680,7 +8680,7 @@
           <ns0:cNvPr id="8" name="">
             <ns1:extLst>
               <ns1:ext uri="{FF2B5EF4-FFF2-40B4-BE49-F238E27FC236}">
-                <ns2:creationId id="{F036CAFA-53D5-4192-8777-444138BA875A}"/>
+                <ns2:creationId id="{7187F4B5-F0FB-492A-9A32-9AAD47943FD7}"/>
               </ns1:ext>
             </ns1:extLst>
           </ns0:cNvPr>
@@ -8750,7 +8750,7 @@
     </ns0:spTree>
     <ns0:extLst>
       <ns0:ext uri="{BB962C8B-B14F-4D97-AF65-F5344CB8AC3E}">
-        <ns4:creationId val="342702757"/>
+        <ns4:creationId val="773685833"/>
       </ns0:ext>
     </ns0:extLst>
   </ns0:cSld>
@@ -8781,7 +8781,7 @@
           <ns0:cNvPr id="9" name="">
             <ns1:extLst>
               <ns1:ext uri="{FF2B5EF4-FFF2-40B4-BE49-F238E27FC236}">
-                <ns2:creationId id="{660F4F99-9711-46BE-A86F-64F56A35CD52}"/>
+                <ns2:creationId id="{1C1CDA5B-1267-47BD-B596-97FA948C4411}"/>
               </ns1:ext>
             </ns1:extLst>
           </ns0:cNvPr>
@@ -8853,7 +8853,7 @@
           <ns0:cNvPr id="2" name="">
             <ns1:extLst>
               <ns1:ext uri="{FF2B5EF4-FFF2-40B4-BE49-F238E27FC236}">
-                <ns2:creationId id="{6FEFF846-2D8C-4E48-BAE8-B5619BDCC334}"/>
+                <ns2:creationId id="{0EE40F72-06B4-4962-822C-46F180EFB9A6}"/>
               </ns1:ext>
             </ns1:extLst>
           </ns0:cNvPr>
@@ -8925,7 +8925,7 @@
           <ns0:cNvPr id="3" name="">
             <ns1:extLst>
               <ns1:ext uri="{FF2B5EF4-FFF2-40B4-BE49-F238E27FC236}">
-                <ns2:creationId id="{427A7AFA-4EE7-4987-B107-12D9E4F62684}"/>
+                <ns2:creationId id="{5B2F041A-55EA-4CF6-B4CB-DDC39D22D3DD}"/>
               </ns1:ext>
             </ns1:extLst>
           </ns0:cNvPr>
@@ -8935,7 +8935,7 @@
           <ns0:nvPr/>
         </ns0:nvPicPr>
         <ns0:blipFill>
-          <ns1:blip ns3:embed="R46ca8c7b4f3c44ef"/>
+          <ns1:blip ns3:embed="Rd07a50b13ce94e34"/>
           <ns1:srcRect l="0" t="8974" r="0" b="33333"/>
           <ns1:stretch/>
         </ns0:blipFill>
@@ -8954,7 +8954,7 @@
           <ns0:cNvPr id="4" name="">
             <ns1:extLst>
               <ns1:ext uri="{FF2B5EF4-FFF2-40B4-BE49-F238E27FC236}">
-                <ns2:creationId id="{738DA97F-3CF6-42EA-AA2B-270B77F4A3E0}"/>
+                <ns2:creationId id="{2AFA0065-3D73-4AB4-93BA-76B91A21689E}"/>
               </ns1:ext>
             </ns1:extLst>
           </ns0:cNvPr>
@@ -9026,7 +9026,7 @@
           <ns0:cNvPr id="5" name="">
             <ns1:extLst>
               <ns1:ext uri="{FF2B5EF4-FFF2-40B4-BE49-F238E27FC236}">
-                <ns2:creationId id="{8EC15DC7-B656-4DFA-AB7E-393AB3CC1B96}"/>
+                <ns2:creationId id="{60A36E72-4900-410B-B28D-FD54E2625377}"/>
               </ns1:ext>
             </ns1:extLst>
           </ns0:cNvPr>
@@ -9098,7 +9098,7 @@
           <ns0:cNvPr id="6" name="">
             <ns1:extLst>
               <ns1:ext uri="{FF2B5EF4-FFF2-40B4-BE49-F238E27FC236}">
-                <ns2:creationId id="{D783CBEA-A742-47F5-BC74-1BA013814A04}"/>
+                <ns2:creationId id="{E7275140-8A84-4DC4-B145-B6805AB43F50}"/>
               </ns1:ext>
             </ns1:extLst>
           </ns0:cNvPr>
@@ -9170,7 +9170,7 @@
           <ns0:cNvPr id="7" name="">
             <ns1:extLst>
               <ns1:ext uri="{FF2B5EF4-FFF2-40B4-BE49-F238E27FC236}">
-                <ns2:creationId id="{B845B4EC-CD2B-4090-8330-61420B51D03D}"/>
+                <ns2:creationId id="{58C9DD7D-66BF-432A-9FC4-B91012BC2DA9}"/>
               </ns1:ext>
             </ns1:extLst>
           </ns0:cNvPr>
@@ -9232,7 +9232,7 @@
                 <ns1:ea typeface="Arial"/>
                 <ns1:cs typeface="Arial"/>
               </ns1:rPr>
-              <ns1:t>Order changes the result. The control makes the proposed child-transform choice reviewable; matching readers do not establish agreement.</ns1:t>
+              <ns1:t>Order changes the result. The control tests the agreed anchor/child distinction while detailed chart and instance conventions remain candidates.</ns1:t>
             </ns1:r>
           </ns1:p>
         </ns0:txBody>
@@ -9242,7 +9242,7 @@
           <ns0:cNvPr id="8" name="">
             <ns1:extLst>
               <ns1:ext uri="{FF2B5EF4-FFF2-40B4-BE49-F238E27FC236}">
-                <ns2:creationId id="{7D9C4843-0C26-4430-A117-03FF13E0D239}"/>
+                <ns2:creationId id="{640CC6FE-9A8D-4087-B2FE-61F6458301F3}"/>
               </ns1:ext>
             </ns1:extLst>
           </ns0:cNvPr>
@@ -9312,7 +9312,7 @@
     </ns0:spTree>
     <ns0:extLst>
       <ns0:ext uri="{BB962C8B-B14F-4D97-AF65-F5344CB8AC3E}">
-        <ns4:creationId val="912373193"/>
+        <ns4:creationId val="1795429975"/>
       </ns0:ext>
     </ns0:extLst>
   </ns0:cSld>
@@ -9343,7 +9343,7 @@
           <p:cNvPr id="8" name="">
             <a:extLst xmlns:a="http://schemas.openxmlformats.org/drawingml/2006/main">
               <a:ext uri="{FF2B5EF4-FFF2-40B4-BE49-F238E27FC236}">
-                <a16:creationId xmlns:a16="http://schemas.microsoft.com/office/drawing/2014/main" id="{CC556289-84F8-4CB8-BF07-FAEA60A311E8}"/>
+                <a16:creationId xmlns:a16="http://schemas.microsoft.com/office/drawing/2014/main" id="{4D88F6AE-F813-4737-BF5A-96A71640419A}"/>
               </a:ext>
             </a:extLst>
           </p:cNvPr>
@@ -9415,7 +9415,7 @@
           <p:cNvPr id="2" name="">
             <a:extLst xmlns:a="http://schemas.openxmlformats.org/drawingml/2006/main">
               <a:ext uri="{FF2B5EF4-FFF2-40B4-BE49-F238E27FC236}">
-                <a16:creationId xmlns:a16="http://schemas.microsoft.com/office/drawing/2014/main" id="{D60B97B2-4F20-47A1-AC76-79281264E868}"/>
+                <a16:creationId xmlns:a16="http://schemas.microsoft.com/office/drawing/2014/main" id="{B5EA8A7B-7FD6-4053-AA70-4E6294F30597}"/>
               </a:ext>
             </a:extLst>
           </p:cNvPr>
@@ -9487,7 +9487,7 @@
           <p:cNvPr id="3" name="">
             <a:extLst xmlns:a="http://schemas.openxmlformats.org/drawingml/2006/main">
               <a:ext uri="{FF2B5EF4-FFF2-40B4-BE49-F238E27FC236}">
-                <a16:creationId xmlns:a16="http://schemas.microsoft.com/office/drawing/2014/main" id="{D7DC10D9-5E66-4882-B7E2-D5E55D31EAE2}"/>
+                <a16:creationId xmlns:a16="http://schemas.microsoft.com/office/drawing/2014/main" id="{6A96EAB3-9548-4F44-9D49-1DA69B1EB6D6}"/>
               </a:ext>
             </a:extLst>
           </p:cNvPr>
@@ -9559,7 +9559,7 @@
           <p:cNvPr id="4" name="">
             <a:extLst xmlns:a="http://schemas.openxmlformats.org/drawingml/2006/main">
               <a:ext uri="{FF2B5EF4-FFF2-40B4-BE49-F238E27FC236}">
-                <a16:creationId xmlns:a16="http://schemas.microsoft.com/office/drawing/2014/main" id="{D5D1D4AE-4C5D-4135-BE8E-D259CE924804}"/>
+                <a16:creationId xmlns:a16="http://schemas.microsoft.com/office/drawing/2014/main" id="{D4AA487A-6D8C-4CA0-8A55-38B25EA0726C}"/>
               </a:ext>
             </a:extLst>
           </p:cNvPr>
@@ -9908,7 +9908,7 @@
           <p:cNvPr id="5" name="">
             <a:extLst xmlns:a="http://schemas.openxmlformats.org/drawingml/2006/main">
               <a:ext uri="{FF2B5EF4-FFF2-40B4-BE49-F238E27FC236}">
-                <a16:creationId xmlns:a16="http://schemas.microsoft.com/office/drawing/2014/main" id="{24BC7458-6C3C-4DCC-AC2B-509F1BDECCF4}"/>
+                <a16:creationId xmlns:a16="http://schemas.microsoft.com/office/drawing/2014/main" id="{9E09BC29-F537-4556-88DC-D3E9A3FB86EA}"/>
               </a:ext>
             </a:extLst>
           </p:cNvPr>
@@ -9980,7 +9980,7 @@
           <p:cNvPr id="6" name="">
             <a:extLst xmlns:a="http://schemas.openxmlformats.org/drawingml/2006/main">
               <a:ext uri="{FF2B5EF4-FFF2-40B4-BE49-F238E27FC236}">
-                <a16:creationId xmlns:a16="http://schemas.microsoft.com/office/drawing/2014/main" id="{36FD42DF-65F8-436F-A290-8B1D41FA9F6D}"/>
+                <a16:creationId xmlns:a16="http://schemas.microsoft.com/office/drawing/2014/main" id="{22300BC3-E6C5-42C0-A782-43161CFFA228}"/>
               </a:ext>
             </a:extLst>
           </p:cNvPr>
@@ -10329,7 +10329,7 @@
           <p:cNvPr id="7" name="">
             <a:extLst xmlns:a="http://schemas.openxmlformats.org/drawingml/2006/main">
               <a:ext uri="{FF2B5EF4-FFF2-40B4-BE49-F238E27FC236}">
-                <a16:creationId xmlns:a16="http://schemas.microsoft.com/office/drawing/2014/main" id="{4E918993-3FE6-46E1-8C8A-526DEB4D516F}"/>
+                <a16:creationId xmlns:a16="http://schemas.microsoft.com/office/drawing/2014/main" id="{AB736EB1-4787-4B8D-8DE7-72346DD23DB1}"/>
               </a:ext>
             </a:extLst>
           </p:cNvPr>
@@ -10391,7 +10391,7 @@
                 <a:ea typeface="Arial"/>
                 <a:cs typeface="Arial"/>
               </a:rPr>
-              <a:t>Both readers use PROJ, the same CRS conversion library, and share native dataset decoding.</a:t>
+              <a:t>Both readers use PROJ and share dataset decoding.</a:t>
             </a:r>
           </a:p>
         </p:txBody>
@@ -10399,7 +10399,7 @@
     </p:spTree>
     <p:extLst>
       <p:ext uri="{BB962C8B-B14F-4D97-AF65-F5344CB8AC3E}">
-        <p14:creationId xmlns:p14="http://schemas.microsoft.com/office/powerpoint/2010/main" val="1240854999"/>
+        <p14:creationId xmlns:p14="http://schemas.microsoft.com/office/powerpoint/2010/main" val="1433457696"/>
       </p:ext>
     </p:extLst>
   </p:cSld>
@@ -10430,7 +10430,7 @@
           <p:cNvPr id="9" name="">
             <a:extLst xmlns:a="http://schemas.openxmlformats.org/drawingml/2006/main">
               <a:ext uri="{FF2B5EF4-FFF2-40B4-BE49-F238E27FC236}">
-                <a16:creationId xmlns:a16="http://schemas.microsoft.com/office/drawing/2014/main" id="{1D7067A2-1238-4C49-B217-6691362A3C61}"/>
+                <a16:creationId xmlns:a16="http://schemas.microsoft.com/office/drawing/2014/main" id="{3CC839B3-EF91-499F-B0CF-FC7A652E98A4}"/>
               </a:ext>
             </a:extLst>
           </p:cNvPr>
@@ -10502,7 +10502,7 @@
           <p:cNvPr id="2" name="">
             <a:extLst xmlns:a="http://schemas.openxmlformats.org/drawingml/2006/main">
               <a:ext uri="{FF2B5EF4-FFF2-40B4-BE49-F238E27FC236}">
-                <a16:creationId xmlns:a16="http://schemas.microsoft.com/office/drawing/2014/main" id="{5A64ED0F-A8AD-4663-A6AF-4E0E8FA9B207}"/>
+                <a16:creationId xmlns:a16="http://schemas.microsoft.com/office/drawing/2014/main" id="{E8EB1B87-B39E-4EDA-A365-0F8D1CF10E12}"/>
               </a:ext>
             </a:extLst>
           </p:cNvPr>
@@ -10574,7 +10574,7 @@
           <p:cNvPr id="3" name="">
             <a:extLst xmlns:a="http://schemas.openxmlformats.org/drawingml/2006/main">
               <a:ext uri="{FF2B5EF4-FFF2-40B4-BE49-F238E27FC236}">
-                <a16:creationId xmlns:a16="http://schemas.microsoft.com/office/drawing/2014/main" id="{605AD69D-7903-42F5-AE7F-52959F8A7CE7}"/>
+                <a16:creationId xmlns:a16="http://schemas.microsoft.com/office/drawing/2014/main" id="{CD20ACF7-D592-43B7-AB26-2A9305C3A05B}"/>
               </a:ext>
             </a:extLst>
           </p:cNvPr>
@@ -10584,7 +10584,7 @@
           <p:nvPr/>
         </p:nvPicPr>
         <p:blipFill>
-          <a:blip xmlns:r="http://schemas.openxmlformats.org/officeDocument/2006/relationships" xmlns:a="http://schemas.openxmlformats.org/drawingml/2006/main" r:embed="R8b7aa18c79314023"/>
+          <a:blip xmlns:r="http://schemas.openxmlformats.org/officeDocument/2006/relationships" xmlns:a="http://schemas.openxmlformats.org/drawingml/2006/main" r:embed="R69731ffa422042f8"/>
           <a:stretch xmlns:a="http://schemas.openxmlformats.org/drawingml/2006/main"/>
         </p:blipFill>
         <p:spPr>
@@ -10602,7 +10602,7 @@
           <p:cNvPr id="4" name="">
             <a:extLst xmlns:a="http://schemas.openxmlformats.org/drawingml/2006/main">
               <a:ext uri="{FF2B5EF4-FFF2-40B4-BE49-F238E27FC236}">
-                <a16:creationId xmlns:a16="http://schemas.microsoft.com/office/drawing/2014/main" id="{39EF8DE5-BCA5-4D0B-BCCB-28001A13F029}"/>
+                <a16:creationId xmlns:a16="http://schemas.microsoft.com/office/drawing/2014/main" id="{EF80E8D1-1151-4D88-AC43-511AC9C69B6C}"/>
               </a:ext>
             </a:extLst>
           </p:cNvPr>
@@ -10674,7 +10674,7 @@
           <p:cNvPr id="5" name="">
             <a:extLst xmlns:a="http://schemas.openxmlformats.org/drawingml/2006/main">
               <a:ext uri="{FF2B5EF4-FFF2-40B4-BE49-F238E27FC236}">
-                <a16:creationId xmlns:a16="http://schemas.microsoft.com/office/drawing/2014/main" id="{D65B6ED9-060B-4EA8-8B56-5835EBE71B34}"/>
+                <a16:creationId xmlns:a16="http://schemas.microsoft.com/office/drawing/2014/main" id="{C8E54E40-F8C1-4638-A7A0-CEF1138A6FF7}"/>
               </a:ext>
             </a:extLst>
           </p:cNvPr>
@@ -10736,7 +10736,7 @@
                 <a:ea typeface="Arial"/>
                 <a:cs typeface="Arial"/>
               </a:rPr>
-              <a:t>The C++ reader's resolved Eiffel copy reaches Hydra/Storm, a USD rendering path. This image is actual output from the recorded run.</a:t>
+              <a:t>Native Hydra/Storm renders the ordinary USD bake. A double-precision origin keeps local points small; fresh readers recover the placement.</a:t>
             </a:r>
           </a:p>
         </p:txBody>
@@ -10746,7 +10746,7 @@
           <p:cNvPr id="6" name="">
             <a:extLst xmlns:a="http://schemas.openxmlformats.org/drawingml/2006/main">
               <a:ext uri="{FF2B5EF4-FFF2-40B4-BE49-F238E27FC236}">
-                <a16:creationId xmlns:a16="http://schemas.microsoft.com/office/drawing/2014/main" id="{A159CD9D-9221-45D4-A770-A0324CBF5D5D}"/>
+                <a16:creationId xmlns:a16="http://schemas.microsoft.com/office/drawing/2014/main" id="{E566D8F5-262D-4793-AADD-D8550E010C33}"/>
               </a:ext>
             </a:extLst>
           </p:cNvPr>
@@ -10818,7 +10818,7 @@
           <p:cNvPr id="7" name="">
             <a:extLst xmlns:a="http://schemas.openxmlformats.org/drawingml/2006/main">
               <a:ext uri="{FF2B5EF4-FFF2-40B4-BE49-F238E27FC236}">
-                <a16:creationId xmlns:a16="http://schemas.microsoft.com/office/drawing/2014/main" id="{A55F29CC-4D69-403A-929D-8D74CF66577C}"/>
+                <a16:creationId xmlns:a16="http://schemas.microsoft.com/office/drawing/2014/main" id="{C2A21F56-1397-45AB-80BE-51BE6A1CF5ED}"/>
               </a:ext>
             </a:extLst>
           </p:cNvPr>
@@ -10880,7 +10880,7 @@
                 <a:ea typeface="Arial"/>
                 <a:cs typeface="Arial"/>
               </a:rPr>
-              <a:t>This case shows compatibility with an ordinary USD renderer. A separate nested-geometry failure prevents a claim that every bake is correct.</a:t>
+              <a:t>Unaware viewers receive resolved ordinary geometry. Fresh checks reject duplicate meshes and retain an unrelated applied schema.</a:t>
             </a:r>
           </a:p>
         </p:txBody>
@@ -10890,7 +10890,7 @@
           <p:cNvPr id="8" name="">
             <a:extLst xmlns:a="http://schemas.openxmlformats.org/drawingml/2006/main">
               <a:ext uri="{FF2B5EF4-FFF2-40B4-BE49-F238E27FC236}">
-                <a16:creationId xmlns:a16="http://schemas.microsoft.com/office/drawing/2014/main" id="{93D7C810-AF82-4BDE-9908-6F9A539BCF85}"/>
+                <a16:creationId xmlns:a16="http://schemas.microsoft.com/office/drawing/2014/main" id="{236DBB13-2B5B-48D3-B2AC-E7AA50E5A065}"/>
               </a:ext>
             </a:extLst>
           </p:cNvPr>
@@ -10960,7 +10960,7 @@
     </p:spTree>
     <p:extLst>
       <p:ext uri="{BB962C8B-B14F-4D97-AF65-F5344CB8AC3E}">
-        <p14:creationId xmlns:p14="http://schemas.microsoft.com/office/powerpoint/2010/main" val="649580977"/>
+        <p14:creationId xmlns:p14="http://schemas.microsoft.com/office/powerpoint/2010/main" val="493390405"/>
       </p:ext>
     </p:extLst>
   </p:cSld>
@@ -10991,7 +10991,7 @@
           <p:cNvPr id="6" name="">
             <a:extLst xmlns:a="http://schemas.openxmlformats.org/drawingml/2006/main">
               <a:ext uri="{FF2B5EF4-FFF2-40B4-BE49-F238E27FC236}">
-                <a16:creationId xmlns:a16="http://schemas.microsoft.com/office/drawing/2014/main" id="{92F94A92-7B97-49EE-97A3-DDFF37A06220}"/>
+                <a16:creationId xmlns:a16="http://schemas.microsoft.com/office/drawing/2014/main" id="{0ADEBFD0-223D-499A-9C9D-EEB69517B6A7}"/>
               </a:ext>
             </a:extLst>
           </p:cNvPr>
@@ -11063,7 +11063,7 @@
           <p:cNvPr id="2" name="">
             <a:extLst xmlns:a="http://schemas.openxmlformats.org/drawingml/2006/main">
               <a:ext uri="{FF2B5EF4-FFF2-40B4-BE49-F238E27FC236}">
-                <a16:creationId xmlns:a16="http://schemas.microsoft.com/office/drawing/2014/main" id="{3B2E9724-D19A-4130-97E6-F1CBA533AE82}"/>
+                <a16:creationId xmlns:a16="http://schemas.microsoft.com/office/drawing/2014/main" id="{E00042F4-5461-4D9F-98F0-01A2508B728A}"/>
               </a:ext>
             </a:extLst>
           </p:cNvPr>
@@ -11135,7 +11135,7 @@
           <p:cNvPr id="3" name="">
             <a:extLst xmlns:a="http://schemas.openxmlformats.org/drawingml/2006/main">
               <a:ext uri="{FF2B5EF4-FFF2-40B4-BE49-F238E27FC236}">
-                <a16:creationId xmlns:a16="http://schemas.microsoft.com/office/drawing/2014/main" id="{E3811190-EFD5-4201-8BB4-8DEAF5D33217}"/>
+                <a16:creationId xmlns:a16="http://schemas.microsoft.com/office/drawing/2014/main" id="{53983AA4-94B5-4A56-A2B2-5D0DD0781D4A}"/>
               </a:ext>
             </a:extLst>
           </p:cNvPr>
@@ -11145,7 +11145,7 @@
           <p:nvPr/>
         </p:nvPicPr>
         <p:blipFill>
-          <a:blip xmlns:r="http://schemas.openxmlformats.org/officeDocument/2006/relationships" xmlns:a="http://schemas.openxmlformats.org/drawingml/2006/main" r:embed="R0b1fc4eb1f484ab1"/>
+          <a:blip xmlns:r="http://schemas.openxmlformats.org/officeDocument/2006/relationships" xmlns:a="http://schemas.openxmlformats.org/drawingml/2006/main" r:embed="R55dd3fba41f648b8"/>
           <a:stretch xmlns:a="http://schemas.openxmlformats.org/drawingml/2006/main"/>
         </p:blipFill>
         <p:spPr>
@@ -11163,7 +11163,7 @@
           <p:cNvPr id="4" name="">
             <a:extLst xmlns:a="http://schemas.openxmlformats.org/drawingml/2006/main">
               <a:ext uri="{FF2B5EF4-FFF2-40B4-BE49-F238E27FC236}">
-                <a16:creationId xmlns:a16="http://schemas.microsoft.com/office/drawing/2014/main" id="{6AA03224-CBEA-42BB-A679-8DE2455C4F33}"/>
+                <a16:creationId xmlns:a16="http://schemas.microsoft.com/office/drawing/2014/main" id="{44CFC8D4-1215-43D9-AAA3-65B7EF566683}"/>
               </a:ext>
             </a:extLst>
           </p:cNvPr>
@@ -11235,7 +11235,7 @@
           <p:cNvPr id="5" name="">
             <a:extLst xmlns:a="http://schemas.openxmlformats.org/drawingml/2006/main">
               <a:ext uri="{FF2B5EF4-FFF2-40B4-BE49-F238E27FC236}">
-                <a16:creationId xmlns:a16="http://schemas.microsoft.com/office/drawing/2014/main" id="{D3FEA31A-B19F-4E19-BC6F-163054D8B2AC}"/>
+                <a16:creationId xmlns:a16="http://schemas.microsoft.com/office/drawing/2014/main" id="{7EA5298A-05D9-4689-AA04-1F8065D63788}"/>
               </a:ext>
             </a:extLst>
           </p:cNvPr>
@@ -11297,7 +11297,7 @@
                 <a:ea typeface="Arial"/>
                 <a:cs typeface="Arial"/>
               </a:rPr>
-              <a:t>The heatmap contains synthetic temperatures in kelvin. A different array layout mispairs four of six values and locations. This passing case does not establish support for every layout.</a:t>
+              <a:t>Synthetic values. Dimension-name tests check associations independently of the shared decoder.</a:t>
             </a:r>
           </a:p>
         </p:txBody>
@@ -11305,7 +11305,7 @@
     </p:spTree>
     <p:extLst>
       <p:ext uri="{BB962C8B-B14F-4D97-AF65-F5344CB8AC3E}">
-        <p14:creationId xmlns:p14="http://schemas.microsoft.com/office/powerpoint/2010/main" val="1385028474"/>
+        <p14:creationId xmlns:p14="http://schemas.microsoft.com/office/powerpoint/2010/main" val="810960368"/>
       </p:ext>
     </p:extLst>
   </p:cSld>
@@ -11336,7 +11336,7 @@
           <p:cNvPr id="5" name="">
             <a:extLst xmlns:a="http://schemas.openxmlformats.org/drawingml/2006/main">
               <a:ext uri="{FF2B5EF4-FFF2-40B4-BE49-F238E27FC236}">
-                <a16:creationId xmlns:a16="http://schemas.microsoft.com/office/drawing/2014/main" id="{FBC84943-F769-4E05-AAD7-18C5FF4A70A4}"/>
+                <a16:creationId xmlns:a16="http://schemas.microsoft.com/office/drawing/2014/main" id="{C50E0C46-94AA-4C57-880E-62554390CEF9}"/>
               </a:ext>
             </a:extLst>
           </p:cNvPr>
@@ -11398,7 +11398,7 @@
                 <a:ea typeface="Arial"/>
                 <a:cs typeface="Arial"/>
               </a:rPr>
-              <a:t>What the later audit changes</a:t>
+              <a:t>Fresh independent audit</a:t>
             </a:r>
           </a:p>
         </p:txBody>
@@ -11408,7 +11408,7 @@
           <p:cNvPr id="2" name="">
             <a:extLst xmlns:a="http://schemas.openxmlformats.org/drawingml/2006/main">
               <a:ext uri="{FF2B5EF4-FFF2-40B4-BE49-F238E27FC236}">
-                <a16:creationId xmlns:a16="http://schemas.microsoft.com/office/drawing/2014/main" id="{9FB0D66B-5E44-4497-ABA1-9A2BAB572953}"/>
+                <a16:creationId xmlns:a16="http://schemas.microsoft.com/office/drawing/2014/main" id="{50294DF4-E680-4715-BEC3-984176784B67}"/>
               </a:ext>
             </a:extLst>
           </p:cNvPr>
@@ -11470,7 +11470,7 @@
                 <a:ea typeface="Arial"/>
                 <a:cs typeface="Arial"/>
               </a:rPr>
-              <a:t>The recorded suite passed, then the audit exercised cases it had missed.</a:t>
+              <a:t>Six prior defects pass fresh counterexamples; one remains unresolved.</a:t>
             </a:r>
           </a:p>
         </p:txBody>
@@ -11480,7 +11480,7 @@
           <p:cNvPr id="3" name="">
             <a:extLst xmlns:a="http://schemas.openxmlformats.org/drawingml/2006/main">
               <a:ext uri="{FF2B5EF4-FFF2-40B4-BE49-F238E27FC236}">
-                <a16:creationId xmlns:a16="http://schemas.microsoft.com/office/drawing/2014/main" id="{86ED5D3F-E0B4-4AB8-BE3A-3DFCB95D4261}"/>
+                <a16:creationId xmlns:a16="http://schemas.microsoft.com/office/drawing/2014/main" id="{F6E60BC6-AB7D-4F3E-B36E-02C8654A53A3}"/>
               </a:ext>
             </a:extLst>
           </p:cNvPr>
@@ -11542,7 +11542,7 @@
                           <a:ea typeface="Arial"/>
                           <a:cs typeface="Arial"/>
                         </a:rPr>
-                        <a:t>Confirmed issue</a:t>
+                        <a:t>Fresh audit result</a:t>
                       </a:r>
                     </a:p>
                   </a:txBody>
@@ -11596,7 +11596,7 @@
                           <a:ea typeface="Arial"/>
                           <a:cs typeface="Arial"/>
                         </a:rPr>
-                        <a:t>A private sampling shortcut has no justified error bound. One projected case differs by about 1.24 degrees.</a:t>
+                        <a:t>Remaining: normal sampling has no justified domain/error bound; projected difference about 1.24 degrees.</a:t>
                       </a:r>
                     </a:p>
                   </a:txBody>
@@ -11650,7 +11650,7 @@
                           <a:ea typeface="Arial"/>
                           <a:cs typeface="Arial"/>
                         </a:rPr>
-                        <a:t>A referenced model outside the bound subtree fails instead of receiving the instancer's placement.</a:t>
+                        <a:t>Corrected: an unbound library prototype receives its instancer placement in both readers.</a:t>
                       </a:r>
                     </a:p>
                   </a:txBody>
@@ -11704,7 +11704,7 @@
                           <a:ea typeface="Arial"/>
                           <a:cs typeface="Arial"/>
                         </a:rPr>
-                        <a:t>Two source triangles become three output triangles. The check misses the extra geometry.</a:t>
+                        <a:t>Corrected: two source meshes yield exactly two baked meshes; extras are rejected.</a:t>
                       </a:r>
                     </a:p>
                   </a:txBody>
@@ -11758,7 +11758,7 @@
                           <a:ea typeface="Arial"/>
                           <a:cs typeface="Arial"/>
                         </a:rPr>
-                        <a:t>A different array dimension order pairs four of six values with the wrong locations. Both readers share this decoder.</a:t>
+                        <a:t>Corrected: all six measurements retain the coordinates declared by dimension names.</a:t>
                       </a:r>
                     </a:p>
                   </a:txBody>
@@ -11812,7 +11812,7 @@
                           <a:ea typeface="Arial"/>
                           <a:cs typeface="Arial"/>
                         </a:rPr>
-                        <a:t>The bake removes an unrelated MotionAPI schema application, changing other scene meaning.</a:t>
+                        <a:t>Corrected: the bake retains MotionAPI and its velocity-scale value.</a:t>
                       </a:r>
                     </a:p>
                   </a:txBody>
@@ -11866,7 +11866,7 @@
                           <a:ea typeface="Arial"/>
                           <a:cs typeface="Arial"/>
                         </a:rPr>
-                        <a:t>Reports omit required per-component errors and separate angular errors.</a:t>
+                        <a:t>Corrected: reports include component errors, magnitudes and angular errors.</a:t>
                       </a:r>
                     </a:p>
                   </a:txBody>
@@ -11920,7 +11920,7 @@
                           <a:ea typeface="Arial"/>
                           <a:cs typeface="Arial"/>
                         </a:rPr>
-                        <a:t>An invalid placement attribute on an inherited-only child is silently ignored.</a:t>
+                        <a:t>Corrected: both readers reject an invalid child placement field.</a:t>
                       </a:r>
                     </a:p>
                   </a:txBody>
@@ -11940,7 +11940,7 @@
           <p:cNvPr id="4" name="">
             <a:extLst xmlns:a="http://schemas.openxmlformats.org/drawingml/2006/main">
               <a:ext uri="{FF2B5EF4-FFF2-40B4-BE49-F238E27FC236}">
-                <a16:creationId xmlns:a16="http://schemas.microsoft.com/office/drawing/2014/main" id="{2A0D9D80-ECB5-4435-9575-E27A5110AD9C}"/>
+                <a16:creationId xmlns:a16="http://schemas.microsoft.com/office/drawing/2014/main" id="{E364DE42-4A0A-4FA5-BC89-B680E3E16AB6}"/>
               </a:ext>
             </a:extLst>
           </p:cNvPr>
@@ -12002,7 +12002,7 @@
                 <a:ea typeface="Arial"/>
                 <a:cs typeface="Arial"/>
               </a:rPr>
-              <a:t>Repair these against the existing proposed rules. If repair reveals truly unspecified meaning, flag that separately.</a:t>
+              <a:t>Normal sampling still needs justified domain/error evidence. Do not turn its shortcut into a proposal rule.</a:t>
             </a:r>
           </a:p>
         </p:txBody>
@@ -12010,7 +12010,7 @@
     </p:spTree>
     <p:extLst>
       <p:ext uri="{BB962C8B-B14F-4D97-AF65-F5344CB8AC3E}">
-        <p14:creationId xmlns:p14="http://schemas.microsoft.com/office/powerpoint/2010/main" val="1322089845"/>
+        <p14:creationId xmlns:p14="http://schemas.microsoft.com/office/powerpoint/2010/main" val="486715488"/>
       </p:ext>
     </p:extLst>
   </p:cSld>
@@ -12041,7 +12041,7 @@
           <p:cNvPr id="9" name="">
             <a:extLst xmlns:a="http://schemas.openxmlformats.org/drawingml/2006/main">
               <a:ext uri="{FF2B5EF4-FFF2-40B4-BE49-F238E27FC236}">
-                <a16:creationId xmlns:a16="http://schemas.microsoft.com/office/drawing/2014/main" id="{0D7063AB-BC4F-4F2A-88FD-5E32E18D89BB}"/>
+                <a16:creationId xmlns:a16="http://schemas.microsoft.com/office/drawing/2014/main" id="{6967941E-35C9-495E-9987-7FFB410DBAC7}"/>
               </a:ext>
             </a:extLst>
           </p:cNvPr>
@@ -12113,7 +12113,7 @@
           <p:cNvPr id="2" name="">
             <a:extLst xmlns:a="http://schemas.openxmlformats.org/drawingml/2006/main">
               <a:ext uri="{FF2B5EF4-FFF2-40B4-BE49-F238E27FC236}">
-                <a16:creationId xmlns:a16="http://schemas.microsoft.com/office/drawing/2014/main" id="{88066F21-6D6C-4C7E-8B45-853AEE432EFC}"/>
+                <a16:creationId xmlns:a16="http://schemas.microsoft.com/office/drawing/2014/main" id="{2049EF4F-DFF8-4405-A447-DCA3DDDD3AB9}"/>
               </a:ext>
             </a:extLst>
           </p:cNvPr>
@@ -12185,7 +12185,7 @@
           <p:cNvPr id="3" name="">
             <a:extLst xmlns:a="http://schemas.openxmlformats.org/drawingml/2006/main">
               <a:ext uri="{FF2B5EF4-FFF2-40B4-BE49-F238E27FC236}">
-                <a16:creationId xmlns:a16="http://schemas.microsoft.com/office/drawing/2014/main" id="{DD8ACDB4-857F-4588-8F16-6B1EC37F6B3C}"/>
+                <a16:creationId xmlns:a16="http://schemas.microsoft.com/office/drawing/2014/main" id="{AF554BFF-712E-4472-9CC2-0CC9FD258AF5}"/>
               </a:ext>
             </a:extLst>
           </p:cNvPr>
@@ -12195,7 +12195,7 @@
           <p:nvPr/>
         </p:nvPicPr>
         <p:blipFill>
-          <a:blip xmlns:r="http://schemas.openxmlformats.org/officeDocument/2006/relationships" xmlns:a="http://schemas.openxmlformats.org/drawingml/2006/main" r:embed="R84745d2bd1d74eac"/>
+          <a:blip xmlns:r="http://schemas.openxmlformats.org/officeDocument/2006/relationships" xmlns:a="http://schemas.openxmlformats.org/drawingml/2006/main" r:embed="R2efcedba11f14ad1"/>
           <a:stretch xmlns:a="http://schemas.openxmlformats.org/drawingml/2006/main"/>
         </p:blipFill>
         <p:spPr>
@@ -12213,7 +12213,7 @@
           <p:cNvPr id="4" name="">
             <a:extLst xmlns:a="http://schemas.openxmlformats.org/drawingml/2006/main">
               <a:ext uri="{FF2B5EF4-FFF2-40B4-BE49-F238E27FC236}">
-                <a16:creationId xmlns:a16="http://schemas.microsoft.com/office/drawing/2014/main" id="{84C2E3AA-F4C1-4153-8B64-46CD28C78285}"/>
+                <a16:creationId xmlns:a16="http://schemas.microsoft.com/office/drawing/2014/main" id="{9CBAB235-C44A-41F7-8D58-09ECBD197082}"/>
               </a:ext>
             </a:extLst>
           </p:cNvPr>
@@ -12285,7 +12285,7 @@
           <p:cNvPr id="5" name="">
             <a:extLst xmlns:a="http://schemas.openxmlformats.org/drawingml/2006/main">
               <a:ext uri="{FF2B5EF4-FFF2-40B4-BE49-F238E27FC236}">
-                <a16:creationId xmlns:a16="http://schemas.microsoft.com/office/drawing/2014/main" id="{5132ECD4-A1D6-407E-9CA4-303E7CCE946A}"/>
+                <a16:creationId xmlns:a16="http://schemas.microsoft.com/office/drawing/2014/main" id="{08ED7D4D-5973-4C4F-BB21-16ABBEF14400}"/>
               </a:ext>
             </a:extLst>
           </p:cNvPr>
@@ -12357,7 +12357,7 @@
           <p:cNvPr id="6" name="">
             <a:extLst xmlns:a="http://schemas.openxmlformats.org/drawingml/2006/main">
               <a:ext uri="{FF2B5EF4-FFF2-40B4-BE49-F238E27FC236}">
-                <a16:creationId xmlns:a16="http://schemas.microsoft.com/office/drawing/2014/main" id="{140DEB75-B3B2-4BAF-9281-2EA3B52C3D96}"/>
+                <a16:creationId xmlns:a16="http://schemas.microsoft.com/office/drawing/2014/main" id="{04BA30B3-C2CE-44E6-B33F-CAD0CC72BBEB}"/>
               </a:ext>
             </a:extLst>
           </p:cNvPr>
@@ -12429,7 +12429,7 @@
           <p:cNvPr id="7" name="">
             <a:extLst xmlns:a="http://schemas.openxmlformats.org/drawingml/2006/main">
               <a:ext uri="{FF2B5EF4-FFF2-40B4-BE49-F238E27FC236}">
-                <a16:creationId xmlns:a16="http://schemas.microsoft.com/office/drawing/2014/main" id="{4E2D8C1C-C6BC-4EE3-BB28-85F3AB4B0F5D}"/>
+                <a16:creationId xmlns:a16="http://schemas.microsoft.com/office/drawing/2014/main" id="{D81F189A-E063-4C8A-9FC0-CCFCFA632491}"/>
               </a:ext>
             </a:extLst>
           </p:cNvPr>
@@ -12501,7 +12501,7 @@
           <p:cNvPr id="8" name="">
             <a:extLst xmlns:a="http://schemas.openxmlformats.org/drawingml/2006/main">
               <a:ext uri="{FF2B5EF4-FFF2-40B4-BE49-F238E27FC236}">
-                <a16:creationId xmlns:a16="http://schemas.microsoft.com/office/drawing/2014/main" id="{F024C352-014E-4C70-BF26-0543EEF606AF}"/>
+                <a16:creationId xmlns:a16="http://schemas.microsoft.com/office/drawing/2014/main" id="{0C071068-74FC-4568-A57A-66802C5B33F9}"/>
               </a:ext>
             </a:extLst>
           </p:cNvPr>
@@ -12571,7 +12571,7 @@
     </p:spTree>
     <p:extLst>
       <p:ext uri="{BB962C8B-B14F-4D97-AF65-F5344CB8AC3E}">
-        <p14:creationId xmlns:p14="http://schemas.microsoft.com/office/powerpoint/2010/main" val="1721608692"/>
+        <p14:creationId xmlns:p14="http://schemas.microsoft.com/office/powerpoint/2010/main" val="1666206875"/>
       </p:ext>
     </p:extLst>
   </p:cSld>

</xml_diff>

<commit_message>
Deliver local HPR build evidence and coherent proposal assessment
</commit_message>
<xml_diff>
--- a/extras/usd/examples/usdGeospatialBuild/delivery/geospatial-build.pptx
+++ b/extras/usd/examples/usdGeospatialBuild/delivery/geospatial-build.pptx
@@ -2,26 +2,26 @@
 <file path=ppt/presentation.xml><?xml version="1.0" encoding="utf-8"?>
 <p:presentation xmlns:p="http://schemas.openxmlformats.org/presentationml/2006/main">
   <p:sldMasterIdLst>
-    <p:sldMasterId xmlns:r="http://schemas.openxmlformats.org/officeDocument/2006/relationships" id="2147483648" r:id="Rdb7e2e0cc0f74f48"/>
+    <p:sldMasterId xmlns:r="http://schemas.openxmlformats.org/officeDocument/2006/relationships" id="2147483648" r:id="Rf9bb615d0f5a45a3"/>
   </p:sldMasterIdLst>
   <p:notesMasterIdLst>
-    <p:notesMasterId xmlns:r="http://schemas.openxmlformats.org/officeDocument/2006/relationships" r:id="R040f136531de4a88"/>
+    <p:notesMasterId xmlns:r="http://schemas.openxmlformats.org/officeDocument/2006/relationships" r:id="R2d2db94645f9461d"/>
   </p:notesMasterIdLst>
   <p:sldIdLst>
-    <p:sldId xmlns:r="http://schemas.openxmlformats.org/officeDocument/2006/relationships" id="256" r:id="R97802bcd5ce04758"/>
-    <p:sldId xmlns:r="http://schemas.openxmlformats.org/officeDocument/2006/relationships" id="257" r:id="Rbfd173ff249e4525"/>
-    <p:sldId xmlns:r="http://schemas.openxmlformats.org/officeDocument/2006/relationships" id="258" r:id="R99a4a70af04f4271"/>
-    <p:sldId xmlns:r="http://schemas.openxmlformats.org/officeDocument/2006/relationships" id="259" r:id="R90ea7b0f14d44179"/>
-    <p:sldId xmlns:r="http://schemas.openxmlformats.org/officeDocument/2006/relationships" id="260" r:id="R0fe1607c7ea646ba"/>
-    <p:sldId xmlns:r="http://schemas.openxmlformats.org/officeDocument/2006/relationships" id="261" r:id="R6ecd547532664220"/>
-    <p:sldId xmlns:r="http://schemas.openxmlformats.org/officeDocument/2006/relationships" id="262" r:id="R75eb8b4bfe754741"/>
-    <p:sldId xmlns:r="http://schemas.openxmlformats.org/officeDocument/2006/relationships" id="263" r:id="R4060aa22fcc84108"/>
-    <p:sldId xmlns:r="http://schemas.openxmlformats.org/officeDocument/2006/relationships" id="264" r:id="Ra9b805987d6e4d05"/>
-    <p:sldId xmlns:r="http://schemas.openxmlformats.org/officeDocument/2006/relationships" id="265" r:id="Rf4ec0743b14e4da1"/>
-    <p:sldId xmlns:r="http://schemas.openxmlformats.org/officeDocument/2006/relationships" id="266" r:id="R1c2206ef310c4212"/>
-    <p:sldId xmlns:r="http://schemas.openxmlformats.org/officeDocument/2006/relationships" id="267" r:id="R0142330e72d94e4c"/>
-    <p:sldId xmlns:r="http://schemas.openxmlformats.org/officeDocument/2006/relationships" id="268" r:id="R4d28be993475403c"/>
-    <p:sldId xmlns:r="http://schemas.openxmlformats.org/officeDocument/2006/relationships" id="269" r:id="Rb04c1697162b446f"/>
+    <p:sldId xmlns:r="http://schemas.openxmlformats.org/officeDocument/2006/relationships" id="256" r:id="R549ff8e5d1294045"/>
+    <p:sldId xmlns:r="http://schemas.openxmlformats.org/officeDocument/2006/relationships" id="257" r:id="Rfd59fda9a86c4469"/>
+    <p:sldId xmlns:r="http://schemas.openxmlformats.org/officeDocument/2006/relationships" id="258" r:id="R3f0e028930484127"/>
+    <p:sldId xmlns:r="http://schemas.openxmlformats.org/officeDocument/2006/relationships" id="259" r:id="R0b2912092f644fc4"/>
+    <p:sldId xmlns:r="http://schemas.openxmlformats.org/officeDocument/2006/relationships" id="260" r:id="R3ad39765d598475e"/>
+    <p:sldId xmlns:r="http://schemas.openxmlformats.org/officeDocument/2006/relationships" id="261" r:id="R65ba8b15aefd4055"/>
+    <p:sldId xmlns:r="http://schemas.openxmlformats.org/officeDocument/2006/relationships" id="262" r:id="R247ff39179394db8"/>
+    <p:sldId xmlns:r="http://schemas.openxmlformats.org/officeDocument/2006/relationships" id="263" r:id="R85713a523be849dc"/>
+    <p:sldId xmlns:r="http://schemas.openxmlformats.org/officeDocument/2006/relationships" id="264" r:id="Rf6187c8511794cd7"/>
+    <p:sldId xmlns:r="http://schemas.openxmlformats.org/officeDocument/2006/relationships" id="265" r:id="R13dd1d220f4a4f3d"/>
+    <p:sldId xmlns:r="http://schemas.openxmlformats.org/officeDocument/2006/relationships" id="266" r:id="R5bf7df65ebe64a90"/>
+    <p:sldId xmlns:r="http://schemas.openxmlformats.org/officeDocument/2006/relationships" id="267" r:id="R94f721e25e6a4b08"/>
+    <p:sldId xmlns:r="http://schemas.openxmlformats.org/officeDocument/2006/relationships" id="268" r:id="Rf0bc6be3006b4cb7"/>
+    <p:sldId xmlns:r="http://schemas.openxmlformats.org/officeDocument/2006/relationships" id="269" r:id="Rcb179a09765b4fb3"/>
   </p:sldIdLst>
   <p:sldSz cx="12192000" cy="6858000"/>
   <p:notesSz cx="6858000" cy="9144000"/>
@@ -465,22 +465,22 @@
           </a:p>
           <a:p xmlns:a="http://schemas.openxmlformats.org/drawingml/2006/main">
             <a:r>
-              <a:t>README SHA-256 708a3b5c2d26a82e32e7ec3c381c2ebb7cda8274fd4567709f98d76d85ca8f6c</a:t>
-            </a:r>
-          </a:p>
-          <a:p xmlns:a="http://schemas.openxmlformats.org/drawingml/2006/main">
-            <a:r>
-              <a:t>Proposal SHA-256 28768109389139a56d5c8e5f473446bfa46dd1ab46a48924165b97fb92cb7ae9</a:t>
-            </a:r>
-          </a:p>
-          <a:p xmlns:a="http://schemas.openxmlformats.org/drawingml/2006/main">
-            <a:r>
-              <a:t>Immutable execution receipt SHA-256 b12019e039ab52f930fb2f4321ca2289875bcdefbd3dbbd669b72a8689647e46</a:t>
-            </a:r>
-          </a:p>
-          <a:p xmlns:a="http://schemas.openxmlformats.org/drawingml/2006/main">
-            <a:r>
-              <a:t>Later audit SHA-256 e7e5278ba30509b5a3e94196ffdb6d59aaa54eadacae97022f6ffab098d94a9a</a:t>
+              <a:t>README SHA-256 e7a38c47715e43994a8c44f1474cd6c4a0e924aab1ae63af557fc405cff0a90e</a:t>
+            </a:r>
+          </a:p>
+          <a:p xmlns:a="http://schemas.openxmlformats.org/drawingml/2006/main">
+            <a:r>
+              <a:t>Proposal SHA-256 0ed1dcda854e43bb82b7e830ba4b2224cdb8da0741fa9d6cb4fe459d4266ace0</a:t>
+            </a:r>
+          </a:p>
+          <a:p xmlns:a="http://schemas.openxmlformats.org/drawingml/2006/main">
+            <a:r>
+              <a:t>Immutable execution receipt SHA-256 bc2c422dc4a9ec855fe6831a1b6afcd2ef86961db5bc954bd71c74d5ec39d842</a:t>
+            </a:r>
+          </a:p>
+          <a:p xmlns:a="http://schemas.openxmlformats.org/drawingml/2006/main">
+            <a:r>
+              <a:t>Later audit SHA-256 2c11e5d97389f5cdcabab87f586d0511c5d6e4e8bdc0b2bd4cdcbfdb7f9d783c</a:t>
             </a:r>
           </a:p>
           <a:p xmlns:a="http://schemas.openxmlformats.org/drawingml/2006/main">
@@ -590,12 +590,12 @@
           </a:p>
           <a:p xmlns:a="http://schemas.openxmlformats.org/drawingml/2006/main">
             <a:r>
-              <a:t>Proposal: ### External measurement association at proposal/proposal-source.txt:1610</a:t>
-            </a:r>
-          </a:p>
-          <a:p xmlns:a="http://schemas.openxmlformats.org/drawingml/2006/main">
-            <a:r>
-              <a:t>Functional requirements: [{"id":8,"title":"Brought-in data keeps its coordinates and its CRS.","line":751},{"id":12,"title":"No angle read as a length.","line":831},{"id":19,"title":"Resolution leaves the scene as authored.","line":932},{"id":21,"title":"Never placed by a guess.","line":968}]</a:t>
+              <a:t>Proposal: ### External measurement association at proposal/proposal-source.txt:1630</a:t>
+            </a:r>
+          </a:p>
+          <a:p xmlns:a="http://schemas.openxmlformats.org/drawingml/2006/main">
+            <a:r>
+              <a:t>Functional requirements: [{"id":8,"title":"Brought-in data keeps its coordinates and its CRS.","line":753},{"id":12,"title":"No angle read as a length.","line":836},{"id":19,"title":"Resolution leaves the scene as authored.","line":937},{"id":21,"title":"Never placed by a guess.","line":973}]</a:t>
             </a:r>
           </a:p>
           <a:p xmlns:a="http://schemas.openxmlformats.org/drawingml/2006/main">
@@ -610,22 +610,22 @@
           </a:p>
           <a:p xmlns:a="http://schemas.openxmlformats.org/drawingml/2006/main">
             <a:r>
-              <a:t>README SHA-256 708a3b5c2d26a82e32e7ec3c381c2ebb7cda8274fd4567709f98d76d85ca8f6c</a:t>
-            </a:r>
-          </a:p>
-          <a:p xmlns:a="http://schemas.openxmlformats.org/drawingml/2006/main">
-            <a:r>
-              <a:t>Proposal SHA-256 28768109389139a56d5c8e5f473446bfa46dd1ab46a48924165b97fb92cb7ae9</a:t>
-            </a:r>
-          </a:p>
-          <a:p xmlns:a="http://schemas.openxmlformats.org/drawingml/2006/main">
-            <a:r>
-              <a:t>Immutable execution receipt SHA-256 b12019e039ab52f930fb2f4321ca2289875bcdefbd3dbbd669b72a8689647e46</a:t>
-            </a:r>
-          </a:p>
-          <a:p xmlns:a="http://schemas.openxmlformats.org/drawingml/2006/main">
-            <a:r>
-              <a:t>Later audit SHA-256 e7e5278ba30509b5a3e94196ffdb6d59aaa54eadacae97022f6ffab098d94a9a</a:t>
+              <a:t>README SHA-256 e7a38c47715e43994a8c44f1474cd6c4a0e924aab1ae63af557fc405cff0a90e</a:t>
+            </a:r>
+          </a:p>
+          <a:p xmlns:a="http://schemas.openxmlformats.org/drawingml/2006/main">
+            <a:r>
+              <a:t>Proposal SHA-256 0ed1dcda854e43bb82b7e830ba4b2224cdb8da0741fa9d6cb4fe459d4266ace0</a:t>
+            </a:r>
+          </a:p>
+          <a:p xmlns:a="http://schemas.openxmlformats.org/drawingml/2006/main">
+            <a:r>
+              <a:t>Immutable execution receipt SHA-256 bc2c422dc4a9ec855fe6831a1b6afcd2ef86961db5bc954bd71c74d5ec39d842</a:t>
+            </a:r>
+          </a:p>
+          <a:p xmlns:a="http://schemas.openxmlformats.org/drawingml/2006/main">
+            <a:r>
+              <a:t>Later audit SHA-256 2c11e5d97389f5cdcabab87f586d0511c5d6e4e8bdc0b2bd4cdcbfdb7f9d783c</a:t>
             </a:r>
           </a:p>
           <a:p xmlns:a="http://schemas.openxmlformats.org/drawingml/2006/main">
@@ -730,17 +730,17 @@
           </a:p>
           <a:p xmlns:a="http://schemas.openxmlformats.org/drawingml/2006/main">
             <a:r>
-              <a:t>Limit: The bake preserves time codes 0, 5, 10 and 48 time codes per second. It provides no original-trajectory guarantee between those samples.</a:t>
-            </a:r>
-          </a:p>
-          <a:p xmlns:a="http://schemas.openxmlformats.org/drawingml/2006/main">
-            <a:r>
-              <a:t>Proposal: #### Evaluation at proposal/proposal-source.txt:1910</a:t>
-            </a:r>
-          </a:p>
-          <a:p xmlns:a="http://schemas.openxmlformats.org/drawingml/2006/main">
-            <a:r>
-              <a:t>Functional requirements: [{"id":20,"title":"Positions between recorded moments.","line":951},{"id":29,"title":"Implementable from the text alone.","line":1117}]</a:t>
+              <a:t>Limit: Position interpolation is shown here. HPR wrap, held samples, reference offsets and value clips pass separate controls.</a:t>
+            </a:r>
+          </a:p>
+          <a:p xmlns:a="http://schemas.openxmlformats.org/drawingml/2006/main">
+            <a:r>
+              <a:t>Proposal: #### Evaluation at proposal/proposal-source.txt:1930</a:t>
+            </a:r>
+          </a:p>
+          <a:p xmlns:a="http://schemas.openxmlformats.org/drawingml/2006/main">
+            <a:r>
+              <a:t>Functional requirements: [{"id":20,"title":"Positions between recorded moments.","line":956},{"id":29,"title":"Implementable from the text alone.","line":1122}]</a:t>
             </a:r>
           </a:p>
           <a:p xmlns:a="http://schemas.openxmlformats.org/drawingml/2006/main">
@@ -755,22 +755,22 @@
           </a:p>
           <a:p xmlns:a="http://schemas.openxmlformats.org/drawingml/2006/main">
             <a:r>
-              <a:t>README SHA-256 708a3b5c2d26a82e32e7ec3c381c2ebb7cda8274fd4567709f98d76d85ca8f6c</a:t>
-            </a:r>
-          </a:p>
-          <a:p xmlns:a="http://schemas.openxmlformats.org/drawingml/2006/main">
-            <a:r>
-              <a:t>Proposal SHA-256 28768109389139a56d5c8e5f473446bfa46dd1ab46a48924165b97fb92cb7ae9</a:t>
-            </a:r>
-          </a:p>
-          <a:p xmlns:a="http://schemas.openxmlformats.org/drawingml/2006/main">
-            <a:r>
-              <a:t>Immutable execution receipt SHA-256 b12019e039ab52f930fb2f4321ca2289875bcdefbd3dbbd669b72a8689647e46</a:t>
-            </a:r>
-          </a:p>
-          <a:p xmlns:a="http://schemas.openxmlformats.org/drawingml/2006/main">
-            <a:r>
-              <a:t>Later audit SHA-256 e7e5278ba30509b5a3e94196ffdb6d59aaa54eadacae97022f6ffab098d94a9a</a:t>
+              <a:t>README SHA-256 e7a38c47715e43994a8c44f1474cd6c4a0e924aab1ae63af557fc405cff0a90e</a:t>
+            </a:r>
+          </a:p>
+          <a:p xmlns:a="http://schemas.openxmlformats.org/drawingml/2006/main">
+            <a:r>
+              <a:t>Proposal SHA-256 0ed1dcda854e43bb82b7e830ba4b2224cdb8da0741fa9d6cb4fe459d4266ace0</a:t>
+            </a:r>
+          </a:p>
+          <a:p xmlns:a="http://schemas.openxmlformats.org/drawingml/2006/main">
+            <a:r>
+              <a:t>Immutable execution receipt SHA-256 bc2c422dc4a9ec855fe6831a1b6afcd2ef86961db5bc954bd71c74d5ec39d842</a:t>
+            </a:r>
+          </a:p>
+          <a:p xmlns:a="http://schemas.openxmlformats.org/drawingml/2006/main">
+            <a:r>
+              <a:t>Later audit SHA-256 2c11e5d97389f5cdcabab87f586d0511c5d6e4e8bdc0b2bd4cdcbfdb7f9d783c</a:t>
             </a:r>
           </a:p>
           <a:p xmlns:a="http://schemas.openxmlformats.org/drawingml/2006/main">
@@ -855,27 +855,27 @@
           </a:p>
           <a:p xmlns:a="http://schemas.openxmlformats.org/drawingml/2006/main">
             <a:r>
-              <a:t>[["Physical orientation","Input-only meaning is supported. Stored quaternion versus one heading/pitch/roll tuple and its interpolation need review."],["The object with its own georeference","Project adjustment meaning is supported. The detailed fixed working-frame convention remains a candidate."],["Child objects","Model-local meaning is supported. The follow-up specifies chart/reset details and tests that offsets retain their interpretation."],["Independently georeferenced repeated models","Keep a prototype's own geographic placement and apply each instance effect once."],["Geographic queries and scene geometry","Return longitude/latitude/height for geographic queries. Cartesian geometry and bounds use the datum's Earth-centred frame."]]</a:t>
-            </a:r>
-          </a:p>
-          <a:p xmlns:a="http://schemas.openxmlformats.org/drawingml/2006/main">
-            <a:r>
-              <a:t>README SHA-256 708a3b5c2d26a82e32e7ec3c381c2ebb7cda8274fd4567709f98d76d85ca8f6c</a:t>
-            </a:r>
-          </a:p>
-          <a:p xmlns:a="http://schemas.openxmlformats.org/drawingml/2006/main">
-            <a:r>
-              <a:t>Proposal SHA-256 28768109389139a56d5c8e5f473446bfa46dd1ab46a48924165b97fb92cb7ae9</a:t>
-            </a:r>
-          </a:p>
-          <a:p xmlns:a="http://schemas.openxmlformats.org/drawingml/2006/main">
-            <a:r>
-              <a:t>Immutable execution receipt SHA-256 b12019e039ab52f930fb2f4321ca2289875bcdefbd3dbbd669b72a8689647e46</a:t>
-            </a:r>
-          </a:p>
-          <a:p xmlns:a="http://schemas.openxmlformats.org/drawingml/2006/main">
-            <a:r>
-              <a:t>Later audit SHA-256 e7e5278ba30509b5a3e94196ffdb6d59aaa54eadacae97022f6ffab098d94a9a</a:t>
+              <a:t>[["Physical orientation","Preferred HPR tuple in degrees, with explicit pose interpolation. Authored inputs only; adoption pending."],["The object with its own georeference","Project adjustment meaning is supported. The detailed fixed working-frame convention remains a candidate."],["Child objects","Model-local meaning is supported. The follow-up specifies chart/reset details and tests that offsets retain their interpretation."],["Independently georeferenced repeated models","Keep a prototype's own geographic placement and apply each instance effect once."],["Geographic queries and scene geometry","Return longitude/latitude/height for geographic queries. Cartesian geometry and bounds use the datum's Earth-centred frame."]]</a:t>
+            </a:r>
+          </a:p>
+          <a:p xmlns:a="http://schemas.openxmlformats.org/drawingml/2006/main">
+            <a:r>
+              <a:t>README SHA-256 e7a38c47715e43994a8c44f1474cd6c4a0e924aab1ae63af557fc405cff0a90e</a:t>
+            </a:r>
+          </a:p>
+          <a:p xmlns:a="http://schemas.openxmlformats.org/drawingml/2006/main">
+            <a:r>
+              <a:t>Proposal SHA-256 0ed1dcda854e43bb82b7e830ba4b2224cdb8da0741fa9d6cb4fe459d4266ace0</a:t>
+            </a:r>
+          </a:p>
+          <a:p xmlns:a="http://schemas.openxmlformats.org/drawingml/2006/main">
+            <a:r>
+              <a:t>Immutable execution receipt SHA-256 bc2c422dc4a9ec855fe6831a1b6afcd2ef86961db5bc954bd71c74d5ec39d842</a:t>
+            </a:r>
+          </a:p>
+          <a:p xmlns:a="http://schemas.openxmlformats.org/drawingml/2006/main">
+            <a:r>
+              <a:t>Later audit SHA-256 2c11e5d97389f5cdcabab87f586d0511c5d6e4e8bdc0b2bd4cdcbfdb7f9d783c</a:t>
             </a:r>
           </a:p>
           <a:p xmlns:a="http://schemas.openxmlformats.org/drawingml/2006/main">
@@ -965,22 +965,22 @@
           </a:p>
           <a:p xmlns:a="http://schemas.openxmlformats.org/drawingml/2006/main">
             <a:r>
-              <a:t>README SHA-256 708a3b5c2d26a82e32e7ec3c381c2ebb7cda8274fd4567709f98d76d85ca8f6c</a:t>
-            </a:r>
-          </a:p>
-          <a:p xmlns:a="http://schemas.openxmlformats.org/drawingml/2006/main">
-            <a:r>
-              <a:t>Proposal SHA-256 28768109389139a56d5c8e5f473446bfa46dd1ab46a48924165b97fb92cb7ae9</a:t>
-            </a:r>
-          </a:p>
-          <a:p xmlns:a="http://schemas.openxmlformats.org/drawingml/2006/main">
-            <a:r>
-              <a:t>Immutable execution receipt SHA-256 b12019e039ab52f930fb2f4321ca2289875bcdefbd3dbbd669b72a8689647e46</a:t>
-            </a:r>
-          </a:p>
-          <a:p xmlns:a="http://schemas.openxmlformats.org/drawingml/2006/main">
-            <a:r>
-              <a:t>Later audit SHA-256 e7e5278ba30509b5a3e94196ffdb6d59aaa54eadacae97022f6ffab098d94a9a</a:t>
+              <a:t>README SHA-256 e7a38c47715e43994a8c44f1474cd6c4a0e924aab1ae63af557fc405cff0a90e</a:t>
+            </a:r>
+          </a:p>
+          <a:p xmlns:a="http://schemas.openxmlformats.org/drawingml/2006/main">
+            <a:r>
+              <a:t>Proposal SHA-256 0ed1dcda854e43bb82b7e830ba4b2224cdb8da0741fa9d6cb4fe459d4266ace0</a:t>
+            </a:r>
+          </a:p>
+          <a:p xmlns:a="http://schemas.openxmlformats.org/drawingml/2006/main">
+            <a:r>
+              <a:t>Immutable execution receipt SHA-256 bc2c422dc4a9ec855fe6831a1b6afcd2ef86961db5bc954bd71c74d5ec39d842</a:t>
+            </a:r>
+          </a:p>
+          <a:p xmlns:a="http://schemas.openxmlformats.org/drawingml/2006/main">
+            <a:r>
+              <a:t>Later audit SHA-256 2c11e5d97389f5cdcabab87f586d0511c5d6e4e8bdc0b2bd4cdcbfdb7f9d783c</a:t>
             </a:r>
           </a:p>
           <a:p xmlns:a="http://schemas.openxmlformats.org/drawingml/2006/main">
@@ -1065,27 +1065,27 @@
           </a:p>
           <a:p xmlns:a="http://schemas.openxmlformats.org/drawingml/2006/main">
             <a:r>
-              <a:t>[["Python and C++ readers","213,231 coordinate results per reader. Maximum measured difference 3.39e-08 m. They share PROJ and native dataset decoding."],["Omniverse stage geometry integration","Reuses Python placement. Recorded readback covers 177,864 geometry vertices and 36 edit, failure and recovery checks, across 35 jobs."],["Hydra / Storm","Two selected ordinary USD bakes reach native rendering. This consumer path uses the C++ placement results."],["Recorded tests","70 regressions and 61 distinguishing controls passed. Fresh independent diagnostics verify six repairs and retain the unresolved normal case."],["Source preservation","Original inputs and all frozen execution files remained unchanged during this run. The immutable receipt identifies the exact executed content."],["Bake readbacks","11 selected exports were checked. The fresh nested-geometry counterexample verifies the complete inventory, including unexpected extras."]]</a:t>
-            </a:r>
-          </a:p>
-          <a:p xmlns:a="http://schemas.openxmlformats.org/drawingml/2006/main">
-            <a:r>
-              <a:t>README SHA-256 708a3b5c2d26a82e32e7ec3c381c2ebb7cda8274fd4567709f98d76d85ca8f6c</a:t>
-            </a:r>
-          </a:p>
-          <a:p xmlns:a="http://schemas.openxmlformats.org/drawingml/2006/main">
-            <a:r>
-              <a:t>Proposal SHA-256 28768109389139a56d5c8e5f473446bfa46dd1ab46a48924165b97fb92cb7ae9</a:t>
-            </a:r>
-          </a:p>
-          <a:p xmlns:a="http://schemas.openxmlformats.org/drawingml/2006/main">
-            <a:r>
-              <a:t>Immutable execution receipt SHA-256 b12019e039ab52f930fb2f4321ca2289875bcdefbd3dbbd669b72a8689647e46</a:t>
-            </a:r>
-          </a:p>
-          <a:p xmlns:a="http://schemas.openxmlformats.org/drawingml/2006/main">
-            <a:r>
-              <a:t>Later audit SHA-256 e7e5278ba30509b5a3e94196ffdb6d59aaa54eadacae97022f6ffab098d94a9a</a:t>
+              <a:t>[["Python and C++ readers","213,243 coordinate results per reader. Maximum measured difference 3.39e-08 m. They share PROJ and native dataset decoding."],["Omniverse stage geometry integration","Reuses Python placement. Recorded readback covers 177,872 geometry vertices and 48 edit, failure and recovery checks, across 39 jobs."],["Hydra / Storm","Two selected ordinary USD bakes reach native rendering. This consumer path uses the C++ placement results."],["Recorded tests","88 regressions and 65 distinguishing controls passed. Fresh independent diagnostics verify six repairs and retain the unresolved normal case."],["Source preservation","Original inputs and all frozen execution files remained unchanged during this run. The immutable receipt identifies the exact executed content."],["Bake readbacks","11 selected exports were checked. The fresh nested-geometry counterexample verifies the complete inventory, including unexpected extras."]]</a:t>
+            </a:r>
+          </a:p>
+          <a:p xmlns:a="http://schemas.openxmlformats.org/drawingml/2006/main">
+            <a:r>
+              <a:t>README SHA-256 e7a38c47715e43994a8c44f1474cd6c4a0e924aab1ae63af557fc405cff0a90e</a:t>
+            </a:r>
+          </a:p>
+          <a:p xmlns:a="http://schemas.openxmlformats.org/drawingml/2006/main">
+            <a:r>
+              <a:t>Proposal SHA-256 0ed1dcda854e43bb82b7e830ba4b2224cdb8da0741fa9d6cb4fe459d4266ace0</a:t>
+            </a:r>
+          </a:p>
+          <a:p xmlns:a="http://schemas.openxmlformats.org/drawingml/2006/main">
+            <a:r>
+              <a:t>Immutable execution receipt SHA-256 bc2c422dc4a9ec855fe6831a1b6afcd2ef86961db5bc954bd71c74d5ec39d842</a:t>
+            </a:r>
+          </a:p>
+          <a:p xmlns:a="http://schemas.openxmlformats.org/drawingml/2006/main">
+            <a:r>
+              <a:t>Later audit SHA-256 2c11e5d97389f5cdcabab87f586d0511c5d6e4e8bdc0b2bd4cdcbfdb7f9d783c</a:t>
             </a:r>
           </a:p>
           <a:p xmlns:a="http://schemas.openxmlformats.org/drawingml/2006/main">
@@ -1180,27 +1180,27 @@
           </a:p>
           <a:p xmlns:a="http://schemas.openxmlformats.org/drawingml/2006/main">
             <a:r>
-              <a:t>Observed: The candidate defines position and orientation inputs, with concrete component, unit, default and evaluation rules. Ordinary model transforms remain separate.</a:t>
-            </a:r>
-          </a:p>
-          <a:p xmlns:a="http://schemas.openxmlformats.org/drawingml/2006/main">
-            <a:r>
-              <a:t>Implication for proposal quality: These definitions make the intended inputs explicit. Their usefulness depends on the agreed meanings, not on choosing a particular implementation library.</a:t>
-            </a:r>
-          </a:p>
-          <a:p xmlns:a="http://schemas.openxmlformats.org/drawingml/2006/main">
-            <a:r>
-              <a:t>Limit: This is an explanation of proposed definitions. The group still needs to review them.</a:t>
-            </a:r>
-          </a:p>
-          <a:p xmlns:a="http://schemas.openxmlformats.org/drawingml/2006/main">
-            <a:r>
-              <a:t>Proposal: #### Authored properties at proposal/proposal-source.txt:1523</a:t>
-            </a:r>
-          </a:p>
-          <a:p xmlns:a="http://schemas.openxmlformats.org/drawingml/2006/main">
-            <a:r>
-              <a:t>Functional requirements: [{"id":9,"title":"Positions, and offsets from them.","line":777},{"id":10,"title":"Offsets along the axes of their position.","line":795},{"id":12,"title":"No angle read as a length.","line":831},{"id":14,"title":"Scene conventions stay the scene's.","line":857},{"id":15,"title":"Placement separate from conformance.","line":870}]</a:t>
+              <a:t>Observed: The source stores a single double3 heading/pitch/roll tuple in degrees. The rules define its true-north/ellipsoid-up meaning, rotation order and time-sample evaluation; computed quaternions stay transient.</a:t>
+            </a:r>
+          </a:p>
+          <a:p xmlns:a="http://schemas.openxmlformats.org/drawingml/2006/main">
+            <a:r>
+              <a:t>Implication for proposal quality: The proposed representation follows the concrete authoring workflow. New checks show that reading, editing and composing these inputs produces the specified physical pose.</a:t>
+            </a:r>
+          </a:p>
+          <a:p xmlns:a="http://schemas.openxmlformats.org/drawingml/2006/main">
+            <a:r>
+              <a:t>Limit: This is the preferred local candidate, not group adoption. At +170 and -170 degrees the readers pass through 180 degrees; ordinary tuple interpolation would face 0 degrees.</a:t>
+            </a:r>
+          </a:p>
+          <a:p xmlns:a="http://schemas.openxmlformats.org/drawingml/2006/main">
+            <a:r>
+              <a:t>Proposal: #### Authored properties at proposal/proposal-source.txt:1532</a:t>
+            </a:r>
+          </a:p>
+          <a:p xmlns:a="http://schemas.openxmlformats.org/drawingml/2006/main">
+            <a:r>
+              <a:t>Functional requirements: [{"id":9,"title":"Positions, and offsets from them.","line":779},{"id":10,"title":"Offsets along the axes of their position.","line":800},{"id":12,"title":"No angle read as a length.","line":836},{"id":14,"title":"Scene conventions stay the scene's.","line":862},{"id":15,"title":"Placement separate from conformance.","line":875}]</a:t>
             </a:r>
           </a:p>
           <a:p xmlns:a="http://schemas.openxmlformats.org/drawingml/2006/main">
@@ -1215,22 +1215,22 @@
           </a:p>
           <a:p xmlns:a="http://schemas.openxmlformats.org/drawingml/2006/main">
             <a:r>
-              <a:t>README SHA-256 708a3b5c2d26a82e32e7ec3c381c2ebb7cda8274fd4567709f98d76d85ca8f6c</a:t>
-            </a:r>
-          </a:p>
-          <a:p xmlns:a="http://schemas.openxmlformats.org/drawingml/2006/main">
-            <a:r>
-              <a:t>Proposal SHA-256 28768109389139a56d5c8e5f473446bfa46dd1ab46a48924165b97fb92cb7ae9</a:t>
-            </a:r>
-          </a:p>
-          <a:p xmlns:a="http://schemas.openxmlformats.org/drawingml/2006/main">
-            <a:r>
-              <a:t>Immutable execution receipt SHA-256 b12019e039ab52f930fb2f4321ca2289875bcdefbd3dbbd669b72a8689647e46</a:t>
-            </a:r>
-          </a:p>
-          <a:p xmlns:a="http://schemas.openxmlformats.org/drawingml/2006/main">
-            <a:r>
-              <a:t>Later audit SHA-256 e7e5278ba30509b5a3e94196ffdb6d59aaa54eadacae97022f6ffab098d94a9a</a:t>
+              <a:t>README SHA-256 e7a38c47715e43994a8c44f1474cd6c4a0e924aab1ae63af557fc405cff0a90e</a:t>
+            </a:r>
+          </a:p>
+          <a:p xmlns:a="http://schemas.openxmlformats.org/drawingml/2006/main">
+            <a:r>
+              <a:t>Proposal SHA-256 0ed1dcda854e43bb82b7e830ba4b2224cdb8da0741fa9d6cb4fe459d4266ace0</a:t>
+            </a:r>
+          </a:p>
+          <a:p xmlns:a="http://schemas.openxmlformats.org/drawingml/2006/main">
+            <a:r>
+              <a:t>Immutable execution receipt SHA-256 bc2c422dc4a9ec855fe6831a1b6afcd2ef86961db5bc954bd71c74d5ec39d842</a:t>
+            </a:r>
+          </a:p>
+          <a:p xmlns:a="http://schemas.openxmlformats.org/drawingml/2006/main">
+            <a:r>
+              <a:t>Later audit SHA-256 2c11e5d97389f5cdcabab87f586d0511c5d6e4e8bdc0b2bd4cdcbfdb7f9d783c</a:t>
             </a:r>
           </a:p>
           <a:p xmlns:a="http://schemas.openxmlformats.org/drawingml/2006/main">
@@ -1340,12 +1340,12 @@
           </a:p>
           <a:p xmlns:a="http://schemas.openxmlformats.org/drawingml/2006/main">
             <a:r>
-              <a:t>Proposal: ### Source placement evaluation and transform order at proposal/proposal-source.txt:1810</a:t>
-            </a:r>
-          </a:p>
-          <a:p xmlns:a="http://schemas.openxmlformats.org/drawingml/2006/main">
-            <a:r>
-              <a:t>Functional requirements: [{"id":9,"title":"Positions, and offsets from them.","line":777},{"id":12,"title":"No angle read as a length.","line":831},{"id":13,"title":"One axis mapping.","line":845},{"id":16,"title":"One CRS out.","line":882},{"id":19,"title":"Resolution leaves the scene as authored.","line":932}]</a:t>
+              <a:t>Proposal: ### Source placement evaluation and transform order at proposal/proposal-source.txt:1830</a:t>
+            </a:r>
+          </a:p>
+          <a:p xmlns:a="http://schemas.openxmlformats.org/drawingml/2006/main">
+            <a:r>
+              <a:t>Functional requirements: [{"id":9,"title":"Positions, and offsets from them.","line":779},{"id":12,"title":"No angle read as a length.","line":836},{"id":13,"title":"One axis mapping.","line":850},{"id":16,"title":"One CRS out.","line":887},{"id":19,"title":"Resolution leaves the scene as authored.","line":937}]</a:t>
             </a:r>
           </a:p>
           <a:p xmlns:a="http://schemas.openxmlformats.org/drawingml/2006/main">
@@ -1360,22 +1360,22 @@
           </a:p>
           <a:p xmlns:a="http://schemas.openxmlformats.org/drawingml/2006/main">
             <a:r>
-              <a:t>README SHA-256 708a3b5c2d26a82e32e7ec3c381c2ebb7cda8274fd4567709f98d76d85ca8f6c</a:t>
-            </a:r>
-          </a:p>
-          <a:p xmlns:a="http://schemas.openxmlformats.org/drawingml/2006/main">
-            <a:r>
-              <a:t>Proposal SHA-256 28768109389139a56d5c8e5f473446bfa46dd1ab46a48924165b97fb92cb7ae9</a:t>
-            </a:r>
-          </a:p>
-          <a:p xmlns:a="http://schemas.openxmlformats.org/drawingml/2006/main">
-            <a:r>
-              <a:t>Immutable execution receipt SHA-256 b12019e039ab52f930fb2f4321ca2289875bcdefbd3dbbd669b72a8689647e46</a:t>
-            </a:r>
-          </a:p>
-          <a:p xmlns:a="http://schemas.openxmlformats.org/drawingml/2006/main">
-            <a:r>
-              <a:t>Later audit SHA-256 e7e5278ba30509b5a3e94196ffdb6d59aaa54eadacae97022f6ffab098d94a9a</a:t>
+              <a:t>README SHA-256 e7a38c47715e43994a8c44f1474cd6c4a0e924aab1ae63af557fc405cff0a90e</a:t>
+            </a:r>
+          </a:p>
+          <a:p xmlns:a="http://schemas.openxmlformats.org/drawingml/2006/main">
+            <a:r>
+              <a:t>Proposal SHA-256 0ed1dcda854e43bb82b7e830ba4b2224cdb8da0741fa9d6cb4fe459d4266ace0</a:t>
+            </a:r>
+          </a:p>
+          <a:p xmlns:a="http://schemas.openxmlformats.org/drawingml/2006/main">
+            <a:r>
+              <a:t>Immutable execution receipt SHA-256 bc2c422dc4a9ec855fe6831a1b6afcd2ef86961db5bc954bd71c74d5ec39d842</a:t>
+            </a:r>
+          </a:p>
+          <a:p xmlns:a="http://schemas.openxmlformats.org/drawingml/2006/main">
+            <a:r>
+              <a:t>Later audit SHA-256 2c11e5d97389f5cdcabab87f586d0511c5d6e4e8bdc0b2bd4cdcbfdb7f9d783c</a:t>
             </a:r>
           </a:p>
           <a:p xmlns:a="http://schemas.openxmlformats.org/drawingml/2006/main">
@@ -1485,12 +1485,12 @@
           </a:p>
           <a:p xmlns:a="http://schemas.openxmlformats.org/drawingml/2006/main">
             <a:r>
-              <a:t>Proposal: #### Evaluation at proposal/proposal-source.txt:1910</a:t>
-            </a:r>
-          </a:p>
-          <a:p xmlns:a="http://schemas.openxmlformats.org/drawingml/2006/main">
-            <a:r>
-              <a:t>Functional requirements: [{"id":9,"title":"Positions, and offsets from them.","line":777},{"id":14,"title":"Scene conventions stay the scene's.","line":857},{"id":15,"title":"Placement separate from conformance.","line":870},{"id":17,"title":"The same answer for every consumer.","line":902},{"id":19,"title":"Resolution leaves the scene as authored.","line":932}]</a:t>
+              <a:t>Proposal: #### Evaluation at proposal/proposal-source.txt:1930</a:t>
+            </a:r>
+          </a:p>
+          <a:p xmlns:a="http://schemas.openxmlformats.org/drawingml/2006/main">
+            <a:r>
+              <a:t>Functional requirements: [{"id":9,"title":"Positions, and offsets from them.","line":779},{"id":14,"title":"Scene conventions stay the scene's.","line":862},{"id":15,"title":"Placement separate from conformance.","line":875},{"id":17,"title":"The same answer for every consumer.","line":907},{"id":19,"title":"Resolution leaves the scene as authored.","line":937}]</a:t>
             </a:r>
           </a:p>
           <a:p xmlns:a="http://schemas.openxmlformats.org/drawingml/2006/main">
@@ -1505,22 +1505,22 @@
           </a:p>
           <a:p xmlns:a="http://schemas.openxmlformats.org/drawingml/2006/main">
             <a:r>
-              <a:t>README SHA-256 708a3b5c2d26a82e32e7ec3c381c2ebb7cda8274fd4567709f98d76d85ca8f6c</a:t>
-            </a:r>
-          </a:p>
-          <a:p xmlns:a="http://schemas.openxmlformats.org/drawingml/2006/main">
-            <a:r>
-              <a:t>Proposal SHA-256 28768109389139a56d5c8e5f473446bfa46dd1ab46a48924165b97fb92cb7ae9</a:t>
-            </a:r>
-          </a:p>
-          <a:p xmlns:a="http://schemas.openxmlformats.org/drawingml/2006/main">
-            <a:r>
-              <a:t>Immutable execution receipt SHA-256 b12019e039ab52f930fb2f4321ca2289875bcdefbd3dbbd669b72a8689647e46</a:t>
-            </a:r>
-          </a:p>
-          <a:p xmlns:a="http://schemas.openxmlformats.org/drawingml/2006/main">
-            <a:r>
-              <a:t>Later audit SHA-256 e7e5278ba30509b5a3e94196ffdb6d59aaa54eadacae97022f6ffab098d94a9a</a:t>
+              <a:t>README SHA-256 e7a38c47715e43994a8c44f1474cd6c4a0e924aab1ae63af557fc405cff0a90e</a:t>
+            </a:r>
+          </a:p>
+          <a:p xmlns:a="http://schemas.openxmlformats.org/drawingml/2006/main">
+            <a:r>
+              <a:t>Proposal SHA-256 0ed1dcda854e43bb82b7e830ba4b2224cdb8da0741fa9d6cb4fe459d4266ace0</a:t>
+            </a:r>
+          </a:p>
+          <a:p xmlns:a="http://schemas.openxmlformats.org/drawingml/2006/main">
+            <a:r>
+              <a:t>Immutable execution receipt SHA-256 bc2c422dc4a9ec855fe6831a1b6afcd2ef86961db5bc954bd71c74d5ec39d842</a:t>
+            </a:r>
+          </a:p>
+          <a:p xmlns:a="http://schemas.openxmlformats.org/drawingml/2006/main">
+            <a:r>
+              <a:t>Later audit SHA-256 2c11e5d97389f5cdcabab87f586d0511c5d6e4e8bdc0b2bd4cdcbfdb7f9d783c</a:t>
             </a:r>
           </a:p>
           <a:p xmlns:a="http://schemas.openxmlformats.org/drawingml/2006/main">
@@ -1630,12 +1630,12 @@
           </a:p>
           <a:p xmlns:a="http://schemas.openxmlformats.org/drawingml/2006/main">
             <a:r>
-              <a:t>Proposal: ### Extent and result comparison at proposal/proposal-source.txt:2042</a:t>
-            </a:r>
-          </a:p>
-          <a:p xmlns:a="http://schemas.openxmlformats.org/drawingml/2006/main">
-            <a:r>
-              <a:t>Functional requirements: [{"id":4,"title":"A site's own grid is a CRS like any other.","line":674},{"id":13,"title":"One axis mapping.","line":845},{"id":16,"title":"One CRS out.","line":882},{"id":17,"title":"The same answer for every consumer.","line":902},{"id":18,"title":"Coordinates back out.","line":917},{"id":28,"title":"A result says what produced it.","line":1099},{"id":29,"title":"Implementable from the text alone.","line":1117}]</a:t>
+              <a:t>Proposal: ### Extent and result comparison at proposal/proposal-source.txt:2085</a:t>
+            </a:r>
+          </a:p>
+          <a:p xmlns:a="http://schemas.openxmlformats.org/drawingml/2006/main">
+            <a:r>
+              <a:t>Functional requirements: [{"id":4,"title":"A site's own grid is a CRS like any other.","line":676},{"id":13,"title":"One axis mapping.","line":850},{"id":16,"title":"One CRS out.","line":887},{"id":17,"title":"The same answer for every consumer.","line":907},{"id":18,"title":"Coordinates back out.","line":922},{"id":28,"title":"A result says what produced it.","line":1104},{"id":29,"title":"Implementable from the text alone.","line":1122}]</a:t>
             </a:r>
           </a:p>
           <a:p xmlns:a="http://schemas.openxmlformats.org/drawingml/2006/main">
@@ -1650,22 +1650,22 @@
           </a:p>
           <a:p xmlns:a="http://schemas.openxmlformats.org/drawingml/2006/main">
             <a:r>
-              <a:t>README SHA-256 708a3b5c2d26a82e32e7ec3c381c2ebb7cda8274fd4567709f98d76d85ca8f6c</a:t>
-            </a:r>
-          </a:p>
-          <a:p xmlns:a="http://schemas.openxmlformats.org/drawingml/2006/main">
-            <a:r>
-              <a:t>Proposal SHA-256 28768109389139a56d5c8e5f473446bfa46dd1ab46a48924165b97fb92cb7ae9</a:t>
-            </a:r>
-          </a:p>
-          <a:p xmlns:a="http://schemas.openxmlformats.org/drawingml/2006/main">
-            <a:r>
-              <a:t>Immutable execution receipt SHA-256 b12019e039ab52f930fb2f4321ca2289875bcdefbd3dbbd669b72a8689647e46</a:t>
-            </a:r>
-          </a:p>
-          <a:p xmlns:a="http://schemas.openxmlformats.org/drawingml/2006/main">
-            <a:r>
-              <a:t>Later audit SHA-256 e7e5278ba30509b5a3e94196ffdb6d59aaa54eadacae97022f6ffab098d94a9a</a:t>
+              <a:t>README SHA-256 e7a38c47715e43994a8c44f1474cd6c4a0e924aab1ae63af557fc405cff0a90e</a:t>
+            </a:r>
+          </a:p>
+          <a:p xmlns:a="http://schemas.openxmlformats.org/drawingml/2006/main">
+            <a:r>
+              <a:t>Proposal SHA-256 0ed1dcda854e43bb82b7e830ba4b2224cdb8da0741fa9d6cb4fe459d4266ace0</a:t>
+            </a:r>
+          </a:p>
+          <a:p xmlns:a="http://schemas.openxmlformats.org/drawingml/2006/main">
+            <a:r>
+              <a:t>Immutable execution receipt SHA-256 bc2c422dc4a9ec855fe6831a1b6afcd2ef86961db5bc954bd71c74d5ec39d842</a:t>
+            </a:r>
+          </a:p>
+          <a:p xmlns:a="http://schemas.openxmlformats.org/drawingml/2006/main">
+            <a:r>
+              <a:t>Later audit SHA-256 2c11e5d97389f5cdcabab87f586d0511c5d6e4e8bdc0b2bd4cdcbfdb7f9d783c</a:t>
             </a:r>
           </a:p>
           <a:p xmlns:a="http://schemas.openxmlformats.org/drawingml/2006/main">
@@ -1775,12 +1775,12 @@
           </a:p>
           <a:p xmlns:a="http://schemas.openxmlformats.org/drawingml/2006/main">
             <a:r>
-              <a:t>Proposal: ### Explicit export and sampling at proposal/proposal-source.txt:2095</a:t>
-            </a:r>
-          </a:p>
-          <a:p xmlns:a="http://schemas.openxmlformats.org/drawingml/2006/main">
-            <a:r>
-              <a:t>Functional requirements: [{"id":17,"title":"The same answer for every consumer.","line":902},{"id":19,"title":"Resolution leaves the scene as authored.","line":932},{"id":23,"title":"Detail that does not depend on location.","line":1038},{"id":25,"title":"Additive for consumers that ignore it.","line":1062},{"id":29,"title":"Implementable from the text alone.","line":1117}]</a:t>
+              <a:t>Proposal: ### Explicit export and sampling at proposal/proposal-source.txt:2138</a:t>
+            </a:r>
+          </a:p>
+          <a:p xmlns:a="http://schemas.openxmlformats.org/drawingml/2006/main">
+            <a:r>
+              <a:t>Functional requirements: [{"id":17,"title":"The same answer for every consumer.","line":907},{"id":19,"title":"Resolution leaves the scene as authored.","line":937},{"id":23,"title":"Detail that does not depend on location.","line":1043},{"id":25,"title":"Additive for consumers that ignore it.","line":1067},{"id":29,"title":"Implementable from the text alone.","line":1122}]</a:t>
             </a:r>
           </a:p>
           <a:p xmlns:a="http://schemas.openxmlformats.org/drawingml/2006/main">
@@ -1795,22 +1795,22 @@
           </a:p>
           <a:p xmlns:a="http://schemas.openxmlformats.org/drawingml/2006/main">
             <a:r>
-              <a:t>README SHA-256 708a3b5c2d26a82e32e7ec3c381c2ebb7cda8274fd4567709f98d76d85ca8f6c</a:t>
-            </a:r>
-          </a:p>
-          <a:p xmlns:a="http://schemas.openxmlformats.org/drawingml/2006/main">
-            <a:r>
-              <a:t>Proposal SHA-256 28768109389139a56d5c8e5f473446bfa46dd1ab46a48924165b97fb92cb7ae9</a:t>
-            </a:r>
-          </a:p>
-          <a:p xmlns:a="http://schemas.openxmlformats.org/drawingml/2006/main">
-            <a:r>
-              <a:t>Immutable execution receipt SHA-256 b12019e039ab52f930fb2f4321ca2289875bcdefbd3dbbd669b72a8689647e46</a:t>
-            </a:r>
-          </a:p>
-          <a:p xmlns:a="http://schemas.openxmlformats.org/drawingml/2006/main">
-            <a:r>
-              <a:t>Later audit SHA-256 e7e5278ba30509b5a3e94196ffdb6d59aaa54eadacae97022f6ffab098d94a9a</a:t>
+              <a:t>README SHA-256 e7a38c47715e43994a8c44f1474cd6c4a0e924aab1ae63af557fc405cff0a90e</a:t>
+            </a:r>
+          </a:p>
+          <a:p xmlns:a="http://schemas.openxmlformats.org/drawingml/2006/main">
+            <a:r>
+              <a:t>Proposal SHA-256 0ed1dcda854e43bb82b7e830ba4b2224cdb8da0741fa9d6cb4fe459d4266ace0</a:t>
+            </a:r>
+          </a:p>
+          <a:p xmlns:a="http://schemas.openxmlformats.org/drawingml/2006/main">
+            <a:r>
+              <a:t>Immutable execution receipt SHA-256 bc2c422dc4a9ec855fe6831a1b6afcd2ef86961db5bc954bd71c74d5ec39d842</a:t>
+            </a:r>
+          </a:p>
+          <a:p xmlns:a="http://schemas.openxmlformats.org/drawingml/2006/main">
+            <a:r>
+              <a:t>Later audit SHA-256 2c11e5d97389f5cdcabab87f586d0511c5d6e4e8bdc0b2bd4cdcbfdb7f9d783c</a:t>
             </a:r>
           </a:p>
           <a:p xmlns:a="http://schemas.openxmlformats.org/drawingml/2006/main">
@@ -1915,17 +1915,17 @@
           </a:p>
           <a:p xmlns:a="http://schemas.openxmlformats.org/drawingml/2006/main">
             <a:r>
-              <a:t>Limit: Synthetic values. Dimension-name tests check associations independently of the shared decoder.</a:t>
-            </a:r>
-          </a:p>
-          <a:p xmlns:a="http://schemas.openxmlformats.org/drawingml/2006/main">
-            <a:r>
-              <a:t>Proposal: ### External measurement association at proposal/proposal-source.txt:1610</a:t>
-            </a:r>
-          </a:p>
-          <a:p xmlns:a="http://schemas.openxmlformats.org/drawingml/2006/main">
-            <a:r>
-              <a:t>Functional requirements: [{"id":8,"title":"Brought-in data keeps its coordinates and its CRS.","line":751},{"id":12,"title":"No angle read as a length.","line":831},{"id":18,"title":"Coordinates back out.","line":917},{"id":19,"title":"Resolution leaves the scene as authored.","line":932},{"id":21,"title":"Never placed by a guess.","line":968},{"id":30,"title":"Measurements remain usable as data.","line":1003}]</a:t>
+              <a:t>Limit: The values are synthetic. Named-dimension associations are independently tested; agreeing readers alone cannot verify shared decoding.</a:t>
+            </a:r>
+          </a:p>
+          <a:p xmlns:a="http://schemas.openxmlformats.org/drawingml/2006/main">
+            <a:r>
+              <a:t>Proposal: ### External measurement association at proposal/proposal-source.txt:1630</a:t>
+            </a:r>
+          </a:p>
+          <a:p xmlns:a="http://schemas.openxmlformats.org/drawingml/2006/main">
+            <a:r>
+              <a:t>Functional requirements: [{"id":8,"title":"Brought-in data keeps its coordinates and its CRS.","line":753},{"id":12,"title":"No angle read as a length.","line":836},{"id":18,"title":"Coordinates back out.","line":922},{"id":19,"title":"Resolution leaves the scene as authored.","line":937},{"id":21,"title":"Never placed by a guess.","line":973},{"id":30,"title":"Measurements remain usable as data.","line":1008}]</a:t>
             </a:r>
           </a:p>
           <a:p xmlns:a="http://schemas.openxmlformats.org/drawingml/2006/main">
@@ -1940,22 +1940,22 @@
           </a:p>
           <a:p xmlns:a="http://schemas.openxmlformats.org/drawingml/2006/main">
             <a:r>
-              <a:t>README SHA-256 708a3b5c2d26a82e32e7ec3c381c2ebb7cda8274fd4567709f98d76d85ca8f6c</a:t>
-            </a:r>
-          </a:p>
-          <a:p xmlns:a="http://schemas.openxmlformats.org/drawingml/2006/main">
-            <a:r>
-              <a:t>Proposal SHA-256 28768109389139a56d5c8e5f473446bfa46dd1ab46a48924165b97fb92cb7ae9</a:t>
-            </a:r>
-          </a:p>
-          <a:p xmlns:a="http://schemas.openxmlformats.org/drawingml/2006/main">
-            <a:r>
-              <a:t>Immutable execution receipt SHA-256 b12019e039ab52f930fb2f4321ca2289875bcdefbd3dbbd669b72a8689647e46</a:t>
-            </a:r>
-          </a:p>
-          <a:p xmlns:a="http://schemas.openxmlformats.org/drawingml/2006/main">
-            <a:r>
-              <a:t>Later audit SHA-256 e7e5278ba30509b5a3e94196ffdb6d59aaa54eadacae97022f6ffab098d94a9a</a:t>
+              <a:t>README SHA-256 e7a38c47715e43994a8c44f1474cd6c4a0e924aab1ae63af557fc405cff0a90e</a:t>
+            </a:r>
+          </a:p>
+          <a:p xmlns:a="http://schemas.openxmlformats.org/drawingml/2006/main">
+            <a:r>
+              <a:t>Proposal SHA-256 0ed1dcda854e43bb82b7e830ba4b2224cdb8da0741fa9d6cb4fe459d4266ace0</a:t>
+            </a:r>
+          </a:p>
+          <a:p xmlns:a="http://schemas.openxmlformats.org/drawingml/2006/main">
+            <a:r>
+              <a:t>Immutable execution receipt SHA-256 bc2c422dc4a9ec855fe6831a1b6afcd2ef86961db5bc954bd71c74d5ec39d842</a:t>
+            </a:r>
+          </a:p>
+          <a:p xmlns:a="http://schemas.openxmlformats.org/drawingml/2006/main">
+            <a:r>
+              <a:t>Later audit SHA-256 2c11e5d97389f5cdcabab87f586d0511c5d6e4e8bdc0b2bd4cdcbfdb7f9d783c</a:t>
             </a:r>
           </a:p>
           <a:p xmlns:a="http://schemas.openxmlformats.org/drawingml/2006/main">
@@ -2045,22 +2045,22 @@
           </a:p>
           <a:p xmlns:a="http://schemas.openxmlformats.org/drawingml/2006/main">
             <a:r>
-              <a:t>README SHA-256 708a3b5c2d26a82e32e7ec3c381c2ebb7cda8274fd4567709f98d76d85ca8f6c</a:t>
-            </a:r>
-          </a:p>
-          <a:p xmlns:a="http://schemas.openxmlformats.org/drawingml/2006/main">
-            <a:r>
-              <a:t>Proposal SHA-256 28768109389139a56d5c8e5f473446bfa46dd1ab46a48924165b97fb92cb7ae9</a:t>
-            </a:r>
-          </a:p>
-          <a:p xmlns:a="http://schemas.openxmlformats.org/drawingml/2006/main">
-            <a:r>
-              <a:t>Immutable execution receipt SHA-256 b12019e039ab52f930fb2f4321ca2289875bcdefbd3dbbd669b72a8689647e46</a:t>
-            </a:r>
-          </a:p>
-          <a:p xmlns:a="http://schemas.openxmlformats.org/drawingml/2006/main">
-            <a:r>
-              <a:t>Later audit SHA-256 e7e5278ba30509b5a3e94196ffdb6d59aaa54eadacae97022f6ffab098d94a9a</a:t>
+              <a:t>README SHA-256 e7a38c47715e43994a8c44f1474cd6c4a0e924aab1ae63af557fc405cff0a90e</a:t>
+            </a:r>
+          </a:p>
+          <a:p xmlns:a="http://schemas.openxmlformats.org/drawingml/2006/main">
+            <a:r>
+              <a:t>Proposal SHA-256 0ed1dcda854e43bb82b7e830ba4b2224cdb8da0741fa9d6cb4fe459d4266ace0</a:t>
+            </a:r>
+          </a:p>
+          <a:p xmlns:a="http://schemas.openxmlformats.org/drawingml/2006/main">
+            <a:r>
+              <a:t>Immutable execution receipt SHA-256 bc2c422dc4a9ec855fe6831a1b6afcd2ef86961db5bc954bd71c74d5ec39d842</a:t>
+            </a:r>
+          </a:p>
+          <a:p xmlns:a="http://schemas.openxmlformats.org/drawingml/2006/main">
+            <a:r>
+              <a:t>Later audit SHA-256 2c11e5d97389f5cdcabab87f586d0511c5d6e4e8bdc0b2bd4cdcbfdb7f9d783c</a:t>
             </a:r>
           </a:p>
           <a:p xmlns:a="http://schemas.openxmlformats.org/drawingml/2006/main">
@@ -2170,12 +2170,12 @@
           </a:p>
           <a:p xmlns:a="http://schemas.openxmlformats.org/drawingml/2006/main">
             <a:r>
-              <a:t>Proposal: #### Decision on question 7: site calibration at proposal/proposal-source.txt:1294</a:t>
-            </a:r>
-          </a:p>
-          <a:p xmlns:a="http://schemas.openxmlformats.org/drawingml/2006/main">
-            <a:r>
-              <a:t>Functional requirements: [{"id":4,"title":"A site's own grid is a CRS like any other.","line":674},{"id":14,"title":"Scene conventions stay the scene's.","line":857},{"id":15,"title":"Placement separate from conformance.","line":870},{"id":17,"title":"The same answer for every consumer.","line":902}]</a:t>
+              <a:t>Proposal: #### Decision on question 7: site calibration at proposal/proposal-source.txt:1303</a:t>
+            </a:r>
+          </a:p>
+          <a:p xmlns:a="http://schemas.openxmlformats.org/drawingml/2006/main">
+            <a:r>
+              <a:t>Functional requirements: [{"id":4,"title":"A site's own grid is a CRS like any other.","line":676},{"id":14,"title":"Scene conventions stay the scene's.","line":862},{"id":15,"title":"Placement separate from conformance.","line":875},{"id":17,"title":"The same answer for every consumer.","line":907}]</a:t>
             </a:r>
           </a:p>
           <a:p xmlns:a="http://schemas.openxmlformats.org/drawingml/2006/main">
@@ -2190,22 +2190,22 @@
           </a:p>
           <a:p xmlns:a="http://schemas.openxmlformats.org/drawingml/2006/main">
             <a:r>
-              <a:t>README SHA-256 708a3b5c2d26a82e32e7ec3c381c2ebb7cda8274fd4567709f98d76d85ca8f6c</a:t>
-            </a:r>
-          </a:p>
-          <a:p xmlns:a="http://schemas.openxmlformats.org/drawingml/2006/main">
-            <a:r>
-              <a:t>Proposal SHA-256 28768109389139a56d5c8e5f473446bfa46dd1ab46a48924165b97fb92cb7ae9</a:t>
-            </a:r>
-          </a:p>
-          <a:p xmlns:a="http://schemas.openxmlformats.org/drawingml/2006/main">
-            <a:r>
-              <a:t>Immutable execution receipt SHA-256 b12019e039ab52f930fb2f4321ca2289875bcdefbd3dbbd669b72a8689647e46</a:t>
-            </a:r>
-          </a:p>
-          <a:p xmlns:a="http://schemas.openxmlformats.org/drawingml/2006/main">
-            <a:r>
-              <a:t>Later audit SHA-256 e7e5278ba30509b5a3e94196ffdb6d59aaa54eadacae97022f6ffab098d94a9a</a:t>
+              <a:t>README SHA-256 e7a38c47715e43994a8c44f1474cd6c4a0e924aab1ae63af557fc405cff0a90e</a:t>
+            </a:r>
+          </a:p>
+          <a:p xmlns:a="http://schemas.openxmlformats.org/drawingml/2006/main">
+            <a:r>
+              <a:t>Proposal SHA-256 0ed1dcda854e43bb82b7e830ba4b2224cdb8da0741fa9d6cb4fe459d4266ace0</a:t>
+            </a:r>
+          </a:p>
+          <a:p xmlns:a="http://schemas.openxmlformats.org/drawingml/2006/main">
+            <a:r>
+              <a:t>Immutable execution receipt SHA-256 bc2c422dc4a9ec855fe6831a1b6afcd2ef86961db5bc954bd71c74d5ec39d842</a:t>
+            </a:r>
+          </a:p>
+          <a:p xmlns:a="http://schemas.openxmlformats.org/drawingml/2006/main">
+            <a:r>
+              <a:t>Later audit SHA-256 2c11e5d97389f5cdcabab87f586d0511c5d6e4e8bdc0b2bd4cdcbfdb7f9d783c</a:t>
             </a:r>
           </a:p>
           <a:p xmlns:a="http://schemas.openxmlformats.org/drawingml/2006/main">
@@ -2262,7 +2262,7 @@
           <p:cNvPr id="3" name="Title">
             <a:extLst xmlns:a="http://schemas.openxmlformats.org/drawingml/2006/main">
               <a:ext uri="{FF2B5EF4-FFF2-40B4-BE49-F238E27FC236}">
-                <a16:creationId xmlns:a16="http://schemas.microsoft.com/office/drawing/2014/main" id="{21BB5223-5EEC-44E0-AE9A-8D60D412E027}"/>
+                <a16:creationId xmlns:a16="http://schemas.microsoft.com/office/drawing/2014/main" id="{589443B7-F491-4E4E-BBDD-573B9813CCA6}"/>
               </a:ext>
             </a:extLst>
           </p:cNvPr>
@@ -2419,7 +2419,7 @@
           <p:cNvPr id="2" name="Subtitle">
             <a:extLst xmlns:a="http://schemas.openxmlformats.org/drawingml/2006/main">
               <a:ext uri="{FF2B5EF4-FFF2-40B4-BE49-F238E27FC236}">
-                <a16:creationId xmlns:a16="http://schemas.microsoft.com/office/drawing/2014/main" id="{011BF116-BB13-46A9-90BE-2E473EF69CE7}"/>
+                <a16:creationId xmlns:a16="http://schemas.microsoft.com/office/drawing/2014/main" id="{C64C70A5-A4BD-47D7-BB1A-673AD6D257D7}"/>
               </a:ext>
             </a:extLst>
           </p:cNvPr>
@@ -2593,7 +2593,7 @@
           <p:cNvPr id="2" name="Section title">
             <a:extLst xmlns:a="http://schemas.openxmlformats.org/drawingml/2006/main">
               <a:ext uri="{FF2B5EF4-FFF2-40B4-BE49-F238E27FC236}">
-                <a16:creationId xmlns:a16="http://schemas.microsoft.com/office/drawing/2014/main" id="{23BCB66F-27A5-4AE5-BCD3-AEAC8EE46F7D}"/>
+                <a16:creationId xmlns:a16="http://schemas.microsoft.com/office/drawing/2014/main" id="{81B7AAEC-5292-4A83-9971-92D2773B5C79}"/>
               </a:ext>
             </a:extLst>
           </p:cNvPr>
@@ -2767,7 +2767,7 @@
           <p:cNvPr id="3" name="Title">
             <a:extLst xmlns:a="http://schemas.openxmlformats.org/drawingml/2006/main">
               <a:ext uri="{FF2B5EF4-FFF2-40B4-BE49-F238E27FC236}">
-                <a16:creationId xmlns:a16="http://schemas.microsoft.com/office/drawing/2014/main" id="{24E279D9-2EB9-416D-A08E-5E01B5862D6E}"/>
+                <a16:creationId xmlns:a16="http://schemas.microsoft.com/office/drawing/2014/main" id="{A6875809-DE26-4022-B6E7-A83AF9956BDC}"/>
               </a:ext>
             </a:extLst>
           </p:cNvPr>
@@ -2924,7 +2924,7 @@
           <p:cNvPr id="2" name="Body">
             <a:extLst xmlns:a="http://schemas.openxmlformats.org/drawingml/2006/main">
               <a:ext uri="{FF2B5EF4-FFF2-40B4-BE49-F238E27FC236}">
-                <a16:creationId xmlns:a16="http://schemas.microsoft.com/office/drawing/2014/main" id="{AC70189C-322D-4E71-A2D1-BFAC58395084}"/>
+                <a16:creationId xmlns:a16="http://schemas.microsoft.com/office/drawing/2014/main" id="{401D9240-D6BD-43EA-A35A-64CCAF4EC322}"/>
               </a:ext>
             </a:extLst>
           </p:cNvPr>
@@ -3098,7 +3098,7 @@
           <p:cNvPr id="4" name="Title">
             <a:extLst xmlns:a="http://schemas.openxmlformats.org/drawingml/2006/main">
               <a:ext uri="{FF2B5EF4-FFF2-40B4-BE49-F238E27FC236}">
-                <a16:creationId xmlns:a16="http://schemas.microsoft.com/office/drawing/2014/main" id="{E444A410-EB75-4A5B-9E35-5A33E8322C64}"/>
+                <a16:creationId xmlns:a16="http://schemas.microsoft.com/office/drawing/2014/main" id="{47F4A65D-249C-4836-B169-AE45EED44B21}"/>
               </a:ext>
             </a:extLst>
           </p:cNvPr>
@@ -3255,7 +3255,7 @@
           <p:cNvPr id="2" name="Left column">
             <a:extLst xmlns:a="http://schemas.openxmlformats.org/drawingml/2006/main">
               <a:ext uri="{FF2B5EF4-FFF2-40B4-BE49-F238E27FC236}">
-                <a16:creationId xmlns:a16="http://schemas.microsoft.com/office/drawing/2014/main" id="{9A7B4911-8414-46C6-BD4E-8A208B2817F5}"/>
+                <a16:creationId xmlns:a16="http://schemas.microsoft.com/office/drawing/2014/main" id="{DDB7F9C7-5DB0-49A8-90C3-53160992AD70}"/>
               </a:ext>
             </a:extLst>
           </p:cNvPr>
@@ -3412,7 +3412,7 @@
           <p:cNvPr id="3" name="Right column">
             <a:extLst xmlns:a="http://schemas.openxmlformats.org/drawingml/2006/main">
               <a:ext uri="{FF2B5EF4-FFF2-40B4-BE49-F238E27FC236}">
-                <a16:creationId xmlns:a16="http://schemas.microsoft.com/office/drawing/2014/main" id="{10785BDE-9A24-4D8D-AB5A-9E6CEE9EFD03}"/>
+                <a16:creationId xmlns:a16="http://schemas.microsoft.com/office/drawing/2014/main" id="{9580D369-38C5-462D-B215-2BF71FEECDEE}"/>
               </a:ext>
             </a:extLst>
           </p:cNvPr>
@@ -3586,7 +3586,7 @@
           <p:cNvPr id="3" name="Title">
             <a:extLst xmlns:a="http://schemas.openxmlformats.org/drawingml/2006/main">
               <a:ext uri="{FF2B5EF4-FFF2-40B4-BE49-F238E27FC236}">
-                <a16:creationId xmlns:a16="http://schemas.microsoft.com/office/drawing/2014/main" id="{EA7322A0-617E-4A6D-9B63-543C50B1B663}"/>
+                <a16:creationId xmlns:a16="http://schemas.microsoft.com/office/drawing/2014/main" id="{28ACD92B-798A-4E31-A617-470290B31D24}"/>
               </a:ext>
             </a:extLst>
           </p:cNvPr>
@@ -3743,7 +3743,7 @@
           <p:cNvPr id="2" name="Left column">
             <a:extLst xmlns:a="http://schemas.openxmlformats.org/drawingml/2006/main">
               <a:ext uri="{FF2B5EF4-FFF2-40B4-BE49-F238E27FC236}">
-                <a16:creationId xmlns:a16="http://schemas.microsoft.com/office/drawing/2014/main" id="{7A3F0FC4-FCCF-498D-B8AB-DC92CFA92172}"/>
+                <a16:creationId xmlns:a16="http://schemas.microsoft.com/office/drawing/2014/main" id="{0F0EA803-E8DB-43E9-B099-69E9A6F5B8C0}"/>
               </a:ext>
             </a:extLst>
           </p:cNvPr>
@@ -3938,12 +3938,12 @@
   </p:cSld>
   <p:clrMap bg1="lt1" tx1="dk1" bg2="lt2" tx2="dk2" accent1="accent1" accent2="accent2" accent3="accent3" accent4="accent4" accent5="accent5" accent6="accent6" hlink="hlink" folHlink="folHlink"/>
   <p:sldLayoutIdLst>
-    <p:sldLayoutId xmlns:r="http://schemas.openxmlformats.org/officeDocument/2006/relationships" id="2147483649" r:id="R47389a25d2694ec1"/>
-    <p:sldLayoutId xmlns:r="http://schemas.openxmlformats.org/officeDocument/2006/relationships" id="2147483650" r:id="R5c9e4b39db504ff9"/>
-    <p:sldLayoutId xmlns:r="http://schemas.openxmlformats.org/officeDocument/2006/relationships" id="2147483651" r:id="R974c490a934049ea"/>
-    <p:sldLayoutId xmlns:r="http://schemas.openxmlformats.org/officeDocument/2006/relationships" id="2147483652" r:id="R4bfcf0087f034859"/>
-    <p:sldLayoutId xmlns:r="http://schemas.openxmlformats.org/officeDocument/2006/relationships" id="2147483653" r:id="R9eb25a25fd9a4fc1"/>
-    <p:sldLayoutId xmlns:r="http://schemas.openxmlformats.org/officeDocument/2006/relationships" id="2147483654" r:id="Rac238190cc924918"/>
+    <p:sldLayoutId xmlns:r="http://schemas.openxmlformats.org/officeDocument/2006/relationships" id="2147483649" r:id="R1202b325ffe84126"/>
+    <p:sldLayoutId xmlns:r="http://schemas.openxmlformats.org/officeDocument/2006/relationships" id="2147483650" r:id="R50f88dabeddb4e34"/>
+    <p:sldLayoutId xmlns:r="http://schemas.openxmlformats.org/officeDocument/2006/relationships" id="2147483651" r:id="R816c748fecde4915"/>
+    <p:sldLayoutId xmlns:r="http://schemas.openxmlformats.org/officeDocument/2006/relationships" id="2147483652" r:id="Re72ad86a6f7e483e"/>
+    <p:sldLayoutId xmlns:r="http://schemas.openxmlformats.org/officeDocument/2006/relationships" id="2147483653" r:id="Rd6048145743e4f9b"/>
+    <p:sldLayoutId xmlns:r="http://schemas.openxmlformats.org/officeDocument/2006/relationships" id="2147483654" r:id="R5edcac9528e84997"/>
   </p:sldLayoutIdLst>
   <p:txStyles>
     <p:titleStyle>
@@ -4758,7 +4758,7 @@
           <p:cNvPr id="5" name="">
             <a:extLst xmlns:a="http://schemas.openxmlformats.org/drawingml/2006/main">
               <a:ext uri="{FF2B5EF4-FFF2-40B4-BE49-F238E27FC236}">
-                <a16:creationId xmlns:a16="http://schemas.microsoft.com/office/drawing/2014/main" id="{B339C9E5-DF6F-4457-B0B3-C80E3076CF75}"/>
+                <a16:creationId xmlns:a16="http://schemas.microsoft.com/office/drawing/2014/main" id="{B9C4D5B6-FC81-4520-BDB9-96063679D8D9}"/>
               </a:ext>
             </a:extLst>
           </p:cNvPr>
@@ -4830,7 +4830,7 @@
           <p:cNvPr id="2" name="">
             <a:extLst xmlns:a="http://schemas.openxmlformats.org/drawingml/2006/main">
               <a:ext uri="{FF2B5EF4-FFF2-40B4-BE49-F238E27FC236}">
-                <a16:creationId xmlns:a16="http://schemas.microsoft.com/office/drawing/2014/main" id="{8D3C77EB-E9C4-44C3-8E48-EBA8BE154B7D}"/>
+                <a16:creationId xmlns:a16="http://schemas.microsoft.com/office/drawing/2014/main" id="{00F62D1C-0AE8-4CB1-BD6E-05E0E6BFE869}"/>
               </a:ext>
             </a:extLst>
           </p:cNvPr>
@@ -4902,7 +4902,7 @@
           <p:cNvPr id="3" name="">
             <a:extLst xmlns:a="http://schemas.openxmlformats.org/drawingml/2006/main">
               <a:ext uri="{FF2B5EF4-FFF2-40B4-BE49-F238E27FC236}">
-                <a16:creationId xmlns:a16="http://schemas.microsoft.com/office/drawing/2014/main" id="{E91A9F4F-FF3E-494E-90AE-08B943FBA73E}"/>
+                <a16:creationId xmlns:a16="http://schemas.microsoft.com/office/drawing/2014/main" id="{57D2E54B-BBE8-4229-AA23-6C7611790BEA}"/>
               </a:ext>
             </a:extLst>
           </p:cNvPr>
@@ -4964,7 +4964,7 @@
                 <a:ea typeface="Arial"/>
                 <a:cs typeface="Arial"/>
               </a:rPr>
-              <a:t>The local split gives reviewers a focused requirements baseline and a separate full model/runtime candidate. Clearer array, invalid-input and bake rules now have fresh tests.</a:t>
+              <a:t>The full follow-up now starts from placement authoring: a readable heading/pitch/roll input, with explicit physical meaning and sample evaluation. The focused requirements baseline remains separate.</a:t>
             </a:r>
           </a:p>
         </p:txBody>
@@ -4974,7 +4974,7 @@
           <p:cNvPr id="4" name="">
             <a:extLst xmlns:a="http://schemas.openxmlformats.org/drawingml/2006/main">
               <a:ext uri="{FF2B5EF4-FFF2-40B4-BE49-F238E27FC236}">
-                <a16:creationId xmlns:a16="http://schemas.microsoft.com/office/drawing/2014/main" id="{04AF12E0-4D5D-4755-B730-A288F2D2AE4C}"/>
+                <a16:creationId xmlns:a16="http://schemas.microsoft.com/office/drawing/2014/main" id="{54523966-949A-4F93-ACE2-B98ED68B0512}"/>
               </a:ext>
             </a:extLst>
           </p:cNvPr>
@@ -5036,7 +5036,7 @@
                 <a:ea typeface="Arial"/>
                 <a:cs typeface="Arial"/>
               </a:rPr>
-              <a:t>All prior recorded numeric results match. Six audited defects are corrected; normal sampling remains unresolved. Orientation storage and detailed conventions still need review.</a:t>
+              <a:t>All 105 prior case comparisons remain within their existing acceptance limits. New orientation and composition controls pass. Normal sampling remains unresolved; the preferred HPR model still needs group adoption.</a:t>
             </a:r>
           </a:p>
         </p:txBody>
@@ -5044,7 +5044,7 @@
     </p:spTree>
     <p:extLst>
       <p:ext uri="{BB962C8B-B14F-4D97-AF65-F5344CB8AC3E}">
-        <p14:creationId xmlns:p14="http://schemas.microsoft.com/office/powerpoint/2010/main" val="1674383663"/>
+        <p14:creationId xmlns:p14="http://schemas.microsoft.com/office/powerpoint/2010/main" val="71205490"/>
       </p:ext>
     </p:extLst>
   </p:cSld>
@@ -5075,7 +5075,7 @@
           <p:cNvPr id="9" name="">
             <a:extLst xmlns:a="http://schemas.openxmlformats.org/drawingml/2006/main">
               <a:ext uri="{FF2B5EF4-FFF2-40B4-BE49-F238E27FC236}">
-                <a16:creationId xmlns:a16="http://schemas.microsoft.com/office/drawing/2014/main" id="{F82EAF67-1390-4799-B7DD-5CD317638EE3}"/>
+                <a16:creationId xmlns:a16="http://schemas.microsoft.com/office/drawing/2014/main" id="{50F85D39-18B0-4645-9E0B-1E526A4E0104}"/>
               </a:ext>
             </a:extLst>
           </p:cNvPr>
@@ -5147,7 +5147,7 @@
           <p:cNvPr id="2" name="">
             <a:extLst xmlns:a="http://schemas.openxmlformats.org/drawingml/2006/main">
               <a:ext uri="{FF2B5EF4-FFF2-40B4-BE49-F238E27FC236}">
-                <a16:creationId xmlns:a16="http://schemas.microsoft.com/office/drawing/2014/main" id="{EC16A695-28E5-4D86-8A7A-DB6954A10881}"/>
+                <a16:creationId xmlns:a16="http://schemas.microsoft.com/office/drawing/2014/main" id="{89E2141E-A7D6-4917-8CF3-F5A14DAAD5E9}"/>
               </a:ext>
             </a:extLst>
           </p:cNvPr>
@@ -5219,7 +5219,7 @@
           <p:cNvPr id="3" name="">
             <a:extLst xmlns:a="http://schemas.openxmlformats.org/drawingml/2006/main">
               <a:ext uri="{FF2B5EF4-FFF2-40B4-BE49-F238E27FC236}">
-                <a16:creationId xmlns:a16="http://schemas.microsoft.com/office/drawing/2014/main" id="{A4260F1B-37C8-46F2-9899-BEBC6ACD6FBC}"/>
+                <a16:creationId xmlns:a16="http://schemas.microsoft.com/office/drawing/2014/main" id="{E476F78F-CB94-48C1-BAE7-CAA7CD6604AD}"/>
               </a:ext>
             </a:extLst>
           </p:cNvPr>
@@ -5229,7 +5229,7 @@
           <p:nvPr/>
         </p:nvPicPr>
         <p:blipFill>
-          <a:blip xmlns:r="http://schemas.openxmlformats.org/officeDocument/2006/relationships" xmlns:a="http://schemas.openxmlformats.org/drawingml/2006/main" r:embed="R2e02d866ed564574"/>
+          <a:blip xmlns:r="http://schemas.openxmlformats.org/officeDocument/2006/relationships" xmlns:a="http://schemas.openxmlformats.org/drawingml/2006/main" r:embed="R5c9372ad25c642d4"/>
           <a:stretch xmlns:a="http://schemas.openxmlformats.org/drawingml/2006/main"/>
         </p:blipFill>
         <p:spPr>
@@ -5247,7 +5247,7 @@
           <p:cNvPr id="4" name="">
             <a:extLst xmlns:a="http://schemas.openxmlformats.org/drawingml/2006/main">
               <a:ext uri="{FF2B5EF4-FFF2-40B4-BE49-F238E27FC236}">
-                <a16:creationId xmlns:a16="http://schemas.microsoft.com/office/drawing/2014/main" id="{7ADD2866-C0AE-447F-8355-BD923741E0CC}"/>
+                <a16:creationId xmlns:a16="http://schemas.microsoft.com/office/drawing/2014/main" id="{966208A4-5B0A-4ACD-901E-1D72634D224E}"/>
               </a:ext>
             </a:extLst>
           </p:cNvPr>
@@ -5319,7 +5319,7 @@
           <p:cNvPr id="5" name="">
             <a:extLst xmlns:a="http://schemas.openxmlformats.org/drawingml/2006/main">
               <a:ext uri="{FF2B5EF4-FFF2-40B4-BE49-F238E27FC236}">
-                <a16:creationId xmlns:a16="http://schemas.microsoft.com/office/drawing/2014/main" id="{9420BE06-00E2-40E6-806B-A20C8BF214D6}"/>
+                <a16:creationId xmlns:a16="http://schemas.microsoft.com/office/drawing/2014/main" id="{26090DF2-927A-49F6-937D-CFE14A29B53E}"/>
               </a:ext>
             </a:extLst>
           </p:cNvPr>
@@ -5391,7 +5391,7 @@
           <p:cNvPr id="6" name="">
             <a:extLst xmlns:a="http://schemas.openxmlformats.org/drawingml/2006/main">
               <a:ext uri="{FF2B5EF4-FFF2-40B4-BE49-F238E27FC236}">
-                <a16:creationId xmlns:a16="http://schemas.microsoft.com/office/drawing/2014/main" id="{78ED6A29-2FF0-432D-A10D-9DEA0B618836}"/>
+                <a16:creationId xmlns:a16="http://schemas.microsoft.com/office/drawing/2014/main" id="{9446A2DE-A3E9-4679-8B09-A098D690C306}"/>
               </a:ext>
             </a:extLst>
           </p:cNvPr>
@@ -5463,7 +5463,7 @@
           <p:cNvPr id="7" name="">
             <a:extLst xmlns:a="http://schemas.openxmlformats.org/drawingml/2006/main">
               <a:ext uri="{FF2B5EF4-FFF2-40B4-BE49-F238E27FC236}">
-                <a16:creationId xmlns:a16="http://schemas.microsoft.com/office/drawing/2014/main" id="{82E1BB47-20E9-4B26-8668-3A1167A689C7}"/>
+                <a16:creationId xmlns:a16="http://schemas.microsoft.com/office/drawing/2014/main" id="{9A0338E3-861B-4E92-915E-67038AC95C81}"/>
               </a:ext>
             </a:extLst>
           </p:cNvPr>
@@ -5535,7 +5535,7 @@
           <p:cNvPr id="8" name="">
             <a:extLst xmlns:a="http://schemas.openxmlformats.org/drawingml/2006/main">
               <a:ext uri="{FF2B5EF4-FFF2-40B4-BE49-F238E27FC236}">
-                <a16:creationId xmlns:a16="http://schemas.microsoft.com/office/drawing/2014/main" id="{0E16DF49-A3FB-4C87-B501-3A3264A27C7E}"/>
+                <a16:creationId xmlns:a16="http://schemas.microsoft.com/office/drawing/2014/main" id="{B50FBA1C-1115-4179-B488-8C183EA3E1B8}"/>
               </a:ext>
             </a:extLst>
           </p:cNvPr>
@@ -5605,7 +5605,7 @@
     </p:spTree>
     <p:extLst>
       <p:ext uri="{BB962C8B-B14F-4D97-AF65-F5344CB8AC3E}">
-        <p14:creationId xmlns:p14="http://schemas.microsoft.com/office/powerpoint/2010/main" val="465805258"/>
+        <p14:creationId xmlns:p14="http://schemas.microsoft.com/office/powerpoint/2010/main" val="1605089012"/>
       </p:ext>
     </p:extLst>
   </p:cSld>
@@ -5636,7 +5636,7 @@
           <p:cNvPr id="7" name="">
             <a:extLst xmlns:a="http://schemas.openxmlformats.org/drawingml/2006/main">
               <a:ext uri="{FF2B5EF4-FFF2-40B4-BE49-F238E27FC236}">
-                <a16:creationId xmlns:a16="http://schemas.microsoft.com/office/drawing/2014/main" id="{4D88F204-8723-436A-BF7F-03B1E7F10E19}"/>
+                <a16:creationId xmlns:a16="http://schemas.microsoft.com/office/drawing/2014/main" id="{E9DC3F84-F697-4313-8765-636546700FB6}"/>
               </a:ext>
             </a:extLst>
           </p:cNvPr>
@@ -5708,7 +5708,7 @@
           <p:cNvPr id="2" name="">
             <a:extLst xmlns:a="http://schemas.openxmlformats.org/drawingml/2006/main">
               <a:ext uri="{FF2B5EF4-FFF2-40B4-BE49-F238E27FC236}">
-                <a16:creationId xmlns:a16="http://schemas.microsoft.com/office/drawing/2014/main" id="{04A40F4B-5382-42BB-B555-FE28CD3429F7}"/>
+                <a16:creationId xmlns:a16="http://schemas.microsoft.com/office/drawing/2014/main" id="{FDBCF429-2388-4EE9-B423-90438E83B9AC}"/>
               </a:ext>
             </a:extLst>
           </p:cNvPr>
@@ -5780,7 +5780,7 @@
           <p:cNvPr id="3" name="Chart">
             <a:extLst xmlns:a="http://schemas.openxmlformats.org/drawingml/2006/main">
               <a:ext uri="{FF2B5EF4-FFF2-40B4-BE49-F238E27FC236}">
-                <a16:creationId xmlns:a16="http://schemas.microsoft.com/office/drawing/2014/main" id="{4819782F-2B50-43D3-80EB-D1D8C64785F6}"/>
+                <a16:creationId xmlns:a16="http://schemas.microsoft.com/office/drawing/2014/main" id="{7BDF7478-3460-444B-B6FD-7BB1FC5A4ED4}"/>
               </a:ext>
             </a:extLst>
           </p:cNvPr>
@@ -5793,7 +5793,7 @@
         </p:xfrm>
         <a:graphic xmlns:a="http://schemas.openxmlformats.org/drawingml/2006/main">
           <a:graphicData uri="http://schemas.openxmlformats.org/drawingml/2006/chart">
-            <c:chart xmlns:r="http://schemas.openxmlformats.org/officeDocument/2006/relationships" xmlns:c="http://schemas.openxmlformats.org/drawingml/2006/chart" r:id="R737f6c6caba24874"/>
+            <c:chart xmlns:r="http://schemas.openxmlformats.org/officeDocument/2006/relationships" xmlns:c="http://schemas.openxmlformats.org/drawingml/2006/chart" r:id="Rb22176a038284531"/>
           </a:graphicData>
         </a:graphic>
       </p:graphicFrame>
@@ -5802,7 +5802,7 @@
           <p:cNvPr id="4" name="">
             <a:extLst xmlns:a="http://schemas.openxmlformats.org/drawingml/2006/main">
               <a:ext uri="{FF2B5EF4-FFF2-40B4-BE49-F238E27FC236}">
-                <a16:creationId xmlns:a16="http://schemas.microsoft.com/office/drawing/2014/main" id="{63714EE2-9E5C-4D9B-A271-23F1B303A628}"/>
+                <a16:creationId xmlns:a16="http://schemas.microsoft.com/office/drawing/2014/main" id="{F20050D4-DD38-41C7-A50C-9D0346EAD894}"/>
               </a:ext>
             </a:extLst>
           </p:cNvPr>
@@ -5874,7 +5874,7 @@
           <p:cNvPr id="5" name="">
             <a:extLst xmlns:a="http://schemas.openxmlformats.org/drawingml/2006/main">
               <a:ext uri="{FF2B5EF4-FFF2-40B4-BE49-F238E27FC236}">
-                <a16:creationId xmlns:a16="http://schemas.microsoft.com/office/drawing/2014/main" id="{A4CFC832-D3F4-4D84-9B35-69442FCCD750}"/>
+                <a16:creationId xmlns:a16="http://schemas.microsoft.com/office/drawing/2014/main" id="{5AB39E84-7237-452B-8C2E-81CC9C0B6224}"/>
               </a:ext>
             </a:extLst>
           </p:cNvPr>
@@ -5946,7 +5946,7 @@
           <p:cNvPr id="6" name="">
             <a:extLst xmlns:a="http://schemas.openxmlformats.org/drawingml/2006/main">
               <a:ext uri="{FF2B5EF4-FFF2-40B4-BE49-F238E27FC236}">
-                <a16:creationId xmlns:a16="http://schemas.microsoft.com/office/drawing/2014/main" id="{AE1027ED-4A1E-4EE1-B372-BEAC93788B38}"/>
+                <a16:creationId xmlns:a16="http://schemas.microsoft.com/office/drawing/2014/main" id="{D411DE03-7FE3-4BE1-9E2A-812D399280FE}"/>
               </a:ext>
             </a:extLst>
           </p:cNvPr>
@@ -6008,7 +6008,7 @@
                 <a:ea typeface="Arial"/>
                 <a:cs typeface="Arial"/>
               </a:rPr>
-              <a:t>The bake preserves time codes 0, 5, 10 and 48 time codes per second. It provides no original-trajectory guarantee between those samples.</a:t>
+              <a:t>Position interpolation is shown here. HPR wrap, held samples, reference offsets and value clips pass separate controls.</a:t>
             </a:r>
           </a:p>
         </p:txBody>
@@ -6016,7 +6016,7 @@
     </p:spTree>
     <p:extLst>
       <p:ext uri="{BB962C8B-B14F-4D97-AF65-F5344CB8AC3E}">
-        <p14:creationId xmlns:p14="http://schemas.microsoft.com/office/powerpoint/2010/main" val="1580927308"/>
+        <p14:creationId xmlns:p14="http://schemas.microsoft.com/office/powerpoint/2010/main" val="1506157751"/>
       </p:ext>
     </p:extLst>
   </p:cSld>
@@ -6047,7 +6047,7 @@
           <p:cNvPr id="4" name="">
             <a:extLst xmlns:a="http://schemas.openxmlformats.org/drawingml/2006/main">
               <a:ext uri="{FF2B5EF4-FFF2-40B4-BE49-F238E27FC236}">
-                <a16:creationId xmlns:a16="http://schemas.microsoft.com/office/drawing/2014/main" id="{C166774B-7F2B-48AF-9D5B-65941AAE0262}"/>
+                <a16:creationId xmlns:a16="http://schemas.microsoft.com/office/drawing/2014/main" id="{63D0A52E-9748-4142-94C3-BC1C466AD00F}"/>
               </a:ext>
             </a:extLst>
           </p:cNvPr>
@@ -6119,7 +6119,7 @@
           <p:cNvPr id="2" name="">
             <a:extLst xmlns:a="http://schemas.openxmlformats.org/drawingml/2006/main">
               <a:ext uri="{FF2B5EF4-FFF2-40B4-BE49-F238E27FC236}">
-                <a16:creationId xmlns:a16="http://schemas.microsoft.com/office/drawing/2014/main" id="{F0A6E468-D0C7-41BD-B066-6163EA746BE4}"/>
+                <a16:creationId xmlns:a16="http://schemas.microsoft.com/office/drawing/2014/main" id="{3CAFAAC1-95BB-48CE-B432-2AB28342149B}"/>
               </a:ext>
             </a:extLst>
           </p:cNvPr>
@@ -6235,7 +6235,7 @@
                           <a:ea typeface="Arial"/>
                           <a:cs typeface="Arial"/>
                         </a:rPr>
-                        <a:t>Input-only meaning is supported. Stored quaternion versus one heading/pitch/roll tuple and its interpolation need review.</a:t>
+                        <a:t>Preferred HPR tuple in degrees, with explicit pose interpolation. Authored inputs only; adoption pending.</a:t>
                       </a:r>
                     </a:p>
                   </a:txBody>
@@ -6471,7 +6471,7 @@
           <p:cNvPr id="3" name="">
             <a:extLst xmlns:a="http://schemas.openxmlformats.org/drawingml/2006/main">
               <a:ext uri="{FF2B5EF4-FFF2-40B4-BE49-F238E27FC236}">
-                <a16:creationId xmlns:a16="http://schemas.microsoft.com/office/drawing/2014/main" id="{3318E34D-242F-4065-B85A-6DF13EC76921}"/>
+                <a16:creationId xmlns:a16="http://schemas.microsoft.com/office/drawing/2014/main" id="{CF8881D9-77F1-4779-BE18-CBA9DDF6CE2A}"/>
               </a:ext>
             </a:extLst>
           </p:cNvPr>
@@ -6533,7 +6533,7 @@
                 <a:ea typeface="Arial"/>
                 <a:cs typeface="Arial"/>
               </a:rPr>
-              <a:t>Review stored orientation and detailed conventions; keep the supported input-only meaning.</a:t>
+              <a:t>Prefer HPR for authoring; review the precise pose convention and interpolation before adoption.</a:t>
             </a:r>
           </a:p>
         </p:txBody>
@@ -6541,7 +6541,7 @@
     </p:spTree>
     <p:extLst>
       <p:ext uri="{BB962C8B-B14F-4D97-AF65-F5344CB8AC3E}">
-        <p14:creationId xmlns:p14="http://schemas.microsoft.com/office/powerpoint/2010/main" val="2059646077"/>
+        <p14:creationId xmlns:p14="http://schemas.microsoft.com/office/powerpoint/2010/main" val="971006590"/>
       </p:ext>
     </p:extLst>
   </p:cSld>
@@ -6572,7 +6572,7 @@
           <p:cNvPr id="4" name="">
             <a:extLst xmlns:a="http://schemas.openxmlformats.org/drawingml/2006/main">
               <a:ext uri="{FF2B5EF4-FFF2-40B4-BE49-F238E27FC236}">
-                <a16:creationId xmlns:a16="http://schemas.microsoft.com/office/drawing/2014/main" id="{93DD7A22-F0D1-4E8E-A06D-1313101D09B7}"/>
+                <a16:creationId xmlns:a16="http://schemas.microsoft.com/office/drawing/2014/main" id="{1081F1EC-CF05-4A1F-A315-F3D517BEBAF8}"/>
               </a:ext>
             </a:extLst>
           </p:cNvPr>
@@ -6644,7 +6644,7 @@
           <p:cNvPr id="2" name="">
             <a:extLst xmlns:a="http://schemas.openxmlformats.org/drawingml/2006/main">
               <a:ext uri="{FF2B5EF4-FFF2-40B4-BE49-F238E27FC236}">
-                <a16:creationId xmlns:a16="http://schemas.microsoft.com/office/drawing/2014/main" id="{E85426E1-D85F-409F-92C1-18F056F48C77}"/>
+                <a16:creationId xmlns:a16="http://schemas.microsoft.com/office/drawing/2014/main" id="{E14D3E32-C483-4EF4-99C4-1654F9811FDD}"/>
               </a:ext>
             </a:extLst>
           </p:cNvPr>
@@ -6996,7 +6996,7 @@
           <p:cNvPr id="3" name="">
             <a:extLst xmlns:a="http://schemas.openxmlformats.org/drawingml/2006/main">
               <a:ext uri="{FF2B5EF4-FFF2-40B4-BE49-F238E27FC236}">
-                <a16:creationId xmlns:a16="http://schemas.microsoft.com/office/drawing/2014/main" id="{1CB5E1FF-DAD5-413D-B09B-2CF3FE0ED234}"/>
+                <a16:creationId xmlns:a16="http://schemas.microsoft.com/office/drawing/2014/main" id="{85731CF5-1065-4B63-85E6-E56D918A90F0}"/>
               </a:ext>
             </a:extLst>
           </p:cNvPr>
@@ -7066,7 +7066,7 @@
     </p:spTree>
     <p:extLst>
       <p:ext uri="{BB962C8B-B14F-4D97-AF65-F5344CB8AC3E}">
-        <p14:creationId xmlns:p14="http://schemas.microsoft.com/office/powerpoint/2010/main" val="1354288103"/>
+        <p14:creationId xmlns:p14="http://schemas.microsoft.com/office/powerpoint/2010/main" val="937388719"/>
       </p:ext>
     </p:extLst>
   </p:cSld>
@@ -7097,7 +7097,7 @@
           <p:cNvPr id="4" name="">
             <a:extLst xmlns:a="http://schemas.openxmlformats.org/drawingml/2006/main">
               <a:ext uri="{FF2B5EF4-FFF2-40B4-BE49-F238E27FC236}">
-                <a16:creationId xmlns:a16="http://schemas.microsoft.com/office/drawing/2014/main" id="{0A8DA65A-F5AE-4A29-A568-644D37B5B6A5}"/>
+                <a16:creationId xmlns:a16="http://schemas.microsoft.com/office/drawing/2014/main" id="{8B16CE18-35BB-40C7-9804-7D3F93B6FE13}"/>
               </a:ext>
             </a:extLst>
           </p:cNvPr>
@@ -7169,7 +7169,7 @@
           <p:cNvPr id="2" name="">
             <a:extLst xmlns:a="http://schemas.openxmlformats.org/drawingml/2006/main">
               <a:ext uri="{FF2B5EF4-FFF2-40B4-BE49-F238E27FC236}">
-                <a16:creationId xmlns:a16="http://schemas.microsoft.com/office/drawing/2014/main" id="{880D8B17-AEEC-438A-88BC-789A1370D361}"/>
+                <a16:creationId xmlns:a16="http://schemas.microsoft.com/office/drawing/2014/main" id="{8EA7B8C0-D0F1-4FA4-8D51-79BC3584C8FA}"/>
               </a:ext>
             </a:extLst>
           </p:cNvPr>
@@ -7285,7 +7285,7 @@
                           <a:ea typeface="Arial"/>
                           <a:cs typeface="Arial"/>
                         </a:rPr>
-                        <a:t>213,231 coordinate results per reader. Maximum measured difference 3.39e-08 m. They share PROJ and native dataset decoding.</a:t>
+                        <a:t>213,243 coordinate results per reader. Maximum measured difference 3.39e-08 m. They share PROJ and native dataset decoding.</a:t>
                       </a:r>
                     </a:p>
                   </a:txBody>
@@ -7339,7 +7339,7 @@
                           <a:ea typeface="Arial"/>
                           <a:cs typeface="Arial"/>
                         </a:rPr>
-                        <a:t>Reuses Python placement. Recorded readback covers 177,864 geometry vertices and 36 edit, failure and recovery checks, across 35 jobs.</a:t>
+                        <a:t>Reuses Python placement. Recorded readback covers 177,872 geometry vertices and 48 edit, failure and recovery checks, across 39 jobs.</a:t>
                       </a:r>
                     </a:p>
                   </a:txBody>
@@ -7447,7 +7447,7 @@
                           <a:ea typeface="Arial"/>
                           <a:cs typeface="Arial"/>
                         </a:rPr>
-                        <a:t>70 regressions and 61 distinguishing controls passed. Fresh independent diagnostics verify six repairs and retain the unresolved normal case.</a:t>
+                        <a:t>88 regressions and 65 distinguishing controls passed. Fresh independent diagnostics verify six repairs and retain the unresolved normal case.</a:t>
                       </a:r>
                     </a:p>
                   </a:txBody>
@@ -7575,7 +7575,7 @@
           <p:cNvPr id="3" name="">
             <a:extLst xmlns:a="http://schemas.openxmlformats.org/drawingml/2006/main">
               <a:ext uri="{FF2B5EF4-FFF2-40B4-BE49-F238E27FC236}">
-                <a16:creationId xmlns:a16="http://schemas.microsoft.com/office/drawing/2014/main" id="{799C3C2D-0E32-433F-A1CD-8C840C554423}"/>
+                <a16:creationId xmlns:a16="http://schemas.microsoft.com/office/drawing/2014/main" id="{32428F0A-2AFF-4D95-8286-241719A8C6E2}"/>
               </a:ext>
             </a:extLst>
           </p:cNvPr>
@@ -7645,7 +7645,7 @@
     </p:spTree>
     <p:extLst>
       <p:ext uri="{BB962C8B-B14F-4D97-AF65-F5344CB8AC3E}">
-        <p14:creationId xmlns:p14="http://schemas.microsoft.com/office/powerpoint/2010/main" val="1941559474"/>
+        <p14:creationId xmlns:p14="http://schemas.microsoft.com/office/powerpoint/2010/main" val="627203414"/>
       </p:ext>
     </p:extLst>
   </p:cSld>
@@ -7676,7 +7676,7 @@
           <p:cNvPr id="5" name="">
             <a:extLst xmlns:a="http://schemas.openxmlformats.org/drawingml/2006/main">
               <a:ext uri="{FF2B5EF4-FFF2-40B4-BE49-F238E27FC236}">
-                <a16:creationId xmlns:a16="http://schemas.microsoft.com/office/drawing/2014/main" id="{16E05D2E-B59A-4A21-AE8D-177F977D3D34}"/>
+                <a16:creationId xmlns:a16="http://schemas.microsoft.com/office/drawing/2014/main" id="{C7098617-C0EA-4FB6-8F6F-3873D5B86966}"/>
               </a:ext>
             </a:extLst>
           </p:cNvPr>
@@ -7748,7 +7748,7 @@
           <p:cNvPr id="2" name="">
             <a:extLst xmlns:a="http://schemas.openxmlformats.org/drawingml/2006/main">
               <a:ext uri="{FF2B5EF4-FFF2-40B4-BE49-F238E27FC236}">
-                <a16:creationId xmlns:a16="http://schemas.microsoft.com/office/drawing/2014/main" id="{7A894154-04AC-445D-9F96-91709503C409}"/>
+                <a16:creationId xmlns:a16="http://schemas.microsoft.com/office/drawing/2014/main" id="{B84A849F-7C28-4737-95FD-577076B289C4}"/>
               </a:ext>
             </a:extLst>
           </p:cNvPr>
@@ -7820,7 +7820,7 @@
           <p:cNvPr id="3" name="">
             <a:extLst xmlns:a="http://schemas.openxmlformats.org/drawingml/2006/main">
               <a:ext uri="{FF2B5EF4-FFF2-40B4-BE49-F238E27FC236}">
-                <a16:creationId xmlns:a16="http://schemas.microsoft.com/office/drawing/2014/main" id="{6FB36966-D90A-45AC-81F1-BDA953897139}"/>
+                <a16:creationId xmlns:a16="http://schemas.microsoft.com/office/drawing/2014/main" id="{90A3FDB3-3255-47AB-BEB4-BF3566A666BC}"/>
               </a:ext>
             </a:extLst>
           </p:cNvPr>
@@ -8098,7 +8098,7 @@
                           <a:ea typeface="Arial"/>
                           <a:cs typeface="Arial"/>
                         </a:rPr>
-                        <a:t>crs:orientation says which way the model faces and tilts relative to local east, north and up at its origin.</a:t>
+                        <a:t>crs:orientation stores heading, pitch and roll in degrees: which way the model faces and tilts at its origin.</a:t>
                       </a:r>
                     </a:p>
                   </a:txBody>
@@ -8118,7 +8118,7 @@
           <p:cNvPr id="4" name="">
             <a:extLst xmlns:a="http://schemas.openxmlformats.org/drawingml/2006/main">
               <a:ext uri="{FF2B5EF4-FFF2-40B4-BE49-F238E27FC236}">
-                <a16:creationId xmlns:a16="http://schemas.microsoft.com/office/drawing/2014/main" id="{921F0828-9793-4813-A65B-ADFABF4CBDF3}"/>
+                <a16:creationId xmlns:a16="http://schemas.microsoft.com/office/drawing/2014/main" id="{361B0EE0-C136-4D11-92F0-60D522DD8D18}"/>
               </a:ext>
             </a:extLst>
           </p:cNvPr>
@@ -8188,7 +8188,7 @@
     </p:spTree>
     <p:extLst>
       <p:ext uri="{BB962C8B-B14F-4D97-AF65-F5344CB8AC3E}">
-        <p14:creationId xmlns:p14="http://schemas.microsoft.com/office/powerpoint/2010/main" val="1763462481"/>
+        <p14:creationId xmlns:p14="http://schemas.microsoft.com/office/powerpoint/2010/main" val="1330021116"/>
       </p:ext>
     </p:extLst>
   </p:cSld>
@@ -8219,7 +8219,7 @@
           <ns0:cNvPr id="9" name="">
             <ns1:extLst>
               <ns1:ext uri="{FF2B5EF4-FFF2-40B4-BE49-F238E27FC236}">
-                <ns2:creationId id="{3D86A9BA-8A12-415A-BFB4-AFE6D8B382F5}"/>
+                <ns2:creationId id="{217C1DC2-1262-45F7-B10E-80D08A51C672}"/>
               </ns1:ext>
             </ns1:extLst>
           </ns0:cNvPr>
@@ -8291,7 +8291,7 @@
           <ns0:cNvPr id="2" name="">
             <ns1:extLst>
               <ns1:ext uri="{FF2B5EF4-FFF2-40B4-BE49-F238E27FC236}">
-                <ns2:creationId id="{95DF31BE-574A-427B-899C-1A671E863588}"/>
+                <ns2:creationId id="{29DBD395-82D2-48AD-824B-80B8FFB6A1AE}"/>
               </ns1:ext>
             </ns1:extLst>
           </ns0:cNvPr>
@@ -8363,7 +8363,7 @@
           <ns0:cNvPr id="3" name="">
             <ns1:extLst>
               <ns1:ext uri="{FF2B5EF4-FFF2-40B4-BE49-F238E27FC236}">
-                <ns2:creationId id="{D1B9E510-DBB8-4A17-A926-CC2A7BC0E611}"/>
+                <ns2:creationId id="{C9D8D000-B5F5-44E8-B716-B52FCBFC2AC9}"/>
               </ns1:ext>
             </ns1:extLst>
           </ns0:cNvPr>
@@ -8373,7 +8373,7 @@
           <ns0:nvPr/>
         </ns0:nvPicPr>
         <ns0:blipFill>
-          <ns1:blip ns3:embed="Rb8d858c899bd4a9d"/>
+          <ns1:blip ns3:embed="R71129250e8424158"/>
           <ns1:srcRect l="0" t="8974" r="0" b="33333"/>
           <ns1:stretch/>
         </ns0:blipFill>
@@ -8392,7 +8392,7 @@
           <ns0:cNvPr id="4" name="">
             <ns1:extLst>
               <ns1:ext uri="{FF2B5EF4-FFF2-40B4-BE49-F238E27FC236}">
-                <ns2:creationId id="{AA1FB82F-B4E3-4407-BC1E-6CB4CAD6D4A2}"/>
+                <ns2:creationId id="{A55CB239-0A2C-4E6C-975A-5C19188D57CB}"/>
               </ns1:ext>
             </ns1:extLst>
           </ns0:cNvPr>
@@ -8464,7 +8464,7 @@
           <ns0:cNvPr id="5" name="">
             <ns1:extLst>
               <ns1:ext uri="{FF2B5EF4-FFF2-40B4-BE49-F238E27FC236}">
-                <ns2:creationId id="{AFBC5CDA-3B79-4986-B954-948331925C04}"/>
+                <ns2:creationId id="{23B6FB3F-DF7B-4DBB-A0E5-3571FB3E92B6}"/>
               </ns1:ext>
             </ns1:extLst>
           </ns0:cNvPr>
@@ -8536,7 +8536,7 @@
           <ns0:cNvPr id="6" name="">
             <ns1:extLst>
               <ns1:ext uri="{FF2B5EF4-FFF2-40B4-BE49-F238E27FC236}">
-                <ns2:creationId id="{5E7D78C6-AD82-4579-A2AB-45EC61855353}"/>
+                <ns2:creationId id="{D1A0BC71-445A-4555-A396-D373BB04092A}"/>
               </ns1:ext>
             </ns1:extLst>
           </ns0:cNvPr>
@@ -8608,7 +8608,7 @@
           <ns0:cNvPr id="7" name="">
             <ns1:extLst>
               <ns1:ext uri="{FF2B5EF4-FFF2-40B4-BE49-F238E27FC236}">
-                <ns2:creationId id="{F5C322F2-F9BD-4F8E-9897-CB49546197A9}"/>
+                <ns2:creationId id="{26052368-F006-4134-8169-9EFFF25D3E72}"/>
               </ns1:ext>
             </ns1:extLst>
           </ns0:cNvPr>
@@ -8680,7 +8680,7 @@
           <ns0:cNvPr id="8" name="">
             <ns1:extLst>
               <ns1:ext uri="{FF2B5EF4-FFF2-40B4-BE49-F238E27FC236}">
-                <ns2:creationId id="{7187F4B5-F0FB-492A-9A32-9AAD47943FD7}"/>
+                <ns2:creationId id="{82AD54BB-B271-4D89-B98D-BB74520FD1F3}"/>
               </ns1:ext>
             </ns1:extLst>
           </ns0:cNvPr>
@@ -8750,7 +8750,7 @@
     </ns0:spTree>
     <ns0:extLst>
       <ns0:ext uri="{BB962C8B-B14F-4D97-AF65-F5344CB8AC3E}">
-        <ns4:creationId val="773685833"/>
+        <ns4:creationId val="60000145"/>
       </ns0:ext>
     </ns0:extLst>
   </ns0:cSld>
@@ -8781,7 +8781,7 @@
           <ns0:cNvPr id="9" name="">
             <ns1:extLst>
               <ns1:ext uri="{FF2B5EF4-FFF2-40B4-BE49-F238E27FC236}">
-                <ns2:creationId id="{1C1CDA5B-1267-47BD-B596-97FA948C4411}"/>
+                <ns2:creationId id="{E8680611-9BB4-4924-A1B7-B995CEF6F19C}"/>
               </ns1:ext>
             </ns1:extLst>
           </ns0:cNvPr>
@@ -8853,7 +8853,7 @@
           <ns0:cNvPr id="2" name="">
             <ns1:extLst>
               <ns1:ext uri="{FF2B5EF4-FFF2-40B4-BE49-F238E27FC236}">
-                <ns2:creationId id="{0EE40F72-06B4-4962-822C-46F180EFB9A6}"/>
+                <ns2:creationId id="{B476CFD8-BEC2-4394-BFCD-D376627604E5}"/>
               </ns1:ext>
             </ns1:extLst>
           </ns0:cNvPr>
@@ -8925,7 +8925,7 @@
           <ns0:cNvPr id="3" name="">
             <ns1:extLst>
               <ns1:ext uri="{FF2B5EF4-FFF2-40B4-BE49-F238E27FC236}">
-                <ns2:creationId id="{5B2F041A-55EA-4CF6-B4CB-DDC39D22D3DD}"/>
+                <ns2:creationId id="{C12E792C-1AC3-48B6-95D8-1654FF86FEAE}"/>
               </ns1:ext>
             </ns1:extLst>
           </ns0:cNvPr>
@@ -8935,7 +8935,7 @@
           <ns0:nvPr/>
         </ns0:nvPicPr>
         <ns0:blipFill>
-          <ns1:blip ns3:embed="Rd07a50b13ce94e34"/>
+          <ns1:blip ns3:embed="R7b9eee2dbe034fa3"/>
           <ns1:srcRect l="0" t="8974" r="0" b="33333"/>
           <ns1:stretch/>
         </ns0:blipFill>
@@ -8954,7 +8954,7 @@
           <ns0:cNvPr id="4" name="">
             <ns1:extLst>
               <ns1:ext uri="{FF2B5EF4-FFF2-40B4-BE49-F238E27FC236}">
-                <ns2:creationId id="{2AFA0065-3D73-4AB4-93BA-76B91A21689E}"/>
+                <ns2:creationId id="{F290FA25-A9D6-459E-B11C-039820519AD2}"/>
               </ns1:ext>
             </ns1:extLst>
           </ns0:cNvPr>
@@ -9026,7 +9026,7 @@
           <ns0:cNvPr id="5" name="">
             <ns1:extLst>
               <ns1:ext uri="{FF2B5EF4-FFF2-40B4-BE49-F238E27FC236}">
-                <ns2:creationId id="{60A36E72-4900-410B-B28D-FD54E2625377}"/>
+                <ns2:creationId id="{7E4878C4-8F12-4FC3-83D6-F6CC299D78BB}"/>
               </ns1:ext>
             </ns1:extLst>
           </ns0:cNvPr>
@@ -9098,7 +9098,7 @@
           <ns0:cNvPr id="6" name="">
             <ns1:extLst>
               <ns1:ext uri="{FF2B5EF4-FFF2-40B4-BE49-F238E27FC236}">
-                <ns2:creationId id="{E7275140-8A84-4DC4-B145-B6805AB43F50}"/>
+                <ns2:creationId id="{AA82C676-B1B9-4202-889E-46530D0B008C}"/>
               </ns1:ext>
             </ns1:extLst>
           </ns0:cNvPr>
@@ -9170,7 +9170,7 @@
           <ns0:cNvPr id="7" name="">
             <ns1:extLst>
               <ns1:ext uri="{FF2B5EF4-FFF2-40B4-BE49-F238E27FC236}">
-                <ns2:creationId id="{58C9DD7D-66BF-432A-9FC4-B91012BC2DA9}"/>
+                <ns2:creationId id="{4A61FED5-E9BB-4741-B87B-6162964EA437}"/>
               </ns1:ext>
             </ns1:extLst>
           </ns0:cNvPr>
@@ -9242,7 +9242,7 @@
           <ns0:cNvPr id="8" name="">
             <ns1:extLst>
               <ns1:ext uri="{FF2B5EF4-FFF2-40B4-BE49-F238E27FC236}">
-                <ns2:creationId id="{640CC6FE-9A8D-4087-B2FE-61F6458301F3}"/>
+                <ns2:creationId id="{5D039E69-0194-49C2-BB8A-35FC5A0E7F36}"/>
               </ns1:ext>
             </ns1:extLst>
           </ns0:cNvPr>
@@ -9312,7 +9312,7 @@
     </ns0:spTree>
     <ns0:extLst>
       <ns0:ext uri="{BB962C8B-B14F-4D97-AF65-F5344CB8AC3E}">
-        <ns4:creationId val="1795429975"/>
+        <ns4:creationId val="1982735989"/>
       </ns0:ext>
     </ns0:extLst>
   </ns0:cSld>
@@ -9343,7 +9343,7 @@
           <p:cNvPr id="8" name="">
             <a:extLst xmlns:a="http://schemas.openxmlformats.org/drawingml/2006/main">
               <a:ext uri="{FF2B5EF4-FFF2-40B4-BE49-F238E27FC236}">
-                <a16:creationId xmlns:a16="http://schemas.microsoft.com/office/drawing/2014/main" id="{4D88F6AE-F813-4737-BF5A-96A71640419A}"/>
+                <a16:creationId xmlns:a16="http://schemas.microsoft.com/office/drawing/2014/main" id="{21C678C0-7BE9-46A4-9CB2-D2B701244AF5}"/>
               </a:ext>
             </a:extLst>
           </p:cNvPr>
@@ -9415,7 +9415,7 @@
           <p:cNvPr id="2" name="">
             <a:extLst xmlns:a="http://schemas.openxmlformats.org/drawingml/2006/main">
               <a:ext uri="{FF2B5EF4-FFF2-40B4-BE49-F238E27FC236}">
-                <a16:creationId xmlns:a16="http://schemas.microsoft.com/office/drawing/2014/main" id="{B5EA8A7B-7FD6-4053-AA70-4E6294F30597}"/>
+                <a16:creationId xmlns:a16="http://schemas.microsoft.com/office/drawing/2014/main" id="{2BD3C420-61B5-4F2C-BB0E-61879D4CE061}"/>
               </a:ext>
             </a:extLst>
           </p:cNvPr>
@@ -9487,7 +9487,7 @@
           <p:cNvPr id="3" name="">
             <a:extLst xmlns:a="http://schemas.openxmlformats.org/drawingml/2006/main">
               <a:ext uri="{FF2B5EF4-FFF2-40B4-BE49-F238E27FC236}">
-                <a16:creationId xmlns:a16="http://schemas.microsoft.com/office/drawing/2014/main" id="{6A96EAB3-9548-4F44-9D49-1DA69B1EB6D6}"/>
+                <a16:creationId xmlns:a16="http://schemas.microsoft.com/office/drawing/2014/main" id="{CC0892FB-1929-4A97-89C6-6764EECA39B1}"/>
               </a:ext>
             </a:extLst>
           </p:cNvPr>
@@ -9559,7 +9559,7 @@
           <p:cNvPr id="4" name="">
             <a:extLst xmlns:a="http://schemas.openxmlformats.org/drawingml/2006/main">
               <a:ext uri="{FF2B5EF4-FFF2-40B4-BE49-F238E27FC236}">
-                <a16:creationId xmlns:a16="http://schemas.microsoft.com/office/drawing/2014/main" id="{D4AA487A-6D8C-4CA0-8A55-38B25EA0726C}"/>
+                <a16:creationId xmlns:a16="http://schemas.microsoft.com/office/drawing/2014/main" id="{CBB10B86-B2E0-413B-8F07-08071F4AB493}"/>
               </a:ext>
             </a:extLst>
           </p:cNvPr>
@@ -9908,7 +9908,7 @@
           <p:cNvPr id="5" name="">
             <a:extLst xmlns:a="http://schemas.openxmlformats.org/drawingml/2006/main">
               <a:ext uri="{FF2B5EF4-FFF2-40B4-BE49-F238E27FC236}">
-                <a16:creationId xmlns:a16="http://schemas.microsoft.com/office/drawing/2014/main" id="{9E09BC29-F537-4556-88DC-D3E9A3FB86EA}"/>
+                <a16:creationId xmlns:a16="http://schemas.microsoft.com/office/drawing/2014/main" id="{D4B2AC0D-0783-45B8-B801-44BD22541FAB}"/>
               </a:ext>
             </a:extLst>
           </p:cNvPr>
@@ -9980,7 +9980,7 @@
           <p:cNvPr id="6" name="">
             <a:extLst xmlns:a="http://schemas.openxmlformats.org/drawingml/2006/main">
               <a:ext uri="{FF2B5EF4-FFF2-40B4-BE49-F238E27FC236}">
-                <a16:creationId xmlns:a16="http://schemas.microsoft.com/office/drawing/2014/main" id="{22300BC3-E6C5-42C0-A782-43161CFFA228}"/>
+                <a16:creationId xmlns:a16="http://schemas.microsoft.com/office/drawing/2014/main" id="{E7775E7F-FC2E-42D6-8658-05236DFDA6D6}"/>
               </a:ext>
             </a:extLst>
           </p:cNvPr>
@@ -10329,7 +10329,7 @@
           <p:cNvPr id="7" name="">
             <a:extLst xmlns:a="http://schemas.openxmlformats.org/drawingml/2006/main">
               <a:ext uri="{FF2B5EF4-FFF2-40B4-BE49-F238E27FC236}">
-                <a16:creationId xmlns:a16="http://schemas.microsoft.com/office/drawing/2014/main" id="{AB736EB1-4787-4B8D-8DE7-72346DD23DB1}"/>
+                <a16:creationId xmlns:a16="http://schemas.microsoft.com/office/drawing/2014/main" id="{9050F218-F0FD-47EA-93C2-8FC8F6DEC108}"/>
               </a:ext>
             </a:extLst>
           </p:cNvPr>
@@ -10399,7 +10399,7 @@
     </p:spTree>
     <p:extLst>
       <p:ext uri="{BB962C8B-B14F-4D97-AF65-F5344CB8AC3E}">
-        <p14:creationId xmlns:p14="http://schemas.microsoft.com/office/powerpoint/2010/main" val="1433457696"/>
+        <p14:creationId xmlns:p14="http://schemas.microsoft.com/office/powerpoint/2010/main" val="213783025"/>
       </p:ext>
     </p:extLst>
   </p:cSld>
@@ -10430,7 +10430,7 @@
           <p:cNvPr id="9" name="">
             <a:extLst xmlns:a="http://schemas.openxmlformats.org/drawingml/2006/main">
               <a:ext uri="{FF2B5EF4-FFF2-40B4-BE49-F238E27FC236}">
-                <a16:creationId xmlns:a16="http://schemas.microsoft.com/office/drawing/2014/main" id="{3CC839B3-EF91-499F-B0CF-FC7A652E98A4}"/>
+                <a16:creationId xmlns:a16="http://schemas.microsoft.com/office/drawing/2014/main" id="{BE9B0715-1A07-4725-8D81-5B8CB3E12959}"/>
               </a:ext>
             </a:extLst>
           </p:cNvPr>
@@ -10502,7 +10502,7 @@
           <p:cNvPr id="2" name="">
             <a:extLst xmlns:a="http://schemas.openxmlformats.org/drawingml/2006/main">
               <a:ext uri="{FF2B5EF4-FFF2-40B4-BE49-F238E27FC236}">
-                <a16:creationId xmlns:a16="http://schemas.microsoft.com/office/drawing/2014/main" id="{E8EB1B87-B39E-4EDA-A365-0F8D1CF10E12}"/>
+                <a16:creationId xmlns:a16="http://schemas.microsoft.com/office/drawing/2014/main" id="{7E7563BE-9A0B-4155-A6E8-5D3E96B00228}"/>
               </a:ext>
             </a:extLst>
           </p:cNvPr>
@@ -10574,7 +10574,7 @@
           <p:cNvPr id="3" name="">
             <a:extLst xmlns:a="http://schemas.openxmlformats.org/drawingml/2006/main">
               <a:ext uri="{FF2B5EF4-FFF2-40B4-BE49-F238E27FC236}">
-                <a16:creationId xmlns:a16="http://schemas.microsoft.com/office/drawing/2014/main" id="{CD20ACF7-D592-43B7-AB26-2A9305C3A05B}"/>
+                <a16:creationId xmlns:a16="http://schemas.microsoft.com/office/drawing/2014/main" id="{65187886-06E1-4BA8-BB5F-784F1E186C19}"/>
               </a:ext>
             </a:extLst>
           </p:cNvPr>
@@ -10584,7 +10584,7 @@
           <p:nvPr/>
         </p:nvPicPr>
         <p:blipFill>
-          <a:blip xmlns:r="http://schemas.openxmlformats.org/officeDocument/2006/relationships" xmlns:a="http://schemas.openxmlformats.org/drawingml/2006/main" r:embed="R69731ffa422042f8"/>
+          <a:blip xmlns:r="http://schemas.openxmlformats.org/officeDocument/2006/relationships" xmlns:a="http://schemas.openxmlformats.org/drawingml/2006/main" r:embed="R383a418c57274d36"/>
           <a:stretch xmlns:a="http://schemas.openxmlformats.org/drawingml/2006/main"/>
         </p:blipFill>
         <p:spPr>
@@ -10602,7 +10602,7 @@
           <p:cNvPr id="4" name="">
             <a:extLst xmlns:a="http://schemas.openxmlformats.org/drawingml/2006/main">
               <a:ext uri="{FF2B5EF4-FFF2-40B4-BE49-F238E27FC236}">
-                <a16:creationId xmlns:a16="http://schemas.microsoft.com/office/drawing/2014/main" id="{EF80E8D1-1151-4D88-AC43-511AC9C69B6C}"/>
+                <a16:creationId xmlns:a16="http://schemas.microsoft.com/office/drawing/2014/main" id="{8F7A33E4-DF51-4438-9204-9EE1500D3A7B}"/>
               </a:ext>
             </a:extLst>
           </p:cNvPr>
@@ -10674,7 +10674,7 @@
           <p:cNvPr id="5" name="">
             <a:extLst xmlns:a="http://schemas.openxmlformats.org/drawingml/2006/main">
               <a:ext uri="{FF2B5EF4-FFF2-40B4-BE49-F238E27FC236}">
-                <a16:creationId xmlns:a16="http://schemas.microsoft.com/office/drawing/2014/main" id="{C8E54E40-F8C1-4638-A7A0-CEF1138A6FF7}"/>
+                <a16:creationId xmlns:a16="http://schemas.microsoft.com/office/drawing/2014/main" id="{A23B0A65-661C-4F2F-99FF-4E7B23993F29}"/>
               </a:ext>
             </a:extLst>
           </p:cNvPr>
@@ -10746,7 +10746,7 @@
           <p:cNvPr id="6" name="">
             <a:extLst xmlns:a="http://schemas.openxmlformats.org/drawingml/2006/main">
               <a:ext uri="{FF2B5EF4-FFF2-40B4-BE49-F238E27FC236}">
-                <a16:creationId xmlns:a16="http://schemas.microsoft.com/office/drawing/2014/main" id="{E566D8F5-262D-4793-AADD-D8550E010C33}"/>
+                <a16:creationId xmlns:a16="http://schemas.microsoft.com/office/drawing/2014/main" id="{668FCFF9-464F-4234-9454-D344F77A8DC4}"/>
               </a:ext>
             </a:extLst>
           </p:cNvPr>
@@ -10818,7 +10818,7 @@
           <p:cNvPr id="7" name="">
             <a:extLst xmlns:a="http://schemas.openxmlformats.org/drawingml/2006/main">
               <a:ext uri="{FF2B5EF4-FFF2-40B4-BE49-F238E27FC236}">
-                <a16:creationId xmlns:a16="http://schemas.microsoft.com/office/drawing/2014/main" id="{C2A21F56-1397-45AB-80BE-51BE6A1CF5ED}"/>
+                <a16:creationId xmlns:a16="http://schemas.microsoft.com/office/drawing/2014/main" id="{0F812867-10F2-45ED-A4AD-924E3C56E7B5}"/>
               </a:ext>
             </a:extLst>
           </p:cNvPr>
@@ -10890,7 +10890,7 @@
           <p:cNvPr id="8" name="">
             <a:extLst xmlns:a="http://schemas.openxmlformats.org/drawingml/2006/main">
               <a:ext uri="{FF2B5EF4-FFF2-40B4-BE49-F238E27FC236}">
-                <a16:creationId xmlns:a16="http://schemas.microsoft.com/office/drawing/2014/main" id="{236DBB13-2B5B-48D3-B2AC-E7AA50E5A065}"/>
+                <a16:creationId xmlns:a16="http://schemas.microsoft.com/office/drawing/2014/main" id="{7F67E0CC-ABD7-4A62-9473-9616E5BD1552}"/>
               </a:ext>
             </a:extLst>
           </p:cNvPr>
@@ -10960,7 +10960,7 @@
     </p:spTree>
     <p:extLst>
       <p:ext uri="{BB962C8B-B14F-4D97-AF65-F5344CB8AC3E}">
-        <p14:creationId xmlns:p14="http://schemas.microsoft.com/office/powerpoint/2010/main" val="493390405"/>
+        <p14:creationId xmlns:p14="http://schemas.microsoft.com/office/powerpoint/2010/main" val="1267397729"/>
       </p:ext>
     </p:extLst>
   </p:cSld>
@@ -10991,7 +10991,7 @@
           <p:cNvPr id="6" name="">
             <a:extLst xmlns:a="http://schemas.openxmlformats.org/drawingml/2006/main">
               <a:ext uri="{FF2B5EF4-FFF2-40B4-BE49-F238E27FC236}">
-                <a16:creationId xmlns:a16="http://schemas.microsoft.com/office/drawing/2014/main" id="{0ADEBFD0-223D-499A-9C9D-EEB69517B6A7}"/>
+                <a16:creationId xmlns:a16="http://schemas.microsoft.com/office/drawing/2014/main" id="{59B635C4-9525-4C1A-9F7A-CA1BC97F5EB8}"/>
               </a:ext>
             </a:extLst>
           </p:cNvPr>
@@ -11063,7 +11063,7 @@
           <p:cNvPr id="2" name="">
             <a:extLst xmlns:a="http://schemas.openxmlformats.org/drawingml/2006/main">
               <a:ext uri="{FF2B5EF4-FFF2-40B4-BE49-F238E27FC236}">
-                <a16:creationId xmlns:a16="http://schemas.microsoft.com/office/drawing/2014/main" id="{E00042F4-5461-4D9F-98F0-01A2508B728A}"/>
+                <a16:creationId xmlns:a16="http://schemas.microsoft.com/office/drawing/2014/main" id="{9BA54FBC-1368-4841-A940-80A707CF5991}"/>
               </a:ext>
             </a:extLst>
           </p:cNvPr>
@@ -11135,7 +11135,7 @@
           <p:cNvPr id="3" name="">
             <a:extLst xmlns:a="http://schemas.openxmlformats.org/drawingml/2006/main">
               <a:ext uri="{FF2B5EF4-FFF2-40B4-BE49-F238E27FC236}">
-                <a16:creationId xmlns:a16="http://schemas.microsoft.com/office/drawing/2014/main" id="{53983AA4-94B5-4A56-A2B2-5D0DD0781D4A}"/>
+                <a16:creationId xmlns:a16="http://schemas.microsoft.com/office/drawing/2014/main" id="{768AB706-4762-4848-AAA5-5E1C04A86EC8}"/>
               </a:ext>
             </a:extLst>
           </p:cNvPr>
@@ -11145,7 +11145,7 @@
           <p:nvPr/>
         </p:nvPicPr>
         <p:blipFill>
-          <a:blip xmlns:r="http://schemas.openxmlformats.org/officeDocument/2006/relationships" xmlns:a="http://schemas.openxmlformats.org/drawingml/2006/main" r:embed="R55dd3fba41f648b8"/>
+          <a:blip xmlns:r="http://schemas.openxmlformats.org/officeDocument/2006/relationships" xmlns:a="http://schemas.openxmlformats.org/drawingml/2006/main" r:embed="R0d4923b9de324e9c"/>
           <a:stretch xmlns:a="http://schemas.openxmlformats.org/drawingml/2006/main"/>
         </p:blipFill>
         <p:spPr>
@@ -11163,7 +11163,7 @@
           <p:cNvPr id="4" name="">
             <a:extLst xmlns:a="http://schemas.openxmlformats.org/drawingml/2006/main">
               <a:ext uri="{FF2B5EF4-FFF2-40B4-BE49-F238E27FC236}">
-                <a16:creationId xmlns:a16="http://schemas.microsoft.com/office/drawing/2014/main" id="{44CFC8D4-1215-43D9-AAA3-65B7EF566683}"/>
+                <a16:creationId xmlns:a16="http://schemas.microsoft.com/office/drawing/2014/main" id="{08D72438-EBAE-4271-8227-E20F8E23A110}"/>
               </a:ext>
             </a:extLst>
           </p:cNvPr>
@@ -11235,7 +11235,7 @@
           <p:cNvPr id="5" name="">
             <a:extLst xmlns:a="http://schemas.openxmlformats.org/drawingml/2006/main">
               <a:ext uri="{FF2B5EF4-FFF2-40B4-BE49-F238E27FC236}">
-                <a16:creationId xmlns:a16="http://schemas.microsoft.com/office/drawing/2014/main" id="{7EA5298A-05D9-4689-AA04-1F8065D63788}"/>
+                <a16:creationId xmlns:a16="http://schemas.microsoft.com/office/drawing/2014/main" id="{69825CCF-B4AE-40C2-8F33-38D172E4C43F}"/>
               </a:ext>
             </a:extLst>
           </p:cNvPr>
@@ -11297,7 +11297,7 @@
                 <a:ea typeface="Arial"/>
                 <a:cs typeface="Arial"/>
               </a:rPr>
-              <a:t>Synthetic values. Dimension-name tests check associations independently of the shared decoder.</a:t>
+              <a:t>The values are synthetic. Named-dimension associations are independently tested; agreeing readers alone cannot verify shared decoding.</a:t>
             </a:r>
           </a:p>
         </p:txBody>
@@ -11305,7 +11305,7 @@
     </p:spTree>
     <p:extLst>
       <p:ext uri="{BB962C8B-B14F-4D97-AF65-F5344CB8AC3E}">
-        <p14:creationId xmlns:p14="http://schemas.microsoft.com/office/powerpoint/2010/main" val="810960368"/>
+        <p14:creationId xmlns:p14="http://schemas.microsoft.com/office/powerpoint/2010/main" val="652356291"/>
       </p:ext>
     </p:extLst>
   </p:cSld>
@@ -11336,7 +11336,7 @@
           <p:cNvPr id="5" name="">
             <a:extLst xmlns:a="http://schemas.openxmlformats.org/drawingml/2006/main">
               <a:ext uri="{FF2B5EF4-FFF2-40B4-BE49-F238E27FC236}">
-                <a16:creationId xmlns:a16="http://schemas.microsoft.com/office/drawing/2014/main" id="{C50E0C46-94AA-4C57-880E-62554390CEF9}"/>
+                <a16:creationId xmlns:a16="http://schemas.microsoft.com/office/drawing/2014/main" id="{D3A34B28-8D9B-4062-A16E-F9DA22238A9A}"/>
               </a:ext>
             </a:extLst>
           </p:cNvPr>
@@ -11408,7 +11408,7 @@
           <p:cNvPr id="2" name="">
             <a:extLst xmlns:a="http://schemas.openxmlformats.org/drawingml/2006/main">
               <a:ext uri="{FF2B5EF4-FFF2-40B4-BE49-F238E27FC236}">
-                <a16:creationId xmlns:a16="http://schemas.microsoft.com/office/drawing/2014/main" id="{50294DF4-E680-4715-BEC3-984176784B67}"/>
+                <a16:creationId xmlns:a16="http://schemas.microsoft.com/office/drawing/2014/main" id="{0F73BD4F-8853-400F-8584-87238B5AA0DA}"/>
               </a:ext>
             </a:extLst>
           </p:cNvPr>
@@ -11480,7 +11480,7 @@
           <p:cNvPr id="3" name="">
             <a:extLst xmlns:a="http://schemas.openxmlformats.org/drawingml/2006/main">
               <a:ext uri="{FF2B5EF4-FFF2-40B4-BE49-F238E27FC236}">
-                <a16:creationId xmlns:a16="http://schemas.microsoft.com/office/drawing/2014/main" id="{F6E60BC6-AB7D-4F3E-B36E-02C8654A53A3}"/>
+                <a16:creationId xmlns:a16="http://schemas.microsoft.com/office/drawing/2014/main" id="{055B5895-0B96-4E30-83CC-DBE639B1AEF3}"/>
               </a:ext>
             </a:extLst>
           </p:cNvPr>
@@ -11940,7 +11940,7 @@
           <p:cNvPr id="4" name="">
             <a:extLst xmlns:a="http://schemas.openxmlformats.org/drawingml/2006/main">
               <a:ext uri="{FF2B5EF4-FFF2-40B4-BE49-F238E27FC236}">
-                <a16:creationId xmlns:a16="http://schemas.microsoft.com/office/drawing/2014/main" id="{E364DE42-4A0A-4FA5-BC89-B680E3E16AB6}"/>
+                <a16:creationId xmlns:a16="http://schemas.microsoft.com/office/drawing/2014/main" id="{0893E84F-C37C-434E-9707-B68FCB9AE912}"/>
               </a:ext>
             </a:extLst>
           </p:cNvPr>
@@ -12010,7 +12010,7 @@
     </p:spTree>
     <p:extLst>
       <p:ext uri="{BB962C8B-B14F-4D97-AF65-F5344CB8AC3E}">
-        <p14:creationId xmlns:p14="http://schemas.microsoft.com/office/powerpoint/2010/main" val="486715488"/>
+        <p14:creationId xmlns:p14="http://schemas.microsoft.com/office/powerpoint/2010/main" val="2132031523"/>
       </p:ext>
     </p:extLst>
   </p:cSld>
@@ -12041,7 +12041,7 @@
           <p:cNvPr id="9" name="">
             <a:extLst xmlns:a="http://schemas.openxmlformats.org/drawingml/2006/main">
               <a:ext uri="{FF2B5EF4-FFF2-40B4-BE49-F238E27FC236}">
-                <a16:creationId xmlns:a16="http://schemas.microsoft.com/office/drawing/2014/main" id="{6967941E-35C9-495E-9987-7FFB410DBAC7}"/>
+                <a16:creationId xmlns:a16="http://schemas.microsoft.com/office/drawing/2014/main" id="{DD6BF383-B061-4A35-ADC4-3150757226AA}"/>
               </a:ext>
             </a:extLst>
           </p:cNvPr>
@@ -12113,7 +12113,7 @@
           <p:cNvPr id="2" name="">
             <a:extLst xmlns:a="http://schemas.openxmlformats.org/drawingml/2006/main">
               <a:ext uri="{FF2B5EF4-FFF2-40B4-BE49-F238E27FC236}">
-                <a16:creationId xmlns:a16="http://schemas.microsoft.com/office/drawing/2014/main" id="{2049EF4F-DFF8-4405-A447-DCA3DDDD3AB9}"/>
+                <a16:creationId xmlns:a16="http://schemas.microsoft.com/office/drawing/2014/main" id="{AB34A648-595B-44F2-9C57-B0DBA56E59A8}"/>
               </a:ext>
             </a:extLst>
           </p:cNvPr>
@@ -12185,7 +12185,7 @@
           <p:cNvPr id="3" name="">
             <a:extLst xmlns:a="http://schemas.openxmlformats.org/drawingml/2006/main">
               <a:ext uri="{FF2B5EF4-FFF2-40B4-BE49-F238E27FC236}">
-                <a16:creationId xmlns:a16="http://schemas.microsoft.com/office/drawing/2014/main" id="{AF554BFF-712E-4472-9CC2-0CC9FD258AF5}"/>
+                <a16:creationId xmlns:a16="http://schemas.microsoft.com/office/drawing/2014/main" id="{6DAE4C99-07FE-42F6-8500-0C1354DAF36E}"/>
               </a:ext>
             </a:extLst>
           </p:cNvPr>
@@ -12195,7 +12195,7 @@
           <p:nvPr/>
         </p:nvPicPr>
         <p:blipFill>
-          <a:blip xmlns:r="http://schemas.openxmlformats.org/officeDocument/2006/relationships" xmlns:a="http://schemas.openxmlformats.org/drawingml/2006/main" r:embed="R2efcedba11f14ad1"/>
+          <a:blip xmlns:r="http://schemas.openxmlformats.org/officeDocument/2006/relationships" xmlns:a="http://schemas.openxmlformats.org/drawingml/2006/main" r:embed="R6037c39680914654"/>
           <a:stretch xmlns:a="http://schemas.openxmlformats.org/drawingml/2006/main"/>
         </p:blipFill>
         <p:spPr>
@@ -12213,7 +12213,7 @@
           <p:cNvPr id="4" name="">
             <a:extLst xmlns:a="http://schemas.openxmlformats.org/drawingml/2006/main">
               <a:ext uri="{FF2B5EF4-FFF2-40B4-BE49-F238E27FC236}">
-                <a16:creationId xmlns:a16="http://schemas.microsoft.com/office/drawing/2014/main" id="{9CBAB235-C44A-41F7-8D58-09ECBD197082}"/>
+                <a16:creationId xmlns:a16="http://schemas.microsoft.com/office/drawing/2014/main" id="{370C51C0-2BF0-477B-8D83-2566BD67DBF0}"/>
               </a:ext>
             </a:extLst>
           </p:cNvPr>
@@ -12285,7 +12285,7 @@
           <p:cNvPr id="5" name="">
             <a:extLst xmlns:a="http://schemas.openxmlformats.org/drawingml/2006/main">
               <a:ext uri="{FF2B5EF4-FFF2-40B4-BE49-F238E27FC236}">
-                <a16:creationId xmlns:a16="http://schemas.microsoft.com/office/drawing/2014/main" id="{08ED7D4D-5973-4C4F-BB21-16ABBEF14400}"/>
+                <a16:creationId xmlns:a16="http://schemas.microsoft.com/office/drawing/2014/main" id="{3F423587-9148-4C29-B4AC-7126AF427156}"/>
               </a:ext>
             </a:extLst>
           </p:cNvPr>
@@ -12357,7 +12357,7 @@
           <p:cNvPr id="6" name="">
             <a:extLst xmlns:a="http://schemas.openxmlformats.org/drawingml/2006/main">
               <a:ext uri="{FF2B5EF4-FFF2-40B4-BE49-F238E27FC236}">
-                <a16:creationId xmlns:a16="http://schemas.microsoft.com/office/drawing/2014/main" id="{04BA30B3-C2CE-44E6-B33F-CAD0CC72BBEB}"/>
+                <a16:creationId xmlns:a16="http://schemas.microsoft.com/office/drawing/2014/main" id="{CDFA1876-3D6A-4F51-89A6-25345B33756D}"/>
               </a:ext>
             </a:extLst>
           </p:cNvPr>
@@ -12429,7 +12429,7 @@
           <p:cNvPr id="7" name="">
             <a:extLst xmlns:a="http://schemas.openxmlformats.org/drawingml/2006/main">
               <a:ext uri="{FF2B5EF4-FFF2-40B4-BE49-F238E27FC236}">
-                <a16:creationId xmlns:a16="http://schemas.microsoft.com/office/drawing/2014/main" id="{D81F189A-E063-4C8A-9FC0-CCFCFA632491}"/>
+                <a16:creationId xmlns:a16="http://schemas.microsoft.com/office/drawing/2014/main" id="{4BB93905-3BBA-4E91-AC80-073CD641968F}"/>
               </a:ext>
             </a:extLst>
           </p:cNvPr>
@@ -12501,7 +12501,7 @@
           <p:cNvPr id="8" name="">
             <a:extLst xmlns:a="http://schemas.openxmlformats.org/drawingml/2006/main">
               <a:ext uri="{FF2B5EF4-FFF2-40B4-BE49-F238E27FC236}">
-                <a16:creationId xmlns:a16="http://schemas.microsoft.com/office/drawing/2014/main" id="{0C071068-74FC-4568-A57A-66802C5B33F9}"/>
+                <a16:creationId xmlns:a16="http://schemas.microsoft.com/office/drawing/2014/main" id="{6AC47F9D-C2C6-4FBF-BBF5-B6F49C54648A}"/>
               </a:ext>
             </a:extLst>
           </p:cNvPr>
@@ -12571,7 +12571,7 @@
     </p:spTree>
     <p:extLst>
       <p:ext uri="{BB962C8B-B14F-4D97-AF65-F5344CB8AC3E}">
-        <p14:creationId xmlns:p14="http://schemas.microsoft.com/office/powerpoint/2010/main" val="1666206875"/>
+        <p14:creationId xmlns:p14="http://schemas.microsoft.com/office/powerpoint/2010/main" val="1516864774"/>
       </p:ext>
     </p:extLst>
   </p:cSld>

</xml_diff>

<commit_message>
Deliver standalone assessment of October 12 geospatial feedback build
</commit_message>
<xml_diff>
--- a/extras/usd/examples/usdGeospatialBuild/delivery/geospatial-build.pptx
+++ b/extras/usd/examples/usdGeospatialBuild/delivery/geospatial-build.pptx
@@ -2,26 +2,26 @@
 <file path=ppt/presentation.xml><?xml version="1.0" encoding="utf-8"?>
 <p:presentation xmlns:p="http://schemas.openxmlformats.org/presentationml/2006/main">
   <p:sldMasterIdLst>
-    <p:sldMasterId xmlns:r="http://schemas.openxmlformats.org/officeDocument/2006/relationships" id="2147483648" r:id="Rdfba1843544343d3"/>
+    <p:sldMasterId xmlns:r="http://schemas.openxmlformats.org/officeDocument/2006/relationships" id="2147483648" r:id="R9f305b25e35240ce"/>
   </p:sldMasterIdLst>
   <p:notesMasterIdLst>
-    <p:notesMasterId xmlns:r="http://schemas.openxmlformats.org/officeDocument/2006/relationships" r:id="R78bb458733b44785"/>
+    <p:notesMasterId xmlns:r="http://schemas.openxmlformats.org/officeDocument/2006/relationships" r:id="R655df4b8610a47a3"/>
   </p:notesMasterIdLst>
   <p:sldIdLst>
-    <p:sldId xmlns:r="http://schemas.openxmlformats.org/officeDocument/2006/relationships" id="256" r:id="R0561bb57196a4964"/>
-    <p:sldId xmlns:r="http://schemas.openxmlformats.org/officeDocument/2006/relationships" id="257" r:id="Rec53372af7cb4d6d"/>
-    <p:sldId xmlns:r="http://schemas.openxmlformats.org/officeDocument/2006/relationships" id="258" r:id="R002ac477fa8d48c7"/>
-    <p:sldId xmlns:r="http://schemas.openxmlformats.org/officeDocument/2006/relationships" id="259" r:id="Rd0eccbc8ba064ccf"/>
-    <p:sldId xmlns:r="http://schemas.openxmlformats.org/officeDocument/2006/relationships" id="260" r:id="R29e24ee684a34d62"/>
-    <p:sldId xmlns:r="http://schemas.openxmlformats.org/officeDocument/2006/relationships" id="261" r:id="R7f417be9ef844295"/>
-    <p:sldId xmlns:r="http://schemas.openxmlformats.org/officeDocument/2006/relationships" id="262" r:id="Rcbe224f013e648f9"/>
-    <p:sldId xmlns:r="http://schemas.openxmlformats.org/officeDocument/2006/relationships" id="263" r:id="R08cdce61928447c9"/>
-    <p:sldId xmlns:r="http://schemas.openxmlformats.org/officeDocument/2006/relationships" id="264" r:id="Rc964f8576b854e50"/>
-    <p:sldId xmlns:r="http://schemas.openxmlformats.org/officeDocument/2006/relationships" id="265" r:id="R5c5b123e1bd74d0c"/>
-    <p:sldId xmlns:r="http://schemas.openxmlformats.org/officeDocument/2006/relationships" id="266" r:id="R6bb35783a8d143c1"/>
-    <p:sldId xmlns:r="http://schemas.openxmlformats.org/officeDocument/2006/relationships" id="267" r:id="R6039c4fd694f425a"/>
-    <p:sldId xmlns:r="http://schemas.openxmlformats.org/officeDocument/2006/relationships" id="268" r:id="R468a85123d794f08"/>
-    <p:sldId xmlns:r="http://schemas.openxmlformats.org/officeDocument/2006/relationships" id="269" r:id="R750acfe1cb914bc4"/>
+    <p:sldId xmlns:r="http://schemas.openxmlformats.org/officeDocument/2006/relationships" id="256" r:id="R2065c74de6154965"/>
+    <p:sldId xmlns:r="http://schemas.openxmlformats.org/officeDocument/2006/relationships" id="257" r:id="Rb8a20d546e9f4ff1"/>
+    <p:sldId xmlns:r="http://schemas.openxmlformats.org/officeDocument/2006/relationships" id="258" r:id="Rc01c7185d6fc46fd"/>
+    <p:sldId xmlns:r="http://schemas.openxmlformats.org/officeDocument/2006/relationships" id="259" r:id="Rf73741f5fb854842"/>
+    <p:sldId xmlns:r="http://schemas.openxmlformats.org/officeDocument/2006/relationships" id="260" r:id="R17153d3d980c4654"/>
+    <p:sldId xmlns:r="http://schemas.openxmlformats.org/officeDocument/2006/relationships" id="261" r:id="R83ad27dfcc4f4265"/>
+    <p:sldId xmlns:r="http://schemas.openxmlformats.org/officeDocument/2006/relationships" id="262" r:id="R1cc4c2f476724789"/>
+    <p:sldId xmlns:r="http://schemas.openxmlformats.org/officeDocument/2006/relationships" id="263" r:id="R7f6fa74f647f4bba"/>
+    <p:sldId xmlns:r="http://schemas.openxmlformats.org/officeDocument/2006/relationships" id="264" r:id="R2ba5cc79b46c42f2"/>
+    <p:sldId xmlns:r="http://schemas.openxmlformats.org/officeDocument/2006/relationships" id="265" r:id="R3d32a039ea014606"/>
+    <p:sldId xmlns:r="http://schemas.openxmlformats.org/officeDocument/2006/relationships" id="266" r:id="Reae08caa4bf34d12"/>
+    <p:sldId xmlns:r="http://schemas.openxmlformats.org/officeDocument/2006/relationships" id="267" r:id="R675f1e175b044cfa"/>
+    <p:sldId xmlns:r="http://schemas.openxmlformats.org/officeDocument/2006/relationships" id="268" r:id="Rbf004268b6cf4be7"/>
+    <p:sldId xmlns:r="http://schemas.openxmlformats.org/officeDocument/2006/relationships" id="269" r:id="R715d1b89862f4f98"/>
   </p:sldIdLst>
   <p:sldSz cx="12192000" cy="6858000"/>
   <p:notesSz cx="6858000" cy="9144000"/>
@@ -455,7 +455,7 @@
           <a:lstStyle xmlns:a="http://schemas.openxmlformats.org/drawingml/2006/main"/>
           <a:p xmlns:a="http://schemas.openxmlformats.org/drawingml/2006/main">
             <a:r>
-              <a:t>{"assessment":[["Data model and runtime rules","The draft separates authored inputs from computed results and defines placement, adjustment, query and bake behavior."],["Group alignment","The detailed orientation, frame, WKT string normalization and publication conventions remain proposed."],["Prototype limitations","Lighting directions lack an error bound. Rotation uncertainty is unquantified. A quoted CRS name causes false rejection."],["Verification coverage","Selected workflows and distinguishing controls support the rules. Broader composition and continuous space/time coverage remain unverified."]],"placement":[["Physical orientation","One heading/pitch/roll tuple describes physical attitude against local east, north and up. Projection effects stay computed."],["Project adjustments","The directly bound model's own xformOps adjust its placed result in a fixed project chart, including ordinary pivots."],["Child objects","Child transforms define model-local geometry. Their offsets follow model axes and the geospatial attitude."],["Repeated models","Each instance offset retains its instancer-local meaning. Independent prototype placement participates once. A required unavailable inverse fails."],["Geographic scene results","Geographic queries retain longitude/latitude/height. Cartesian geometry and bounds use the datum's Earth-centred frame."]],"data":[["Native data associations","Declare the asset, field and coordinate domain. Preserve named dimensions and observation times."],["WKT string normalization","Normalize lexical spelling without losing represented information. Equal tokens establish serialized identity."],["Semantic CRS comparison","Different normalized texts can represent equivalent CRSs. Comparison names its criteria and domain."],["Dependency declaration","Existing Profiles metadata carries a proposed complete publication summary, including unloaded and retained variant content."],["Baked coordinate context","Retain a Cartesian CRS and double-precision origin without an active source placement binding. Ordinary USD controls subsequent transforms."]]}</a:t>
+              <a:t>{"assessment":[["Data model and runtime rules","The draft separates authored inputs from computed results and defines placement, adjustment, query and bake behavior."],["Group alignment","Input and declaration rules have agreement. Detailed conventions and identities await review."],["Prototype limitations","Lighting directions lack an error bound. Rotation uncertainty is unquantified. A quoted CRS name causes false rejection."],["Verification coverage","Selected workflows and distinguishing controls support the rules. Broader composition and continuous space/time coverage remain unverified."]],"placement":[["Physical orientation","One heading/pitch/roll tuple describes physical attitude against local east, north and up. Projection effects stay computed."],["Project adjustments","The directly bound model's own xformOps adjust its placed result in a fixed project chart, including ordinary pivots."],["Child objects","Child transforms define model-local geometry. Their offsets follow model axes and the geospatial attitude."],["Repeated models","Each instance offset retains its instancer-local meaning. Independent prototype placement participates once. A required unavailable inverse fails."],["Geographic scene results","Geographic queries retain longitude/latitude/height. Cartesian geometry and bounds use the datum's Earth-centred frame."]],"data":[["Native data associations","Declare the asset, field and coordinate domain. Preserve named dimensions and observation times."],["WKT string normalization","Normalize lexical spelling without losing represented information. Equal tokens establish serialized identity."],["Semantic CRS comparison","Different normalized texts can represent equivalent CRSs. Comparison names its criteria and domain."],["Dependency declaration","Profiles records complete publication coverage, including unloaded and retained variant content. Fixed v1 identities remain proposed."],["Baked coordinate context","Retain a Cartesian CRS and double-precision origin without an active source placement binding. Ordinary USD controls subsequent transforms."]]}</a:t>
             </a:r>
           </a:p>
           <a:p xmlns:a="http://schemas.openxmlformats.org/drawingml/2006/main">
@@ -465,17 +465,17 @@
           </a:p>
           <a:p xmlns:a="http://schemas.openxmlformats.org/drawingml/2006/main">
             <a:r>
-              <a:t>Proposal 7b5b34b7282305135f672663a3cffb0f94342ecc SHA-256 010d4c0243e7e6985284cccadb00fb7c6f7b0c5c50f22d81bb31ada960548d75</a:t>
-            </a:r>
-          </a:p>
-          <a:p xmlns:a="http://schemas.openxmlformats.org/drawingml/2006/main">
-            <a:r>
-              <a:t>README SHA-256 32731631975544a0d484f84f76524fd94c3aac82ac3347a37b6990cbe7907035</a:t>
-            </a:r>
-          </a:p>
-          <a:p xmlns:a="http://schemas.openxmlformats.org/drawingml/2006/main">
-            <a:r>
-              <a:t>Immutable receipt SHA-256 db39bc27bc04bf7f70bfaf2e5048b085798e3ef8b72e58fa54a367a51b7b6d91</a:t>
+              <a:t>Proposal da2f49aad42811fc5d660c7bcf9ff190599f2d74 SHA-256 2613649fd06516d77339d73b56432e84613dd1925e739761efea738f41b4f0a4</a:t>
+            </a:r>
+          </a:p>
+          <a:p xmlns:a="http://schemas.openxmlformats.org/drawingml/2006/main">
+            <a:r>
+              <a:t>README SHA-256 f97eb66b4642d85817c1bface96cc358cea536a8a8104a439f22a2715af103d5</a:t>
+            </a:r>
+          </a:p>
+          <a:p xmlns:a="http://schemas.openxmlformats.org/drawingml/2006/main">
+            <a:r>
+              <a:t>Immutable receipt SHA-256 ad59ead3c86c780b6d79a243a23032e492c14809f0c01f575397ae221939068f</a:t>
             </a:r>
           </a:p>
           <a:p xmlns:a="http://schemas.openxmlformats.org/drawingml/2006/main">
@@ -485,7 +485,7 @@
           </a:p>
           <a:p xmlns:a="http://schemas.openxmlformats.org/drawingml/2006/main">
             <a:r>
-              <a:t>Full detailed model remains proposed. Python and C++ share PROJ and decoding. Omniverse reuses Python. Hydra consumes a resolved ordinary USD bake.</a:t>
+              <a:t>Accepted source and declaration rules are distinguished from detailed conventions and identities awaiting review. Python and C++ share PROJ and decoding. Omniverse reuses Python. Hydra consumes a resolved ordinary USD bake.</a:t>
             </a:r>
           </a:p>
         </p:txBody>
@@ -585,7 +585,7 @@
           </a:p>
           <a:p xmlns:a="http://schemas.openxmlformats.org/drawingml/2006/main">
             <a:r>
-              <a:t>Proposal clause: ### External measurement association at proposal/proposal-source.txt:1641</a:t>
+              <a:t>Proposal clause: ### External measurement association at proposal/proposal-source.txt:1689</a:t>
             </a:r>
           </a:p>
           <a:p xmlns:a="http://schemas.openxmlformats.org/drawingml/2006/main">
@@ -600,17 +600,17 @@
           </a:p>
           <a:p xmlns:a="http://schemas.openxmlformats.org/drawingml/2006/main">
             <a:r>
-              <a:t>Proposal 7b5b34b7282305135f672663a3cffb0f94342ecc SHA-256 010d4c0243e7e6985284cccadb00fb7c6f7b0c5c50f22d81bb31ada960548d75</a:t>
-            </a:r>
-          </a:p>
-          <a:p xmlns:a="http://schemas.openxmlformats.org/drawingml/2006/main">
-            <a:r>
-              <a:t>README SHA-256 32731631975544a0d484f84f76524fd94c3aac82ac3347a37b6990cbe7907035</a:t>
-            </a:r>
-          </a:p>
-          <a:p xmlns:a="http://schemas.openxmlformats.org/drawingml/2006/main">
-            <a:r>
-              <a:t>Immutable receipt SHA-256 db39bc27bc04bf7f70bfaf2e5048b085798e3ef8b72e58fa54a367a51b7b6d91</a:t>
+              <a:t>Proposal da2f49aad42811fc5d660c7bcf9ff190599f2d74 SHA-256 2613649fd06516d77339d73b56432e84613dd1925e739761efea738f41b4f0a4</a:t>
+            </a:r>
+          </a:p>
+          <a:p xmlns:a="http://schemas.openxmlformats.org/drawingml/2006/main">
+            <a:r>
+              <a:t>README SHA-256 f97eb66b4642d85817c1bface96cc358cea536a8a8104a439f22a2715af103d5</a:t>
+            </a:r>
+          </a:p>
+          <a:p xmlns:a="http://schemas.openxmlformats.org/drawingml/2006/main">
+            <a:r>
+              <a:t>Immutable receipt SHA-256 ad59ead3c86c780b6d79a243a23032e492c14809f0c01f575397ae221939068f</a:t>
             </a:r>
           </a:p>
           <a:p xmlns:a="http://schemas.openxmlformats.org/drawingml/2006/main">
@@ -620,7 +620,7 @@
           </a:p>
           <a:p xmlns:a="http://schemas.openxmlformats.org/drawingml/2006/main">
             <a:r>
-              <a:t>Full detailed model remains proposed. Python and C++ share PROJ and decoding. Omniverse reuses Python. Hydra consumes a resolved ordinary USD bake.</a:t>
+              <a:t>Accepted source and declaration rules are distinguished from detailed conventions and identities awaiting review. Python and C++ share PROJ and decoding. Omniverse reuses Python. Hydra consumes a resolved ordinary USD bake.</a:t>
             </a:r>
           </a:p>
         </p:txBody>
@@ -720,7 +720,7 @@
           </a:p>
           <a:p xmlns:a="http://schemas.openxmlformats.org/drawingml/2006/main">
             <a:r>
-              <a:t>Proposal clause: #### Evaluation at proposal/proposal-source.txt:1957</a:t>
+              <a:t>Proposal clause: #### Evaluation at proposal/proposal-source.txt:2016</a:t>
             </a:r>
           </a:p>
           <a:p xmlns:a="http://schemas.openxmlformats.org/drawingml/2006/main">
@@ -735,17 +735,17 @@
           </a:p>
           <a:p xmlns:a="http://schemas.openxmlformats.org/drawingml/2006/main">
             <a:r>
-              <a:t>Proposal 7b5b34b7282305135f672663a3cffb0f94342ecc SHA-256 010d4c0243e7e6985284cccadb00fb7c6f7b0c5c50f22d81bb31ada960548d75</a:t>
-            </a:r>
-          </a:p>
-          <a:p xmlns:a="http://schemas.openxmlformats.org/drawingml/2006/main">
-            <a:r>
-              <a:t>README SHA-256 32731631975544a0d484f84f76524fd94c3aac82ac3347a37b6990cbe7907035</a:t>
-            </a:r>
-          </a:p>
-          <a:p xmlns:a="http://schemas.openxmlformats.org/drawingml/2006/main">
-            <a:r>
-              <a:t>Immutable receipt SHA-256 db39bc27bc04bf7f70bfaf2e5048b085798e3ef8b72e58fa54a367a51b7b6d91</a:t>
+              <a:t>Proposal da2f49aad42811fc5d660c7bcf9ff190599f2d74 SHA-256 2613649fd06516d77339d73b56432e84613dd1925e739761efea738f41b4f0a4</a:t>
+            </a:r>
+          </a:p>
+          <a:p xmlns:a="http://schemas.openxmlformats.org/drawingml/2006/main">
+            <a:r>
+              <a:t>README SHA-256 f97eb66b4642d85817c1bface96cc358cea536a8a8104a439f22a2715af103d5</a:t>
+            </a:r>
+          </a:p>
+          <a:p xmlns:a="http://schemas.openxmlformats.org/drawingml/2006/main">
+            <a:r>
+              <a:t>Immutable receipt SHA-256 ad59ead3c86c780b6d79a243a23032e492c14809f0c01f575397ae221939068f</a:t>
             </a:r>
           </a:p>
           <a:p xmlns:a="http://schemas.openxmlformats.org/drawingml/2006/main">
@@ -755,7 +755,7 @@
           </a:p>
           <a:p xmlns:a="http://schemas.openxmlformats.org/drawingml/2006/main">
             <a:r>
-              <a:t>Full detailed model remains proposed. Python and C++ share PROJ and decoding. Omniverse reuses Python. Hydra consumes a resolved ordinary USD bake.</a:t>
+              <a:t>Accepted source and declaration rules are distinguished from detailed conventions and identities awaiting review. Python and C++ share PROJ and decoding. Omniverse reuses Python. Hydra consumes a resolved ordinary USD bake.</a:t>
             </a:r>
           </a:p>
         </p:txBody>
@@ -825,7 +825,7 @@
           <a:lstStyle xmlns:a="http://schemas.openxmlformats.org/drawingml/2006/main"/>
           <a:p xmlns:a="http://schemas.openxmlformats.org/drawingml/2006/main">
             <a:r>
-              <a:t>{"assessment":[["Data model and runtime rules","The draft separates authored inputs from computed results and defines placement, adjustment, query and bake behavior."],["Group alignment","The detailed orientation, frame, WKT string normalization and publication conventions remain proposed."],["Prototype limitations","Lighting directions lack an error bound. Rotation uncertainty is unquantified. A quoted CRS name causes false rejection."],["Verification coverage","Selected workflows and distinguishing controls support the rules. Broader composition and continuous space/time coverage remain unverified."]],"placement":[["Physical orientation","One heading/pitch/roll tuple describes physical attitude against local east, north and up. Projection effects stay computed."],["Project adjustments","The directly bound model's own xformOps adjust its placed result in a fixed project chart, including ordinary pivots."],["Child objects","Child transforms define model-local geometry. Their offsets follow model axes and the geospatial attitude."],["Repeated models","Each instance offset retains its instancer-local meaning. Independent prototype placement participates once. A required unavailable inverse fails."],["Geographic scene results","Geographic queries retain longitude/latitude/height. Cartesian geometry and bounds use the datum's Earth-centred frame."]],"data":[["Native data associations","Declare the asset, field and coordinate domain. Preserve named dimensions and observation times."],["WKT string normalization","Normalize lexical spelling without losing represented information. Equal tokens establish serialized identity."],["Semantic CRS comparison","Different normalized texts can represent equivalent CRSs. Comparison names its criteria and domain."],["Dependency declaration","Existing Profiles metadata carries a proposed complete publication summary, including unloaded and retained variant content."],["Baked coordinate context","Retain a Cartesian CRS and double-precision origin without an active source placement binding. Ordinary USD controls subsequent transforms."]]}</a:t>
+              <a:t>{"assessment":[["Data model and runtime rules","The draft separates authored inputs from computed results and defines placement, adjustment, query and bake behavior."],["Group alignment","Input and declaration rules have agreement. Detailed conventions and identities await review."],["Prototype limitations","Lighting directions lack an error bound. Rotation uncertainty is unquantified. A quoted CRS name causes false rejection."],["Verification coverage","Selected workflows and distinguishing controls support the rules. Broader composition and continuous space/time coverage remain unverified."]],"placement":[["Physical orientation","One heading/pitch/roll tuple describes physical attitude against local east, north and up. Projection effects stay computed."],["Project adjustments","The directly bound model's own xformOps adjust its placed result in a fixed project chart, including ordinary pivots."],["Child objects","Child transforms define model-local geometry. Their offsets follow model axes and the geospatial attitude."],["Repeated models","Each instance offset retains its instancer-local meaning. Independent prototype placement participates once. A required unavailable inverse fails."],["Geographic scene results","Geographic queries retain longitude/latitude/height. Cartesian geometry and bounds use the datum's Earth-centred frame."]],"data":[["Native data associations","Declare the asset, field and coordinate domain. Preserve named dimensions and observation times."],["WKT string normalization","Normalize lexical spelling without losing represented information. Equal tokens establish serialized identity."],["Semantic CRS comparison","Different normalized texts can represent equivalent CRSs. Comparison names its criteria and domain."],["Dependency declaration","Profiles records complete publication coverage, including unloaded and retained variant content. Fixed v1 identities remain proposed."],["Baked coordinate context","Retain a Cartesian CRS and double-precision origin without an active source placement binding. Ordinary USD controls subsequent transforms."]]}</a:t>
             </a:r>
           </a:p>
           <a:p xmlns:a="http://schemas.openxmlformats.org/drawingml/2006/main">
@@ -835,17 +835,17 @@
           </a:p>
           <a:p xmlns:a="http://schemas.openxmlformats.org/drawingml/2006/main">
             <a:r>
-              <a:t>Proposal 7b5b34b7282305135f672663a3cffb0f94342ecc SHA-256 010d4c0243e7e6985284cccadb00fb7c6f7b0c5c50f22d81bb31ada960548d75</a:t>
-            </a:r>
-          </a:p>
-          <a:p xmlns:a="http://schemas.openxmlformats.org/drawingml/2006/main">
-            <a:r>
-              <a:t>README SHA-256 32731631975544a0d484f84f76524fd94c3aac82ac3347a37b6990cbe7907035</a:t>
-            </a:r>
-          </a:p>
-          <a:p xmlns:a="http://schemas.openxmlformats.org/drawingml/2006/main">
-            <a:r>
-              <a:t>Immutable receipt SHA-256 db39bc27bc04bf7f70bfaf2e5048b085798e3ef8b72e58fa54a367a51b7b6d91</a:t>
+              <a:t>Proposal da2f49aad42811fc5d660c7bcf9ff190599f2d74 SHA-256 2613649fd06516d77339d73b56432e84613dd1925e739761efea738f41b4f0a4</a:t>
+            </a:r>
+          </a:p>
+          <a:p xmlns:a="http://schemas.openxmlformats.org/drawingml/2006/main">
+            <a:r>
+              <a:t>README SHA-256 f97eb66b4642d85817c1bface96cc358cea536a8a8104a439f22a2715af103d5</a:t>
+            </a:r>
+          </a:p>
+          <a:p xmlns:a="http://schemas.openxmlformats.org/drawingml/2006/main">
+            <a:r>
+              <a:t>Immutable receipt SHA-256 ad59ead3c86c780b6d79a243a23032e492c14809f0c01f575397ae221939068f</a:t>
             </a:r>
           </a:p>
           <a:p xmlns:a="http://schemas.openxmlformats.org/drawingml/2006/main">
@@ -855,7 +855,7 @@
           </a:p>
           <a:p xmlns:a="http://schemas.openxmlformats.org/drawingml/2006/main">
             <a:r>
-              <a:t>Full detailed model remains proposed. Python and C++ share PROJ and decoding. Omniverse reuses Python. Hydra consumes a resolved ordinary USD bake.</a:t>
+              <a:t>Accepted source and declaration rules are distinguished from detailed conventions and identities awaiting review. Python and C++ share PROJ and decoding. Omniverse reuses Python. Hydra consumes a resolved ordinary USD bake.</a:t>
             </a:r>
           </a:p>
         </p:txBody>
@@ -925,27 +925,27 @@
           <a:lstStyle xmlns:a="http://schemas.openxmlformats.org/drawingml/2006/main"/>
           <a:p xmlns:a="http://schemas.openxmlformats.org/drawingml/2006/main">
             <a:r>
-              <a:t>{"assessment":[["Data model and runtime rules","The draft separates authored inputs from computed results and defines placement, adjustment, query and bake behavior."],["Group alignment","The detailed orientation, frame, WKT string normalization and publication conventions remain proposed."],["Prototype limitations","Lighting directions lack an error bound. Rotation uncertainty is unquantified. A quoted CRS name causes false rejection."],["Verification coverage","Selected workflows and distinguishing controls support the rules. Broader composition and continuous space/time coverage remain unverified."]],"placement":[["Physical orientation","One heading/pitch/roll tuple describes physical attitude against local east, north and up. Projection effects stay computed."],["Project adjustments","The directly bound model's own xformOps adjust its placed result in a fixed project chart, including ordinary pivots."],["Child objects","Child transforms define model-local geometry. Their offsets follow model axes and the geospatial attitude."],["Repeated models","Each instance offset retains its instancer-local meaning. Independent prototype placement participates once. A required unavailable inverse fails."],["Geographic scene results","Geographic queries retain longitude/latitude/height. Cartesian geometry and bounds use the datum's Earth-centred frame."]],"data":[["Native data associations","Declare the asset, field and coordinate domain. Preserve named dimensions and observation times."],["WKT string normalization","Normalize lexical spelling without losing represented information. Equal tokens establish serialized identity."],["Semantic CRS comparison","Different normalized texts can represent equivalent CRSs. Comparison names its criteria and domain."],["Dependency declaration","Existing Profiles metadata carries a proposed complete publication summary, including unloaded and retained variant content."],["Baked coordinate context","Retain a Cartesian CRS and double-precision origin without an active source placement binding. Ordinary USD controls subsequent transforms."]]}</a:t>
-            </a:r>
-          </a:p>
-          <a:p xmlns:a="http://schemas.openxmlformats.org/drawingml/2006/main">
-            <a:r>
-              <a:t>[["Native data associations","Declare the asset, field and coordinate domain. Preserve named dimensions and observation times."],["WKT string normalization","Normalize lexical spelling without losing represented information. Equal tokens establish serialized identity."],["Semantic CRS comparison","Different normalized texts can represent equivalent CRSs. Comparison names its criteria and domain."],["Dependency declaration","Existing Profiles metadata carries a proposed complete publication summary, including unloaded and retained variant content."],["Baked coordinate context","Retain a Cartesian CRS and double-precision origin without an active source placement binding. Ordinary USD controls subsequent transforms."]]</a:t>
-            </a:r>
-          </a:p>
-          <a:p xmlns:a="http://schemas.openxmlformats.org/drawingml/2006/main">
-            <a:r>
-              <a:t>Proposal 7b5b34b7282305135f672663a3cffb0f94342ecc SHA-256 010d4c0243e7e6985284cccadb00fb7c6f7b0c5c50f22d81bb31ada960548d75</a:t>
-            </a:r>
-          </a:p>
-          <a:p xmlns:a="http://schemas.openxmlformats.org/drawingml/2006/main">
-            <a:r>
-              <a:t>README SHA-256 32731631975544a0d484f84f76524fd94c3aac82ac3347a37b6990cbe7907035</a:t>
-            </a:r>
-          </a:p>
-          <a:p xmlns:a="http://schemas.openxmlformats.org/drawingml/2006/main">
-            <a:r>
-              <a:t>Immutable receipt SHA-256 db39bc27bc04bf7f70bfaf2e5048b085798e3ef8b72e58fa54a367a51b7b6d91</a:t>
+              <a:t>{"assessment":[["Data model and runtime rules","The draft separates authored inputs from computed results and defines placement, adjustment, query and bake behavior."],["Group alignment","Input and declaration rules have agreement. Detailed conventions and identities await review."],["Prototype limitations","Lighting directions lack an error bound. Rotation uncertainty is unquantified. A quoted CRS name causes false rejection."],["Verification coverage","Selected workflows and distinguishing controls support the rules. Broader composition and continuous space/time coverage remain unverified."]],"placement":[["Physical orientation","One heading/pitch/roll tuple describes physical attitude against local east, north and up. Projection effects stay computed."],["Project adjustments","The directly bound model's own xformOps adjust its placed result in a fixed project chart, including ordinary pivots."],["Child objects","Child transforms define model-local geometry. Their offsets follow model axes and the geospatial attitude."],["Repeated models","Each instance offset retains its instancer-local meaning. Independent prototype placement participates once. A required unavailable inverse fails."],["Geographic scene results","Geographic queries retain longitude/latitude/height. Cartesian geometry and bounds use the datum's Earth-centred frame."]],"data":[["Native data associations","Declare the asset, field and coordinate domain. Preserve named dimensions and observation times."],["WKT string normalization","Normalize lexical spelling without losing represented information. Equal tokens establish serialized identity."],["Semantic CRS comparison","Different normalized texts can represent equivalent CRSs. Comparison names its criteria and domain."],["Dependency declaration","Profiles records complete publication coverage, including unloaded and retained variant content. Fixed v1 identities remain proposed."],["Baked coordinate context","Retain a Cartesian CRS and double-precision origin without an active source placement binding. Ordinary USD controls subsequent transforms."]]}</a:t>
+            </a:r>
+          </a:p>
+          <a:p xmlns:a="http://schemas.openxmlformats.org/drawingml/2006/main">
+            <a:r>
+              <a:t>[["Native data associations","Declare the asset, field and coordinate domain. Preserve named dimensions and observation times."],["WKT string normalization","Normalize lexical spelling without losing represented information. Equal tokens establish serialized identity."],["Semantic CRS comparison","Different normalized texts can represent equivalent CRSs. Comparison names its criteria and domain."],["Dependency declaration","Profiles records complete publication coverage, including unloaded and retained variant content. Fixed v1 identities remain proposed."],["Baked coordinate context","Retain a Cartesian CRS and double-precision origin without an active source placement binding. Ordinary USD controls subsequent transforms."]]</a:t>
+            </a:r>
+          </a:p>
+          <a:p xmlns:a="http://schemas.openxmlformats.org/drawingml/2006/main">
+            <a:r>
+              <a:t>Proposal da2f49aad42811fc5d660c7bcf9ff190599f2d74 SHA-256 2613649fd06516d77339d73b56432e84613dd1925e739761efea738f41b4f0a4</a:t>
+            </a:r>
+          </a:p>
+          <a:p xmlns:a="http://schemas.openxmlformats.org/drawingml/2006/main">
+            <a:r>
+              <a:t>README SHA-256 f97eb66b4642d85817c1bface96cc358cea536a8a8104a439f22a2715af103d5</a:t>
+            </a:r>
+          </a:p>
+          <a:p xmlns:a="http://schemas.openxmlformats.org/drawingml/2006/main">
+            <a:r>
+              <a:t>Immutable receipt SHA-256 ad59ead3c86c780b6d79a243a23032e492c14809f0c01f575397ae221939068f</a:t>
             </a:r>
           </a:p>
           <a:p xmlns:a="http://schemas.openxmlformats.org/drawingml/2006/main">
@@ -955,7 +955,7 @@
           </a:p>
           <a:p xmlns:a="http://schemas.openxmlformats.org/drawingml/2006/main">
             <a:r>
-              <a:t>Full detailed model remains proposed. Python and C++ share PROJ and decoding. Omniverse reuses Python. Hydra consumes a resolved ordinary USD bake.</a:t>
+              <a:t>Accepted source and declaration rules are distinguished from detailed conventions and identities awaiting review. Python and C++ share PROJ and decoding. Omniverse reuses Python. Hydra consumes a resolved ordinary USD bake.</a:t>
             </a:r>
           </a:p>
         </p:txBody>
@@ -1025,27 +1025,27 @@
           <a:lstStyle xmlns:a="http://schemas.openxmlformats.org/drawingml/2006/main"/>
           <a:p xmlns:a="http://schemas.openxmlformats.org/drawingml/2006/main">
             <a:r>
-              <a:t>{"assessment":[["Data model and runtime rules","The draft separates authored inputs from computed results and defines placement, adjustment, query and bake behavior."],["Group alignment","The detailed orientation, frame, WKT string normalization and publication conventions remain proposed."],["Prototype limitations","Lighting directions lack an error bound. Rotation uncertainty is unquantified. A quoted CRS name causes false rejection."],["Verification coverage","Selected workflows and distinguishing controls support the rules. Broader composition and continuous space/time coverage remain unverified."]],"placement":[["Physical orientation","One heading/pitch/roll tuple describes physical attitude against local east, north and up. Projection effects stay computed."],["Project adjustments","The directly bound model's own xformOps adjust its placed result in a fixed project chart, including ordinary pivots."],["Child objects","Child transforms define model-local geometry. Their offsets follow model axes and the geospatial attitude."],["Repeated models","Each instance offset retains its instancer-local meaning. Independent prototype placement participates once. A required unavailable inverse fails."],["Geographic scene results","Geographic queries retain longitude/latitude/height. Cartesian geometry and bounds use the datum's Earth-centred frame."]],"data":[["Native data associations","Declare the asset, field and coordinate domain. Preserve named dimensions and observation times."],["WKT string normalization","Normalize lexical spelling without losing represented information. Equal tokens establish serialized identity."],["Semantic CRS comparison","Different normalized texts can represent equivalent CRSs. Comparison names its criteria and domain."],["Dependency declaration","Existing Profiles metadata carries a proposed complete publication summary, including unloaded and retained variant content."],["Baked coordinate context","Retain a Cartesian CRS and double-precision origin without an active source placement binding. Ordinary USD controls subsequent transforms."]]}</a:t>
-            </a:r>
-          </a:p>
-          <a:p xmlns:a="http://schemas.openxmlformats.org/drawingml/2006/main">
-            <a:r>
-              <a:t>[["Python and C++ readers","213,243 coordinate results per reader. Maximum measured difference 3.39e-08 m. Shared PROJ and decoding."],["Omniverse stage geometry","Reuses Python placement. Readback covers 177,872 vertices and 48 edit, failure and recovery checks across 39 jobs."],["Hydra / Storm","Two selected ordinary USD bakes reach native rendering using C++-resolved placements."],["Recorded tests","113 contract tests and 65 distinguishing controls pass. Separate diagnostics expose the reported prototype limits."],["Source preservation","Original inputs and 47 frozen execution files remain unchanged. The immutable receipt identifies exact executed content."],["Bake readbacks","11 selected exports checked. No general material/primvar, physics or continuous trajectory conformance is claimed."]]</a:t>
-            </a:r>
-          </a:p>
-          <a:p xmlns:a="http://schemas.openxmlformats.org/drawingml/2006/main">
-            <a:r>
-              <a:t>Proposal 7b5b34b7282305135f672663a3cffb0f94342ecc SHA-256 010d4c0243e7e6985284cccadb00fb7c6f7b0c5c50f22d81bb31ada960548d75</a:t>
-            </a:r>
-          </a:p>
-          <a:p xmlns:a="http://schemas.openxmlformats.org/drawingml/2006/main">
-            <a:r>
-              <a:t>README SHA-256 32731631975544a0d484f84f76524fd94c3aac82ac3347a37b6990cbe7907035</a:t>
-            </a:r>
-          </a:p>
-          <a:p xmlns:a="http://schemas.openxmlformats.org/drawingml/2006/main">
-            <a:r>
-              <a:t>Immutable receipt SHA-256 db39bc27bc04bf7f70bfaf2e5048b085798e3ef8b72e58fa54a367a51b7b6d91</a:t>
+              <a:t>{"assessment":[["Data model and runtime rules","The draft separates authored inputs from computed results and defines placement, adjustment, query and bake behavior."],["Group alignment","Input and declaration rules have agreement. Detailed conventions and identities await review."],["Prototype limitations","Lighting directions lack an error bound. Rotation uncertainty is unquantified. A quoted CRS name causes false rejection."],["Verification coverage","Selected workflows and distinguishing controls support the rules. Broader composition and continuous space/time coverage remain unverified."]],"placement":[["Physical orientation","One heading/pitch/roll tuple describes physical attitude against local east, north and up. Projection effects stay computed."],["Project adjustments","The directly bound model's own xformOps adjust its placed result in a fixed project chart, including ordinary pivots."],["Child objects","Child transforms define model-local geometry. Their offsets follow model axes and the geospatial attitude."],["Repeated models","Each instance offset retains its instancer-local meaning. Independent prototype placement participates once. A required unavailable inverse fails."],["Geographic scene results","Geographic queries retain longitude/latitude/height. Cartesian geometry and bounds use the datum's Earth-centred frame."]],"data":[["Native data associations","Declare the asset, field and coordinate domain. Preserve named dimensions and observation times."],["WKT string normalization","Normalize lexical spelling without losing represented information. Equal tokens establish serialized identity."],["Semantic CRS comparison","Different normalized texts can represent equivalent CRSs. Comparison names its criteria and domain."],["Dependency declaration","Profiles records complete publication coverage, including unloaded and retained variant content. Fixed v1 identities remain proposed."],["Baked coordinate context","Retain a Cartesian CRS and double-precision origin without an active source placement binding. Ordinary USD controls subsequent transforms."]]}</a:t>
+            </a:r>
+          </a:p>
+          <a:p xmlns:a="http://schemas.openxmlformats.org/drawingml/2006/main">
+            <a:r>
+              <a:t>[["Python and C++ readers","213,243 coordinate results per reader. Maximum measured difference 3.39e-08 m. Shared PROJ and decoding."],["Omniverse stage geometry","Reuses Python placement. Readback covers 177,872 vertices and 48 edit, failure and recovery checks across 39 jobs."],["Hydra / Storm","Two selected ordinary USD bakes reach native rendering using C++-resolved placements."],["Recorded tests","116 contract tests and 65 distinguishing controls pass. Separate diagnostics expose the reported prototype limits."],["Source preservation","Original inputs and 48 frozen execution files remain unchanged. The immutable receipt identifies exact executed content."],["Bake readbacks","11 selected exports checked. No general material/primvar, physics or continuous trajectory conformance is claimed."]]</a:t>
+            </a:r>
+          </a:p>
+          <a:p xmlns:a="http://schemas.openxmlformats.org/drawingml/2006/main">
+            <a:r>
+              <a:t>Proposal da2f49aad42811fc5d660c7bcf9ff190599f2d74 SHA-256 2613649fd06516d77339d73b56432e84613dd1925e739761efea738f41b4f0a4</a:t>
+            </a:r>
+          </a:p>
+          <a:p xmlns:a="http://schemas.openxmlformats.org/drawingml/2006/main">
+            <a:r>
+              <a:t>README SHA-256 f97eb66b4642d85817c1bface96cc358cea536a8a8104a439f22a2715af103d5</a:t>
+            </a:r>
+          </a:p>
+          <a:p xmlns:a="http://schemas.openxmlformats.org/drawingml/2006/main">
+            <a:r>
+              <a:t>Immutable receipt SHA-256 ad59ead3c86c780b6d79a243a23032e492c14809f0c01f575397ae221939068f</a:t>
             </a:r>
           </a:p>
           <a:p xmlns:a="http://schemas.openxmlformats.org/drawingml/2006/main">
@@ -1055,7 +1055,7 @@
           </a:p>
           <a:p xmlns:a="http://schemas.openxmlformats.org/drawingml/2006/main">
             <a:r>
-              <a:t>Full detailed model remains proposed. Python and C++ share PROJ and decoding. Omniverse reuses Python. Hydra consumes a resolved ordinary USD bake.</a:t>
+              <a:t>Accepted source and declaration rules are distinguished from detailed conventions and identities awaiting review. Python and C++ share PROJ and decoding. Omniverse reuses Python. Hydra consumes a resolved ordinary USD bake.</a:t>
             </a:r>
           </a:p>
         </p:txBody>
@@ -1145,7 +1145,7 @@
           </a:p>
           <a:p xmlns:a="http://schemas.openxmlformats.org/drawingml/2006/main">
             <a:r>
-              <a:t>What this says about the proposal: Inputs-only authoring gives the reader one authority for each meaning. The detailed field and pose conventions remain proposed.</a:t>
+              <a:t>What this says about the proposal: Inputs-only authoring gives the reader one authority for each meaning. Source position and the heading/pitch/roll tuple are agreed; detailed pose conventions remain proposed.</a:t>
             </a:r>
           </a:p>
           <a:p xmlns:a="http://schemas.openxmlformats.org/drawingml/2006/main">
@@ -1155,7 +1155,7 @@
           </a:p>
           <a:p xmlns:a="http://schemas.openxmlformats.org/drawingml/2006/main">
             <a:r>
-              <a:t>Proposal clause: #### Authored properties at proposal/proposal-source.txt:1540</a:t>
+              <a:t>Proposal clause: #### Authored properties at proposal/proposal-source.txt:1588</a:t>
             </a:r>
           </a:p>
           <a:p xmlns:a="http://schemas.openxmlformats.org/drawingml/2006/main">
@@ -1170,17 +1170,17 @@
           </a:p>
           <a:p xmlns:a="http://schemas.openxmlformats.org/drawingml/2006/main">
             <a:r>
-              <a:t>Proposal 7b5b34b7282305135f672663a3cffb0f94342ecc SHA-256 010d4c0243e7e6985284cccadb00fb7c6f7b0c5c50f22d81bb31ada960548d75</a:t>
-            </a:r>
-          </a:p>
-          <a:p xmlns:a="http://schemas.openxmlformats.org/drawingml/2006/main">
-            <a:r>
-              <a:t>README SHA-256 32731631975544a0d484f84f76524fd94c3aac82ac3347a37b6990cbe7907035</a:t>
-            </a:r>
-          </a:p>
-          <a:p xmlns:a="http://schemas.openxmlformats.org/drawingml/2006/main">
-            <a:r>
-              <a:t>Immutable receipt SHA-256 db39bc27bc04bf7f70bfaf2e5048b085798e3ef8b72e58fa54a367a51b7b6d91</a:t>
+              <a:t>Proposal da2f49aad42811fc5d660c7bcf9ff190599f2d74 SHA-256 2613649fd06516d77339d73b56432e84613dd1925e739761efea738f41b4f0a4</a:t>
+            </a:r>
+          </a:p>
+          <a:p xmlns:a="http://schemas.openxmlformats.org/drawingml/2006/main">
+            <a:r>
+              <a:t>README SHA-256 f97eb66b4642d85817c1bface96cc358cea536a8a8104a439f22a2715af103d5</a:t>
+            </a:r>
+          </a:p>
+          <a:p xmlns:a="http://schemas.openxmlformats.org/drawingml/2006/main">
+            <a:r>
+              <a:t>Immutable receipt SHA-256 ad59ead3c86c780b6d79a243a23032e492c14809f0c01f575397ae221939068f</a:t>
             </a:r>
           </a:p>
           <a:p xmlns:a="http://schemas.openxmlformats.org/drawingml/2006/main">
@@ -1190,7 +1190,7 @@
           </a:p>
           <a:p xmlns:a="http://schemas.openxmlformats.org/drawingml/2006/main">
             <a:r>
-              <a:t>Full detailed model remains proposed. Python and C++ share PROJ and decoding. Omniverse reuses Python. Hydra consumes a resolved ordinary USD bake.</a:t>
+              <a:t>Accepted source and declaration rules are distinguished from detailed conventions and identities awaiting review. Python and C++ share PROJ and decoding. Omniverse reuses Python. Hydra consumes a resolved ordinary USD bake.</a:t>
             </a:r>
           </a:p>
         </p:txBody>
@@ -1290,7 +1290,7 @@
           </a:p>
           <a:p xmlns:a="http://schemas.openxmlformats.org/drawingml/2006/main">
             <a:r>
-              <a:t>Proposal clause: ### Source placement evaluation and transform order at proposal/proposal-source.txt:1857</a:t>
+              <a:t>Proposal clause: ### Source placement evaluation and transform order at proposal/proposal-source.txt:1916</a:t>
             </a:r>
           </a:p>
           <a:p xmlns:a="http://schemas.openxmlformats.org/drawingml/2006/main">
@@ -1305,17 +1305,17 @@
           </a:p>
           <a:p xmlns:a="http://schemas.openxmlformats.org/drawingml/2006/main">
             <a:r>
-              <a:t>Proposal 7b5b34b7282305135f672663a3cffb0f94342ecc SHA-256 010d4c0243e7e6985284cccadb00fb7c6f7b0c5c50f22d81bb31ada960548d75</a:t>
-            </a:r>
-          </a:p>
-          <a:p xmlns:a="http://schemas.openxmlformats.org/drawingml/2006/main">
-            <a:r>
-              <a:t>README SHA-256 32731631975544a0d484f84f76524fd94c3aac82ac3347a37b6990cbe7907035</a:t>
-            </a:r>
-          </a:p>
-          <a:p xmlns:a="http://schemas.openxmlformats.org/drawingml/2006/main">
-            <a:r>
-              <a:t>Immutable receipt SHA-256 db39bc27bc04bf7f70bfaf2e5048b085798e3ef8b72e58fa54a367a51b7b6d91</a:t>
+              <a:t>Proposal da2f49aad42811fc5d660c7bcf9ff190599f2d74 SHA-256 2613649fd06516d77339d73b56432e84613dd1925e739761efea738f41b4f0a4</a:t>
+            </a:r>
+          </a:p>
+          <a:p xmlns:a="http://schemas.openxmlformats.org/drawingml/2006/main">
+            <a:r>
+              <a:t>README SHA-256 f97eb66b4642d85817c1bface96cc358cea536a8a8104a439f22a2715af103d5</a:t>
+            </a:r>
+          </a:p>
+          <a:p xmlns:a="http://schemas.openxmlformats.org/drawingml/2006/main">
+            <a:r>
+              <a:t>Immutable receipt SHA-256 ad59ead3c86c780b6d79a243a23032e492c14809f0c01f575397ae221939068f</a:t>
             </a:r>
           </a:p>
           <a:p xmlns:a="http://schemas.openxmlformats.org/drawingml/2006/main">
@@ -1325,7 +1325,7 @@
           </a:p>
           <a:p xmlns:a="http://schemas.openxmlformats.org/drawingml/2006/main">
             <a:r>
-              <a:t>Full detailed model remains proposed. Python and C++ share PROJ and decoding. Omniverse reuses Python. Hydra consumes a resolved ordinary USD bake.</a:t>
+              <a:t>Accepted source and declaration rules are distinguished from detailed conventions and identities awaiting review. Python and C++ share PROJ and decoding. Omniverse reuses Python. Hydra consumes a resolved ordinary USD bake.</a:t>
             </a:r>
           </a:p>
         </p:txBody>
@@ -1425,7 +1425,7 @@
           </a:p>
           <a:p xmlns:a="http://schemas.openxmlformats.org/drawingml/2006/main">
             <a:r>
-              <a:t>Proposal clause: #### Evaluation at proposal/proposal-source.txt:1957</a:t>
+              <a:t>Proposal clause: #### Evaluation at proposal/proposal-source.txt:2016</a:t>
             </a:r>
           </a:p>
           <a:p xmlns:a="http://schemas.openxmlformats.org/drawingml/2006/main">
@@ -1440,17 +1440,17 @@
           </a:p>
           <a:p xmlns:a="http://schemas.openxmlformats.org/drawingml/2006/main">
             <a:r>
-              <a:t>Proposal 7b5b34b7282305135f672663a3cffb0f94342ecc SHA-256 010d4c0243e7e6985284cccadb00fb7c6f7b0c5c50f22d81bb31ada960548d75</a:t>
-            </a:r>
-          </a:p>
-          <a:p xmlns:a="http://schemas.openxmlformats.org/drawingml/2006/main">
-            <a:r>
-              <a:t>README SHA-256 32731631975544a0d484f84f76524fd94c3aac82ac3347a37b6990cbe7907035</a:t>
-            </a:r>
-          </a:p>
-          <a:p xmlns:a="http://schemas.openxmlformats.org/drawingml/2006/main">
-            <a:r>
-              <a:t>Immutable receipt SHA-256 db39bc27bc04bf7f70bfaf2e5048b085798e3ef8b72e58fa54a367a51b7b6d91</a:t>
+              <a:t>Proposal da2f49aad42811fc5d660c7bcf9ff190599f2d74 SHA-256 2613649fd06516d77339d73b56432e84613dd1925e739761efea738f41b4f0a4</a:t>
+            </a:r>
+          </a:p>
+          <a:p xmlns:a="http://schemas.openxmlformats.org/drawingml/2006/main">
+            <a:r>
+              <a:t>README SHA-256 f97eb66b4642d85817c1bface96cc358cea536a8a8104a439f22a2715af103d5</a:t>
+            </a:r>
+          </a:p>
+          <a:p xmlns:a="http://schemas.openxmlformats.org/drawingml/2006/main">
+            <a:r>
+              <a:t>Immutable receipt SHA-256 ad59ead3c86c780b6d79a243a23032e492c14809f0c01f575397ae221939068f</a:t>
             </a:r>
           </a:p>
           <a:p xmlns:a="http://schemas.openxmlformats.org/drawingml/2006/main">
@@ -1460,7 +1460,7 @@
           </a:p>
           <a:p xmlns:a="http://schemas.openxmlformats.org/drawingml/2006/main">
             <a:r>
-              <a:t>Full detailed model remains proposed. Python and C++ share PROJ and decoding. Omniverse reuses Python. Hydra consumes a resolved ordinary USD bake.</a:t>
+              <a:t>Accepted source and declaration rules are distinguished from detailed conventions and identities awaiting review. Python and C++ share PROJ and decoding. Omniverse reuses Python. Hydra consumes a resolved ordinary USD bake.</a:t>
             </a:r>
           </a:p>
         </p:txBody>
@@ -1560,7 +1560,7 @@
           </a:p>
           <a:p xmlns:a="http://schemas.openxmlformats.org/drawingml/2006/main">
             <a:r>
-              <a:t>Proposal clause: ### Extent and result comparison at proposal/proposal-source.txt:2138</a:t>
+              <a:t>Proposal clause: ### Extent and result comparison at proposal/proposal-source.txt:2197</a:t>
             </a:r>
           </a:p>
           <a:p xmlns:a="http://schemas.openxmlformats.org/drawingml/2006/main">
@@ -1575,17 +1575,17 @@
           </a:p>
           <a:p xmlns:a="http://schemas.openxmlformats.org/drawingml/2006/main">
             <a:r>
-              <a:t>Proposal 7b5b34b7282305135f672663a3cffb0f94342ecc SHA-256 010d4c0243e7e6985284cccadb00fb7c6f7b0c5c50f22d81bb31ada960548d75</a:t>
-            </a:r>
-          </a:p>
-          <a:p xmlns:a="http://schemas.openxmlformats.org/drawingml/2006/main">
-            <a:r>
-              <a:t>README SHA-256 32731631975544a0d484f84f76524fd94c3aac82ac3347a37b6990cbe7907035</a:t>
-            </a:r>
-          </a:p>
-          <a:p xmlns:a="http://schemas.openxmlformats.org/drawingml/2006/main">
-            <a:r>
-              <a:t>Immutable receipt SHA-256 db39bc27bc04bf7f70bfaf2e5048b085798e3ef8b72e58fa54a367a51b7b6d91</a:t>
+              <a:t>Proposal da2f49aad42811fc5d660c7bcf9ff190599f2d74 SHA-256 2613649fd06516d77339d73b56432e84613dd1925e739761efea738f41b4f0a4</a:t>
+            </a:r>
+          </a:p>
+          <a:p xmlns:a="http://schemas.openxmlformats.org/drawingml/2006/main">
+            <a:r>
+              <a:t>README SHA-256 f97eb66b4642d85817c1bface96cc358cea536a8a8104a439f22a2715af103d5</a:t>
+            </a:r>
+          </a:p>
+          <a:p xmlns:a="http://schemas.openxmlformats.org/drawingml/2006/main">
+            <a:r>
+              <a:t>Immutable receipt SHA-256 ad59ead3c86c780b6d79a243a23032e492c14809f0c01f575397ae221939068f</a:t>
             </a:r>
           </a:p>
           <a:p xmlns:a="http://schemas.openxmlformats.org/drawingml/2006/main">
@@ -1595,7 +1595,7 @@
           </a:p>
           <a:p xmlns:a="http://schemas.openxmlformats.org/drawingml/2006/main">
             <a:r>
-              <a:t>Full detailed model remains proposed. Python and C++ share PROJ and decoding. Omniverse reuses Python. Hydra consumes a resolved ordinary USD bake.</a:t>
+              <a:t>Accepted source and declaration rules are distinguished from detailed conventions and identities awaiting review. Python and C++ share PROJ and decoding. Omniverse reuses Python. Hydra consumes a resolved ordinary USD bake.</a:t>
             </a:r>
           </a:p>
         </p:txBody>
@@ -1695,7 +1695,7 @@
           </a:p>
           <a:p xmlns:a="http://schemas.openxmlformats.org/drawingml/2006/main">
             <a:r>
-              <a:t>Proposal clause: ### Explicit export and sampling at proposal/proposal-source.txt:2195</a:t>
+              <a:t>Proposal clause: ### Explicit export and sampling at proposal/proposal-source.txt:2254</a:t>
             </a:r>
           </a:p>
           <a:p xmlns:a="http://schemas.openxmlformats.org/drawingml/2006/main">
@@ -1710,17 +1710,17 @@
           </a:p>
           <a:p xmlns:a="http://schemas.openxmlformats.org/drawingml/2006/main">
             <a:r>
-              <a:t>Proposal 7b5b34b7282305135f672663a3cffb0f94342ecc SHA-256 010d4c0243e7e6985284cccadb00fb7c6f7b0c5c50f22d81bb31ada960548d75</a:t>
-            </a:r>
-          </a:p>
-          <a:p xmlns:a="http://schemas.openxmlformats.org/drawingml/2006/main">
-            <a:r>
-              <a:t>README SHA-256 32731631975544a0d484f84f76524fd94c3aac82ac3347a37b6990cbe7907035</a:t>
-            </a:r>
-          </a:p>
-          <a:p xmlns:a="http://schemas.openxmlformats.org/drawingml/2006/main">
-            <a:r>
-              <a:t>Immutable receipt SHA-256 db39bc27bc04bf7f70bfaf2e5048b085798e3ef8b72e58fa54a367a51b7b6d91</a:t>
+              <a:t>Proposal da2f49aad42811fc5d660c7bcf9ff190599f2d74 SHA-256 2613649fd06516d77339d73b56432e84613dd1925e739761efea738f41b4f0a4</a:t>
+            </a:r>
+          </a:p>
+          <a:p xmlns:a="http://schemas.openxmlformats.org/drawingml/2006/main">
+            <a:r>
+              <a:t>README SHA-256 f97eb66b4642d85817c1bface96cc358cea536a8a8104a439f22a2715af103d5</a:t>
+            </a:r>
+          </a:p>
+          <a:p xmlns:a="http://schemas.openxmlformats.org/drawingml/2006/main">
+            <a:r>
+              <a:t>Immutable receipt SHA-256 ad59ead3c86c780b6d79a243a23032e492c14809f0c01f575397ae221939068f</a:t>
             </a:r>
           </a:p>
           <a:p xmlns:a="http://schemas.openxmlformats.org/drawingml/2006/main">
@@ -1730,7 +1730,7 @@
           </a:p>
           <a:p xmlns:a="http://schemas.openxmlformats.org/drawingml/2006/main">
             <a:r>
-              <a:t>Full detailed model remains proposed. Python and C++ share PROJ and decoding. Omniverse reuses Python. Hydra consumes a resolved ordinary USD bake.</a:t>
+              <a:t>Accepted source and declaration rules are distinguished from detailed conventions and identities awaiting review. Python and C++ share PROJ and decoding. Omniverse reuses Python. Hydra consumes a resolved ordinary USD bake.</a:t>
             </a:r>
           </a:p>
         </p:txBody>
@@ -1830,7 +1830,7 @@
           </a:p>
           <a:p xmlns:a="http://schemas.openxmlformats.org/drawingml/2006/main">
             <a:r>
-              <a:t>Proposal clause: ### External measurement association at proposal/proposal-source.txt:1641</a:t>
+              <a:t>Proposal clause: ### External measurement association at proposal/proposal-source.txt:1689</a:t>
             </a:r>
           </a:p>
           <a:p xmlns:a="http://schemas.openxmlformats.org/drawingml/2006/main">
@@ -1845,17 +1845,17 @@
           </a:p>
           <a:p xmlns:a="http://schemas.openxmlformats.org/drawingml/2006/main">
             <a:r>
-              <a:t>Proposal 7b5b34b7282305135f672663a3cffb0f94342ecc SHA-256 010d4c0243e7e6985284cccadb00fb7c6f7b0c5c50f22d81bb31ada960548d75</a:t>
-            </a:r>
-          </a:p>
-          <a:p xmlns:a="http://schemas.openxmlformats.org/drawingml/2006/main">
-            <a:r>
-              <a:t>README SHA-256 32731631975544a0d484f84f76524fd94c3aac82ac3347a37b6990cbe7907035</a:t>
-            </a:r>
-          </a:p>
-          <a:p xmlns:a="http://schemas.openxmlformats.org/drawingml/2006/main">
-            <a:r>
-              <a:t>Immutable receipt SHA-256 db39bc27bc04bf7f70bfaf2e5048b085798e3ef8b72e58fa54a367a51b7b6d91</a:t>
+              <a:t>Proposal da2f49aad42811fc5d660c7bcf9ff190599f2d74 SHA-256 2613649fd06516d77339d73b56432e84613dd1925e739761efea738f41b4f0a4</a:t>
+            </a:r>
+          </a:p>
+          <a:p xmlns:a="http://schemas.openxmlformats.org/drawingml/2006/main">
+            <a:r>
+              <a:t>README SHA-256 f97eb66b4642d85817c1bface96cc358cea536a8a8104a439f22a2715af103d5</a:t>
+            </a:r>
+          </a:p>
+          <a:p xmlns:a="http://schemas.openxmlformats.org/drawingml/2006/main">
+            <a:r>
+              <a:t>Immutable receipt SHA-256 ad59ead3c86c780b6d79a243a23032e492c14809f0c01f575397ae221939068f</a:t>
             </a:r>
           </a:p>
           <a:p xmlns:a="http://schemas.openxmlformats.org/drawingml/2006/main">
@@ -1865,7 +1865,7 @@
           </a:p>
           <a:p xmlns:a="http://schemas.openxmlformats.org/drawingml/2006/main">
             <a:r>
-              <a:t>Full detailed model remains proposed. Python and C++ share PROJ and decoding. Omniverse reuses Python. Hydra consumes a resolved ordinary USD bake.</a:t>
+              <a:t>Accepted source and declaration rules are distinguished from detailed conventions and identities awaiting review. Python and C++ share PROJ and decoding. Omniverse reuses Python. Hydra consumes a resolved ordinary USD bake.</a:t>
             </a:r>
           </a:p>
         </p:txBody>
@@ -1935,7 +1935,7 @@
           <a:lstStyle xmlns:a="http://schemas.openxmlformats.org/drawingml/2006/main"/>
           <a:p xmlns:a="http://schemas.openxmlformats.org/drawingml/2006/main">
             <a:r>
-              <a:t>{"assessment":[["Data model and runtime rules","The draft separates authored inputs from computed results and defines placement, adjustment, query and bake behavior."],["Group alignment","The detailed orientation, frame, WKT string normalization and publication conventions remain proposed."],["Prototype limitations","Lighting directions lack an error bound. Rotation uncertainty is unquantified. A quoted CRS name causes false rejection."],["Verification coverage","Selected workflows and distinguishing controls support the rules. Broader composition and continuous space/time coverage remain unverified."]],"placement":[["Physical orientation","One heading/pitch/roll tuple describes physical attitude against local east, north and up. Projection effects stay computed."],["Project adjustments","The directly bound model's own xformOps adjust its placed result in a fixed project chart, including ordinary pivots."],["Child objects","Child transforms define model-local geometry. Their offsets follow model axes and the geospatial attitude."],["Repeated models","Each instance offset retains its instancer-local meaning. Independent prototype placement participates once. A required unavailable inverse fails."],["Geographic scene results","Geographic queries retain longitude/latitude/height. Cartesian geometry and bounds use the datum's Earth-centred frame."]],"data":[["Native data associations","Declare the asset, field and coordinate domain. Preserve named dimensions and observation times."],["WKT string normalization","Normalize lexical spelling without losing represented information. Equal tokens establish serialized identity."],["Semantic CRS comparison","Different normalized texts can represent equivalent CRSs. Comparison names its criteria and domain."],["Dependency declaration","Existing Profiles metadata carries a proposed complete publication summary, including unloaded and retained variant content."],["Baked coordinate context","Retain a Cartesian CRS and double-precision origin without an active source placement binding. Ordinary USD controls subsequent transforms."]]}</a:t>
+              <a:t>{"assessment":[["Data model and runtime rules","The draft separates authored inputs from computed results and defines placement, adjustment, query and bake behavior."],["Group alignment","Input and declaration rules have agreement. Detailed conventions and identities await review."],["Prototype limitations","Lighting directions lack an error bound. Rotation uncertainty is unquantified. A quoted CRS name causes false rejection."],["Verification coverage","Selected workflows and distinguishing controls support the rules. Broader composition and continuous space/time coverage remain unverified."]],"placement":[["Physical orientation","One heading/pitch/roll tuple describes physical attitude against local east, north and up. Projection effects stay computed."],["Project adjustments","The directly bound model's own xformOps adjust its placed result in a fixed project chart, including ordinary pivots."],["Child objects","Child transforms define model-local geometry. Their offsets follow model axes and the geospatial attitude."],["Repeated models","Each instance offset retains its instancer-local meaning. Independent prototype placement participates once. A required unavailable inverse fails."],["Geographic scene results","Geographic queries retain longitude/latitude/height. Cartesian geometry and bounds use the datum's Earth-centred frame."]],"data":[["Native data associations","Declare the asset, field and coordinate domain. Preserve named dimensions and observation times."],["WKT string normalization","Normalize lexical spelling without losing represented information. Equal tokens establish serialized identity."],["Semantic CRS comparison","Different normalized texts can represent equivalent CRSs. Comparison names its criteria and domain."],["Dependency declaration","Profiles records complete publication coverage, including unloaded and retained variant content. Fixed v1 identities remain proposed."],["Baked coordinate context","Retain a Cartesian CRS and double-precision origin without an active source placement binding. Ordinary USD controls subsequent transforms."]]}</a:t>
             </a:r>
           </a:p>
           <a:p xmlns:a="http://schemas.openxmlformats.org/drawingml/2006/main">
@@ -1945,17 +1945,17 @@
           </a:p>
           <a:p xmlns:a="http://schemas.openxmlformats.org/drawingml/2006/main">
             <a:r>
-              <a:t>Proposal 7b5b34b7282305135f672663a3cffb0f94342ecc SHA-256 010d4c0243e7e6985284cccadb00fb7c6f7b0c5c50f22d81bb31ada960548d75</a:t>
-            </a:r>
-          </a:p>
-          <a:p xmlns:a="http://schemas.openxmlformats.org/drawingml/2006/main">
-            <a:r>
-              <a:t>README SHA-256 32731631975544a0d484f84f76524fd94c3aac82ac3347a37b6990cbe7907035</a:t>
-            </a:r>
-          </a:p>
-          <a:p xmlns:a="http://schemas.openxmlformats.org/drawingml/2006/main">
-            <a:r>
-              <a:t>Immutable receipt SHA-256 db39bc27bc04bf7f70bfaf2e5048b085798e3ef8b72e58fa54a367a51b7b6d91</a:t>
+              <a:t>Proposal da2f49aad42811fc5d660c7bcf9ff190599f2d74 SHA-256 2613649fd06516d77339d73b56432e84613dd1925e739761efea738f41b4f0a4</a:t>
+            </a:r>
+          </a:p>
+          <a:p xmlns:a="http://schemas.openxmlformats.org/drawingml/2006/main">
+            <a:r>
+              <a:t>README SHA-256 f97eb66b4642d85817c1bface96cc358cea536a8a8104a439f22a2715af103d5</a:t>
+            </a:r>
+          </a:p>
+          <a:p xmlns:a="http://schemas.openxmlformats.org/drawingml/2006/main">
+            <a:r>
+              <a:t>Immutable receipt SHA-256 ad59ead3c86c780b6d79a243a23032e492c14809f0c01f575397ae221939068f</a:t>
             </a:r>
           </a:p>
           <a:p xmlns:a="http://schemas.openxmlformats.org/drawingml/2006/main">
@@ -1965,7 +1965,7 @@
           </a:p>
           <a:p xmlns:a="http://schemas.openxmlformats.org/drawingml/2006/main">
             <a:r>
-              <a:t>Full detailed model remains proposed. Python and C++ share PROJ and decoding. Omniverse reuses Python. Hydra consumes a resolved ordinary USD bake.</a:t>
+              <a:t>Accepted source and declaration rules are distinguished from detailed conventions and identities awaiting review. Python and C++ share PROJ and decoding. Omniverse reuses Python. Hydra consumes a resolved ordinary USD bake.</a:t>
             </a:r>
           </a:p>
         </p:txBody>
@@ -2065,7 +2065,7 @@
           </a:p>
           <a:p xmlns:a="http://schemas.openxmlformats.org/drawingml/2006/main">
             <a:r>
-              <a:t>Proposal clause: #### Decision on question 7: site calibration at proposal/proposal-source.txt:1304</a:t>
+              <a:t>Proposal clause: #### Decision on question 7: site calibration at proposal/proposal-source.txt:1344</a:t>
             </a:r>
           </a:p>
           <a:p xmlns:a="http://schemas.openxmlformats.org/drawingml/2006/main">
@@ -2080,17 +2080,17 @@
           </a:p>
           <a:p xmlns:a="http://schemas.openxmlformats.org/drawingml/2006/main">
             <a:r>
-              <a:t>Proposal 7b5b34b7282305135f672663a3cffb0f94342ecc SHA-256 010d4c0243e7e6985284cccadb00fb7c6f7b0c5c50f22d81bb31ada960548d75</a:t>
-            </a:r>
-          </a:p>
-          <a:p xmlns:a="http://schemas.openxmlformats.org/drawingml/2006/main">
-            <a:r>
-              <a:t>README SHA-256 32731631975544a0d484f84f76524fd94c3aac82ac3347a37b6990cbe7907035</a:t>
-            </a:r>
-          </a:p>
-          <a:p xmlns:a="http://schemas.openxmlformats.org/drawingml/2006/main">
-            <a:r>
-              <a:t>Immutable receipt SHA-256 db39bc27bc04bf7f70bfaf2e5048b085798e3ef8b72e58fa54a367a51b7b6d91</a:t>
+              <a:t>Proposal da2f49aad42811fc5d660c7bcf9ff190599f2d74 SHA-256 2613649fd06516d77339d73b56432e84613dd1925e739761efea738f41b4f0a4</a:t>
+            </a:r>
+          </a:p>
+          <a:p xmlns:a="http://schemas.openxmlformats.org/drawingml/2006/main">
+            <a:r>
+              <a:t>README SHA-256 f97eb66b4642d85817c1bface96cc358cea536a8a8104a439f22a2715af103d5</a:t>
+            </a:r>
+          </a:p>
+          <a:p xmlns:a="http://schemas.openxmlformats.org/drawingml/2006/main">
+            <a:r>
+              <a:t>Immutable receipt SHA-256 ad59ead3c86c780b6d79a243a23032e492c14809f0c01f575397ae221939068f</a:t>
             </a:r>
           </a:p>
           <a:p xmlns:a="http://schemas.openxmlformats.org/drawingml/2006/main">
@@ -2100,7 +2100,7 @@
           </a:p>
           <a:p xmlns:a="http://schemas.openxmlformats.org/drawingml/2006/main">
             <a:r>
-              <a:t>Full detailed model remains proposed. Python and C++ share PROJ and decoding. Omniverse reuses Python. Hydra consumes a resolved ordinary USD bake.</a:t>
+              <a:t>Accepted source and declaration rules are distinguished from detailed conventions and identities awaiting review. Python and C++ share PROJ and decoding. Omniverse reuses Python. Hydra consumes a resolved ordinary USD bake.</a:t>
             </a:r>
           </a:p>
         </p:txBody>
@@ -2147,7 +2147,7 @@
           <p:cNvPr id="3" name="Title">
             <a:extLst xmlns:a="http://schemas.openxmlformats.org/drawingml/2006/main">
               <a:ext uri="{FF2B5EF4-FFF2-40B4-BE49-F238E27FC236}">
-                <a16:creationId xmlns:a16="http://schemas.microsoft.com/office/drawing/2014/main" id="{8D475AEB-D8A4-4425-AD19-A4590C8F11A3}"/>
+                <a16:creationId xmlns:a16="http://schemas.microsoft.com/office/drawing/2014/main" id="{A50AC5D3-9C97-4890-A84B-63B6523E39BA}"/>
               </a:ext>
             </a:extLst>
           </p:cNvPr>
@@ -2304,7 +2304,7 @@
           <p:cNvPr id="2" name="Subtitle">
             <a:extLst xmlns:a="http://schemas.openxmlformats.org/drawingml/2006/main">
               <a:ext uri="{FF2B5EF4-FFF2-40B4-BE49-F238E27FC236}">
-                <a16:creationId xmlns:a16="http://schemas.microsoft.com/office/drawing/2014/main" id="{D0C48101-212F-46E7-9E8C-C3FE4774FA2B}"/>
+                <a16:creationId xmlns:a16="http://schemas.microsoft.com/office/drawing/2014/main" id="{AE74225E-70BD-434B-93C7-6BE012BDE7C8}"/>
               </a:ext>
             </a:extLst>
           </p:cNvPr>
@@ -2478,7 +2478,7 @@
           <p:cNvPr id="2" name="Section title">
             <a:extLst xmlns:a="http://schemas.openxmlformats.org/drawingml/2006/main">
               <a:ext uri="{FF2B5EF4-FFF2-40B4-BE49-F238E27FC236}">
-                <a16:creationId xmlns:a16="http://schemas.microsoft.com/office/drawing/2014/main" id="{34D6A53A-5B10-4DC9-9E8B-D787DBE97CC3}"/>
+                <a16:creationId xmlns:a16="http://schemas.microsoft.com/office/drawing/2014/main" id="{83815F44-81BC-40E4-A600-462971652472}"/>
               </a:ext>
             </a:extLst>
           </p:cNvPr>
@@ -2652,7 +2652,7 @@
           <p:cNvPr id="3" name="Title">
             <a:extLst xmlns:a="http://schemas.openxmlformats.org/drawingml/2006/main">
               <a:ext uri="{FF2B5EF4-FFF2-40B4-BE49-F238E27FC236}">
-                <a16:creationId xmlns:a16="http://schemas.microsoft.com/office/drawing/2014/main" id="{67DDC44D-6D65-499D-B972-FCD5DCCADD8D}"/>
+                <a16:creationId xmlns:a16="http://schemas.microsoft.com/office/drawing/2014/main" id="{3D05F309-2D97-49E7-B31C-0020415A5CC1}"/>
               </a:ext>
             </a:extLst>
           </p:cNvPr>
@@ -2809,7 +2809,7 @@
           <p:cNvPr id="2" name="Body">
             <a:extLst xmlns:a="http://schemas.openxmlformats.org/drawingml/2006/main">
               <a:ext uri="{FF2B5EF4-FFF2-40B4-BE49-F238E27FC236}">
-                <a16:creationId xmlns:a16="http://schemas.microsoft.com/office/drawing/2014/main" id="{582FC061-02E8-4446-9FCB-2F20B891AFDB}"/>
+                <a16:creationId xmlns:a16="http://schemas.microsoft.com/office/drawing/2014/main" id="{2814E0B4-1840-4BF6-BFE2-1FBC9617EF05}"/>
               </a:ext>
             </a:extLst>
           </p:cNvPr>
@@ -2983,7 +2983,7 @@
           <p:cNvPr id="4" name="Title">
             <a:extLst xmlns:a="http://schemas.openxmlformats.org/drawingml/2006/main">
               <a:ext uri="{FF2B5EF4-FFF2-40B4-BE49-F238E27FC236}">
-                <a16:creationId xmlns:a16="http://schemas.microsoft.com/office/drawing/2014/main" id="{1C87D3D1-8CE7-4F57-82C9-35480111BA34}"/>
+                <a16:creationId xmlns:a16="http://schemas.microsoft.com/office/drawing/2014/main" id="{64B1183B-6FBC-472E-8520-708D0186B1C4}"/>
               </a:ext>
             </a:extLst>
           </p:cNvPr>
@@ -3140,7 +3140,7 @@
           <p:cNvPr id="2" name="Left column">
             <a:extLst xmlns:a="http://schemas.openxmlformats.org/drawingml/2006/main">
               <a:ext uri="{FF2B5EF4-FFF2-40B4-BE49-F238E27FC236}">
-                <a16:creationId xmlns:a16="http://schemas.microsoft.com/office/drawing/2014/main" id="{00F73DAF-40C0-4D71-A688-1A568418A6B6}"/>
+                <a16:creationId xmlns:a16="http://schemas.microsoft.com/office/drawing/2014/main" id="{CB73622A-047C-497B-B5D2-497EB766C8FC}"/>
               </a:ext>
             </a:extLst>
           </p:cNvPr>
@@ -3297,7 +3297,7 @@
           <p:cNvPr id="3" name="Right column">
             <a:extLst xmlns:a="http://schemas.openxmlformats.org/drawingml/2006/main">
               <a:ext uri="{FF2B5EF4-FFF2-40B4-BE49-F238E27FC236}">
-                <a16:creationId xmlns:a16="http://schemas.microsoft.com/office/drawing/2014/main" id="{7994E8A3-D44C-4607-8341-C69D83D13011}"/>
+                <a16:creationId xmlns:a16="http://schemas.microsoft.com/office/drawing/2014/main" id="{1F6CF98F-C49D-4E28-9F61-0811C2929619}"/>
               </a:ext>
             </a:extLst>
           </p:cNvPr>
@@ -3471,7 +3471,7 @@
           <p:cNvPr id="3" name="Title">
             <a:extLst xmlns:a="http://schemas.openxmlformats.org/drawingml/2006/main">
               <a:ext uri="{FF2B5EF4-FFF2-40B4-BE49-F238E27FC236}">
-                <a16:creationId xmlns:a16="http://schemas.microsoft.com/office/drawing/2014/main" id="{8735B04F-4596-4A23-9907-64A68289ADF6}"/>
+                <a16:creationId xmlns:a16="http://schemas.microsoft.com/office/drawing/2014/main" id="{943F2BE3-00F1-44DF-ACBC-ACD4B7BDF6F8}"/>
               </a:ext>
             </a:extLst>
           </p:cNvPr>
@@ -3628,7 +3628,7 @@
           <p:cNvPr id="2" name="Left column">
             <a:extLst xmlns:a="http://schemas.openxmlformats.org/drawingml/2006/main">
               <a:ext uri="{FF2B5EF4-FFF2-40B4-BE49-F238E27FC236}">
-                <a16:creationId xmlns:a16="http://schemas.microsoft.com/office/drawing/2014/main" id="{7B8AEE93-2B53-4707-9B98-60F27BCA4ABD}"/>
+                <a16:creationId xmlns:a16="http://schemas.microsoft.com/office/drawing/2014/main" id="{CD05DE4A-E378-407C-ABE3-25241FC32561}"/>
               </a:ext>
             </a:extLst>
           </p:cNvPr>
@@ -3823,12 +3823,12 @@
   </p:cSld>
   <p:clrMap bg1="lt1" tx1="dk1" bg2="lt2" tx2="dk2" accent1="accent1" accent2="accent2" accent3="accent3" accent4="accent4" accent5="accent5" accent6="accent6" hlink="hlink" folHlink="folHlink"/>
   <p:sldLayoutIdLst>
-    <p:sldLayoutId xmlns:r="http://schemas.openxmlformats.org/officeDocument/2006/relationships" id="2147483649" r:id="Rff7ba0c0b2c04775"/>
-    <p:sldLayoutId xmlns:r="http://schemas.openxmlformats.org/officeDocument/2006/relationships" id="2147483650" r:id="Re5b51691d3ff47dd"/>
-    <p:sldLayoutId xmlns:r="http://schemas.openxmlformats.org/officeDocument/2006/relationships" id="2147483651" r:id="Rccf7f5c858c347e3"/>
-    <p:sldLayoutId xmlns:r="http://schemas.openxmlformats.org/officeDocument/2006/relationships" id="2147483652" r:id="R91544a1a63104f27"/>
-    <p:sldLayoutId xmlns:r="http://schemas.openxmlformats.org/officeDocument/2006/relationships" id="2147483653" r:id="R6f54fd9e991043d2"/>
-    <p:sldLayoutId xmlns:r="http://schemas.openxmlformats.org/officeDocument/2006/relationships" id="2147483654" r:id="R6d7aa54083a74a60"/>
+    <p:sldLayoutId xmlns:r="http://schemas.openxmlformats.org/officeDocument/2006/relationships" id="2147483649" r:id="R87b7fd6dd1f94ff7"/>
+    <p:sldLayoutId xmlns:r="http://schemas.openxmlformats.org/officeDocument/2006/relationships" id="2147483650" r:id="Re7154fb901144cf8"/>
+    <p:sldLayoutId xmlns:r="http://schemas.openxmlformats.org/officeDocument/2006/relationships" id="2147483651" r:id="R0ae1a6e7c51b43e2"/>
+    <p:sldLayoutId xmlns:r="http://schemas.openxmlformats.org/officeDocument/2006/relationships" id="2147483652" r:id="Rad93a27509c34cd5"/>
+    <p:sldLayoutId xmlns:r="http://schemas.openxmlformats.org/officeDocument/2006/relationships" id="2147483653" r:id="R24ee76392df941e8"/>
+    <p:sldLayoutId xmlns:r="http://schemas.openxmlformats.org/officeDocument/2006/relationships" id="2147483654" r:id="R9d1b6cdbfcfc4d77"/>
   </p:sldLayoutIdLst>
   <p:txStyles>
     <p:titleStyle>
@@ -4646,7 +4646,7 @@
           <p:cNvPr id="5" name="">
             <a:extLst xmlns:a="http://schemas.openxmlformats.org/drawingml/2006/main">
               <a:ext uri="{FF2B5EF4-FFF2-40B4-BE49-F238E27FC236}">
-                <a16:creationId xmlns:a16="http://schemas.microsoft.com/office/drawing/2014/main" id="{DD899C30-FA86-4363-9F3B-0C552D69CAF5}"/>
+                <a16:creationId xmlns:a16="http://schemas.microsoft.com/office/drawing/2014/main" id="{96F0D17F-808C-4451-B949-4BB06DFBDEDD}"/>
               </a:ext>
             </a:extLst>
           </p:cNvPr>
@@ -4714,7 +4714,7 @@
           <p:cNvPr id="2" name="">
             <a:extLst xmlns:a="http://schemas.openxmlformats.org/drawingml/2006/main">
               <a:ext uri="{FF2B5EF4-FFF2-40B4-BE49-F238E27FC236}">
-                <a16:creationId xmlns:a16="http://schemas.microsoft.com/office/drawing/2014/main" id="{98D9EC52-9C42-405D-8322-CFF040F49731}"/>
+                <a16:creationId xmlns:a16="http://schemas.microsoft.com/office/drawing/2014/main" id="{CF6014A7-A5E4-487C-B85B-193E7DF93C7D}"/>
               </a:ext>
             </a:extLst>
           </p:cNvPr>
@@ -4782,7 +4782,7 @@
           <p:cNvPr id="3" name="">
             <a:extLst xmlns:a="http://schemas.openxmlformats.org/drawingml/2006/main">
               <a:ext uri="{FF2B5EF4-FFF2-40B4-BE49-F238E27FC236}">
-                <a16:creationId xmlns:a16="http://schemas.microsoft.com/office/drawing/2014/main" id="{CA34F448-51F6-43F4-9D40-48736EE74195}"/>
+                <a16:creationId xmlns:a16="http://schemas.microsoft.com/office/drawing/2014/main" id="{4F4E33B8-6594-4AA9-8D2B-1BB4BC51C6A0}"/>
               </a:ext>
             </a:extLst>
           </p:cNvPr>
@@ -4850,7 +4850,7 @@
           <p:cNvPr id="4" name="">
             <a:extLst xmlns:a="http://schemas.openxmlformats.org/drawingml/2006/main">
               <a:ext uri="{FF2B5EF4-FFF2-40B4-BE49-F238E27FC236}">
-                <a16:creationId xmlns:a16="http://schemas.microsoft.com/office/drawing/2014/main" id="{4C2CEF57-6356-44BC-B267-96CA156D3345}"/>
+                <a16:creationId xmlns:a16="http://schemas.microsoft.com/office/drawing/2014/main" id="{FBD2666B-ED8F-4171-968B-F07346958D9E}"/>
               </a:ext>
             </a:extLst>
           </p:cNvPr>
@@ -4916,7 +4916,7 @@
     </p:spTree>
     <p:extLst>
       <p:ext uri="{BB962C8B-B14F-4D97-AF65-F5344CB8AC3E}">
-        <p14:creationId xmlns:p14="http://schemas.microsoft.com/office/powerpoint/2010/main" val="1749863232"/>
+        <p14:creationId xmlns:p14="http://schemas.microsoft.com/office/powerpoint/2010/main" val="2100642048"/>
       </p:ext>
     </p:extLst>
   </p:cSld>
@@ -4947,7 +4947,7 @@
           <p:cNvPr id="9" name="">
             <a:extLst xmlns:a="http://schemas.openxmlformats.org/drawingml/2006/main">
               <a:ext uri="{FF2B5EF4-FFF2-40B4-BE49-F238E27FC236}">
-                <a16:creationId xmlns:a16="http://schemas.microsoft.com/office/drawing/2014/main" id="{E2A57AD8-4157-42C0-AB8B-E4A3DB2D39B5}"/>
+                <a16:creationId xmlns:a16="http://schemas.microsoft.com/office/drawing/2014/main" id="{21576D8E-A85E-4F52-AC53-923385F554C3}"/>
               </a:ext>
             </a:extLst>
           </p:cNvPr>
@@ -5015,7 +5015,7 @@
           <p:cNvPr id="2" name="">
             <a:extLst xmlns:a="http://schemas.openxmlformats.org/drawingml/2006/main">
               <a:ext uri="{FF2B5EF4-FFF2-40B4-BE49-F238E27FC236}">
-                <a16:creationId xmlns:a16="http://schemas.microsoft.com/office/drawing/2014/main" id="{863DD7DA-49DB-4910-AE50-EB81FDB674AB}"/>
+                <a16:creationId xmlns:a16="http://schemas.microsoft.com/office/drawing/2014/main" id="{955C9E3B-290C-4CA9-BC9D-D4A0A45A2F66}"/>
               </a:ext>
             </a:extLst>
           </p:cNvPr>
@@ -5083,7 +5083,7 @@
           <p:cNvPr id="3" name="">
             <a:extLst xmlns:a="http://schemas.openxmlformats.org/drawingml/2006/main">
               <a:ext uri="{FF2B5EF4-FFF2-40B4-BE49-F238E27FC236}">
-                <a16:creationId xmlns:a16="http://schemas.microsoft.com/office/drawing/2014/main" id="{81C3B088-4811-4A03-980C-AE4540220605}"/>
+                <a16:creationId xmlns:a16="http://schemas.microsoft.com/office/drawing/2014/main" id="{CA313B4D-105C-4242-994C-09327999E7BE}"/>
               </a:ext>
             </a:extLst>
           </p:cNvPr>
@@ -5093,13 +5093,13 @@
           <p:nvPr/>
         </p:nvPicPr>
         <p:blipFill>
-          <a:blip xmlns:r="http://schemas.openxmlformats.org/officeDocument/2006/relationships" xmlns:a="http://schemas.openxmlformats.org/drawingml/2006/main" r:embed="Rbcfbe249142f457d"/>
+          <a:blip xmlns:r="http://schemas.openxmlformats.org/officeDocument/2006/relationships" xmlns:a="http://schemas.openxmlformats.org/drawingml/2006/main" r:embed="Rbb2905966eed44b9"/>
           <a:stretch xmlns:a="http://schemas.openxmlformats.org/drawingml/2006/main"/>
         </p:blipFill>
         <p:spPr>
           <a:xfrm xmlns:a="http://schemas.openxmlformats.org/drawingml/2006/main">
-            <a:off x="1878478" y="2381250"/>
-            <a:ext cx="4720294" cy="4086225"/>
+            <a:off x="609600" y="2558007"/>
+            <a:ext cx="7258050" cy="3732711"/>
           </a:xfrm>
           <a:prstGeom xmlns:a="http://schemas.openxmlformats.org/drawingml/2006/main" prst="rect">
             <a:avLst/>
@@ -5111,7 +5111,7 @@
           <p:cNvPr id="4" name="">
             <a:extLst xmlns:a="http://schemas.openxmlformats.org/drawingml/2006/main">
               <a:ext uri="{FF2B5EF4-FFF2-40B4-BE49-F238E27FC236}">
-                <a16:creationId xmlns:a16="http://schemas.microsoft.com/office/drawing/2014/main" id="{D74885AA-FF43-4B40-91ED-C91AE09083A6}"/>
+                <a16:creationId xmlns:a16="http://schemas.microsoft.com/office/drawing/2014/main" id="{D70A8B49-0766-4D9D-9D09-CBFECEDB773C}"/>
               </a:ext>
             </a:extLst>
           </p:cNvPr>
@@ -5179,7 +5179,7 @@
           <p:cNvPr id="5" name="">
             <a:extLst xmlns:a="http://schemas.openxmlformats.org/drawingml/2006/main">
               <a:ext uri="{FF2B5EF4-FFF2-40B4-BE49-F238E27FC236}">
-                <a16:creationId xmlns:a16="http://schemas.microsoft.com/office/drawing/2014/main" id="{703CC82C-4D23-4E05-AD16-7EFB814E3080}"/>
+                <a16:creationId xmlns:a16="http://schemas.microsoft.com/office/drawing/2014/main" id="{F64B633F-E476-4BD4-B266-688F5DC6A545}"/>
               </a:ext>
             </a:extLst>
           </p:cNvPr>
@@ -5247,7 +5247,7 @@
           <p:cNvPr id="6" name="">
             <a:extLst xmlns:a="http://schemas.openxmlformats.org/drawingml/2006/main">
               <a:ext uri="{FF2B5EF4-FFF2-40B4-BE49-F238E27FC236}">
-                <a16:creationId xmlns:a16="http://schemas.microsoft.com/office/drawing/2014/main" id="{D3CA1DF0-BE10-4451-B2E1-19F702FA7792}"/>
+                <a16:creationId xmlns:a16="http://schemas.microsoft.com/office/drawing/2014/main" id="{B63A3976-653D-4106-9FDE-E4F147EF49B1}"/>
               </a:ext>
             </a:extLst>
           </p:cNvPr>
@@ -5315,7 +5315,7 @@
           <p:cNvPr id="7" name="">
             <a:extLst xmlns:a="http://schemas.openxmlformats.org/drawingml/2006/main">
               <a:ext uri="{FF2B5EF4-FFF2-40B4-BE49-F238E27FC236}">
-                <a16:creationId xmlns:a16="http://schemas.microsoft.com/office/drawing/2014/main" id="{2782C00B-A739-4FD6-84F0-5E14739787AA}"/>
+                <a16:creationId xmlns:a16="http://schemas.microsoft.com/office/drawing/2014/main" id="{5885F3E6-9A6C-449E-A59F-AB0B2993D1B0}"/>
               </a:ext>
             </a:extLst>
           </p:cNvPr>
@@ -5383,7 +5383,7 @@
           <p:cNvPr id="8" name="">
             <a:extLst xmlns:a="http://schemas.openxmlformats.org/drawingml/2006/main">
               <a:ext uri="{FF2B5EF4-FFF2-40B4-BE49-F238E27FC236}">
-                <a16:creationId xmlns:a16="http://schemas.microsoft.com/office/drawing/2014/main" id="{C3CE3E4B-887D-45AA-A32F-86DB68997734}"/>
+                <a16:creationId xmlns:a16="http://schemas.microsoft.com/office/drawing/2014/main" id="{672233D1-9E15-41E8-8B0C-7786A3A2E2D0}"/>
               </a:ext>
             </a:extLst>
           </p:cNvPr>
@@ -5449,7 +5449,7 @@
     </p:spTree>
     <p:extLst>
       <p:ext uri="{BB962C8B-B14F-4D97-AF65-F5344CB8AC3E}">
-        <p14:creationId xmlns:p14="http://schemas.microsoft.com/office/powerpoint/2010/main" val="527987045"/>
+        <p14:creationId xmlns:p14="http://schemas.microsoft.com/office/powerpoint/2010/main" val="874142571"/>
       </p:ext>
     </p:extLst>
   </p:cSld>
@@ -5480,7 +5480,7 @@
           <p:cNvPr id="8" name="">
             <a:extLst xmlns:a="http://schemas.openxmlformats.org/drawingml/2006/main">
               <a:ext uri="{FF2B5EF4-FFF2-40B4-BE49-F238E27FC236}">
-                <a16:creationId xmlns:a16="http://schemas.microsoft.com/office/drawing/2014/main" id="{21A993A1-3212-4B56-BF46-68E8EB1A1457}"/>
+                <a16:creationId xmlns:a16="http://schemas.microsoft.com/office/drawing/2014/main" id="{DEDC4C2F-2E3B-452E-9D65-77DA5CC2CEC4}"/>
               </a:ext>
             </a:extLst>
           </p:cNvPr>
@@ -5548,7 +5548,7 @@
           <p:cNvPr id="2" name="">
             <a:extLst xmlns:a="http://schemas.openxmlformats.org/drawingml/2006/main">
               <a:ext uri="{FF2B5EF4-FFF2-40B4-BE49-F238E27FC236}">
-                <a16:creationId xmlns:a16="http://schemas.microsoft.com/office/drawing/2014/main" id="{80164E3A-0F69-42D4-B86D-134EB42A84D9}"/>
+                <a16:creationId xmlns:a16="http://schemas.microsoft.com/office/drawing/2014/main" id="{CE8D26BD-BB78-4F80-8FE3-05DE9A2E21B8}"/>
               </a:ext>
             </a:extLst>
           </p:cNvPr>
@@ -5616,7 +5616,7 @@
           <p:cNvPr id="3" name="">
             <a:extLst xmlns:a="http://schemas.openxmlformats.org/drawingml/2006/main">
               <a:ext uri="{FF2B5EF4-FFF2-40B4-BE49-F238E27FC236}">
-                <a16:creationId xmlns:a16="http://schemas.microsoft.com/office/drawing/2014/main" id="{190CF976-AC29-445D-A93B-5CA8E53DC522}"/>
+                <a16:creationId xmlns:a16="http://schemas.microsoft.com/office/drawing/2014/main" id="{74952E9E-7D84-4367-9C70-C271CB7E37B6}"/>
               </a:ext>
             </a:extLst>
           </p:cNvPr>
@@ -5684,7 +5684,7 @@
           <p:cNvPr id="4" name="Chart">
             <a:extLst xmlns:a="http://schemas.openxmlformats.org/drawingml/2006/main">
               <a:ext uri="{FF2B5EF4-FFF2-40B4-BE49-F238E27FC236}">
-                <a16:creationId xmlns:a16="http://schemas.microsoft.com/office/drawing/2014/main" id="{2EB04BBD-BCFA-4E41-BDF3-5F03E05BA3E5}"/>
+                <a16:creationId xmlns:a16="http://schemas.microsoft.com/office/drawing/2014/main" id="{4F0960DD-604D-4BBE-A6D6-612732239C26}"/>
               </a:ext>
             </a:extLst>
           </p:cNvPr>
@@ -5697,7 +5697,7 @@
         </p:xfrm>
         <a:graphic xmlns:a="http://schemas.openxmlformats.org/drawingml/2006/main">
           <a:graphicData uri="http://schemas.openxmlformats.org/drawingml/2006/chart">
-            <c:chart xmlns:r="http://schemas.openxmlformats.org/officeDocument/2006/relationships" xmlns:c="http://schemas.openxmlformats.org/drawingml/2006/chart" r:id="Rbee1f8f135e34072"/>
+            <c:chart xmlns:r="http://schemas.openxmlformats.org/officeDocument/2006/relationships" xmlns:c="http://schemas.openxmlformats.org/drawingml/2006/chart" r:id="R093850bba7d14aa5"/>
           </a:graphicData>
         </a:graphic>
       </p:graphicFrame>
@@ -5706,7 +5706,7 @@
           <p:cNvPr id="5" name="">
             <a:extLst xmlns:a="http://schemas.openxmlformats.org/drawingml/2006/main">
               <a:ext uri="{FF2B5EF4-FFF2-40B4-BE49-F238E27FC236}">
-                <a16:creationId xmlns:a16="http://schemas.microsoft.com/office/drawing/2014/main" id="{887BF657-EADC-4EA5-813D-62D45DFE3930}"/>
+                <a16:creationId xmlns:a16="http://schemas.microsoft.com/office/drawing/2014/main" id="{8DB78D98-B65F-4041-9BC9-06A2553B4E8F}"/>
               </a:ext>
             </a:extLst>
           </p:cNvPr>
@@ -5774,7 +5774,7 @@
           <p:cNvPr id="6" name="">
             <a:extLst xmlns:a="http://schemas.openxmlformats.org/drawingml/2006/main">
               <a:ext uri="{FF2B5EF4-FFF2-40B4-BE49-F238E27FC236}">
-                <a16:creationId xmlns:a16="http://schemas.microsoft.com/office/drawing/2014/main" id="{984EB732-139C-47B3-99F5-E7DB8F02CED5}"/>
+                <a16:creationId xmlns:a16="http://schemas.microsoft.com/office/drawing/2014/main" id="{CA890856-B246-49D4-9D61-8E75D7359CAF}"/>
               </a:ext>
             </a:extLst>
           </p:cNvPr>
@@ -5842,7 +5842,7 @@
           <p:cNvPr id="7" name="">
             <a:extLst xmlns:a="http://schemas.openxmlformats.org/drawingml/2006/main">
               <a:ext uri="{FF2B5EF4-FFF2-40B4-BE49-F238E27FC236}">
-                <a16:creationId xmlns:a16="http://schemas.microsoft.com/office/drawing/2014/main" id="{3171493D-7871-4AFB-8710-F75903DEF053}"/>
+                <a16:creationId xmlns:a16="http://schemas.microsoft.com/office/drawing/2014/main" id="{09CB1569-53D6-4087-B81B-B2E33DFF4915}"/>
               </a:ext>
             </a:extLst>
           </p:cNvPr>
@@ -5908,7 +5908,7 @@
     </p:spTree>
     <p:extLst>
       <p:ext uri="{BB962C8B-B14F-4D97-AF65-F5344CB8AC3E}">
-        <p14:creationId xmlns:p14="http://schemas.microsoft.com/office/powerpoint/2010/main" val="414453839"/>
+        <p14:creationId xmlns:p14="http://schemas.microsoft.com/office/powerpoint/2010/main" val="1794705531"/>
       </p:ext>
     </p:extLst>
   </p:cSld>
@@ -5939,7 +5939,7 @@
           <p:cNvPr id="4" name="">
             <a:extLst xmlns:a="http://schemas.openxmlformats.org/drawingml/2006/main">
               <a:ext uri="{FF2B5EF4-FFF2-40B4-BE49-F238E27FC236}">
-                <a16:creationId xmlns:a16="http://schemas.microsoft.com/office/drawing/2014/main" id="{5AEE1F4F-04D2-4CF8-8F5E-BF4204C85C7F}"/>
+                <a16:creationId xmlns:a16="http://schemas.microsoft.com/office/drawing/2014/main" id="{920241F1-1808-4A9A-909D-FEDD16F51114}"/>
               </a:ext>
             </a:extLst>
           </p:cNvPr>
@@ -6007,7 +6007,7 @@
           <p:cNvPr id="2" name="">
             <a:extLst xmlns:a="http://schemas.openxmlformats.org/drawingml/2006/main">
               <a:ext uri="{FF2B5EF4-FFF2-40B4-BE49-F238E27FC236}">
-                <a16:creationId xmlns:a16="http://schemas.microsoft.com/office/drawing/2014/main" id="{1C0958F2-C633-444B-A29E-781C43CD6B4A}"/>
+                <a16:creationId xmlns:a16="http://schemas.microsoft.com/office/drawing/2014/main" id="{E3257B85-6B9F-4646-8FCB-54B149EBFA88}"/>
               </a:ext>
             </a:extLst>
           </p:cNvPr>
@@ -6359,7 +6359,7 @@
           <p:cNvPr id="3" name="">
             <a:extLst xmlns:a="http://schemas.openxmlformats.org/drawingml/2006/main">
               <a:ext uri="{FF2B5EF4-FFF2-40B4-BE49-F238E27FC236}">
-                <a16:creationId xmlns:a16="http://schemas.microsoft.com/office/drawing/2014/main" id="{4D52E606-4866-4FE3-9F8D-9F0860862A20}"/>
+                <a16:creationId xmlns:a16="http://schemas.microsoft.com/office/drawing/2014/main" id="{961DB3FB-20D6-4097-878C-33EC7ED294DE}"/>
               </a:ext>
             </a:extLst>
           </p:cNvPr>
@@ -6425,7 +6425,7 @@
     </p:spTree>
     <p:extLst>
       <p:ext uri="{BB962C8B-B14F-4D97-AF65-F5344CB8AC3E}">
-        <p14:creationId xmlns:p14="http://schemas.microsoft.com/office/powerpoint/2010/main" val="1857045714"/>
+        <p14:creationId xmlns:p14="http://schemas.microsoft.com/office/powerpoint/2010/main" val="1815321188"/>
       </p:ext>
     </p:extLst>
   </p:cSld>
@@ -6456,7 +6456,7 @@
           <p:cNvPr id="4" name="">
             <a:extLst xmlns:a="http://schemas.openxmlformats.org/drawingml/2006/main">
               <a:ext uri="{FF2B5EF4-FFF2-40B4-BE49-F238E27FC236}">
-                <a16:creationId xmlns:a16="http://schemas.microsoft.com/office/drawing/2014/main" id="{AD5A4570-2A8A-4FFF-986F-F74B07AE3108}"/>
+                <a16:creationId xmlns:a16="http://schemas.microsoft.com/office/drawing/2014/main" id="{312E37A7-7494-4BCD-A8DE-7F82A546F9FE}"/>
               </a:ext>
             </a:extLst>
           </p:cNvPr>
@@ -6524,7 +6524,7 @@
           <p:cNvPr id="2" name="">
             <a:extLst xmlns:a="http://schemas.openxmlformats.org/drawingml/2006/main">
               <a:ext uri="{FF2B5EF4-FFF2-40B4-BE49-F238E27FC236}">
-                <a16:creationId xmlns:a16="http://schemas.microsoft.com/office/drawing/2014/main" id="{5D0931D9-2C51-4C38-867C-FE7FE9FD2261}"/>
+                <a16:creationId xmlns:a16="http://schemas.microsoft.com/office/drawing/2014/main" id="{1A22BDAA-4BE9-4E03-A8C7-0B2479E39887}"/>
               </a:ext>
             </a:extLst>
           </p:cNvPr>
@@ -6802,7 +6802,7 @@
                           <a:ea typeface="Arial"/>
                           <a:cs typeface="Arial"/>
                         </a:rPr>
-                        <a:t>Existing Profiles metadata carries a proposed complete publication summary, including unloaded and retained variant content.</a:t>
+                        <a:t>Profiles records complete publication coverage, including unloaded and retained variant content. Fixed v1 identities remain proposed.</a:t>
                       </a:r>
                     </a:p>
                   </a:txBody>
@@ -6876,7 +6876,7 @@
           <p:cNvPr id="3" name="">
             <a:extLst xmlns:a="http://schemas.openxmlformats.org/drawingml/2006/main">
               <a:ext uri="{FF2B5EF4-FFF2-40B4-BE49-F238E27FC236}">
-                <a16:creationId xmlns:a16="http://schemas.microsoft.com/office/drawing/2014/main" id="{51F5CC13-A329-4AE2-B061-85B813B28F86}"/>
+                <a16:creationId xmlns:a16="http://schemas.microsoft.com/office/drawing/2014/main" id="{31C5A975-ABB4-43A4-9A96-ECC204B30242}"/>
               </a:ext>
             </a:extLst>
           </p:cNvPr>
@@ -6942,7 +6942,7 @@
     </p:spTree>
     <p:extLst>
       <p:ext uri="{BB962C8B-B14F-4D97-AF65-F5344CB8AC3E}">
-        <p14:creationId xmlns:p14="http://schemas.microsoft.com/office/powerpoint/2010/main" val="1660350761"/>
+        <p14:creationId xmlns:p14="http://schemas.microsoft.com/office/powerpoint/2010/main" val="1549565108"/>
       </p:ext>
     </p:extLst>
   </p:cSld>
@@ -6973,7 +6973,7 @@
           <p:cNvPr id="4" name="">
             <a:extLst xmlns:a="http://schemas.openxmlformats.org/drawingml/2006/main">
               <a:ext uri="{FF2B5EF4-FFF2-40B4-BE49-F238E27FC236}">
-                <a16:creationId xmlns:a16="http://schemas.microsoft.com/office/drawing/2014/main" id="{FDEE6995-B652-4DEF-A1F3-04D33433421E}"/>
+                <a16:creationId xmlns:a16="http://schemas.microsoft.com/office/drawing/2014/main" id="{555D9875-C5AF-4193-916D-BB44F21F7B98}"/>
               </a:ext>
             </a:extLst>
           </p:cNvPr>
@@ -7041,7 +7041,7 @@
           <p:cNvPr id="2" name="">
             <a:extLst xmlns:a="http://schemas.openxmlformats.org/drawingml/2006/main">
               <a:ext uri="{FF2B5EF4-FFF2-40B4-BE49-F238E27FC236}">
-                <a16:creationId xmlns:a16="http://schemas.microsoft.com/office/drawing/2014/main" id="{10E54460-6455-4244-B983-9FA9E4E4BAF1}"/>
+                <a16:creationId xmlns:a16="http://schemas.microsoft.com/office/drawing/2014/main" id="{12288FC7-72B0-4232-A16C-945EAD6C75E0}"/>
               </a:ext>
             </a:extLst>
           </p:cNvPr>
@@ -7319,7 +7319,7 @@
                           <a:ea typeface="Arial"/>
                           <a:cs typeface="Arial"/>
                         </a:rPr>
-                        <a:t>113 contract tests and 65 distinguishing controls pass. Separate diagnostics expose the reported prototype limits.</a:t>
+                        <a:t>116 contract tests and 65 distinguishing controls pass. Separate diagnostics expose the reported prototype limits.</a:t>
                       </a:r>
                     </a:p>
                   </a:txBody>
@@ -7373,7 +7373,7 @@
                           <a:ea typeface="Arial"/>
                           <a:cs typeface="Arial"/>
                         </a:rPr>
-                        <a:t>Original inputs and 47 frozen execution files remain unchanged. The immutable receipt identifies exact executed content.</a:t>
+                        <a:t>Original inputs and 48 frozen execution files remain unchanged. The immutable receipt identifies exact executed content.</a:t>
                       </a:r>
                     </a:p>
                   </a:txBody>
@@ -7447,7 +7447,7 @@
           <p:cNvPr id="3" name="">
             <a:extLst xmlns:a="http://schemas.openxmlformats.org/drawingml/2006/main">
               <a:ext uri="{FF2B5EF4-FFF2-40B4-BE49-F238E27FC236}">
-                <a16:creationId xmlns:a16="http://schemas.microsoft.com/office/drawing/2014/main" id="{5ED00BD9-6875-4086-94C8-6014393951D7}"/>
+                <a16:creationId xmlns:a16="http://schemas.microsoft.com/office/drawing/2014/main" id="{4B4A559A-92E5-4D78-A00A-88CE65BFB08B}"/>
               </a:ext>
             </a:extLst>
           </p:cNvPr>
@@ -7513,7 +7513,7 @@
     </p:spTree>
     <p:extLst>
       <p:ext uri="{BB962C8B-B14F-4D97-AF65-F5344CB8AC3E}">
-        <p14:creationId xmlns:p14="http://schemas.microsoft.com/office/powerpoint/2010/main" val="997950830"/>
+        <p14:creationId xmlns:p14="http://schemas.microsoft.com/office/powerpoint/2010/main" val="1772005043"/>
       </p:ext>
     </p:extLst>
   </p:cSld>
@@ -7544,7 +7544,7 @@
           <p:cNvPr id="5" name="">
             <a:extLst xmlns:a="http://schemas.openxmlformats.org/drawingml/2006/main">
               <a:ext uri="{FF2B5EF4-FFF2-40B4-BE49-F238E27FC236}">
-                <a16:creationId xmlns:a16="http://schemas.microsoft.com/office/drawing/2014/main" id="{F2563E96-B631-492D-B075-820434AD974C}"/>
+                <a16:creationId xmlns:a16="http://schemas.microsoft.com/office/drawing/2014/main" id="{5BB62EBF-86D1-461E-845E-766AC9273C9D}"/>
               </a:ext>
             </a:extLst>
           </p:cNvPr>
@@ -7612,7 +7612,7 @@
           <p:cNvPr id="2" name="">
             <a:extLst xmlns:a="http://schemas.openxmlformats.org/drawingml/2006/main">
               <a:ext uri="{FF2B5EF4-FFF2-40B4-BE49-F238E27FC236}">
-                <a16:creationId xmlns:a16="http://schemas.microsoft.com/office/drawing/2014/main" id="{971577B2-44C9-43F8-BF1F-2D1E4E8B0D62}"/>
+                <a16:creationId xmlns:a16="http://schemas.microsoft.com/office/drawing/2014/main" id="{3B466CE3-F485-4981-9427-653B21AEDAFC}"/>
               </a:ext>
             </a:extLst>
           </p:cNvPr>
@@ -7680,7 +7680,7 @@
           <p:cNvPr id="3" name="">
             <a:extLst xmlns:a="http://schemas.openxmlformats.org/drawingml/2006/main">
               <a:ext uri="{FF2B5EF4-FFF2-40B4-BE49-F238E27FC236}">
-                <a16:creationId xmlns:a16="http://schemas.microsoft.com/office/drawing/2014/main" id="{D630B73E-B318-4CE3-9A99-4E363F244FBD}"/>
+                <a16:creationId xmlns:a16="http://schemas.microsoft.com/office/drawing/2014/main" id="{8349BCFA-108D-4D3C-B92F-3A1D4F35676D}"/>
               </a:ext>
             </a:extLst>
           </p:cNvPr>
@@ -7978,7 +7978,7 @@
           <p:cNvPr id="4" name="">
             <a:extLst xmlns:a="http://schemas.openxmlformats.org/drawingml/2006/main">
               <a:ext uri="{FF2B5EF4-FFF2-40B4-BE49-F238E27FC236}">
-                <a16:creationId xmlns:a16="http://schemas.microsoft.com/office/drawing/2014/main" id="{B93FA8A3-55ED-47CA-BC92-C16865E532E8}"/>
+                <a16:creationId xmlns:a16="http://schemas.microsoft.com/office/drawing/2014/main" id="{CAE02E76-AD85-475E-BE5A-0E9F7983BE90}"/>
               </a:ext>
             </a:extLst>
           </p:cNvPr>
@@ -8044,7 +8044,7 @@
     </p:spTree>
     <p:extLst>
       <p:ext uri="{BB962C8B-B14F-4D97-AF65-F5344CB8AC3E}">
-        <p14:creationId xmlns:p14="http://schemas.microsoft.com/office/powerpoint/2010/main" val="695027163"/>
+        <p14:creationId xmlns:p14="http://schemas.microsoft.com/office/powerpoint/2010/main" val="418793482"/>
       </p:ext>
     </p:extLst>
   </p:cSld>
@@ -8075,7 +8075,7 @@
           <p:cNvPr id="9" name="">
             <a:extLst xmlns:a="http://schemas.openxmlformats.org/drawingml/2006/main">
               <a:ext uri="{FF2B5EF4-FFF2-40B4-BE49-F238E27FC236}">
-                <a16:creationId xmlns:a16="http://schemas.microsoft.com/office/drawing/2014/main" id="{AA538F70-E80B-4B96-9F9A-1242D76F5EF1}"/>
+                <a16:creationId xmlns:a16="http://schemas.microsoft.com/office/drawing/2014/main" id="{E71A9758-A673-47E7-9054-AE43FA4A5C5C}"/>
               </a:ext>
             </a:extLst>
           </p:cNvPr>
@@ -8143,7 +8143,7 @@
           <p:cNvPr id="2" name="">
             <a:extLst xmlns:a="http://schemas.openxmlformats.org/drawingml/2006/main">
               <a:ext uri="{FF2B5EF4-FFF2-40B4-BE49-F238E27FC236}">
-                <a16:creationId xmlns:a16="http://schemas.microsoft.com/office/drawing/2014/main" id="{90CC91A2-A414-4E2B-A5EC-7792B46C0913}"/>
+                <a16:creationId xmlns:a16="http://schemas.microsoft.com/office/drawing/2014/main" id="{BD194932-34D2-4D3E-8E31-692EC3E7F47C}"/>
               </a:ext>
             </a:extLst>
           </p:cNvPr>
@@ -8211,7 +8211,7 @@
           <p:cNvPr id="3" name="">
             <a:extLst xmlns:a="http://schemas.openxmlformats.org/drawingml/2006/main">
               <a:ext uri="{FF2B5EF4-FFF2-40B4-BE49-F238E27FC236}">
-                <a16:creationId xmlns:a16="http://schemas.microsoft.com/office/drawing/2014/main" id="{C3246415-A39C-44F5-A383-0BD61C39C245}"/>
+                <a16:creationId xmlns:a16="http://schemas.microsoft.com/office/drawing/2014/main" id="{10FF5315-CE04-4EE0-9AB8-48A0D1FE9073}"/>
               </a:ext>
             </a:extLst>
           </p:cNvPr>
@@ -8221,7 +8221,7 @@
           <p:nvPr/>
         </p:nvPicPr>
         <p:blipFill>
-          <a:blip xmlns:r="http://schemas.openxmlformats.org/officeDocument/2006/relationships" xmlns:a="http://schemas.openxmlformats.org/drawingml/2006/main" r:embed="Ra928073ddee345e5"/>
+          <a:blip xmlns:r="http://schemas.openxmlformats.org/officeDocument/2006/relationships" xmlns:a="http://schemas.openxmlformats.org/drawingml/2006/main" r:embed="R5d40dfcef7ba4a49"/>
           <a:srcRect xmlns:a="http://schemas.openxmlformats.org/drawingml/2006/main" l="0" t="8974" r="0" b="33333"/>
           <a:stretch xmlns:a="http://schemas.openxmlformats.org/drawingml/2006/main"/>
         </p:blipFill>
@@ -8240,7 +8240,7 @@
           <p:cNvPr id="4" name="">
             <a:extLst xmlns:a="http://schemas.openxmlformats.org/drawingml/2006/main">
               <a:ext uri="{FF2B5EF4-FFF2-40B4-BE49-F238E27FC236}">
-                <a16:creationId xmlns:a16="http://schemas.microsoft.com/office/drawing/2014/main" id="{9EF8916F-EC4F-4874-98A9-D96A03344BE9}"/>
+                <a16:creationId xmlns:a16="http://schemas.microsoft.com/office/drawing/2014/main" id="{FFCFDC51-546D-41E5-95CD-1D76B84DD0E4}"/>
               </a:ext>
             </a:extLst>
           </p:cNvPr>
@@ -8308,7 +8308,7 @@
           <p:cNvPr id="5" name="">
             <a:extLst xmlns:a="http://schemas.openxmlformats.org/drawingml/2006/main">
               <a:ext uri="{FF2B5EF4-FFF2-40B4-BE49-F238E27FC236}">
-                <a16:creationId xmlns:a16="http://schemas.microsoft.com/office/drawing/2014/main" id="{7DACD6EA-F297-4A7C-8E2B-F14B6AFC7719}"/>
+                <a16:creationId xmlns:a16="http://schemas.microsoft.com/office/drawing/2014/main" id="{E8DBDD50-E9CD-4807-BCDD-107588235560}"/>
               </a:ext>
             </a:extLst>
           </p:cNvPr>
@@ -8376,7 +8376,7 @@
           <p:cNvPr id="6" name="">
             <a:extLst xmlns:a="http://schemas.openxmlformats.org/drawingml/2006/main">
               <a:ext uri="{FF2B5EF4-FFF2-40B4-BE49-F238E27FC236}">
-                <a16:creationId xmlns:a16="http://schemas.microsoft.com/office/drawing/2014/main" id="{DA0A6CF3-8317-4319-A170-2D9AB68E767D}"/>
+                <a16:creationId xmlns:a16="http://schemas.microsoft.com/office/drawing/2014/main" id="{7BD8DBE3-D7E6-45FA-8975-69B8C597FD9E}"/>
               </a:ext>
             </a:extLst>
           </p:cNvPr>
@@ -8444,7 +8444,7 @@
           <p:cNvPr id="7" name="">
             <a:extLst xmlns:a="http://schemas.openxmlformats.org/drawingml/2006/main">
               <a:ext uri="{FF2B5EF4-FFF2-40B4-BE49-F238E27FC236}">
-                <a16:creationId xmlns:a16="http://schemas.microsoft.com/office/drawing/2014/main" id="{1B1AA1B6-0BD9-4F1D-86AC-896F6CE2BDEA}"/>
+                <a16:creationId xmlns:a16="http://schemas.microsoft.com/office/drawing/2014/main" id="{F8735F64-E0FF-4626-BC67-E66014305142}"/>
               </a:ext>
             </a:extLst>
           </p:cNvPr>
@@ -8512,7 +8512,7 @@
           <p:cNvPr id="8" name="">
             <a:extLst xmlns:a="http://schemas.openxmlformats.org/drawingml/2006/main">
               <a:ext uri="{FF2B5EF4-FFF2-40B4-BE49-F238E27FC236}">
-                <a16:creationId xmlns:a16="http://schemas.microsoft.com/office/drawing/2014/main" id="{116FADAE-106C-446B-BACE-17D4152E4E66}"/>
+                <a16:creationId xmlns:a16="http://schemas.microsoft.com/office/drawing/2014/main" id="{28DA9AA7-B881-4BD5-BFFB-63AC10D7F2F1}"/>
               </a:ext>
             </a:extLst>
           </p:cNvPr>
@@ -8578,7 +8578,7 @@
     </p:spTree>
     <p:extLst>
       <p:ext uri="{BB962C8B-B14F-4D97-AF65-F5344CB8AC3E}">
-        <p14:creationId xmlns:p14="http://schemas.microsoft.com/office/powerpoint/2010/main" val="276423842"/>
+        <p14:creationId xmlns:p14="http://schemas.microsoft.com/office/powerpoint/2010/main" val="1437884512"/>
       </p:ext>
     </p:extLst>
   </p:cSld>
@@ -8609,7 +8609,7 @@
           <p:cNvPr id="9" name="">
             <a:extLst xmlns:a="http://schemas.openxmlformats.org/drawingml/2006/main">
               <a:ext uri="{FF2B5EF4-FFF2-40B4-BE49-F238E27FC236}">
-                <a16:creationId xmlns:a16="http://schemas.microsoft.com/office/drawing/2014/main" id="{1044AEC2-AE82-4FFB-AA65-5B19302B07A4}"/>
+                <a16:creationId xmlns:a16="http://schemas.microsoft.com/office/drawing/2014/main" id="{ADBC29F6-6DAE-4CF9-8AEF-A65797364C68}"/>
               </a:ext>
             </a:extLst>
           </p:cNvPr>
@@ -8677,7 +8677,7 @@
           <p:cNvPr id="2" name="">
             <a:extLst xmlns:a="http://schemas.openxmlformats.org/drawingml/2006/main">
               <a:ext uri="{FF2B5EF4-FFF2-40B4-BE49-F238E27FC236}">
-                <a16:creationId xmlns:a16="http://schemas.microsoft.com/office/drawing/2014/main" id="{CA0F4658-6741-4B98-B4B0-8AFAA7C1058D}"/>
+                <a16:creationId xmlns:a16="http://schemas.microsoft.com/office/drawing/2014/main" id="{5001E4A8-1BC3-4991-8088-1785B32FAED7}"/>
               </a:ext>
             </a:extLst>
           </p:cNvPr>
@@ -8745,7 +8745,7 @@
           <p:cNvPr id="3" name="">
             <a:extLst xmlns:a="http://schemas.openxmlformats.org/drawingml/2006/main">
               <a:ext uri="{FF2B5EF4-FFF2-40B4-BE49-F238E27FC236}">
-                <a16:creationId xmlns:a16="http://schemas.microsoft.com/office/drawing/2014/main" id="{012343D7-7670-468B-A4AB-C3FB25F18E4D}"/>
+                <a16:creationId xmlns:a16="http://schemas.microsoft.com/office/drawing/2014/main" id="{1AE72C8F-C62D-4BBD-8A14-6579E6F16B66}"/>
               </a:ext>
             </a:extLst>
           </p:cNvPr>
@@ -8755,7 +8755,7 @@
           <p:nvPr/>
         </p:nvPicPr>
         <p:blipFill>
-          <a:blip xmlns:r="http://schemas.openxmlformats.org/officeDocument/2006/relationships" xmlns:a="http://schemas.openxmlformats.org/drawingml/2006/main" r:embed="Rcd7626631d0342b1"/>
+          <a:blip xmlns:r="http://schemas.openxmlformats.org/officeDocument/2006/relationships" xmlns:a="http://schemas.openxmlformats.org/drawingml/2006/main" r:embed="R06f13d1dff514f79"/>
           <a:srcRect xmlns:a="http://schemas.openxmlformats.org/drawingml/2006/main" l="0" t="8974" r="0" b="33333"/>
           <a:stretch xmlns:a="http://schemas.openxmlformats.org/drawingml/2006/main"/>
         </p:blipFill>
@@ -8774,7 +8774,7 @@
           <p:cNvPr id="4" name="">
             <a:extLst xmlns:a="http://schemas.openxmlformats.org/drawingml/2006/main">
               <a:ext uri="{FF2B5EF4-FFF2-40B4-BE49-F238E27FC236}">
-                <a16:creationId xmlns:a16="http://schemas.microsoft.com/office/drawing/2014/main" id="{58D9335E-DEBC-43DF-B88E-D28A995F412D}"/>
+                <a16:creationId xmlns:a16="http://schemas.microsoft.com/office/drawing/2014/main" id="{DA825AA8-6511-4430-B817-A3E443D17E21}"/>
               </a:ext>
             </a:extLst>
           </p:cNvPr>
@@ -8842,7 +8842,7 @@
           <p:cNvPr id="5" name="">
             <a:extLst xmlns:a="http://schemas.openxmlformats.org/drawingml/2006/main">
               <a:ext uri="{FF2B5EF4-FFF2-40B4-BE49-F238E27FC236}">
-                <a16:creationId xmlns:a16="http://schemas.microsoft.com/office/drawing/2014/main" id="{06D2041B-4ABB-45B2-A164-4859502D7502}"/>
+                <a16:creationId xmlns:a16="http://schemas.microsoft.com/office/drawing/2014/main" id="{4B8C664C-E461-4731-92E0-62370CF23F0F}"/>
               </a:ext>
             </a:extLst>
           </p:cNvPr>
@@ -8910,7 +8910,7 @@
           <p:cNvPr id="6" name="">
             <a:extLst xmlns:a="http://schemas.openxmlformats.org/drawingml/2006/main">
               <a:ext uri="{FF2B5EF4-FFF2-40B4-BE49-F238E27FC236}">
-                <a16:creationId xmlns:a16="http://schemas.microsoft.com/office/drawing/2014/main" id="{F97E94B4-EDA8-4BDF-A4A2-AF5D9315AD99}"/>
+                <a16:creationId xmlns:a16="http://schemas.microsoft.com/office/drawing/2014/main" id="{F05EAB3B-2642-4440-B776-C5F5CC71F62E}"/>
               </a:ext>
             </a:extLst>
           </p:cNvPr>
@@ -8978,7 +8978,7 @@
           <p:cNvPr id="7" name="">
             <a:extLst xmlns:a="http://schemas.openxmlformats.org/drawingml/2006/main">
               <a:ext uri="{FF2B5EF4-FFF2-40B4-BE49-F238E27FC236}">
-                <a16:creationId xmlns:a16="http://schemas.microsoft.com/office/drawing/2014/main" id="{B17A1579-D4C1-493D-A9AA-2EAD1A39BD32}"/>
+                <a16:creationId xmlns:a16="http://schemas.microsoft.com/office/drawing/2014/main" id="{9EF9DA61-5C26-4503-AFB9-543E9F729167}"/>
               </a:ext>
             </a:extLst>
           </p:cNvPr>
@@ -9046,7 +9046,7 @@
           <p:cNvPr id="8" name="">
             <a:extLst xmlns:a="http://schemas.openxmlformats.org/drawingml/2006/main">
               <a:ext uri="{FF2B5EF4-FFF2-40B4-BE49-F238E27FC236}">
-                <a16:creationId xmlns:a16="http://schemas.microsoft.com/office/drawing/2014/main" id="{CE622457-F0F0-4574-B89D-7C86C78ACB9A}"/>
+                <a16:creationId xmlns:a16="http://schemas.microsoft.com/office/drawing/2014/main" id="{FE969F74-096C-4971-94F7-1D6B7F0FE25D}"/>
               </a:ext>
             </a:extLst>
           </p:cNvPr>
@@ -9112,7 +9112,7 @@
     </p:spTree>
     <p:extLst>
       <p:ext uri="{BB962C8B-B14F-4D97-AF65-F5344CB8AC3E}">
-        <p14:creationId xmlns:p14="http://schemas.microsoft.com/office/powerpoint/2010/main" val="1010929930"/>
+        <p14:creationId xmlns:p14="http://schemas.microsoft.com/office/powerpoint/2010/main" val="252688260"/>
       </p:ext>
     </p:extLst>
   </p:cSld>
@@ -9143,7 +9143,7 @@
           <p:cNvPr id="8" name="">
             <a:extLst xmlns:a="http://schemas.openxmlformats.org/drawingml/2006/main">
               <a:ext uri="{FF2B5EF4-FFF2-40B4-BE49-F238E27FC236}">
-                <a16:creationId xmlns:a16="http://schemas.microsoft.com/office/drawing/2014/main" id="{D045D77E-F59F-4437-A984-6F5FF38B660E}"/>
+                <a16:creationId xmlns:a16="http://schemas.microsoft.com/office/drawing/2014/main" id="{A31EF2DB-179A-4FB8-BF45-30B4468E39EA}"/>
               </a:ext>
             </a:extLst>
           </p:cNvPr>
@@ -9211,7 +9211,7 @@
           <p:cNvPr id="2" name="">
             <a:extLst xmlns:a="http://schemas.openxmlformats.org/drawingml/2006/main">
               <a:ext uri="{FF2B5EF4-FFF2-40B4-BE49-F238E27FC236}">
-                <a16:creationId xmlns:a16="http://schemas.microsoft.com/office/drawing/2014/main" id="{A45A709A-DA2E-4403-93F2-1072E87DD216}"/>
+                <a16:creationId xmlns:a16="http://schemas.microsoft.com/office/drawing/2014/main" id="{8BFFB91F-0614-412F-967F-D7C27EDB57EE}"/>
               </a:ext>
             </a:extLst>
           </p:cNvPr>
@@ -9279,7 +9279,7 @@
           <p:cNvPr id="3" name="">
             <a:extLst xmlns:a="http://schemas.openxmlformats.org/drawingml/2006/main">
               <a:ext uri="{FF2B5EF4-FFF2-40B4-BE49-F238E27FC236}">
-                <a16:creationId xmlns:a16="http://schemas.microsoft.com/office/drawing/2014/main" id="{C3EF841E-E312-4512-8B20-E674549C7918}"/>
+                <a16:creationId xmlns:a16="http://schemas.microsoft.com/office/drawing/2014/main" id="{86CF5164-009F-4392-8B3D-DECCBBCDD787}"/>
               </a:ext>
             </a:extLst>
           </p:cNvPr>
@@ -9347,7 +9347,7 @@
           <p:cNvPr id="4" name="">
             <a:extLst xmlns:a="http://schemas.openxmlformats.org/drawingml/2006/main">
               <a:ext uri="{FF2B5EF4-FFF2-40B4-BE49-F238E27FC236}">
-                <a16:creationId xmlns:a16="http://schemas.microsoft.com/office/drawing/2014/main" id="{FC8CD0AC-CA4B-4A25-A863-CFBE6141274E}"/>
+                <a16:creationId xmlns:a16="http://schemas.microsoft.com/office/drawing/2014/main" id="{099C4F64-843E-4DE2-A77D-69BDA46D82E5}"/>
               </a:ext>
             </a:extLst>
           </p:cNvPr>
@@ -9696,7 +9696,7 @@
           <p:cNvPr id="5" name="">
             <a:extLst xmlns:a="http://schemas.openxmlformats.org/drawingml/2006/main">
               <a:ext uri="{FF2B5EF4-FFF2-40B4-BE49-F238E27FC236}">
-                <a16:creationId xmlns:a16="http://schemas.microsoft.com/office/drawing/2014/main" id="{421C0DC1-FC45-46B2-9CC6-002D57A24453}"/>
+                <a16:creationId xmlns:a16="http://schemas.microsoft.com/office/drawing/2014/main" id="{AE311E57-A9D5-408D-8B35-9A868920DE4F}"/>
               </a:ext>
             </a:extLst>
           </p:cNvPr>
@@ -9764,7 +9764,7 @@
           <p:cNvPr id="6" name="">
             <a:extLst xmlns:a="http://schemas.openxmlformats.org/drawingml/2006/main">
               <a:ext uri="{FF2B5EF4-FFF2-40B4-BE49-F238E27FC236}">
-                <a16:creationId xmlns:a16="http://schemas.microsoft.com/office/drawing/2014/main" id="{57103520-77DE-444C-9E7A-0C15DC85337B}"/>
+                <a16:creationId xmlns:a16="http://schemas.microsoft.com/office/drawing/2014/main" id="{E1408FA4-F2F2-47FD-860B-548B124721C5}"/>
               </a:ext>
             </a:extLst>
           </p:cNvPr>
@@ -10113,7 +10113,7 @@
           <p:cNvPr id="7" name="">
             <a:extLst xmlns:a="http://schemas.openxmlformats.org/drawingml/2006/main">
               <a:ext uri="{FF2B5EF4-FFF2-40B4-BE49-F238E27FC236}">
-                <a16:creationId xmlns:a16="http://schemas.microsoft.com/office/drawing/2014/main" id="{5BEFB72E-6138-4960-9BB3-B47CADEFC067}"/>
+                <a16:creationId xmlns:a16="http://schemas.microsoft.com/office/drawing/2014/main" id="{9FD073C2-EDD9-4680-98D2-950597240A8A}"/>
               </a:ext>
             </a:extLst>
           </p:cNvPr>
@@ -10179,7 +10179,7 @@
     </p:spTree>
     <p:extLst>
       <p:ext uri="{BB962C8B-B14F-4D97-AF65-F5344CB8AC3E}">
-        <p14:creationId xmlns:p14="http://schemas.microsoft.com/office/powerpoint/2010/main" val="701503755"/>
+        <p14:creationId xmlns:p14="http://schemas.microsoft.com/office/powerpoint/2010/main" val="1569226765"/>
       </p:ext>
     </p:extLst>
   </p:cSld>
@@ -10210,7 +10210,7 @@
           <p:cNvPr id="9" name="">
             <a:extLst xmlns:a="http://schemas.openxmlformats.org/drawingml/2006/main">
               <a:ext uri="{FF2B5EF4-FFF2-40B4-BE49-F238E27FC236}">
-                <a16:creationId xmlns:a16="http://schemas.microsoft.com/office/drawing/2014/main" id="{FA47CCB9-E97A-4603-B8A5-546BE065D233}"/>
+                <a16:creationId xmlns:a16="http://schemas.microsoft.com/office/drawing/2014/main" id="{5F4C22E2-CFC5-4C08-A60E-3FC375186EF4}"/>
               </a:ext>
             </a:extLst>
           </p:cNvPr>
@@ -10278,7 +10278,7 @@
           <p:cNvPr id="2" name="">
             <a:extLst xmlns:a="http://schemas.openxmlformats.org/drawingml/2006/main">
               <a:ext uri="{FF2B5EF4-FFF2-40B4-BE49-F238E27FC236}">
-                <a16:creationId xmlns:a16="http://schemas.microsoft.com/office/drawing/2014/main" id="{2564FD89-DA37-451B-A74C-5F3DB1144696}"/>
+                <a16:creationId xmlns:a16="http://schemas.microsoft.com/office/drawing/2014/main" id="{28CFA4DB-C75F-4157-A0F6-84FBD362F5B7}"/>
               </a:ext>
             </a:extLst>
           </p:cNvPr>
@@ -10346,7 +10346,7 @@
           <p:cNvPr id="3" name="">
             <a:extLst xmlns:a="http://schemas.openxmlformats.org/drawingml/2006/main">
               <a:ext uri="{FF2B5EF4-FFF2-40B4-BE49-F238E27FC236}">
-                <a16:creationId xmlns:a16="http://schemas.microsoft.com/office/drawing/2014/main" id="{6E99F284-9B81-4187-8FC9-E2B8FB2D0430}"/>
+                <a16:creationId xmlns:a16="http://schemas.microsoft.com/office/drawing/2014/main" id="{D81102AE-847E-4C6B-A02E-1ED454DEA753}"/>
               </a:ext>
             </a:extLst>
           </p:cNvPr>
@@ -10356,7 +10356,7 @@
           <p:nvPr/>
         </p:nvPicPr>
         <p:blipFill>
-          <a:blip xmlns:r="http://schemas.openxmlformats.org/officeDocument/2006/relationships" xmlns:a="http://schemas.openxmlformats.org/drawingml/2006/main" r:embed="Rc9c5ba3a6d0a4408"/>
+          <a:blip xmlns:r="http://schemas.openxmlformats.org/officeDocument/2006/relationships" xmlns:a="http://schemas.openxmlformats.org/drawingml/2006/main" r:embed="R72e8dd37bfaa45d2"/>
           <a:stretch xmlns:a="http://schemas.openxmlformats.org/drawingml/2006/main"/>
         </p:blipFill>
         <p:spPr>
@@ -10374,7 +10374,7 @@
           <p:cNvPr id="4" name="">
             <a:extLst xmlns:a="http://schemas.openxmlformats.org/drawingml/2006/main">
               <a:ext uri="{FF2B5EF4-FFF2-40B4-BE49-F238E27FC236}">
-                <a16:creationId xmlns:a16="http://schemas.microsoft.com/office/drawing/2014/main" id="{08351795-9C56-4477-AA94-B3DEDC8FBD73}"/>
+                <a16:creationId xmlns:a16="http://schemas.microsoft.com/office/drawing/2014/main" id="{3C0D9E11-50E2-4F2D-A4D2-3FFCAF48F453}"/>
               </a:ext>
             </a:extLst>
           </p:cNvPr>
@@ -10442,7 +10442,7 @@
           <p:cNvPr id="5" name="">
             <a:extLst xmlns:a="http://schemas.openxmlformats.org/drawingml/2006/main">
               <a:ext uri="{FF2B5EF4-FFF2-40B4-BE49-F238E27FC236}">
-                <a16:creationId xmlns:a16="http://schemas.microsoft.com/office/drawing/2014/main" id="{377955D8-8153-4800-9446-79821C4E385C}"/>
+                <a16:creationId xmlns:a16="http://schemas.microsoft.com/office/drawing/2014/main" id="{E663510E-9496-4850-B6F6-F8886BD5F99E}"/>
               </a:ext>
             </a:extLst>
           </p:cNvPr>
@@ -10510,7 +10510,7 @@
           <p:cNvPr id="6" name="">
             <a:extLst xmlns:a="http://schemas.openxmlformats.org/drawingml/2006/main">
               <a:ext uri="{FF2B5EF4-FFF2-40B4-BE49-F238E27FC236}">
-                <a16:creationId xmlns:a16="http://schemas.microsoft.com/office/drawing/2014/main" id="{0F970FBB-30F8-46B1-8733-D09B0AC3CAEF}"/>
+                <a16:creationId xmlns:a16="http://schemas.microsoft.com/office/drawing/2014/main" id="{9841E020-9404-4562-ACA4-9FEEA9C3DDC1}"/>
               </a:ext>
             </a:extLst>
           </p:cNvPr>
@@ -10578,7 +10578,7 @@
           <p:cNvPr id="7" name="">
             <a:extLst xmlns:a="http://schemas.openxmlformats.org/drawingml/2006/main">
               <a:ext uri="{FF2B5EF4-FFF2-40B4-BE49-F238E27FC236}">
-                <a16:creationId xmlns:a16="http://schemas.microsoft.com/office/drawing/2014/main" id="{E3FF81F3-ADBA-41A0-9D81-BB797306AA65}"/>
+                <a16:creationId xmlns:a16="http://schemas.microsoft.com/office/drawing/2014/main" id="{4EDA09EA-D4B0-4331-9CA8-4277A7717510}"/>
               </a:ext>
             </a:extLst>
           </p:cNvPr>
@@ -10646,7 +10646,7 @@
           <p:cNvPr id="8" name="">
             <a:extLst xmlns:a="http://schemas.openxmlformats.org/drawingml/2006/main">
               <a:ext uri="{FF2B5EF4-FFF2-40B4-BE49-F238E27FC236}">
-                <a16:creationId xmlns:a16="http://schemas.microsoft.com/office/drawing/2014/main" id="{B85106D5-4320-499C-BF59-DAA5366195EC}"/>
+                <a16:creationId xmlns:a16="http://schemas.microsoft.com/office/drawing/2014/main" id="{BFA7507B-B629-4ABA-949E-874A4D998825}"/>
               </a:ext>
             </a:extLst>
           </p:cNvPr>
@@ -10712,7 +10712,7 @@
     </p:spTree>
     <p:extLst>
       <p:ext uri="{BB962C8B-B14F-4D97-AF65-F5344CB8AC3E}">
-        <p14:creationId xmlns:p14="http://schemas.microsoft.com/office/powerpoint/2010/main" val="946972507"/>
+        <p14:creationId xmlns:p14="http://schemas.microsoft.com/office/powerpoint/2010/main" val="134240948"/>
       </p:ext>
     </p:extLst>
   </p:cSld>
@@ -10743,7 +10743,7 @@
           <p:cNvPr id="6" name="">
             <a:extLst xmlns:a="http://schemas.openxmlformats.org/drawingml/2006/main">
               <a:ext uri="{FF2B5EF4-FFF2-40B4-BE49-F238E27FC236}">
-                <a16:creationId xmlns:a16="http://schemas.microsoft.com/office/drawing/2014/main" id="{E504A29B-2B1A-46B9-A931-178AD2C12048}"/>
+                <a16:creationId xmlns:a16="http://schemas.microsoft.com/office/drawing/2014/main" id="{91F393C5-CF2A-43AC-879A-C346606FD68E}"/>
               </a:ext>
             </a:extLst>
           </p:cNvPr>
@@ -10811,7 +10811,7 @@
           <p:cNvPr id="2" name="">
             <a:extLst xmlns:a="http://schemas.openxmlformats.org/drawingml/2006/main">
               <a:ext uri="{FF2B5EF4-FFF2-40B4-BE49-F238E27FC236}">
-                <a16:creationId xmlns:a16="http://schemas.microsoft.com/office/drawing/2014/main" id="{CBCD08D7-9821-4B55-BF35-85B53C988721}"/>
+                <a16:creationId xmlns:a16="http://schemas.microsoft.com/office/drawing/2014/main" id="{B3F21F8E-7D85-456E-B154-E922E0DC5AE0}"/>
               </a:ext>
             </a:extLst>
           </p:cNvPr>
@@ -10879,7 +10879,7 @@
           <p:cNvPr id="3" name="">
             <a:extLst xmlns:a="http://schemas.openxmlformats.org/drawingml/2006/main">
               <a:ext uri="{FF2B5EF4-FFF2-40B4-BE49-F238E27FC236}">
-                <a16:creationId xmlns:a16="http://schemas.microsoft.com/office/drawing/2014/main" id="{9A5C06E4-78F5-472C-9625-E3EBE1EA5415}"/>
+                <a16:creationId xmlns:a16="http://schemas.microsoft.com/office/drawing/2014/main" id="{BA7FC6C9-7247-4E3A-9E39-8B79A52E654C}"/>
               </a:ext>
             </a:extLst>
           </p:cNvPr>
@@ -10889,7 +10889,7 @@
           <p:nvPr/>
         </p:nvPicPr>
         <p:blipFill>
-          <a:blip xmlns:r="http://schemas.openxmlformats.org/officeDocument/2006/relationships" xmlns:a="http://schemas.openxmlformats.org/drawingml/2006/main" r:embed="Reff07694a7d64a09"/>
+          <a:blip xmlns:r="http://schemas.openxmlformats.org/officeDocument/2006/relationships" xmlns:a="http://schemas.openxmlformats.org/drawingml/2006/main" r:embed="Rce131b0a78ec4c5a"/>
           <a:stretch xmlns:a="http://schemas.openxmlformats.org/drawingml/2006/main"/>
         </p:blipFill>
         <p:spPr>
@@ -10907,7 +10907,7 @@
           <p:cNvPr id="4" name="">
             <a:extLst xmlns:a="http://schemas.openxmlformats.org/drawingml/2006/main">
               <a:ext uri="{FF2B5EF4-FFF2-40B4-BE49-F238E27FC236}">
-                <a16:creationId xmlns:a16="http://schemas.microsoft.com/office/drawing/2014/main" id="{7C2C00D1-CF25-459E-A44A-10512AE9F0F8}"/>
+                <a16:creationId xmlns:a16="http://schemas.microsoft.com/office/drawing/2014/main" id="{7C038111-B572-4E3B-BD84-9D8E1D0D1EF5}"/>
               </a:ext>
             </a:extLst>
           </p:cNvPr>
@@ -10975,7 +10975,7 @@
           <p:cNvPr id="5" name="">
             <a:extLst xmlns:a="http://schemas.openxmlformats.org/drawingml/2006/main">
               <a:ext uri="{FF2B5EF4-FFF2-40B4-BE49-F238E27FC236}">
-                <a16:creationId xmlns:a16="http://schemas.microsoft.com/office/drawing/2014/main" id="{2E6D4134-E17D-44FB-8B1D-01FF42EFF8B7}"/>
+                <a16:creationId xmlns:a16="http://schemas.microsoft.com/office/drawing/2014/main" id="{59723578-CE4A-49DC-AD8D-A469E6DC5652}"/>
               </a:ext>
             </a:extLst>
           </p:cNvPr>
@@ -11041,7 +11041,7 @@
     </p:spTree>
     <p:extLst>
       <p:ext uri="{BB962C8B-B14F-4D97-AF65-F5344CB8AC3E}">
-        <p14:creationId xmlns:p14="http://schemas.microsoft.com/office/powerpoint/2010/main" val="1844870903"/>
+        <p14:creationId xmlns:p14="http://schemas.microsoft.com/office/powerpoint/2010/main" val="230914736"/>
       </p:ext>
     </p:extLst>
   </p:cSld>
@@ -11072,7 +11072,7 @@
           <p:cNvPr id="5" name="">
             <a:extLst xmlns:a="http://schemas.openxmlformats.org/drawingml/2006/main">
               <a:ext uri="{FF2B5EF4-FFF2-40B4-BE49-F238E27FC236}">
-                <a16:creationId xmlns:a16="http://schemas.microsoft.com/office/drawing/2014/main" id="{F433CE2F-69C3-451D-94DC-F1647234B9E5}"/>
+                <a16:creationId xmlns:a16="http://schemas.microsoft.com/office/drawing/2014/main" id="{B92E377D-B5F5-4F34-86D5-7A2297E8CBEC}"/>
               </a:ext>
             </a:extLst>
           </p:cNvPr>
@@ -11140,7 +11140,7 @@
           <p:cNvPr id="2" name="">
             <a:extLst xmlns:a="http://schemas.openxmlformats.org/drawingml/2006/main">
               <a:ext uri="{FF2B5EF4-FFF2-40B4-BE49-F238E27FC236}">
-                <a16:creationId xmlns:a16="http://schemas.microsoft.com/office/drawing/2014/main" id="{284F7940-487C-487B-A593-8E9666687035}"/>
+                <a16:creationId xmlns:a16="http://schemas.microsoft.com/office/drawing/2014/main" id="{322DD70B-7863-4322-B4A7-22DDC8F00C63}"/>
               </a:ext>
             </a:extLst>
           </p:cNvPr>
@@ -11208,7 +11208,7 @@
           <p:cNvPr id="3" name="">
             <a:extLst xmlns:a="http://schemas.openxmlformats.org/drawingml/2006/main">
               <a:ext uri="{FF2B5EF4-FFF2-40B4-BE49-F238E27FC236}">
-                <a16:creationId xmlns:a16="http://schemas.microsoft.com/office/drawing/2014/main" id="{4B1098D2-71E0-4C49-8EDB-9E4F497AAC17}"/>
+                <a16:creationId xmlns:a16="http://schemas.microsoft.com/office/drawing/2014/main" id="{05FD2639-337E-44B1-A2C6-9C2F5B1AA6B8}"/>
               </a:ext>
             </a:extLst>
           </p:cNvPr>
@@ -11378,7 +11378,7 @@
                           <a:ea typeface="Arial"/>
                           <a:cs typeface="Arial"/>
                         </a:rPr>
-                        <a:t>The detailed orientation, frame, WKT string normalization and publication conventions remain proposed.</a:t>
+                        <a:t>Input and declaration rules have agreement. Detailed conventions and identities await review.</a:t>
                       </a:r>
                     </a:p>
                   </a:txBody>
@@ -11506,7 +11506,7 @@
           <p:cNvPr id="4" name="">
             <a:extLst xmlns:a="http://schemas.openxmlformats.org/drawingml/2006/main">
               <a:ext uri="{FF2B5EF4-FFF2-40B4-BE49-F238E27FC236}">
-                <a16:creationId xmlns:a16="http://schemas.microsoft.com/office/drawing/2014/main" id="{B98CC8FB-A0F7-4D71-9295-E5A0EEB3B969}"/>
+                <a16:creationId xmlns:a16="http://schemas.microsoft.com/office/drawing/2014/main" id="{6F04C8E4-72A0-4F69-8E12-0C8C341E9B40}"/>
               </a:ext>
             </a:extLst>
           </p:cNvPr>
@@ -11572,7 +11572,7 @@
     </p:spTree>
     <p:extLst>
       <p:ext uri="{BB962C8B-B14F-4D97-AF65-F5344CB8AC3E}">
-        <p14:creationId xmlns:p14="http://schemas.microsoft.com/office/powerpoint/2010/main" val="230428592"/>
+        <p14:creationId xmlns:p14="http://schemas.microsoft.com/office/powerpoint/2010/main" val="1631378121"/>
       </p:ext>
     </p:extLst>
   </p:cSld>
@@ -11603,7 +11603,7 @@
           <p:cNvPr id="9" name="">
             <a:extLst xmlns:a="http://schemas.openxmlformats.org/drawingml/2006/main">
               <a:ext uri="{FF2B5EF4-FFF2-40B4-BE49-F238E27FC236}">
-                <a16:creationId xmlns:a16="http://schemas.microsoft.com/office/drawing/2014/main" id="{EF417B38-50E6-415E-A50B-7FF9F8D6CAB4}"/>
+                <a16:creationId xmlns:a16="http://schemas.microsoft.com/office/drawing/2014/main" id="{73AA4BDE-39A7-4A7E-9F17-3BBDA3B31213}"/>
               </a:ext>
             </a:extLst>
           </p:cNvPr>
@@ -11671,7 +11671,7 @@
           <p:cNvPr id="2" name="">
             <a:extLst xmlns:a="http://schemas.openxmlformats.org/drawingml/2006/main">
               <a:ext uri="{FF2B5EF4-FFF2-40B4-BE49-F238E27FC236}">
-                <a16:creationId xmlns:a16="http://schemas.microsoft.com/office/drawing/2014/main" id="{F934C1B0-AB0B-4F5A-A520-BEF4063C4CCC}"/>
+                <a16:creationId xmlns:a16="http://schemas.microsoft.com/office/drawing/2014/main" id="{C65FD8E7-BC03-4305-9349-33F81188C92B}"/>
               </a:ext>
             </a:extLst>
           </p:cNvPr>
@@ -11739,7 +11739,7 @@
           <p:cNvPr id="3" name="">
             <a:extLst xmlns:a="http://schemas.openxmlformats.org/drawingml/2006/main">
               <a:ext uri="{FF2B5EF4-FFF2-40B4-BE49-F238E27FC236}">
-                <a16:creationId xmlns:a16="http://schemas.microsoft.com/office/drawing/2014/main" id="{4ACC1F64-21F6-4032-81EA-86D50EDF36D7}"/>
+                <a16:creationId xmlns:a16="http://schemas.microsoft.com/office/drawing/2014/main" id="{144E53A4-771F-4D41-B9EC-EA9491CD877C}"/>
               </a:ext>
             </a:extLst>
           </p:cNvPr>
@@ -11749,7 +11749,7 @@
           <p:nvPr/>
         </p:nvPicPr>
         <p:blipFill>
-          <a:blip xmlns:r="http://schemas.openxmlformats.org/officeDocument/2006/relationships" xmlns:a="http://schemas.openxmlformats.org/drawingml/2006/main" r:embed="Ra59159356e6a4547"/>
+          <a:blip xmlns:r="http://schemas.openxmlformats.org/officeDocument/2006/relationships" xmlns:a="http://schemas.openxmlformats.org/drawingml/2006/main" r:embed="R696969b9b1d7439a"/>
           <a:stretch xmlns:a="http://schemas.openxmlformats.org/drawingml/2006/main"/>
         </p:blipFill>
         <p:spPr>
@@ -11767,7 +11767,7 @@
           <p:cNvPr id="4" name="">
             <a:extLst xmlns:a="http://schemas.openxmlformats.org/drawingml/2006/main">
               <a:ext uri="{FF2B5EF4-FFF2-40B4-BE49-F238E27FC236}">
-                <a16:creationId xmlns:a16="http://schemas.microsoft.com/office/drawing/2014/main" id="{BB12225E-EC75-4ED2-A327-2AD85B0953EF}"/>
+                <a16:creationId xmlns:a16="http://schemas.microsoft.com/office/drawing/2014/main" id="{E1C5D8F5-BA8E-4524-9FCC-5AF1E63A9CD0}"/>
               </a:ext>
             </a:extLst>
           </p:cNvPr>
@@ -11835,7 +11835,7 @@
           <p:cNvPr id="5" name="">
             <a:extLst xmlns:a="http://schemas.openxmlformats.org/drawingml/2006/main">
               <a:ext uri="{FF2B5EF4-FFF2-40B4-BE49-F238E27FC236}">
-                <a16:creationId xmlns:a16="http://schemas.microsoft.com/office/drawing/2014/main" id="{C36AFE17-5D28-451D-B3DB-75F7442CBFC9}"/>
+                <a16:creationId xmlns:a16="http://schemas.microsoft.com/office/drawing/2014/main" id="{EE86E619-5F16-4378-A1D8-48A5196A7DD4}"/>
               </a:ext>
             </a:extLst>
           </p:cNvPr>
@@ -11903,7 +11903,7 @@
           <p:cNvPr id="6" name="">
             <a:extLst xmlns:a="http://schemas.openxmlformats.org/drawingml/2006/main">
               <a:ext uri="{FF2B5EF4-FFF2-40B4-BE49-F238E27FC236}">
-                <a16:creationId xmlns:a16="http://schemas.microsoft.com/office/drawing/2014/main" id="{71A67865-0E7C-43DC-94E0-D47FE3723D5D}"/>
+                <a16:creationId xmlns:a16="http://schemas.microsoft.com/office/drawing/2014/main" id="{74F651E1-1730-46EE-BF9E-74444D83C843}"/>
               </a:ext>
             </a:extLst>
           </p:cNvPr>
@@ -11971,7 +11971,7 @@
           <p:cNvPr id="7" name="">
             <a:extLst xmlns:a="http://schemas.openxmlformats.org/drawingml/2006/main">
               <a:ext uri="{FF2B5EF4-FFF2-40B4-BE49-F238E27FC236}">
-                <a16:creationId xmlns:a16="http://schemas.microsoft.com/office/drawing/2014/main" id="{F6729EE2-C0E6-4B17-82FA-4E37A2805C6A}"/>
+                <a16:creationId xmlns:a16="http://schemas.microsoft.com/office/drawing/2014/main" id="{7FBDB236-C074-473E-A844-A4956030C283}"/>
               </a:ext>
             </a:extLst>
           </p:cNvPr>
@@ -12039,7 +12039,7 @@
           <p:cNvPr id="8" name="">
             <a:extLst xmlns:a="http://schemas.openxmlformats.org/drawingml/2006/main">
               <a:ext uri="{FF2B5EF4-FFF2-40B4-BE49-F238E27FC236}">
-                <a16:creationId xmlns:a16="http://schemas.microsoft.com/office/drawing/2014/main" id="{BFA6F17F-FB6A-4E29-9C0C-2CE9C7ED1508}"/>
+                <a16:creationId xmlns:a16="http://schemas.microsoft.com/office/drawing/2014/main" id="{71EB2CB4-DC18-4C4E-91CF-0DD6DF41E14A}"/>
               </a:ext>
             </a:extLst>
           </p:cNvPr>
@@ -12105,7 +12105,7 @@
     </p:spTree>
     <p:extLst>
       <p:ext uri="{BB962C8B-B14F-4D97-AF65-F5344CB8AC3E}">
-        <p14:creationId xmlns:p14="http://schemas.microsoft.com/office/powerpoint/2010/main" val="537882496"/>
+        <p14:creationId xmlns:p14="http://schemas.microsoft.com/office/powerpoint/2010/main" val="1661851679"/>
       </p:ext>
     </p:extLst>
   </p:cSld>

</xml_diff>